<commit_message>
Lab01: reship the deck without the running example
Matches eecs498-aase/aase-f26 at 7ff0860. 40 slides.

Co-Authored-By: Claude Opus 5 (1M context) <noreply@anthropic.com>
Claude-Session: https://claude.ai/code/session_015pu78gNF4378sH81fTPKSc
</commit_message>
<xml_diff>
--- a/labs/Lab01/slides.pptx
+++ b/labs/Lab01/slides.pptx
@@ -45,10 +45,9 @@
     <p:sldId id="293" r:id="rId39"/>
     <p:sldId id="294" r:id="rId40"/>
     <p:sldId id="295" r:id="rId41"/>
-    <p:sldId id="296" r:id="rId42"/>
   </p:sldIdLst>
   <p:notesMasterIdLst>
-    <p:notesMasterId r:id="rId43"/>
+    <p:notesMasterId r:id="rId42"/>
   </p:notesMasterIdLst>
   <p:sldSz cx="9334500" cy="5248275"/>
   <p:notesSz cx="5248275" cy="9334500"/>
@@ -632,97 +631,6 @@
           <a:p>
             <a:r>
               <a:rPr lang="en-US" dirty="0"/>
-              <a:t>Walk through why these three files and not the whole package. This is one
-sensible selection, not a rule to add everything. Read-only context still
-costs budget. /tokens tells you what you are spending, and nothing about
-whether the edit will be correct.</a:t>
-            </a:r>
-            <a:endParaRPr lang="en-US" dirty="0"/>
-          </a:p>
-        </p:txBody>
-      </p:sp>
-      <p:sp>
-        <p:nvSpPr>
-          <p:cNvPr id="4" name="Slide Number Placeholder 3"/>
-          <p:cNvSpPr>
-            <a:spLocks noGrp="1"/>
-          </p:cNvSpPr>
-          <p:nvPr>
-            <p:ph type="sldNum" sz="quarter" idx="10"/>
-          </p:nvPr>
-        </p:nvSpPr>
-        <p:spPr/>
-        <p:txBody>
-          <a:bodyPr/>
-          <a:lstStyle/>
-          <a:p>
-            <a:fld id="{F7021451-1387-4CA6-816F-3879F97B5CBC}" type="slidenum">
-              <a:rPr lang="en-US"/>
-              <a:t>10</a:t>
-            </a:fld>
-            <a:endParaRPr lang="en-US"/>
-          </a:p>
-        </p:txBody>
-      </p:sp>
-    </p:spTree>
-    <p:extLst>
-      <p:ext uri="{BB962C8B-B14F-4D97-AF65-F5344CB8AC3E}">
-        <p14:creationId xmlns:p14="http://schemas.microsoft.com/office/powerpoint/2010/main" val="1024086991"/>
-      </p:ext>
-    </p:extLst>
-  </p:cSld>
-  <p:clrMapOvr>
-    <a:masterClrMapping/>
-  </p:clrMapOvr>
-</p:notes>
-</file>
-
-<file path=ppt/notesSlides/notesSlide11.xml><?xml version="1.0" encoding="utf-8"?>
-<p:notes xmlns:a="http://schemas.openxmlformats.org/drawingml/2006/main" xmlns:r="http://schemas.openxmlformats.org/officeDocument/2006/relationships" xmlns:p="http://schemas.openxmlformats.org/presentationml/2006/main">
-  <p:cSld>
-    <p:spTree>
-      <p:nvGrpSpPr>
-        <p:cNvPr id="1" name=""/>
-        <p:cNvGrpSpPr/>
-        <p:nvPr/>
-      </p:nvGrpSpPr>
-      <p:grpSpPr>
-        <a:xfrm>
-          <a:off x="0" y="0"/>
-          <a:ext cx="0" cy="0"/>
-          <a:chOff x="0" y="0"/>
-          <a:chExt cx="0" cy="0"/>
-        </a:xfrm>
-      </p:grpSpPr>
-      <p:sp>
-        <p:nvSpPr>
-          <p:cNvPr id="2" name="Slide Image Placeholder 1"/>
-          <p:cNvSpPr>
-            <a:spLocks noGrp="1" noRot="1" noChangeAspect="1"/>
-          </p:cNvSpPr>
-          <p:nvPr>
-            <p:ph type="sldImg"/>
-          </p:nvPr>
-        </p:nvSpPr>
-        <p:spPr/>
-      </p:sp>
-      <p:sp>
-        <p:nvSpPr>
-          <p:cNvPr id="3" name="Notes Placeholder 2"/>
-          <p:cNvSpPr>
-            <a:spLocks noGrp="1"/>
-          </p:cNvSpPr>
-          <p:nvPr>
-            <p:ph type="body" idx="1"/>
-          </p:nvPr>
-        </p:nvSpPr>
-        <p:spPr/>
-        <p:txBody>
-          <a:bodyPr/>
-          <a:lstStyle/>
-          <a:p>
-            <a:r>
-              <a:rPr lang="en-US" dirty="0"/>
               <a:t>The excerpt is illustrative. Do not promise the map contains every file, and do
 not use its silence as proof that a dependency is absent. When a student says
 "the model should have known," check whether they added the file or only let the
@@ -752,7 +660,7 @@
           <a:p>
             <a:fld id="{F7021451-1387-4CA6-816F-3879F97B5CBC}" type="slidenum">
               <a:rPr lang="en-US"/>
-              <a:t>11</a:t>
+              <a:t>10</a:t>
             </a:fld>
             <a:endParaRPr lang="en-US"/>
           </a:p>
@@ -771,7 +679,7 @@
 </p:notes>
 </file>
 
-<file path=ppt/notesSlides/notesSlide12.xml><?xml version="1.0" encoding="utf-8"?>
+<file path=ppt/notesSlides/notesSlide11.xml><?xml version="1.0" encoding="utf-8"?>
 <p:notes xmlns:a="http://schemas.openxmlformats.org/drawingml/2006/main" xmlns:r="http://schemas.openxmlformats.org/officeDocument/2006/relationships" xmlns:p="http://schemas.openxmlformats.org/presentationml/2006/main">
   <p:cSld>
     <p:spTree>
@@ -843,7 +751,7 @@
           <a:p>
             <a:fld id="{F7021451-1387-4CA6-816F-3879F97B5CBC}" type="slidenum">
               <a:rPr lang="en-US"/>
-              <a:t>12</a:t>
+              <a:t>11</a:t>
             </a:fld>
             <a:endParaRPr lang="en-US"/>
           </a:p>
@@ -862,7 +770,7 @@
 </p:notes>
 </file>
 
-<file path=ppt/notesSlides/notesSlide13.xml><?xml version="1.0" encoding="utf-8"?>
+<file path=ppt/notesSlides/notesSlide12.xml><?xml version="1.0" encoding="utf-8"?>
 <p:notes xmlns:a="http://schemas.openxmlformats.org/drawingml/2006/main" xmlns:r="http://schemas.openxmlformats.org/officeDocument/2006/relationships" xmlns:p="http://schemas.openxmlformats.org/presentationml/2006/main">
   <p:cSld>
     <p:spTree>
@@ -908,9 +816,10 @@
           <a:p>
             <a:r>
               <a:rPr lang="en-US" dirty="0"/>
-              <a:t>Deliberately small and deliberately incomplete. Ask what is missing before you
-say it: task.py never gains the field, store.py never writes it. A student who
-reads only this block sees a finished feature.
+              <a:t>Ask what a block like this does not tell you. It names one file. A change that
+needs three files needs three blocks, and nothing in the format obliges the
+model to produce all three. A student who reads one well-formed block sees a
+finished feature.
 Nothing has changed on disk yet. This is a proposal in a chat reply.</a:t>
             </a:r>
             <a:endParaRPr lang="en-US" dirty="0"/>
@@ -934,7 +843,7 @@
           <a:p>
             <a:fld id="{F7021451-1387-4CA6-816F-3879F97B5CBC}" type="slidenum">
               <a:rPr lang="en-US"/>
-              <a:t>13</a:t>
+              <a:t>12</a:t>
             </a:fld>
             <a:endParaRPr lang="en-US"/>
           </a:p>
@@ -953,7 +862,7 @@
 </p:notes>
 </file>
 
-<file path=ppt/notesSlides/notesSlide14.xml><?xml version="1.0" encoding="utf-8"?>
+<file path=ppt/notesSlides/notesSlide13.xml><?xml version="1.0" encoding="utf-8"?>
 <p:notes xmlns:a="http://schemas.openxmlformats.org/drawingml/2006/main" xmlns:r="http://schemas.openxmlformats.org/officeDocument/2006/relationships" xmlns:p="http://schemas.openxmlformats.org/presentationml/2006/main">
   <p:cSld>
     <p:spTree>
@@ -1024,7 +933,7 @@
           <a:p>
             <a:fld id="{F7021451-1387-4CA6-816F-3879F97B5CBC}" type="slidenum">
               <a:rPr lang="en-US"/>
-              <a:t>14</a:t>
+              <a:t>13</a:t>
             </a:fld>
             <a:endParaRPr lang="en-US"/>
           </a:p>
@@ -1043,7 +952,7 @@
 </p:notes>
 </file>
 
-<file path=ppt/notesSlides/notesSlide15.xml><?xml version="1.0" encoding="utf-8"?>
+<file path=ppt/notesSlides/notesSlide14.xml><?xml version="1.0" encoding="utf-8"?>
 <p:notes xmlns:a="http://schemas.openxmlformats.org/drawingml/2006/main" xmlns:r="http://schemas.openxmlformats.org/officeDocument/2006/relationships" xmlns:p="http://schemas.openxmlformats.org/presentationml/2006/main">
   <p:cSld>
     <p:spTree>
@@ -1119,7 +1028,7 @@
           <a:p>
             <a:fld id="{F7021451-1387-4CA6-816F-3879F97B5CBC}" type="slidenum">
               <a:rPr lang="en-US"/>
-              <a:t>15</a:t>
+              <a:t>14</a:t>
             </a:fld>
             <a:endParaRPr lang="en-US"/>
           </a:p>
@@ -1138,7 +1047,7 @@
 </p:notes>
 </file>
 
-<file path=ppt/notesSlides/notesSlide16.xml><?xml version="1.0" encoding="utf-8"?>
+<file path=ppt/notesSlides/notesSlide15.xml><?xml version="1.0" encoding="utf-8"?>
 <p:notes xmlns:a="http://schemas.openxmlformats.org/drawingml/2006/main" xmlns:r="http://schemas.openxmlformats.org/officeDocument/2006/relationships" xmlns:p="http://schemas.openxmlformats.org/presentationml/2006/main">
   <p:cSld>
     <p:spTree>
@@ -1211,7 +1120,7 @@
           <a:p>
             <a:fld id="{F7021451-1387-4CA6-816F-3879F97B5CBC}" type="slidenum">
               <a:rPr lang="en-US"/>
-              <a:t>16</a:t>
+              <a:t>15</a:t>
             </a:fld>
             <a:endParaRPr lang="en-US"/>
           </a:p>
@@ -1230,7 +1139,7 @@
 </p:notes>
 </file>
 
-<file path=ppt/notesSlides/notesSlide17.xml><?xml version="1.0" encoding="utf-8"?>
+<file path=ppt/notesSlides/notesSlide16.xml><?xml version="1.0" encoding="utf-8"?>
 <p:notes xmlns:a="http://schemas.openxmlformats.org/drawingml/2006/main" xmlns:r="http://schemas.openxmlformats.org/officeDocument/2006/relationships" xmlns:p="http://schemas.openxmlformats.org/presentationml/2006/main">
   <p:cSld>
     <p:spTree>
@@ -1306,7 +1215,7 @@
           <a:p>
             <a:fld id="{F7021451-1387-4CA6-816F-3879F97B5CBC}" type="slidenum">
               <a:rPr lang="en-US"/>
-              <a:t>17</a:t>
+              <a:t>16</a:t>
             </a:fld>
             <a:endParaRPr lang="en-US"/>
           </a:p>
@@ -1325,6 +1234,96 @@
 </p:notes>
 </file>
 
+<file path=ppt/notesSlides/notesSlide17.xml><?xml version="1.0" encoding="utf-8"?>
+<p:notes xmlns:a="http://schemas.openxmlformats.org/drawingml/2006/main" xmlns:r="http://schemas.openxmlformats.org/officeDocument/2006/relationships" xmlns:p="http://schemas.openxmlformats.org/presentationml/2006/main">
+  <p:cSld>
+    <p:spTree>
+      <p:nvGrpSpPr>
+        <p:cNvPr id="1" name=""/>
+        <p:cNvGrpSpPr/>
+        <p:nvPr/>
+      </p:nvGrpSpPr>
+      <p:grpSpPr>
+        <a:xfrm>
+          <a:off x="0" y="0"/>
+          <a:ext cx="0" cy="0"/>
+          <a:chOff x="0" y="0"/>
+          <a:chExt cx="0" cy="0"/>
+        </a:xfrm>
+      </p:grpSpPr>
+      <p:sp>
+        <p:nvSpPr>
+          <p:cNvPr id="2" name="Slide Image Placeholder 1"/>
+          <p:cNvSpPr>
+            <a:spLocks noGrp="1" noRot="1" noChangeAspect="1"/>
+          </p:cNvSpPr>
+          <p:nvPr>
+            <p:ph type="sldImg"/>
+          </p:nvPr>
+        </p:nvSpPr>
+        <p:spPr/>
+      </p:sp>
+      <p:sp>
+        <p:nvSpPr>
+          <p:cNvPr id="3" name="Notes Placeholder 2"/>
+          <p:cNvSpPr>
+            <a:spLocks noGrp="1"/>
+          </p:cNvSpPr>
+          <p:nvPr>
+            <p:ph type="body" idx="1"/>
+          </p:nvPr>
+        </p:nvSpPr>
+        <p:spPr/>
+        <p:txBody>
+          <a:bodyPr/>
+          <a:lstStyle/>
+          <a:p>
+            <a:r>
+              <a:rPr lang="en-US" dirty="0"/>
+              <a:t>Pairs for two minutes, then take two answers. You are listening for a write
+that never happened and the test that would have caught it. Do not reward
+naming a source file inside aider.</a:t>
+            </a:r>
+            <a:endParaRPr lang="en-US" dirty="0"/>
+          </a:p>
+        </p:txBody>
+      </p:sp>
+      <p:sp>
+        <p:nvSpPr>
+          <p:cNvPr id="4" name="Slide Number Placeholder 3"/>
+          <p:cNvSpPr>
+            <a:spLocks noGrp="1"/>
+          </p:cNvSpPr>
+          <p:nvPr>
+            <p:ph type="sldNum" sz="quarter" idx="10"/>
+          </p:nvPr>
+        </p:nvSpPr>
+        <p:spPr/>
+        <p:txBody>
+          <a:bodyPr/>
+          <a:lstStyle/>
+          <a:p>
+            <a:fld id="{F7021451-1387-4CA6-816F-3879F97B5CBC}" type="slidenum">
+              <a:rPr lang="en-US"/>
+              <a:t>17</a:t>
+            </a:fld>
+            <a:endParaRPr lang="en-US"/>
+          </a:p>
+        </p:txBody>
+      </p:sp>
+    </p:spTree>
+    <p:extLst>
+      <p:ext uri="{BB962C8B-B14F-4D97-AF65-F5344CB8AC3E}">
+        <p14:creationId xmlns:p14="http://schemas.microsoft.com/office/powerpoint/2010/main" val="1024086991"/>
+      </p:ext>
+    </p:extLst>
+  </p:cSld>
+  <p:clrMapOvr>
+    <a:masterClrMapping/>
+  </p:clrMapOvr>
+</p:notes>
+</file>
+
 <file path=ppt/notesSlides/notesSlide18.xml><?xml version="1.0" encoding="utf-8"?>
 <p:notes xmlns:a="http://schemas.openxmlformats.org/drawingml/2006/main" xmlns:r="http://schemas.openxmlformats.org/officeDocument/2006/relationships" xmlns:p="http://schemas.openxmlformats.org/presentationml/2006/main">
   <p:cSld>
@@ -1371,9 +1370,8 @@
           <a:p>
             <a:r>
               <a:rPr lang="en-US" dirty="0"/>
-              <a:t>Pairs for two minutes, then take two answers. You are listening for the missing
-storage write or the missing persistence test. Do not reward naming a source
-file inside aider.</a:t>
+              <a:t>Ten minutes. The habit to build: a symptom is evidence about which of the three
+levers is wrong, and re-running the same prompt tests nothing.</a:t>
             </a:r>
             <a:endParaRPr lang="en-US" dirty="0"/>
           </a:p>
@@ -1461,8 +1459,9 @@
           <a:p>
             <a:r>
               <a:rPr lang="en-US" dirty="0"/>
-              <a:t>Ten minutes. The habit to build: a symptom is evidence about which of the three
-levers is wrong, and re-running the same prompt tests nothing.</a:t>
+              <a:t>Push back on "the model is too weak" every time it comes up today. Ask what
+observation would distinguish a weak model from a missing file, and make them
+answer before they change models.</a:t>
             </a:r>
             <a:endParaRPr lang="en-US" dirty="0"/>
           </a:p>
@@ -1645,9 +1644,9 @@
           <a:p>
             <a:r>
               <a:rPr lang="en-US" dirty="0"/>
-              <a:t>Push back on "the model is too weak" every time it comes up today. Ask what
-observation would distinguish a weak model from a missing file, and make them
-answer before they change models.</a:t>
+              <a:t>Do not let this become "the model does not matter" or "every failure is
+context." Both halves are real. The point is that the harness is the half they
+are about to build, and it is the half they control.</a:t>
             </a:r>
             <a:endParaRPr lang="en-US" dirty="0"/>
           </a:p>
@@ -1735,98 +1734,10 @@
           <a:p>
             <a:r>
               <a:rPr lang="en-US" dirty="0"/>
-              <a:t>Do not let this become "the model does not matter" or "every failure is
-context." Both halves are real. The point is that the harness is the half they
-are about to build, and it is the half they control.</a:t>
-            </a:r>
-            <a:endParaRPr lang="en-US" dirty="0"/>
-          </a:p>
-        </p:txBody>
-      </p:sp>
-      <p:sp>
-        <p:nvSpPr>
-          <p:cNvPr id="4" name="Slide Number Placeholder 3"/>
-          <p:cNvSpPr>
-            <a:spLocks noGrp="1"/>
-          </p:cNvSpPr>
-          <p:nvPr>
-            <p:ph type="sldNum" sz="quarter" idx="10"/>
-          </p:nvPr>
-        </p:nvSpPr>
-        <p:spPr/>
-        <p:txBody>
-          <a:bodyPr/>
-          <a:lstStyle/>
-          <a:p>
-            <a:fld id="{F7021451-1387-4CA6-816F-3879F97B5CBC}" type="slidenum">
-              <a:rPr lang="en-US"/>
-              <a:t>21</a:t>
-            </a:fld>
-            <a:endParaRPr lang="en-US"/>
-          </a:p>
-        </p:txBody>
-      </p:sp>
-    </p:spTree>
-    <p:extLst>
-      <p:ext uri="{BB962C8B-B14F-4D97-AF65-F5344CB8AC3E}">
-        <p14:creationId xmlns:p14="http://schemas.microsoft.com/office/powerpoint/2010/main" val="1024086991"/>
-      </p:ext>
-    </p:extLst>
-  </p:cSld>
-  <p:clrMapOvr>
-    <a:masterClrMapping/>
-  </p:clrMapOvr>
-</p:notes>
-</file>
-
-<file path=ppt/notesSlides/notesSlide22.xml><?xml version="1.0" encoding="utf-8"?>
-<p:notes xmlns:a="http://schemas.openxmlformats.org/drawingml/2006/main" xmlns:r="http://schemas.openxmlformats.org/officeDocument/2006/relationships" xmlns:p="http://schemas.openxmlformats.org/presentationml/2006/main">
-  <p:cSld>
-    <p:spTree>
-      <p:nvGrpSpPr>
-        <p:cNvPr id="1" name=""/>
-        <p:cNvGrpSpPr/>
-        <p:nvPr/>
-      </p:nvGrpSpPr>
-      <p:grpSpPr>
-        <a:xfrm>
-          <a:off x="0" y="0"/>
-          <a:ext cx="0" cy="0"/>
-          <a:chOff x="0" y="0"/>
-          <a:chExt cx="0" cy="0"/>
-        </a:xfrm>
-      </p:grpSpPr>
-      <p:sp>
-        <p:nvSpPr>
-          <p:cNvPr id="2" name="Slide Image Placeholder 1"/>
-          <p:cNvSpPr>
-            <a:spLocks noGrp="1" noRot="1" noChangeAspect="1"/>
-          </p:cNvSpPr>
-          <p:nvPr>
-            <p:ph type="sldImg"/>
-          </p:nvPr>
-        </p:nvSpPr>
-        <p:spPr/>
-      </p:sp>
-      <p:sp>
-        <p:nvSpPr>
-          <p:cNvPr id="3" name="Notes Placeholder 2"/>
-          <p:cNvSpPr>
-            <a:spLocks noGrp="1"/>
-          </p:cNvSpPr>
-          <p:nvPr>
-            <p:ph type="body" idx="1"/>
-          </p:nvPr>
-        </p:nvSpPr>
-        <p:spPr/>
-        <p:txBody>
-          <a:bodyPr/>
-          <a:lstStyle/>
-          <a:p>
-            <a:r>
-              <a:rPr lang="en-US" dirty="0"/>
               <a:t>Four minutes in pairs, two for answers. A persistence round trip is the answer
-you are hoping for: write it, restart, read it back.
+you are hoping for: write it, restart, read it back. The symptom is stated
+without a worked case on purpose, so ask the room to name a change this could
+happen to before you ask where to look.
 Watch for the two reflexes you want to break. Adding every file in the package
 is not diagnosis, and switching models is not diagnosis.
 The exercise, which is no longer written on the slide: write the acceptance
@@ -1854,7 +1765,7 @@
           <a:p>
             <a:fld id="{F7021451-1387-4CA6-816F-3879F97B5CBC}" type="slidenum">
               <a:rPr lang="en-US"/>
-              <a:t>22</a:t>
+              <a:t>21</a:t>
             </a:fld>
             <a:endParaRPr lang="en-US"/>
           </a:p>
@@ -1873,7 +1784,7 @@
 </p:notes>
 </file>
 
-<file path=ppt/notesSlides/notesSlide23.xml><?xml version="1.0" encoding="utf-8"?>
+<file path=ppt/notesSlides/notesSlide22.xml><?xml version="1.0" encoding="utf-8"?>
 <p:notes xmlns:a="http://schemas.openxmlformats.org/drawingml/2006/main" xmlns:r="http://schemas.openxmlformats.org/officeDocument/2006/relationships" xmlns:p="http://schemas.openxmlformats.org/presentationml/2006/main">
   <p:cSld>
     <p:spTree>
@@ -1947,7 +1858,7 @@
           <a:p>
             <a:fld id="{F7021451-1387-4CA6-816F-3879F97B5CBC}" type="slidenum">
               <a:rPr lang="en-US"/>
-              <a:t>23</a:t>
+              <a:t>22</a:t>
             </a:fld>
             <a:endParaRPr lang="en-US"/>
           </a:p>
@@ -1966,7 +1877,7 @@
 </p:notes>
 </file>
 
-<file path=ppt/notesSlides/notesSlide24.xml><?xml version="1.0" encoding="utf-8"?>
+<file path=ppt/notesSlides/notesSlide23.xml><?xml version="1.0" encoding="utf-8"?>
 <p:notes xmlns:a="http://schemas.openxmlformats.org/drawingml/2006/main" xmlns:r="http://schemas.openxmlformats.org/officeDocument/2006/relationships" xmlns:p="http://schemas.openxmlformats.org/presentationml/2006/main">
   <p:cSld>
     <p:spTree>
@@ -2036,7 +1947,7 @@
           <a:p>
             <a:fld id="{F7021451-1387-4CA6-816F-3879F97B5CBC}" type="slidenum">
               <a:rPr lang="en-US"/>
-              <a:t>24</a:t>
+              <a:t>23</a:t>
             </a:fld>
             <a:endParaRPr lang="en-US"/>
           </a:p>
@@ -2055,7 +1966,7 @@
 </p:notes>
 </file>
 
-<file path=ppt/notesSlides/notesSlide25.xml><?xml version="1.0" encoding="utf-8"?>
+<file path=ppt/notesSlides/notesSlide24.xml><?xml version="1.0" encoding="utf-8"?>
 <p:notes xmlns:a="http://schemas.openxmlformats.org/drawingml/2006/main" xmlns:r="http://schemas.openxmlformats.org/officeDocument/2006/relationships" xmlns:p="http://schemas.openxmlformats.org/presentationml/2006/main">
   <p:cSld>
     <p:spTree>
@@ -2132,7 +2043,7 @@
           <a:p>
             <a:fld id="{F7021451-1387-4CA6-816F-3879F97B5CBC}" type="slidenum">
               <a:rPr lang="en-US"/>
-              <a:t>25</a:t>
+              <a:t>24</a:t>
             </a:fld>
             <a:endParaRPr lang="en-US"/>
           </a:p>
@@ -2151,7 +2062,7 @@
 </p:notes>
 </file>
 
-<file path=ppt/notesSlides/notesSlide26.xml><?xml version="1.0" encoding="utf-8"?>
+<file path=ppt/notesSlides/notesSlide25.xml><?xml version="1.0" encoding="utf-8"?>
 <p:notes xmlns:a="http://schemas.openxmlformats.org/drawingml/2006/main" xmlns:r="http://schemas.openxmlformats.org/officeDocument/2006/relationships" xmlns:p="http://schemas.openxmlformats.org/presentationml/2006/main">
   <p:cSld>
     <p:spTree>
@@ -2225,7 +2136,7 @@
           <a:p>
             <a:fld id="{F7021451-1387-4CA6-816F-3879F97B5CBC}" type="slidenum">
               <a:rPr lang="en-US"/>
-              <a:t>26</a:t>
+              <a:t>25</a:t>
             </a:fld>
             <a:endParaRPr lang="en-US"/>
           </a:p>
@@ -2244,7 +2155,7 @@
 </p:notes>
 </file>
 
-<file path=ppt/notesSlides/notesSlide27.xml><?xml version="1.0" encoding="utf-8"?>
+<file path=ppt/notesSlides/notesSlide26.xml><?xml version="1.0" encoding="utf-8"?>
 <p:notes xmlns:a="http://schemas.openxmlformats.org/drawingml/2006/main" xmlns:r="http://schemas.openxmlformats.org/officeDocument/2006/relationships" xmlns:p="http://schemas.openxmlformats.org/presentationml/2006/main">
   <p:cSld>
     <p:spTree>
@@ -2317,7 +2228,7 @@
           <a:p>
             <a:fld id="{F7021451-1387-4CA6-816F-3879F97B5CBC}" type="slidenum">
               <a:rPr lang="en-US"/>
-              <a:t>27</a:t>
+              <a:t>26</a:t>
             </a:fld>
             <a:endParaRPr lang="en-US"/>
           </a:p>
@@ -2336,7 +2247,7 @@
 </p:notes>
 </file>
 
-<file path=ppt/notesSlides/notesSlide28.xml><?xml version="1.0" encoding="utf-8"?>
+<file path=ppt/notesSlides/notesSlide27.xml><?xml version="1.0" encoding="utf-8"?>
 <p:notes xmlns:a="http://schemas.openxmlformats.org/drawingml/2006/main" xmlns:r="http://schemas.openxmlformats.org/officeDocument/2006/relationships" xmlns:p="http://schemas.openxmlformats.org/presentationml/2006/main">
   <p:cSld>
     <p:spTree>
@@ -2409,7 +2320,7 @@
           <a:p>
             <a:fld id="{F7021451-1387-4CA6-816F-3879F97B5CBC}" type="slidenum">
               <a:rPr lang="en-US"/>
-              <a:t>28</a:t>
+              <a:t>27</a:t>
             </a:fld>
             <a:endParaRPr lang="en-US"/>
           </a:p>
@@ -2428,7 +2339,7 @@
 </p:notes>
 </file>
 
-<file path=ppt/notesSlides/notesSlide29.xml><?xml version="1.0" encoding="utf-8"?>
+<file path=ppt/notesSlides/notesSlide28.xml><?xml version="1.0" encoding="utf-8"?>
 <p:notes xmlns:a="http://schemas.openxmlformats.org/drawingml/2006/main" xmlns:r="http://schemas.openxmlformats.org/officeDocument/2006/relationships" xmlns:p="http://schemas.openxmlformats.org/presentationml/2006/main">
   <p:cSld>
     <p:spTree>
@@ -2505,6 +2416,96 @@
           <a:p>
             <a:fld id="{F7021451-1387-4CA6-816F-3879F97B5CBC}" type="slidenum">
               <a:rPr lang="en-US"/>
+              <a:t>28</a:t>
+            </a:fld>
+            <a:endParaRPr lang="en-US"/>
+          </a:p>
+        </p:txBody>
+      </p:sp>
+    </p:spTree>
+    <p:extLst>
+      <p:ext uri="{BB962C8B-B14F-4D97-AF65-F5344CB8AC3E}">
+        <p14:creationId xmlns:p14="http://schemas.microsoft.com/office/powerpoint/2010/main" val="1024086991"/>
+      </p:ext>
+    </p:extLst>
+  </p:cSld>
+  <p:clrMapOvr>
+    <a:masterClrMapping/>
+  </p:clrMapOvr>
+</p:notes>
+</file>
+
+<file path=ppt/notesSlides/notesSlide29.xml><?xml version="1.0" encoding="utf-8"?>
+<p:notes xmlns:a="http://schemas.openxmlformats.org/drawingml/2006/main" xmlns:r="http://schemas.openxmlformats.org/officeDocument/2006/relationships" xmlns:p="http://schemas.openxmlformats.org/presentationml/2006/main">
+  <p:cSld>
+    <p:spTree>
+      <p:nvGrpSpPr>
+        <p:cNvPr id="1" name=""/>
+        <p:cNvGrpSpPr/>
+        <p:nvPr/>
+      </p:nvGrpSpPr>
+      <p:grpSpPr>
+        <a:xfrm>
+          <a:off x="0" y="0"/>
+          <a:ext cx="0" cy="0"/>
+          <a:chOff x="0" y="0"/>
+          <a:chExt cx="0" cy="0"/>
+        </a:xfrm>
+      </p:grpSpPr>
+      <p:sp>
+        <p:nvSpPr>
+          <p:cNvPr id="2" name="Slide Image Placeholder 1"/>
+          <p:cNvSpPr>
+            <a:spLocks noGrp="1" noRot="1" noChangeAspect="1"/>
+          </p:cNvSpPr>
+          <p:nvPr>
+            <p:ph type="sldImg"/>
+          </p:nvPr>
+        </p:nvSpPr>
+        <p:spPr/>
+      </p:sp>
+      <p:sp>
+        <p:nvSpPr>
+          <p:cNvPr id="3" name="Notes Placeholder 2"/>
+          <p:cNvSpPr>
+            <a:spLocks noGrp="1"/>
+          </p:cNvSpPr>
+          <p:nvPr>
+            <p:ph type="body" idx="1"/>
+          </p:nvPr>
+        </p:nvSpPr>
+        <p:spPr/>
+        <p:txBody>
+          <a:bodyPr/>
+          <a:lstStyle/>
+          <a:p>
+            <a:r>
+              <a:rPr lang="en-US" dirty="0"/>
+              <a:t>The last line is the one to say out loud. A plugin framework in week 3, written
+for a capability they have not been given yet, is a cost with no evidence behind
+it. Future compatibility needs a reason.</a:t>
+            </a:r>
+            <a:endParaRPr lang="en-US" dirty="0"/>
+          </a:p>
+        </p:txBody>
+      </p:sp>
+      <p:sp>
+        <p:nvSpPr>
+          <p:cNvPr id="4" name="Slide Number Placeholder 3"/>
+          <p:cNvSpPr>
+            <a:spLocks noGrp="1"/>
+          </p:cNvSpPr>
+          <p:nvPr>
+            <p:ph type="sldNum" sz="quarter" idx="10"/>
+          </p:nvPr>
+        </p:nvSpPr>
+        <p:spPr/>
+        <p:txBody>
+          <a:bodyPr/>
+          <a:lstStyle/>
+          <a:p>
+            <a:fld id="{F7021451-1387-4CA6-816F-3879F97B5CBC}" type="slidenum">
+              <a:rPr lang="en-US"/>
               <a:t>29</a:t>
             </a:fld>
             <a:endParaRPr lang="en-US"/>
@@ -2665,96 +2666,6 @@
           <a:p>
             <a:r>
               <a:rPr lang="en-US" dirty="0"/>
-              <a:t>The last line is the one to say out loud. A plugin framework in week 3, written
-for a capability they have not been given yet, is a cost with no evidence behind
-it. Future compatibility needs a reason.</a:t>
-            </a:r>
-            <a:endParaRPr lang="en-US" dirty="0"/>
-          </a:p>
-        </p:txBody>
-      </p:sp>
-      <p:sp>
-        <p:nvSpPr>
-          <p:cNvPr id="4" name="Slide Number Placeholder 3"/>
-          <p:cNvSpPr>
-            <a:spLocks noGrp="1"/>
-          </p:cNvSpPr>
-          <p:nvPr>
-            <p:ph type="sldNum" sz="quarter" idx="10"/>
-          </p:nvPr>
-        </p:nvSpPr>
-        <p:spPr/>
-        <p:txBody>
-          <a:bodyPr/>
-          <a:lstStyle/>
-          <a:p>
-            <a:fld id="{F7021451-1387-4CA6-816F-3879F97B5CBC}" type="slidenum">
-              <a:rPr lang="en-US"/>
-              <a:t>30</a:t>
-            </a:fld>
-            <a:endParaRPr lang="en-US"/>
-          </a:p>
-        </p:txBody>
-      </p:sp>
-    </p:spTree>
-    <p:extLst>
-      <p:ext uri="{BB962C8B-B14F-4D97-AF65-F5344CB8AC3E}">
-        <p14:creationId xmlns:p14="http://schemas.microsoft.com/office/powerpoint/2010/main" val="1024086991"/>
-      </p:ext>
-    </p:extLst>
-  </p:cSld>
-  <p:clrMapOvr>
-    <a:masterClrMapping/>
-  </p:clrMapOvr>
-</p:notes>
-</file>
-
-<file path=ppt/notesSlides/notesSlide31.xml><?xml version="1.0" encoding="utf-8"?>
-<p:notes xmlns:a="http://schemas.openxmlformats.org/drawingml/2006/main" xmlns:r="http://schemas.openxmlformats.org/officeDocument/2006/relationships" xmlns:p="http://schemas.openxmlformats.org/presentationml/2006/main">
-  <p:cSld>
-    <p:spTree>
-      <p:nvGrpSpPr>
-        <p:cNvPr id="1" name=""/>
-        <p:cNvGrpSpPr/>
-        <p:nvPr/>
-      </p:nvGrpSpPr>
-      <p:grpSpPr>
-        <a:xfrm>
-          <a:off x="0" y="0"/>
-          <a:ext cx="0" cy="0"/>
-          <a:chOff x="0" y="0"/>
-          <a:chExt cx="0" cy="0"/>
-        </a:xfrm>
-      </p:grpSpPr>
-      <p:sp>
-        <p:nvSpPr>
-          <p:cNvPr id="2" name="Slide Image Placeholder 1"/>
-          <p:cNvSpPr>
-            <a:spLocks noGrp="1" noRot="1" noChangeAspect="1"/>
-          </p:cNvSpPr>
-          <p:nvPr>
-            <p:ph type="sldImg"/>
-          </p:nvPr>
-        </p:nvSpPr>
-        <p:spPr/>
-      </p:sp>
-      <p:sp>
-        <p:nvSpPr>
-          <p:cNvPr id="3" name="Notes Placeholder 2"/>
-          <p:cNvSpPr>
-            <a:spLocks noGrp="1"/>
-          </p:cNvSpPr>
-          <p:nvPr>
-            <p:ph type="body" idx="1"/>
-          </p:nvPr>
-        </p:nvSpPr>
-        <p:spPr/>
-        <p:txBody>
-          <a:bodyPr/>
-          <a:lstStyle/>
-          <a:p>
-            <a:r>
-              <a:rPr lang="en-US" dirty="0"/>
               <a:t>A system spec is not one giant context dump. Requirements map to planned tests,
 and those test files do not have to exist yet.
 Experiments are allowed. Label them, and reconcile them with the design before
@@ -2781,7 +2692,7 @@
           <a:p>
             <a:fld id="{F7021451-1387-4CA6-816F-3879F97B5CBC}" type="slidenum">
               <a:rPr lang="en-US"/>
-              <a:t>31</a:t>
+              <a:t>30</a:t>
             </a:fld>
             <a:endParaRPr lang="en-US"/>
           </a:p>
@@ -2800,7 +2711,7 @@
 </p:notes>
 </file>
 
-<file path=ppt/notesSlides/notesSlide32.xml><?xml version="1.0" encoding="utf-8"?>
+<file path=ppt/notesSlides/notesSlide31.xml><?xml version="1.0" encoding="utf-8"?>
 <p:notes xmlns:a="http://schemas.openxmlformats.org/drawingml/2006/main" xmlns:r="http://schemas.openxmlformats.org/officeDocument/2006/relationships" xmlns:p="http://schemas.openxmlformats.org/presentationml/2006/main">
   <p:cSld>
     <p:spTree>
@@ -2871,7 +2782,7 @@
           <a:p>
             <a:fld id="{F7021451-1387-4CA6-816F-3879F97B5CBC}" type="slidenum">
               <a:rPr lang="en-US"/>
-              <a:t>32</a:t>
+              <a:t>31</a:t>
             </a:fld>
             <a:endParaRPr lang="en-US"/>
           </a:p>
@@ -2890,7 +2801,7 @@
 </p:notes>
 </file>
 
-<file path=ppt/notesSlides/notesSlide33.xml><?xml version="1.0" encoding="utf-8"?>
+<file path=ppt/notesSlides/notesSlide32.xml><?xml version="1.0" encoding="utf-8"?>
 <p:notes xmlns:a="http://schemas.openxmlformats.org/drawingml/2006/main" xmlns:r="http://schemas.openxmlformats.org/officeDocument/2006/relationships" xmlns:p="http://schemas.openxmlformats.org/presentationml/2006/main">
   <p:cSld>
     <p:spTree>
@@ -2973,7 +2884,7 @@
           <a:p>
             <a:fld id="{F7021451-1387-4CA6-816F-3879F97B5CBC}" type="slidenum">
               <a:rPr lang="en-US"/>
-              <a:t>33</a:t>
+              <a:t>32</a:t>
             </a:fld>
             <a:endParaRPr lang="en-US"/>
           </a:p>
@@ -2992,7 +2903,7 @@
 </p:notes>
 </file>
 
-<file path=ppt/notesSlides/notesSlide34.xml><?xml version="1.0" encoding="utf-8"?>
+<file path=ppt/notesSlides/notesSlide33.xml><?xml version="1.0" encoding="utf-8"?>
 <p:notes xmlns:a="http://schemas.openxmlformats.org/drawingml/2006/main" xmlns:r="http://schemas.openxmlformats.org/officeDocument/2006/relationships" xmlns:p="http://schemas.openxmlformats.org/presentationml/2006/main">
   <p:cSld>
     <p:spTree>
@@ -3065,7 +2976,7 @@
           <a:p>
             <a:fld id="{F7021451-1387-4CA6-816F-3879F97B5CBC}" type="slidenum">
               <a:rPr lang="en-US"/>
-              <a:t>34</a:t>
+              <a:t>33</a:t>
             </a:fld>
             <a:endParaRPr lang="en-US"/>
           </a:p>
@@ -3084,7 +2995,7 @@
 </p:notes>
 </file>
 
-<file path=ppt/notesSlides/notesSlide35.xml><?xml version="1.0" encoding="utf-8"?>
+<file path=ppt/notesSlides/notesSlide34.xml><?xml version="1.0" encoding="utf-8"?>
 <p:notes xmlns:a="http://schemas.openxmlformats.org/drawingml/2006/main" xmlns:r="http://schemas.openxmlformats.org/officeDocument/2006/relationships" xmlns:p="http://schemas.openxmlformats.org/presentationml/2006/main">
   <p:cSld>
     <p:spTree>
@@ -3155,7 +3066,7 @@
           <a:p>
             <a:fld id="{F7021451-1387-4CA6-816F-3879F97B5CBC}" type="slidenum">
               <a:rPr lang="en-US"/>
-              <a:t>35</a:t>
+              <a:t>34</a:t>
             </a:fld>
             <a:endParaRPr lang="en-US"/>
           </a:p>
@@ -3174,7 +3085,7 @@
 </p:notes>
 </file>
 
-<file path=ppt/notesSlides/notesSlide36.xml><?xml version="1.0" encoding="utf-8"?>
+<file path=ppt/notesSlides/notesSlide35.xml><?xml version="1.0" encoding="utf-8"?>
 <p:notes xmlns:a="http://schemas.openxmlformats.org/drawingml/2006/main" xmlns:r="http://schemas.openxmlformats.org/officeDocument/2006/relationships" xmlns:p="http://schemas.openxmlformats.org/presentationml/2006/main">
   <p:cSld>
     <p:spTree>
@@ -3245,7 +3156,7 @@
           <a:p>
             <a:fld id="{F7021451-1387-4CA6-816F-3879F97B5CBC}" type="slidenum">
               <a:rPr lang="en-US"/>
-              <a:t>36</a:t>
+              <a:t>35</a:t>
             </a:fld>
             <a:endParaRPr lang="en-US"/>
           </a:p>
@@ -3264,7 +3175,7 @@
 </p:notes>
 </file>
 
-<file path=ppt/notesSlides/notesSlide37.xml><?xml version="1.0" encoding="utf-8"?>
+<file path=ppt/notesSlides/notesSlide36.xml><?xml version="1.0" encoding="utf-8"?>
 <p:notes xmlns:a="http://schemas.openxmlformats.org/drawingml/2006/main" xmlns:r="http://schemas.openxmlformats.org/officeDocument/2006/relationships" xmlns:p="http://schemas.openxmlformats.org/presentationml/2006/main">
   <p:cSld>
     <p:spTree>
@@ -3335,7 +3246,7 @@
           <a:p>
             <a:fld id="{F7021451-1387-4CA6-816F-3879F97B5CBC}" type="slidenum">
               <a:rPr lang="en-US"/>
-              <a:t>37</a:t>
+              <a:t>36</a:t>
             </a:fld>
             <a:endParaRPr lang="en-US"/>
           </a:p>
@@ -3354,7 +3265,7 @@
 </p:notes>
 </file>
 
-<file path=ppt/notesSlides/notesSlide38.xml><?xml version="1.0" encoding="utf-8"?>
+<file path=ppt/notesSlides/notesSlide37.xml><?xml version="1.0" encoding="utf-8"?>
 <p:notes xmlns:a="http://schemas.openxmlformats.org/drawingml/2006/main" xmlns:r="http://schemas.openxmlformats.org/officeDocument/2006/relationships" xmlns:p="http://schemas.openxmlformats.org/presentationml/2006/main">
   <p:cSld>
     <p:spTree>
@@ -3425,7 +3336,7 @@
           <a:p>
             <a:fld id="{F7021451-1387-4CA6-816F-3879F97B5CBC}" type="slidenum">
               <a:rPr lang="en-US"/>
-              <a:t>38</a:t>
+              <a:t>37</a:t>
             </a:fld>
             <a:endParaRPr lang="en-US"/>
           </a:p>
@@ -3444,7 +3355,7 @@
 </p:notes>
 </file>
 
-<file path=ppt/notesSlides/notesSlide39.xml><?xml version="1.0" encoding="utf-8"?>
+<file path=ppt/notesSlides/notesSlide38.xml><?xml version="1.0" encoding="utf-8"?>
 <p:notes xmlns:a="http://schemas.openxmlformats.org/drawingml/2006/main" xmlns:r="http://schemas.openxmlformats.org/officeDocument/2006/relationships" xmlns:p="http://schemas.openxmlformats.org/presentationml/2006/main">
   <p:cSld>
     <p:spTree>
@@ -3492,6 +3403,97 @@
               <a:rPr lang="en-US" dirty="0"/>
               <a:t>End the comparison here, at minute 65. Nothing after this slide is yours to
 talk through.</a:t>
+            </a:r>
+            <a:endParaRPr lang="en-US" dirty="0"/>
+          </a:p>
+        </p:txBody>
+      </p:sp>
+      <p:sp>
+        <p:nvSpPr>
+          <p:cNvPr id="4" name="Slide Number Placeholder 3"/>
+          <p:cNvSpPr>
+            <a:spLocks noGrp="1"/>
+          </p:cNvSpPr>
+          <p:nvPr>
+            <p:ph type="sldNum" sz="quarter" idx="10"/>
+          </p:nvPr>
+        </p:nvSpPr>
+        <p:spPr/>
+        <p:txBody>
+          <a:bodyPr/>
+          <a:lstStyle/>
+          <a:p>
+            <a:fld id="{F7021451-1387-4CA6-816F-3879F97B5CBC}" type="slidenum">
+              <a:rPr lang="en-US"/>
+              <a:t>38</a:t>
+            </a:fld>
+            <a:endParaRPr lang="en-US"/>
+          </a:p>
+        </p:txBody>
+      </p:sp>
+    </p:spTree>
+    <p:extLst>
+      <p:ext uri="{BB962C8B-B14F-4D97-AF65-F5344CB8AC3E}">
+        <p14:creationId xmlns:p14="http://schemas.microsoft.com/office/powerpoint/2010/main" val="1024086991"/>
+      </p:ext>
+    </p:extLst>
+  </p:cSld>
+  <p:clrMapOvr>
+    <a:masterClrMapping/>
+  </p:clrMapOvr>
+</p:notes>
+</file>
+
+<file path=ppt/notesSlides/notesSlide39.xml><?xml version="1.0" encoding="utf-8"?>
+<p:notes xmlns:a="http://schemas.openxmlformats.org/drawingml/2006/main" xmlns:r="http://schemas.openxmlformats.org/officeDocument/2006/relationships" xmlns:p="http://schemas.openxmlformats.org/presentationml/2006/main">
+  <p:cSld>
+    <p:spTree>
+      <p:nvGrpSpPr>
+        <p:cNvPr id="1" name=""/>
+        <p:cNvGrpSpPr/>
+        <p:nvPr/>
+      </p:nvGrpSpPr>
+      <p:grpSpPr>
+        <a:xfrm>
+          <a:off x="0" y="0"/>
+          <a:ext cx="0" cy="0"/>
+          <a:chOff x="0" y="0"/>
+          <a:chExt cx="0" cy="0"/>
+        </a:xfrm>
+      </p:grpSpPr>
+      <p:sp>
+        <p:nvSpPr>
+          <p:cNvPr id="2" name="Slide Image Placeholder 1"/>
+          <p:cNvSpPr>
+            <a:spLocks noGrp="1" noRot="1" noChangeAspect="1"/>
+          </p:cNvSpPr>
+          <p:nvPr>
+            <p:ph type="sldImg"/>
+          </p:nvPr>
+        </p:nvSpPr>
+        <p:spPr/>
+      </p:sp>
+      <p:sp>
+        <p:nvSpPr>
+          <p:cNvPr id="3" name="Notes Placeholder 2"/>
+          <p:cNvSpPr>
+            <a:spLocks noGrp="1"/>
+          </p:cNvSpPr>
+          <p:nvPr>
+            <p:ph type="body" idx="1"/>
+          </p:nvPr>
+        </p:nvSpPr>
+        <p:spPr/>
+        <p:txBody>
+          <a:bodyPr/>
+          <a:lstStyle/>
+          <a:p>
+            <a:r>
+              <a:rPr lang="en-US" dirty="0"/>
+              <a:t>Stop talking. Staff circulate from here. Leave the deck up so students can page
+back through it themselves.
+This is the point where you say plainly that nothing is due at the end of
+today. Most of them will still expect a checkoff.</a:t>
             </a:r>
             <a:endParaRPr lang="en-US" dirty="0"/>
           </a:p>
@@ -3675,10 +3677,7 @@
           <a:p>
             <a:r>
               <a:rPr lang="en-US" dirty="0"/>
-              <a:t>Stop talking. Staff circulate from here. Leave the deck up so students can page
-back through it themselves.
-This is the point where you say plainly that nothing is due at the end of
-today. Most of them will still expect a checkoff.</a:t>
+              <a:t/>
             </a:r>
             <a:endParaRPr lang="en-US" dirty="0"/>
           </a:p>
@@ -3702,94 +3701,6 @@
             <a:fld id="{F7021451-1387-4CA6-816F-3879F97B5CBC}" type="slidenum">
               <a:rPr lang="en-US"/>
               <a:t>40</a:t>
-            </a:fld>
-            <a:endParaRPr lang="en-US"/>
-          </a:p>
-        </p:txBody>
-      </p:sp>
-    </p:spTree>
-    <p:extLst>
-      <p:ext uri="{BB962C8B-B14F-4D97-AF65-F5344CB8AC3E}">
-        <p14:creationId xmlns:p14="http://schemas.microsoft.com/office/powerpoint/2010/main" val="1024086991"/>
-      </p:ext>
-    </p:extLst>
-  </p:cSld>
-  <p:clrMapOvr>
-    <a:masterClrMapping/>
-  </p:clrMapOvr>
-</p:notes>
-</file>
-
-<file path=ppt/notesSlides/notesSlide41.xml><?xml version="1.0" encoding="utf-8"?>
-<p:notes xmlns:a="http://schemas.openxmlformats.org/drawingml/2006/main" xmlns:r="http://schemas.openxmlformats.org/officeDocument/2006/relationships" xmlns:p="http://schemas.openxmlformats.org/presentationml/2006/main">
-  <p:cSld>
-    <p:spTree>
-      <p:nvGrpSpPr>
-        <p:cNvPr id="1" name=""/>
-        <p:cNvGrpSpPr/>
-        <p:nvPr/>
-      </p:nvGrpSpPr>
-      <p:grpSpPr>
-        <a:xfrm>
-          <a:off x="0" y="0"/>
-          <a:ext cx="0" cy="0"/>
-          <a:chOff x="0" y="0"/>
-          <a:chExt cx="0" cy="0"/>
-        </a:xfrm>
-      </p:grpSpPr>
-      <p:sp>
-        <p:nvSpPr>
-          <p:cNvPr id="2" name="Slide Image Placeholder 1"/>
-          <p:cNvSpPr>
-            <a:spLocks noGrp="1" noRot="1" noChangeAspect="1"/>
-          </p:cNvSpPr>
-          <p:nvPr>
-            <p:ph type="sldImg"/>
-          </p:nvPr>
-        </p:nvSpPr>
-        <p:spPr/>
-      </p:sp>
-      <p:sp>
-        <p:nvSpPr>
-          <p:cNvPr id="3" name="Notes Placeholder 2"/>
-          <p:cNvSpPr>
-            <a:spLocks noGrp="1"/>
-          </p:cNvSpPr>
-          <p:nvPr>
-            <p:ph type="body" idx="1"/>
-          </p:nvPr>
-        </p:nvSpPr>
-        <p:spPr/>
-        <p:txBody>
-          <a:bodyPr/>
-          <a:lstStyle/>
-          <a:p>
-            <a:r>
-              <a:rPr lang="en-US" dirty="0"/>
-              <a:t/>
-            </a:r>
-            <a:endParaRPr lang="en-US" dirty="0"/>
-          </a:p>
-        </p:txBody>
-      </p:sp>
-      <p:sp>
-        <p:nvSpPr>
-          <p:cNvPr id="4" name="Slide Number Placeholder 3"/>
-          <p:cNvSpPr>
-            <a:spLocks noGrp="1"/>
-          </p:cNvSpPr>
-          <p:nvPr>
-            <p:ph type="sldNum" sz="quarter" idx="10"/>
-          </p:nvPr>
-        </p:nvSpPr>
-        <p:spPr/>
-        <p:txBody>
-          <a:bodyPr/>
-          <a:lstStyle/>
-          <a:p>
-            <a:fld id="{F7021451-1387-4CA6-816F-3879F97B5CBC}" type="slidenum">
-              <a:rPr lang="en-US"/>
-              <a:t>41</a:t>
             </a:fld>
             <a:endParaRPr lang="en-US"/>
           </a:p>
@@ -3946,10 +3857,7 @@
           <a:p>
             <a:r>
               <a:rPr lang="en-US" dirty="0"/>
-              <a:t>They met this request in the practice lessons, in whole-file mode. Today's
-trace is diff mode and it is illustrative: a simplified turn, not a captured
-transcript of a particular model. The three files matter later, when the
-feature half-works.</a:t>
+              <a:t>Six steps. Say up front that only step 2 belongs to the model.</a:t>
             </a:r>
             <a:endParaRPr lang="en-US" dirty="0"/>
           </a:p>
@@ -3992,94 +3900,6 @@
 </file>
 
 <file path=ppt/notesSlides/notesSlide7.xml><?xml version="1.0" encoding="utf-8"?>
-<p:notes xmlns:a="http://schemas.openxmlformats.org/drawingml/2006/main" xmlns:r="http://schemas.openxmlformats.org/officeDocument/2006/relationships" xmlns:p="http://schemas.openxmlformats.org/presentationml/2006/main">
-  <p:cSld>
-    <p:spTree>
-      <p:nvGrpSpPr>
-        <p:cNvPr id="1" name=""/>
-        <p:cNvGrpSpPr/>
-        <p:nvPr/>
-      </p:nvGrpSpPr>
-      <p:grpSpPr>
-        <a:xfrm>
-          <a:off x="0" y="0"/>
-          <a:ext cx="0" cy="0"/>
-          <a:chOff x="0" y="0"/>
-          <a:chExt cx="0" cy="0"/>
-        </a:xfrm>
-      </p:grpSpPr>
-      <p:sp>
-        <p:nvSpPr>
-          <p:cNvPr id="2" name="Slide Image Placeholder 1"/>
-          <p:cNvSpPr>
-            <a:spLocks noGrp="1" noRot="1" noChangeAspect="1"/>
-          </p:cNvSpPr>
-          <p:nvPr>
-            <p:ph type="sldImg"/>
-          </p:nvPr>
-        </p:nvSpPr>
-        <p:spPr/>
-      </p:sp>
-      <p:sp>
-        <p:nvSpPr>
-          <p:cNvPr id="3" name="Notes Placeholder 2"/>
-          <p:cNvSpPr>
-            <a:spLocks noGrp="1"/>
-          </p:cNvSpPr>
-          <p:nvPr>
-            <p:ph type="body" idx="1"/>
-          </p:nvPr>
-        </p:nvSpPr>
-        <p:spPr/>
-        <p:txBody>
-          <a:bodyPr/>
-          <a:lstStyle/>
-          <a:p>
-            <a:r>
-              <a:rPr lang="en-US" dirty="0"/>
-              <a:t>Six steps. Say up front that only step 2 belongs to the model.</a:t>
-            </a:r>
-            <a:endParaRPr lang="en-US" dirty="0"/>
-          </a:p>
-        </p:txBody>
-      </p:sp>
-      <p:sp>
-        <p:nvSpPr>
-          <p:cNvPr id="4" name="Slide Number Placeholder 3"/>
-          <p:cNvSpPr>
-            <a:spLocks noGrp="1"/>
-          </p:cNvSpPr>
-          <p:nvPr>
-            <p:ph type="sldNum" sz="quarter" idx="10"/>
-          </p:nvPr>
-        </p:nvSpPr>
-        <p:spPr/>
-        <p:txBody>
-          <a:bodyPr/>
-          <a:lstStyle/>
-          <a:p>
-            <a:fld id="{F7021451-1387-4CA6-816F-3879F97B5CBC}" type="slidenum">
-              <a:rPr lang="en-US"/>
-              <a:t>7</a:t>
-            </a:fld>
-            <a:endParaRPr lang="en-US"/>
-          </a:p>
-        </p:txBody>
-      </p:sp>
-    </p:spTree>
-    <p:extLst>
-      <p:ext uri="{BB962C8B-B14F-4D97-AF65-F5344CB8AC3E}">
-        <p14:creationId xmlns:p14="http://schemas.microsoft.com/office/powerpoint/2010/main" val="1024086991"/>
-      </p:ext>
-    </p:extLst>
-  </p:cSld>
-  <p:clrMapOvr>
-    <a:masterClrMapping/>
-  </p:clrMapOvr>
-</p:notes>
-</file>
-
-<file path=ppt/notesSlides/notesSlide8.xml><?xml version="1.0" encoding="utf-8"?>
 <p:notes xmlns:a="http://schemas.openxmlformats.org/drawingml/2006/main" xmlns:r="http://schemas.openxmlformats.org/officeDocument/2006/relationships" xmlns:p="http://schemas.openxmlformats.org/presentationml/2006/main">
   <p:cSld>
     <p:spTree>
@@ -4151,7 +3971,7 @@
           <a:p>
             <a:fld id="{F7021451-1387-4CA6-816F-3879F97B5CBC}" type="slidenum">
               <a:rPr lang="en-US"/>
-              <a:t>8</a:t>
+              <a:t>7</a:t>
             </a:fld>
             <a:endParaRPr lang="en-US"/>
           </a:p>
@@ -4170,7 +3990,7 @@
 </p:notes>
 </file>
 
-<file path=ppt/notesSlides/notesSlide9.xml><?xml version="1.0" encoding="utf-8"?>
+<file path=ppt/notesSlides/notesSlide8.xml><?xml version="1.0" encoding="utf-8"?>
 <p:notes xmlns:a="http://schemas.openxmlformats.org/drawingml/2006/main" xmlns:r="http://schemas.openxmlformats.org/officeDocument/2006/relationships" xmlns:p="http://schemas.openxmlformats.org/presentationml/2006/main">
   <p:cSld>
     <p:spTree>
@@ -4219,8 +4039,99 @@
               <a:t>Do not claim a fixed seven-part ordering. What actually goes into the prompt
 depends on the coder, the model and the settings, and it changes between
 releases. The list above is the shape, not the wire format.
-Ask what the model would need in order to add priority consistently to the CLI,
-the task and the store. That question sets up the next two slides.</a:t>
+Ask what the model would need in order to change three files consistently, when
+nothing has told it which three. That question sets up the next two slides.</a:t>
+            </a:r>
+            <a:endParaRPr lang="en-US" dirty="0"/>
+          </a:p>
+        </p:txBody>
+      </p:sp>
+      <p:sp>
+        <p:nvSpPr>
+          <p:cNvPr id="4" name="Slide Number Placeholder 3"/>
+          <p:cNvSpPr>
+            <a:spLocks noGrp="1"/>
+          </p:cNvSpPr>
+          <p:nvPr>
+            <p:ph type="sldNum" sz="quarter" idx="10"/>
+          </p:nvPr>
+        </p:nvSpPr>
+        <p:spPr/>
+        <p:txBody>
+          <a:bodyPr/>
+          <a:lstStyle/>
+          <a:p>
+            <a:fld id="{F7021451-1387-4CA6-816F-3879F97B5CBC}" type="slidenum">
+              <a:rPr lang="en-US"/>
+              <a:t>8</a:t>
+            </a:fld>
+            <a:endParaRPr lang="en-US"/>
+          </a:p>
+        </p:txBody>
+      </p:sp>
+    </p:spTree>
+    <p:extLst>
+      <p:ext uri="{BB962C8B-B14F-4D97-AF65-F5344CB8AC3E}">
+        <p14:creationId xmlns:p14="http://schemas.microsoft.com/office/powerpoint/2010/main" val="1024086991"/>
+      </p:ext>
+    </p:extLst>
+  </p:cSld>
+  <p:clrMapOvr>
+    <a:masterClrMapping/>
+  </p:clrMapOvr>
+</p:notes>
+</file>
+
+<file path=ppt/notesSlides/notesSlide9.xml><?xml version="1.0" encoding="utf-8"?>
+<p:notes xmlns:a="http://schemas.openxmlformats.org/drawingml/2006/main" xmlns:r="http://schemas.openxmlformats.org/officeDocument/2006/relationships" xmlns:p="http://schemas.openxmlformats.org/presentationml/2006/main">
+  <p:cSld>
+    <p:spTree>
+      <p:nvGrpSpPr>
+        <p:cNvPr id="1" name=""/>
+        <p:cNvGrpSpPr/>
+        <p:nvPr/>
+      </p:nvGrpSpPr>
+      <p:grpSpPr>
+        <a:xfrm>
+          <a:off x="0" y="0"/>
+          <a:ext cx="0" cy="0"/>
+          <a:chOff x="0" y="0"/>
+          <a:chExt cx="0" cy="0"/>
+        </a:xfrm>
+      </p:grpSpPr>
+      <p:sp>
+        <p:nvSpPr>
+          <p:cNvPr id="2" name="Slide Image Placeholder 1"/>
+          <p:cNvSpPr>
+            <a:spLocks noGrp="1" noRot="1" noChangeAspect="1"/>
+          </p:cNvSpPr>
+          <p:nvPr>
+            <p:ph type="sldImg"/>
+          </p:nvPr>
+        </p:nvSpPr>
+        <p:spPr/>
+      </p:sp>
+      <p:sp>
+        <p:nvSpPr>
+          <p:cNvPr id="3" name="Notes Placeholder 2"/>
+          <p:cNvSpPr>
+            <a:spLocks noGrp="1"/>
+          </p:cNvSpPr>
+          <p:nvPr>
+            <p:ph type="body" idx="1"/>
+          </p:nvPr>
+        </p:nvSpPr>
+        <p:spPr/>
+        <p:txBody>
+          <a:bodyPr/>
+          <a:lstStyle/>
+          <a:p>
+            <a:r>
+              <a:rPr lang="en-US" dirty="0"/>
+              <a:t>Walk through choosing the few files a change touches rather than the whole
+package. Adding everything is not a selection strategy, it is a way to spend
+the budget. Read-only context still costs budget. /tokens tells you what you
+are spending, and nothing about whether the edit will be correct.</a:t>
             </a:r>
             <a:endParaRPr lang="en-US" dirty="0"/>
           </a:p>
@@ -5898,45 +5809,6 @@
 <file path=ppt/slides/slide40.xml><?xml version="1.0" encoding="utf-8"?>
 <p:sld xmlns:a="http://schemas.openxmlformats.org/drawingml/2006/main" xmlns:r="http://schemas.openxmlformats.org/officeDocument/2006/relationships" xmlns:p="http://schemas.openxmlformats.org/presentationml/2006/main">
   <p:cSld name="Slide 40">
-    <p:bg>
-      <p:bgPr>
-        <a:blipFill dpi="0" rotWithShape="1">
-          <a:blip r:embed="rId1">
-            <a:lum/>
-          </a:blip>
-          <a:srcRect/>
-          <a:stretch>
-            <a:fillRect/>
-          </a:stretch>
-        </a:blipFill>
-        <a:effectLst/>
-      </p:bgPr>
-    </p:bg>
-    <p:spTree>
-      <p:nvGrpSpPr>
-        <p:cNvPr id="1" name=""/>
-        <p:cNvGrpSpPr/>
-        <p:nvPr/>
-      </p:nvGrpSpPr>
-      <p:grpSpPr>
-        <a:xfrm>
-          <a:off x="0" y="0"/>
-          <a:ext cx="0" cy="0"/>
-          <a:chOff x="0" y="0"/>
-          <a:chExt cx="0" cy="0"/>
-        </a:xfrm>
-      </p:grpSpPr>
-    </p:spTree>
-  </p:cSld>
-  <p:clrMapOvr>
-    <a:masterClrMapping/>
-  </p:clrMapOvr>
-</p:sld>
-</file>
-
-<file path=ppt/slides/slide41.xml><?xml version="1.0" encoding="utf-8"?>
-<p:sld xmlns:a="http://schemas.openxmlformats.org/drawingml/2006/main" xmlns:r="http://schemas.openxmlformats.org/officeDocument/2006/relationships" xmlns:p="http://schemas.openxmlformats.org/presentationml/2006/main">
-  <p:cSld name="Slide 41">
     <p:bg>
       <p:bgPr>
         <a:blipFill dpi="0" rotWithShape="1">

</xml_diff>

<commit_message>
Lab01: reship the deck at 32 slides
Matches eecs498-aase/aase-f26 at e016ed0. The repo map is three slides
again, the turn ends at applying an edit, and the project and closing
sections are rewritten.

Co-Authored-By: Claude Opus 5 (1M context) <noreply@anthropic.com>
Claude-Session: https://claude.ai/code/session_015pu78gNF4378sH81fTPKSc
</commit_message>
<xml_diff>
--- a/labs/Lab01/slides.pptx
+++ b/labs/Lab01/slides.pptx
@@ -37,17 +37,9 @@
     <p:sldId id="285" r:id="rId31"/>
     <p:sldId id="286" r:id="rId32"/>
     <p:sldId id="287" r:id="rId33"/>
-    <p:sldId id="288" r:id="rId34"/>
-    <p:sldId id="289" r:id="rId35"/>
-    <p:sldId id="290" r:id="rId36"/>
-    <p:sldId id="291" r:id="rId37"/>
-    <p:sldId id="292" r:id="rId38"/>
-    <p:sldId id="293" r:id="rId39"/>
-    <p:sldId id="294" r:id="rId40"/>
-    <p:sldId id="295" r:id="rId41"/>
   </p:sldIdLst>
   <p:notesMasterIdLst>
-    <p:notesMasterId r:id="rId42"/>
+    <p:notesMasterId r:id="rId34"/>
   </p:notesMasterIdLst>
   <p:sldSz cx="9334500" cy="5248275"/>
   <p:notesSz cx="5248275" cy="9334500"/>
@@ -631,13 +623,10 @@
           <a:p>
             <a:r>
               <a:rPr lang="en-US" dirty="0"/>
-              <a:t>The excerpt is illustrative. Do not promise the map contains every file, and do
-not use its silence as proof that a dependency is absent. When a student says
-"the model should have known," check whether they added the file or only let the
-map mention it. Source: https://aider.chat/docs/repomap.html
-Cut from the slide and worth saying: a signature tells you where to look, it
-does not tell the model how the function works. Students read a map line as
-evidence the model understands the function.</a:t>
+              <a:t>Point at the vertical bars: that is aider quoting source lines. Point at the
+dots: that is everything it decided not to spend tokens on.
+Ask what this is for. The answer is on the next slide: it is aider guessing
+what you would have typed /add for.</a:t>
             </a:r>
             <a:endParaRPr lang="en-US" dirty="0"/>
           </a:p>
@@ -680,6 +669,193 @@
 </file>
 
 <file path=ppt/notesSlides/notesSlide11.xml><?xml version="1.0" encoding="utf-8"?>
+<p:notes xmlns:a="http://schemas.openxmlformats.org/drawingml/2006/main" xmlns:r="http://schemas.openxmlformats.org/officeDocument/2006/relationships" xmlns:p="http://schemas.openxmlformats.org/presentationml/2006/main">
+  <p:cSld>
+    <p:spTree>
+      <p:nvGrpSpPr>
+        <p:cNvPr id="1" name=""/>
+        <p:cNvGrpSpPr/>
+        <p:nvPr/>
+      </p:nvGrpSpPr>
+      <p:grpSpPr>
+        <a:xfrm>
+          <a:off x="0" y="0"/>
+          <a:ext cx="0" cy="0"/>
+          <a:chOff x="0" y="0"/>
+          <a:chExt cx="0" cy="0"/>
+        </a:xfrm>
+      </p:grpSpPr>
+      <p:sp>
+        <p:nvSpPr>
+          <p:cNvPr id="2" name="Slide Image Placeholder 1"/>
+          <p:cNvSpPr>
+            <a:spLocks noGrp="1" noRot="1" noChangeAspect="1"/>
+          </p:cNvSpPr>
+          <p:nvPr>
+            <p:ph type="sldImg"/>
+          </p:nvPr>
+        </p:nvSpPr>
+        <p:spPr/>
+      </p:sp>
+      <p:sp>
+        <p:nvSpPr>
+          <p:cNvPr id="3" name="Notes Placeholder 2"/>
+          <p:cNvSpPr>
+            <a:spLocks noGrp="1"/>
+          </p:cNvSpPr>
+          <p:nvPr>
+            <p:ph type="body" idx="1"/>
+          </p:nvPr>
+        </p:nvSpPr>
+        <p:spPr/>
+        <p:txBody>
+          <a:bodyPr/>
+          <a:lstStyle/>
+          <a:p>
+            <a:r>
+              <a:rPr lang="en-US" dirty="0"/>
+              <a:t>Off the slide and worth saying: the ranking is tilted toward files you just
+mentioned, and aider renders down the list until the tokens run out.
+Say the ranking rule plainly: a file that lots of other files depend on scores
+high, because it is probably the one you need to know about.
+The dashed line is the point. It is not "here is your repo," it is "here is as
+much of your repo as fits," and whatever falls under the line is invisible to
+the model. 867 lines of aider to guess what you would have typed /add for.</a:t>
+            </a:r>
+            <a:endParaRPr lang="en-US" dirty="0"/>
+          </a:p>
+        </p:txBody>
+      </p:sp>
+      <p:sp>
+        <p:nvSpPr>
+          <p:cNvPr id="4" name="Slide Number Placeholder 3"/>
+          <p:cNvSpPr>
+            <a:spLocks noGrp="1"/>
+          </p:cNvSpPr>
+          <p:nvPr>
+            <p:ph type="sldNum" sz="quarter" idx="10"/>
+          </p:nvPr>
+        </p:nvSpPr>
+        <p:spPr/>
+        <p:txBody>
+          <a:bodyPr/>
+          <a:lstStyle/>
+          <a:p>
+            <a:fld id="{F7021451-1387-4CA6-816F-3879F97B5CBC}" type="slidenum">
+              <a:rPr lang="en-US"/>
+              <a:t>11</a:t>
+            </a:fld>
+            <a:endParaRPr lang="en-US"/>
+          </a:p>
+        </p:txBody>
+      </p:sp>
+    </p:spTree>
+    <p:extLst>
+      <p:ext uri="{BB962C8B-B14F-4D97-AF65-F5344CB8AC3E}">
+        <p14:creationId xmlns:p14="http://schemas.microsoft.com/office/powerpoint/2010/main" val="1024086991"/>
+      </p:ext>
+    </p:extLst>
+  </p:cSld>
+  <p:clrMapOvr>
+    <a:masterClrMapping/>
+  </p:clrMapOvr>
+</p:notes>
+</file>
+
+<file path=ppt/notesSlides/notesSlide12.xml><?xml version="1.0" encoding="utf-8"?>
+<p:notes xmlns:a="http://schemas.openxmlformats.org/drawingml/2006/main" xmlns:r="http://schemas.openxmlformats.org/officeDocument/2006/relationships" xmlns:p="http://schemas.openxmlformats.org/presentationml/2006/main">
+  <p:cSld>
+    <p:spTree>
+      <p:nvGrpSpPr>
+        <p:cNvPr id="1" name=""/>
+        <p:cNvGrpSpPr/>
+        <p:nvPr/>
+      </p:nvGrpSpPr>
+      <p:grpSpPr>
+        <a:xfrm>
+          <a:off x="0" y="0"/>
+          <a:ext cx="0" cy="0"/>
+          <a:chOff x="0" y="0"/>
+          <a:chExt cx="0" cy="0"/>
+        </a:xfrm>
+      </p:grpSpPr>
+      <p:sp>
+        <p:nvSpPr>
+          <p:cNvPr id="2" name="Slide Image Placeholder 1"/>
+          <p:cNvSpPr>
+            <a:spLocks noGrp="1" noRot="1" noChangeAspect="1"/>
+          </p:cNvSpPr>
+          <p:nvPr>
+            <p:ph type="sldImg"/>
+          </p:nvPr>
+        </p:nvSpPr>
+        <p:spPr/>
+      </p:sp>
+      <p:sp>
+        <p:nvSpPr>
+          <p:cNvPr id="3" name="Notes Placeholder 2"/>
+          <p:cNvSpPr>
+            <a:spLocks noGrp="1"/>
+          </p:cNvSpPr>
+          <p:nvPr>
+            <p:ph type="body" idx="1"/>
+          </p:nvPr>
+        </p:nvSpPr>
+        <p:spPr/>
+        <p:txBody>
+          <a:bodyPr/>
+          <a:lstStyle/>
+          <a:p>
+            <a:r>
+              <a:rPr lang="en-US" dirty="0"/>
+              <a:t>Off the slide: on a small model the map often costs more than the files it was
+guessing about.
+This is why aider-practice turns it down. On a 4B with a small window the map
+can eat a third of the budget to describe files the model then cannot see the
+insides of anyway.
+It is out of scope for the build. Say so here, so nobody spends week 4 on it.</a:t>
+            </a:r>
+            <a:endParaRPr lang="en-US" dirty="0"/>
+          </a:p>
+        </p:txBody>
+      </p:sp>
+      <p:sp>
+        <p:nvSpPr>
+          <p:cNvPr id="4" name="Slide Number Placeholder 3"/>
+          <p:cNvSpPr>
+            <a:spLocks noGrp="1"/>
+          </p:cNvSpPr>
+          <p:nvPr>
+            <p:ph type="sldNum" sz="quarter" idx="10"/>
+          </p:nvPr>
+        </p:nvSpPr>
+        <p:spPr/>
+        <p:txBody>
+          <a:bodyPr/>
+          <a:lstStyle/>
+          <a:p>
+            <a:fld id="{F7021451-1387-4CA6-816F-3879F97B5CBC}" type="slidenum">
+              <a:rPr lang="en-US"/>
+              <a:t>12</a:t>
+            </a:fld>
+            <a:endParaRPr lang="en-US"/>
+          </a:p>
+        </p:txBody>
+      </p:sp>
+    </p:spTree>
+    <p:extLst>
+      <p:ext uri="{BB962C8B-B14F-4D97-AF65-F5344CB8AC3E}">
+        <p14:creationId xmlns:p14="http://schemas.microsoft.com/office/powerpoint/2010/main" val="1024086991"/>
+      </p:ext>
+    </p:extLst>
+  </p:cSld>
+  <p:clrMapOvr>
+    <a:masterClrMapping/>
+  </p:clrMapOvr>
+</p:notes>
+</file>
+
+<file path=ppt/notesSlides/notesSlide13.xml><?xml version="1.0" encoding="utf-8"?>
 <p:notes xmlns:a="http://schemas.openxmlformats.org/drawingml/2006/main" xmlns:r="http://schemas.openxmlformats.org/officeDocument/2006/relationships" xmlns:p="http://schemas.openxmlformats.org/presentationml/2006/main">
   <p:cSld>
     <p:spTree>
@@ -751,7 +927,7 @@
           <a:p>
             <a:fld id="{F7021451-1387-4CA6-816F-3879F97B5CBC}" type="slidenum">
               <a:rPr lang="en-US"/>
-              <a:t>11</a:t>
+              <a:t>13</a:t>
             </a:fld>
             <a:endParaRPr lang="en-US"/>
           </a:p>
@@ -770,7 +946,7 @@
 </p:notes>
 </file>
 
-<file path=ppt/notesSlides/notesSlide12.xml><?xml version="1.0" encoding="utf-8"?>
+<file path=ppt/notesSlides/notesSlide14.xml><?xml version="1.0" encoding="utf-8"?>
 <p:notes xmlns:a="http://schemas.openxmlformats.org/drawingml/2006/main" xmlns:r="http://schemas.openxmlformats.org/officeDocument/2006/relationships" xmlns:p="http://schemas.openxmlformats.org/presentationml/2006/main">
   <p:cSld>
     <p:spTree>
@@ -843,7 +1019,7 @@
           <a:p>
             <a:fld id="{F7021451-1387-4CA6-816F-3879F97B5CBC}" type="slidenum">
               <a:rPr lang="en-US"/>
-              <a:t>12</a:t>
+              <a:t>14</a:t>
             </a:fld>
             <a:endParaRPr lang="en-US"/>
           </a:p>
@@ -862,7 +1038,7 @@
 </p:notes>
 </file>
 
-<file path=ppt/notesSlides/notesSlide13.xml><?xml version="1.0" encoding="utf-8"?>
+<file path=ppt/notesSlides/notesSlide15.xml><?xml version="1.0" encoding="utf-8"?>
 <p:notes xmlns:a="http://schemas.openxmlformats.org/drawingml/2006/main" xmlns:r="http://schemas.openxmlformats.org/officeDocument/2006/relationships" xmlns:p="http://schemas.openxmlformats.org/presentationml/2006/main">
   <p:cSld>
     <p:spTree>
@@ -933,7 +1109,7 @@
           <a:p>
             <a:fld id="{F7021451-1387-4CA6-816F-3879F97B5CBC}" type="slidenum">
               <a:rPr lang="en-US"/>
-              <a:t>13</a:t>
+              <a:t>15</a:t>
             </a:fld>
             <a:endParaRPr lang="en-US"/>
           </a:p>
@@ -952,7 +1128,7 @@
 </p:notes>
 </file>
 
-<file path=ppt/notesSlides/notesSlide14.xml><?xml version="1.0" encoding="utf-8"?>
+<file path=ppt/notesSlides/notesSlide16.xml><?xml version="1.0" encoding="utf-8"?>
 <p:notes xmlns:a="http://schemas.openxmlformats.org/drawingml/2006/main" xmlns:r="http://schemas.openxmlformats.org/officeDocument/2006/relationships" xmlns:p="http://schemas.openxmlformats.org/presentationml/2006/main">
   <p:cSld>
     <p:spTree>
@@ -1028,7 +1204,7 @@
           <a:p>
             <a:fld id="{F7021451-1387-4CA6-816F-3879F97B5CBC}" type="slidenum">
               <a:rPr lang="en-US"/>
-              <a:t>14</a:t>
+              <a:t>16</a:t>
             </a:fld>
             <a:endParaRPr lang="en-US"/>
           </a:p>
@@ -1047,7 +1223,7 @@
 </p:notes>
 </file>
 
-<file path=ppt/notesSlides/notesSlide15.xml><?xml version="1.0" encoding="utf-8"?>
+<file path=ppt/notesSlides/notesSlide17.xml><?xml version="1.0" encoding="utf-8"?>
 <p:notes xmlns:a="http://schemas.openxmlformats.org/drawingml/2006/main" xmlns:r="http://schemas.openxmlformats.org/officeDocument/2006/relationships" xmlns:p="http://schemas.openxmlformats.org/presentationml/2006/main">
   <p:cSld>
     <p:spTree>
@@ -1093,11 +1269,12 @@
           <a:p>
             <a:r>
               <a:rPr lang="en-US" dirty="0"/>
-              <a:t>Say clearly that Aider has real automation. It runs commands, it can run your
-tests, and it can loop on their output. Never say it cannot.
-The distinction that matters is who picks the next action. Here the harness has
-a fixed repair cycle. In the tools we look at after the break, the model picks.
-Source: https://aider.chat/docs/usage/lint-test.html</a:t>
+              <a:t>Three minutes including logistics. Room, time and the model in the workspace are
+announced by staff. Do not invent any of them here.
+Say the accommodations line out loud: conflicts and accommodations go to staff
+now, not the week of.
+The caption is the only place in the deck a student sees the build deadline, now
+that the after-lab slide is gone. Do not skip past it.</a:t>
             </a:r>
             <a:endParaRPr lang="en-US" dirty="0"/>
           </a:p>
@@ -1120,7 +1297,7 @@
           <a:p>
             <a:fld id="{F7021451-1387-4CA6-816F-3879F97B5CBC}" type="slidenum">
               <a:rPr lang="en-US"/>
-              <a:t>15</a:t>
+              <a:t>17</a:t>
             </a:fld>
             <a:endParaRPr lang="en-US"/>
           </a:p>
@@ -1139,7 +1316,7 @@
 </p:notes>
 </file>
 
-<file path=ppt/notesSlides/notesSlide16.xml><?xml version="1.0" encoding="utf-8"?>
+<file path=ppt/notesSlides/notesSlide18.xml><?xml version="1.0" encoding="utf-8"?>
 <p:notes xmlns:a="http://schemas.openxmlformats.org/drawingml/2006/main" xmlns:r="http://schemas.openxmlformats.org/officeDocument/2006/relationships" xmlns:p="http://schemas.openxmlformats.org/presentationml/2006/main">
   <p:cSld>
     <p:spTree>
@@ -1185,14 +1362,10 @@
           <a:p>
             <a:r>
               <a:rPr lang="en-US" dirty="0"/>
-              <a:t>Keep two kinds of commit apart: the ones Aider makes while they build, and the
-ones their assistant will make in a target repo. In Stage 1 the target is
-disposable and clean, so an owned HEAD commit can be undone safely. A human
-commit on top, or a dirty tree, means their tool has to refuse.
-Running shell commands arrives in the Analyze phase and brings consequences git
-cannot undo.
-Undo means resetting to the parent of a commit their own session created. It
-will not touch a commit someone else made, which is the guard in "guarded undo".</a:t>
+              <a:t>Minutes 40 to 58. This is the reveal. They have spent two weeks driving a
+harness and the last half hour taking one apart; now they build one.
+Lead with what the thing is, not with the paperwork. The packet carries the
+requirements and they can read it.</a:t>
             </a:r>
             <a:endParaRPr lang="en-US" dirty="0"/>
           </a:p>
@@ -1215,7 +1388,7 @@
           <a:p>
             <a:fld id="{F7021451-1387-4CA6-816F-3879F97B5CBC}" type="slidenum">
               <a:rPr lang="en-US"/>
-              <a:t>16</a:t>
+              <a:t>18</a:t>
             </a:fld>
             <a:endParaRPr lang="en-US"/>
           </a:p>
@@ -1234,185 +1407,6 @@
 </p:notes>
 </file>
 
-<file path=ppt/notesSlides/notesSlide17.xml><?xml version="1.0" encoding="utf-8"?>
-<p:notes xmlns:a="http://schemas.openxmlformats.org/drawingml/2006/main" xmlns:r="http://schemas.openxmlformats.org/officeDocument/2006/relationships" xmlns:p="http://schemas.openxmlformats.org/presentationml/2006/main">
-  <p:cSld>
-    <p:spTree>
-      <p:nvGrpSpPr>
-        <p:cNvPr id="1" name=""/>
-        <p:cNvGrpSpPr/>
-        <p:nvPr/>
-      </p:nvGrpSpPr>
-      <p:grpSpPr>
-        <a:xfrm>
-          <a:off x="0" y="0"/>
-          <a:ext cx="0" cy="0"/>
-          <a:chOff x="0" y="0"/>
-          <a:chExt cx="0" cy="0"/>
-        </a:xfrm>
-      </p:grpSpPr>
-      <p:sp>
-        <p:nvSpPr>
-          <p:cNvPr id="2" name="Slide Image Placeholder 1"/>
-          <p:cNvSpPr>
-            <a:spLocks noGrp="1" noRot="1" noChangeAspect="1"/>
-          </p:cNvSpPr>
-          <p:nvPr>
-            <p:ph type="sldImg"/>
-          </p:nvPr>
-        </p:nvSpPr>
-        <p:spPr/>
-      </p:sp>
-      <p:sp>
-        <p:nvSpPr>
-          <p:cNvPr id="3" name="Notes Placeholder 2"/>
-          <p:cNvSpPr>
-            <a:spLocks noGrp="1"/>
-          </p:cNvSpPr>
-          <p:nvPr>
-            <p:ph type="body" idx="1"/>
-          </p:nvPr>
-        </p:nvSpPr>
-        <p:spPr/>
-        <p:txBody>
-          <a:bodyPr/>
-          <a:lstStyle/>
-          <a:p>
-            <a:r>
-              <a:rPr lang="en-US" dirty="0"/>
-              <a:t>Pairs for two minutes, then take two answers. You are listening for a write
-that never happened and the test that would have caught it. Do not reward
-naming a source file inside aider.</a:t>
-            </a:r>
-            <a:endParaRPr lang="en-US" dirty="0"/>
-          </a:p>
-        </p:txBody>
-      </p:sp>
-      <p:sp>
-        <p:nvSpPr>
-          <p:cNvPr id="4" name="Slide Number Placeholder 3"/>
-          <p:cNvSpPr>
-            <a:spLocks noGrp="1"/>
-          </p:cNvSpPr>
-          <p:nvPr>
-            <p:ph type="sldNum" sz="quarter" idx="10"/>
-          </p:nvPr>
-        </p:nvSpPr>
-        <p:spPr/>
-        <p:txBody>
-          <a:bodyPr/>
-          <a:lstStyle/>
-          <a:p>
-            <a:fld id="{F7021451-1387-4CA6-816F-3879F97B5CBC}" type="slidenum">
-              <a:rPr lang="en-US"/>
-              <a:t>17</a:t>
-            </a:fld>
-            <a:endParaRPr lang="en-US"/>
-          </a:p>
-        </p:txBody>
-      </p:sp>
-    </p:spTree>
-    <p:extLst>
-      <p:ext uri="{BB962C8B-B14F-4D97-AF65-F5344CB8AC3E}">
-        <p14:creationId xmlns:p14="http://schemas.microsoft.com/office/powerpoint/2010/main" val="1024086991"/>
-      </p:ext>
-    </p:extLst>
-  </p:cSld>
-  <p:clrMapOvr>
-    <a:masterClrMapping/>
-  </p:clrMapOvr>
-</p:notes>
-</file>
-
-<file path=ppt/notesSlides/notesSlide18.xml><?xml version="1.0" encoding="utf-8"?>
-<p:notes xmlns:a="http://schemas.openxmlformats.org/drawingml/2006/main" xmlns:r="http://schemas.openxmlformats.org/officeDocument/2006/relationships" xmlns:p="http://schemas.openxmlformats.org/presentationml/2006/main">
-  <p:cSld>
-    <p:spTree>
-      <p:nvGrpSpPr>
-        <p:cNvPr id="1" name=""/>
-        <p:cNvGrpSpPr/>
-        <p:nvPr/>
-      </p:nvGrpSpPr>
-      <p:grpSpPr>
-        <a:xfrm>
-          <a:off x="0" y="0"/>
-          <a:ext cx="0" cy="0"/>
-          <a:chOff x="0" y="0"/>
-          <a:chExt cx="0" cy="0"/>
-        </a:xfrm>
-      </p:grpSpPr>
-      <p:sp>
-        <p:nvSpPr>
-          <p:cNvPr id="2" name="Slide Image Placeholder 1"/>
-          <p:cNvSpPr>
-            <a:spLocks noGrp="1" noRot="1" noChangeAspect="1"/>
-          </p:cNvSpPr>
-          <p:nvPr>
-            <p:ph type="sldImg"/>
-          </p:nvPr>
-        </p:nvSpPr>
-        <p:spPr/>
-      </p:sp>
-      <p:sp>
-        <p:nvSpPr>
-          <p:cNvPr id="3" name="Notes Placeholder 2"/>
-          <p:cNvSpPr>
-            <a:spLocks noGrp="1"/>
-          </p:cNvSpPr>
-          <p:nvPr>
-            <p:ph type="body" idx="1"/>
-          </p:nvPr>
-        </p:nvSpPr>
-        <p:spPr/>
-        <p:txBody>
-          <a:bodyPr/>
-          <a:lstStyle/>
-          <a:p>
-            <a:r>
-              <a:rPr lang="en-US" dirty="0"/>
-              <a:t>Ten minutes. The habit to build: a symptom is evidence about which of the three
-levers is wrong, and re-running the same prompt tests nothing.</a:t>
-            </a:r>
-            <a:endParaRPr lang="en-US" dirty="0"/>
-          </a:p>
-        </p:txBody>
-      </p:sp>
-      <p:sp>
-        <p:nvSpPr>
-          <p:cNvPr id="4" name="Slide Number Placeholder 3"/>
-          <p:cNvSpPr>
-            <a:spLocks noGrp="1"/>
-          </p:cNvSpPr>
-          <p:nvPr>
-            <p:ph type="sldNum" sz="quarter" idx="10"/>
-          </p:nvPr>
-        </p:nvSpPr>
-        <p:spPr/>
-        <p:txBody>
-          <a:bodyPr/>
-          <a:lstStyle/>
-          <a:p>
-            <a:fld id="{F7021451-1387-4CA6-816F-3879F97B5CBC}" type="slidenum">
-              <a:rPr lang="en-US"/>
-              <a:t>18</a:t>
-            </a:fld>
-            <a:endParaRPr lang="en-US"/>
-          </a:p>
-        </p:txBody>
-      </p:sp>
-    </p:spTree>
-    <p:extLst>
-      <p:ext uri="{BB962C8B-B14F-4D97-AF65-F5344CB8AC3E}">
-        <p14:creationId xmlns:p14="http://schemas.microsoft.com/office/powerpoint/2010/main" val="1024086991"/>
-      </p:ext>
-    </p:extLst>
-  </p:cSld>
-  <p:clrMapOvr>
-    <a:masterClrMapping/>
-  </p:clrMapOvr>
-</p:notes>
-</file>
-
 <file path=ppt/notesSlides/notesSlide19.xml><?xml version="1.0" encoding="utf-8"?>
 <p:notes xmlns:a="http://schemas.openxmlformats.org/drawingml/2006/main" xmlns:r="http://schemas.openxmlformats.org/officeDocument/2006/relationships" xmlns:p="http://schemas.openxmlformats.org/presentationml/2006/main">
   <p:cSld>
@@ -1459,9 +1453,13 @@
           <a:p>
             <a:r>
               <a:rPr lang="en-US" dirty="0"/>
-              <a:t>Push back on "the model is too weak" every time it comes up today. Ask what
-observation would distinguish a weak model from a missing file, and make them
-answer before they change models.</a:t>
+              <a:t>Say the one-sentence version out loud: a terminal pair-programmer over files
+you select, talking to an endpoint you configure, that never edits without
+asking. Everything else in the packet is detail under that sentence.
+It is not a clone of Aider and it does not need to be. No repo map, no lint
+loop, no architect mode. What it must have is the spine they just watched.
+If somebody asks how big it is: smaller than they fear, and the specification
+work is the part that decides how long it takes.</a:t>
             </a:r>
             <a:endParaRPr lang="en-US" dirty="0"/>
           </a:p>
@@ -1644,9 +1642,13 @@
           <a:p>
             <a:r>
               <a:rPr lang="en-US" dirty="0"/>
-              <a:t>Do not let this become "the model does not matter" or "every failure is
-context." Both halves are real. The point is that the harness is the half they
-are about to build, and it is the half they control.</a:t>
+              <a:t>Four ideas, seven graded features. The mapping is in SPEC.md and they do not
+need it now.
+The approval gate is the one to dwell on, because it is the safety rule and it
+is where the git behavior lives: one commit per accepted edit set, and an undo
+that refuses to touch a commit their session did not make.
+Configuration is theirs to implement against a fixed schema. It is scored
+inside the first feature rather than as a row of its own, and it is not a gate.</a:t>
             </a:r>
             <a:endParaRPr lang="en-US" dirty="0"/>
           </a:p>
@@ -1734,15 +1736,10 @@
           <a:p>
             <a:r>
               <a:rPr lang="en-US" dirty="0"/>
-              <a:t>Four minutes in pairs, two for answers. A persistence round trip is the answer
-you are hoping for: write it, restart, read it back. The symptom is stated
-without a worked case on purpose, so ask the room to name a change this could
-happen to before you ask where to look.
-Watch for the two reflexes you want to break. Adding every file in the package
-is not diagnosis, and switching models is not diagnosis.
-The exercise, which is no longer written on the slide: write the acceptance
-criterion that was missing, and the test that would have caught it. Say it
-twice; it is the whole point of the six minutes.</a:t>
+              <a:t>Do not read the packet out. Point at it, say the three files above, and move on.
+GLOSSARY.md settles the vocabulary arguments, and the acceptance scenarios are
+the ones to read before starting rather than after finishing.
+Say plainly that nothing is collected at the end of today.</a:t>
             </a:r>
             <a:endParaRPr lang="en-US" dirty="0"/>
           </a:p>
@@ -1785,657 +1782,6 @@
 </file>
 
 <file path=ppt/notesSlides/notesSlide22.xml><?xml version="1.0" encoding="utf-8"?>
-<p:notes xmlns:a="http://schemas.openxmlformats.org/drawingml/2006/main" xmlns:r="http://schemas.openxmlformats.org/officeDocument/2006/relationships" xmlns:p="http://schemas.openxmlformats.org/presentationml/2006/main">
-  <p:cSld>
-    <p:spTree>
-      <p:nvGrpSpPr>
-        <p:cNvPr id="1" name=""/>
-        <p:cNvGrpSpPr/>
-        <p:nvPr/>
-      </p:nvGrpSpPr>
-      <p:grpSpPr>
-        <a:xfrm>
-          <a:off x="0" y="0"/>
-          <a:ext cx="0" cy="0"/>
-          <a:chOff x="0" y="0"/>
-          <a:chExt cx="0" cy="0"/>
-        </a:xfrm>
-      </p:grpSpPr>
-      <p:sp>
-        <p:nvSpPr>
-          <p:cNvPr id="2" name="Slide Image Placeholder 1"/>
-          <p:cNvSpPr>
-            <a:spLocks noGrp="1" noRot="1" noChangeAspect="1"/>
-          </p:cNvSpPr>
-          <p:nvPr>
-            <p:ph type="sldImg"/>
-          </p:nvPr>
-        </p:nvSpPr>
-        <p:spPr/>
-      </p:sp>
-      <p:sp>
-        <p:nvSpPr>
-          <p:cNvPr id="3" name="Notes Placeholder 2"/>
-          <p:cNvSpPr>
-            <a:spLocks noGrp="1"/>
-          </p:cNvSpPr>
-          <p:nvPr>
-            <p:ph type="body" idx="1"/>
-          </p:nvPr>
-        </p:nvSpPr>
-        <p:spPr/>
-        <p:txBody>
-          <a:bodyPr/>
-          <a:lstStyle/>
-          <a:p>
-            <a:r>
-              <a:rPr lang="en-US" dirty="0"/>
-              <a:t>Three minutes including logistics. Room, time and the model in the workspace are
-announced by staff. Do not invent any of them here.
-Say the accommodations line out loud: conflicts and accommodations go to staff
-now, not the week of.
-The caption is the only place in the deck a student sees the build deadline, now
-that the after-lab slide is gone. Do not skip past it.</a:t>
-            </a:r>
-            <a:endParaRPr lang="en-US" dirty="0"/>
-          </a:p>
-        </p:txBody>
-      </p:sp>
-      <p:sp>
-        <p:nvSpPr>
-          <p:cNvPr id="4" name="Slide Number Placeholder 3"/>
-          <p:cNvSpPr>
-            <a:spLocks noGrp="1"/>
-          </p:cNvSpPr>
-          <p:nvPr>
-            <p:ph type="sldNum" sz="quarter" idx="10"/>
-          </p:nvPr>
-        </p:nvSpPr>
-        <p:spPr/>
-        <p:txBody>
-          <a:bodyPr/>
-          <a:lstStyle/>
-          <a:p>
-            <a:fld id="{F7021451-1387-4CA6-816F-3879F97B5CBC}" type="slidenum">
-              <a:rPr lang="en-US"/>
-              <a:t>22</a:t>
-            </a:fld>
-            <a:endParaRPr lang="en-US"/>
-          </a:p>
-        </p:txBody>
-      </p:sp>
-    </p:spTree>
-    <p:extLst>
-      <p:ext uri="{BB962C8B-B14F-4D97-AF65-F5344CB8AC3E}">
-        <p14:creationId xmlns:p14="http://schemas.microsoft.com/office/powerpoint/2010/main" val="1024086991"/>
-      </p:ext>
-    </p:extLst>
-  </p:cSld>
-  <p:clrMapOvr>
-    <a:masterClrMapping/>
-  </p:clrMapOvr>
-</p:notes>
-</file>
-
-<file path=ppt/notesSlides/notesSlide23.xml><?xml version="1.0" encoding="utf-8"?>
-<p:notes xmlns:a="http://schemas.openxmlformats.org/drawingml/2006/main" xmlns:r="http://schemas.openxmlformats.org/officeDocument/2006/relationships" xmlns:p="http://schemas.openxmlformats.org/presentationml/2006/main">
-  <p:cSld>
-    <p:spTree>
-      <p:nvGrpSpPr>
-        <p:cNvPr id="1" name=""/>
-        <p:cNvGrpSpPr/>
-        <p:nvPr/>
-      </p:nvGrpSpPr>
-      <p:grpSpPr>
-        <a:xfrm>
-          <a:off x="0" y="0"/>
-          <a:ext cx="0" cy="0"/>
-          <a:chOff x="0" y="0"/>
-          <a:chExt cx="0" cy="0"/>
-        </a:xfrm>
-      </p:grpSpPr>
-      <p:sp>
-        <p:nvSpPr>
-          <p:cNvPr id="2" name="Slide Image Placeholder 1"/>
-          <p:cNvSpPr>
-            <a:spLocks noGrp="1" noRot="1" noChangeAspect="1"/>
-          </p:cNvSpPr>
-          <p:nvPr>
-            <p:ph type="sldImg"/>
-          </p:nvPr>
-        </p:nvSpPr>
-        <p:spPr/>
-      </p:sp>
-      <p:sp>
-        <p:nvSpPr>
-          <p:cNvPr id="3" name="Notes Placeholder 2"/>
-          <p:cNvSpPr>
-            <a:spLocks noGrp="1"/>
-          </p:cNvSpPr>
-          <p:nvPr>
-            <p:ph type="body" idx="1"/>
-          </p:nvPr>
-        </p:nvSpPr>
-        <p:spPr/>
-        <p:txBody>
-          <a:bodyPr/>
-          <a:lstStyle/>
-          <a:p>
-            <a:r>
-              <a:rPr lang="en-US" dirty="0"/>
-              <a:t>Minute 40. Fifteen minutes. Everything here is also written down in their
-packet, so do not read the rubric aloud line by line.</a:t>
-            </a:r>
-            <a:endParaRPr lang="en-US" dirty="0"/>
-          </a:p>
-        </p:txBody>
-      </p:sp>
-      <p:sp>
-        <p:nvSpPr>
-          <p:cNvPr id="4" name="Slide Number Placeholder 3"/>
-          <p:cNvSpPr>
-            <a:spLocks noGrp="1"/>
-          </p:cNvSpPr>
-          <p:nvPr>
-            <p:ph type="sldNum" sz="quarter" idx="10"/>
-          </p:nvPr>
-        </p:nvSpPr>
-        <p:spPr/>
-        <p:txBody>
-          <a:bodyPr/>
-          <a:lstStyle/>
-          <a:p>
-            <a:fld id="{F7021451-1387-4CA6-816F-3879F97B5CBC}" type="slidenum">
-              <a:rPr lang="en-US"/>
-              <a:t>23</a:t>
-            </a:fld>
-            <a:endParaRPr lang="en-US"/>
-          </a:p>
-        </p:txBody>
-      </p:sp>
-    </p:spTree>
-    <p:extLst>
-      <p:ext uri="{BB962C8B-B14F-4D97-AF65-F5344CB8AC3E}">
-        <p14:creationId xmlns:p14="http://schemas.microsoft.com/office/powerpoint/2010/main" val="1024086991"/>
-      </p:ext>
-    </p:extLst>
-  </p:cSld>
-  <p:clrMapOvr>
-    <a:masterClrMapping/>
-  </p:clrMapOvr>
-</p:notes>
-</file>
-
-<file path=ppt/notesSlides/notesSlide24.xml><?xml version="1.0" encoding="utf-8"?>
-<p:notes xmlns:a="http://schemas.openxmlformats.org/drawingml/2006/main" xmlns:r="http://schemas.openxmlformats.org/officeDocument/2006/relationships" xmlns:p="http://schemas.openxmlformats.org/presentationml/2006/main">
-  <p:cSld>
-    <p:spTree>
-      <p:nvGrpSpPr>
-        <p:cNvPr id="1" name=""/>
-        <p:cNvGrpSpPr/>
-        <p:nvPr/>
-      </p:nvGrpSpPr>
-      <p:grpSpPr>
-        <a:xfrm>
-          <a:off x="0" y="0"/>
-          <a:ext cx="0" cy="0"/>
-          <a:chOff x="0" y="0"/>
-          <a:chExt cx="0" cy="0"/>
-        </a:xfrm>
-      </p:grpSpPr>
-      <p:sp>
-        <p:nvSpPr>
-          <p:cNvPr id="2" name="Slide Image Placeholder 1"/>
-          <p:cNvSpPr>
-            <a:spLocks noGrp="1" noRot="1" noChangeAspect="1"/>
-          </p:cNvSpPr>
-          <p:nvPr>
-            <p:ph type="sldImg"/>
-          </p:nvPr>
-        </p:nvSpPr>
-        <p:spPr/>
-      </p:sp>
-      <p:sp>
-        <p:nvSpPr>
-          <p:cNvPr id="3" name="Notes Placeholder 2"/>
-          <p:cNvSpPr>
-            <a:spLocks noGrp="1"/>
-          </p:cNvSpPr>
-          <p:nvPr>
-            <p:ph type="body" idx="1"/>
-          </p:nvPr>
-        </p:nvSpPr>
-        <p:spPr/>
-        <p:txBody>
-          <a:bodyPr/>
-          <a:lstStyle/>
-          <a:p>
-            <a:r>
-              <a:rPr lang="en-US" dirty="0"/>
-              <a:t>This is the slide that answers the question every student is holding: no
-starter application and no supplied session module.
-Point at CHECKLIST.md by name and say it is the submission list, so nobody
-reconstructs one from these slides. GLOSSARY.md is where a word has a Stage 1
-meaning that differs from its everyday one, and that meaning is the graded one.
-They implement the endpoint client in Stage 1 and extend it for function
-calling in Analyze.
-Say the division out loud, since the slide no longer carries it: they run
-`aider` to build the thing, and they write `bin/assistant` as the thing.</a:t>
-            </a:r>
-            <a:endParaRPr lang="en-US" dirty="0"/>
-          </a:p>
-        </p:txBody>
-      </p:sp>
-      <p:sp>
-        <p:nvSpPr>
-          <p:cNvPr id="4" name="Slide Number Placeholder 3"/>
-          <p:cNvSpPr>
-            <a:spLocks noGrp="1"/>
-          </p:cNvSpPr>
-          <p:nvPr>
-            <p:ph type="sldNum" sz="quarter" idx="10"/>
-          </p:nvPr>
-        </p:nvSpPr>
-        <p:spPr/>
-        <p:txBody>
-          <a:bodyPr/>
-          <a:lstStyle/>
-          <a:p>
-            <a:fld id="{F7021451-1387-4CA6-816F-3879F97B5CBC}" type="slidenum">
-              <a:rPr lang="en-US"/>
-              <a:t>24</a:t>
-            </a:fld>
-            <a:endParaRPr lang="en-US"/>
-          </a:p>
-        </p:txBody>
-      </p:sp>
-    </p:spTree>
-    <p:extLst>
-      <p:ext uri="{BB962C8B-B14F-4D97-AF65-F5344CB8AC3E}">
-        <p14:creationId xmlns:p14="http://schemas.microsoft.com/office/powerpoint/2010/main" val="1024086991"/>
-      </p:ext>
-    </p:extLst>
-  </p:cSld>
-  <p:clrMapOvr>
-    <a:masterClrMapping/>
-  </p:clrMapOvr>
-</p:notes>
-</file>
-
-<file path=ppt/notesSlides/notesSlide25.xml><?xml version="1.0" encoding="utf-8"?>
-<p:notes xmlns:a="http://schemas.openxmlformats.org/drawingml/2006/main" xmlns:r="http://schemas.openxmlformats.org/officeDocument/2006/relationships" xmlns:p="http://schemas.openxmlformats.org/presentationml/2006/main">
-  <p:cSld>
-    <p:spTree>
-      <p:nvGrpSpPr>
-        <p:cNvPr id="1" name=""/>
-        <p:cNvGrpSpPr/>
-        <p:nvPr/>
-      </p:nvGrpSpPr>
-      <p:grpSpPr>
-        <a:xfrm>
-          <a:off x="0" y="0"/>
-          <a:ext cx="0" cy="0"/>
-          <a:chOff x="0" y="0"/>
-          <a:chExt cx="0" cy="0"/>
-        </a:xfrm>
-      </p:grpSpPr>
-      <p:sp>
-        <p:nvSpPr>
-          <p:cNvPr id="2" name="Slide Image Placeholder 1"/>
-          <p:cNvSpPr>
-            <a:spLocks noGrp="1" noRot="1" noChangeAspect="1"/>
-          </p:cNvSpPr>
-          <p:nvPr>
-            <p:ph type="sldImg"/>
-          </p:nvPr>
-        </p:nvSpPr>
-        <p:spPr/>
-      </p:sp>
-      <p:sp>
-        <p:nvSpPr>
-          <p:cNvPr id="3" name="Notes Placeholder 2"/>
-          <p:cNvSpPr>
-            <a:spLocks noGrp="1"/>
-          </p:cNvSpPr>
-          <p:nvPr>
-            <p:ph type="body" idx="1"/>
-          </p:nvPr>
-        </p:nvSpPr>
-        <p:spPr/>
-        <p:txBody>
-          <a:bodyPr/>
-          <a:lstStyle/>
-          <a:p>
-            <a:r>
-              <a:rPr lang="en-US" dirty="0"/>
-              <a:t>Open EXAMPLES.md from the template and walk the four transcripts: a question, an
-approved edit, a cancellation, an undo. Say that these are the expected
-behavior, not a recording of a staff implementation.
-Ask what happens to the files and to HEAD at each point. That question starts
-their acceptance criteria, which is a better use of this block than a tour of
-the feature list.</a:t>
-            </a:r>
-            <a:endParaRPr lang="en-US" dirty="0"/>
-          </a:p>
-        </p:txBody>
-      </p:sp>
-      <p:sp>
-        <p:nvSpPr>
-          <p:cNvPr id="4" name="Slide Number Placeholder 3"/>
-          <p:cNvSpPr>
-            <a:spLocks noGrp="1"/>
-          </p:cNvSpPr>
-          <p:nvPr>
-            <p:ph type="sldNum" sz="quarter" idx="10"/>
-          </p:nvPr>
-        </p:nvSpPr>
-        <p:spPr/>
-        <p:txBody>
-          <a:bodyPr/>
-          <a:lstStyle/>
-          <a:p>
-            <a:fld id="{F7021451-1387-4CA6-816F-3879F97B5CBC}" type="slidenum">
-              <a:rPr lang="en-US"/>
-              <a:t>25</a:t>
-            </a:fld>
-            <a:endParaRPr lang="en-US"/>
-          </a:p>
-        </p:txBody>
-      </p:sp>
-    </p:spTree>
-    <p:extLst>
-      <p:ext uri="{BB962C8B-B14F-4D97-AF65-F5344CB8AC3E}">
-        <p14:creationId xmlns:p14="http://schemas.microsoft.com/office/powerpoint/2010/main" val="1024086991"/>
-      </p:ext>
-    </p:extLst>
-  </p:cSld>
-  <p:clrMapOvr>
-    <a:masterClrMapping/>
-  </p:clrMapOvr>
-</p:notes>
-</file>
-
-<file path=ppt/notesSlides/notesSlide26.xml><?xml version="1.0" encoding="utf-8"?>
-<p:notes xmlns:a="http://schemas.openxmlformats.org/drawingml/2006/main" xmlns:r="http://schemas.openxmlformats.org/officeDocument/2006/relationships" xmlns:p="http://schemas.openxmlformats.org/presentationml/2006/main">
-  <p:cSld>
-    <p:spTree>
-      <p:nvGrpSpPr>
-        <p:cNvPr id="1" name=""/>
-        <p:cNvGrpSpPr/>
-        <p:nvPr/>
-      </p:nvGrpSpPr>
-      <p:grpSpPr>
-        <a:xfrm>
-          <a:off x="0" y="0"/>
-          <a:ext cx="0" cy="0"/>
-          <a:chOff x="0" y="0"/>
-          <a:chExt cx="0" cy="0"/>
-        </a:xfrm>
-      </p:grpSpPr>
-      <p:sp>
-        <p:nvSpPr>
-          <p:cNvPr id="2" name="Slide Image Placeholder 1"/>
-          <p:cNvSpPr>
-            <a:spLocks noGrp="1" noRot="1" noChangeAspect="1"/>
-          </p:cNvSpPr>
-          <p:nvPr>
-            <p:ph type="sldImg"/>
-          </p:nvPr>
-        </p:nvSpPr>
-        <p:spPr/>
-      </p:sp>
-      <p:sp>
-        <p:nvSpPr>
-          <p:cNvPr id="3" name="Notes Placeholder 2"/>
-          <p:cNvSpPr>
-            <a:spLocks noGrp="1"/>
-          </p:cNvSpPr>
-          <p:nvPr>
-            <p:ph type="body" idx="1"/>
-          </p:nvPr>
-        </p:nvSpPr>
-        <p:spPr/>
-        <p:txBody>
-          <a:bodyPr/>
-          <a:lstStyle/>
-          <a:p>
-            <a:r>
-              <a:rPr lang="en-US" dirty="0"/>
-              <a:t>Use the exact greeting files and replies from EXAMPLES.md so the table matches
-what they will read tonight.
-Undo assumes an owned, current-session HEAD and a clean target. A human commit
-on top, or uncommitted changes, means refuse. Ask them what they would assert in
-a test for each row.</a:t>
-            </a:r>
-            <a:endParaRPr lang="en-US" dirty="0"/>
-          </a:p>
-        </p:txBody>
-      </p:sp>
-      <p:sp>
-        <p:nvSpPr>
-          <p:cNvPr id="4" name="Slide Number Placeholder 3"/>
-          <p:cNvSpPr>
-            <a:spLocks noGrp="1"/>
-          </p:cNvSpPr>
-          <p:nvPr>
-            <p:ph type="sldNum" sz="quarter" idx="10"/>
-          </p:nvPr>
-        </p:nvSpPr>
-        <p:spPr/>
-        <p:txBody>
-          <a:bodyPr/>
-          <a:lstStyle/>
-          <a:p>
-            <a:fld id="{F7021451-1387-4CA6-816F-3879F97B5CBC}" type="slidenum">
-              <a:rPr lang="en-US"/>
-              <a:t>26</a:t>
-            </a:fld>
-            <a:endParaRPr lang="en-US"/>
-          </a:p>
-        </p:txBody>
-      </p:sp>
-    </p:spTree>
-    <p:extLst>
-      <p:ext uri="{BB962C8B-B14F-4D97-AF65-F5344CB8AC3E}">
-        <p14:creationId xmlns:p14="http://schemas.microsoft.com/office/powerpoint/2010/main" val="1024086991"/>
-      </p:ext>
-    </p:extLst>
-  </p:cSld>
-  <p:clrMapOvr>
-    <a:masterClrMapping/>
-  </p:clrMapOvr>
-</p:notes>
-</file>
-
-<file path=ppt/notesSlides/notesSlide27.xml><?xml version="1.0" encoding="utf-8"?>
-<p:notes xmlns:a="http://schemas.openxmlformats.org/drawingml/2006/main" xmlns:r="http://schemas.openxmlformats.org/officeDocument/2006/relationships" xmlns:p="http://schemas.openxmlformats.org/presentationml/2006/main">
-  <p:cSld>
-    <p:spTree>
-      <p:nvGrpSpPr>
-        <p:cNvPr id="1" name=""/>
-        <p:cNvGrpSpPr/>
-        <p:nvPr/>
-      </p:nvGrpSpPr>
-      <p:grpSpPr>
-        <a:xfrm>
-          <a:off x="0" y="0"/>
-          <a:ext cx="0" cy="0"/>
-          <a:chOff x="0" y="0"/>
-          <a:chExt cx="0" cy="0"/>
-        </a:xfrm>
-      </p:grpSpPr>
-      <p:sp>
-        <p:nvSpPr>
-          <p:cNvPr id="2" name="Slide Image Placeholder 1"/>
-          <p:cNvSpPr>
-            <a:spLocks noGrp="1" noRot="1" noChangeAspect="1"/>
-          </p:cNvSpPr>
-          <p:nvPr>
-            <p:ph type="sldImg"/>
-          </p:nvPr>
-        </p:nvSpPr>
-        <p:spPr/>
-      </p:sp>
-      <p:sp>
-        <p:nvSpPr>
-          <p:cNvPr id="3" name="Notes Placeholder 2"/>
-          <p:cNvSpPr>
-            <a:spLocks noGrp="1"/>
-          </p:cNvSpPr>
-          <p:nvPr>
-            <p:ph type="body" idx="1"/>
-          </p:nvPr>
-        </p:nvSpPr>
-        <p:spPr/>
-        <p:txBody>
-          <a:bodyPr/>
-          <a:lstStyle/>
-          <a:p>
-            <a:r>
-              <a:rPr lang="en-US" dirty="0"/>
-              <a:t>Configuration and lifecycle are not a hidden eighth feature, and there is no
-scope cut this term. Where they score, from RUBRIC.md: configuration sits
-inside F1's four points and is not a gate, so unfinished configuration does not
-zero the rest of F1. The lifecycle commands score separately, under Operating
-instructions in the evidence group. Every edge case is in SPEC.md.</a:t>
-            </a:r>
-            <a:endParaRPr lang="en-US" dirty="0"/>
-          </a:p>
-        </p:txBody>
-      </p:sp>
-      <p:sp>
-        <p:nvSpPr>
-          <p:cNvPr id="4" name="Slide Number Placeholder 3"/>
-          <p:cNvSpPr>
-            <a:spLocks noGrp="1"/>
-          </p:cNvSpPr>
-          <p:nvPr>
-            <p:ph type="sldNum" sz="quarter" idx="10"/>
-          </p:nvPr>
-        </p:nvSpPr>
-        <p:spPr/>
-        <p:txBody>
-          <a:bodyPr/>
-          <a:lstStyle/>
-          <a:p>
-            <a:fld id="{F7021451-1387-4CA6-816F-3879F97B5CBC}" type="slidenum">
-              <a:rPr lang="en-US"/>
-              <a:t>27</a:t>
-            </a:fld>
-            <a:endParaRPr lang="en-US"/>
-          </a:p>
-        </p:txBody>
-      </p:sp>
-    </p:spTree>
-    <p:extLst>
-      <p:ext uri="{BB962C8B-B14F-4D97-AF65-F5344CB8AC3E}">
-        <p14:creationId xmlns:p14="http://schemas.microsoft.com/office/powerpoint/2010/main" val="1024086991"/>
-      </p:ext>
-    </p:extLst>
-  </p:cSld>
-  <p:clrMapOvr>
-    <a:masterClrMapping/>
-  </p:clrMapOvr>
-</p:notes>
-</file>
-
-<file path=ppt/notesSlides/notesSlide28.xml><?xml version="1.0" encoding="utf-8"?>
-<p:notes xmlns:a="http://schemas.openxmlformats.org/drawingml/2006/main" xmlns:r="http://schemas.openxmlformats.org/officeDocument/2006/relationships" xmlns:p="http://schemas.openxmlformats.org/presentationml/2006/main">
-  <p:cSld>
-    <p:spTree>
-      <p:nvGrpSpPr>
-        <p:cNvPr id="1" name=""/>
-        <p:cNvGrpSpPr/>
-        <p:nvPr/>
-      </p:nvGrpSpPr>
-      <p:grpSpPr>
-        <a:xfrm>
-          <a:off x="0" y="0"/>
-          <a:ext cx="0" cy="0"/>
-          <a:chOff x="0" y="0"/>
-          <a:chExt cx="0" cy="0"/>
-        </a:xfrm>
-      </p:grpSpPr>
-      <p:sp>
-        <p:nvSpPr>
-          <p:cNvPr id="2" name="Slide Image Placeholder 1"/>
-          <p:cNvSpPr>
-            <a:spLocks noGrp="1" noRot="1" noChangeAspect="1"/>
-          </p:cNvSpPr>
-          <p:nvPr>
-            <p:ph type="sldImg"/>
-          </p:nvPr>
-        </p:nvSpPr>
-        <p:spPr/>
-      </p:sp>
-      <p:sp>
-        <p:nvSpPr>
-          <p:cNvPr id="3" name="Notes Placeholder 2"/>
-          <p:cNvSpPr>
-            <a:spLocks noGrp="1"/>
-          </p:cNvSpPr>
-          <p:nvPr>
-            <p:ph type="body" idx="1"/>
-          </p:nvPr>
-        </p:nvSpPr>
-        <p:spPr/>
-        <p:txBody>
-          <a:bodyPr/>
-          <a:lstStyle/>
-          <a:p>
-            <a:r>
-              <a:rPr lang="en-US" dirty="0"/>
-              <a:t>base_url can carry any path prefix. Their client appends /chat/completions and
-nothing else.
-Say explicitly that this YAML is not the .aider.conf.yml they already have in
-aider-practice. Two files, two owners: that one configures the tool they use,
-this one is a schema their own program has to implement. The deck no longer
-walks through Aider's own config, so name the distinction out loud rather than
-assuming the contrast landed earlier in the hour.
-No Ollama-specific dependency belongs anywhere in the application. Provider
-independence is a requirement, not a preference.</a:t>
-            </a:r>
-            <a:endParaRPr lang="en-US" dirty="0"/>
-          </a:p>
-        </p:txBody>
-      </p:sp>
-      <p:sp>
-        <p:nvSpPr>
-          <p:cNvPr id="4" name="Slide Number Placeholder 3"/>
-          <p:cNvSpPr>
-            <a:spLocks noGrp="1"/>
-          </p:cNvSpPr>
-          <p:nvPr>
-            <p:ph type="sldNum" sz="quarter" idx="10"/>
-          </p:nvPr>
-        </p:nvSpPr>
-        <p:spPr/>
-        <p:txBody>
-          <a:bodyPr/>
-          <a:lstStyle/>
-          <a:p>
-            <a:fld id="{F7021451-1387-4CA6-816F-3879F97B5CBC}" type="slidenum">
-              <a:rPr lang="en-US"/>
-              <a:t>28</a:t>
-            </a:fld>
-            <a:endParaRPr lang="en-US"/>
-          </a:p>
-        </p:txBody>
-      </p:sp>
-    </p:spTree>
-    <p:extLst>
-      <p:ext uri="{BB962C8B-B14F-4D97-AF65-F5344CB8AC3E}">
-        <p14:creationId xmlns:p14="http://schemas.microsoft.com/office/powerpoint/2010/main" val="1024086991"/>
-      </p:ext>
-    </p:extLst>
-  </p:cSld>
-  <p:clrMapOvr>
-    <a:masterClrMapping/>
-  </p:clrMapOvr>
-</p:notes>
-</file>
-
-<file path=ppt/notesSlides/notesSlide29.xml><?xml version="1.0" encoding="utf-8"?>
 <p:notes xmlns:a="http://schemas.openxmlformats.org/drawingml/2006/main" xmlns:r="http://schemas.openxmlformats.org/officeDocument/2006/relationships" xmlns:p="http://schemas.openxmlformats.org/presentationml/2006/main">
   <p:cSld>
     <p:spTree>
@@ -2506,7 +1852,7 @@
           <a:p>
             <a:fld id="{F7021451-1387-4CA6-816F-3879F97B5CBC}" type="slidenum">
               <a:rPr lang="en-US"/>
-              <a:t>29</a:t>
+              <a:t>22</a:t>
             </a:fld>
             <a:endParaRPr lang="en-US"/>
           </a:p>
@@ -2525,102 +1871,7 @@
 </p:notes>
 </file>
 
-<file path=ppt/notesSlides/notesSlide3.xml><?xml version="1.0" encoding="utf-8"?>
-<p:notes xmlns:a="http://schemas.openxmlformats.org/drawingml/2006/main" xmlns:r="http://schemas.openxmlformats.org/officeDocument/2006/relationships" xmlns:p="http://schemas.openxmlformats.org/presentationml/2006/main">
-  <p:cSld>
-    <p:spTree>
-      <p:nvGrpSpPr>
-        <p:cNvPr id="1" name=""/>
-        <p:cNvGrpSpPr/>
-        <p:nvPr/>
-      </p:nvGrpSpPr>
-      <p:grpSpPr>
-        <a:xfrm>
-          <a:off x="0" y="0"/>
-          <a:ext cx="0" cy="0"/>
-          <a:chOff x="0" y="0"/>
-          <a:chExt cx="0" cy="0"/>
-        </a:xfrm>
-      </p:grpSpPr>
-      <p:sp>
-        <p:nvSpPr>
-          <p:cNvPr id="2" name="Slide Image Placeholder 1"/>
-          <p:cNvSpPr>
-            <a:spLocks noGrp="1" noRot="1" noChangeAspect="1"/>
-          </p:cNvSpPr>
-          <p:nvPr>
-            <p:ph type="sldImg"/>
-          </p:nvPr>
-        </p:nvSpPr>
-        <p:spPr/>
-      </p:sp>
-      <p:sp>
-        <p:nvSpPr>
-          <p:cNvPr id="3" name="Notes Placeholder 2"/>
-          <p:cNvSpPr>
-            <a:spLocks noGrp="1"/>
-          </p:cNvSpPr>
-          <p:nvPr>
-            <p:ph type="body" idx="1"/>
-          </p:nvPr>
-        </p:nvSpPr>
-        <p:spPr/>
-        <p:txBody>
-          <a:bodyPr/>
-          <a:lstStyle/>
-          <a:p>
-            <a:r>
-              <a:rPr lang="en-US" dirty="0"/>
-              <a:t>This is the slide the deck was missing. Sixteen practice lessons gave them the
-muscle memory and none of the model, and the word "harness" is the one they
-need, because it is the thing they build in Stage 1 and extend in Analyze.
-Say the right-hand column out loud. The model's entire contribution is one
-block of text. Every effect on their machine is the left column acting on it.
-If anyone asks about models, endpoints or config: MODEL-POLICY.md, and it is
-not today's subject. qwen3.5:9b recommended, 4B permitted, any compatible
-endpoint.</a:t>
-            </a:r>
-            <a:endParaRPr lang="en-US" dirty="0"/>
-          </a:p>
-        </p:txBody>
-      </p:sp>
-      <p:sp>
-        <p:nvSpPr>
-          <p:cNvPr id="4" name="Slide Number Placeholder 3"/>
-          <p:cNvSpPr>
-            <a:spLocks noGrp="1"/>
-          </p:cNvSpPr>
-          <p:nvPr>
-            <p:ph type="sldNum" sz="quarter" idx="10"/>
-          </p:nvPr>
-        </p:nvSpPr>
-        <p:spPr/>
-        <p:txBody>
-          <a:bodyPr/>
-          <a:lstStyle/>
-          <a:p>
-            <a:fld id="{F7021451-1387-4CA6-816F-3879F97B5CBC}" type="slidenum">
-              <a:rPr lang="en-US"/>
-              <a:t>3</a:t>
-            </a:fld>
-            <a:endParaRPr lang="en-US"/>
-          </a:p>
-        </p:txBody>
-      </p:sp>
-    </p:spTree>
-    <p:extLst>
-      <p:ext uri="{BB962C8B-B14F-4D97-AF65-F5344CB8AC3E}">
-        <p14:creationId xmlns:p14="http://schemas.microsoft.com/office/powerpoint/2010/main" val="1024086991"/>
-      </p:ext>
-    </p:extLst>
-  </p:cSld>
-  <p:clrMapOvr>
-    <a:masterClrMapping/>
-  </p:clrMapOvr>
-</p:notes>
-</file>
-
-<file path=ppt/notesSlides/notesSlide30.xml><?xml version="1.0" encoding="utf-8"?>
+<file path=ppt/notesSlides/notesSlide23.xml><?xml version="1.0" encoding="utf-8"?>
 <p:notes xmlns:a="http://schemas.openxmlformats.org/drawingml/2006/main" xmlns:r="http://schemas.openxmlformats.org/officeDocument/2006/relationships" xmlns:p="http://schemas.openxmlformats.org/presentationml/2006/main">
   <p:cSld>
     <p:spTree>
@@ -2692,7 +1943,7 @@
           <a:p>
             <a:fld id="{F7021451-1387-4CA6-816F-3879F97B5CBC}" type="slidenum">
               <a:rPr lang="en-US"/>
-              <a:t>30</a:t>
+              <a:t>23</a:t>
             </a:fld>
             <a:endParaRPr lang="en-US"/>
           </a:p>
@@ -2711,7 +1962,7 @@
 </p:notes>
 </file>
 
-<file path=ppt/notesSlides/notesSlide31.xml><?xml version="1.0" encoding="utf-8"?>
+<file path=ppt/notesSlides/notesSlide24.xml><?xml version="1.0" encoding="utf-8"?>
 <p:notes xmlns:a="http://schemas.openxmlformats.org/drawingml/2006/main" xmlns:r="http://schemas.openxmlformats.org/officeDocument/2006/relationships" xmlns:p="http://schemas.openxmlformats.org/presentationml/2006/main">
   <p:cSld>
     <p:spTree>
@@ -2782,7 +2033,7 @@
           <a:p>
             <a:fld id="{F7021451-1387-4CA6-816F-3879F97B5CBC}" type="slidenum">
               <a:rPr lang="en-US"/>
-              <a:t>31</a:t>
+              <a:t>24</a:t>
             </a:fld>
             <a:endParaRPr lang="en-US"/>
           </a:p>
@@ -2801,7 +2052,7 @@
 </p:notes>
 </file>
 
-<file path=ppt/notesSlides/notesSlide32.xml><?xml version="1.0" encoding="utf-8"?>
+<file path=ppt/notesSlides/notesSlide25.xml><?xml version="1.0" encoding="utf-8"?>
 <p:notes xmlns:a="http://schemas.openxmlformats.org/drawingml/2006/main" xmlns:r="http://schemas.openxmlformats.org/officeDocument/2006/relationships" xmlns:p="http://schemas.openxmlformats.org/presentationml/2006/main">
   <p:cSld>
     <p:spTree>
@@ -2884,7 +2135,7 @@
           <a:p>
             <a:fld id="{F7021451-1387-4CA6-816F-3879F97B5CBC}" type="slidenum">
               <a:rPr lang="en-US"/>
-              <a:t>32</a:t>
+              <a:t>25</a:t>
             </a:fld>
             <a:endParaRPr lang="en-US"/>
           </a:p>
@@ -2903,7 +2154,7 @@
 </p:notes>
 </file>
 
-<file path=ppt/notesSlides/notesSlide33.xml><?xml version="1.0" encoding="utf-8"?>
+<file path=ppt/notesSlides/notesSlide26.xml><?xml version="1.0" encoding="utf-8"?>
 <p:notes xmlns:a="http://schemas.openxmlformats.org/drawingml/2006/main" xmlns:r="http://schemas.openxmlformats.org/officeDocument/2006/relationships" xmlns:p="http://schemas.openxmlformats.org/presentationml/2006/main">
   <p:cSld>
     <p:spTree>
@@ -2976,7 +2227,7 @@
           <a:p>
             <a:fld id="{F7021451-1387-4CA6-816F-3879F97B5CBC}" type="slidenum">
               <a:rPr lang="en-US"/>
-              <a:t>33</a:t>
+              <a:t>26</a:t>
             </a:fld>
             <a:endParaRPr lang="en-US"/>
           </a:p>
@@ -2995,7 +2246,7 @@
 </p:notes>
 </file>
 
-<file path=ppt/notesSlides/notesSlide34.xml><?xml version="1.0" encoding="utf-8"?>
+<file path=ppt/notesSlides/notesSlide27.xml><?xml version="1.0" encoding="utf-8"?>
 <p:notes xmlns:a="http://schemas.openxmlformats.org/drawingml/2006/main" xmlns:r="http://schemas.openxmlformats.org/officeDocument/2006/relationships" xmlns:p="http://schemas.openxmlformats.org/presentationml/2006/main">
   <p:cSld>
     <p:spTree>
@@ -3041,9 +2292,9 @@
           <a:p>
             <a:r>
               <a:rPr lang="en-US" dirty="0"/>
-              <a:t>Close the project block here. Build due September 25, hackathon September 24.
-Do not estimate the workload out loud. Do say that a runnable slice early is
-what keeps the December integration from being a surprise.</a:t>
+              <a:t>Minutes 58 to 65. Short. The point is the arc, not a tour of tools.
+Nothing here is a Stage 1 dependency and no subscription is needed for this
+course.</a:t>
             </a:r>
             <a:endParaRPr lang="en-US" dirty="0"/>
           </a:p>
@@ -3066,7 +2317,7 @@
           <a:p>
             <a:fld id="{F7021451-1387-4CA6-816F-3879F97B5CBC}" type="slidenum">
               <a:rPr lang="en-US"/>
-              <a:t>34</a:t>
+              <a:t>27</a:t>
             </a:fld>
             <a:endParaRPr lang="en-US"/>
           </a:p>
@@ -3085,7 +2336,7 @@
 </p:notes>
 </file>
 
-<file path=ppt/notesSlides/notesSlide35.xml><?xml version="1.0" encoding="utf-8"?>
+<file path=ppt/notesSlides/notesSlide28.xml><?xml version="1.0" encoding="utf-8"?>
 <p:notes xmlns:a="http://schemas.openxmlformats.org/drawingml/2006/main" xmlns:r="http://schemas.openxmlformats.org/officeDocument/2006/relationships" xmlns:p="http://schemas.openxmlformats.org/presentationml/2006/main">
   <p:cSld>
     <p:spTree>
@@ -3131,9 +2382,13 @@
           <a:p>
             <a:r>
               <a:rPr lang="en-US" dirty="0"/>
-              <a:t>Minutes 55 to 65. This is a mechanism comparison, not a product tour and not a
-recommendation. Nothing here is a Stage 1 dependency and no subscription is
-needed for this course.</a:t>
+              <a:t>Walk the timeline left to right and say what changes at each dot: first the
+human is in the loop, then the model picks the tools, then it keeps state and
+survives contact with real work.
+Build advice that used to sit on this slide and still belongs in the room: one
+small checkable result first, and keep the phase snapshots.
+Do not estimate the workload out loud. Do say that a runnable slice early is
+what keeps the December integration from being a surprise.</a:t>
             </a:r>
             <a:endParaRPr lang="en-US" dirty="0"/>
           </a:p>
@@ -3156,7 +2411,7 @@
           <a:p>
             <a:fld id="{F7021451-1387-4CA6-816F-3879F97B5CBC}" type="slidenum">
               <a:rPr lang="en-US"/>
-              <a:t>35</a:t>
+              <a:t>28</a:t>
             </a:fld>
             <a:endParaRPr lang="en-US"/>
           </a:p>
@@ -3175,7 +2430,7 @@
 </p:notes>
 </file>
 
-<file path=ppt/notesSlides/notesSlide36.xml><?xml version="1.0" encoding="utf-8"?>
+<file path=ppt/notesSlides/notesSlide29.xml><?xml version="1.0" encoding="utf-8"?>
 <p:notes xmlns:a="http://schemas.openxmlformats.org/drawingml/2006/main" xmlns:r="http://schemas.openxmlformats.org/officeDocument/2006/relationships" xmlns:p="http://schemas.openxmlformats.org/presentationml/2006/main">
   <p:cSld>
     <p:spTree>
@@ -3246,7 +2501,7 @@
           <a:p>
             <a:fld id="{F7021451-1387-4CA6-816F-3879F97B5CBC}" type="slidenum">
               <a:rPr lang="en-US"/>
-              <a:t>36</a:t>
+              <a:t>29</a:t>
             </a:fld>
             <a:endParaRPr lang="en-US"/>
           </a:p>
@@ -3265,7 +2520,7 @@
 </p:notes>
 </file>
 
-<file path=ppt/notesSlides/notesSlide37.xml><?xml version="1.0" encoding="utf-8"?>
+<file path=ppt/notesSlides/notesSlide3.xml><?xml version="1.0" encoding="utf-8"?>
 <p:notes xmlns:a="http://schemas.openxmlformats.org/drawingml/2006/main" xmlns:r="http://schemas.openxmlformats.org/officeDocument/2006/relationships" xmlns:p="http://schemas.openxmlformats.org/presentationml/2006/main">
   <p:cSld>
     <p:spTree>
@@ -3311,9 +2566,14 @@
           <a:p>
             <a:r>
               <a:rPr lang="en-US" dirty="0"/>
-              <a:t>Stay at mechanism level and do not promise a week for each branded feature.
-Their DEVELOPMENT.md is the first version of this habit: instructions written
-for a session that has not happened yet.</a:t>
+              <a:t>This is the slide the deck was missing. Sixteen practice lessons gave them the
+muscle memory and none of the model, and the word "harness" is the one they
+need, because it is the thing they build in Stage 1 and extend in Analyze.
+Say the right-hand column out loud. The model's entire contribution is one
+block of text. Every effect on their machine is the left column acting on it.
+If anyone asks about models, endpoints or config: MODEL-POLICY.md, and it is
+not today's subject. qwen3.5:9b recommended, 4B permitted, any compatible
+endpoint.</a:t>
             </a:r>
             <a:endParaRPr lang="en-US" dirty="0"/>
           </a:p>
@@ -3336,7 +2596,7 @@
           <a:p>
             <a:fld id="{F7021451-1387-4CA6-816F-3879F97B5CBC}" type="slidenum">
               <a:rPr lang="en-US"/>
-              <a:t>37</a:t>
+              <a:t>3</a:t>
             </a:fld>
             <a:endParaRPr lang="en-US"/>
           </a:p>
@@ -3355,7 +2615,7 @@
 </p:notes>
 </file>
 
-<file path=ppt/notesSlides/notesSlide38.xml><?xml version="1.0" encoding="utf-8"?>
+<file path=ppt/notesSlides/notesSlide30.xml><?xml version="1.0" encoding="utf-8"?>
 <p:notes xmlns:a="http://schemas.openxmlformats.org/drawingml/2006/main" xmlns:r="http://schemas.openxmlformats.org/officeDocument/2006/relationships" xmlns:p="http://schemas.openxmlformats.org/presentationml/2006/main">
   <p:cSld>
     <p:spTree>
@@ -3401,8 +2661,14 @@
           <a:p>
             <a:r>
               <a:rPr lang="en-US" dirty="0"/>
-              <a:t>End the comparison here, at minute 65. Nothing after this slide is yours to
-talk through.</a:t>
+              <a:t>This is the last thing they hear before office hours, so land it and stop.
+Name the two tools as a shape, not as a target to clone and not as something
+they need an account for. What makes it that shape is the list they will build:
+tools the model chooses, an approval layer, state that survives a run, more
+than one way in.
+The design habit to start now: when a decision could close off one of those,
+leave a boundary rather than an implementation. That is the useful half of the
+slide this replaced.</a:t>
             </a:r>
             <a:endParaRPr lang="en-US" dirty="0"/>
           </a:p>
@@ -3425,7 +2691,7 @@
           <a:p>
             <a:fld id="{F7021451-1387-4CA6-816F-3879F97B5CBC}" type="slidenum">
               <a:rPr lang="en-US"/>
-              <a:t>38</a:t>
+              <a:t>30</a:t>
             </a:fld>
             <a:endParaRPr lang="en-US"/>
           </a:p>
@@ -3444,7 +2710,7 @@
 </p:notes>
 </file>
 
-<file path=ppt/notesSlides/notesSlide39.xml><?xml version="1.0" encoding="utf-8"?>
+<file path=ppt/notesSlides/notesSlide31.xml><?xml version="1.0" encoding="utf-8"?>
 <p:notes xmlns:a="http://schemas.openxmlformats.org/drawingml/2006/main" xmlns:r="http://schemas.openxmlformats.org/officeDocument/2006/relationships" xmlns:p="http://schemas.openxmlformats.org/presentationml/2006/main">
   <p:cSld>
     <p:spTree>
@@ -3516,7 +2782,95 @@
           <a:p>
             <a:fld id="{F7021451-1387-4CA6-816F-3879F97B5CBC}" type="slidenum">
               <a:rPr lang="en-US"/>
-              <a:t>39</a:t>
+              <a:t>31</a:t>
+            </a:fld>
+            <a:endParaRPr lang="en-US"/>
+          </a:p>
+        </p:txBody>
+      </p:sp>
+    </p:spTree>
+    <p:extLst>
+      <p:ext uri="{BB962C8B-B14F-4D97-AF65-F5344CB8AC3E}">
+        <p14:creationId xmlns:p14="http://schemas.microsoft.com/office/powerpoint/2010/main" val="1024086991"/>
+      </p:ext>
+    </p:extLst>
+  </p:cSld>
+  <p:clrMapOvr>
+    <a:masterClrMapping/>
+  </p:clrMapOvr>
+</p:notes>
+</file>
+
+<file path=ppt/notesSlides/notesSlide32.xml><?xml version="1.0" encoding="utf-8"?>
+<p:notes xmlns:a="http://schemas.openxmlformats.org/drawingml/2006/main" xmlns:r="http://schemas.openxmlformats.org/officeDocument/2006/relationships" xmlns:p="http://schemas.openxmlformats.org/presentationml/2006/main">
+  <p:cSld>
+    <p:spTree>
+      <p:nvGrpSpPr>
+        <p:cNvPr id="1" name=""/>
+        <p:cNvGrpSpPr/>
+        <p:nvPr/>
+      </p:nvGrpSpPr>
+      <p:grpSpPr>
+        <a:xfrm>
+          <a:off x="0" y="0"/>
+          <a:ext cx="0" cy="0"/>
+          <a:chOff x="0" y="0"/>
+          <a:chExt cx="0" cy="0"/>
+        </a:xfrm>
+      </p:grpSpPr>
+      <p:sp>
+        <p:nvSpPr>
+          <p:cNvPr id="2" name="Slide Image Placeholder 1"/>
+          <p:cNvSpPr>
+            <a:spLocks noGrp="1" noRot="1" noChangeAspect="1"/>
+          </p:cNvSpPr>
+          <p:nvPr>
+            <p:ph type="sldImg"/>
+          </p:nvPr>
+        </p:nvSpPr>
+        <p:spPr/>
+      </p:sp>
+      <p:sp>
+        <p:nvSpPr>
+          <p:cNvPr id="3" name="Notes Placeholder 2"/>
+          <p:cNvSpPr>
+            <a:spLocks noGrp="1"/>
+          </p:cNvSpPr>
+          <p:nvPr>
+            <p:ph type="body" idx="1"/>
+          </p:nvPr>
+        </p:nvSpPr>
+        <p:spPr/>
+        <p:txBody>
+          <a:bodyPr/>
+          <a:lstStyle/>
+          <a:p>
+            <a:r>
+              <a:rPr lang="en-US" dirty="0"/>
+              <a:t/>
+            </a:r>
+            <a:endParaRPr lang="en-US" dirty="0"/>
+          </a:p>
+        </p:txBody>
+      </p:sp>
+      <p:sp>
+        <p:nvSpPr>
+          <p:cNvPr id="4" name="Slide Number Placeholder 3"/>
+          <p:cNvSpPr>
+            <a:spLocks noGrp="1"/>
+          </p:cNvSpPr>
+          <p:nvPr>
+            <p:ph type="sldNum" sz="quarter" idx="10"/>
+          </p:nvPr>
+        </p:nvSpPr>
+        <p:spPr/>
+        <p:txBody>
+          <a:bodyPr/>
+          <a:lstStyle/>
+          <a:p>
+            <a:fld id="{F7021451-1387-4CA6-816F-3879F97B5CBC}" type="slidenum">
+              <a:rPr lang="en-US"/>
+              <a:t>32</a:t>
             </a:fld>
             <a:endParaRPr lang="en-US"/>
           </a:p>
@@ -3631,94 +2985,6 @@
 </p:notes>
 </file>
 
-<file path=ppt/notesSlides/notesSlide40.xml><?xml version="1.0" encoding="utf-8"?>
-<p:notes xmlns:a="http://schemas.openxmlformats.org/drawingml/2006/main" xmlns:r="http://schemas.openxmlformats.org/officeDocument/2006/relationships" xmlns:p="http://schemas.openxmlformats.org/presentationml/2006/main">
-  <p:cSld>
-    <p:spTree>
-      <p:nvGrpSpPr>
-        <p:cNvPr id="1" name=""/>
-        <p:cNvGrpSpPr/>
-        <p:nvPr/>
-      </p:nvGrpSpPr>
-      <p:grpSpPr>
-        <a:xfrm>
-          <a:off x="0" y="0"/>
-          <a:ext cx="0" cy="0"/>
-          <a:chOff x="0" y="0"/>
-          <a:chExt cx="0" cy="0"/>
-        </a:xfrm>
-      </p:grpSpPr>
-      <p:sp>
-        <p:nvSpPr>
-          <p:cNvPr id="2" name="Slide Image Placeholder 1"/>
-          <p:cNvSpPr>
-            <a:spLocks noGrp="1" noRot="1" noChangeAspect="1"/>
-          </p:cNvSpPr>
-          <p:nvPr>
-            <p:ph type="sldImg"/>
-          </p:nvPr>
-        </p:nvSpPr>
-        <p:spPr/>
-      </p:sp>
-      <p:sp>
-        <p:nvSpPr>
-          <p:cNvPr id="3" name="Notes Placeholder 2"/>
-          <p:cNvSpPr>
-            <a:spLocks noGrp="1"/>
-          </p:cNvSpPr>
-          <p:nvPr>
-            <p:ph type="body" idx="1"/>
-          </p:nvPr>
-        </p:nvSpPr>
-        <p:spPr/>
-        <p:txBody>
-          <a:bodyPr/>
-          <a:lstStyle/>
-          <a:p>
-            <a:r>
-              <a:rPr lang="en-US" dirty="0"/>
-              <a:t/>
-            </a:r>
-            <a:endParaRPr lang="en-US" dirty="0"/>
-          </a:p>
-        </p:txBody>
-      </p:sp>
-      <p:sp>
-        <p:nvSpPr>
-          <p:cNvPr id="4" name="Slide Number Placeholder 3"/>
-          <p:cNvSpPr>
-            <a:spLocks noGrp="1"/>
-          </p:cNvSpPr>
-          <p:nvPr>
-            <p:ph type="sldNum" sz="quarter" idx="10"/>
-          </p:nvPr>
-        </p:nvSpPr>
-        <p:spPr/>
-        <p:txBody>
-          <a:bodyPr/>
-          <a:lstStyle/>
-          <a:p>
-            <a:fld id="{F7021451-1387-4CA6-816F-3879F97B5CBC}" type="slidenum">
-              <a:rPr lang="en-US"/>
-              <a:t>40</a:t>
-            </a:fld>
-            <a:endParaRPr lang="en-US"/>
-          </a:p>
-        </p:txBody>
-      </p:sp>
-    </p:spTree>
-    <p:extLst>
-      <p:ext uri="{BB962C8B-B14F-4D97-AF65-F5344CB8AC3E}">
-        <p14:creationId xmlns:p14="http://schemas.microsoft.com/office/powerpoint/2010/main" val="1024086991"/>
-      </p:ext>
-    </p:extLst>
-  </p:cSld>
-  <p:clrMapOvr>
-    <a:masterClrMapping/>
-  </p:clrMapOvr>
-</p:notes>
-</file>
-
 <file path=ppt/notesSlides/notesSlide5.xml><?xml version="1.0" encoding="utf-8"?>
 <p:notes xmlns:a="http://schemas.openxmlformats.org/drawingml/2006/main" xmlns:r="http://schemas.openxmlformats.org/officeDocument/2006/relationships" xmlns:p="http://schemas.openxmlformats.org/presentationml/2006/main">
   <p:cSld>
@@ -3857,7 +3123,7 @@
           <a:p>
             <a:r>
               <a:rPr lang="en-US" dirty="0"/>
-              <a:t>Six steps. Say up front that only step 2 belongs to the model.</a:t>
+              <a:t>Four steps. Say up front that only step 2 belongs to the model.</a:t>
             </a:r>
             <a:endParaRPr lang="en-US" dirty="0"/>
           </a:p>
@@ -5494,321 +4760,9 @@
 </p:sld>
 </file>
 
-<file path=ppt/slides/slide33.xml><?xml version="1.0" encoding="utf-8"?>
-<p:sld xmlns:a="http://schemas.openxmlformats.org/drawingml/2006/main" xmlns:r="http://schemas.openxmlformats.org/officeDocument/2006/relationships" xmlns:p="http://schemas.openxmlformats.org/presentationml/2006/main">
-  <p:cSld name="Slide 33">
-    <p:bg>
-      <p:bgPr>
-        <a:blipFill dpi="0" rotWithShape="1">
-          <a:blip r:embed="rId1">
-            <a:lum/>
-          </a:blip>
-          <a:srcRect/>
-          <a:stretch>
-            <a:fillRect/>
-          </a:stretch>
-        </a:blipFill>
-        <a:effectLst/>
-      </p:bgPr>
-    </p:bg>
-    <p:spTree>
-      <p:nvGrpSpPr>
-        <p:cNvPr id="1" name=""/>
-        <p:cNvGrpSpPr/>
-        <p:nvPr/>
-      </p:nvGrpSpPr>
-      <p:grpSpPr>
-        <a:xfrm>
-          <a:off x="0" y="0"/>
-          <a:ext cx="0" cy="0"/>
-          <a:chOff x="0" y="0"/>
-          <a:chExt cx="0" cy="0"/>
-        </a:xfrm>
-      </p:grpSpPr>
-    </p:spTree>
-  </p:cSld>
-  <p:clrMapOvr>
-    <a:masterClrMapping/>
-  </p:clrMapOvr>
-</p:sld>
-</file>
-
-<file path=ppt/slides/slide34.xml><?xml version="1.0" encoding="utf-8"?>
-<p:sld xmlns:a="http://schemas.openxmlformats.org/drawingml/2006/main" xmlns:r="http://schemas.openxmlformats.org/officeDocument/2006/relationships" xmlns:p="http://schemas.openxmlformats.org/presentationml/2006/main">
-  <p:cSld name="Slide 34">
-    <p:bg>
-      <p:bgPr>
-        <a:blipFill dpi="0" rotWithShape="1">
-          <a:blip r:embed="rId1">
-            <a:lum/>
-          </a:blip>
-          <a:srcRect/>
-          <a:stretch>
-            <a:fillRect/>
-          </a:stretch>
-        </a:blipFill>
-        <a:effectLst/>
-      </p:bgPr>
-    </p:bg>
-    <p:spTree>
-      <p:nvGrpSpPr>
-        <p:cNvPr id="1" name=""/>
-        <p:cNvGrpSpPr/>
-        <p:nvPr/>
-      </p:nvGrpSpPr>
-      <p:grpSpPr>
-        <a:xfrm>
-          <a:off x="0" y="0"/>
-          <a:ext cx="0" cy="0"/>
-          <a:chOff x="0" y="0"/>
-          <a:chExt cx="0" cy="0"/>
-        </a:xfrm>
-      </p:grpSpPr>
-    </p:spTree>
-  </p:cSld>
-  <p:clrMapOvr>
-    <a:masterClrMapping/>
-  </p:clrMapOvr>
-</p:sld>
-</file>
-
-<file path=ppt/slides/slide35.xml><?xml version="1.0" encoding="utf-8"?>
-<p:sld xmlns:a="http://schemas.openxmlformats.org/drawingml/2006/main" xmlns:r="http://schemas.openxmlformats.org/officeDocument/2006/relationships" xmlns:p="http://schemas.openxmlformats.org/presentationml/2006/main">
-  <p:cSld name="Slide 35">
-    <p:bg>
-      <p:bgPr>
-        <a:blipFill dpi="0" rotWithShape="1">
-          <a:blip r:embed="rId1">
-            <a:lum/>
-          </a:blip>
-          <a:srcRect/>
-          <a:stretch>
-            <a:fillRect/>
-          </a:stretch>
-        </a:blipFill>
-        <a:effectLst/>
-      </p:bgPr>
-    </p:bg>
-    <p:spTree>
-      <p:nvGrpSpPr>
-        <p:cNvPr id="1" name=""/>
-        <p:cNvGrpSpPr/>
-        <p:nvPr/>
-      </p:nvGrpSpPr>
-      <p:grpSpPr>
-        <a:xfrm>
-          <a:off x="0" y="0"/>
-          <a:ext cx="0" cy="0"/>
-          <a:chOff x="0" y="0"/>
-          <a:chExt cx="0" cy="0"/>
-        </a:xfrm>
-      </p:grpSpPr>
-    </p:spTree>
-  </p:cSld>
-  <p:clrMapOvr>
-    <a:masterClrMapping/>
-  </p:clrMapOvr>
-</p:sld>
-</file>
-
-<file path=ppt/slides/slide36.xml><?xml version="1.0" encoding="utf-8"?>
-<p:sld xmlns:a="http://schemas.openxmlformats.org/drawingml/2006/main" xmlns:r="http://schemas.openxmlformats.org/officeDocument/2006/relationships" xmlns:p="http://schemas.openxmlformats.org/presentationml/2006/main">
-  <p:cSld name="Slide 36">
-    <p:bg>
-      <p:bgPr>
-        <a:blipFill dpi="0" rotWithShape="1">
-          <a:blip r:embed="rId1">
-            <a:lum/>
-          </a:blip>
-          <a:srcRect/>
-          <a:stretch>
-            <a:fillRect/>
-          </a:stretch>
-        </a:blipFill>
-        <a:effectLst/>
-      </p:bgPr>
-    </p:bg>
-    <p:spTree>
-      <p:nvGrpSpPr>
-        <p:cNvPr id="1" name=""/>
-        <p:cNvGrpSpPr/>
-        <p:nvPr/>
-      </p:nvGrpSpPr>
-      <p:grpSpPr>
-        <a:xfrm>
-          <a:off x="0" y="0"/>
-          <a:ext cx="0" cy="0"/>
-          <a:chOff x="0" y="0"/>
-          <a:chExt cx="0" cy="0"/>
-        </a:xfrm>
-      </p:grpSpPr>
-    </p:spTree>
-  </p:cSld>
-  <p:clrMapOvr>
-    <a:masterClrMapping/>
-  </p:clrMapOvr>
-</p:sld>
-</file>
-
-<file path=ppt/slides/slide37.xml><?xml version="1.0" encoding="utf-8"?>
-<p:sld xmlns:a="http://schemas.openxmlformats.org/drawingml/2006/main" xmlns:r="http://schemas.openxmlformats.org/officeDocument/2006/relationships" xmlns:p="http://schemas.openxmlformats.org/presentationml/2006/main">
-  <p:cSld name="Slide 37">
-    <p:bg>
-      <p:bgPr>
-        <a:blipFill dpi="0" rotWithShape="1">
-          <a:blip r:embed="rId1">
-            <a:lum/>
-          </a:blip>
-          <a:srcRect/>
-          <a:stretch>
-            <a:fillRect/>
-          </a:stretch>
-        </a:blipFill>
-        <a:effectLst/>
-      </p:bgPr>
-    </p:bg>
-    <p:spTree>
-      <p:nvGrpSpPr>
-        <p:cNvPr id="1" name=""/>
-        <p:cNvGrpSpPr/>
-        <p:nvPr/>
-      </p:nvGrpSpPr>
-      <p:grpSpPr>
-        <a:xfrm>
-          <a:off x="0" y="0"/>
-          <a:ext cx="0" cy="0"/>
-          <a:chOff x="0" y="0"/>
-          <a:chExt cx="0" cy="0"/>
-        </a:xfrm>
-      </p:grpSpPr>
-    </p:spTree>
-  </p:cSld>
-  <p:clrMapOvr>
-    <a:masterClrMapping/>
-  </p:clrMapOvr>
-</p:sld>
-</file>
-
-<file path=ppt/slides/slide38.xml><?xml version="1.0" encoding="utf-8"?>
-<p:sld xmlns:a="http://schemas.openxmlformats.org/drawingml/2006/main" xmlns:r="http://schemas.openxmlformats.org/officeDocument/2006/relationships" xmlns:p="http://schemas.openxmlformats.org/presentationml/2006/main">
-  <p:cSld name="Slide 38">
-    <p:bg>
-      <p:bgPr>
-        <a:blipFill dpi="0" rotWithShape="1">
-          <a:blip r:embed="rId1">
-            <a:lum/>
-          </a:blip>
-          <a:srcRect/>
-          <a:stretch>
-            <a:fillRect/>
-          </a:stretch>
-        </a:blipFill>
-        <a:effectLst/>
-      </p:bgPr>
-    </p:bg>
-    <p:spTree>
-      <p:nvGrpSpPr>
-        <p:cNvPr id="1" name=""/>
-        <p:cNvGrpSpPr/>
-        <p:nvPr/>
-      </p:nvGrpSpPr>
-      <p:grpSpPr>
-        <a:xfrm>
-          <a:off x="0" y="0"/>
-          <a:ext cx="0" cy="0"/>
-          <a:chOff x="0" y="0"/>
-          <a:chExt cx="0" cy="0"/>
-        </a:xfrm>
-      </p:grpSpPr>
-    </p:spTree>
-  </p:cSld>
-  <p:clrMapOvr>
-    <a:masterClrMapping/>
-  </p:clrMapOvr>
-</p:sld>
-</file>
-
-<file path=ppt/slides/slide39.xml><?xml version="1.0" encoding="utf-8"?>
-<p:sld xmlns:a="http://schemas.openxmlformats.org/drawingml/2006/main" xmlns:r="http://schemas.openxmlformats.org/officeDocument/2006/relationships" xmlns:p="http://schemas.openxmlformats.org/presentationml/2006/main">
-  <p:cSld name="Slide 39">
-    <p:bg>
-      <p:bgPr>
-        <a:blipFill dpi="0" rotWithShape="1">
-          <a:blip r:embed="rId1">
-            <a:lum/>
-          </a:blip>
-          <a:srcRect/>
-          <a:stretch>
-            <a:fillRect/>
-          </a:stretch>
-        </a:blipFill>
-        <a:effectLst/>
-      </p:bgPr>
-    </p:bg>
-    <p:spTree>
-      <p:nvGrpSpPr>
-        <p:cNvPr id="1" name=""/>
-        <p:cNvGrpSpPr/>
-        <p:nvPr/>
-      </p:nvGrpSpPr>
-      <p:grpSpPr>
-        <a:xfrm>
-          <a:off x="0" y="0"/>
-          <a:ext cx="0" cy="0"/>
-          <a:chOff x="0" y="0"/>
-          <a:chExt cx="0" cy="0"/>
-        </a:xfrm>
-      </p:grpSpPr>
-    </p:spTree>
-  </p:cSld>
-  <p:clrMapOvr>
-    <a:masterClrMapping/>
-  </p:clrMapOvr>
-</p:sld>
-</file>
-
 <file path=ppt/slides/slide4.xml><?xml version="1.0" encoding="utf-8"?>
 <p:sld xmlns:a="http://schemas.openxmlformats.org/drawingml/2006/main" xmlns:r="http://schemas.openxmlformats.org/officeDocument/2006/relationships" xmlns:p="http://schemas.openxmlformats.org/presentationml/2006/main">
   <p:cSld name="Slide 4">
-    <p:bg>
-      <p:bgPr>
-        <a:blipFill dpi="0" rotWithShape="1">
-          <a:blip r:embed="rId1">
-            <a:lum/>
-          </a:blip>
-          <a:srcRect/>
-          <a:stretch>
-            <a:fillRect/>
-          </a:stretch>
-        </a:blipFill>
-        <a:effectLst/>
-      </p:bgPr>
-    </p:bg>
-    <p:spTree>
-      <p:nvGrpSpPr>
-        <p:cNvPr id="1" name=""/>
-        <p:cNvGrpSpPr/>
-        <p:nvPr/>
-      </p:nvGrpSpPr>
-      <p:grpSpPr>
-        <a:xfrm>
-          <a:off x="0" y="0"/>
-          <a:ext cx="0" cy="0"/>
-          <a:chOff x="0" y="0"/>
-          <a:chExt cx="0" cy="0"/>
-        </a:xfrm>
-      </p:grpSpPr>
-    </p:spTree>
-  </p:cSld>
-  <p:clrMapOvr>
-    <a:masterClrMapping/>
-  </p:clrMapOvr>
-</p:sld>
-</file>
-
-<file path=ppt/slides/slide40.xml><?xml version="1.0" encoding="utf-8"?>
-<p:sld xmlns:a="http://schemas.openxmlformats.org/drawingml/2006/main" xmlns:r="http://schemas.openxmlformats.org/officeDocument/2006/relationships" xmlns:p="http://schemas.openxmlformats.org/presentationml/2006/main">
-  <p:cSld name="Slide 40">
     <p:bg>
       <p:bgPr>
         <a:blipFill dpi="0" rotWithShape="1">

</xml_diff>

<commit_message>
Lab01: reship at 30 slides, with the September 29 deadline
Matches eecs498-aase/aase-f26 at 830dbbc. The project section is
restructured around the three grading sections, the walkthrough is
reframed as context, and the Apply build deadline is Tuesday
September 29.

Co-Authored-By: Claude Opus 5 (1M context) <noreply@anthropic.com>
Claude-Session: https://claude.ai/code/session_015pu78gNF4378sH81fTPKSc
</commit_message>
<xml_diff>
--- a/labs/Lab01/slides.pptx
+++ b/labs/Lab01/slides.pptx
@@ -35,11 +35,9 @@
     <p:sldId id="283" r:id="rId29"/>
     <p:sldId id="284" r:id="rId30"/>
     <p:sldId id="285" r:id="rId31"/>
-    <p:sldId id="286" r:id="rId32"/>
-    <p:sldId id="287" r:id="rId33"/>
   </p:sldIdLst>
   <p:notesMasterIdLst>
-    <p:notesMasterId r:id="rId34"/>
+    <p:notesMasterId r:id="rId32"/>
   </p:notesMasterIdLst>
   <p:sldSz cx="9334500" cy="5248275"/>
   <p:notesSz cx="5248275" cy="9334500"/>
@@ -623,97 +621,6 @@
           <a:p>
             <a:r>
               <a:rPr lang="en-US" dirty="0"/>
-              <a:t>Point at the vertical bars: that is aider quoting source lines. Point at the
-dots: that is everything it decided not to spend tokens on.
-Ask what this is for. The answer is on the next slide: it is aider guessing
-what you would have typed /add for.</a:t>
-            </a:r>
-            <a:endParaRPr lang="en-US" dirty="0"/>
-          </a:p>
-        </p:txBody>
-      </p:sp>
-      <p:sp>
-        <p:nvSpPr>
-          <p:cNvPr id="4" name="Slide Number Placeholder 3"/>
-          <p:cNvSpPr>
-            <a:spLocks noGrp="1"/>
-          </p:cNvSpPr>
-          <p:nvPr>
-            <p:ph type="sldNum" sz="quarter" idx="10"/>
-          </p:nvPr>
-        </p:nvSpPr>
-        <p:spPr/>
-        <p:txBody>
-          <a:bodyPr/>
-          <a:lstStyle/>
-          <a:p>
-            <a:fld id="{F7021451-1387-4CA6-816F-3879F97B5CBC}" type="slidenum">
-              <a:rPr lang="en-US"/>
-              <a:t>10</a:t>
-            </a:fld>
-            <a:endParaRPr lang="en-US"/>
-          </a:p>
-        </p:txBody>
-      </p:sp>
-    </p:spTree>
-    <p:extLst>
-      <p:ext uri="{BB962C8B-B14F-4D97-AF65-F5344CB8AC3E}">
-        <p14:creationId xmlns:p14="http://schemas.microsoft.com/office/powerpoint/2010/main" val="1024086991"/>
-      </p:ext>
-    </p:extLst>
-  </p:cSld>
-  <p:clrMapOvr>
-    <a:masterClrMapping/>
-  </p:clrMapOvr>
-</p:notes>
-</file>
-
-<file path=ppt/notesSlides/notesSlide11.xml><?xml version="1.0" encoding="utf-8"?>
-<p:notes xmlns:a="http://schemas.openxmlformats.org/drawingml/2006/main" xmlns:r="http://schemas.openxmlformats.org/officeDocument/2006/relationships" xmlns:p="http://schemas.openxmlformats.org/presentationml/2006/main">
-  <p:cSld>
-    <p:spTree>
-      <p:nvGrpSpPr>
-        <p:cNvPr id="1" name=""/>
-        <p:cNvGrpSpPr/>
-        <p:nvPr/>
-      </p:nvGrpSpPr>
-      <p:grpSpPr>
-        <a:xfrm>
-          <a:off x="0" y="0"/>
-          <a:ext cx="0" cy="0"/>
-          <a:chOff x="0" y="0"/>
-          <a:chExt cx="0" cy="0"/>
-        </a:xfrm>
-      </p:grpSpPr>
-      <p:sp>
-        <p:nvSpPr>
-          <p:cNvPr id="2" name="Slide Image Placeholder 1"/>
-          <p:cNvSpPr>
-            <a:spLocks noGrp="1" noRot="1" noChangeAspect="1"/>
-          </p:cNvSpPr>
-          <p:nvPr>
-            <p:ph type="sldImg"/>
-          </p:nvPr>
-        </p:nvSpPr>
-        <p:spPr/>
-      </p:sp>
-      <p:sp>
-        <p:nvSpPr>
-          <p:cNvPr id="3" name="Notes Placeholder 2"/>
-          <p:cNvSpPr>
-            <a:spLocks noGrp="1"/>
-          </p:cNvSpPr>
-          <p:nvPr>
-            <p:ph type="body" idx="1"/>
-          </p:nvPr>
-        </p:nvSpPr>
-        <p:spPr/>
-        <p:txBody>
-          <a:bodyPr/>
-          <a:lstStyle/>
-          <a:p>
-            <a:r>
-              <a:rPr lang="en-US" dirty="0"/>
               <a:t>Off the slide and worth saying: the ranking is tilted toward files you just
 mentioned, and aider renders down the list until the tokens run out.
 Say the ranking rule plainly: a file that lots of other files depend on scores
@@ -743,7 +650,7 @@
           <a:p>
             <a:fld id="{F7021451-1387-4CA6-816F-3879F97B5CBC}" type="slidenum">
               <a:rPr lang="en-US"/>
-              <a:t>11</a:t>
+              <a:t>10</a:t>
             </a:fld>
             <a:endParaRPr lang="en-US"/>
           </a:p>
@@ -762,7 +669,7 @@
 </p:notes>
 </file>
 
-<file path=ppt/notesSlides/notesSlide12.xml><?xml version="1.0" encoding="utf-8"?>
+<file path=ppt/notesSlides/notesSlide11.xml><?xml version="1.0" encoding="utf-8"?>
 <p:notes xmlns:a="http://schemas.openxmlformats.org/drawingml/2006/main" xmlns:r="http://schemas.openxmlformats.org/officeDocument/2006/relationships" xmlns:p="http://schemas.openxmlformats.org/presentationml/2006/main">
   <p:cSld>
     <p:spTree>
@@ -836,7 +743,7 @@
           <a:p>
             <a:fld id="{F7021451-1387-4CA6-816F-3879F97B5CBC}" type="slidenum">
               <a:rPr lang="en-US"/>
-              <a:t>12</a:t>
+              <a:t>11</a:t>
             </a:fld>
             <a:endParaRPr lang="en-US"/>
           </a:p>
@@ -855,7 +762,7 @@
 </p:notes>
 </file>
 
-<file path=ppt/notesSlides/notesSlide13.xml><?xml version="1.0" encoding="utf-8"?>
+<file path=ppt/notesSlides/notesSlide12.xml><?xml version="1.0" encoding="utf-8"?>
 <p:notes xmlns:a="http://schemas.openxmlformats.org/drawingml/2006/main" xmlns:r="http://schemas.openxmlformats.org/officeDocument/2006/relationships" xmlns:p="http://schemas.openxmlformats.org/presentationml/2006/main">
   <p:cSld>
     <p:spTree>
@@ -927,7 +834,7 @@
           <a:p>
             <a:fld id="{F7021451-1387-4CA6-816F-3879F97B5CBC}" type="slidenum">
               <a:rPr lang="en-US"/>
-              <a:t>13</a:t>
+              <a:t>12</a:t>
             </a:fld>
             <a:endParaRPr lang="en-US"/>
           </a:p>
@@ -946,7 +853,7 @@
 </p:notes>
 </file>
 
-<file path=ppt/notesSlides/notesSlide14.xml><?xml version="1.0" encoding="utf-8"?>
+<file path=ppt/notesSlides/notesSlide13.xml><?xml version="1.0" encoding="utf-8"?>
 <p:notes xmlns:a="http://schemas.openxmlformats.org/drawingml/2006/main" xmlns:r="http://schemas.openxmlformats.org/officeDocument/2006/relationships" xmlns:p="http://schemas.openxmlformats.org/presentationml/2006/main">
   <p:cSld>
     <p:spTree>
@@ -1019,7 +926,7 @@
           <a:p>
             <a:fld id="{F7021451-1387-4CA6-816F-3879F97B5CBC}" type="slidenum">
               <a:rPr lang="en-US"/>
-              <a:t>14</a:t>
+              <a:t>13</a:t>
             </a:fld>
             <a:endParaRPr lang="en-US"/>
           </a:p>
@@ -1038,192 +945,7 @@
 </p:notes>
 </file>
 
-<file path=ppt/notesSlides/notesSlide15.xml><?xml version="1.0" encoding="utf-8"?>
-<p:notes xmlns:a="http://schemas.openxmlformats.org/drawingml/2006/main" xmlns:r="http://schemas.openxmlformats.org/officeDocument/2006/relationships" xmlns:p="http://schemas.openxmlformats.org/presentationml/2006/main">
-  <p:cSld>
-    <p:spTree>
-      <p:nvGrpSpPr>
-        <p:cNvPr id="1" name=""/>
-        <p:cNvGrpSpPr/>
-        <p:nvPr/>
-      </p:nvGrpSpPr>
-      <p:grpSpPr>
-        <a:xfrm>
-          <a:off x="0" y="0"/>
-          <a:ext cx="0" cy="0"/>
-          <a:chOff x="0" y="0"/>
-          <a:chExt cx="0" cy="0"/>
-        </a:xfrm>
-      </p:grpSpPr>
-      <p:sp>
-        <p:nvSpPr>
-          <p:cNvPr id="2" name="Slide Image Placeholder 1"/>
-          <p:cNvSpPr>
-            <a:spLocks noGrp="1" noRot="1" noChangeAspect="1"/>
-          </p:cNvSpPr>
-          <p:nvPr>
-            <p:ph type="sldImg"/>
-          </p:nvPr>
-        </p:nvSpPr>
-        <p:spPr/>
-      </p:sp>
-      <p:sp>
-        <p:nvSpPr>
-          <p:cNvPr id="3" name="Notes Placeholder 2"/>
-          <p:cNvSpPr>
-            <a:spLocks noGrp="1"/>
-          </p:cNvSpPr>
-          <p:nvPr>
-            <p:ph type="body" idx="1"/>
-          </p:nvPr>
-        </p:nvSpPr>
-        <p:spPr/>
-        <p:txBody>
-          <a:bodyPr/>
-          <a:lstStyle/>
-          <a:p>
-            <a:r>
-              <a:rPr lang="en-US" dirty="0"/>
-              <a:t>Their design may split these across two functions or keep them in one. We grade
-the error behavior, not the signature. What we do want is that a malformed block
-and an unapplicable block are distinguishable to the person reading the output.</a:t>
-            </a:r>
-            <a:endParaRPr lang="en-US" dirty="0"/>
-          </a:p>
-        </p:txBody>
-      </p:sp>
-      <p:sp>
-        <p:nvSpPr>
-          <p:cNvPr id="4" name="Slide Number Placeholder 3"/>
-          <p:cNvSpPr>
-            <a:spLocks noGrp="1"/>
-          </p:cNvSpPr>
-          <p:nvPr>
-            <p:ph type="sldNum" sz="quarter" idx="10"/>
-          </p:nvPr>
-        </p:nvSpPr>
-        <p:spPr/>
-        <p:txBody>
-          <a:bodyPr/>
-          <a:lstStyle/>
-          <a:p>
-            <a:fld id="{F7021451-1387-4CA6-816F-3879F97B5CBC}" type="slidenum">
-              <a:rPr lang="en-US"/>
-              <a:t>15</a:t>
-            </a:fld>
-            <a:endParaRPr lang="en-US"/>
-          </a:p>
-        </p:txBody>
-      </p:sp>
-    </p:spTree>
-    <p:extLst>
-      <p:ext uri="{BB962C8B-B14F-4D97-AF65-F5344CB8AC3E}">
-        <p14:creationId xmlns:p14="http://schemas.microsoft.com/office/powerpoint/2010/main" val="1024086991"/>
-      </p:ext>
-    </p:extLst>
-  </p:cSld>
-  <p:clrMapOvr>
-    <a:masterClrMapping/>
-  </p:clrMapOvr>
-</p:notes>
-</file>
-
-<file path=ppt/notesSlides/notesSlide16.xml><?xml version="1.0" encoding="utf-8"?>
-<p:notes xmlns:a="http://schemas.openxmlformats.org/drawingml/2006/main" xmlns:r="http://schemas.openxmlformats.org/officeDocument/2006/relationships" xmlns:p="http://schemas.openxmlformats.org/presentationml/2006/main">
-  <p:cSld>
-    <p:spTree>
-      <p:nvGrpSpPr>
-        <p:cNvPr id="1" name=""/>
-        <p:cNvGrpSpPr/>
-        <p:nvPr/>
-      </p:nvGrpSpPr>
-      <p:grpSpPr>
-        <a:xfrm>
-          <a:off x="0" y="0"/>
-          <a:ext cx="0" cy="0"/>
-          <a:chOff x="0" y="0"/>
-          <a:chExt cx="0" cy="0"/>
-        </a:xfrm>
-      </p:grpSpPr>
-      <p:sp>
-        <p:nvSpPr>
-          <p:cNvPr id="2" name="Slide Image Placeholder 1"/>
-          <p:cNvSpPr>
-            <a:spLocks noGrp="1" noRot="1" noChangeAspect="1"/>
-          </p:cNvSpPr>
-          <p:nvPr>
-            <p:ph type="sldImg"/>
-          </p:nvPr>
-        </p:nvSpPr>
-        <p:spPr/>
-      </p:sp>
-      <p:sp>
-        <p:nvSpPr>
-          <p:cNvPr id="3" name="Notes Placeholder 2"/>
-          <p:cNvSpPr>
-            <a:spLocks noGrp="1"/>
-          </p:cNvSpPr>
-          <p:nvPr>
-            <p:ph type="body" idx="1"/>
-          </p:nvPr>
-        </p:nvSpPr>
-        <p:spPr/>
-        <p:txBody>
-          <a:bodyPr/>
-          <a:lstStyle/>
-          <a:p>
-            <a:r>
-              <a:rPr lang="en-US" dirty="0"/>
-              <a:t>Two spaces are enough to break a match. Show the difference before you name it.
-Partial application is not untestable, it is testable against a different
-contract. Do not tell them one policy is the only defensible one. The stricter
-rule is here because it makes the state after a failure trivial to state and
-to assert.
-Cut from the slide: Aider itself can fall back to looser matching and can keep
-the blocks that did apply. Their Stage 1 contract does neither, and that is the
-contrast worth drawing out loud.</a:t>
-            </a:r>
-            <a:endParaRPr lang="en-US" dirty="0"/>
-          </a:p>
-        </p:txBody>
-      </p:sp>
-      <p:sp>
-        <p:nvSpPr>
-          <p:cNvPr id="4" name="Slide Number Placeholder 3"/>
-          <p:cNvSpPr>
-            <a:spLocks noGrp="1"/>
-          </p:cNvSpPr>
-          <p:nvPr>
-            <p:ph type="sldNum" sz="quarter" idx="10"/>
-          </p:nvPr>
-        </p:nvSpPr>
-        <p:spPr/>
-        <p:txBody>
-          <a:bodyPr/>
-          <a:lstStyle/>
-          <a:p>
-            <a:fld id="{F7021451-1387-4CA6-816F-3879F97B5CBC}" type="slidenum">
-              <a:rPr lang="en-US"/>
-              <a:t>16</a:t>
-            </a:fld>
-            <a:endParaRPr lang="en-US"/>
-          </a:p>
-        </p:txBody>
-      </p:sp>
-    </p:spTree>
-    <p:extLst>
-      <p:ext uri="{BB962C8B-B14F-4D97-AF65-F5344CB8AC3E}">
-        <p14:creationId xmlns:p14="http://schemas.microsoft.com/office/powerpoint/2010/main" val="1024086991"/>
-      </p:ext>
-    </p:extLst>
-  </p:cSld>
-  <p:clrMapOvr>
-    <a:masterClrMapping/>
-  </p:clrMapOvr>
-</p:notes>
-</file>
-
-<file path=ppt/notesSlides/notesSlide17.xml><?xml version="1.0" encoding="utf-8"?>
+<file path=ppt/notesSlides/notesSlide14.xml><?xml version="1.0" encoding="utf-8"?>
 <p:notes xmlns:a="http://schemas.openxmlformats.org/drawingml/2006/main" xmlns:r="http://schemas.openxmlformats.org/officeDocument/2006/relationships" xmlns:p="http://schemas.openxmlformats.org/presentationml/2006/main">
   <p:cSld>
     <p:spTree>
@@ -1297,7 +1019,7 @@
           <a:p>
             <a:fld id="{F7021451-1387-4CA6-816F-3879F97B5CBC}" type="slidenum">
               <a:rPr lang="en-US"/>
-              <a:t>17</a:t>
+              <a:t>14</a:t>
             </a:fld>
             <a:endParaRPr lang="en-US"/>
           </a:p>
@@ -1316,7 +1038,7 @@
 </p:notes>
 </file>
 
-<file path=ppt/notesSlides/notesSlide18.xml><?xml version="1.0" encoding="utf-8"?>
+<file path=ppt/notesSlides/notesSlide15.xml><?xml version="1.0" encoding="utf-8"?>
 <p:notes xmlns:a="http://schemas.openxmlformats.org/drawingml/2006/main" xmlns:r="http://schemas.openxmlformats.org/officeDocument/2006/relationships" xmlns:p="http://schemas.openxmlformats.org/presentationml/2006/main">
   <p:cSld>
     <p:spTree>
@@ -1388,7 +1110,7 @@
           <a:p>
             <a:fld id="{F7021451-1387-4CA6-816F-3879F97B5CBC}" type="slidenum">
               <a:rPr lang="en-US"/>
-              <a:t>18</a:t>
+              <a:t>15</a:t>
             </a:fld>
             <a:endParaRPr lang="en-US"/>
           </a:p>
@@ -1407,7 +1129,7 @@
 </p:notes>
 </file>
 
-<file path=ppt/notesSlides/notesSlide19.xml><?xml version="1.0" encoding="utf-8"?>
+<file path=ppt/notesSlides/notesSlide16.xml><?xml version="1.0" encoding="utf-8"?>
 <p:notes xmlns:a="http://schemas.openxmlformats.org/drawingml/2006/main" xmlns:r="http://schemas.openxmlformats.org/officeDocument/2006/relationships" xmlns:p="http://schemas.openxmlformats.org/presentationml/2006/main">
   <p:cSld>
     <p:spTree>
@@ -1460,6 +1182,284 @@
 loop, no architect mode. What it must have is the spine they just watched.
 If somebody asks how big it is: smaller than they fear, and the specification
 work is the part that decides how long it takes.</a:t>
+            </a:r>
+            <a:endParaRPr lang="en-US" dirty="0"/>
+          </a:p>
+        </p:txBody>
+      </p:sp>
+      <p:sp>
+        <p:nvSpPr>
+          <p:cNvPr id="4" name="Slide Number Placeholder 3"/>
+          <p:cNvSpPr>
+            <a:spLocks noGrp="1"/>
+          </p:cNvSpPr>
+          <p:nvPr>
+            <p:ph type="sldNum" sz="quarter" idx="10"/>
+          </p:nvPr>
+        </p:nvSpPr>
+        <p:spPr/>
+        <p:txBody>
+          <a:bodyPr/>
+          <a:lstStyle/>
+          <a:p>
+            <a:fld id="{F7021451-1387-4CA6-816F-3879F97B5CBC}" type="slidenum">
+              <a:rPr lang="en-US"/>
+              <a:t>16</a:t>
+            </a:fld>
+            <a:endParaRPr lang="en-US"/>
+          </a:p>
+        </p:txBody>
+      </p:sp>
+    </p:spTree>
+    <p:extLst>
+      <p:ext uri="{BB962C8B-B14F-4D97-AF65-F5344CB8AC3E}">
+        <p14:creationId xmlns:p14="http://schemas.microsoft.com/office/powerpoint/2010/main" val="1024086991"/>
+      </p:ext>
+    </p:extLst>
+  </p:cSld>
+  <p:clrMapOvr>
+    <a:masterClrMapping/>
+  </p:clrMapOvr>
+</p:notes>
+</file>
+
+<file path=ppt/notesSlides/notesSlide17.xml><?xml version="1.0" encoding="utf-8"?>
+<p:notes xmlns:a="http://schemas.openxmlformats.org/drawingml/2006/main" xmlns:r="http://schemas.openxmlformats.org/officeDocument/2006/relationships" xmlns:p="http://schemas.openxmlformats.org/presentationml/2006/main">
+  <p:cSld>
+    <p:spTree>
+      <p:nvGrpSpPr>
+        <p:cNvPr id="1" name=""/>
+        <p:cNvGrpSpPr/>
+        <p:nvPr/>
+      </p:nvGrpSpPr>
+      <p:grpSpPr>
+        <a:xfrm>
+          <a:off x="0" y="0"/>
+          <a:ext cx="0" cy="0"/>
+          <a:chOff x="0" y="0"/>
+          <a:chExt cx="0" cy="0"/>
+        </a:xfrm>
+      </p:grpSpPr>
+      <p:sp>
+        <p:nvSpPr>
+          <p:cNvPr id="2" name="Slide Image Placeholder 1"/>
+          <p:cNvSpPr>
+            <a:spLocks noGrp="1" noRot="1" noChangeAspect="1"/>
+          </p:cNvSpPr>
+          <p:nvPr>
+            <p:ph type="sldImg"/>
+          </p:nvPr>
+        </p:nvSpPr>
+        <p:spPr/>
+      </p:sp>
+      <p:sp>
+        <p:nvSpPr>
+          <p:cNvPr id="3" name="Notes Placeholder 2"/>
+          <p:cNvSpPr>
+            <a:spLocks noGrp="1"/>
+          </p:cNvSpPr>
+          <p:nvPr>
+            <p:ph type="body" idx="1"/>
+          </p:nvPr>
+        </p:nvSpPr>
+        <p:spPr/>
+        <p:txBody>
+          <a:bodyPr/>
+          <a:lstStyle/>
+          <a:p>
+            <a:r>
+              <a:rPr lang="en-US" dirty="0"/>
+              <a:t>This is the whole shape of Stage 1 and the thing most of them will get wrong by
+starting with code. Nobody hands them a specification: they write their own
+requirements, their own acceptance criteria, and their own increments.
+The history is evidence, not bureaucracy. A design committed after the code it
+describes earns nothing, and they cannot reconstruct it at the end.
+Increment specs are what an Aider session can actually execute: scoped context,
+ordered tasks, a checkable result.</a:t>
+            </a:r>
+            <a:endParaRPr lang="en-US" dirty="0"/>
+          </a:p>
+        </p:txBody>
+      </p:sp>
+      <p:sp>
+        <p:nvSpPr>
+          <p:cNvPr id="4" name="Slide Number Placeholder 3"/>
+          <p:cNvSpPr>
+            <a:spLocks noGrp="1"/>
+          </p:cNvSpPr>
+          <p:nvPr>
+            <p:ph type="sldNum" sz="quarter" idx="10"/>
+          </p:nvPr>
+        </p:nvSpPr>
+        <p:spPr/>
+        <p:txBody>
+          <a:bodyPr/>
+          <a:lstStyle/>
+          <a:p>
+            <a:fld id="{F7021451-1387-4CA6-816F-3879F97B5CBC}" type="slidenum">
+              <a:rPr lang="en-US"/>
+              <a:t>17</a:t>
+            </a:fld>
+            <a:endParaRPr lang="en-US"/>
+          </a:p>
+        </p:txBody>
+      </p:sp>
+    </p:spTree>
+    <p:extLst>
+      <p:ext uri="{BB962C8B-B14F-4D97-AF65-F5344CB8AC3E}">
+        <p14:creationId xmlns:p14="http://schemas.microsoft.com/office/powerpoint/2010/main" val="1024086991"/>
+      </p:ext>
+    </p:extLst>
+  </p:cSld>
+  <p:clrMapOvr>
+    <a:masterClrMapping/>
+  </p:clrMapOvr>
+</p:notes>
+</file>
+
+<file path=ppt/notesSlides/notesSlide18.xml><?xml version="1.0" encoding="utf-8"?>
+<p:notes xmlns:a="http://schemas.openxmlformats.org/drawingml/2006/main" xmlns:r="http://schemas.openxmlformats.org/officeDocument/2006/relationships" xmlns:p="http://schemas.openxmlformats.org/presentationml/2006/main">
+  <p:cSld>
+    <p:spTree>
+      <p:nvGrpSpPr>
+        <p:cNvPr id="1" name=""/>
+        <p:cNvGrpSpPr/>
+        <p:nvPr/>
+      </p:nvGrpSpPr>
+      <p:grpSpPr>
+        <a:xfrm>
+          <a:off x="0" y="0"/>
+          <a:ext cx="0" cy="0"/>
+          <a:chOff x="0" y="0"/>
+          <a:chExt cx="0" cy="0"/>
+        </a:xfrm>
+      </p:grpSpPr>
+      <p:sp>
+        <p:nvSpPr>
+          <p:cNvPr id="2" name="Slide Image Placeholder 1"/>
+          <p:cNvSpPr>
+            <a:spLocks noGrp="1" noRot="1" noChangeAspect="1"/>
+          </p:cNvSpPr>
+          <p:nvPr>
+            <p:ph type="sldImg"/>
+          </p:nvPr>
+        </p:nvSpPr>
+        <p:spPr/>
+      </p:sp>
+      <p:sp>
+        <p:nvSpPr>
+          <p:cNvPr id="3" name="Notes Placeholder 2"/>
+          <p:cNvSpPr>
+            <a:spLocks noGrp="1"/>
+          </p:cNvSpPr>
+          <p:nvPr>
+            <p:ph type="body" idx="1"/>
+          </p:nvPr>
+        </p:nvSpPr>
+        <p:spPr/>
+        <p:txBody>
+          <a:bodyPr/>
+          <a:lstStyle/>
+          <a:p>
+            <a:r>
+              <a:rPr lang="en-US" dirty="0"/>
+              <a:t>Their requirements have to cover the configuration and execution contracts as
+well as the seven features, with observable outcomes, edge cases and exclusions,
+and each one has to trace to an acceptance criterion of their own.
+The diagrams describe their system, not Aider. Copying this morning's picture
+earns nothing. Mermaid is enough, labels have to be legible and accurate, and
+there is no length requirement anywhere in this section.</a:t>
+            </a:r>
+            <a:endParaRPr lang="en-US" dirty="0"/>
+          </a:p>
+        </p:txBody>
+      </p:sp>
+      <p:sp>
+        <p:nvSpPr>
+          <p:cNvPr id="4" name="Slide Number Placeholder 3"/>
+          <p:cNvSpPr>
+            <a:spLocks noGrp="1"/>
+          </p:cNvSpPr>
+          <p:nvPr>
+            <p:ph type="sldNum" sz="quarter" idx="10"/>
+          </p:nvPr>
+        </p:nvSpPr>
+        <p:spPr/>
+        <p:txBody>
+          <a:bodyPr/>
+          <a:lstStyle/>
+          <a:p>
+            <a:fld id="{F7021451-1387-4CA6-816F-3879F97B5CBC}" type="slidenum">
+              <a:rPr lang="en-US"/>
+              <a:t>18</a:t>
+            </a:fld>
+            <a:endParaRPr lang="en-US"/>
+          </a:p>
+        </p:txBody>
+      </p:sp>
+    </p:spTree>
+    <p:extLst>
+      <p:ext uri="{BB962C8B-B14F-4D97-AF65-F5344CB8AC3E}">
+        <p14:creationId xmlns:p14="http://schemas.microsoft.com/office/powerpoint/2010/main" val="1024086991"/>
+      </p:ext>
+    </p:extLst>
+  </p:cSld>
+  <p:clrMapOvr>
+    <a:masterClrMapping/>
+  </p:clrMapOvr>
+</p:notes>
+</file>
+
+<file path=ppt/notesSlides/notesSlide19.xml><?xml version="1.0" encoding="utf-8"?>
+<p:notes xmlns:a="http://schemas.openxmlformats.org/drawingml/2006/main" xmlns:r="http://schemas.openxmlformats.org/officeDocument/2006/relationships" xmlns:p="http://schemas.openxmlformats.org/presentationml/2006/main">
+  <p:cSld>
+    <p:spTree>
+      <p:nvGrpSpPr>
+        <p:cNvPr id="1" name=""/>
+        <p:cNvGrpSpPr/>
+        <p:nvPr/>
+      </p:nvGrpSpPr>
+      <p:grpSpPr>
+        <a:xfrm>
+          <a:off x="0" y="0"/>
+          <a:ext cx="0" cy="0"/>
+          <a:chOff x="0" y="0"/>
+          <a:chExt cx="0" cy="0"/>
+        </a:xfrm>
+      </p:grpSpPr>
+      <p:sp>
+        <p:nvSpPr>
+          <p:cNvPr id="2" name="Slide Image Placeholder 1"/>
+          <p:cNvSpPr>
+            <a:spLocks noGrp="1" noRot="1" noChangeAspect="1"/>
+          </p:cNvSpPr>
+          <p:nvPr>
+            <p:ph type="sldImg"/>
+          </p:nvPr>
+        </p:nvSpPr>
+        <p:spPr/>
+      </p:sp>
+      <p:sp>
+        <p:nvSpPr>
+          <p:cNvPr id="3" name="Notes Placeholder 2"/>
+          <p:cNvSpPr>
+            <a:spLocks noGrp="1"/>
+          </p:cNvSpPr>
+          <p:nvPr>
+            <p:ph type="body" idx="1"/>
+          </p:nvPr>
+        </p:nvSpPr>
+        <p:spPr/>
+        <p:txBody>
+          <a:bodyPr/>
+          <a:lstStyle/>
+          <a:p>
+            <a:r>
+              <a:rPr lang="en-US" dirty="0"/>
+              <a:t>Do not read the table out. The one thing worth saying: a part they designed and
+did not implement keeps its design credit as long as it is labelled.
+Architecture credit includes explaining where tool execution, a replacement
+endpoint client and a non-terminal interface would fit, without building them.</a:t>
             </a:r>
             <a:endParaRPr lang="en-US" dirty="0"/>
           </a:p>
@@ -1642,13 +1642,11 @@
           <a:p>
             <a:r>
               <a:rPr lang="en-US" dirty="0"/>
-              <a:t>Four ideas, seven graded features. The mapping is in SPEC.md and they do not
-need it now.
-The approval gate is the one to dwell on, because it is the safety rule and it
-is where the git behavior lives: one commit per accepted edit set, and an undo
-that refuses to touch a commit their session did not make.
-Configuration is theirs to implement against a fixed schema. It is scored
-inside the first feature rather than as a row of its own, and it is not a gate.</a:t>
+              <a:t>Staff read the repository snapshot at the deadline, run their tests, and work
+through ACCEPTANCE.md. There is no hidden suite and no requirement that is not
+in SPEC.md.
+Routine tests use fakes. Live checks are documented separately and opt in, and
+honest reporting of a failed live attempt still earns its evidence points.</a:t>
             </a:r>
             <a:endParaRPr lang="en-US" dirty="0"/>
           </a:p>
@@ -1736,10 +1734,12 @@
           <a:p>
             <a:r>
               <a:rPr lang="en-US" dirty="0"/>
-              <a:t>Do not read the packet out. Point at it, say the three files above, and move on.
-GLOSSARY.md settles the vocabulary arguments, and the acceptance scenarios are
-the ones to read before starting rather than after finishing.
-Say plainly that nothing is collected at the end of today.</a:t>
+              <a:t>Half credit exists for behavior that partly works, so an unfinished feature is
+not a zero.
+Test count and coverage earn nothing by themselves. A test earns credit when it
+asserts an outcome and isolates the filesystem. Weakening an assertion to turn
+the suite green is scored as what it is.
+Configuration sits inside F1's four points and is not a gate.</a:t>
             </a:r>
             <a:endParaRPr lang="en-US" dirty="0"/>
           </a:p>
@@ -1827,9 +1827,11 @@
           <a:p>
             <a:r>
               <a:rPr lang="en-US" dirty="0"/>
-              <a:t>The last line is the one to say out loud. A plugin framework in week 3, written
-for a capability they have not been given yet, is a cost with no evidence behind
-it. Future compatibility needs a reason.</a:t>
+              <a:t>This is the section students lose points on by leaving it to the last evening,
+because it cannot be reconstructed afterwards.
+A design that worked does not need an invented failure. Say what the evidence
+was. Differences between the initial and final design are worth credit when they
+are explained.</a:t>
             </a:r>
             <a:endParaRPr lang="en-US" dirty="0"/>
           </a:p>
@@ -1917,10 +1919,10 @@
           <a:p>
             <a:r>
               <a:rPr lang="en-US" dirty="0"/>
-              <a:t>A system spec is not one giant context dump. Requirements map to planned tests,
-and those test files do not have to exist yet.
-Experiments are allowed. Label them, and reconcile them with the design before
-you build on top of them.</a:t>
+              <a:t>100 points in total across the three sections. These are build points, not
+course-grade percentages: the build is 4.5% of the course.
+Send them to RUBRIC.md rather than reading rows aloud. It names the requirement
+IDs each row scores.</a:t>
             </a:r>
             <a:endParaRPr lang="en-US" dirty="0"/>
           </a:p>
@@ -1963,198 +1965,6 @@
 </file>
 
 <file path=ppt/notesSlides/notesSlide24.xml><?xml version="1.0" encoding="utf-8"?>
-<p:notes xmlns:a="http://schemas.openxmlformats.org/drawingml/2006/main" xmlns:r="http://schemas.openxmlformats.org/officeDocument/2006/relationships" xmlns:p="http://schemas.openxmlformats.org/presentationml/2006/main">
-  <p:cSld>
-    <p:spTree>
-      <p:nvGrpSpPr>
-        <p:cNvPr id="1" name=""/>
-        <p:cNvGrpSpPr/>
-        <p:nvPr/>
-      </p:nvGrpSpPr>
-      <p:grpSpPr>
-        <a:xfrm>
-          <a:off x="0" y="0"/>
-          <a:ext cx="0" cy="0"/>
-          <a:chOff x="0" y="0"/>
-          <a:chExt cx="0" cy="0"/>
-        </a:xfrm>
-      </p:grpSpPr>
-      <p:sp>
-        <p:nvSpPr>
-          <p:cNvPr id="2" name="Slide Image Placeholder 1"/>
-          <p:cNvSpPr>
-            <a:spLocks noGrp="1" noRot="1" noChangeAspect="1"/>
-          </p:cNvSpPr>
-          <p:nvPr>
-            <p:ph type="sldImg"/>
-          </p:nvPr>
-        </p:nvSpPr>
-        <p:spPr/>
-      </p:sp>
-      <p:sp>
-        <p:nvSpPr>
-          <p:cNvPr id="3" name="Notes Placeholder 2"/>
-          <p:cNvSpPr>
-            <a:spLocks noGrp="1"/>
-          </p:cNvSpPr>
-          <p:nvPr>
-            <p:ph type="body" idx="1"/>
-          </p:nvPr>
-        </p:nvSpPr>
-        <p:spPr/>
-        <p:txBody>
-          <a:bodyPr/>
-          <a:lstStyle/>
-          <a:p>
-            <a:r>
-              <a:rPr lang="en-US" dirty="0"/>
-              <a:t>Their diagrams describe their system. Copying the Aider picture from earlier
-today earns nothing. Label anything not yet implemented, and tie component names
-to real code once the code exists.</a:t>
-            </a:r>
-            <a:endParaRPr lang="en-US" dirty="0"/>
-          </a:p>
-        </p:txBody>
-      </p:sp>
-      <p:sp>
-        <p:nvSpPr>
-          <p:cNvPr id="4" name="Slide Number Placeholder 3"/>
-          <p:cNvSpPr>
-            <a:spLocks noGrp="1"/>
-          </p:cNvSpPr>
-          <p:nvPr>
-            <p:ph type="sldNum" sz="quarter" idx="10"/>
-          </p:nvPr>
-        </p:nvSpPr>
-        <p:spPr/>
-        <p:txBody>
-          <a:bodyPr/>
-          <a:lstStyle/>
-          <a:p>
-            <a:fld id="{F7021451-1387-4CA6-816F-3879F97B5CBC}" type="slidenum">
-              <a:rPr lang="en-US"/>
-              <a:t>24</a:t>
-            </a:fld>
-            <a:endParaRPr lang="en-US"/>
-          </a:p>
-        </p:txBody>
-      </p:sp>
-    </p:spTree>
-    <p:extLst>
-      <p:ext uri="{BB962C8B-B14F-4D97-AF65-F5344CB8AC3E}">
-        <p14:creationId xmlns:p14="http://schemas.microsoft.com/office/powerpoint/2010/main" val="1024086991"/>
-      </p:ext>
-    </p:extLst>
-  </p:cSld>
-  <p:clrMapOvr>
-    <a:masterClrMapping/>
-  </p:clrMapOvr>
-</p:notes>
-</file>
-
-<file path=ppt/notesSlides/notesSlide25.xml><?xml version="1.0" encoding="utf-8"?>
-<p:notes xmlns:a="http://schemas.openxmlformats.org/drawingml/2006/main" xmlns:r="http://schemas.openxmlformats.org/officeDocument/2006/relationships" xmlns:p="http://schemas.openxmlformats.org/presentationml/2006/main">
-  <p:cSld>
-    <p:spTree>
-      <p:nvGrpSpPr>
-        <p:cNvPr id="1" name=""/>
-        <p:cNvGrpSpPr/>
-        <p:nvPr/>
-      </p:nvGrpSpPr>
-      <p:grpSpPr>
-        <a:xfrm>
-          <a:off x="0" y="0"/>
-          <a:ext cx="0" cy="0"/>
-          <a:chOff x="0" y="0"/>
-          <a:chExt cx="0" cy="0"/>
-        </a:xfrm>
-      </p:grpSpPr>
-      <p:sp>
-        <p:nvSpPr>
-          <p:cNvPr id="2" name="Slide Image Placeholder 1"/>
-          <p:cNvSpPr>
-            <a:spLocks noGrp="1" noRot="1" noChangeAspect="1"/>
-          </p:cNvSpPr>
-          <p:nvPr>
-            <p:ph type="sldImg"/>
-          </p:nvPr>
-        </p:nvSpPr>
-        <p:spPr/>
-      </p:sp>
-      <p:sp>
-        <p:nvSpPr>
-          <p:cNvPr id="3" name="Notes Placeholder 2"/>
-          <p:cNvSpPr>
-            <a:spLocks noGrp="1"/>
-          </p:cNvSpPr>
-          <p:nvPr>
-            <p:ph type="body" idx="1"/>
-          </p:nvPr>
-        </p:nvSpPr>
-        <p:spPr/>
-        <p:txBody>
-          <a:bodyPr/>
-          <a:lstStyle/>
-          <a:p>
-            <a:r>
-              <a:rPr lang="en-US" dirty="0"/>
-              <a:t>These are points inside the build grade, not percentages of the course grade.
-The build is 4.5% of the course and is due September 25.
-Do not read the table out. Send them to RUBRIC.md, which carries the
-per-criterion breakdown this slide summarizes, and spend the time on the four
-things worth saying out loud instead:
-- Completeness and usefulness are graded. Document length is not.
-- A correct failing test can earn test credit while exposing an unfinished
-  feature. Only one point in the whole rubric depends on the live model
-  actually succeeding, and honest evidence of a failed run still earns the
-  reporting points.
-- Design keeps its credit when the implementation falls short, as long as the
-  design's claims and the final status are honest. No repeated deductions for
-  one missing feature across otherwise sound artifacts.
-- Evidence means a pointer someone can follow. Volume of logs is not evidence.
-Policy violations go through academic integrity procedures, not the rubric.</a:t>
-            </a:r>
-            <a:endParaRPr lang="en-US" dirty="0"/>
-          </a:p>
-        </p:txBody>
-      </p:sp>
-      <p:sp>
-        <p:nvSpPr>
-          <p:cNvPr id="4" name="Slide Number Placeholder 3"/>
-          <p:cNvSpPr>
-            <a:spLocks noGrp="1"/>
-          </p:cNvSpPr>
-          <p:nvPr>
-            <p:ph type="sldNum" sz="quarter" idx="10"/>
-          </p:nvPr>
-        </p:nvSpPr>
-        <p:spPr/>
-        <p:txBody>
-          <a:bodyPr/>
-          <a:lstStyle/>
-          <a:p>
-            <a:fld id="{F7021451-1387-4CA6-816F-3879F97B5CBC}" type="slidenum">
-              <a:rPr lang="en-US"/>
-              <a:t>25</a:t>
-            </a:fld>
-            <a:endParaRPr lang="en-US"/>
-          </a:p>
-        </p:txBody>
-      </p:sp>
-    </p:spTree>
-    <p:extLst>
-      <p:ext uri="{BB962C8B-B14F-4D97-AF65-F5344CB8AC3E}">
-        <p14:creationId xmlns:p14="http://schemas.microsoft.com/office/powerpoint/2010/main" val="1024086991"/>
-      </p:ext>
-    </p:extLst>
-  </p:cSld>
-  <p:clrMapOvr>
-    <a:masterClrMapping/>
-  </p:clrMapOvr>
-</p:notes>
-</file>
-
-<file path=ppt/notesSlides/notesSlide26.xml><?xml version="1.0" encoding="utf-8"?>
 <p:notes xmlns:a="http://schemas.openxmlformats.org/drawingml/2006/main" xmlns:r="http://schemas.openxmlformats.org/officeDocument/2006/relationships" xmlns:p="http://schemas.openxmlformats.org/presentationml/2006/main">
   <p:cSld>
     <p:spTree>
@@ -2227,7 +2037,7 @@
           <a:p>
             <a:fld id="{F7021451-1387-4CA6-816F-3879F97B5CBC}" type="slidenum">
               <a:rPr lang="en-US"/>
-              <a:t>26</a:t>
+              <a:t>24</a:t>
             </a:fld>
             <a:endParaRPr lang="en-US"/>
           </a:p>
@@ -2246,7 +2056,7 @@
 </p:notes>
 </file>
 
-<file path=ppt/notesSlides/notesSlide27.xml><?xml version="1.0" encoding="utf-8"?>
+<file path=ppt/notesSlides/notesSlide25.xml><?xml version="1.0" encoding="utf-8"?>
 <p:notes xmlns:a="http://schemas.openxmlformats.org/drawingml/2006/main" xmlns:r="http://schemas.openxmlformats.org/officeDocument/2006/relationships" xmlns:p="http://schemas.openxmlformats.org/presentationml/2006/main">
   <p:cSld>
     <p:spTree>
@@ -2317,7 +2127,7 @@
           <a:p>
             <a:fld id="{F7021451-1387-4CA6-816F-3879F97B5CBC}" type="slidenum">
               <a:rPr lang="en-US"/>
-              <a:t>27</a:t>
+              <a:t>25</a:t>
             </a:fld>
             <a:endParaRPr lang="en-US"/>
           </a:p>
@@ -2336,7 +2146,7 @@
 </p:notes>
 </file>
 
-<file path=ppt/notesSlides/notesSlide28.xml><?xml version="1.0" encoding="utf-8"?>
+<file path=ppt/notesSlides/notesSlide26.xml><?xml version="1.0" encoding="utf-8"?>
 <p:notes xmlns:a="http://schemas.openxmlformats.org/drawingml/2006/main" xmlns:r="http://schemas.openxmlformats.org/officeDocument/2006/relationships" xmlns:p="http://schemas.openxmlformats.org/presentationml/2006/main">
   <p:cSld>
     <p:spTree>
@@ -2411,7 +2221,7 @@
           <a:p>
             <a:fld id="{F7021451-1387-4CA6-816F-3879F97B5CBC}" type="slidenum">
               <a:rPr lang="en-US"/>
-              <a:t>28</a:t>
+              <a:t>26</a:t>
             </a:fld>
             <a:endParaRPr lang="en-US"/>
           </a:p>
@@ -2430,7 +2240,7 @@
 </p:notes>
 </file>
 
-<file path=ppt/notesSlides/notesSlide29.xml><?xml version="1.0" encoding="utf-8"?>
+<file path=ppt/notesSlides/notesSlide27.xml><?xml version="1.0" encoding="utf-8"?>
 <p:notes xmlns:a="http://schemas.openxmlformats.org/drawingml/2006/main" xmlns:r="http://schemas.openxmlformats.org/officeDocument/2006/relationships" xmlns:p="http://schemas.openxmlformats.org/presentationml/2006/main">
   <p:cSld>
     <p:spTree>
@@ -2479,6 +2289,192 @@
               <a:t>Do not turn the left column into a weakness. Aider automates plenty. What
 changes on the right is who decides the next action.
 Source: https://code.claude.com/docs/en/overview</a:t>
+            </a:r>
+            <a:endParaRPr lang="en-US" dirty="0"/>
+          </a:p>
+        </p:txBody>
+      </p:sp>
+      <p:sp>
+        <p:nvSpPr>
+          <p:cNvPr id="4" name="Slide Number Placeholder 3"/>
+          <p:cNvSpPr>
+            <a:spLocks noGrp="1"/>
+          </p:cNvSpPr>
+          <p:nvPr>
+            <p:ph type="sldNum" sz="quarter" idx="10"/>
+          </p:nvPr>
+        </p:nvSpPr>
+        <p:spPr/>
+        <p:txBody>
+          <a:bodyPr/>
+          <a:lstStyle/>
+          <a:p>
+            <a:fld id="{F7021451-1387-4CA6-816F-3879F97B5CBC}" type="slidenum">
+              <a:rPr lang="en-US"/>
+              <a:t>27</a:t>
+            </a:fld>
+            <a:endParaRPr lang="en-US"/>
+          </a:p>
+        </p:txBody>
+      </p:sp>
+    </p:spTree>
+    <p:extLst>
+      <p:ext uri="{BB962C8B-B14F-4D97-AF65-F5344CB8AC3E}">
+        <p14:creationId xmlns:p14="http://schemas.microsoft.com/office/powerpoint/2010/main" val="1024086991"/>
+      </p:ext>
+    </p:extLst>
+  </p:cSld>
+  <p:clrMapOvr>
+    <a:masterClrMapping/>
+  </p:clrMapOvr>
+</p:notes>
+</file>
+
+<file path=ppt/notesSlides/notesSlide28.xml><?xml version="1.0" encoding="utf-8"?>
+<p:notes xmlns:a="http://schemas.openxmlformats.org/drawingml/2006/main" xmlns:r="http://schemas.openxmlformats.org/officeDocument/2006/relationships" xmlns:p="http://schemas.openxmlformats.org/presentationml/2006/main">
+  <p:cSld>
+    <p:spTree>
+      <p:nvGrpSpPr>
+        <p:cNvPr id="1" name=""/>
+        <p:cNvGrpSpPr/>
+        <p:nvPr/>
+      </p:nvGrpSpPr>
+      <p:grpSpPr>
+        <a:xfrm>
+          <a:off x="0" y="0"/>
+          <a:ext cx="0" cy="0"/>
+          <a:chOff x="0" y="0"/>
+          <a:chExt cx="0" cy="0"/>
+        </a:xfrm>
+      </p:grpSpPr>
+      <p:sp>
+        <p:nvSpPr>
+          <p:cNvPr id="2" name="Slide Image Placeholder 1"/>
+          <p:cNvSpPr>
+            <a:spLocks noGrp="1" noRot="1" noChangeAspect="1"/>
+          </p:cNvSpPr>
+          <p:nvPr>
+            <p:ph type="sldImg"/>
+          </p:nvPr>
+        </p:nvSpPr>
+        <p:spPr/>
+      </p:sp>
+      <p:sp>
+        <p:nvSpPr>
+          <p:cNvPr id="3" name="Notes Placeholder 2"/>
+          <p:cNvSpPr>
+            <a:spLocks noGrp="1"/>
+          </p:cNvSpPr>
+          <p:nvPr>
+            <p:ph type="body" idx="1"/>
+          </p:nvPr>
+        </p:nvSpPr>
+        <p:spPr/>
+        <p:txBody>
+          <a:bodyPr/>
+          <a:lstStyle/>
+          <a:p>
+            <a:r>
+              <a:rPr lang="en-US" dirty="0"/>
+              <a:t>This is the last thing they hear before office hours, so land it and stop.
+Name the two tools as a shape, not as a target to clone and not as something
+they need an account for. What makes it that shape is the list they will build:
+tools the model chooses, an approval layer, state that survives a run, more
+than one way in.
+The design habit to start now: when a decision could close off one of those,
+leave a boundary rather than an implementation. That is the useful half of the
+slide this replaced.</a:t>
+            </a:r>
+            <a:endParaRPr lang="en-US" dirty="0"/>
+          </a:p>
+        </p:txBody>
+      </p:sp>
+      <p:sp>
+        <p:nvSpPr>
+          <p:cNvPr id="4" name="Slide Number Placeholder 3"/>
+          <p:cNvSpPr>
+            <a:spLocks noGrp="1"/>
+          </p:cNvSpPr>
+          <p:nvPr>
+            <p:ph type="sldNum" sz="quarter" idx="10"/>
+          </p:nvPr>
+        </p:nvSpPr>
+        <p:spPr/>
+        <p:txBody>
+          <a:bodyPr/>
+          <a:lstStyle/>
+          <a:p>
+            <a:fld id="{F7021451-1387-4CA6-816F-3879F97B5CBC}" type="slidenum">
+              <a:rPr lang="en-US"/>
+              <a:t>28</a:t>
+            </a:fld>
+            <a:endParaRPr lang="en-US"/>
+          </a:p>
+        </p:txBody>
+      </p:sp>
+    </p:spTree>
+    <p:extLst>
+      <p:ext uri="{BB962C8B-B14F-4D97-AF65-F5344CB8AC3E}">
+        <p14:creationId xmlns:p14="http://schemas.microsoft.com/office/powerpoint/2010/main" val="1024086991"/>
+      </p:ext>
+    </p:extLst>
+  </p:cSld>
+  <p:clrMapOvr>
+    <a:masterClrMapping/>
+  </p:clrMapOvr>
+</p:notes>
+</file>
+
+<file path=ppt/notesSlides/notesSlide29.xml><?xml version="1.0" encoding="utf-8"?>
+<p:notes xmlns:a="http://schemas.openxmlformats.org/drawingml/2006/main" xmlns:r="http://schemas.openxmlformats.org/officeDocument/2006/relationships" xmlns:p="http://schemas.openxmlformats.org/presentationml/2006/main">
+  <p:cSld>
+    <p:spTree>
+      <p:nvGrpSpPr>
+        <p:cNvPr id="1" name=""/>
+        <p:cNvGrpSpPr/>
+        <p:nvPr/>
+      </p:nvGrpSpPr>
+      <p:grpSpPr>
+        <a:xfrm>
+          <a:off x="0" y="0"/>
+          <a:ext cx="0" cy="0"/>
+          <a:chOff x="0" y="0"/>
+          <a:chExt cx="0" cy="0"/>
+        </a:xfrm>
+      </p:grpSpPr>
+      <p:sp>
+        <p:nvSpPr>
+          <p:cNvPr id="2" name="Slide Image Placeholder 1"/>
+          <p:cNvSpPr>
+            <a:spLocks noGrp="1" noRot="1" noChangeAspect="1"/>
+          </p:cNvSpPr>
+          <p:nvPr>
+            <p:ph type="sldImg"/>
+          </p:nvPr>
+        </p:nvSpPr>
+        <p:spPr/>
+      </p:sp>
+      <p:sp>
+        <p:nvSpPr>
+          <p:cNvPr id="3" name="Notes Placeholder 2"/>
+          <p:cNvSpPr>
+            <a:spLocks noGrp="1"/>
+          </p:cNvSpPr>
+          <p:nvPr>
+            <p:ph type="body" idx="1"/>
+          </p:nvPr>
+        </p:nvSpPr>
+        <p:spPr/>
+        <p:txBody>
+          <a:bodyPr/>
+          <a:lstStyle/>
+          <a:p>
+            <a:r>
+              <a:rPr lang="en-US" dirty="0"/>
+              <a:t>Stop talking. Staff circulate from here. Leave the deck up so students can page
+back through it themselves.
+This is the point where you say plainly that nothing is due at the end of
+today. Most of them will still expect a checkoff.</a:t>
             </a:r>
             <a:endParaRPr lang="en-US" dirty="0"/>
           </a:p>
@@ -2661,14 +2657,7 @@
           <a:p>
             <a:r>
               <a:rPr lang="en-US" dirty="0"/>
-              <a:t>This is the last thing they hear before office hours, so land it and stop.
-Name the two tools as a shape, not as a target to clone and not as something
-they need an account for. What makes it that shape is the list they will build:
-tools the model chooses, an approval layer, state that survives a run, more
-than one way in.
-The design habit to start now: when a decision could close off one of those,
-leave a boundary rather than an implementation. That is the useful half of the
-slide this replaced.</a:t>
+              <a:t/>
             </a:r>
             <a:endParaRPr lang="en-US" dirty="0"/>
           </a:p>
@@ -2692,185 +2681,6 @@
             <a:fld id="{F7021451-1387-4CA6-816F-3879F97B5CBC}" type="slidenum">
               <a:rPr lang="en-US"/>
               <a:t>30</a:t>
-            </a:fld>
-            <a:endParaRPr lang="en-US"/>
-          </a:p>
-        </p:txBody>
-      </p:sp>
-    </p:spTree>
-    <p:extLst>
-      <p:ext uri="{BB962C8B-B14F-4D97-AF65-F5344CB8AC3E}">
-        <p14:creationId xmlns:p14="http://schemas.microsoft.com/office/powerpoint/2010/main" val="1024086991"/>
-      </p:ext>
-    </p:extLst>
-  </p:cSld>
-  <p:clrMapOvr>
-    <a:masterClrMapping/>
-  </p:clrMapOvr>
-</p:notes>
-</file>
-
-<file path=ppt/notesSlides/notesSlide31.xml><?xml version="1.0" encoding="utf-8"?>
-<p:notes xmlns:a="http://schemas.openxmlformats.org/drawingml/2006/main" xmlns:r="http://schemas.openxmlformats.org/officeDocument/2006/relationships" xmlns:p="http://schemas.openxmlformats.org/presentationml/2006/main">
-  <p:cSld>
-    <p:spTree>
-      <p:nvGrpSpPr>
-        <p:cNvPr id="1" name=""/>
-        <p:cNvGrpSpPr/>
-        <p:nvPr/>
-      </p:nvGrpSpPr>
-      <p:grpSpPr>
-        <a:xfrm>
-          <a:off x="0" y="0"/>
-          <a:ext cx="0" cy="0"/>
-          <a:chOff x="0" y="0"/>
-          <a:chExt cx="0" cy="0"/>
-        </a:xfrm>
-      </p:grpSpPr>
-      <p:sp>
-        <p:nvSpPr>
-          <p:cNvPr id="2" name="Slide Image Placeholder 1"/>
-          <p:cNvSpPr>
-            <a:spLocks noGrp="1" noRot="1" noChangeAspect="1"/>
-          </p:cNvSpPr>
-          <p:nvPr>
-            <p:ph type="sldImg"/>
-          </p:nvPr>
-        </p:nvSpPr>
-        <p:spPr/>
-      </p:sp>
-      <p:sp>
-        <p:nvSpPr>
-          <p:cNvPr id="3" name="Notes Placeholder 2"/>
-          <p:cNvSpPr>
-            <a:spLocks noGrp="1"/>
-          </p:cNvSpPr>
-          <p:nvPr>
-            <p:ph type="body" idx="1"/>
-          </p:nvPr>
-        </p:nvSpPr>
-        <p:spPr/>
-        <p:txBody>
-          <a:bodyPr/>
-          <a:lstStyle/>
-          <a:p>
-            <a:r>
-              <a:rPr lang="en-US" dirty="0"/>
-              <a:t>Stop talking. Staff circulate from here. Leave the deck up so students can page
-back through it themselves.
-This is the point where you say plainly that nothing is due at the end of
-today. Most of them will still expect a checkoff.</a:t>
-            </a:r>
-            <a:endParaRPr lang="en-US" dirty="0"/>
-          </a:p>
-        </p:txBody>
-      </p:sp>
-      <p:sp>
-        <p:nvSpPr>
-          <p:cNvPr id="4" name="Slide Number Placeholder 3"/>
-          <p:cNvSpPr>
-            <a:spLocks noGrp="1"/>
-          </p:cNvSpPr>
-          <p:nvPr>
-            <p:ph type="sldNum" sz="quarter" idx="10"/>
-          </p:nvPr>
-        </p:nvSpPr>
-        <p:spPr/>
-        <p:txBody>
-          <a:bodyPr/>
-          <a:lstStyle/>
-          <a:p>
-            <a:fld id="{F7021451-1387-4CA6-816F-3879F97B5CBC}" type="slidenum">
-              <a:rPr lang="en-US"/>
-              <a:t>31</a:t>
-            </a:fld>
-            <a:endParaRPr lang="en-US"/>
-          </a:p>
-        </p:txBody>
-      </p:sp>
-    </p:spTree>
-    <p:extLst>
-      <p:ext uri="{BB962C8B-B14F-4D97-AF65-F5344CB8AC3E}">
-        <p14:creationId xmlns:p14="http://schemas.microsoft.com/office/powerpoint/2010/main" val="1024086991"/>
-      </p:ext>
-    </p:extLst>
-  </p:cSld>
-  <p:clrMapOvr>
-    <a:masterClrMapping/>
-  </p:clrMapOvr>
-</p:notes>
-</file>
-
-<file path=ppt/notesSlides/notesSlide32.xml><?xml version="1.0" encoding="utf-8"?>
-<p:notes xmlns:a="http://schemas.openxmlformats.org/drawingml/2006/main" xmlns:r="http://schemas.openxmlformats.org/officeDocument/2006/relationships" xmlns:p="http://schemas.openxmlformats.org/presentationml/2006/main">
-  <p:cSld>
-    <p:spTree>
-      <p:nvGrpSpPr>
-        <p:cNvPr id="1" name=""/>
-        <p:cNvGrpSpPr/>
-        <p:nvPr/>
-      </p:nvGrpSpPr>
-      <p:grpSpPr>
-        <a:xfrm>
-          <a:off x="0" y="0"/>
-          <a:ext cx="0" cy="0"/>
-          <a:chOff x="0" y="0"/>
-          <a:chExt cx="0" cy="0"/>
-        </a:xfrm>
-      </p:grpSpPr>
-      <p:sp>
-        <p:nvSpPr>
-          <p:cNvPr id="2" name="Slide Image Placeholder 1"/>
-          <p:cNvSpPr>
-            <a:spLocks noGrp="1" noRot="1" noChangeAspect="1"/>
-          </p:cNvSpPr>
-          <p:nvPr>
-            <p:ph type="sldImg"/>
-          </p:nvPr>
-        </p:nvSpPr>
-        <p:spPr/>
-      </p:sp>
-      <p:sp>
-        <p:nvSpPr>
-          <p:cNvPr id="3" name="Notes Placeholder 2"/>
-          <p:cNvSpPr>
-            <a:spLocks noGrp="1"/>
-          </p:cNvSpPr>
-          <p:nvPr>
-            <p:ph type="body" idx="1"/>
-          </p:nvPr>
-        </p:nvSpPr>
-        <p:spPr/>
-        <p:txBody>
-          <a:bodyPr/>
-          <a:lstStyle/>
-          <a:p>
-            <a:r>
-              <a:rPr lang="en-US" dirty="0"/>
-              <a:t/>
-            </a:r>
-            <a:endParaRPr lang="en-US" dirty="0"/>
-          </a:p>
-        </p:txBody>
-      </p:sp>
-      <p:sp>
-        <p:nvSpPr>
-          <p:cNvPr id="4" name="Slide Number Placeholder 3"/>
-          <p:cNvSpPr>
-            <a:spLocks noGrp="1"/>
-          </p:cNvSpPr>
-          <p:nvPr>
-            <p:ph type="sldNum" sz="quarter" idx="10"/>
-          </p:nvPr>
-        </p:nvSpPr>
-        <p:spPr/>
-        <p:txBody>
-          <a:bodyPr/>
-          <a:lstStyle/>
-          <a:p>
-            <a:fld id="{F7021451-1387-4CA6-816F-3879F97B5CBC}" type="slidenum">
-              <a:rPr lang="en-US"/>
-              <a:t>32</a:t>
             </a:fld>
             <a:endParaRPr lang="en-US"/>
           </a:p>
@@ -3123,7 +2933,11 @@
           <a:p>
             <a:r>
               <a:rPr lang="en-US" dirty="0"/>
-              <a:t>Four steps. Say up front that only step 2 belongs to the model.</a:t>
+              <a:t>This block is now about context rather than a walkthrough of a whole turn
+(instructor cuts 2026-09-13). Most of it is the repo map, because that is the
+part nobody has met before and the part that quietly spends their budget.
+Say up front that only the reply belongs to the model. Everything else in this
+block is the harness deciding what the model gets to see.</a:t>
             </a:r>
             <a:endParaRPr lang="en-US" dirty="0"/>
           </a:p>
@@ -3306,7 +3120,12 @@
 depends on the coder, the model and the settings, and it changes between
 releases. The list above is the shape, not the wire format.
 Ask what the model would need in order to change three files consistently, when
-nothing has told it which three. That question sets up the next two slides.</a:t>
+nothing has told it which three. That question sets up the repo map.
+The /add slide was cut on 2026-09-13 because they have been doing this for two
+weeks. Two things it carried, worth saying if anyone asks rather than putting
+back on the glass: added files can be rewritten while read-only files can only
+be cited, and adding the whole package is not a selection strategy, it is a way
+to spend the budget.</a:t>
             </a:r>
             <a:endParaRPr lang="en-US" dirty="0"/>
           </a:p>
@@ -3394,10 +3213,10 @@
           <a:p>
             <a:r>
               <a:rPr lang="en-US" dirty="0"/>
-              <a:t>Walk through choosing the few files a change touches rather than the whole
-package. Adding everything is not a selection strategy, it is a way to spend
-the budget. Read-only context still costs budget. /tokens tells you what you
-are spending, and nothing about whether the edit will be correct.</a:t>
+              <a:t>Point at the vertical bars: that is aider quoting source lines. Point at the
+dots: that is everything it decided not to spend tokens on.
+Ask what this is for. The answer is on the next slide: it is aider guessing
+what you would have typed /add for.</a:t>
             </a:r>
             <a:endParaRPr lang="en-US" dirty="0"/>
           </a:p>
@@ -4646,84 +4465,6 @@
 <file path=ppt/slides/slide30.xml><?xml version="1.0" encoding="utf-8"?>
 <p:sld xmlns:a="http://schemas.openxmlformats.org/drawingml/2006/main" xmlns:r="http://schemas.openxmlformats.org/officeDocument/2006/relationships" xmlns:p="http://schemas.openxmlformats.org/presentationml/2006/main">
   <p:cSld name="Slide 30">
-    <p:bg>
-      <p:bgPr>
-        <a:blipFill dpi="0" rotWithShape="1">
-          <a:blip r:embed="rId1">
-            <a:lum/>
-          </a:blip>
-          <a:srcRect/>
-          <a:stretch>
-            <a:fillRect/>
-          </a:stretch>
-        </a:blipFill>
-        <a:effectLst/>
-      </p:bgPr>
-    </p:bg>
-    <p:spTree>
-      <p:nvGrpSpPr>
-        <p:cNvPr id="1" name=""/>
-        <p:cNvGrpSpPr/>
-        <p:nvPr/>
-      </p:nvGrpSpPr>
-      <p:grpSpPr>
-        <a:xfrm>
-          <a:off x="0" y="0"/>
-          <a:ext cx="0" cy="0"/>
-          <a:chOff x="0" y="0"/>
-          <a:chExt cx="0" cy="0"/>
-        </a:xfrm>
-      </p:grpSpPr>
-    </p:spTree>
-  </p:cSld>
-  <p:clrMapOvr>
-    <a:masterClrMapping/>
-  </p:clrMapOvr>
-</p:sld>
-</file>
-
-<file path=ppt/slides/slide31.xml><?xml version="1.0" encoding="utf-8"?>
-<p:sld xmlns:a="http://schemas.openxmlformats.org/drawingml/2006/main" xmlns:r="http://schemas.openxmlformats.org/officeDocument/2006/relationships" xmlns:p="http://schemas.openxmlformats.org/presentationml/2006/main">
-  <p:cSld name="Slide 31">
-    <p:bg>
-      <p:bgPr>
-        <a:blipFill dpi="0" rotWithShape="1">
-          <a:blip r:embed="rId1">
-            <a:lum/>
-          </a:blip>
-          <a:srcRect/>
-          <a:stretch>
-            <a:fillRect/>
-          </a:stretch>
-        </a:blipFill>
-        <a:effectLst/>
-      </p:bgPr>
-    </p:bg>
-    <p:spTree>
-      <p:nvGrpSpPr>
-        <p:cNvPr id="1" name=""/>
-        <p:cNvGrpSpPr/>
-        <p:nvPr/>
-      </p:nvGrpSpPr>
-      <p:grpSpPr>
-        <a:xfrm>
-          <a:off x="0" y="0"/>
-          <a:ext cx="0" cy="0"/>
-          <a:chOff x="0" y="0"/>
-          <a:chExt cx="0" cy="0"/>
-        </a:xfrm>
-      </p:grpSpPr>
-    </p:spTree>
-  </p:cSld>
-  <p:clrMapOvr>
-    <a:masterClrMapping/>
-  </p:clrMapOvr>
-</p:sld>
-</file>
-
-<file path=ppt/slides/slide32.xml><?xml version="1.0" encoding="utf-8"?>
-<p:sld xmlns:a="http://schemas.openxmlformats.org/drawingml/2006/main" xmlns:r="http://schemas.openxmlformats.org/officeDocument/2006/relationships" xmlns:p="http://schemas.openxmlformats.org/presentationml/2006/main">
-  <p:cSld name="Slide 32">
     <p:bg>
       <p:bgPr>
         <a:blipFill dpi="0" rotWithShape="1">

</xml_diff>

<commit_message>
Lab01: cut "What staff will run"
Reship of aase-f26 36e01e3. The supporting slide before the
demonstrated-behavior grading breakdown is gone; the deck is 29
slides, 29 PDF pages, 29 PPTX slides.

Co-Authored-By: Claude Opus 5 (1M context) <noreply@anthropic.com>
Claude-Session: https://claude.ai/code/session_015pu78gNF4378sH81fTPKSc
</commit_message>
<xml_diff>
--- a/labs/Lab01/slides.pptx
+++ b/labs/Lab01/slides.pptx
@@ -34,10 +34,9 @@
     <p:sldId id="282" r:id="rId28"/>
     <p:sldId id="283" r:id="rId29"/>
     <p:sldId id="284" r:id="rId30"/>
-    <p:sldId id="285" r:id="rId31"/>
   </p:sldIdLst>
   <p:notesMasterIdLst>
-    <p:notesMasterId r:id="rId32"/>
+    <p:notesMasterId r:id="rId31"/>
   </p:notesMasterIdLst>
   <p:sldSz cx="9334500" cy="5248275"/>
   <p:notesSz cx="5248275" cy="9334500"/>
@@ -1642,11 +1641,17 @@
           <a:p>
             <a:r>
               <a:rPr lang="en-US" dirty="0"/>
-              <a:t>Staff read the repository snapshot at the deadline, run their tests, and work
-through ACCEPTANCE.md. There is no hidden suite and no requirement that is not
-in SPEC.md.
-Routine tests use fakes. Live checks are documented separately and opt in, and
-honest reporting of a failed live attempt still earns its evidence points.</a:t>
+              <a:t>Half credit exists for behavior that partly works, so an unfinished feature is
+not a zero.
+Test count and coverage earn nothing by themselves. A test earns credit when it
+asserts an outcome and isolates the filesystem. Weakening an assertion to turn
+the suite green is scored as what it is.
+Configuration sits inside F1's four points and is not a gate.
+Staff read the repository snapshot at the deadline, run their own tests, and
+work through ACCEPTANCE.md. There is no hidden suite and no requirement that is
+not in SPEC.md. Routine tests use fakes rather than a live model; live checks
+are documented separately and opt in, and an honestly reported failed live
+attempt still earns its evidence points.</a:t>
             </a:r>
             <a:endParaRPr lang="en-US" dirty="0"/>
           </a:p>
@@ -1689,99 +1694,6 @@
 </file>
 
 <file path=ppt/notesSlides/notesSlide21.xml><?xml version="1.0" encoding="utf-8"?>
-<p:notes xmlns:a="http://schemas.openxmlformats.org/drawingml/2006/main" xmlns:r="http://schemas.openxmlformats.org/officeDocument/2006/relationships" xmlns:p="http://schemas.openxmlformats.org/presentationml/2006/main">
-  <p:cSld>
-    <p:spTree>
-      <p:nvGrpSpPr>
-        <p:cNvPr id="1" name=""/>
-        <p:cNvGrpSpPr/>
-        <p:nvPr/>
-      </p:nvGrpSpPr>
-      <p:grpSpPr>
-        <a:xfrm>
-          <a:off x="0" y="0"/>
-          <a:ext cx="0" cy="0"/>
-          <a:chOff x="0" y="0"/>
-          <a:chExt cx="0" cy="0"/>
-        </a:xfrm>
-      </p:grpSpPr>
-      <p:sp>
-        <p:nvSpPr>
-          <p:cNvPr id="2" name="Slide Image Placeholder 1"/>
-          <p:cNvSpPr>
-            <a:spLocks noGrp="1" noRot="1" noChangeAspect="1"/>
-          </p:cNvSpPr>
-          <p:nvPr>
-            <p:ph type="sldImg"/>
-          </p:nvPr>
-        </p:nvSpPr>
-        <p:spPr/>
-      </p:sp>
-      <p:sp>
-        <p:nvSpPr>
-          <p:cNvPr id="3" name="Notes Placeholder 2"/>
-          <p:cNvSpPr>
-            <a:spLocks noGrp="1"/>
-          </p:cNvSpPr>
-          <p:nvPr>
-            <p:ph type="body" idx="1"/>
-          </p:nvPr>
-        </p:nvSpPr>
-        <p:spPr/>
-        <p:txBody>
-          <a:bodyPr/>
-          <a:lstStyle/>
-          <a:p>
-            <a:r>
-              <a:rPr lang="en-US" dirty="0"/>
-              <a:t>Half credit exists for behavior that partly works, so an unfinished feature is
-not a zero.
-Test count and coverage earn nothing by themselves. A test earns credit when it
-asserts an outcome and isolates the filesystem. Weakening an assertion to turn
-the suite green is scored as what it is.
-Configuration sits inside F1's four points and is not a gate.</a:t>
-            </a:r>
-            <a:endParaRPr lang="en-US" dirty="0"/>
-          </a:p>
-        </p:txBody>
-      </p:sp>
-      <p:sp>
-        <p:nvSpPr>
-          <p:cNvPr id="4" name="Slide Number Placeholder 3"/>
-          <p:cNvSpPr>
-            <a:spLocks noGrp="1"/>
-          </p:cNvSpPr>
-          <p:nvPr>
-            <p:ph type="sldNum" sz="quarter" idx="10"/>
-          </p:nvPr>
-        </p:nvSpPr>
-        <p:spPr/>
-        <p:txBody>
-          <a:bodyPr/>
-          <a:lstStyle/>
-          <a:p>
-            <a:fld id="{F7021451-1387-4CA6-816F-3879F97B5CBC}" type="slidenum">
-              <a:rPr lang="en-US"/>
-              <a:t>21</a:t>
-            </a:fld>
-            <a:endParaRPr lang="en-US"/>
-          </a:p>
-        </p:txBody>
-      </p:sp>
-    </p:spTree>
-    <p:extLst>
-      <p:ext uri="{BB962C8B-B14F-4D97-AF65-F5344CB8AC3E}">
-        <p14:creationId xmlns:p14="http://schemas.microsoft.com/office/powerpoint/2010/main" val="1024086991"/>
-      </p:ext>
-    </p:extLst>
-  </p:cSld>
-  <p:clrMapOvr>
-    <a:masterClrMapping/>
-  </p:clrMapOvr>
-</p:notes>
-</file>
-
-<file path=ppt/notesSlides/notesSlide22.xml><?xml version="1.0" encoding="utf-8"?>
 <p:notes xmlns:a="http://schemas.openxmlformats.org/drawingml/2006/main" xmlns:r="http://schemas.openxmlformats.org/officeDocument/2006/relationships" xmlns:p="http://schemas.openxmlformats.org/presentationml/2006/main">
   <p:cSld>
     <p:spTree>
@@ -1854,7 +1766,7 @@
           <a:p>
             <a:fld id="{F7021451-1387-4CA6-816F-3879F97B5CBC}" type="slidenum">
               <a:rPr lang="en-US"/>
-              <a:t>22</a:t>
+              <a:t>21</a:t>
             </a:fld>
             <a:endParaRPr lang="en-US"/>
           </a:p>
@@ -1873,7 +1785,7 @@
 </p:notes>
 </file>
 
-<file path=ppt/notesSlides/notesSlide23.xml><?xml version="1.0" encoding="utf-8"?>
+<file path=ppt/notesSlides/notesSlide22.xml><?xml version="1.0" encoding="utf-8"?>
 <p:notes xmlns:a="http://schemas.openxmlformats.org/drawingml/2006/main" xmlns:r="http://schemas.openxmlformats.org/officeDocument/2006/relationships" xmlns:p="http://schemas.openxmlformats.org/presentationml/2006/main">
   <p:cSld>
     <p:spTree>
@@ -1945,7 +1857,7 @@
           <a:p>
             <a:fld id="{F7021451-1387-4CA6-816F-3879F97B5CBC}" type="slidenum">
               <a:rPr lang="en-US"/>
-              <a:t>23</a:t>
+              <a:t>22</a:t>
             </a:fld>
             <a:endParaRPr lang="en-US"/>
           </a:p>
@@ -1964,7 +1876,7 @@
 </p:notes>
 </file>
 
-<file path=ppt/notesSlides/notesSlide24.xml><?xml version="1.0" encoding="utf-8"?>
+<file path=ppt/notesSlides/notesSlide23.xml><?xml version="1.0" encoding="utf-8"?>
 <p:notes xmlns:a="http://schemas.openxmlformats.org/drawingml/2006/main" xmlns:r="http://schemas.openxmlformats.org/officeDocument/2006/relationships" xmlns:p="http://schemas.openxmlformats.org/presentationml/2006/main">
   <p:cSld>
     <p:spTree>
@@ -2037,7 +1949,7 @@
           <a:p>
             <a:fld id="{F7021451-1387-4CA6-816F-3879F97B5CBC}" type="slidenum">
               <a:rPr lang="en-US"/>
-              <a:t>24</a:t>
+              <a:t>23</a:t>
             </a:fld>
             <a:endParaRPr lang="en-US"/>
           </a:p>
@@ -2056,7 +1968,7 @@
 </p:notes>
 </file>
 
-<file path=ppt/notesSlides/notesSlide25.xml><?xml version="1.0" encoding="utf-8"?>
+<file path=ppt/notesSlides/notesSlide24.xml><?xml version="1.0" encoding="utf-8"?>
 <p:notes xmlns:a="http://schemas.openxmlformats.org/drawingml/2006/main" xmlns:r="http://schemas.openxmlformats.org/officeDocument/2006/relationships" xmlns:p="http://schemas.openxmlformats.org/presentationml/2006/main">
   <p:cSld>
     <p:spTree>
@@ -2127,7 +2039,7 @@
           <a:p>
             <a:fld id="{F7021451-1387-4CA6-816F-3879F97B5CBC}" type="slidenum">
               <a:rPr lang="en-US"/>
-              <a:t>25</a:t>
+              <a:t>24</a:t>
             </a:fld>
             <a:endParaRPr lang="en-US"/>
           </a:p>
@@ -2146,7 +2058,7 @@
 </p:notes>
 </file>
 
-<file path=ppt/notesSlides/notesSlide26.xml><?xml version="1.0" encoding="utf-8"?>
+<file path=ppt/notesSlides/notesSlide25.xml><?xml version="1.0" encoding="utf-8"?>
 <p:notes xmlns:a="http://schemas.openxmlformats.org/drawingml/2006/main" xmlns:r="http://schemas.openxmlformats.org/officeDocument/2006/relationships" xmlns:p="http://schemas.openxmlformats.org/presentationml/2006/main">
   <p:cSld>
     <p:spTree>
@@ -2221,7 +2133,7 @@
           <a:p>
             <a:fld id="{F7021451-1387-4CA6-816F-3879F97B5CBC}" type="slidenum">
               <a:rPr lang="en-US"/>
-              <a:t>26</a:t>
+              <a:t>25</a:t>
             </a:fld>
             <a:endParaRPr lang="en-US"/>
           </a:p>
@@ -2240,7 +2152,7 @@
 </p:notes>
 </file>
 
-<file path=ppt/notesSlides/notesSlide27.xml><?xml version="1.0" encoding="utf-8"?>
+<file path=ppt/notesSlides/notesSlide26.xml><?xml version="1.0" encoding="utf-8"?>
 <p:notes xmlns:a="http://schemas.openxmlformats.org/drawingml/2006/main" xmlns:r="http://schemas.openxmlformats.org/officeDocument/2006/relationships" xmlns:p="http://schemas.openxmlformats.org/presentationml/2006/main">
   <p:cSld>
     <p:spTree>
@@ -2311,7 +2223,7 @@
           <a:p>
             <a:fld id="{F7021451-1387-4CA6-816F-3879F97B5CBC}" type="slidenum">
               <a:rPr lang="en-US"/>
-              <a:t>27</a:t>
+              <a:t>26</a:t>
             </a:fld>
             <a:endParaRPr lang="en-US"/>
           </a:p>
@@ -2330,7 +2242,7 @@
 </p:notes>
 </file>
 
-<file path=ppt/notesSlides/notesSlide28.xml><?xml version="1.0" encoding="utf-8"?>
+<file path=ppt/notesSlides/notesSlide27.xml><?xml version="1.0" encoding="utf-8"?>
 <p:notes xmlns:a="http://schemas.openxmlformats.org/drawingml/2006/main" xmlns:r="http://schemas.openxmlformats.org/officeDocument/2006/relationships" xmlns:p="http://schemas.openxmlformats.org/presentationml/2006/main">
   <p:cSld>
     <p:spTree>
@@ -2406,7 +2318,7 @@
           <a:p>
             <a:fld id="{F7021451-1387-4CA6-816F-3879F97B5CBC}" type="slidenum">
               <a:rPr lang="en-US"/>
-              <a:t>28</a:t>
+              <a:t>27</a:t>
             </a:fld>
             <a:endParaRPr lang="en-US"/>
           </a:p>
@@ -2425,7 +2337,7 @@
 </p:notes>
 </file>
 
-<file path=ppt/notesSlides/notesSlide29.xml><?xml version="1.0" encoding="utf-8"?>
+<file path=ppt/notesSlides/notesSlide28.xml><?xml version="1.0" encoding="utf-8"?>
 <p:notes xmlns:a="http://schemas.openxmlformats.org/drawingml/2006/main" xmlns:r="http://schemas.openxmlformats.org/officeDocument/2006/relationships" xmlns:p="http://schemas.openxmlformats.org/presentationml/2006/main">
   <p:cSld>
     <p:spTree>
@@ -2475,6 +2387,94 @@
 back through it themselves.
 This is the point where you say plainly that nothing is due at the end of
 today. Most of them will still expect a checkoff.</a:t>
+            </a:r>
+            <a:endParaRPr lang="en-US" dirty="0"/>
+          </a:p>
+        </p:txBody>
+      </p:sp>
+      <p:sp>
+        <p:nvSpPr>
+          <p:cNvPr id="4" name="Slide Number Placeholder 3"/>
+          <p:cNvSpPr>
+            <a:spLocks noGrp="1"/>
+          </p:cNvSpPr>
+          <p:nvPr>
+            <p:ph type="sldNum" sz="quarter" idx="10"/>
+          </p:nvPr>
+        </p:nvSpPr>
+        <p:spPr/>
+        <p:txBody>
+          <a:bodyPr/>
+          <a:lstStyle/>
+          <a:p>
+            <a:fld id="{F7021451-1387-4CA6-816F-3879F97B5CBC}" type="slidenum">
+              <a:rPr lang="en-US"/>
+              <a:t>28</a:t>
+            </a:fld>
+            <a:endParaRPr lang="en-US"/>
+          </a:p>
+        </p:txBody>
+      </p:sp>
+    </p:spTree>
+    <p:extLst>
+      <p:ext uri="{BB962C8B-B14F-4D97-AF65-F5344CB8AC3E}">
+        <p14:creationId xmlns:p14="http://schemas.microsoft.com/office/powerpoint/2010/main" val="1024086991"/>
+      </p:ext>
+    </p:extLst>
+  </p:cSld>
+  <p:clrMapOvr>
+    <a:masterClrMapping/>
+  </p:clrMapOvr>
+</p:notes>
+</file>
+
+<file path=ppt/notesSlides/notesSlide29.xml><?xml version="1.0" encoding="utf-8"?>
+<p:notes xmlns:a="http://schemas.openxmlformats.org/drawingml/2006/main" xmlns:r="http://schemas.openxmlformats.org/officeDocument/2006/relationships" xmlns:p="http://schemas.openxmlformats.org/presentationml/2006/main">
+  <p:cSld>
+    <p:spTree>
+      <p:nvGrpSpPr>
+        <p:cNvPr id="1" name=""/>
+        <p:cNvGrpSpPr/>
+        <p:nvPr/>
+      </p:nvGrpSpPr>
+      <p:grpSpPr>
+        <a:xfrm>
+          <a:off x="0" y="0"/>
+          <a:ext cx="0" cy="0"/>
+          <a:chOff x="0" y="0"/>
+          <a:chExt cx="0" cy="0"/>
+        </a:xfrm>
+      </p:grpSpPr>
+      <p:sp>
+        <p:nvSpPr>
+          <p:cNvPr id="2" name="Slide Image Placeholder 1"/>
+          <p:cNvSpPr>
+            <a:spLocks noGrp="1" noRot="1" noChangeAspect="1"/>
+          </p:cNvSpPr>
+          <p:nvPr>
+            <p:ph type="sldImg"/>
+          </p:nvPr>
+        </p:nvSpPr>
+        <p:spPr/>
+      </p:sp>
+      <p:sp>
+        <p:nvSpPr>
+          <p:cNvPr id="3" name="Notes Placeholder 2"/>
+          <p:cNvSpPr>
+            <a:spLocks noGrp="1"/>
+          </p:cNvSpPr>
+          <p:nvPr>
+            <p:ph type="body" idx="1"/>
+          </p:nvPr>
+        </p:nvSpPr>
+        <p:spPr/>
+        <p:txBody>
+          <a:bodyPr/>
+          <a:lstStyle/>
+          <a:p>
+            <a:r>
+              <a:rPr lang="en-US" dirty="0"/>
+              <a:t/>
             </a:r>
             <a:endParaRPr lang="en-US" dirty="0"/>
           </a:p>
@@ -2593,94 +2593,6 @@
             <a:fld id="{F7021451-1387-4CA6-816F-3879F97B5CBC}" type="slidenum">
               <a:rPr lang="en-US"/>
               <a:t>3</a:t>
-            </a:fld>
-            <a:endParaRPr lang="en-US"/>
-          </a:p>
-        </p:txBody>
-      </p:sp>
-    </p:spTree>
-    <p:extLst>
-      <p:ext uri="{BB962C8B-B14F-4D97-AF65-F5344CB8AC3E}">
-        <p14:creationId xmlns:p14="http://schemas.microsoft.com/office/powerpoint/2010/main" val="1024086991"/>
-      </p:ext>
-    </p:extLst>
-  </p:cSld>
-  <p:clrMapOvr>
-    <a:masterClrMapping/>
-  </p:clrMapOvr>
-</p:notes>
-</file>
-
-<file path=ppt/notesSlides/notesSlide30.xml><?xml version="1.0" encoding="utf-8"?>
-<p:notes xmlns:a="http://schemas.openxmlformats.org/drawingml/2006/main" xmlns:r="http://schemas.openxmlformats.org/officeDocument/2006/relationships" xmlns:p="http://schemas.openxmlformats.org/presentationml/2006/main">
-  <p:cSld>
-    <p:spTree>
-      <p:nvGrpSpPr>
-        <p:cNvPr id="1" name=""/>
-        <p:cNvGrpSpPr/>
-        <p:nvPr/>
-      </p:nvGrpSpPr>
-      <p:grpSpPr>
-        <a:xfrm>
-          <a:off x="0" y="0"/>
-          <a:ext cx="0" cy="0"/>
-          <a:chOff x="0" y="0"/>
-          <a:chExt cx="0" cy="0"/>
-        </a:xfrm>
-      </p:grpSpPr>
-      <p:sp>
-        <p:nvSpPr>
-          <p:cNvPr id="2" name="Slide Image Placeholder 1"/>
-          <p:cNvSpPr>
-            <a:spLocks noGrp="1" noRot="1" noChangeAspect="1"/>
-          </p:cNvSpPr>
-          <p:nvPr>
-            <p:ph type="sldImg"/>
-          </p:nvPr>
-        </p:nvSpPr>
-        <p:spPr/>
-      </p:sp>
-      <p:sp>
-        <p:nvSpPr>
-          <p:cNvPr id="3" name="Notes Placeholder 2"/>
-          <p:cNvSpPr>
-            <a:spLocks noGrp="1"/>
-          </p:cNvSpPr>
-          <p:nvPr>
-            <p:ph type="body" idx="1"/>
-          </p:nvPr>
-        </p:nvSpPr>
-        <p:spPr/>
-        <p:txBody>
-          <a:bodyPr/>
-          <a:lstStyle/>
-          <a:p>
-            <a:r>
-              <a:rPr lang="en-US" dirty="0"/>
-              <a:t/>
-            </a:r>
-            <a:endParaRPr lang="en-US" dirty="0"/>
-          </a:p>
-        </p:txBody>
-      </p:sp>
-      <p:sp>
-        <p:nvSpPr>
-          <p:cNvPr id="4" name="Slide Number Placeholder 3"/>
-          <p:cNvSpPr>
-            <a:spLocks noGrp="1"/>
-          </p:cNvSpPr>
-          <p:nvPr>
-            <p:ph type="sldNum" sz="quarter" idx="10"/>
-          </p:nvPr>
-        </p:nvSpPr>
-        <p:spPr/>
-        <p:txBody>
-          <a:bodyPr/>
-          <a:lstStyle/>
-          <a:p>
-            <a:fld id="{F7021451-1387-4CA6-816F-3879F97B5CBC}" type="slidenum">
-              <a:rPr lang="en-US"/>
-              <a:t>30</a:t>
             </a:fld>
             <a:endParaRPr lang="en-US"/>
           </a:p>
@@ -4426,45 +4338,6 @@
 <file path=ppt/slides/slide3.xml><?xml version="1.0" encoding="utf-8"?>
 <p:sld xmlns:a="http://schemas.openxmlformats.org/drawingml/2006/main" xmlns:r="http://schemas.openxmlformats.org/officeDocument/2006/relationships" xmlns:p="http://schemas.openxmlformats.org/presentationml/2006/main">
   <p:cSld name="Slide 3">
-    <p:bg>
-      <p:bgPr>
-        <a:blipFill dpi="0" rotWithShape="1">
-          <a:blip r:embed="rId1">
-            <a:lum/>
-          </a:blip>
-          <a:srcRect/>
-          <a:stretch>
-            <a:fillRect/>
-          </a:stretch>
-        </a:blipFill>
-        <a:effectLst/>
-      </p:bgPr>
-    </p:bg>
-    <p:spTree>
-      <p:nvGrpSpPr>
-        <p:cNvPr id="1" name=""/>
-        <p:cNvGrpSpPr/>
-        <p:nvPr/>
-      </p:nvGrpSpPr>
-      <p:grpSpPr>
-        <a:xfrm>
-          <a:off x="0" y="0"/>
-          <a:ext cx="0" cy="0"/>
-          <a:chOff x="0" y="0"/>
-          <a:chExt cx="0" cy="0"/>
-        </a:xfrm>
-      </p:grpSpPr>
-    </p:spTree>
-  </p:cSld>
-  <p:clrMapOvr>
-    <a:masterClrMapping/>
-  </p:clrMapOvr>
-</p:sld>
-</file>
-
-<file path=ppt/slides/slide30.xml><?xml version="1.0" encoding="utf-8"?>
-<p:sld xmlns:a="http://schemas.openxmlformats.org/drawingml/2006/main" xmlns:r="http://schemas.openxmlformats.org/officeDocument/2006/relationships" xmlns:p="http://schemas.openxmlformats.org/presentationml/2006/main">
-  <p:cSld name="Slide 30">
     <p:bg>
       <p:bgPr>
         <a:blipFill dpi="0" rotWithShape="1">

</xml_diff>

<commit_message>
Lab01: reship the deck with the 50-50 grading slides
Before: the public deck carried three grading slides on the old 40/40/20 rubric.

After: two, Specification and design at 50 and Implementation and tests at 50,
matching the packet. 28 slides, 28 PDF pages, 28 PPTX slides by
bin/build-slides --verify.

Source is eecs498-aase/aase-f26 493cad6; the rubric is
eecs498-aase/ai-assistant de20433.

Co-Authored-By: Claude Opus 5 (1M context) <noreply@anthropic.com>
Claude-Session: https://claude.ai/code/session_01AjRrVHfRTdzFsBQte5rgc3
</commit_message>
<xml_diff>
--- a/labs/Lab01/slides.pptx
+++ b/labs/Lab01/slides.pptx
@@ -33,10 +33,9 @@
     <p:sldId id="281" r:id="rId27"/>
     <p:sldId id="282" r:id="rId28"/>
     <p:sldId id="283" r:id="rId29"/>
-    <p:sldId id="284" r:id="rId30"/>
   </p:sldIdLst>
   <p:notesMasterIdLst>
-    <p:notesMasterId r:id="rId31"/>
+    <p:notesMasterId r:id="rId30"/>
   </p:notesMasterIdLst>
   <p:sldSz cx="9334500" cy="5248275"/>
   <p:notesSz cx="5248275" cy="9334500"/>
@@ -1458,7 +1457,11 @@
               <a:t>Do not read the table out. The one thing worth saying: a part they designed and
 did not implement keeps its design credit as long as it is labelled.
 Architecture credit includes explaining where tool execution, a replacement
-endpoint client and a non-terminal interface would fit, without building them.</a:t>
+endpoint client and a non-terminal interface would fit, without building them.
+The last two rows are read from git history rather than from a document. Specs
+before code is scored on commit order, and what changed and why is the
+reconciliation between the design they started with and the system they
+finished. A design that worked does not need an invented failure.</a:t>
             </a:r>
             <a:endParaRPr lang="en-US" dirty="0"/>
           </a:p>
@@ -1641,17 +1644,22 @@
           <a:p>
             <a:r>
               <a:rPr lang="en-US" dirty="0"/>
-              <a:t>Half credit exists for behavior that partly works, so an unfinished feature is
+              <a:t>100 points across two sections of 50. These are build points, not course-grade
+percentages: the build is 4.5% of the course.
+Functional correctness is the seven features, scored one row each in RUBRIC.md.
+Half credit exists for behavior that partly works, so an unfinished feature is
 not a zero.
 Test count and coverage earn nothing by themselves. A test earns credit when it
 asserts an outcome and isolates the filesystem. Weakening an assertion to turn
 the suite green is scored as what it is.
-Configuration sits inside F1's four points and is not a gate.
+Configuration sits inside F1's five points and is not a gate.
 Staff read the repository snapshot at the deadline, run their own tests, and
 work through ACCEPTANCE.md. There is no hidden suite and no requirement that is
 not in SPEC.md. Routine tests use fakes rather than a live model; live checks
 are documented separately and opt in, and an honestly reported failed live
-attempt still earns its evidence points.</a:t>
+attempt still earns its evidence points.
+Send them to RUBRIC.md rather than reading rows aloud. It names the requirement
+IDs each row scores.</a:t>
             </a:r>
             <a:endParaRPr lang="en-US" dirty="0"/>
           </a:p>
@@ -1739,11 +1747,12 @@
           <a:p>
             <a:r>
               <a:rPr lang="en-US" dirty="0"/>
-              <a:t>This is the section students lose points on by leaving it to the last evening,
-because it cannot be reconstructed afterwards.
-A design that worked does not need an invented failure. Say what the evidence
-was. Differences between the initial and final design are worth credit when they
-are explained.</a:t>
+              <a:t>None of this can be reconstructed the night before, which is why it is worth a
+minute here. Commits and reconciliation are the last two scored rows on the
+specification slide.
+Sessions and model disclosure are required but score no points of their own.
+They are what lets staff follow the rest of the evidence, so a submission
+without them loses credit wherever a claim cannot be checked.</a:t>
             </a:r>
             <a:endParaRPr lang="en-US" dirty="0"/>
           </a:p>
@@ -1786,97 +1795,6 @@
 </file>
 
 <file path=ppt/notesSlides/notesSlide22.xml><?xml version="1.0" encoding="utf-8"?>
-<p:notes xmlns:a="http://schemas.openxmlformats.org/drawingml/2006/main" xmlns:r="http://schemas.openxmlformats.org/officeDocument/2006/relationships" xmlns:p="http://schemas.openxmlformats.org/presentationml/2006/main">
-  <p:cSld>
-    <p:spTree>
-      <p:nvGrpSpPr>
-        <p:cNvPr id="1" name=""/>
-        <p:cNvGrpSpPr/>
-        <p:nvPr/>
-      </p:nvGrpSpPr>
-      <p:grpSpPr>
-        <a:xfrm>
-          <a:off x="0" y="0"/>
-          <a:ext cx="0" cy="0"/>
-          <a:chOff x="0" y="0"/>
-          <a:chExt cx="0" cy="0"/>
-        </a:xfrm>
-      </p:grpSpPr>
-      <p:sp>
-        <p:nvSpPr>
-          <p:cNvPr id="2" name="Slide Image Placeholder 1"/>
-          <p:cNvSpPr>
-            <a:spLocks noGrp="1" noRot="1" noChangeAspect="1"/>
-          </p:cNvSpPr>
-          <p:nvPr>
-            <p:ph type="sldImg"/>
-          </p:nvPr>
-        </p:nvSpPr>
-        <p:spPr/>
-      </p:sp>
-      <p:sp>
-        <p:nvSpPr>
-          <p:cNvPr id="3" name="Notes Placeholder 2"/>
-          <p:cNvSpPr>
-            <a:spLocks noGrp="1"/>
-          </p:cNvSpPr>
-          <p:nvPr>
-            <p:ph type="body" idx="1"/>
-          </p:nvPr>
-        </p:nvSpPr>
-        <p:spPr/>
-        <p:txBody>
-          <a:bodyPr/>
-          <a:lstStyle/>
-          <a:p>
-            <a:r>
-              <a:rPr lang="en-US" dirty="0"/>
-              <a:t>100 points in total across the three sections. These are build points, not
-course-grade percentages: the build is 4.5% of the course.
-Send them to RUBRIC.md rather than reading rows aloud. It names the requirement
-IDs each row scores.</a:t>
-            </a:r>
-            <a:endParaRPr lang="en-US" dirty="0"/>
-          </a:p>
-        </p:txBody>
-      </p:sp>
-      <p:sp>
-        <p:nvSpPr>
-          <p:cNvPr id="4" name="Slide Number Placeholder 3"/>
-          <p:cNvSpPr>
-            <a:spLocks noGrp="1"/>
-          </p:cNvSpPr>
-          <p:nvPr>
-            <p:ph type="sldNum" sz="quarter" idx="10"/>
-          </p:nvPr>
-        </p:nvSpPr>
-        <p:spPr/>
-        <p:txBody>
-          <a:bodyPr/>
-          <a:lstStyle/>
-          <a:p>
-            <a:fld id="{F7021451-1387-4CA6-816F-3879F97B5CBC}" type="slidenum">
-              <a:rPr lang="en-US"/>
-              <a:t>22</a:t>
-            </a:fld>
-            <a:endParaRPr lang="en-US"/>
-          </a:p>
-        </p:txBody>
-      </p:sp>
-    </p:spTree>
-    <p:extLst>
-      <p:ext uri="{BB962C8B-B14F-4D97-AF65-F5344CB8AC3E}">
-        <p14:creationId xmlns:p14="http://schemas.microsoft.com/office/powerpoint/2010/main" val="1024086991"/>
-      </p:ext>
-    </p:extLst>
-  </p:cSld>
-  <p:clrMapOvr>
-    <a:masterClrMapping/>
-  </p:clrMapOvr>
-</p:notes>
-</file>
-
-<file path=ppt/notesSlides/notesSlide23.xml><?xml version="1.0" encoding="utf-8"?>
 <p:notes xmlns:a="http://schemas.openxmlformats.org/drawingml/2006/main" xmlns:r="http://schemas.openxmlformats.org/officeDocument/2006/relationships" xmlns:p="http://schemas.openxmlformats.org/presentationml/2006/main">
   <p:cSld>
     <p:spTree>
@@ -1949,7 +1867,7 @@
           <a:p>
             <a:fld id="{F7021451-1387-4CA6-816F-3879F97B5CBC}" type="slidenum">
               <a:rPr lang="en-US"/>
-              <a:t>23</a:t>
+              <a:t>22</a:t>
             </a:fld>
             <a:endParaRPr lang="en-US"/>
           </a:p>
@@ -1968,7 +1886,7 @@
 </p:notes>
 </file>
 
-<file path=ppt/notesSlides/notesSlide24.xml><?xml version="1.0" encoding="utf-8"?>
+<file path=ppt/notesSlides/notesSlide23.xml><?xml version="1.0" encoding="utf-8"?>
 <p:notes xmlns:a="http://schemas.openxmlformats.org/drawingml/2006/main" xmlns:r="http://schemas.openxmlformats.org/officeDocument/2006/relationships" xmlns:p="http://schemas.openxmlformats.org/presentationml/2006/main">
   <p:cSld>
     <p:spTree>
@@ -2039,7 +1957,7 @@
           <a:p>
             <a:fld id="{F7021451-1387-4CA6-816F-3879F97B5CBC}" type="slidenum">
               <a:rPr lang="en-US"/>
-              <a:t>24</a:t>
+              <a:t>23</a:t>
             </a:fld>
             <a:endParaRPr lang="en-US"/>
           </a:p>
@@ -2058,7 +1976,7 @@
 </p:notes>
 </file>
 
-<file path=ppt/notesSlides/notesSlide25.xml><?xml version="1.0" encoding="utf-8"?>
+<file path=ppt/notesSlides/notesSlide24.xml><?xml version="1.0" encoding="utf-8"?>
 <p:notes xmlns:a="http://schemas.openxmlformats.org/drawingml/2006/main" xmlns:r="http://schemas.openxmlformats.org/officeDocument/2006/relationships" xmlns:p="http://schemas.openxmlformats.org/presentationml/2006/main">
   <p:cSld>
     <p:spTree>
@@ -2133,7 +2051,7 @@
           <a:p>
             <a:fld id="{F7021451-1387-4CA6-816F-3879F97B5CBC}" type="slidenum">
               <a:rPr lang="en-US"/>
-              <a:t>25</a:t>
+              <a:t>24</a:t>
             </a:fld>
             <a:endParaRPr lang="en-US"/>
           </a:p>
@@ -2152,7 +2070,7 @@
 </p:notes>
 </file>
 
-<file path=ppt/notesSlides/notesSlide26.xml><?xml version="1.0" encoding="utf-8"?>
+<file path=ppt/notesSlides/notesSlide25.xml><?xml version="1.0" encoding="utf-8"?>
 <p:notes xmlns:a="http://schemas.openxmlformats.org/drawingml/2006/main" xmlns:r="http://schemas.openxmlformats.org/officeDocument/2006/relationships" xmlns:p="http://schemas.openxmlformats.org/presentationml/2006/main">
   <p:cSld>
     <p:spTree>
@@ -2223,7 +2141,7 @@
           <a:p>
             <a:fld id="{F7021451-1387-4CA6-816F-3879F97B5CBC}" type="slidenum">
               <a:rPr lang="en-US"/>
-              <a:t>26</a:t>
+              <a:t>25</a:t>
             </a:fld>
             <a:endParaRPr lang="en-US"/>
           </a:p>
@@ -2242,7 +2160,7 @@
 </p:notes>
 </file>
 
-<file path=ppt/notesSlides/notesSlide27.xml><?xml version="1.0" encoding="utf-8"?>
+<file path=ppt/notesSlides/notesSlide26.xml><?xml version="1.0" encoding="utf-8"?>
 <p:notes xmlns:a="http://schemas.openxmlformats.org/drawingml/2006/main" xmlns:r="http://schemas.openxmlformats.org/officeDocument/2006/relationships" xmlns:p="http://schemas.openxmlformats.org/presentationml/2006/main">
   <p:cSld>
     <p:spTree>
@@ -2318,7 +2236,7 @@
           <a:p>
             <a:fld id="{F7021451-1387-4CA6-816F-3879F97B5CBC}" type="slidenum">
               <a:rPr lang="en-US"/>
-              <a:t>27</a:t>
+              <a:t>26</a:t>
             </a:fld>
             <a:endParaRPr lang="en-US"/>
           </a:p>
@@ -2337,7 +2255,7 @@
 </p:notes>
 </file>
 
-<file path=ppt/notesSlides/notesSlide28.xml><?xml version="1.0" encoding="utf-8"?>
+<file path=ppt/notesSlides/notesSlide27.xml><?xml version="1.0" encoding="utf-8"?>
 <p:notes xmlns:a="http://schemas.openxmlformats.org/drawingml/2006/main" xmlns:r="http://schemas.openxmlformats.org/officeDocument/2006/relationships" xmlns:p="http://schemas.openxmlformats.org/presentationml/2006/main">
   <p:cSld>
     <p:spTree>
@@ -2409,7 +2327,7 @@
           <a:p>
             <a:fld id="{F7021451-1387-4CA6-816F-3879F97B5CBC}" type="slidenum">
               <a:rPr lang="en-US"/>
-              <a:t>28</a:t>
+              <a:t>27</a:t>
             </a:fld>
             <a:endParaRPr lang="en-US"/>
           </a:p>
@@ -2428,7 +2346,7 @@
 </p:notes>
 </file>
 
-<file path=ppt/notesSlides/notesSlide29.xml><?xml version="1.0" encoding="utf-8"?>
+<file path=ppt/notesSlides/notesSlide28.xml><?xml version="1.0" encoding="utf-8"?>
 <p:notes xmlns:a="http://schemas.openxmlformats.org/drawingml/2006/main" xmlns:r="http://schemas.openxmlformats.org/officeDocument/2006/relationships" xmlns:p="http://schemas.openxmlformats.org/presentationml/2006/main">
   <p:cSld>
     <p:spTree>
@@ -2497,7 +2415,7 @@
           <a:p>
             <a:fld id="{F7021451-1387-4CA6-816F-3879F97B5CBC}" type="slidenum">
               <a:rPr lang="en-US"/>
-              <a:t>29</a:t>
+              <a:t>28</a:t>
             </a:fld>
             <a:endParaRPr lang="en-US"/>
           </a:p>
@@ -4260,45 +4178,6 @@
 <file path=ppt/slides/slide28.xml><?xml version="1.0" encoding="utf-8"?>
 <p:sld xmlns:a="http://schemas.openxmlformats.org/drawingml/2006/main" xmlns:r="http://schemas.openxmlformats.org/officeDocument/2006/relationships" xmlns:p="http://schemas.openxmlformats.org/presentationml/2006/main">
   <p:cSld name="Slide 28">
-    <p:bg>
-      <p:bgPr>
-        <a:blipFill dpi="0" rotWithShape="1">
-          <a:blip r:embed="rId1">
-            <a:lum/>
-          </a:blip>
-          <a:srcRect/>
-          <a:stretch>
-            <a:fillRect/>
-          </a:stretch>
-        </a:blipFill>
-        <a:effectLst/>
-      </p:bgPr>
-    </p:bg>
-    <p:spTree>
-      <p:nvGrpSpPr>
-        <p:cNvPr id="1" name=""/>
-        <p:cNvGrpSpPr/>
-        <p:nvPr/>
-      </p:nvGrpSpPr>
-      <p:grpSpPr>
-        <a:xfrm>
-          <a:off x="0" y="0"/>
-          <a:ext cx="0" cy="0"/>
-          <a:chOff x="0" y="0"/>
-          <a:chExt cx="0" cy="0"/>
-        </a:xfrm>
-      </p:grpSpPr>
-    </p:spTree>
-  </p:cSld>
-  <p:clrMapOvr>
-    <a:masterClrMapping/>
-  </p:clrMapOvr>
-</p:sld>
-</file>
-
-<file path=ppt/slides/slide29.xml><?xml version="1.0" encoding="utf-8"?>
-<p:sld xmlns:a="http://schemas.openxmlformats.org/drawingml/2006/main" xmlns:r="http://schemas.openxmlformats.org/officeDocument/2006/relationships" xmlns:p="http://schemas.openxmlformats.org/presentationml/2006/main">
-  <p:cSld name="Slide 29">
     <p:bg>
       <p:bgPr>
         <a:blipFill dpi="0" rotWithShape="1">

</xml_diff>

<commit_message>
Lab01: reship the deck with the 50-50 grading slides (#3)
Before: the public deck carried three grading slides on the old 40/40/20 rubric.

After: two, Specification and design at 50 and Implementation and tests at 50,
matching the packet. 28 slides, 28 PDF pages, 28 PPTX slides by
bin/build-slides --verify.

Source is eecs498-aase/aase-f26 493cad6; the rubric is
eecs498-aase/ai-assistant de20433.


Claude-Session: https://claude.ai/code/session_01AjRrVHfRTdzFsBQte5rgc3

Co-authored-by: Claude <noreply@anthropic.com>
</commit_message>
<xml_diff>
--- a/labs/Lab01/slides.pptx
+++ b/labs/Lab01/slides.pptx
@@ -33,10 +33,9 @@
     <p:sldId id="281" r:id="rId27"/>
     <p:sldId id="282" r:id="rId28"/>
     <p:sldId id="283" r:id="rId29"/>
-    <p:sldId id="284" r:id="rId30"/>
   </p:sldIdLst>
   <p:notesMasterIdLst>
-    <p:notesMasterId r:id="rId31"/>
+    <p:notesMasterId r:id="rId30"/>
   </p:notesMasterIdLst>
   <p:sldSz cx="9334500" cy="5248275"/>
   <p:notesSz cx="5248275" cy="9334500"/>
@@ -1458,7 +1457,11 @@
               <a:t>Do not read the table out. The one thing worth saying: a part they designed and
 did not implement keeps its design credit as long as it is labelled.
 Architecture credit includes explaining where tool execution, a replacement
-endpoint client and a non-terminal interface would fit, without building them.</a:t>
+endpoint client and a non-terminal interface would fit, without building them.
+The last two rows are read from git history rather than from a document. Specs
+before code is scored on commit order, and what changed and why is the
+reconciliation between the design they started with and the system they
+finished. A design that worked does not need an invented failure.</a:t>
             </a:r>
             <a:endParaRPr lang="en-US" dirty="0"/>
           </a:p>
@@ -1641,17 +1644,22 @@
           <a:p>
             <a:r>
               <a:rPr lang="en-US" dirty="0"/>
-              <a:t>Half credit exists for behavior that partly works, so an unfinished feature is
+              <a:t>100 points across two sections of 50. These are build points, not course-grade
+percentages: the build is 4.5% of the course.
+Functional correctness is the seven features, scored one row each in RUBRIC.md.
+Half credit exists for behavior that partly works, so an unfinished feature is
 not a zero.
 Test count and coverage earn nothing by themselves. A test earns credit when it
 asserts an outcome and isolates the filesystem. Weakening an assertion to turn
 the suite green is scored as what it is.
-Configuration sits inside F1's four points and is not a gate.
+Configuration sits inside F1's five points and is not a gate.
 Staff read the repository snapshot at the deadline, run their own tests, and
 work through ACCEPTANCE.md. There is no hidden suite and no requirement that is
 not in SPEC.md. Routine tests use fakes rather than a live model; live checks
 are documented separately and opt in, and an honestly reported failed live
-attempt still earns its evidence points.</a:t>
+attempt still earns its evidence points.
+Send them to RUBRIC.md rather than reading rows aloud. It names the requirement
+IDs each row scores.</a:t>
             </a:r>
             <a:endParaRPr lang="en-US" dirty="0"/>
           </a:p>
@@ -1739,11 +1747,12 @@
           <a:p>
             <a:r>
               <a:rPr lang="en-US" dirty="0"/>
-              <a:t>This is the section students lose points on by leaving it to the last evening,
-because it cannot be reconstructed afterwards.
-A design that worked does not need an invented failure. Say what the evidence
-was. Differences between the initial and final design are worth credit when they
-are explained.</a:t>
+              <a:t>None of this can be reconstructed the night before, which is why it is worth a
+minute here. Commits and reconciliation are the last two scored rows on the
+specification slide.
+Sessions and model disclosure are required but score no points of their own.
+They are what lets staff follow the rest of the evidence, so a submission
+without them loses credit wherever a claim cannot be checked.</a:t>
             </a:r>
             <a:endParaRPr lang="en-US" dirty="0"/>
           </a:p>
@@ -1786,97 +1795,6 @@
 </file>
 
 <file path=ppt/notesSlides/notesSlide22.xml><?xml version="1.0" encoding="utf-8"?>
-<p:notes xmlns:a="http://schemas.openxmlformats.org/drawingml/2006/main" xmlns:r="http://schemas.openxmlformats.org/officeDocument/2006/relationships" xmlns:p="http://schemas.openxmlformats.org/presentationml/2006/main">
-  <p:cSld>
-    <p:spTree>
-      <p:nvGrpSpPr>
-        <p:cNvPr id="1" name=""/>
-        <p:cNvGrpSpPr/>
-        <p:nvPr/>
-      </p:nvGrpSpPr>
-      <p:grpSpPr>
-        <a:xfrm>
-          <a:off x="0" y="0"/>
-          <a:ext cx="0" cy="0"/>
-          <a:chOff x="0" y="0"/>
-          <a:chExt cx="0" cy="0"/>
-        </a:xfrm>
-      </p:grpSpPr>
-      <p:sp>
-        <p:nvSpPr>
-          <p:cNvPr id="2" name="Slide Image Placeholder 1"/>
-          <p:cNvSpPr>
-            <a:spLocks noGrp="1" noRot="1" noChangeAspect="1"/>
-          </p:cNvSpPr>
-          <p:nvPr>
-            <p:ph type="sldImg"/>
-          </p:nvPr>
-        </p:nvSpPr>
-        <p:spPr/>
-      </p:sp>
-      <p:sp>
-        <p:nvSpPr>
-          <p:cNvPr id="3" name="Notes Placeholder 2"/>
-          <p:cNvSpPr>
-            <a:spLocks noGrp="1"/>
-          </p:cNvSpPr>
-          <p:nvPr>
-            <p:ph type="body" idx="1"/>
-          </p:nvPr>
-        </p:nvSpPr>
-        <p:spPr/>
-        <p:txBody>
-          <a:bodyPr/>
-          <a:lstStyle/>
-          <a:p>
-            <a:r>
-              <a:rPr lang="en-US" dirty="0"/>
-              <a:t>100 points in total across the three sections. These are build points, not
-course-grade percentages: the build is 4.5% of the course.
-Send them to RUBRIC.md rather than reading rows aloud. It names the requirement
-IDs each row scores.</a:t>
-            </a:r>
-            <a:endParaRPr lang="en-US" dirty="0"/>
-          </a:p>
-        </p:txBody>
-      </p:sp>
-      <p:sp>
-        <p:nvSpPr>
-          <p:cNvPr id="4" name="Slide Number Placeholder 3"/>
-          <p:cNvSpPr>
-            <a:spLocks noGrp="1"/>
-          </p:cNvSpPr>
-          <p:nvPr>
-            <p:ph type="sldNum" sz="quarter" idx="10"/>
-          </p:nvPr>
-        </p:nvSpPr>
-        <p:spPr/>
-        <p:txBody>
-          <a:bodyPr/>
-          <a:lstStyle/>
-          <a:p>
-            <a:fld id="{F7021451-1387-4CA6-816F-3879F97B5CBC}" type="slidenum">
-              <a:rPr lang="en-US"/>
-              <a:t>22</a:t>
-            </a:fld>
-            <a:endParaRPr lang="en-US"/>
-          </a:p>
-        </p:txBody>
-      </p:sp>
-    </p:spTree>
-    <p:extLst>
-      <p:ext uri="{BB962C8B-B14F-4D97-AF65-F5344CB8AC3E}">
-        <p14:creationId xmlns:p14="http://schemas.microsoft.com/office/powerpoint/2010/main" val="1024086991"/>
-      </p:ext>
-    </p:extLst>
-  </p:cSld>
-  <p:clrMapOvr>
-    <a:masterClrMapping/>
-  </p:clrMapOvr>
-</p:notes>
-</file>
-
-<file path=ppt/notesSlides/notesSlide23.xml><?xml version="1.0" encoding="utf-8"?>
 <p:notes xmlns:a="http://schemas.openxmlformats.org/drawingml/2006/main" xmlns:r="http://schemas.openxmlformats.org/officeDocument/2006/relationships" xmlns:p="http://schemas.openxmlformats.org/presentationml/2006/main">
   <p:cSld>
     <p:spTree>
@@ -1949,7 +1867,7 @@
           <a:p>
             <a:fld id="{F7021451-1387-4CA6-816F-3879F97B5CBC}" type="slidenum">
               <a:rPr lang="en-US"/>
-              <a:t>23</a:t>
+              <a:t>22</a:t>
             </a:fld>
             <a:endParaRPr lang="en-US"/>
           </a:p>
@@ -1968,7 +1886,7 @@
 </p:notes>
 </file>
 
-<file path=ppt/notesSlides/notesSlide24.xml><?xml version="1.0" encoding="utf-8"?>
+<file path=ppt/notesSlides/notesSlide23.xml><?xml version="1.0" encoding="utf-8"?>
 <p:notes xmlns:a="http://schemas.openxmlformats.org/drawingml/2006/main" xmlns:r="http://schemas.openxmlformats.org/officeDocument/2006/relationships" xmlns:p="http://schemas.openxmlformats.org/presentationml/2006/main">
   <p:cSld>
     <p:spTree>
@@ -2039,7 +1957,7 @@
           <a:p>
             <a:fld id="{F7021451-1387-4CA6-816F-3879F97B5CBC}" type="slidenum">
               <a:rPr lang="en-US"/>
-              <a:t>24</a:t>
+              <a:t>23</a:t>
             </a:fld>
             <a:endParaRPr lang="en-US"/>
           </a:p>
@@ -2058,7 +1976,7 @@
 </p:notes>
 </file>
 
-<file path=ppt/notesSlides/notesSlide25.xml><?xml version="1.0" encoding="utf-8"?>
+<file path=ppt/notesSlides/notesSlide24.xml><?xml version="1.0" encoding="utf-8"?>
 <p:notes xmlns:a="http://schemas.openxmlformats.org/drawingml/2006/main" xmlns:r="http://schemas.openxmlformats.org/officeDocument/2006/relationships" xmlns:p="http://schemas.openxmlformats.org/presentationml/2006/main">
   <p:cSld>
     <p:spTree>
@@ -2133,7 +2051,7 @@
           <a:p>
             <a:fld id="{F7021451-1387-4CA6-816F-3879F97B5CBC}" type="slidenum">
               <a:rPr lang="en-US"/>
-              <a:t>25</a:t>
+              <a:t>24</a:t>
             </a:fld>
             <a:endParaRPr lang="en-US"/>
           </a:p>
@@ -2152,7 +2070,7 @@
 </p:notes>
 </file>
 
-<file path=ppt/notesSlides/notesSlide26.xml><?xml version="1.0" encoding="utf-8"?>
+<file path=ppt/notesSlides/notesSlide25.xml><?xml version="1.0" encoding="utf-8"?>
 <p:notes xmlns:a="http://schemas.openxmlformats.org/drawingml/2006/main" xmlns:r="http://schemas.openxmlformats.org/officeDocument/2006/relationships" xmlns:p="http://schemas.openxmlformats.org/presentationml/2006/main">
   <p:cSld>
     <p:spTree>
@@ -2223,7 +2141,7 @@
           <a:p>
             <a:fld id="{F7021451-1387-4CA6-816F-3879F97B5CBC}" type="slidenum">
               <a:rPr lang="en-US"/>
-              <a:t>26</a:t>
+              <a:t>25</a:t>
             </a:fld>
             <a:endParaRPr lang="en-US"/>
           </a:p>
@@ -2242,7 +2160,7 @@
 </p:notes>
 </file>
 
-<file path=ppt/notesSlides/notesSlide27.xml><?xml version="1.0" encoding="utf-8"?>
+<file path=ppt/notesSlides/notesSlide26.xml><?xml version="1.0" encoding="utf-8"?>
 <p:notes xmlns:a="http://schemas.openxmlformats.org/drawingml/2006/main" xmlns:r="http://schemas.openxmlformats.org/officeDocument/2006/relationships" xmlns:p="http://schemas.openxmlformats.org/presentationml/2006/main">
   <p:cSld>
     <p:spTree>
@@ -2318,7 +2236,7 @@
           <a:p>
             <a:fld id="{F7021451-1387-4CA6-816F-3879F97B5CBC}" type="slidenum">
               <a:rPr lang="en-US"/>
-              <a:t>27</a:t>
+              <a:t>26</a:t>
             </a:fld>
             <a:endParaRPr lang="en-US"/>
           </a:p>
@@ -2337,7 +2255,7 @@
 </p:notes>
 </file>
 
-<file path=ppt/notesSlides/notesSlide28.xml><?xml version="1.0" encoding="utf-8"?>
+<file path=ppt/notesSlides/notesSlide27.xml><?xml version="1.0" encoding="utf-8"?>
 <p:notes xmlns:a="http://schemas.openxmlformats.org/drawingml/2006/main" xmlns:r="http://schemas.openxmlformats.org/officeDocument/2006/relationships" xmlns:p="http://schemas.openxmlformats.org/presentationml/2006/main">
   <p:cSld>
     <p:spTree>
@@ -2409,7 +2327,7 @@
           <a:p>
             <a:fld id="{F7021451-1387-4CA6-816F-3879F97B5CBC}" type="slidenum">
               <a:rPr lang="en-US"/>
-              <a:t>28</a:t>
+              <a:t>27</a:t>
             </a:fld>
             <a:endParaRPr lang="en-US"/>
           </a:p>
@@ -2428,7 +2346,7 @@
 </p:notes>
 </file>
 
-<file path=ppt/notesSlides/notesSlide29.xml><?xml version="1.0" encoding="utf-8"?>
+<file path=ppt/notesSlides/notesSlide28.xml><?xml version="1.0" encoding="utf-8"?>
 <p:notes xmlns:a="http://schemas.openxmlformats.org/drawingml/2006/main" xmlns:r="http://schemas.openxmlformats.org/officeDocument/2006/relationships" xmlns:p="http://schemas.openxmlformats.org/presentationml/2006/main">
   <p:cSld>
     <p:spTree>
@@ -2497,7 +2415,7 @@
           <a:p>
             <a:fld id="{F7021451-1387-4CA6-816F-3879F97B5CBC}" type="slidenum">
               <a:rPr lang="en-US"/>
-              <a:t>29</a:t>
+              <a:t>28</a:t>
             </a:fld>
             <a:endParaRPr lang="en-US"/>
           </a:p>
@@ -4260,45 +4178,6 @@
 <file path=ppt/slides/slide28.xml><?xml version="1.0" encoding="utf-8"?>
 <p:sld xmlns:a="http://schemas.openxmlformats.org/drawingml/2006/main" xmlns:r="http://schemas.openxmlformats.org/officeDocument/2006/relationships" xmlns:p="http://schemas.openxmlformats.org/presentationml/2006/main">
   <p:cSld name="Slide 28">
-    <p:bg>
-      <p:bgPr>
-        <a:blipFill dpi="0" rotWithShape="1">
-          <a:blip r:embed="rId1">
-            <a:lum/>
-          </a:blip>
-          <a:srcRect/>
-          <a:stretch>
-            <a:fillRect/>
-          </a:stretch>
-        </a:blipFill>
-        <a:effectLst/>
-      </p:bgPr>
-    </p:bg>
-    <p:spTree>
-      <p:nvGrpSpPr>
-        <p:cNvPr id="1" name=""/>
-        <p:cNvGrpSpPr/>
-        <p:nvPr/>
-      </p:nvGrpSpPr>
-      <p:grpSpPr>
-        <a:xfrm>
-          <a:off x="0" y="0"/>
-          <a:ext cx="0" cy="0"/>
-          <a:chOff x="0" y="0"/>
-          <a:chExt cx="0" cy="0"/>
-        </a:xfrm>
-      </p:grpSpPr>
-    </p:spTree>
-  </p:cSld>
-  <p:clrMapOvr>
-    <a:masterClrMapping/>
-  </p:clrMapOvr>
-</p:sld>
-</file>
-
-<file path=ppt/slides/slide29.xml><?xml version="1.0" encoding="utf-8"?>
-<p:sld xmlns:a="http://schemas.openxmlformats.org/drawingml/2006/main" xmlns:r="http://schemas.openxmlformats.org/officeDocument/2006/relationships" xmlns:p="http://schemas.openxmlformats.org/presentationml/2006/main">
-  <p:cSld name="Slide 29">
     <p:bg>
       <p:bgPr>
         <a:blipFill dpi="0" rotWithShape="1">

</xml_diff>

<commit_message>
Reship Lab01 and Lab02 with the October 6 deadline
Lab01 also moves the build deadline off the Hackathon 1 slide, which now
carries only its own date, onto the project slide.

Co-Authored-By: Claude Opus 5 (1M context) <noreply@anthropic.com>
Claude-Session: https://claude.ai/code/session_01W93UZep7mkyr672vwh5gYS
</commit_message>
<xml_diff>
--- a/labs/Lab01/slides.pptx
+++ b/labs/Lab01/slides.pptx
@@ -993,8 +993,8 @@
 announced by staff. Do not invent any of them here.
 Say the accommodations line out loud: conflicts and accommodations go to staff
 now, not the week of.
-The caption is the only place in the deck a student sees the build deadline, now
-that the after-lab slide is gone. Do not skip past it.</a:t>
+This slide carries the hackathon date and nothing else. The build deadline is on
+the project slide, which is the only place a student should look for it.</a:t>
             </a:r>
             <a:endParaRPr lang="en-US" dirty="0"/>
           </a:p>
@@ -1179,7 +1179,9 @@
 It is not a clone of Aider and it does not need to be. No repo map, no lint
 loop, no architect mode. What it must have is the spine they just watched.
 If somebody asks how big it is: smaller than they fear, and the specification
-work is the part that decides how long it takes.</a:t>
+work is the part that decides how long it takes.
+The date under the caption is the only place in the deck a student sees the
+build deadline. Say it out loud rather than skipping past it.</a:t>
             </a:r>
             <a:endParaRPr lang="en-US" dirty="0"/>
           </a:p>

</xml_diff>

<commit_message>
Reship Lab01 and Lab02 with the October 6 deadline (#7)
Lab01 also moves the build deadline off the Hackathon 1 slide, which now
carries only its own date, onto the project slide.


Claude-Session: https://claude.ai/code/session_01W93UZep7mkyr672vwh5gYS

Co-authored-by: Claude <noreply@anthropic.com>
</commit_message>
<xml_diff>
--- a/labs/Lab01/slides.pptx
+++ b/labs/Lab01/slides.pptx
@@ -993,8 +993,8 @@
 announced by staff. Do not invent any of them here.
 Say the accommodations line out loud: conflicts and accommodations go to staff
 now, not the week of.
-The caption is the only place in the deck a student sees the build deadline, now
-that the after-lab slide is gone. Do not skip past it.</a:t>
+This slide carries the hackathon date and nothing else. The build deadline is on
+the project slide, which is the only place a student should look for it.</a:t>
             </a:r>
             <a:endParaRPr lang="en-US" dirty="0"/>
           </a:p>
@@ -1179,7 +1179,9 @@
 It is not a clone of Aider and it does not need to be. No repo map, no lint
 loop, no architect mode. What it must have is the spine they just watched.
 If somebody asks how big it is: smaller than they fear, and the specification
-work is the part that decides how long it takes.</a:t>
+work is the part that decides how long it takes.
+The date under the caption is the only place in the deck a student sees the
+build deadline. Say it out loud rather than skipping past it.</a:t>
             </a:r>
             <a:endParaRPr lang="en-US" dirty="0"/>
           </a:p>

</xml_diff>

<commit_message>
Lab01: republish with the reworked sections
Before: the published deck carried slides whose closing lines described
what was above them rather than saying why the slide was there, and two
sections the instructor found confusing.

After: every slide in the deep-dive material ends on its point, the
map-cost diagram is folded into the shared-budget slide, the re-send
section is three slides instead of four, the hackathon weight slide is
gone, and the closing section is a discussion ending in three open
questions.

How: reshipped from the term repo with bin/ship after the exports were
rebuilt and verified at 44/44/44. The three files match the source that
merged as aase-f26 51fadf7 (PR #13) byte for byte.

Co-Authored-By: Claude Opus 5 (1M context) <noreply@anthropic.com>
Claude-Session: https://claude.ai/code/session_01HK8wFbKHvmKPXQf2PSK8c1
</commit_message>
<xml_diff>
--- a/labs/Lab01/slides.pptx
+++ b/labs/Lab01/slides.pptx
@@ -49,11 +49,9 @@
     <p:sldId id="297" r:id="rId43"/>
     <p:sldId id="298" r:id="rId44"/>
     <p:sldId id="299" r:id="rId45"/>
-    <p:sldId id="300" r:id="rId46"/>
-    <p:sldId id="301" r:id="rId47"/>
   </p:sldIdLst>
   <p:notesMasterIdLst>
-    <p:notesMasterId r:id="rId48"/>
+    <p:notesMasterId r:id="rId46"/>
   </p:notesMasterIdLst>
   <p:sldSz cx="9334500" cy="5248275"/>
   <p:notesSz cx="5248275" cy="9334500"/>
@@ -1109,12 +1107,21 @@
           <a:p>
             <a:r>
               <a:rPr lang="en-US" dirty="0"/>
-              <a:t>Off the slide: on a small model the map often costs more than the files it was
-guessing about.
-This is why aider-practice turns it down. On a 4B with a small window the map
-can eat a third of the budget to describe files the model then cannot see the
-insides of anyway.
-It is out of scope for the build. Say so here, so nobody spends week 4 on it.</a:t>
+              <a:t>This slide now carries what the separate map-cost slide used to say, because two
+diagrams of the same budget read as two unrelated facts (instructor note
+2026-09-13).
+Walk the two bars. Nothing about the early turn is wrong; the later turn is the
+same prompt after the history has grown, and the thing that stops fitting is
+their own message. Everything above it was spent before they typed.
+The bold line is the map's part in that. It is charged to the same budget as the
+files it was guessing about, which on a 4B can be a third of the window spent
+describing files the model then cannot see inside. That is why aider-practice
+turns it down, and it is why the map is out of scope for the build. Say so, so
+nobody spends week 4 on it.
+Ask what they would drop first and what has to survive. Their Stage 1 contract
+keeps the system instructions, the current request and the added file contents,
+and refuses an oversized required input instead of silently trimming it. That
+refusal is a design decision they have to write down and test.</a:t>
             </a:r>
             <a:endParaRPr lang="en-US" dirty="0"/>
           </a:p>
@@ -1202,10 +1209,13 @@
           <a:p>
             <a:r>
               <a:rPr lang="en-US" dirty="0"/>
-              <a:t>Ask what they would drop first and what has to survive. Their Stage 1 contract
-keeps the system instructions, the current request and the added file contents,
-and refuses an oversized required input instead of silently trimming it. That
-refusal is a design decision they have to write down and test.</a:t>
+              <a:t>Reworked 2026-09-13: the old version of this section had four slides and two of
+them showed the same seven-part list in different groupings, which is what made
+it read as confusing. It is three slides now and they argue in a line: here is
+the order, here is why the order was chosen, here is what ruins it.
+The one sentence to open with, because everything here follows from it: the
+model keeps nothing between turns. Turn twelve sends everything turn one sent,
+plus more. Every design decision in this section exists because of that.</a:t>
             </a:r>
             <a:endParaRPr lang="en-US" dirty="0"/>
           </a:p>
@@ -1293,10 +1303,14 @@
           <a:p>
             <a:r>
               <a:rPr lang="en-US" dirty="0"/>
-              <a:t>This block is new and it is the one they will not have met anywhere. It pays off
-the budget slide: having decided what to send, the harness now has to send it
-every single turn, because the model remembers nothing.
-Keep it on the mechanism. Nobody needs Aider's flag names.</a:t>
+              <a:t>Three groups rather than a numbered list of seven, because the grouping is the
+point and the exact ordinal of each part is not.
+Do not explain why yet. Put it up, say that the order is deliberate and looks
+strange, and let the next slide pay it off. If someone guesses the reason before
+you get there, that is the best outcome available.
+Their build assembles this same thing, and the packet asks them to say what goes
+in it and in what order. This slide is the argument that the answer is a design
+decision rather than a detail.</a:t>
             </a:r>
             <a:endParaRPr lang="en-US" dirty="0"/>
           </a:p>
@@ -1384,13 +1398,18 @@
           <a:p>
             <a:r>
               <a:rPr lang="en-US" dirty="0"/>
-              <a:t>Seven parts, one order, and the order is not arbitrary. Walk down it once.
-The thing to land: none of this is stored anywhere on the model's side. Turn
-twelve sends all seven parts again, and turn twelve costs more than turn one for
-exactly that reason.
-Their build assembles this same thing. The packet asks them to say what is in it
-and in what order, which is a design decision rather than an implementation
-detail.</a:t>
+              <a:t>Now the previous slide makes sense. Work the two rows and then point back.
+This is not the model remembering. Nothing is remembered between sessions. It is
+the serving layer recognising text it has already processed and picking up where
+it left off, and it holds on the course endpoint as much as on a hosted API. The
+plumbing differs, a hosted API marks the points explicitly and a local server
+reuses the longest opening it recognises, and the rule is identical either way.
+Then land the bold line against the order slide: the parts that change every
+turn were put at the end so that changing them costs the least. That is a real
+design principle and it is worth more to them than the mechanism itself.
+If they want dollar figures, quote the provider's current pricing page rather
+than a number from memory. What they will feel on their own machine is the
+wait before the first token, not money.</a:t>
             </a:r>
             <a:endParaRPr lang="en-US" dirty="0"/>
           </a:p>
@@ -1478,15 +1497,20 @@
           <a:p>
             <a:r>
               <a:rPr lang="en-US" dirty="0"/>
-              <a:t>This is the single most useful idea in the block and it holds everywhere, on
-ollama and on a hosted API alike. The server keeps the computed state for a
-prefix it has seen. Send the same opening again and it picks up where it left
-off. Change one token near the front and every token after it is recomputed.
-Say plainly that this is not memory. Nothing is remembered between sessions.
-It is an optimisation on repeated text, and it is the only reason a design that
-re-sends everything every turn is affordable at all.
-Hosted APIs expose it as an explicit marker; a local server does it
-automatically over the longest prefix it recognises. Same rule either way.</a:t>
+              <a:t>Three things, all verified in the source, and the third is the one nobody
+guesses.
+Ask mode is not a smaller code mode. It is a different system prompt with the
+worked examples removed, and it sits at the very front, so flipping between ask
+and code throws the whole prefix away rather than part of it. A quick question
+mid task is not free.
+Adding a file changes the file block and the repo map, because files in the chat
+come out of the map.
+The third: by default the map is rebuilt from the filenames and identifiers
+found in the message just typed. Mention a file in passing and the map moves.
+Aider knows, which is why turning caching on quietly switches the map to a
+stabler refresh mode.
+The habit worth giving them: settle the file set before starting, and keep a
+question in its own session.</a:t>
             </a:r>
             <a:endParaRPr lang="en-US" dirty="0"/>
           </a:p>
@@ -1669,201 +1693,6 @@
           <a:p>
             <a:r>
               <a:rPr lang="en-US" dirty="0"/>
-              <a:t>All three verified against the source, and the third is the one nobody guesses.
-Ask mode is not a smaller version of code mode. It is a different system prompt
-with the worked examples removed, and it sits at the very front, so flipping
-between ask and code throws away the whole prefix and not just part of it.
-Asking a quick question mid task is not free.
-Adding a file changes the repo map as well as the file block, because files in
-the chat come out of the map.
-The third: by default the map is rebuilt from the filenames and identifiers
-found in the message just typed. Mention a file in passing, the map changes, and
-everything after it recomputes. Aider knows this, which is why turning caching
-on quietly switches the map to a stabler refresh mode.
-The habit worth giving them: settle the file set before starting, and keep a
-question in its own session.</a:t>
-            </a:r>
-            <a:endParaRPr lang="en-US" dirty="0"/>
-          </a:p>
-        </p:txBody>
-      </p:sp>
-      <p:sp>
-        <p:nvSpPr>
-          <p:cNvPr id="4" name="Slide Number Placeholder 3"/>
-          <p:cNvSpPr>
-            <a:spLocks noGrp="1"/>
-          </p:cNvSpPr>
-          <p:nvPr>
-            <p:ph type="sldNum" sz="quarter" idx="10"/>
-          </p:nvPr>
-        </p:nvSpPr>
-        <p:spPr/>
-        <p:txBody>
-          <a:bodyPr/>
-          <a:lstStyle/>
-          <a:p>
-            <a:fld id="{F7021451-1387-4CA6-816F-3879F97B5CBC}" type="slidenum">
-              <a:rPr lang="en-US"/>
-              <a:t>20</a:t>
-            </a:fld>
-            <a:endParaRPr lang="en-US"/>
-          </a:p>
-        </p:txBody>
-      </p:sp>
-    </p:spTree>
-    <p:extLst>
-      <p:ext uri="{BB962C8B-B14F-4D97-AF65-F5344CB8AC3E}">
-        <p14:creationId xmlns:p14="http://schemas.microsoft.com/office/powerpoint/2010/main" val="1024086991"/>
-      </p:ext>
-    </p:extLst>
-  </p:cSld>
-  <p:clrMapOvr>
-    <a:masterClrMapping/>
-  </p:clrMapOvr>
-</p:notes>
-</file>
-
-<file path=ppt/notesSlides/notesSlide21.xml><?xml version="1.0" encoding="utf-8"?>
-<p:notes xmlns:a="http://schemas.openxmlformats.org/drawingml/2006/main" xmlns:r="http://schemas.openxmlformats.org/officeDocument/2006/relationships" xmlns:p="http://schemas.openxmlformats.org/presentationml/2006/main">
-  <p:cSld>
-    <p:spTree>
-      <p:nvGrpSpPr>
-        <p:cNvPr id="1" name=""/>
-        <p:cNvGrpSpPr/>
-        <p:nvPr/>
-      </p:nvGrpSpPr>
-      <p:grpSpPr>
-        <a:xfrm>
-          <a:off x="0" y="0"/>
-          <a:ext cx="0" cy="0"/>
-          <a:chOff x="0" y="0"/>
-          <a:chExt cx="0" cy="0"/>
-        </a:xfrm>
-      </p:grpSpPr>
-      <p:sp>
-        <p:nvSpPr>
-          <p:cNvPr id="2" name="Slide Image Placeholder 1"/>
-          <p:cNvSpPr>
-            <a:spLocks noGrp="1" noRot="1" noChangeAspect="1"/>
-          </p:cNvSpPr>
-          <p:nvPr>
-            <p:ph type="sldImg"/>
-          </p:nvPr>
-        </p:nvSpPr>
-        <p:spPr/>
-      </p:sp>
-      <p:sp>
-        <p:nvSpPr>
-          <p:cNvPr id="3" name="Notes Placeholder 2"/>
-          <p:cNvSpPr>
-            <a:spLocks noGrp="1"/>
-          </p:cNvSpPr>
-          <p:nvPr>
-            <p:ph type="body" idx="1"/>
-          </p:nvPr>
-        </p:nvSpPr>
-        <p:spPr/>
-        <p:txBody>
-          <a:bodyPr/>
-          <a:lstStyle/>
-          <a:p>
-            <a:r>
-              <a:rPr lang="en-US" dirty="0"/>
-              <a:t>Now the assembly order makes sense. It is sorted by how often each part changes,
-stable first and volatile last, so the part that changes most often invalidates
-the least behind it.
-Edit a file and only the tail of the prefix recomputes. Put the file contents at
-the front instead and every edit would throw away the whole thing.
-This is a genuinely good piece of design and it generalises. When their build
-decides what order to assemble a prompt in, the answer is not the order that
-reads nicely, it is stable content first.</a:t>
-            </a:r>
-            <a:endParaRPr lang="en-US" dirty="0"/>
-          </a:p>
-        </p:txBody>
-      </p:sp>
-      <p:sp>
-        <p:nvSpPr>
-          <p:cNvPr id="4" name="Slide Number Placeholder 3"/>
-          <p:cNvSpPr>
-            <a:spLocks noGrp="1"/>
-          </p:cNvSpPr>
-          <p:nvPr>
-            <p:ph type="sldNum" sz="quarter" idx="10"/>
-          </p:nvPr>
-        </p:nvSpPr>
-        <p:spPr/>
-        <p:txBody>
-          <a:bodyPr/>
-          <a:lstStyle/>
-          <a:p>
-            <a:fld id="{F7021451-1387-4CA6-816F-3879F97B5CBC}" type="slidenum">
-              <a:rPr lang="en-US"/>
-              <a:t>21</a:t>
-            </a:fld>
-            <a:endParaRPr lang="en-US"/>
-          </a:p>
-        </p:txBody>
-      </p:sp>
-    </p:spTree>
-    <p:extLst>
-      <p:ext uri="{BB962C8B-B14F-4D97-AF65-F5344CB8AC3E}">
-        <p14:creationId xmlns:p14="http://schemas.microsoft.com/office/powerpoint/2010/main" val="1024086991"/>
-      </p:ext>
-    </p:extLst>
-  </p:cSld>
-  <p:clrMapOvr>
-    <a:masterClrMapping/>
-  </p:clrMapOvr>
-</p:notes>
-</file>
-
-<file path=ppt/notesSlides/notesSlide22.xml><?xml version="1.0" encoding="utf-8"?>
-<p:notes xmlns:a="http://schemas.openxmlformats.org/drawingml/2006/main" xmlns:r="http://schemas.openxmlformats.org/officeDocument/2006/relationships" xmlns:p="http://schemas.openxmlformats.org/presentationml/2006/main">
-  <p:cSld>
-    <p:spTree>
-      <p:nvGrpSpPr>
-        <p:cNvPr id="1" name=""/>
-        <p:cNvGrpSpPr/>
-        <p:nvPr/>
-      </p:nvGrpSpPr>
-      <p:grpSpPr>
-        <a:xfrm>
-          <a:off x="0" y="0"/>
-          <a:ext cx="0" cy="0"/>
-          <a:chOff x="0" y="0"/>
-          <a:chExt cx="0" cy="0"/>
-        </a:xfrm>
-      </p:grpSpPr>
-      <p:sp>
-        <p:nvSpPr>
-          <p:cNvPr id="2" name="Slide Image Placeholder 1"/>
-          <p:cNvSpPr>
-            <a:spLocks noGrp="1" noRot="1" noChangeAspect="1"/>
-          </p:cNvSpPr>
-          <p:nvPr>
-            <p:ph type="sldImg"/>
-          </p:nvPr>
-        </p:nvSpPr>
-        <p:spPr/>
-      </p:sp>
-      <p:sp>
-        <p:nvSpPr>
-          <p:cNvPr id="3" name="Notes Placeholder 2"/>
-          <p:cNvSpPr>
-            <a:spLocks noGrp="1"/>
-          </p:cNvSpPr>
-          <p:nvPr>
-            <p:ph type="body" idx="1"/>
-          </p:nvPr>
-        </p:nvSpPr>
-        <p:spPr/>
-        <p:txBody>
-          <a:bodyPr/>
-          <a:lstStyle/>
-          <a:p>
-            <a:r>
-              <a:rPr lang="en-US" dirty="0"/>
               <a:t>Ask what a block like this does not tell you. It names one file. A change that
 needs three files needs three blocks, and nothing in the format obliges the
 model to produce all three. A student who reads one well-formed block sees a
@@ -1891,7 +1720,7 @@
           <a:p>
             <a:fld id="{F7021451-1387-4CA6-816F-3879F97B5CBC}" type="slidenum">
               <a:rPr lang="en-US"/>
-              <a:t>22</a:t>
+              <a:t>20</a:t>
             </a:fld>
             <a:endParaRPr lang="en-US"/>
           </a:p>
@@ -1910,7 +1739,7 @@
 </p:notes>
 </file>
 
-<file path=ppt/notesSlides/notesSlide23.xml><?xml version="1.0" encoding="utf-8"?>
+<file path=ppt/notesSlides/notesSlide21.xml><?xml version="1.0" encoding="utf-8"?>
 <p:notes xmlns:a="http://schemas.openxmlformats.org/drawingml/2006/main" xmlns:r="http://schemas.openxmlformats.org/officeDocument/2006/relationships" xmlns:p="http://schemas.openxmlformats.org/presentationml/2006/main">
   <p:cSld>
     <p:spTree>
@@ -1987,7 +1816,7 @@
           <a:p>
             <a:fld id="{F7021451-1387-4CA6-816F-3879F97B5CBC}" type="slidenum">
               <a:rPr lang="en-US"/>
-              <a:t>23</a:t>
+              <a:t>21</a:t>
             </a:fld>
             <a:endParaRPr lang="en-US"/>
           </a:p>
@@ -2006,7 +1835,7 @@
 </p:notes>
 </file>
 
-<file path=ppt/notesSlides/notesSlide24.xml><?xml version="1.0" encoding="utf-8"?>
+<file path=ppt/notesSlides/notesSlide22.xml><?xml version="1.0" encoding="utf-8"?>
 <p:notes xmlns:a="http://schemas.openxmlformats.org/drawingml/2006/main" xmlns:r="http://schemas.openxmlformats.org/officeDocument/2006/relationships" xmlns:p="http://schemas.openxmlformats.org/presentationml/2006/main">
   <p:cSld>
     <p:spTree>
@@ -2084,7 +1913,7 @@
           <a:p>
             <a:fld id="{F7021451-1387-4CA6-816F-3879F97B5CBC}" type="slidenum">
               <a:rPr lang="en-US"/>
-              <a:t>24</a:t>
+              <a:t>22</a:t>
             </a:fld>
             <a:endParaRPr lang="en-US"/>
           </a:p>
@@ -2103,7 +1932,7 @@
 </p:notes>
 </file>
 
-<file path=ppt/notesSlides/notesSlide25.xml><?xml version="1.0" encoding="utf-8"?>
+<file path=ppt/notesSlides/notesSlide23.xml><?xml version="1.0" encoding="utf-8"?>
 <p:notes xmlns:a="http://schemas.openxmlformats.org/drawingml/2006/main" xmlns:r="http://schemas.openxmlformats.org/officeDocument/2006/relationships" xmlns:p="http://schemas.openxmlformats.org/presentationml/2006/main">
   <p:cSld>
     <p:spTree>
@@ -2180,7 +2009,7 @@
           <a:p>
             <a:fld id="{F7021451-1387-4CA6-816F-3879F97B5CBC}" type="slidenum">
               <a:rPr lang="en-US"/>
-              <a:t>25</a:t>
+              <a:t>23</a:t>
             </a:fld>
             <a:endParaRPr lang="en-US"/>
           </a:p>
@@ -2199,7 +2028,7 @@
 </p:notes>
 </file>
 
-<file path=ppt/notesSlides/notesSlide26.xml><?xml version="1.0" encoding="utf-8"?>
+<file path=ppt/notesSlides/notesSlide24.xml><?xml version="1.0" encoding="utf-8"?>
 <p:notes xmlns:a="http://schemas.openxmlformats.org/drawingml/2006/main" xmlns:r="http://schemas.openxmlformats.org/officeDocument/2006/relationships" xmlns:p="http://schemas.openxmlformats.org/presentationml/2006/main">
   <p:cSld>
     <p:spTree>
@@ -2278,7 +2107,7 @@
           <a:p>
             <a:fld id="{F7021451-1387-4CA6-816F-3879F97B5CBC}" type="slidenum">
               <a:rPr lang="en-US"/>
-              <a:t>26</a:t>
+              <a:t>24</a:t>
             </a:fld>
             <a:endParaRPr lang="en-US"/>
           </a:p>
@@ -2297,7 +2126,7 @@
 </p:notes>
 </file>
 
-<file path=ppt/notesSlides/notesSlide27.xml><?xml version="1.0" encoding="utf-8"?>
+<file path=ppt/notesSlides/notesSlide25.xml><?xml version="1.0" encoding="utf-8"?>
 <p:notes xmlns:a="http://schemas.openxmlformats.org/drawingml/2006/main" xmlns:r="http://schemas.openxmlformats.org/officeDocument/2006/relationships" xmlns:p="http://schemas.openxmlformats.org/presentationml/2006/main">
   <p:cSld>
     <p:spTree>
@@ -2376,7 +2205,7 @@
           <a:p>
             <a:fld id="{F7021451-1387-4CA6-816F-3879F97B5CBC}" type="slidenum">
               <a:rPr lang="en-US"/>
-              <a:t>27</a:t>
+              <a:t>25</a:t>
             </a:fld>
             <a:endParaRPr lang="en-US"/>
           </a:p>
@@ -2395,7 +2224,7 @@
 </p:notes>
 </file>
 
-<file path=ppt/notesSlides/notesSlide28.xml><?xml version="1.0" encoding="utf-8"?>
+<file path=ppt/notesSlides/notesSlide26.xml><?xml version="1.0" encoding="utf-8"?>
 <p:notes xmlns:a="http://schemas.openxmlformats.org/drawingml/2006/main" xmlns:r="http://schemas.openxmlformats.org/officeDocument/2006/relationships" xmlns:p="http://schemas.openxmlformats.org/presentationml/2006/main">
   <p:cSld>
     <p:spTree>
@@ -2469,7 +2298,7 @@
           <a:p>
             <a:fld id="{F7021451-1387-4CA6-816F-3879F97B5CBC}" type="slidenum">
               <a:rPr lang="en-US"/>
-              <a:t>28</a:t>
+              <a:t>26</a:t>
             </a:fld>
             <a:endParaRPr lang="en-US"/>
           </a:p>
@@ -2488,7 +2317,7 @@
 </p:notes>
 </file>
 
-<file path=ppt/notesSlides/notesSlide29.xml><?xml version="1.0" encoding="utf-8"?>
+<file path=ppt/notesSlides/notesSlide27.xml><?xml version="1.0" encoding="utf-8"?>
 <p:notes xmlns:a="http://schemas.openxmlformats.org/drawingml/2006/main" xmlns:r="http://schemas.openxmlformats.org/officeDocument/2006/relationships" xmlns:p="http://schemas.openxmlformats.org/presentationml/2006/main">
   <p:cSld>
     <p:spTree>
@@ -2545,7 +2374,15 @@
 pages, and choosing well is the difference between finishing and not. That is
 the context budget with a grade attached.
 Announce the room, the start time and the makeup path from the current staff
-announcement. Do not invent any of them here.</a:t>
+announcement. Do not invent any of them here.
+**The weight slide was cut on 2026-09-13 and the number is yours to say or not.**
+For the record: hackathon 1 is 10 of the 20 Apply parts, so half the Apply grade
+against a quarter for the build and a quarter for the practice lessons. It is
+not on the glass any more.
+The bold line is the preparation instruction and it is the one thing here that
+changes what they do tonight. The prompt asks for one feature on their own code,
+revealed in the room, so a repository that does not run cannot be started on.
+Anyone mid-refactor that evening has a much worse two hours.</a:t>
             </a:r>
             <a:endParaRPr lang="en-US" dirty="0"/>
           </a:p>
@@ -2568,7 +2405,7 @@
           <a:p>
             <a:fld id="{F7021451-1387-4CA6-816F-3879F97B5CBC}" type="slidenum">
               <a:rPr lang="en-US"/>
-              <a:t>29</a:t>
+              <a:t>27</a:t>
             </a:fld>
             <a:endParaRPr lang="en-US"/>
           </a:p>
@@ -2587,198 +2424,7 @@
 </p:notes>
 </file>
 
-<file path=ppt/notesSlides/notesSlide3.xml><?xml version="1.0" encoding="utf-8"?>
-<p:notes xmlns:a="http://schemas.openxmlformats.org/drawingml/2006/main" xmlns:r="http://schemas.openxmlformats.org/officeDocument/2006/relationships" xmlns:p="http://schemas.openxmlformats.org/presentationml/2006/main">
-  <p:cSld>
-    <p:spTree>
-      <p:nvGrpSpPr>
-        <p:cNvPr id="1" name=""/>
-        <p:cNvGrpSpPr/>
-        <p:nvPr/>
-      </p:nvGrpSpPr>
-      <p:grpSpPr>
-        <a:xfrm>
-          <a:off x="0" y="0"/>
-          <a:ext cx="0" cy="0"/>
-          <a:chOff x="0" y="0"/>
-          <a:chExt cx="0" cy="0"/>
-        </a:xfrm>
-      </p:grpSpPr>
-      <p:sp>
-        <p:nvSpPr>
-          <p:cNvPr id="2" name="Slide Image Placeholder 1"/>
-          <p:cNvSpPr>
-            <a:spLocks noGrp="1" noRot="1" noChangeAspect="1"/>
-          </p:cNvSpPr>
-          <p:nvPr>
-            <p:ph type="sldImg"/>
-          </p:nvPr>
-        </p:nvSpPr>
-        <p:spPr/>
-      </p:sp>
-      <p:sp>
-        <p:nvSpPr>
-          <p:cNvPr id="3" name="Notes Placeholder 2"/>
-          <p:cNvSpPr>
-            <a:spLocks noGrp="1"/>
-          </p:cNvSpPr>
-          <p:nvPr>
-            <p:ph type="body" idx="1"/>
-          </p:nvPr>
-        </p:nvSpPr>
-        <p:spPr/>
-        <p:txBody>
-          <a:bodyPr/>
-          <a:lstStyle/>
-          <a:p>
-            <a:r>
-              <a:rPr lang="en-US" dirty="0"/>
-              <a:t>This is the slide the deck was missing. Sixteen practice lessons gave them the
-muscle memory and none of the model, and the word "harness" is the one they
-need, because it is the thing they build in Stage 1 and extend in Analyze.
-Say the right-hand column out loud. The model's entire contribution is one
-block of text. Every effect on their machine is the left column acting on it.
-If anyone asks about models, endpoints or config: MODEL-POLICY.md, and it is
-not today's subject. qwen3.5:9b recommended, 4B permitted, any compatible
-endpoint.</a:t>
-            </a:r>
-            <a:endParaRPr lang="en-US" dirty="0"/>
-          </a:p>
-        </p:txBody>
-      </p:sp>
-      <p:sp>
-        <p:nvSpPr>
-          <p:cNvPr id="4" name="Slide Number Placeholder 3"/>
-          <p:cNvSpPr>
-            <a:spLocks noGrp="1"/>
-          </p:cNvSpPr>
-          <p:nvPr>
-            <p:ph type="sldNum" sz="quarter" idx="10"/>
-          </p:nvPr>
-        </p:nvSpPr>
-        <p:spPr/>
-        <p:txBody>
-          <a:bodyPr/>
-          <a:lstStyle/>
-          <a:p>
-            <a:fld id="{F7021451-1387-4CA6-816F-3879F97B5CBC}" type="slidenum">
-              <a:rPr lang="en-US"/>
-              <a:t>3</a:t>
-            </a:fld>
-            <a:endParaRPr lang="en-US"/>
-          </a:p>
-        </p:txBody>
-      </p:sp>
-    </p:spTree>
-    <p:extLst>
-      <p:ext uri="{BB962C8B-B14F-4D97-AF65-F5344CB8AC3E}">
-        <p14:creationId xmlns:p14="http://schemas.microsoft.com/office/powerpoint/2010/main" val="1024086991"/>
-      </p:ext>
-    </p:extLst>
-  </p:cSld>
-  <p:clrMapOvr>
-    <a:masterClrMapping/>
-  </p:clrMapOvr>
-</p:notes>
-</file>
-
-<file path=ppt/notesSlides/notesSlide30.xml><?xml version="1.0" encoding="utf-8"?>
-<p:notes xmlns:a="http://schemas.openxmlformats.org/drawingml/2006/main" xmlns:r="http://schemas.openxmlformats.org/officeDocument/2006/relationships" xmlns:p="http://schemas.openxmlformats.org/presentationml/2006/main">
-  <p:cSld>
-    <p:spTree>
-      <p:nvGrpSpPr>
-        <p:cNvPr id="1" name=""/>
-        <p:cNvGrpSpPr/>
-        <p:nvPr/>
-      </p:nvGrpSpPr>
-      <p:grpSpPr>
-        <a:xfrm>
-          <a:off x="0" y="0"/>
-          <a:ext cx="0" cy="0"/>
-          <a:chOff x="0" y="0"/>
-          <a:chExt cx="0" cy="0"/>
-        </a:xfrm>
-      </p:grpSpPr>
-      <p:sp>
-        <p:nvSpPr>
-          <p:cNvPr id="2" name="Slide Image Placeholder 1"/>
-          <p:cNvSpPr>
-            <a:spLocks noGrp="1" noRot="1" noChangeAspect="1"/>
-          </p:cNvSpPr>
-          <p:nvPr>
-            <p:ph type="sldImg"/>
-          </p:nvPr>
-        </p:nvSpPr>
-        <p:spPr/>
-      </p:sp>
-      <p:sp>
-        <p:nvSpPr>
-          <p:cNvPr id="3" name="Notes Placeholder 2"/>
-          <p:cNvSpPr>
-            <a:spLocks noGrp="1"/>
-          </p:cNvSpPr>
-          <p:nvPr>
-            <p:ph type="body" idx="1"/>
-          </p:nvPr>
-        </p:nvSpPr>
-        <p:spPr/>
-        <p:txBody>
-          <a:bodyPr/>
-          <a:lstStyle/>
-          <a:p>
-            <a:r>
-              <a:rPr lang="en-US" dirty="0"/>
-              <a:t>Say this number plainly, because the deck has never carried it and it changes
-how they should prepare. One evening is worth twice the three-week build.
-That is not a reason to spend less time on the build. It is the reason the build
-has to be in a state they can add a feature to on demand: the hackathon prompt
-asks for one feature on their own code, revealed in the room, and a student
-whose repository does not run cannot start.
-The bottom line is the whole preparation instruction. Keep something runnable
-from now until the twenty-fourth. Anyone whose build is mid-refactor that
-evening has a much worse two hours than anyone whose build is small and working.</a:t>
-            </a:r>
-            <a:endParaRPr lang="en-US" dirty="0"/>
-          </a:p>
-        </p:txBody>
-      </p:sp>
-      <p:sp>
-        <p:nvSpPr>
-          <p:cNvPr id="4" name="Slide Number Placeholder 3"/>
-          <p:cNvSpPr>
-            <a:spLocks noGrp="1"/>
-          </p:cNvSpPr>
-          <p:nvPr>
-            <p:ph type="sldNum" sz="quarter" idx="10"/>
-          </p:nvPr>
-        </p:nvSpPr>
-        <p:spPr/>
-        <p:txBody>
-          <a:bodyPr/>
-          <a:lstStyle/>
-          <a:p>
-            <a:fld id="{F7021451-1387-4CA6-816F-3879F97B5CBC}" type="slidenum">
-              <a:rPr lang="en-US"/>
-              <a:t>30</a:t>
-            </a:fld>
-            <a:endParaRPr lang="en-US"/>
-          </a:p>
-        </p:txBody>
-      </p:sp>
-    </p:spTree>
-    <p:extLst>
-      <p:ext uri="{BB962C8B-B14F-4D97-AF65-F5344CB8AC3E}">
-        <p14:creationId xmlns:p14="http://schemas.microsoft.com/office/powerpoint/2010/main" val="1024086991"/>
-      </p:ext>
-    </p:extLst>
-  </p:cSld>
-  <p:clrMapOvr>
-    <a:masterClrMapping/>
-  </p:clrMapOvr>
-</p:notes>
-</file>
-
-<file path=ppt/notesSlides/notesSlide31.xml><?xml version="1.0" encoding="utf-8"?>
+<file path=ppt/notesSlides/notesSlide28.xml><?xml version="1.0" encoding="utf-8"?>
 <p:notes xmlns:a="http://schemas.openxmlformats.org/drawingml/2006/main" xmlns:r="http://schemas.openxmlformats.org/officeDocument/2006/relationships" xmlns:p="http://schemas.openxmlformats.org/presentationml/2006/main">
   <p:cSld>
     <p:spTree>
@@ -2850,7 +2496,7 @@
           <a:p>
             <a:fld id="{F7021451-1387-4CA6-816F-3879F97B5CBC}" type="slidenum">
               <a:rPr lang="en-US"/>
-              <a:t>31</a:t>
+              <a:t>28</a:t>
             </a:fld>
             <a:endParaRPr lang="en-US"/>
           </a:p>
@@ -2869,7 +2515,7 @@
 </p:notes>
 </file>
 
-<file path=ppt/notesSlides/notesSlide32.xml><?xml version="1.0" encoding="utf-8"?>
+<file path=ppt/notesSlides/notesSlide29.xml><?xml version="1.0" encoding="utf-8"?>
 <p:notes xmlns:a="http://schemas.openxmlformats.org/drawingml/2006/main" xmlns:r="http://schemas.openxmlformats.org/officeDocument/2006/relationships" xmlns:p="http://schemas.openxmlformats.org/presentationml/2006/main">
   <p:cSld>
     <p:spTree>
@@ -2946,7 +2592,7 @@
           <a:p>
             <a:fld id="{F7021451-1387-4CA6-816F-3879F97B5CBC}" type="slidenum">
               <a:rPr lang="en-US"/>
-              <a:t>32</a:t>
+              <a:t>29</a:t>
             </a:fld>
             <a:endParaRPr lang="en-US"/>
           </a:p>
@@ -2965,7 +2611,102 @@
 </p:notes>
 </file>
 
-<file path=ppt/notesSlides/notesSlide33.xml><?xml version="1.0" encoding="utf-8"?>
+<file path=ppt/notesSlides/notesSlide3.xml><?xml version="1.0" encoding="utf-8"?>
+<p:notes xmlns:a="http://schemas.openxmlformats.org/drawingml/2006/main" xmlns:r="http://schemas.openxmlformats.org/officeDocument/2006/relationships" xmlns:p="http://schemas.openxmlformats.org/presentationml/2006/main">
+  <p:cSld>
+    <p:spTree>
+      <p:nvGrpSpPr>
+        <p:cNvPr id="1" name=""/>
+        <p:cNvGrpSpPr/>
+        <p:nvPr/>
+      </p:nvGrpSpPr>
+      <p:grpSpPr>
+        <a:xfrm>
+          <a:off x="0" y="0"/>
+          <a:ext cx="0" cy="0"/>
+          <a:chOff x="0" y="0"/>
+          <a:chExt cx="0" cy="0"/>
+        </a:xfrm>
+      </p:grpSpPr>
+      <p:sp>
+        <p:nvSpPr>
+          <p:cNvPr id="2" name="Slide Image Placeholder 1"/>
+          <p:cNvSpPr>
+            <a:spLocks noGrp="1" noRot="1" noChangeAspect="1"/>
+          </p:cNvSpPr>
+          <p:nvPr>
+            <p:ph type="sldImg"/>
+          </p:nvPr>
+        </p:nvSpPr>
+        <p:spPr/>
+      </p:sp>
+      <p:sp>
+        <p:nvSpPr>
+          <p:cNvPr id="3" name="Notes Placeholder 2"/>
+          <p:cNvSpPr>
+            <a:spLocks noGrp="1"/>
+          </p:cNvSpPr>
+          <p:nvPr>
+            <p:ph type="body" idx="1"/>
+          </p:nvPr>
+        </p:nvSpPr>
+        <p:spPr/>
+        <p:txBody>
+          <a:bodyPr/>
+          <a:lstStyle/>
+          <a:p>
+            <a:r>
+              <a:rPr lang="en-US" dirty="0"/>
+              <a:t>This is the slide the deck was missing. Sixteen practice lessons gave them the
+muscle memory and none of the model, and the word "harness" is the one they
+need, because it is the thing they build in Stage 1 and extend in Analyze.
+Say the right-hand column out loud. The model's entire contribution is one
+block of text. Every effect on their machine is the left column acting on it.
+If anyone asks about models, endpoints or config: MODEL-POLICY.md, and it is
+not today's subject. qwen3.5:9b recommended, 4B permitted, any compatible
+endpoint.</a:t>
+            </a:r>
+            <a:endParaRPr lang="en-US" dirty="0"/>
+          </a:p>
+        </p:txBody>
+      </p:sp>
+      <p:sp>
+        <p:nvSpPr>
+          <p:cNvPr id="4" name="Slide Number Placeholder 3"/>
+          <p:cNvSpPr>
+            <a:spLocks noGrp="1"/>
+          </p:cNvSpPr>
+          <p:nvPr>
+            <p:ph type="sldNum" sz="quarter" idx="10"/>
+          </p:nvPr>
+        </p:nvSpPr>
+        <p:spPr/>
+        <p:txBody>
+          <a:bodyPr/>
+          <a:lstStyle/>
+          <a:p>
+            <a:fld id="{F7021451-1387-4CA6-816F-3879F97B5CBC}" type="slidenum">
+              <a:rPr lang="en-US"/>
+              <a:t>3</a:t>
+            </a:fld>
+            <a:endParaRPr lang="en-US"/>
+          </a:p>
+        </p:txBody>
+      </p:sp>
+    </p:spTree>
+    <p:extLst>
+      <p:ext uri="{BB962C8B-B14F-4D97-AF65-F5344CB8AC3E}">
+        <p14:creationId xmlns:p14="http://schemas.microsoft.com/office/powerpoint/2010/main" val="1024086991"/>
+      </p:ext>
+    </p:extLst>
+  </p:cSld>
+  <p:clrMapOvr>
+    <a:masterClrMapping/>
+  </p:clrMapOvr>
+</p:notes>
+</file>
+
+<file path=ppt/notesSlides/notesSlide30.xml><?xml version="1.0" encoding="utf-8"?>
 <p:notes xmlns:a="http://schemas.openxmlformats.org/drawingml/2006/main" xmlns:r="http://schemas.openxmlformats.org/officeDocument/2006/relationships" xmlns:p="http://schemas.openxmlformats.org/presentationml/2006/main">
   <p:cSld>
     <p:spTree>
@@ -3045,7 +2786,7 @@
           <a:p>
             <a:fld id="{F7021451-1387-4CA6-816F-3879F97B5CBC}" type="slidenum">
               <a:rPr lang="en-US"/>
-              <a:t>33</a:t>
+              <a:t>30</a:t>
             </a:fld>
             <a:endParaRPr lang="en-US"/>
           </a:p>
@@ -3064,7 +2805,7 @@
 </p:notes>
 </file>
 
-<file path=ppt/notesSlides/notesSlide34.xml><?xml version="1.0" encoding="utf-8"?>
+<file path=ppt/notesSlides/notesSlide31.xml><?xml version="1.0" encoding="utf-8"?>
 <p:notes xmlns:a="http://schemas.openxmlformats.org/drawingml/2006/main" xmlns:r="http://schemas.openxmlformats.org/officeDocument/2006/relationships" xmlns:p="http://schemas.openxmlformats.org/presentationml/2006/main">
   <p:cSld>
     <p:spTree>
@@ -3138,7 +2879,7 @@
           <a:p>
             <a:fld id="{F7021451-1387-4CA6-816F-3879F97B5CBC}" type="slidenum">
               <a:rPr lang="en-US"/>
-              <a:t>34</a:t>
+              <a:t>31</a:t>
             </a:fld>
             <a:endParaRPr lang="en-US"/>
           </a:p>
@@ -3157,7 +2898,7 @@
 </p:notes>
 </file>
 
-<file path=ppt/notesSlides/notesSlide35.xml><?xml version="1.0" encoding="utf-8"?>
+<file path=ppt/notesSlides/notesSlide32.xml><?xml version="1.0" encoding="utf-8"?>
 <p:notes xmlns:a="http://schemas.openxmlformats.org/drawingml/2006/main" xmlns:r="http://schemas.openxmlformats.org/officeDocument/2006/relationships" xmlns:p="http://schemas.openxmlformats.org/presentationml/2006/main">
   <p:cSld>
     <p:spTree>
@@ -3233,7 +2974,7 @@
           <a:p>
             <a:fld id="{F7021451-1387-4CA6-816F-3879F97B5CBC}" type="slidenum">
               <a:rPr lang="en-US"/>
-              <a:t>35</a:t>
+              <a:t>32</a:t>
             </a:fld>
             <a:endParaRPr lang="en-US"/>
           </a:p>
@@ -3252,7 +2993,7 @@
 </p:notes>
 </file>
 
-<file path=ppt/notesSlides/notesSlide36.xml><?xml version="1.0" encoding="utf-8"?>
+<file path=ppt/notesSlides/notesSlide33.xml><?xml version="1.0" encoding="utf-8"?>
 <p:notes xmlns:a="http://schemas.openxmlformats.org/drawingml/2006/main" xmlns:r="http://schemas.openxmlformats.org/officeDocument/2006/relationships" xmlns:p="http://schemas.openxmlformats.org/presentationml/2006/main">
   <p:cSld>
     <p:spTree>
@@ -3336,7 +3077,7 @@
           <a:p>
             <a:fld id="{F7021451-1387-4CA6-816F-3879F97B5CBC}" type="slidenum">
               <a:rPr lang="en-US"/>
-              <a:t>36</a:t>
+              <a:t>33</a:t>
             </a:fld>
             <a:endParaRPr lang="en-US"/>
           </a:p>
@@ -3355,7 +3096,7 @@
 </p:notes>
 </file>
 
-<file path=ppt/notesSlides/notesSlide37.xml><?xml version="1.0" encoding="utf-8"?>
+<file path=ppt/notesSlides/notesSlide34.xml><?xml version="1.0" encoding="utf-8"?>
 <p:notes xmlns:a="http://schemas.openxmlformats.org/drawingml/2006/main" xmlns:r="http://schemas.openxmlformats.org/officeDocument/2006/relationships" xmlns:p="http://schemas.openxmlformats.org/presentationml/2006/main">
   <p:cSld>
     <p:spTree>
@@ -3429,7 +3170,7 @@
           <a:p>
             <a:fld id="{F7021451-1387-4CA6-816F-3879F97B5CBC}" type="slidenum">
               <a:rPr lang="en-US"/>
-              <a:t>37</a:t>
+              <a:t>34</a:t>
             </a:fld>
             <a:endParaRPr lang="en-US"/>
           </a:p>
@@ -3448,7 +3189,7 @@
 </p:notes>
 </file>
 
-<file path=ppt/notesSlides/notesSlide38.xml><?xml version="1.0" encoding="utf-8"?>
+<file path=ppt/notesSlides/notesSlide35.xml><?xml version="1.0" encoding="utf-8"?>
 <p:notes xmlns:a="http://schemas.openxmlformats.org/drawingml/2006/main" xmlns:r="http://schemas.openxmlformats.org/officeDocument/2006/relationships" xmlns:p="http://schemas.openxmlformats.org/presentationml/2006/main">
   <p:cSld>
     <p:spTree>
@@ -3521,7 +3262,7 @@
           <a:p>
             <a:fld id="{F7021451-1387-4CA6-816F-3879F97B5CBC}" type="slidenum">
               <a:rPr lang="en-US"/>
-              <a:t>38</a:t>
+              <a:t>35</a:t>
             </a:fld>
             <a:endParaRPr lang="en-US"/>
           </a:p>
@@ -3540,6 +3281,293 @@
 </p:notes>
 </file>
 
+<file path=ppt/notesSlides/notesSlide36.xml><?xml version="1.0" encoding="utf-8"?>
+<p:notes xmlns:a="http://schemas.openxmlformats.org/drawingml/2006/main" xmlns:r="http://schemas.openxmlformats.org/officeDocument/2006/relationships" xmlns:p="http://schemas.openxmlformats.org/presentationml/2006/main">
+  <p:cSld>
+    <p:spTree>
+      <p:nvGrpSpPr>
+        <p:cNvPr id="1" name=""/>
+        <p:cNvGrpSpPr/>
+        <p:nvPr/>
+      </p:nvGrpSpPr>
+      <p:grpSpPr>
+        <a:xfrm>
+          <a:off x="0" y="0"/>
+          <a:ext cx="0" cy="0"/>
+          <a:chOff x="0" y="0"/>
+          <a:chExt cx="0" cy="0"/>
+        </a:xfrm>
+      </p:grpSpPr>
+      <p:sp>
+        <p:nvSpPr>
+          <p:cNvPr id="2" name="Slide Image Placeholder 1"/>
+          <p:cNvSpPr>
+            <a:spLocks noGrp="1" noRot="1" noChangeAspect="1"/>
+          </p:cNvSpPr>
+          <p:nvPr>
+            <p:ph type="sldImg"/>
+          </p:nvPr>
+        </p:nvSpPr>
+        <p:spPr/>
+      </p:sp>
+      <p:sp>
+        <p:nvSpPr>
+          <p:cNvPr id="3" name="Notes Placeholder 2"/>
+          <p:cNvSpPr>
+            <a:spLocks noGrp="1"/>
+          </p:cNvSpPr>
+          <p:nvPr>
+            <p:ph type="body" idx="1"/>
+          </p:nvPr>
+        </p:nvSpPr>
+        <p:spPr/>
+        <p:txBody>
+          <a:bodyPr/>
+          <a:lstStyle/>
+          <a:p>
+            <a:r>
+              <a:rPr lang="en-US" dirty="0"/>
+              <a:t>Reworked into a discussion 2026-09-13. It was two dense tables at the end of a
+long taught half and it read as a summary nobody asked for.
+It is now a short argument followed by real questions. The tables are the
+material for the discussion, not the point of the section. Put one up, give them
+the line, and then get out of the way.
+The question some of them have been holding for two weeks is why this course
+teaches on Aider rather than the tool everyone talks about. Answer it here, once,
+and answer it honestly rather than defending the choice.</a:t>
+            </a:r>
+            <a:endParaRPr lang="en-US" dirty="0"/>
+          </a:p>
+        </p:txBody>
+      </p:sp>
+      <p:sp>
+        <p:nvSpPr>
+          <p:cNvPr id="4" name="Slide Number Placeholder 3"/>
+          <p:cNvSpPr>
+            <a:spLocks noGrp="1"/>
+          </p:cNvSpPr>
+          <p:nvPr>
+            <p:ph type="sldNum" sz="quarter" idx="10"/>
+          </p:nvPr>
+        </p:nvSpPr>
+        <p:spPr/>
+        <p:txBody>
+          <a:bodyPr/>
+          <a:lstStyle/>
+          <a:p>
+            <a:fld id="{F7021451-1387-4CA6-816F-3879F97B5CBC}" type="slidenum">
+              <a:rPr lang="en-US"/>
+              <a:t>36</a:t>
+            </a:fld>
+            <a:endParaRPr lang="en-US"/>
+          </a:p>
+        </p:txBody>
+      </p:sp>
+    </p:spTree>
+    <p:extLst>
+      <p:ext uri="{BB962C8B-B14F-4D97-AF65-F5344CB8AC3E}">
+        <p14:creationId xmlns:p14="http://schemas.microsoft.com/office/powerpoint/2010/main" val="1024086991"/>
+      </p:ext>
+    </p:extLst>
+  </p:cSld>
+  <p:clrMapOvr>
+    <a:masterClrMapping/>
+  </p:clrMapOvr>
+</p:notes>
+</file>
+
+<file path=ppt/notesSlides/notesSlide37.xml><?xml version="1.0" encoding="utf-8"?>
+<p:notes xmlns:a="http://schemas.openxmlformats.org/drawingml/2006/main" xmlns:r="http://schemas.openxmlformats.org/officeDocument/2006/relationships" xmlns:p="http://schemas.openxmlformats.org/presentationml/2006/main">
+  <p:cSld>
+    <p:spTree>
+      <p:nvGrpSpPr>
+        <p:cNvPr id="1" name=""/>
+        <p:cNvGrpSpPr/>
+        <p:nvPr/>
+      </p:nvGrpSpPr>
+      <p:grpSpPr>
+        <a:xfrm>
+          <a:off x="0" y="0"/>
+          <a:ext cx="0" cy="0"/>
+          <a:chOff x="0" y="0"/>
+          <a:chExt cx="0" cy="0"/>
+        </a:xfrm>
+      </p:grpSpPr>
+      <p:sp>
+        <p:nvSpPr>
+          <p:cNvPr id="2" name="Slide Image Placeholder 1"/>
+          <p:cNvSpPr>
+            <a:spLocks noGrp="1" noRot="1" noChangeAspect="1"/>
+          </p:cNvSpPr>
+          <p:nvPr>
+            <p:ph type="sldImg"/>
+          </p:nvPr>
+        </p:nvSpPr>
+        <p:spPr/>
+      </p:sp>
+      <p:sp>
+        <p:nvSpPr>
+          <p:cNvPr id="3" name="Notes Placeholder 2"/>
+          <p:cNvSpPr>
+            <a:spLocks noGrp="1"/>
+          </p:cNvSpPr>
+          <p:nvPr>
+            <p:ph type="body" idx="1"/>
+          </p:nvPr>
+        </p:nvSpPr>
+        <p:spPr/>
+        <p:txBody>
+          <a:bodyPr/>
+          <a:lstStyle/>
+          <a:p>
+            <a:r>
+              <a:rPr lang="en-US" dirty="0"/>
+              <a:t>Read down it and resist making the left column win. Each line is a single design
+choice seen twice, which is what a trade-off actually is, and the right column is
+not a list of bugs.
+Do not spend long here. The rows are the raw material for the questions two
+slides on, and the discussion is worth more than your commentary.
+The row to expand if you expand one: forgetting between sessions is not a
+limitation of the model. Every tool of this kind does it. Continuity is the
+harness re-sending, which is the first thing they learned today.</a:t>
+            </a:r>
+            <a:endParaRPr lang="en-US" dirty="0"/>
+          </a:p>
+        </p:txBody>
+      </p:sp>
+      <p:sp>
+        <p:nvSpPr>
+          <p:cNvPr id="4" name="Slide Number Placeholder 3"/>
+          <p:cNvSpPr>
+            <a:spLocks noGrp="1"/>
+          </p:cNvSpPr>
+          <p:nvPr>
+            <p:ph type="sldNum" sz="quarter" idx="10"/>
+          </p:nvPr>
+        </p:nvSpPr>
+        <p:spPr/>
+        <p:txBody>
+          <a:bodyPr/>
+          <a:lstStyle/>
+          <a:p>
+            <a:fld id="{F7021451-1387-4CA6-816F-3879F97B5CBC}" type="slidenum">
+              <a:rPr lang="en-US"/>
+              <a:t>37</a:t>
+            </a:fld>
+            <a:endParaRPr lang="en-US"/>
+          </a:p>
+        </p:txBody>
+      </p:sp>
+    </p:spTree>
+    <p:extLst>
+      <p:ext uri="{BB962C8B-B14F-4D97-AF65-F5344CB8AC3E}">
+        <p14:creationId xmlns:p14="http://schemas.microsoft.com/office/powerpoint/2010/main" val="1024086991"/>
+      </p:ext>
+    </p:extLst>
+  </p:cSld>
+  <p:clrMapOvr>
+    <a:masterClrMapping/>
+  </p:clrMapOvr>
+</p:notes>
+</file>
+
+<file path=ppt/notesSlides/notesSlide38.xml><?xml version="1.0" encoding="utf-8"?>
+<p:notes xmlns:a="http://schemas.openxmlformats.org/drawingml/2006/main" xmlns:r="http://schemas.openxmlformats.org/officeDocument/2006/relationships" xmlns:p="http://schemas.openxmlformats.org/presentationml/2006/main">
+  <p:cSld>
+    <p:spTree>
+      <p:nvGrpSpPr>
+        <p:cNvPr id="1" name=""/>
+        <p:cNvGrpSpPr/>
+        <p:nvPr/>
+      </p:nvGrpSpPr>
+      <p:grpSpPr>
+        <a:xfrm>
+          <a:off x="0" y="0"/>
+          <a:ext cx="0" cy="0"/>
+          <a:chOff x="0" y="0"/>
+          <a:chExt cx="0" cy="0"/>
+        </a:xfrm>
+      </p:grpSpPr>
+      <p:sp>
+        <p:nvSpPr>
+          <p:cNvPr id="2" name="Slide Image Placeholder 1"/>
+          <p:cNvSpPr>
+            <a:spLocks noGrp="1" noRot="1" noChangeAspect="1"/>
+          </p:cNvSpPr>
+          <p:nvPr>
+            <p:ph type="sldImg"/>
+          </p:nvPr>
+        </p:nvSpPr>
+        <p:spPr/>
+      </p:sp>
+      <p:sp>
+        <p:nvSpPr>
+          <p:cNvPr id="3" name="Notes Placeholder 2"/>
+          <p:cNvSpPr>
+            <a:spLocks noGrp="1"/>
+          </p:cNvSpPr>
+          <p:nvPr>
+            <p:ph type="body" idx="1"/>
+          </p:nvPr>
+        </p:nvSpPr>
+        <p:spPr/>
+        <p:txBody>
+          <a:bodyPr/>
+          <a:lstStyle/>
+          <a:p>
+            <a:r>
+              <a:rPr lang="en-US" dirty="0"/>
+              <a:t>The ladder, and the real answer to why this lab is worth two hours. All three
+rungs solve one problem, getting the right text in front of the model, and they
+differ only in who does the choosing.
+Aider stands on the first two with the joins showing. A more automated tool makes
+the same decisions without displaying them, which is exactly what makes it a
+worse thing to learn on and a better thing to use.
+Stop at context. Who picks the next action is tomorrow's lecture and it has a
+live demo for it, so do not pre-empt it.
+Then the bold line, which is the promise: none of this is magic, it is machinery,
+and they start writing it this week.</a:t>
+            </a:r>
+            <a:endParaRPr lang="en-US" dirty="0"/>
+          </a:p>
+        </p:txBody>
+      </p:sp>
+      <p:sp>
+        <p:nvSpPr>
+          <p:cNvPr id="4" name="Slide Number Placeholder 3"/>
+          <p:cNvSpPr>
+            <a:spLocks noGrp="1"/>
+          </p:cNvSpPr>
+          <p:nvPr>
+            <p:ph type="sldNum" sz="quarter" idx="10"/>
+          </p:nvPr>
+        </p:nvSpPr>
+        <p:spPr/>
+        <p:txBody>
+          <a:bodyPr/>
+          <a:lstStyle/>
+          <a:p>
+            <a:fld id="{F7021451-1387-4CA6-816F-3879F97B5CBC}" type="slidenum">
+              <a:rPr lang="en-US"/>
+              <a:t>38</a:t>
+            </a:fld>
+            <a:endParaRPr lang="en-US"/>
+          </a:p>
+        </p:txBody>
+      </p:sp>
+    </p:spTree>
+    <p:extLst>
+      <p:ext uri="{BB962C8B-B14F-4D97-AF65-F5344CB8AC3E}">
+        <p14:creationId xmlns:p14="http://schemas.microsoft.com/office/powerpoint/2010/main" val="1024086991"/>
+      </p:ext>
+    </p:extLst>
+  </p:cSld>
+  <p:clrMapOvr>
+    <a:masterClrMapping/>
+  </p:clrMapOvr>
+</p:notes>
+</file>
+
 <file path=ppt/notesSlides/notesSlide39.xml><?xml version="1.0" encoding="utf-8"?>
 <p:notes xmlns:a="http://schemas.openxmlformats.org/drawingml/2006/main" xmlns:r="http://schemas.openxmlformats.org/officeDocument/2006/relationships" xmlns:p="http://schemas.openxmlformats.org/presentationml/2006/main">
   <p:cSld>
@@ -3586,12 +3614,19 @@
           <a:p>
             <a:r>
               <a:rPr lang="en-US" dirty="0"/>
-              <a:t>The end of the taught half, and the answer to a question some of them have been
-holding for two weeks: why are we using this rather than the tool everyone talks
-about.
-Do not oversell Aider and do not apologise for it. The honest answer is that it
-makes every decision visible, and that is worth more to somebody about to build
-one than a smoother experience would be.</a:t>
+              <a:t>Leave this up and let them talk. Five minutes, and it is fine if only two of the
+three get air.
+One is the honest one: somebody will say they would never ship a tool that
+forgets everything, and that is a real design position with a real cost, which is
+the whole point of the ledger.
+Two is the bridge to tomorrow's lecture and to Analyze, so take an answer and
+leave it open rather than resolving it.
+Three is the one that makes them better engineers this week. It comes straight
+off the error-message slide: the audience for a failure might be the user, the
+model, or the log, and choosing wrong is why so many of their sessions will
+stall. Their failure-path tests are worth eight points.
+If the room is flat, ask three directly at one person's build rather than at the
+room.</a:t>
             </a:r>
             <a:endParaRPr lang="en-US" dirty="0"/>
           </a:p>
@@ -3775,200 +3810,6 @@
           <a:p>
             <a:r>
               <a:rPr lang="en-US" dirty="0"/>
-              <a:t>Work down the rows and resist making the left column win. Each line is the same
-decision read from two sides, which is what a design trade-off actually is.
-The right column is not a list of bugs. Every entry is a deliberate choice with
-a reason behind it, and their build will make each of those choices again in
-three weeks, mostly the same way, because the packet asks for the strict version
-on purpose.
-The one row worth expanding: forgetting between sessions is not a limitation of
-the model, it is what every one of these tools does. Continuity is the harness
-re-sending, which is the first thing they learned today.</a:t>
-            </a:r>
-            <a:endParaRPr lang="en-US" dirty="0"/>
-          </a:p>
-        </p:txBody>
-      </p:sp>
-      <p:sp>
-        <p:nvSpPr>
-          <p:cNvPr id="4" name="Slide Number Placeholder 3"/>
-          <p:cNvSpPr>
-            <a:spLocks noGrp="1"/>
-          </p:cNvSpPr>
-          <p:nvPr>
-            <p:ph type="sldNum" sz="quarter" idx="10"/>
-          </p:nvPr>
-        </p:nvSpPr>
-        <p:spPr/>
-        <p:txBody>
-          <a:bodyPr/>
-          <a:lstStyle/>
-          <a:p>
-            <a:fld id="{F7021451-1387-4CA6-816F-3879F97B5CBC}" type="slidenum">
-              <a:rPr lang="en-US"/>
-              <a:t>40</a:t>
-            </a:fld>
-            <a:endParaRPr lang="en-US"/>
-          </a:p>
-        </p:txBody>
-      </p:sp>
-    </p:spTree>
-    <p:extLst>
-      <p:ext uri="{BB962C8B-B14F-4D97-AF65-F5344CB8AC3E}">
-        <p14:creationId xmlns:p14="http://schemas.microsoft.com/office/powerpoint/2010/main" val="1024086991"/>
-      </p:ext>
-    </p:extLst>
-  </p:cSld>
-  <p:clrMapOvr>
-    <a:masterClrMapping/>
-  </p:clrMapOvr>
-</p:notes>
-</file>
-
-<file path=ppt/notesSlides/notesSlide41.xml><?xml version="1.0" encoding="utf-8"?>
-<p:notes xmlns:a="http://schemas.openxmlformats.org/drawingml/2006/main" xmlns:r="http://schemas.openxmlformats.org/officeDocument/2006/relationships" xmlns:p="http://schemas.openxmlformats.org/presentationml/2006/main">
-  <p:cSld>
-    <p:spTree>
-      <p:nvGrpSpPr>
-        <p:cNvPr id="1" name=""/>
-        <p:cNvGrpSpPr/>
-        <p:nvPr/>
-      </p:nvGrpSpPr>
-      <p:grpSpPr>
-        <a:xfrm>
-          <a:off x="0" y="0"/>
-          <a:ext cx="0" cy="0"/>
-          <a:chOff x="0" y="0"/>
-          <a:chExt cx="0" cy="0"/>
-        </a:xfrm>
-      </p:grpSpPr>
-      <p:sp>
-        <p:nvSpPr>
-          <p:cNvPr id="2" name="Slide Image Placeholder 1"/>
-          <p:cNvSpPr>
-            <a:spLocks noGrp="1" noRot="1" noChangeAspect="1"/>
-          </p:cNvSpPr>
-          <p:nvPr>
-            <p:ph type="sldImg"/>
-          </p:nvPr>
-        </p:nvSpPr>
-        <p:spPr/>
-      </p:sp>
-      <p:sp>
-        <p:nvSpPr>
-          <p:cNvPr id="3" name="Notes Placeholder 2"/>
-          <p:cNvSpPr>
-            <a:spLocks noGrp="1"/>
-          </p:cNvSpPr>
-          <p:nvPr>
-            <p:ph type="body" idx="1"/>
-          </p:nvPr>
-        </p:nvSpPr>
-        <p:spPr/>
-        <p:txBody>
-          <a:bodyPr/>
-          <a:lstStyle/>
-          <a:p>
-            <a:r>
-              <a:rPr lang="en-US" dirty="0"/>
-              <a:t>The ladder, and the reason this lab is worth two hours. All three rungs solve
-the same problem, which is getting the right text in front of the model, and
-they differ in who does the choosing.
-Aider stands on the first two with the seams showing. A more automated tool
-makes the same decisions without displaying them, which is exactly why it is a
-worse thing to learn on and a better thing to use. Learn it where the joins are
-visible, recognise it where they are hidden.
-Stop at context. Who picks the next action is tomorrow's lecture and it has a
-live demo for it, so do not pre-empt it here.
-Then land the promise: everything on this slide is machinery, not magic, and by
-December they will have written the third row themselves.</a:t>
-            </a:r>
-            <a:endParaRPr lang="en-US" dirty="0"/>
-          </a:p>
-        </p:txBody>
-      </p:sp>
-      <p:sp>
-        <p:nvSpPr>
-          <p:cNvPr id="4" name="Slide Number Placeholder 3"/>
-          <p:cNvSpPr>
-            <a:spLocks noGrp="1"/>
-          </p:cNvSpPr>
-          <p:nvPr>
-            <p:ph type="sldNum" sz="quarter" idx="10"/>
-          </p:nvPr>
-        </p:nvSpPr>
-        <p:spPr/>
-        <p:txBody>
-          <a:bodyPr/>
-          <a:lstStyle/>
-          <a:p>
-            <a:fld id="{F7021451-1387-4CA6-816F-3879F97B5CBC}" type="slidenum">
-              <a:rPr lang="en-US"/>
-              <a:t>41</a:t>
-            </a:fld>
-            <a:endParaRPr lang="en-US"/>
-          </a:p>
-        </p:txBody>
-      </p:sp>
-    </p:spTree>
-    <p:extLst>
-      <p:ext uri="{BB962C8B-B14F-4D97-AF65-F5344CB8AC3E}">
-        <p14:creationId xmlns:p14="http://schemas.microsoft.com/office/powerpoint/2010/main" val="1024086991"/>
-      </p:ext>
-    </p:extLst>
-  </p:cSld>
-  <p:clrMapOvr>
-    <a:masterClrMapping/>
-  </p:clrMapOvr>
-</p:notes>
-</file>
-
-<file path=ppt/notesSlides/notesSlide42.xml><?xml version="1.0" encoding="utf-8"?>
-<p:notes xmlns:a="http://schemas.openxmlformats.org/drawingml/2006/main" xmlns:r="http://schemas.openxmlformats.org/officeDocument/2006/relationships" xmlns:p="http://schemas.openxmlformats.org/presentationml/2006/main">
-  <p:cSld>
-    <p:spTree>
-      <p:nvGrpSpPr>
-        <p:cNvPr id="1" name=""/>
-        <p:cNvGrpSpPr/>
-        <p:nvPr/>
-      </p:nvGrpSpPr>
-      <p:grpSpPr>
-        <a:xfrm>
-          <a:off x="0" y="0"/>
-          <a:ext cx="0" cy="0"/>
-          <a:chOff x="0" y="0"/>
-          <a:chExt cx="0" cy="0"/>
-        </a:xfrm>
-      </p:grpSpPr>
-      <p:sp>
-        <p:nvSpPr>
-          <p:cNvPr id="2" name="Slide Image Placeholder 1"/>
-          <p:cNvSpPr>
-            <a:spLocks noGrp="1" noRot="1" noChangeAspect="1"/>
-          </p:cNvSpPr>
-          <p:nvPr>
-            <p:ph type="sldImg"/>
-          </p:nvPr>
-        </p:nvSpPr>
-        <p:spPr/>
-      </p:sp>
-      <p:sp>
-        <p:nvSpPr>
-          <p:cNvPr id="3" name="Notes Placeholder 2"/>
-          <p:cNvSpPr>
-            <a:spLocks noGrp="1"/>
-          </p:cNvSpPr>
-          <p:nvPr>
-            <p:ph type="body" idx="1"/>
-          </p:nvPr>
-        </p:nvSpPr>
-        <p:spPr/>
-        <p:txBody>
-          <a:bodyPr/>
-          <a:lstStyle/>
-          <a:p>
-            <a:r>
-              <a:rPr lang="en-US" dirty="0"/>
               <a:t>Short, and it comes after the ledger. The point is the arc, not a tour of
 tools.
 Nothing here is a Stage 1 dependency and no subscription is needed for this
@@ -3995,7 +3836,7 @@
           <a:p>
             <a:fld id="{F7021451-1387-4CA6-816F-3879F97B5CBC}" type="slidenum">
               <a:rPr lang="en-US"/>
-              <a:t>42</a:t>
+              <a:t>40</a:t>
             </a:fld>
             <a:endParaRPr lang="en-US"/>
           </a:p>
@@ -4014,7 +3855,7 @@
 </p:notes>
 </file>
 
-<file path=ppt/notesSlides/notesSlide43.xml><?xml version="1.0" encoding="utf-8"?>
+<file path=ppt/notesSlides/notesSlide41.xml><?xml version="1.0" encoding="utf-8"?>
 <p:notes xmlns:a="http://schemas.openxmlformats.org/drawingml/2006/main" xmlns:r="http://schemas.openxmlformats.org/officeDocument/2006/relationships" xmlns:p="http://schemas.openxmlformats.org/presentationml/2006/main">
   <p:cSld>
     <p:spTree>
@@ -4092,7 +3933,7 @@
           <a:p>
             <a:fld id="{F7021451-1387-4CA6-816F-3879F97B5CBC}" type="slidenum">
               <a:rPr lang="en-US"/>
-              <a:t>43</a:t>
+              <a:t>41</a:t>
             </a:fld>
             <a:endParaRPr lang="en-US"/>
           </a:p>
@@ -4111,7 +3952,7 @@
 </p:notes>
 </file>
 
-<file path=ppt/notesSlides/notesSlide44.xml><?xml version="1.0" encoding="utf-8"?>
+<file path=ppt/notesSlides/notesSlide42.xml><?xml version="1.0" encoding="utf-8"?>
 <p:notes xmlns:a="http://schemas.openxmlformats.org/drawingml/2006/main" xmlns:r="http://schemas.openxmlformats.org/officeDocument/2006/relationships" xmlns:p="http://schemas.openxmlformats.org/presentationml/2006/main">
   <p:cSld>
     <p:spTree>
@@ -4187,7 +4028,7 @@
           <a:p>
             <a:fld id="{F7021451-1387-4CA6-816F-3879F97B5CBC}" type="slidenum">
               <a:rPr lang="en-US"/>
-              <a:t>44</a:t>
+              <a:t>42</a:t>
             </a:fld>
             <a:endParaRPr lang="en-US"/>
           </a:p>
@@ -4206,7 +4047,7 @@
 </p:notes>
 </file>
 
-<file path=ppt/notesSlides/notesSlide45.xml><?xml version="1.0" encoding="utf-8"?>
+<file path=ppt/notesSlides/notesSlide43.xml><?xml version="1.0" encoding="utf-8"?>
 <p:notes xmlns:a="http://schemas.openxmlformats.org/drawingml/2006/main" xmlns:r="http://schemas.openxmlformats.org/officeDocument/2006/relationships" xmlns:p="http://schemas.openxmlformats.org/presentationml/2006/main">
   <p:cSld>
     <p:spTree>
@@ -4278,7 +4119,7 @@
           <a:p>
             <a:fld id="{F7021451-1387-4CA6-816F-3879F97B5CBC}" type="slidenum">
               <a:rPr lang="en-US"/>
-              <a:t>45</a:t>
+              <a:t>43</a:t>
             </a:fld>
             <a:endParaRPr lang="en-US"/>
           </a:p>
@@ -4297,7 +4138,7 @@
 </p:notes>
 </file>
 
-<file path=ppt/notesSlides/notesSlide46.xml><?xml version="1.0" encoding="utf-8"?>
+<file path=ppt/notesSlides/notesSlide44.xml><?xml version="1.0" encoding="utf-8"?>
 <p:notes xmlns:a="http://schemas.openxmlformats.org/drawingml/2006/main" xmlns:r="http://schemas.openxmlformats.org/officeDocument/2006/relationships" xmlns:p="http://schemas.openxmlformats.org/presentationml/2006/main">
   <p:cSld>
     <p:spTree>
@@ -4366,7 +4207,7 @@
           <a:p>
             <a:fld id="{F7021451-1387-4CA6-816F-3879F97B5CBC}" type="slidenum">
               <a:rPr lang="en-US"/>
-              <a:t>46</a:t>
+              <a:t>44</a:t>
             </a:fld>
             <a:endParaRPr lang="en-US"/>
           </a:p>
@@ -6649,84 +6490,6 @@
 <file path=ppt/slides/slide44.xml><?xml version="1.0" encoding="utf-8"?>
 <p:sld xmlns:a="http://schemas.openxmlformats.org/drawingml/2006/main" xmlns:r="http://schemas.openxmlformats.org/officeDocument/2006/relationships" xmlns:p="http://schemas.openxmlformats.org/presentationml/2006/main">
   <p:cSld name="Slide 44">
-    <p:bg>
-      <p:bgPr>
-        <a:blipFill dpi="0" rotWithShape="1">
-          <a:blip r:embed="rId1">
-            <a:lum/>
-          </a:blip>
-          <a:srcRect/>
-          <a:stretch>
-            <a:fillRect/>
-          </a:stretch>
-        </a:blipFill>
-        <a:effectLst/>
-      </p:bgPr>
-    </p:bg>
-    <p:spTree>
-      <p:nvGrpSpPr>
-        <p:cNvPr id="1" name=""/>
-        <p:cNvGrpSpPr/>
-        <p:nvPr/>
-      </p:nvGrpSpPr>
-      <p:grpSpPr>
-        <a:xfrm>
-          <a:off x="0" y="0"/>
-          <a:ext cx="0" cy="0"/>
-          <a:chOff x="0" y="0"/>
-          <a:chExt cx="0" cy="0"/>
-        </a:xfrm>
-      </p:grpSpPr>
-    </p:spTree>
-  </p:cSld>
-  <p:clrMapOvr>
-    <a:masterClrMapping/>
-  </p:clrMapOvr>
-</p:sld>
-</file>
-
-<file path=ppt/slides/slide45.xml><?xml version="1.0" encoding="utf-8"?>
-<p:sld xmlns:a="http://schemas.openxmlformats.org/drawingml/2006/main" xmlns:r="http://schemas.openxmlformats.org/officeDocument/2006/relationships" xmlns:p="http://schemas.openxmlformats.org/presentationml/2006/main">
-  <p:cSld name="Slide 45">
-    <p:bg>
-      <p:bgPr>
-        <a:blipFill dpi="0" rotWithShape="1">
-          <a:blip r:embed="rId1">
-            <a:lum/>
-          </a:blip>
-          <a:srcRect/>
-          <a:stretch>
-            <a:fillRect/>
-          </a:stretch>
-        </a:blipFill>
-        <a:effectLst/>
-      </p:bgPr>
-    </p:bg>
-    <p:spTree>
-      <p:nvGrpSpPr>
-        <p:cNvPr id="1" name=""/>
-        <p:cNvGrpSpPr/>
-        <p:nvPr/>
-      </p:nvGrpSpPr>
-      <p:grpSpPr>
-        <a:xfrm>
-          <a:off x="0" y="0"/>
-          <a:ext cx="0" cy="0"/>
-          <a:chOff x="0" y="0"/>
-          <a:chExt cx="0" cy="0"/>
-        </a:xfrm>
-      </p:grpSpPr>
-    </p:spTree>
-  </p:cSld>
-  <p:clrMapOvr>
-    <a:masterClrMapping/>
-  </p:clrMapOvr>
-</p:sld>
-</file>
-
-<file path=ppt/slides/slide46.xml><?xml version="1.0" encoding="utf-8"?>
-<p:sld xmlns:a="http://schemas.openxmlformats.org/drawingml/2006/main" xmlns:r="http://schemas.openxmlformats.org/officeDocument/2006/relationships" xmlns:p="http://schemas.openxmlformats.org/presentationml/2006/main">
-  <p:cSld name="Slide 46">
     <p:bg>
       <p:bgPr>
         <a:blipFill dpi="0" rotWithShape="1">

</xml_diff>

<commit_message>
Lab01: republish with the reworked sections (#11)
Before: the published deck carried slides whose closing lines described
what was above them rather than saying why the slide was there, and two
sections the instructor found confusing.

After: every slide in the deep-dive material ends on its point, the
map-cost diagram is folded into the shared-budget slide, the re-send
section is three slides instead of four, the hackathon weight slide is
gone, and the closing section is a discussion ending in three open
questions.

How: reshipped from the term repo with bin/ship after the exports were
rebuilt and verified at 44/44/44. The three files match the source that
merged as aase-f26 51fadf7 (PR #13) byte for byte.


Claude-Session: https://claude.ai/code/session_01HK8wFbKHvmKPXQf2PSK8c1

Co-authored-by: Claude <noreply@anthropic.com>
</commit_message>
<xml_diff>
--- a/labs/Lab01/slides.pptx
+++ b/labs/Lab01/slides.pptx
@@ -49,11 +49,9 @@
     <p:sldId id="297" r:id="rId43"/>
     <p:sldId id="298" r:id="rId44"/>
     <p:sldId id="299" r:id="rId45"/>
-    <p:sldId id="300" r:id="rId46"/>
-    <p:sldId id="301" r:id="rId47"/>
   </p:sldIdLst>
   <p:notesMasterIdLst>
-    <p:notesMasterId r:id="rId48"/>
+    <p:notesMasterId r:id="rId46"/>
   </p:notesMasterIdLst>
   <p:sldSz cx="9334500" cy="5248275"/>
   <p:notesSz cx="5248275" cy="9334500"/>
@@ -1109,12 +1107,21 @@
           <a:p>
             <a:r>
               <a:rPr lang="en-US" dirty="0"/>
-              <a:t>Off the slide: on a small model the map often costs more than the files it was
-guessing about.
-This is why aider-practice turns it down. On a 4B with a small window the map
-can eat a third of the budget to describe files the model then cannot see the
-insides of anyway.
-It is out of scope for the build. Say so here, so nobody spends week 4 on it.</a:t>
+              <a:t>This slide now carries what the separate map-cost slide used to say, because two
+diagrams of the same budget read as two unrelated facts (instructor note
+2026-09-13).
+Walk the two bars. Nothing about the early turn is wrong; the later turn is the
+same prompt after the history has grown, and the thing that stops fitting is
+their own message. Everything above it was spent before they typed.
+The bold line is the map's part in that. It is charged to the same budget as the
+files it was guessing about, which on a 4B can be a third of the window spent
+describing files the model then cannot see inside. That is why aider-practice
+turns it down, and it is why the map is out of scope for the build. Say so, so
+nobody spends week 4 on it.
+Ask what they would drop first and what has to survive. Their Stage 1 contract
+keeps the system instructions, the current request and the added file contents,
+and refuses an oversized required input instead of silently trimming it. That
+refusal is a design decision they have to write down and test.</a:t>
             </a:r>
             <a:endParaRPr lang="en-US" dirty="0"/>
           </a:p>
@@ -1202,10 +1209,13 @@
           <a:p>
             <a:r>
               <a:rPr lang="en-US" dirty="0"/>
-              <a:t>Ask what they would drop first and what has to survive. Their Stage 1 contract
-keeps the system instructions, the current request and the added file contents,
-and refuses an oversized required input instead of silently trimming it. That
-refusal is a design decision they have to write down and test.</a:t>
+              <a:t>Reworked 2026-09-13: the old version of this section had four slides and two of
+them showed the same seven-part list in different groupings, which is what made
+it read as confusing. It is three slides now and they argue in a line: here is
+the order, here is why the order was chosen, here is what ruins it.
+The one sentence to open with, because everything here follows from it: the
+model keeps nothing between turns. Turn twelve sends everything turn one sent,
+plus more. Every design decision in this section exists because of that.</a:t>
             </a:r>
             <a:endParaRPr lang="en-US" dirty="0"/>
           </a:p>
@@ -1293,10 +1303,14 @@
           <a:p>
             <a:r>
               <a:rPr lang="en-US" dirty="0"/>
-              <a:t>This block is new and it is the one they will not have met anywhere. It pays off
-the budget slide: having decided what to send, the harness now has to send it
-every single turn, because the model remembers nothing.
-Keep it on the mechanism. Nobody needs Aider's flag names.</a:t>
+              <a:t>Three groups rather than a numbered list of seven, because the grouping is the
+point and the exact ordinal of each part is not.
+Do not explain why yet. Put it up, say that the order is deliberate and looks
+strange, and let the next slide pay it off. If someone guesses the reason before
+you get there, that is the best outcome available.
+Their build assembles this same thing, and the packet asks them to say what goes
+in it and in what order. This slide is the argument that the answer is a design
+decision rather than a detail.</a:t>
             </a:r>
             <a:endParaRPr lang="en-US" dirty="0"/>
           </a:p>
@@ -1384,13 +1398,18 @@
           <a:p>
             <a:r>
               <a:rPr lang="en-US" dirty="0"/>
-              <a:t>Seven parts, one order, and the order is not arbitrary. Walk down it once.
-The thing to land: none of this is stored anywhere on the model's side. Turn
-twelve sends all seven parts again, and turn twelve costs more than turn one for
-exactly that reason.
-Their build assembles this same thing. The packet asks them to say what is in it
-and in what order, which is a design decision rather than an implementation
-detail.</a:t>
+              <a:t>Now the previous slide makes sense. Work the two rows and then point back.
+This is not the model remembering. Nothing is remembered between sessions. It is
+the serving layer recognising text it has already processed and picking up where
+it left off, and it holds on the course endpoint as much as on a hosted API. The
+plumbing differs, a hosted API marks the points explicitly and a local server
+reuses the longest opening it recognises, and the rule is identical either way.
+Then land the bold line against the order slide: the parts that change every
+turn were put at the end so that changing them costs the least. That is a real
+design principle and it is worth more to them than the mechanism itself.
+If they want dollar figures, quote the provider's current pricing page rather
+than a number from memory. What they will feel on their own machine is the
+wait before the first token, not money.</a:t>
             </a:r>
             <a:endParaRPr lang="en-US" dirty="0"/>
           </a:p>
@@ -1478,15 +1497,20 @@
           <a:p>
             <a:r>
               <a:rPr lang="en-US" dirty="0"/>
-              <a:t>This is the single most useful idea in the block and it holds everywhere, on
-ollama and on a hosted API alike. The server keeps the computed state for a
-prefix it has seen. Send the same opening again and it picks up where it left
-off. Change one token near the front and every token after it is recomputed.
-Say plainly that this is not memory. Nothing is remembered between sessions.
-It is an optimisation on repeated text, and it is the only reason a design that
-re-sends everything every turn is affordable at all.
-Hosted APIs expose it as an explicit marker; a local server does it
-automatically over the longest prefix it recognises. Same rule either way.</a:t>
+              <a:t>Three things, all verified in the source, and the third is the one nobody
+guesses.
+Ask mode is not a smaller code mode. It is a different system prompt with the
+worked examples removed, and it sits at the very front, so flipping between ask
+and code throws the whole prefix away rather than part of it. A quick question
+mid task is not free.
+Adding a file changes the file block and the repo map, because files in the chat
+come out of the map.
+The third: by default the map is rebuilt from the filenames and identifiers
+found in the message just typed. Mention a file in passing and the map moves.
+Aider knows, which is why turning caching on quietly switches the map to a
+stabler refresh mode.
+The habit worth giving them: settle the file set before starting, and keep a
+question in its own session.</a:t>
             </a:r>
             <a:endParaRPr lang="en-US" dirty="0"/>
           </a:p>
@@ -1669,201 +1693,6 @@
           <a:p>
             <a:r>
               <a:rPr lang="en-US" dirty="0"/>
-              <a:t>All three verified against the source, and the third is the one nobody guesses.
-Ask mode is not a smaller version of code mode. It is a different system prompt
-with the worked examples removed, and it sits at the very front, so flipping
-between ask and code throws away the whole prefix and not just part of it.
-Asking a quick question mid task is not free.
-Adding a file changes the repo map as well as the file block, because files in
-the chat come out of the map.
-The third: by default the map is rebuilt from the filenames and identifiers
-found in the message just typed. Mention a file in passing, the map changes, and
-everything after it recomputes. Aider knows this, which is why turning caching
-on quietly switches the map to a stabler refresh mode.
-The habit worth giving them: settle the file set before starting, and keep a
-question in its own session.</a:t>
-            </a:r>
-            <a:endParaRPr lang="en-US" dirty="0"/>
-          </a:p>
-        </p:txBody>
-      </p:sp>
-      <p:sp>
-        <p:nvSpPr>
-          <p:cNvPr id="4" name="Slide Number Placeholder 3"/>
-          <p:cNvSpPr>
-            <a:spLocks noGrp="1"/>
-          </p:cNvSpPr>
-          <p:nvPr>
-            <p:ph type="sldNum" sz="quarter" idx="10"/>
-          </p:nvPr>
-        </p:nvSpPr>
-        <p:spPr/>
-        <p:txBody>
-          <a:bodyPr/>
-          <a:lstStyle/>
-          <a:p>
-            <a:fld id="{F7021451-1387-4CA6-816F-3879F97B5CBC}" type="slidenum">
-              <a:rPr lang="en-US"/>
-              <a:t>20</a:t>
-            </a:fld>
-            <a:endParaRPr lang="en-US"/>
-          </a:p>
-        </p:txBody>
-      </p:sp>
-    </p:spTree>
-    <p:extLst>
-      <p:ext uri="{BB962C8B-B14F-4D97-AF65-F5344CB8AC3E}">
-        <p14:creationId xmlns:p14="http://schemas.microsoft.com/office/powerpoint/2010/main" val="1024086991"/>
-      </p:ext>
-    </p:extLst>
-  </p:cSld>
-  <p:clrMapOvr>
-    <a:masterClrMapping/>
-  </p:clrMapOvr>
-</p:notes>
-</file>
-
-<file path=ppt/notesSlides/notesSlide21.xml><?xml version="1.0" encoding="utf-8"?>
-<p:notes xmlns:a="http://schemas.openxmlformats.org/drawingml/2006/main" xmlns:r="http://schemas.openxmlformats.org/officeDocument/2006/relationships" xmlns:p="http://schemas.openxmlformats.org/presentationml/2006/main">
-  <p:cSld>
-    <p:spTree>
-      <p:nvGrpSpPr>
-        <p:cNvPr id="1" name=""/>
-        <p:cNvGrpSpPr/>
-        <p:nvPr/>
-      </p:nvGrpSpPr>
-      <p:grpSpPr>
-        <a:xfrm>
-          <a:off x="0" y="0"/>
-          <a:ext cx="0" cy="0"/>
-          <a:chOff x="0" y="0"/>
-          <a:chExt cx="0" cy="0"/>
-        </a:xfrm>
-      </p:grpSpPr>
-      <p:sp>
-        <p:nvSpPr>
-          <p:cNvPr id="2" name="Slide Image Placeholder 1"/>
-          <p:cNvSpPr>
-            <a:spLocks noGrp="1" noRot="1" noChangeAspect="1"/>
-          </p:cNvSpPr>
-          <p:nvPr>
-            <p:ph type="sldImg"/>
-          </p:nvPr>
-        </p:nvSpPr>
-        <p:spPr/>
-      </p:sp>
-      <p:sp>
-        <p:nvSpPr>
-          <p:cNvPr id="3" name="Notes Placeholder 2"/>
-          <p:cNvSpPr>
-            <a:spLocks noGrp="1"/>
-          </p:cNvSpPr>
-          <p:nvPr>
-            <p:ph type="body" idx="1"/>
-          </p:nvPr>
-        </p:nvSpPr>
-        <p:spPr/>
-        <p:txBody>
-          <a:bodyPr/>
-          <a:lstStyle/>
-          <a:p>
-            <a:r>
-              <a:rPr lang="en-US" dirty="0"/>
-              <a:t>Now the assembly order makes sense. It is sorted by how often each part changes,
-stable first and volatile last, so the part that changes most often invalidates
-the least behind it.
-Edit a file and only the tail of the prefix recomputes. Put the file contents at
-the front instead and every edit would throw away the whole thing.
-This is a genuinely good piece of design and it generalises. When their build
-decides what order to assemble a prompt in, the answer is not the order that
-reads nicely, it is stable content first.</a:t>
-            </a:r>
-            <a:endParaRPr lang="en-US" dirty="0"/>
-          </a:p>
-        </p:txBody>
-      </p:sp>
-      <p:sp>
-        <p:nvSpPr>
-          <p:cNvPr id="4" name="Slide Number Placeholder 3"/>
-          <p:cNvSpPr>
-            <a:spLocks noGrp="1"/>
-          </p:cNvSpPr>
-          <p:nvPr>
-            <p:ph type="sldNum" sz="quarter" idx="10"/>
-          </p:nvPr>
-        </p:nvSpPr>
-        <p:spPr/>
-        <p:txBody>
-          <a:bodyPr/>
-          <a:lstStyle/>
-          <a:p>
-            <a:fld id="{F7021451-1387-4CA6-816F-3879F97B5CBC}" type="slidenum">
-              <a:rPr lang="en-US"/>
-              <a:t>21</a:t>
-            </a:fld>
-            <a:endParaRPr lang="en-US"/>
-          </a:p>
-        </p:txBody>
-      </p:sp>
-    </p:spTree>
-    <p:extLst>
-      <p:ext uri="{BB962C8B-B14F-4D97-AF65-F5344CB8AC3E}">
-        <p14:creationId xmlns:p14="http://schemas.microsoft.com/office/powerpoint/2010/main" val="1024086991"/>
-      </p:ext>
-    </p:extLst>
-  </p:cSld>
-  <p:clrMapOvr>
-    <a:masterClrMapping/>
-  </p:clrMapOvr>
-</p:notes>
-</file>
-
-<file path=ppt/notesSlides/notesSlide22.xml><?xml version="1.0" encoding="utf-8"?>
-<p:notes xmlns:a="http://schemas.openxmlformats.org/drawingml/2006/main" xmlns:r="http://schemas.openxmlformats.org/officeDocument/2006/relationships" xmlns:p="http://schemas.openxmlformats.org/presentationml/2006/main">
-  <p:cSld>
-    <p:spTree>
-      <p:nvGrpSpPr>
-        <p:cNvPr id="1" name=""/>
-        <p:cNvGrpSpPr/>
-        <p:nvPr/>
-      </p:nvGrpSpPr>
-      <p:grpSpPr>
-        <a:xfrm>
-          <a:off x="0" y="0"/>
-          <a:ext cx="0" cy="0"/>
-          <a:chOff x="0" y="0"/>
-          <a:chExt cx="0" cy="0"/>
-        </a:xfrm>
-      </p:grpSpPr>
-      <p:sp>
-        <p:nvSpPr>
-          <p:cNvPr id="2" name="Slide Image Placeholder 1"/>
-          <p:cNvSpPr>
-            <a:spLocks noGrp="1" noRot="1" noChangeAspect="1"/>
-          </p:cNvSpPr>
-          <p:nvPr>
-            <p:ph type="sldImg"/>
-          </p:nvPr>
-        </p:nvSpPr>
-        <p:spPr/>
-      </p:sp>
-      <p:sp>
-        <p:nvSpPr>
-          <p:cNvPr id="3" name="Notes Placeholder 2"/>
-          <p:cNvSpPr>
-            <a:spLocks noGrp="1"/>
-          </p:cNvSpPr>
-          <p:nvPr>
-            <p:ph type="body" idx="1"/>
-          </p:nvPr>
-        </p:nvSpPr>
-        <p:spPr/>
-        <p:txBody>
-          <a:bodyPr/>
-          <a:lstStyle/>
-          <a:p>
-            <a:r>
-              <a:rPr lang="en-US" dirty="0"/>
               <a:t>Ask what a block like this does not tell you. It names one file. A change that
 needs three files needs three blocks, and nothing in the format obliges the
 model to produce all three. A student who reads one well-formed block sees a
@@ -1891,7 +1720,7 @@
           <a:p>
             <a:fld id="{F7021451-1387-4CA6-816F-3879F97B5CBC}" type="slidenum">
               <a:rPr lang="en-US"/>
-              <a:t>22</a:t>
+              <a:t>20</a:t>
             </a:fld>
             <a:endParaRPr lang="en-US"/>
           </a:p>
@@ -1910,7 +1739,7 @@
 </p:notes>
 </file>
 
-<file path=ppt/notesSlides/notesSlide23.xml><?xml version="1.0" encoding="utf-8"?>
+<file path=ppt/notesSlides/notesSlide21.xml><?xml version="1.0" encoding="utf-8"?>
 <p:notes xmlns:a="http://schemas.openxmlformats.org/drawingml/2006/main" xmlns:r="http://schemas.openxmlformats.org/officeDocument/2006/relationships" xmlns:p="http://schemas.openxmlformats.org/presentationml/2006/main">
   <p:cSld>
     <p:spTree>
@@ -1987,7 +1816,7 @@
           <a:p>
             <a:fld id="{F7021451-1387-4CA6-816F-3879F97B5CBC}" type="slidenum">
               <a:rPr lang="en-US"/>
-              <a:t>23</a:t>
+              <a:t>21</a:t>
             </a:fld>
             <a:endParaRPr lang="en-US"/>
           </a:p>
@@ -2006,7 +1835,7 @@
 </p:notes>
 </file>
 
-<file path=ppt/notesSlides/notesSlide24.xml><?xml version="1.0" encoding="utf-8"?>
+<file path=ppt/notesSlides/notesSlide22.xml><?xml version="1.0" encoding="utf-8"?>
 <p:notes xmlns:a="http://schemas.openxmlformats.org/drawingml/2006/main" xmlns:r="http://schemas.openxmlformats.org/officeDocument/2006/relationships" xmlns:p="http://schemas.openxmlformats.org/presentationml/2006/main">
   <p:cSld>
     <p:spTree>
@@ -2084,7 +1913,7 @@
           <a:p>
             <a:fld id="{F7021451-1387-4CA6-816F-3879F97B5CBC}" type="slidenum">
               <a:rPr lang="en-US"/>
-              <a:t>24</a:t>
+              <a:t>22</a:t>
             </a:fld>
             <a:endParaRPr lang="en-US"/>
           </a:p>
@@ -2103,7 +1932,7 @@
 </p:notes>
 </file>
 
-<file path=ppt/notesSlides/notesSlide25.xml><?xml version="1.0" encoding="utf-8"?>
+<file path=ppt/notesSlides/notesSlide23.xml><?xml version="1.0" encoding="utf-8"?>
 <p:notes xmlns:a="http://schemas.openxmlformats.org/drawingml/2006/main" xmlns:r="http://schemas.openxmlformats.org/officeDocument/2006/relationships" xmlns:p="http://schemas.openxmlformats.org/presentationml/2006/main">
   <p:cSld>
     <p:spTree>
@@ -2180,7 +2009,7 @@
           <a:p>
             <a:fld id="{F7021451-1387-4CA6-816F-3879F97B5CBC}" type="slidenum">
               <a:rPr lang="en-US"/>
-              <a:t>25</a:t>
+              <a:t>23</a:t>
             </a:fld>
             <a:endParaRPr lang="en-US"/>
           </a:p>
@@ -2199,7 +2028,7 @@
 </p:notes>
 </file>
 
-<file path=ppt/notesSlides/notesSlide26.xml><?xml version="1.0" encoding="utf-8"?>
+<file path=ppt/notesSlides/notesSlide24.xml><?xml version="1.0" encoding="utf-8"?>
 <p:notes xmlns:a="http://schemas.openxmlformats.org/drawingml/2006/main" xmlns:r="http://schemas.openxmlformats.org/officeDocument/2006/relationships" xmlns:p="http://schemas.openxmlformats.org/presentationml/2006/main">
   <p:cSld>
     <p:spTree>
@@ -2278,7 +2107,7 @@
           <a:p>
             <a:fld id="{F7021451-1387-4CA6-816F-3879F97B5CBC}" type="slidenum">
               <a:rPr lang="en-US"/>
-              <a:t>26</a:t>
+              <a:t>24</a:t>
             </a:fld>
             <a:endParaRPr lang="en-US"/>
           </a:p>
@@ -2297,7 +2126,7 @@
 </p:notes>
 </file>
 
-<file path=ppt/notesSlides/notesSlide27.xml><?xml version="1.0" encoding="utf-8"?>
+<file path=ppt/notesSlides/notesSlide25.xml><?xml version="1.0" encoding="utf-8"?>
 <p:notes xmlns:a="http://schemas.openxmlformats.org/drawingml/2006/main" xmlns:r="http://schemas.openxmlformats.org/officeDocument/2006/relationships" xmlns:p="http://schemas.openxmlformats.org/presentationml/2006/main">
   <p:cSld>
     <p:spTree>
@@ -2376,7 +2205,7 @@
           <a:p>
             <a:fld id="{F7021451-1387-4CA6-816F-3879F97B5CBC}" type="slidenum">
               <a:rPr lang="en-US"/>
-              <a:t>27</a:t>
+              <a:t>25</a:t>
             </a:fld>
             <a:endParaRPr lang="en-US"/>
           </a:p>
@@ -2395,7 +2224,7 @@
 </p:notes>
 </file>
 
-<file path=ppt/notesSlides/notesSlide28.xml><?xml version="1.0" encoding="utf-8"?>
+<file path=ppt/notesSlides/notesSlide26.xml><?xml version="1.0" encoding="utf-8"?>
 <p:notes xmlns:a="http://schemas.openxmlformats.org/drawingml/2006/main" xmlns:r="http://schemas.openxmlformats.org/officeDocument/2006/relationships" xmlns:p="http://schemas.openxmlformats.org/presentationml/2006/main">
   <p:cSld>
     <p:spTree>
@@ -2469,7 +2298,7 @@
           <a:p>
             <a:fld id="{F7021451-1387-4CA6-816F-3879F97B5CBC}" type="slidenum">
               <a:rPr lang="en-US"/>
-              <a:t>28</a:t>
+              <a:t>26</a:t>
             </a:fld>
             <a:endParaRPr lang="en-US"/>
           </a:p>
@@ -2488,7 +2317,7 @@
 </p:notes>
 </file>
 
-<file path=ppt/notesSlides/notesSlide29.xml><?xml version="1.0" encoding="utf-8"?>
+<file path=ppt/notesSlides/notesSlide27.xml><?xml version="1.0" encoding="utf-8"?>
 <p:notes xmlns:a="http://schemas.openxmlformats.org/drawingml/2006/main" xmlns:r="http://schemas.openxmlformats.org/officeDocument/2006/relationships" xmlns:p="http://schemas.openxmlformats.org/presentationml/2006/main">
   <p:cSld>
     <p:spTree>
@@ -2545,7 +2374,15 @@
 pages, and choosing well is the difference between finishing and not. That is
 the context budget with a grade attached.
 Announce the room, the start time and the makeup path from the current staff
-announcement. Do not invent any of them here.</a:t>
+announcement. Do not invent any of them here.
+**The weight slide was cut on 2026-09-13 and the number is yours to say or not.**
+For the record: hackathon 1 is 10 of the 20 Apply parts, so half the Apply grade
+against a quarter for the build and a quarter for the practice lessons. It is
+not on the glass any more.
+The bold line is the preparation instruction and it is the one thing here that
+changes what they do tonight. The prompt asks for one feature on their own code,
+revealed in the room, so a repository that does not run cannot be started on.
+Anyone mid-refactor that evening has a much worse two hours.</a:t>
             </a:r>
             <a:endParaRPr lang="en-US" dirty="0"/>
           </a:p>
@@ -2568,7 +2405,7 @@
           <a:p>
             <a:fld id="{F7021451-1387-4CA6-816F-3879F97B5CBC}" type="slidenum">
               <a:rPr lang="en-US"/>
-              <a:t>29</a:t>
+              <a:t>27</a:t>
             </a:fld>
             <a:endParaRPr lang="en-US"/>
           </a:p>
@@ -2587,198 +2424,7 @@
 </p:notes>
 </file>
 
-<file path=ppt/notesSlides/notesSlide3.xml><?xml version="1.0" encoding="utf-8"?>
-<p:notes xmlns:a="http://schemas.openxmlformats.org/drawingml/2006/main" xmlns:r="http://schemas.openxmlformats.org/officeDocument/2006/relationships" xmlns:p="http://schemas.openxmlformats.org/presentationml/2006/main">
-  <p:cSld>
-    <p:spTree>
-      <p:nvGrpSpPr>
-        <p:cNvPr id="1" name=""/>
-        <p:cNvGrpSpPr/>
-        <p:nvPr/>
-      </p:nvGrpSpPr>
-      <p:grpSpPr>
-        <a:xfrm>
-          <a:off x="0" y="0"/>
-          <a:ext cx="0" cy="0"/>
-          <a:chOff x="0" y="0"/>
-          <a:chExt cx="0" cy="0"/>
-        </a:xfrm>
-      </p:grpSpPr>
-      <p:sp>
-        <p:nvSpPr>
-          <p:cNvPr id="2" name="Slide Image Placeholder 1"/>
-          <p:cNvSpPr>
-            <a:spLocks noGrp="1" noRot="1" noChangeAspect="1"/>
-          </p:cNvSpPr>
-          <p:nvPr>
-            <p:ph type="sldImg"/>
-          </p:nvPr>
-        </p:nvSpPr>
-        <p:spPr/>
-      </p:sp>
-      <p:sp>
-        <p:nvSpPr>
-          <p:cNvPr id="3" name="Notes Placeholder 2"/>
-          <p:cNvSpPr>
-            <a:spLocks noGrp="1"/>
-          </p:cNvSpPr>
-          <p:nvPr>
-            <p:ph type="body" idx="1"/>
-          </p:nvPr>
-        </p:nvSpPr>
-        <p:spPr/>
-        <p:txBody>
-          <a:bodyPr/>
-          <a:lstStyle/>
-          <a:p>
-            <a:r>
-              <a:rPr lang="en-US" dirty="0"/>
-              <a:t>This is the slide the deck was missing. Sixteen practice lessons gave them the
-muscle memory and none of the model, and the word "harness" is the one they
-need, because it is the thing they build in Stage 1 and extend in Analyze.
-Say the right-hand column out loud. The model's entire contribution is one
-block of text. Every effect on their machine is the left column acting on it.
-If anyone asks about models, endpoints or config: MODEL-POLICY.md, and it is
-not today's subject. qwen3.5:9b recommended, 4B permitted, any compatible
-endpoint.</a:t>
-            </a:r>
-            <a:endParaRPr lang="en-US" dirty="0"/>
-          </a:p>
-        </p:txBody>
-      </p:sp>
-      <p:sp>
-        <p:nvSpPr>
-          <p:cNvPr id="4" name="Slide Number Placeholder 3"/>
-          <p:cNvSpPr>
-            <a:spLocks noGrp="1"/>
-          </p:cNvSpPr>
-          <p:nvPr>
-            <p:ph type="sldNum" sz="quarter" idx="10"/>
-          </p:nvPr>
-        </p:nvSpPr>
-        <p:spPr/>
-        <p:txBody>
-          <a:bodyPr/>
-          <a:lstStyle/>
-          <a:p>
-            <a:fld id="{F7021451-1387-4CA6-816F-3879F97B5CBC}" type="slidenum">
-              <a:rPr lang="en-US"/>
-              <a:t>3</a:t>
-            </a:fld>
-            <a:endParaRPr lang="en-US"/>
-          </a:p>
-        </p:txBody>
-      </p:sp>
-    </p:spTree>
-    <p:extLst>
-      <p:ext uri="{BB962C8B-B14F-4D97-AF65-F5344CB8AC3E}">
-        <p14:creationId xmlns:p14="http://schemas.microsoft.com/office/powerpoint/2010/main" val="1024086991"/>
-      </p:ext>
-    </p:extLst>
-  </p:cSld>
-  <p:clrMapOvr>
-    <a:masterClrMapping/>
-  </p:clrMapOvr>
-</p:notes>
-</file>
-
-<file path=ppt/notesSlides/notesSlide30.xml><?xml version="1.0" encoding="utf-8"?>
-<p:notes xmlns:a="http://schemas.openxmlformats.org/drawingml/2006/main" xmlns:r="http://schemas.openxmlformats.org/officeDocument/2006/relationships" xmlns:p="http://schemas.openxmlformats.org/presentationml/2006/main">
-  <p:cSld>
-    <p:spTree>
-      <p:nvGrpSpPr>
-        <p:cNvPr id="1" name=""/>
-        <p:cNvGrpSpPr/>
-        <p:nvPr/>
-      </p:nvGrpSpPr>
-      <p:grpSpPr>
-        <a:xfrm>
-          <a:off x="0" y="0"/>
-          <a:ext cx="0" cy="0"/>
-          <a:chOff x="0" y="0"/>
-          <a:chExt cx="0" cy="0"/>
-        </a:xfrm>
-      </p:grpSpPr>
-      <p:sp>
-        <p:nvSpPr>
-          <p:cNvPr id="2" name="Slide Image Placeholder 1"/>
-          <p:cNvSpPr>
-            <a:spLocks noGrp="1" noRot="1" noChangeAspect="1"/>
-          </p:cNvSpPr>
-          <p:nvPr>
-            <p:ph type="sldImg"/>
-          </p:nvPr>
-        </p:nvSpPr>
-        <p:spPr/>
-      </p:sp>
-      <p:sp>
-        <p:nvSpPr>
-          <p:cNvPr id="3" name="Notes Placeholder 2"/>
-          <p:cNvSpPr>
-            <a:spLocks noGrp="1"/>
-          </p:cNvSpPr>
-          <p:nvPr>
-            <p:ph type="body" idx="1"/>
-          </p:nvPr>
-        </p:nvSpPr>
-        <p:spPr/>
-        <p:txBody>
-          <a:bodyPr/>
-          <a:lstStyle/>
-          <a:p>
-            <a:r>
-              <a:rPr lang="en-US" dirty="0"/>
-              <a:t>Say this number plainly, because the deck has never carried it and it changes
-how they should prepare. One evening is worth twice the three-week build.
-That is not a reason to spend less time on the build. It is the reason the build
-has to be in a state they can add a feature to on demand: the hackathon prompt
-asks for one feature on their own code, revealed in the room, and a student
-whose repository does not run cannot start.
-The bottom line is the whole preparation instruction. Keep something runnable
-from now until the twenty-fourth. Anyone whose build is mid-refactor that
-evening has a much worse two hours than anyone whose build is small and working.</a:t>
-            </a:r>
-            <a:endParaRPr lang="en-US" dirty="0"/>
-          </a:p>
-        </p:txBody>
-      </p:sp>
-      <p:sp>
-        <p:nvSpPr>
-          <p:cNvPr id="4" name="Slide Number Placeholder 3"/>
-          <p:cNvSpPr>
-            <a:spLocks noGrp="1"/>
-          </p:cNvSpPr>
-          <p:nvPr>
-            <p:ph type="sldNum" sz="quarter" idx="10"/>
-          </p:nvPr>
-        </p:nvSpPr>
-        <p:spPr/>
-        <p:txBody>
-          <a:bodyPr/>
-          <a:lstStyle/>
-          <a:p>
-            <a:fld id="{F7021451-1387-4CA6-816F-3879F97B5CBC}" type="slidenum">
-              <a:rPr lang="en-US"/>
-              <a:t>30</a:t>
-            </a:fld>
-            <a:endParaRPr lang="en-US"/>
-          </a:p>
-        </p:txBody>
-      </p:sp>
-    </p:spTree>
-    <p:extLst>
-      <p:ext uri="{BB962C8B-B14F-4D97-AF65-F5344CB8AC3E}">
-        <p14:creationId xmlns:p14="http://schemas.microsoft.com/office/powerpoint/2010/main" val="1024086991"/>
-      </p:ext>
-    </p:extLst>
-  </p:cSld>
-  <p:clrMapOvr>
-    <a:masterClrMapping/>
-  </p:clrMapOvr>
-</p:notes>
-</file>
-
-<file path=ppt/notesSlides/notesSlide31.xml><?xml version="1.0" encoding="utf-8"?>
+<file path=ppt/notesSlides/notesSlide28.xml><?xml version="1.0" encoding="utf-8"?>
 <p:notes xmlns:a="http://schemas.openxmlformats.org/drawingml/2006/main" xmlns:r="http://schemas.openxmlformats.org/officeDocument/2006/relationships" xmlns:p="http://schemas.openxmlformats.org/presentationml/2006/main">
   <p:cSld>
     <p:spTree>
@@ -2850,7 +2496,7 @@
           <a:p>
             <a:fld id="{F7021451-1387-4CA6-816F-3879F97B5CBC}" type="slidenum">
               <a:rPr lang="en-US"/>
-              <a:t>31</a:t>
+              <a:t>28</a:t>
             </a:fld>
             <a:endParaRPr lang="en-US"/>
           </a:p>
@@ -2869,7 +2515,7 @@
 </p:notes>
 </file>
 
-<file path=ppt/notesSlides/notesSlide32.xml><?xml version="1.0" encoding="utf-8"?>
+<file path=ppt/notesSlides/notesSlide29.xml><?xml version="1.0" encoding="utf-8"?>
 <p:notes xmlns:a="http://schemas.openxmlformats.org/drawingml/2006/main" xmlns:r="http://schemas.openxmlformats.org/officeDocument/2006/relationships" xmlns:p="http://schemas.openxmlformats.org/presentationml/2006/main">
   <p:cSld>
     <p:spTree>
@@ -2946,7 +2592,7 @@
           <a:p>
             <a:fld id="{F7021451-1387-4CA6-816F-3879F97B5CBC}" type="slidenum">
               <a:rPr lang="en-US"/>
-              <a:t>32</a:t>
+              <a:t>29</a:t>
             </a:fld>
             <a:endParaRPr lang="en-US"/>
           </a:p>
@@ -2965,7 +2611,102 @@
 </p:notes>
 </file>
 
-<file path=ppt/notesSlides/notesSlide33.xml><?xml version="1.0" encoding="utf-8"?>
+<file path=ppt/notesSlides/notesSlide3.xml><?xml version="1.0" encoding="utf-8"?>
+<p:notes xmlns:a="http://schemas.openxmlformats.org/drawingml/2006/main" xmlns:r="http://schemas.openxmlformats.org/officeDocument/2006/relationships" xmlns:p="http://schemas.openxmlformats.org/presentationml/2006/main">
+  <p:cSld>
+    <p:spTree>
+      <p:nvGrpSpPr>
+        <p:cNvPr id="1" name=""/>
+        <p:cNvGrpSpPr/>
+        <p:nvPr/>
+      </p:nvGrpSpPr>
+      <p:grpSpPr>
+        <a:xfrm>
+          <a:off x="0" y="0"/>
+          <a:ext cx="0" cy="0"/>
+          <a:chOff x="0" y="0"/>
+          <a:chExt cx="0" cy="0"/>
+        </a:xfrm>
+      </p:grpSpPr>
+      <p:sp>
+        <p:nvSpPr>
+          <p:cNvPr id="2" name="Slide Image Placeholder 1"/>
+          <p:cNvSpPr>
+            <a:spLocks noGrp="1" noRot="1" noChangeAspect="1"/>
+          </p:cNvSpPr>
+          <p:nvPr>
+            <p:ph type="sldImg"/>
+          </p:nvPr>
+        </p:nvSpPr>
+        <p:spPr/>
+      </p:sp>
+      <p:sp>
+        <p:nvSpPr>
+          <p:cNvPr id="3" name="Notes Placeholder 2"/>
+          <p:cNvSpPr>
+            <a:spLocks noGrp="1"/>
+          </p:cNvSpPr>
+          <p:nvPr>
+            <p:ph type="body" idx="1"/>
+          </p:nvPr>
+        </p:nvSpPr>
+        <p:spPr/>
+        <p:txBody>
+          <a:bodyPr/>
+          <a:lstStyle/>
+          <a:p>
+            <a:r>
+              <a:rPr lang="en-US" dirty="0"/>
+              <a:t>This is the slide the deck was missing. Sixteen practice lessons gave them the
+muscle memory and none of the model, and the word "harness" is the one they
+need, because it is the thing they build in Stage 1 and extend in Analyze.
+Say the right-hand column out loud. The model's entire contribution is one
+block of text. Every effect on their machine is the left column acting on it.
+If anyone asks about models, endpoints or config: MODEL-POLICY.md, and it is
+not today's subject. qwen3.5:9b recommended, 4B permitted, any compatible
+endpoint.</a:t>
+            </a:r>
+            <a:endParaRPr lang="en-US" dirty="0"/>
+          </a:p>
+        </p:txBody>
+      </p:sp>
+      <p:sp>
+        <p:nvSpPr>
+          <p:cNvPr id="4" name="Slide Number Placeholder 3"/>
+          <p:cNvSpPr>
+            <a:spLocks noGrp="1"/>
+          </p:cNvSpPr>
+          <p:nvPr>
+            <p:ph type="sldNum" sz="quarter" idx="10"/>
+          </p:nvPr>
+        </p:nvSpPr>
+        <p:spPr/>
+        <p:txBody>
+          <a:bodyPr/>
+          <a:lstStyle/>
+          <a:p>
+            <a:fld id="{F7021451-1387-4CA6-816F-3879F97B5CBC}" type="slidenum">
+              <a:rPr lang="en-US"/>
+              <a:t>3</a:t>
+            </a:fld>
+            <a:endParaRPr lang="en-US"/>
+          </a:p>
+        </p:txBody>
+      </p:sp>
+    </p:spTree>
+    <p:extLst>
+      <p:ext uri="{BB962C8B-B14F-4D97-AF65-F5344CB8AC3E}">
+        <p14:creationId xmlns:p14="http://schemas.microsoft.com/office/powerpoint/2010/main" val="1024086991"/>
+      </p:ext>
+    </p:extLst>
+  </p:cSld>
+  <p:clrMapOvr>
+    <a:masterClrMapping/>
+  </p:clrMapOvr>
+</p:notes>
+</file>
+
+<file path=ppt/notesSlides/notesSlide30.xml><?xml version="1.0" encoding="utf-8"?>
 <p:notes xmlns:a="http://schemas.openxmlformats.org/drawingml/2006/main" xmlns:r="http://schemas.openxmlformats.org/officeDocument/2006/relationships" xmlns:p="http://schemas.openxmlformats.org/presentationml/2006/main">
   <p:cSld>
     <p:spTree>
@@ -3045,7 +2786,7 @@
           <a:p>
             <a:fld id="{F7021451-1387-4CA6-816F-3879F97B5CBC}" type="slidenum">
               <a:rPr lang="en-US"/>
-              <a:t>33</a:t>
+              <a:t>30</a:t>
             </a:fld>
             <a:endParaRPr lang="en-US"/>
           </a:p>
@@ -3064,7 +2805,7 @@
 </p:notes>
 </file>
 
-<file path=ppt/notesSlides/notesSlide34.xml><?xml version="1.0" encoding="utf-8"?>
+<file path=ppt/notesSlides/notesSlide31.xml><?xml version="1.0" encoding="utf-8"?>
 <p:notes xmlns:a="http://schemas.openxmlformats.org/drawingml/2006/main" xmlns:r="http://schemas.openxmlformats.org/officeDocument/2006/relationships" xmlns:p="http://schemas.openxmlformats.org/presentationml/2006/main">
   <p:cSld>
     <p:spTree>
@@ -3138,7 +2879,7 @@
           <a:p>
             <a:fld id="{F7021451-1387-4CA6-816F-3879F97B5CBC}" type="slidenum">
               <a:rPr lang="en-US"/>
-              <a:t>34</a:t>
+              <a:t>31</a:t>
             </a:fld>
             <a:endParaRPr lang="en-US"/>
           </a:p>
@@ -3157,7 +2898,7 @@
 </p:notes>
 </file>
 
-<file path=ppt/notesSlides/notesSlide35.xml><?xml version="1.0" encoding="utf-8"?>
+<file path=ppt/notesSlides/notesSlide32.xml><?xml version="1.0" encoding="utf-8"?>
 <p:notes xmlns:a="http://schemas.openxmlformats.org/drawingml/2006/main" xmlns:r="http://schemas.openxmlformats.org/officeDocument/2006/relationships" xmlns:p="http://schemas.openxmlformats.org/presentationml/2006/main">
   <p:cSld>
     <p:spTree>
@@ -3233,7 +2974,7 @@
           <a:p>
             <a:fld id="{F7021451-1387-4CA6-816F-3879F97B5CBC}" type="slidenum">
               <a:rPr lang="en-US"/>
-              <a:t>35</a:t>
+              <a:t>32</a:t>
             </a:fld>
             <a:endParaRPr lang="en-US"/>
           </a:p>
@@ -3252,7 +2993,7 @@
 </p:notes>
 </file>
 
-<file path=ppt/notesSlides/notesSlide36.xml><?xml version="1.0" encoding="utf-8"?>
+<file path=ppt/notesSlides/notesSlide33.xml><?xml version="1.0" encoding="utf-8"?>
 <p:notes xmlns:a="http://schemas.openxmlformats.org/drawingml/2006/main" xmlns:r="http://schemas.openxmlformats.org/officeDocument/2006/relationships" xmlns:p="http://schemas.openxmlformats.org/presentationml/2006/main">
   <p:cSld>
     <p:spTree>
@@ -3336,7 +3077,7 @@
           <a:p>
             <a:fld id="{F7021451-1387-4CA6-816F-3879F97B5CBC}" type="slidenum">
               <a:rPr lang="en-US"/>
-              <a:t>36</a:t>
+              <a:t>33</a:t>
             </a:fld>
             <a:endParaRPr lang="en-US"/>
           </a:p>
@@ -3355,7 +3096,7 @@
 </p:notes>
 </file>
 
-<file path=ppt/notesSlides/notesSlide37.xml><?xml version="1.0" encoding="utf-8"?>
+<file path=ppt/notesSlides/notesSlide34.xml><?xml version="1.0" encoding="utf-8"?>
 <p:notes xmlns:a="http://schemas.openxmlformats.org/drawingml/2006/main" xmlns:r="http://schemas.openxmlformats.org/officeDocument/2006/relationships" xmlns:p="http://schemas.openxmlformats.org/presentationml/2006/main">
   <p:cSld>
     <p:spTree>
@@ -3429,7 +3170,7 @@
           <a:p>
             <a:fld id="{F7021451-1387-4CA6-816F-3879F97B5CBC}" type="slidenum">
               <a:rPr lang="en-US"/>
-              <a:t>37</a:t>
+              <a:t>34</a:t>
             </a:fld>
             <a:endParaRPr lang="en-US"/>
           </a:p>
@@ -3448,7 +3189,7 @@
 </p:notes>
 </file>
 
-<file path=ppt/notesSlides/notesSlide38.xml><?xml version="1.0" encoding="utf-8"?>
+<file path=ppt/notesSlides/notesSlide35.xml><?xml version="1.0" encoding="utf-8"?>
 <p:notes xmlns:a="http://schemas.openxmlformats.org/drawingml/2006/main" xmlns:r="http://schemas.openxmlformats.org/officeDocument/2006/relationships" xmlns:p="http://schemas.openxmlformats.org/presentationml/2006/main">
   <p:cSld>
     <p:spTree>
@@ -3521,7 +3262,7 @@
           <a:p>
             <a:fld id="{F7021451-1387-4CA6-816F-3879F97B5CBC}" type="slidenum">
               <a:rPr lang="en-US"/>
-              <a:t>38</a:t>
+              <a:t>35</a:t>
             </a:fld>
             <a:endParaRPr lang="en-US"/>
           </a:p>
@@ -3540,6 +3281,293 @@
 </p:notes>
 </file>
 
+<file path=ppt/notesSlides/notesSlide36.xml><?xml version="1.0" encoding="utf-8"?>
+<p:notes xmlns:a="http://schemas.openxmlformats.org/drawingml/2006/main" xmlns:r="http://schemas.openxmlformats.org/officeDocument/2006/relationships" xmlns:p="http://schemas.openxmlformats.org/presentationml/2006/main">
+  <p:cSld>
+    <p:spTree>
+      <p:nvGrpSpPr>
+        <p:cNvPr id="1" name=""/>
+        <p:cNvGrpSpPr/>
+        <p:nvPr/>
+      </p:nvGrpSpPr>
+      <p:grpSpPr>
+        <a:xfrm>
+          <a:off x="0" y="0"/>
+          <a:ext cx="0" cy="0"/>
+          <a:chOff x="0" y="0"/>
+          <a:chExt cx="0" cy="0"/>
+        </a:xfrm>
+      </p:grpSpPr>
+      <p:sp>
+        <p:nvSpPr>
+          <p:cNvPr id="2" name="Slide Image Placeholder 1"/>
+          <p:cNvSpPr>
+            <a:spLocks noGrp="1" noRot="1" noChangeAspect="1"/>
+          </p:cNvSpPr>
+          <p:nvPr>
+            <p:ph type="sldImg"/>
+          </p:nvPr>
+        </p:nvSpPr>
+        <p:spPr/>
+      </p:sp>
+      <p:sp>
+        <p:nvSpPr>
+          <p:cNvPr id="3" name="Notes Placeholder 2"/>
+          <p:cNvSpPr>
+            <a:spLocks noGrp="1"/>
+          </p:cNvSpPr>
+          <p:nvPr>
+            <p:ph type="body" idx="1"/>
+          </p:nvPr>
+        </p:nvSpPr>
+        <p:spPr/>
+        <p:txBody>
+          <a:bodyPr/>
+          <a:lstStyle/>
+          <a:p>
+            <a:r>
+              <a:rPr lang="en-US" dirty="0"/>
+              <a:t>Reworked into a discussion 2026-09-13. It was two dense tables at the end of a
+long taught half and it read as a summary nobody asked for.
+It is now a short argument followed by real questions. The tables are the
+material for the discussion, not the point of the section. Put one up, give them
+the line, and then get out of the way.
+The question some of them have been holding for two weeks is why this course
+teaches on Aider rather than the tool everyone talks about. Answer it here, once,
+and answer it honestly rather than defending the choice.</a:t>
+            </a:r>
+            <a:endParaRPr lang="en-US" dirty="0"/>
+          </a:p>
+        </p:txBody>
+      </p:sp>
+      <p:sp>
+        <p:nvSpPr>
+          <p:cNvPr id="4" name="Slide Number Placeholder 3"/>
+          <p:cNvSpPr>
+            <a:spLocks noGrp="1"/>
+          </p:cNvSpPr>
+          <p:nvPr>
+            <p:ph type="sldNum" sz="quarter" idx="10"/>
+          </p:nvPr>
+        </p:nvSpPr>
+        <p:spPr/>
+        <p:txBody>
+          <a:bodyPr/>
+          <a:lstStyle/>
+          <a:p>
+            <a:fld id="{F7021451-1387-4CA6-816F-3879F97B5CBC}" type="slidenum">
+              <a:rPr lang="en-US"/>
+              <a:t>36</a:t>
+            </a:fld>
+            <a:endParaRPr lang="en-US"/>
+          </a:p>
+        </p:txBody>
+      </p:sp>
+    </p:spTree>
+    <p:extLst>
+      <p:ext uri="{BB962C8B-B14F-4D97-AF65-F5344CB8AC3E}">
+        <p14:creationId xmlns:p14="http://schemas.microsoft.com/office/powerpoint/2010/main" val="1024086991"/>
+      </p:ext>
+    </p:extLst>
+  </p:cSld>
+  <p:clrMapOvr>
+    <a:masterClrMapping/>
+  </p:clrMapOvr>
+</p:notes>
+</file>
+
+<file path=ppt/notesSlides/notesSlide37.xml><?xml version="1.0" encoding="utf-8"?>
+<p:notes xmlns:a="http://schemas.openxmlformats.org/drawingml/2006/main" xmlns:r="http://schemas.openxmlformats.org/officeDocument/2006/relationships" xmlns:p="http://schemas.openxmlformats.org/presentationml/2006/main">
+  <p:cSld>
+    <p:spTree>
+      <p:nvGrpSpPr>
+        <p:cNvPr id="1" name=""/>
+        <p:cNvGrpSpPr/>
+        <p:nvPr/>
+      </p:nvGrpSpPr>
+      <p:grpSpPr>
+        <a:xfrm>
+          <a:off x="0" y="0"/>
+          <a:ext cx="0" cy="0"/>
+          <a:chOff x="0" y="0"/>
+          <a:chExt cx="0" cy="0"/>
+        </a:xfrm>
+      </p:grpSpPr>
+      <p:sp>
+        <p:nvSpPr>
+          <p:cNvPr id="2" name="Slide Image Placeholder 1"/>
+          <p:cNvSpPr>
+            <a:spLocks noGrp="1" noRot="1" noChangeAspect="1"/>
+          </p:cNvSpPr>
+          <p:nvPr>
+            <p:ph type="sldImg"/>
+          </p:nvPr>
+        </p:nvSpPr>
+        <p:spPr/>
+      </p:sp>
+      <p:sp>
+        <p:nvSpPr>
+          <p:cNvPr id="3" name="Notes Placeholder 2"/>
+          <p:cNvSpPr>
+            <a:spLocks noGrp="1"/>
+          </p:cNvSpPr>
+          <p:nvPr>
+            <p:ph type="body" idx="1"/>
+          </p:nvPr>
+        </p:nvSpPr>
+        <p:spPr/>
+        <p:txBody>
+          <a:bodyPr/>
+          <a:lstStyle/>
+          <a:p>
+            <a:r>
+              <a:rPr lang="en-US" dirty="0"/>
+              <a:t>Read down it and resist making the left column win. Each line is a single design
+choice seen twice, which is what a trade-off actually is, and the right column is
+not a list of bugs.
+Do not spend long here. The rows are the raw material for the questions two
+slides on, and the discussion is worth more than your commentary.
+The row to expand if you expand one: forgetting between sessions is not a
+limitation of the model. Every tool of this kind does it. Continuity is the
+harness re-sending, which is the first thing they learned today.</a:t>
+            </a:r>
+            <a:endParaRPr lang="en-US" dirty="0"/>
+          </a:p>
+        </p:txBody>
+      </p:sp>
+      <p:sp>
+        <p:nvSpPr>
+          <p:cNvPr id="4" name="Slide Number Placeholder 3"/>
+          <p:cNvSpPr>
+            <a:spLocks noGrp="1"/>
+          </p:cNvSpPr>
+          <p:nvPr>
+            <p:ph type="sldNum" sz="quarter" idx="10"/>
+          </p:nvPr>
+        </p:nvSpPr>
+        <p:spPr/>
+        <p:txBody>
+          <a:bodyPr/>
+          <a:lstStyle/>
+          <a:p>
+            <a:fld id="{F7021451-1387-4CA6-816F-3879F97B5CBC}" type="slidenum">
+              <a:rPr lang="en-US"/>
+              <a:t>37</a:t>
+            </a:fld>
+            <a:endParaRPr lang="en-US"/>
+          </a:p>
+        </p:txBody>
+      </p:sp>
+    </p:spTree>
+    <p:extLst>
+      <p:ext uri="{BB962C8B-B14F-4D97-AF65-F5344CB8AC3E}">
+        <p14:creationId xmlns:p14="http://schemas.microsoft.com/office/powerpoint/2010/main" val="1024086991"/>
+      </p:ext>
+    </p:extLst>
+  </p:cSld>
+  <p:clrMapOvr>
+    <a:masterClrMapping/>
+  </p:clrMapOvr>
+</p:notes>
+</file>
+
+<file path=ppt/notesSlides/notesSlide38.xml><?xml version="1.0" encoding="utf-8"?>
+<p:notes xmlns:a="http://schemas.openxmlformats.org/drawingml/2006/main" xmlns:r="http://schemas.openxmlformats.org/officeDocument/2006/relationships" xmlns:p="http://schemas.openxmlformats.org/presentationml/2006/main">
+  <p:cSld>
+    <p:spTree>
+      <p:nvGrpSpPr>
+        <p:cNvPr id="1" name=""/>
+        <p:cNvGrpSpPr/>
+        <p:nvPr/>
+      </p:nvGrpSpPr>
+      <p:grpSpPr>
+        <a:xfrm>
+          <a:off x="0" y="0"/>
+          <a:ext cx="0" cy="0"/>
+          <a:chOff x="0" y="0"/>
+          <a:chExt cx="0" cy="0"/>
+        </a:xfrm>
+      </p:grpSpPr>
+      <p:sp>
+        <p:nvSpPr>
+          <p:cNvPr id="2" name="Slide Image Placeholder 1"/>
+          <p:cNvSpPr>
+            <a:spLocks noGrp="1" noRot="1" noChangeAspect="1"/>
+          </p:cNvSpPr>
+          <p:nvPr>
+            <p:ph type="sldImg"/>
+          </p:nvPr>
+        </p:nvSpPr>
+        <p:spPr/>
+      </p:sp>
+      <p:sp>
+        <p:nvSpPr>
+          <p:cNvPr id="3" name="Notes Placeholder 2"/>
+          <p:cNvSpPr>
+            <a:spLocks noGrp="1"/>
+          </p:cNvSpPr>
+          <p:nvPr>
+            <p:ph type="body" idx="1"/>
+          </p:nvPr>
+        </p:nvSpPr>
+        <p:spPr/>
+        <p:txBody>
+          <a:bodyPr/>
+          <a:lstStyle/>
+          <a:p>
+            <a:r>
+              <a:rPr lang="en-US" dirty="0"/>
+              <a:t>The ladder, and the real answer to why this lab is worth two hours. All three
+rungs solve one problem, getting the right text in front of the model, and they
+differ only in who does the choosing.
+Aider stands on the first two with the joins showing. A more automated tool makes
+the same decisions without displaying them, which is exactly what makes it a
+worse thing to learn on and a better thing to use.
+Stop at context. Who picks the next action is tomorrow's lecture and it has a
+live demo for it, so do not pre-empt it.
+Then the bold line, which is the promise: none of this is magic, it is machinery,
+and they start writing it this week.</a:t>
+            </a:r>
+            <a:endParaRPr lang="en-US" dirty="0"/>
+          </a:p>
+        </p:txBody>
+      </p:sp>
+      <p:sp>
+        <p:nvSpPr>
+          <p:cNvPr id="4" name="Slide Number Placeholder 3"/>
+          <p:cNvSpPr>
+            <a:spLocks noGrp="1"/>
+          </p:cNvSpPr>
+          <p:nvPr>
+            <p:ph type="sldNum" sz="quarter" idx="10"/>
+          </p:nvPr>
+        </p:nvSpPr>
+        <p:spPr/>
+        <p:txBody>
+          <a:bodyPr/>
+          <a:lstStyle/>
+          <a:p>
+            <a:fld id="{F7021451-1387-4CA6-816F-3879F97B5CBC}" type="slidenum">
+              <a:rPr lang="en-US"/>
+              <a:t>38</a:t>
+            </a:fld>
+            <a:endParaRPr lang="en-US"/>
+          </a:p>
+        </p:txBody>
+      </p:sp>
+    </p:spTree>
+    <p:extLst>
+      <p:ext uri="{BB962C8B-B14F-4D97-AF65-F5344CB8AC3E}">
+        <p14:creationId xmlns:p14="http://schemas.microsoft.com/office/powerpoint/2010/main" val="1024086991"/>
+      </p:ext>
+    </p:extLst>
+  </p:cSld>
+  <p:clrMapOvr>
+    <a:masterClrMapping/>
+  </p:clrMapOvr>
+</p:notes>
+</file>
+
 <file path=ppt/notesSlides/notesSlide39.xml><?xml version="1.0" encoding="utf-8"?>
 <p:notes xmlns:a="http://schemas.openxmlformats.org/drawingml/2006/main" xmlns:r="http://schemas.openxmlformats.org/officeDocument/2006/relationships" xmlns:p="http://schemas.openxmlformats.org/presentationml/2006/main">
   <p:cSld>
@@ -3586,12 +3614,19 @@
           <a:p>
             <a:r>
               <a:rPr lang="en-US" dirty="0"/>
-              <a:t>The end of the taught half, and the answer to a question some of them have been
-holding for two weeks: why are we using this rather than the tool everyone talks
-about.
-Do not oversell Aider and do not apologise for it. The honest answer is that it
-makes every decision visible, and that is worth more to somebody about to build
-one than a smoother experience would be.</a:t>
+              <a:t>Leave this up and let them talk. Five minutes, and it is fine if only two of the
+three get air.
+One is the honest one: somebody will say they would never ship a tool that
+forgets everything, and that is a real design position with a real cost, which is
+the whole point of the ledger.
+Two is the bridge to tomorrow's lecture and to Analyze, so take an answer and
+leave it open rather than resolving it.
+Three is the one that makes them better engineers this week. It comes straight
+off the error-message slide: the audience for a failure might be the user, the
+model, or the log, and choosing wrong is why so many of their sessions will
+stall. Their failure-path tests are worth eight points.
+If the room is flat, ask three directly at one person's build rather than at the
+room.</a:t>
             </a:r>
             <a:endParaRPr lang="en-US" dirty="0"/>
           </a:p>
@@ -3775,200 +3810,6 @@
           <a:p>
             <a:r>
               <a:rPr lang="en-US" dirty="0"/>
-              <a:t>Work down the rows and resist making the left column win. Each line is the same
-decision read from two sides, which is what a design trade-off actually is.
-The right column is not a list of bugs. Every entry is a deliberate choice with
-a reason behind it, and their build will make each of those choices again in
-three weeks, mostly the same way, because the packet asks for the strict version
-on purpose.
-The one row worth expanding: forgetting between sessions is not a limitation of
-the model, it is what every one of these tools does. Continuity is the harness
-re-sending, which is the first thing they learned today.</a:t>
-            </a:r>
-            <a:endParaRPr lang="en-US" dirty="0"/>
-          </a:p>
-        </p:txBody>
-      </p:sp>
-      <p:sp>
-        <p:nvSpPr>
-          <p:cNvPr id="4" name="Slide Number Placeholder 3"/>
-          <p:cNvSpPr>
-            <a:spLocks noGrp="1"/>
-          </p:cNvSpPr>
-          <p:nvPr>
-            <p:ph type="sldNum" sz="quarter" idx="10"/>
-          </p:nvPr>
-        </p:nvSpPr>
-        <p:spPr/>
-        <p:txBody>
-          <a:bodyPr/>
-          <a:lstStyle/>
-          <a:p>
-            <a:fld id="{F7021451-1387-4CA6-816F-3879F97B5CBC}" type="slidenum">
-              <a:rPr lang="en-US"/>
-              <a:t>40</a:t>
-            </a:fld>
-            <a:endParaRPr lang="en-US"/>
-          </a:p>
-        </p:txBody>
-      </p:sp>
-    </p:spTree>
-    <p:extLst>
-      <p:ext uri="{BB962C8B-B14F-4D97-AF65-F5344CB8AC3E}">
-        <p14:creationId xmlns:p14="http://schemas.microsoft.com/office/powerpoint/2010/main" val="1024086991"/>
-      </p:ext>
-    </p:extLst>
-  </p:cSld>
-  <p:clrMapOvr>
-    <a:masterClrMapping/>
-  </p:clrMapOvr>
-</p:notes>
-</file>
-
-<file path=ppt/notesSlides/notesSlide41.xml><?xml version="1.0" encoding="utf-8"?>
-<p:notes xmlns:a="http://schemas.openxmlformats.org/drawingml/2006/main" xmlns:r="http://schemas.openxmlformats.org/officeDocument/2006/relationships" xmlns:p="http://schemas.openxmlformats.org/presentationml/2006/main">
-  <p:cSld>
-    <p:spTree>
-      <p:nvGrpSpPr>
-        <p:cNvPr id="1" name=""/>
-        <p:cNvGrpSpPr/>
-        <p:nvPr/>
-      </p:nvGrpSpPr>
-      <p:grpSpPr>
-        <a:xfrm>
-          <a:off x="0" y="0"/>
-          <a:ext cx="0" cy="0"/>
-          <a:chOff x="0" y="0"/>
-          <a:chExt cx="0" cy="0"/>
-        </a:xfrm>
-      </p:grpSpPr>
-      <p:sp>
-        <p:nvSpPr>
-          <p:cNvPr id="2" name="Slide Image Placeholder 1"/>
-          <p:cNvSpPr>
-            <a:spLocks noGrp="1" noRot="1" noChangeAspect="1"/>
-          </p:cNvSpPr>
-          <p:nvPr>
-            <p:ph type="sldImg"/>
-          </p:nvPr>
-        </p:nvSpPr>
-        <p:spPr/>
-      </p:sp>
-      <p:sp>
-        <p:nvSpPr>
-          <p:cNvPr id="3" name="Notes Placeholder 2"/>
-          <p:cNvSpPr>
-            <a:spLocks noGrp="1"/>
-          </p:cNvSpPr>
-          <p:nvPr>
-            <p:ph type="body" idx="1"/>
-          </p:nvPr>
-        </p:nvSpPr>
-        <p:spPr/>
-        <p:txBody>
-          <a:bodyPr/>
-          <a:lstStyle/>
-          <a:p>
-            <a:r>
-              <a:rPr lang="en-US" dirty="0"/>
-              <a:t>The ladder, and the reason this lab is worth two hours. All three rungs solve
-the same problem, which is getting the right text in front of the model, and
-they differ in who does the choosing.
-Aider stands on the first two with the seams showing. A more automated tool
-makes the same decisions without displaying them, which is exactly why it is a
-worse thing to learn on and a better thing to use. Learn it where the joins are
-visible, recognise it where they are hidden.
-Stop at context. Who picks the next action is tomorrow's lecture and it has a
-live demo for it, so do not pre-empt it here.
-Then land the promise: everything on this slide is machinery, not magic, and by
-December they will have written the third row themselves.</a:t>
-            </a:r>
-            <a:endParaRPr lang="en-US" dirty="0"/>
-          </a:p>
-        </p:txBody>
-      </p:sp>
-      <p:sp>
-        <p:nvSpPr>
-          <p:cNvPr id="4" name="Slide Number Placeholder 3"/>
-          <p:cNvSpPr>
-            <a:spLocks noGrp="1"/>
-          </p:cNvSpPr>
-          <p:nvPr>
-            <p:ph type="sldNum" sz="quarter" idx="10"/>
-          </p:nvPr>
-        </p:nvSpPr>
-        <p:spPr/>
-        <p:txBody>
-          <a:bodyPr/>
-          <a:lstStyle/>
-          <a:p>
-            <a:fld id="{F7021451-1387-4CA6-816F-3879F97B5CBC}" type="slidenum">
-              <a:rPr lang="en-US"/>
-              <a:t>41</a:t>
-            </a:fld>
-            <a:endParaRPr lang="en-US"/>
-          </a:p>
-        </p:txBody>
-      </p:sp>
-    </p:spTree>
-    <p:extLst>
-      <p:ext uri="{BB962C8B-B14F-4D97-AF65-F5344CB8AC3E}">
-        <p14:creationId xmlns:p14="http://schemas.microsoft.com/office/powerpoint/2010/main" val="1024086991"/>
-      </p:ext>
-    </p:extLst>
-  </p:cSld>
-  <p:clrMapOvr>
-    <a:masterClrMapping/>
-  </p:clrMapOvr>
-</p:notes>
-</file>
-
-<file path=ppt/notesSlides/notesSlide42.xml><?xml version="1.0" encoding="utf-8"?>
-<p:notes xmlns:a="http://schemas.openxmlformats.org/drawingml/2006/main" xmlns:r="http://schemas.openxmlformats.org/officeDocument/2006/relationships" xmlns:p="http://schemas.openxmlformats.org/presentationml/2006/main">
-  <p:cSld>
-    <p:spTree>
-      <p:nvGrpSpPr>
-        <p:cNvPr id="1" name=""/>
-        <p:cNvGrpSpPr/>
-        <p:nvPr/>
-      </p:nvGrpSpPr>
-      <p:grpSpPr>
-        <a:xfrm>
-          <a:off x="0" y="0"/>
-          <a:ext cx="0" cy="0"/>
-          <a:chOff x="0" y="0"/>
-          <a:chExt cx="0" cy="0"/>
-        </a:xfrm>
-      </p:grpSpPr>
-      <p:sp>
-        <p:nvSpPr>
-          <p:cNvPr id="2" name="Slide Image Placeholder 1"/>
-          <p:cNvSpPr>
-            <a:spLocks noGrp="1" noRot="1" noChangeAspect="1"/>
-          </p:cNvSpPr>
-          <p:nvPr>
-            <p:ph type="sldImg"/>
-          </p:nvPr>
-        </p:nvSpPr>
-        <p:spPr/>
-      </p:sp>
-      <p:sp>
-        <p:nvSpPr>
-          <p:cNvPr id="3" name="Notes Placeholder 2"/>
-          <p:cNvSpPr>
-            <a:spLocks noGrp="1"/>
-          </p:cNvSpPr>
-          <p:nvPr>
-            <p:ph type="body" idx="1"/>
-          </p:nvPr>
-        </p:nvSpPr>
-        <p:spPr/>
-        <p:txBody>
-          <a:bodyPr/>
-          <a:lstStyle/>
-          <a:p>
-            <a:r>
-              <a:rPr lang="en-US" dirty="0"/>
               <a:t>Short, and it comes after the ledger. The point is the arc, not a tour of
 tools.
 Nothing here is a Stage 1 dependency and no subscription is needed for this
@@ -3995,7 +3836,7 @@
           <a:p>
             <a:fld id="{F7021451-1387-4CA6-816F-3879F97B5CBC}" type="slidenum">
               <a:rPr lang="en-US"/>
-              <a:t>42</a:t>
+              <a:t>40</a:t>
             </a:fld>
             <a:endParaRPr lang="en-US"/>
           </a:p>
@@ -4014,7 +3855,7 @@
 </p:notes>
 </file>
 
-<file path=ppt/notesSlides/notesSlide43.xml><?xml version="1.0" encoding="utf-8"?>
+<file path=ppt/notesSlides/notesSlide41.xml><?xml version="1.0" encoding="utf-8"?>
 <p:notes xmlns:a="http://schemas.openxmlformats.org/drawingml/2006/main" xmlns:r="http://schemas.openxmlformats.org/officeDocument/2006/relationships" xmlns:p="http://schemas.openxmlformats.org/presentationml/2006/main">
   <p:cSld>
     <p:spTree>
@@ -4092,7 +3933,7 @@
           <a:p>
             <a:fld id="{F7021451-1387-4CA6-816F-3879F97B5CBC}" type="slidenum">
               <a:rPr lang="en-US"/>
-              <a:t>43</a:t>
+              <a:t>41</a:t>
             </a:fld>
             <a:endParaRPr lang="en-US"/>
           </a:p>
@@ -4111,7 +3952,7 @@
 </p:notes>
 </file>
 
-<file path=ppt/notesSlides/notesSlide44.xml><?xml version="1.0" encoding="utf-8"?>
+<file path=ppt/notesSlides/notesSlide42.xml><?xml version="1.0" encoding="utf-8"?>
 <p:notes xmlns:a="http://schemas.openxmlformats.org/drawingml/2006/main" xmlns:r="http://schemas.openxmlformats.org/officeDocument/2006/relationships" xmlns:p="http://schemas.openxmlformats.org/presentationml/2006/main">
   <p:cSld>
     <p:spTree>
@@ -4187,7 +4028,7 @@
           <a:p>
             <a:fld id="{F7021451-1387-4CA6-816F-3879F97B5CBC}" type="slidenum">
               <a:rPr lang="en-US"/>
-              <a:t>44</a:t>
+              <a:t>42</a:t>
             </a:fld>
             <a:endParaRPr lang="en-US"/>
           </a:p>
@@ -4206,7 +4047,7 @@
 </p:notes>
 </file>
 
-<file path=ppt/notesSlides/notesSlide45.xml><?xml version="1.0" encoding="utf-8"?>
+<file path=ppt/notesSlides/notesSlide43.xml><?xml version="1.0" encoding="utf-8"?>
 <p:notes xmlns:a="http://schemas.openxmlformats.org/drawingml/2006/main" xmlns:r="http://schemas.openxmlformats.org/officeDocument/2006/relationships" xmlns:p="http://schemas.openxmlformats.org/presentationml/2006/main">
   <p:cSld>
     <p:spTree>
@@ -4278,7 +4119,7 @@
           <a:p>
             <a:fld id="{F7021451-1387-4CA6-816F-3879F97B5CBC}" type="slidenum">
               <a:rPr lang="en-US"/>
-              <a:t>45</a:t>
+              <a:t>43</a:t>
             </a:fld>
             <a:endParaRPr lang="en-US"/>
           </a:p>
@@ -4297,7 +4138,7 @@
 </p:notes>
 </file>
 
-<file path=ppt/notesSlides/notesSlide46.xml><?xml version="1.0" encoding="utf-8"?>
+<file path=ppt/notesSlides/notesSlide44.xml><?xml version="1.0" encoding="utf-8"?>
 <p:notes xmlns:a="http://schemas.openxmlformats.org/drawingml/2006/main" xmlns:r="http://schemas.openxmlformats.org/officeDocument/2006/relationships" xmlns:p="http://schemas.openxmlformats.org/presentationml/2006/main">
   <p:cSld>
     <p:spTree>
@@ -4366,7 +4207,7 @@
           <a:p>
             <a:fld id="{F7021451-1387-4CA6-816F-3879F97B5CBC}" type="slidenum">
               <a:rPr lang="en-US"/>
-              <a:t>46</a:t>
+              <a:t>44</a:t>
             </a:fld>
             <a:endParaRPr lang="en-US"/>
           </a:p>
@@ -6649,84 +6490,6 @@
 <file path=ppt/slides/slide44.xml><?xml version="1.0" encoding="utf-8"?>
 <p:sld xmlns:a="http://schemas.openxmlformats.org/drawingml/2006/main" xmlns:r="http://schemas.openxmlformats.org/officeDocument/2006/relationships" xmlns:p="http://schemas.openxmlformats.org/presentationml/2006/main">
   <p:cSld name="Slide 44">
-    <p:bg>
-      <p:bgPr>
-        <a:blipFill dpi="0" rotWithShape="1">
-          <a:blip r:embed="rId1">
-            <a:lum/>
-          </a:blip>
-          <a:srcRect/>
-          <a:stretch>
-            <a:fillRect/>
-          </a:stretch>
-        </a:blipFill>
-        <a:effectLst/>
-      </p:bgPr>
-    </p:bg>
-    <p:spTree>
-      <p:nvGrpSpPr>
-        <p:cNvPr id="1" name=""/>
-        <p:cNvGrpSpPr/>
-        <p:nvPr/>
-      </p:nvGrpSpPr>
-      <p:grpSpPr>
-        <a:xfrm>
-          <a:off x="0" y="0"/>
-          <a:ext cx="0" cy="0"/>
-          <a:chOff x="0" y="0"/>
-          <a:chExt cx="0" cy="0"/>
-        </a:xfrm>
-      </p:grpSpPr>
-    </p:spTree>
-  </p:cSld>
-  <p:clrMapOvr>
-    <a:masterClrMapping/>
-  </p:clrMapOvr>
-</p:sld>
-</file>
-
-<file path=ppt/slides/slide45.xml><?xml version="1.0" encoding="utf-8"?>
-<p:sld xmlns:a="http://schemas.openxmlformats.org/drawingml/2006/main" xmlns:r="http://schemas.openxmlformats.org/officeDocument/2006/relationships" xmlns:p="http://schemas.openxmlformats.org/presentationml/2006/main">
-  <p:cSld name="Slide 45">
-    <p:bg>
-      <p:bgPr>
-        <a:blipFill dpi="0" rotWithShape="1">
-          <a:blip r:embed="rId1">
-            <a:lum/>
-          </a:blip>
-          <a:srcRect/>
-          <a:stretch>
-            <a:fillRect/>
-          </a:stretch>
-        </a:blipFill>
-        <a:effectLst/>
-      </p:bgPr>
-    </p:bg>
-    <p:spTree>
-      <p:nvGrpSpPr>
-        <p:cNvPr id="1" name=""/>
-        <p:cNvGrpSpPr/>
-        <p:nvPr/>
-      </p:nvGrpSpPr>
-      <p:grpSpPr>
-        <a:xfrm>
-          <a:off x="0" y="0"/>
-          <a:ext cx="0" cy="0"/>
-          <a:chOff x="0" y="0"/>
-          <a:chExt cx="0" cy="0"/>
-        </a:xfrm>
-      </p:grpSpPr>
-    </p:spTree>
-  </p:cSld>
-  <p:clrMapOvr>
-    <a:masterClrMapping/>
-  </p:clrMapOvr>
-</p:sld>
-</file>
-
-<file path=ppt/slides/slide46.xml><?xml version="1.0" encoding="utf-8"?>
-<p:sld xmlns:a="http://schemas.openxmlformats.org/drawingml/2006/main" xmlns:r="http://schemas.openxmlformats.org/officeDocument/2006/relationships" xmlns:p="http://schemas.openxmlformats.org/presentationml/2006/main">
-  <p:cSld name="Slide 46">
     <p:bg>
       <p:bgPr>
         <a:blipFill dpi="0" rotWithShape="1">

</xml_diff>

<commit_message>
Lab01: republish at 38 slides after the second cut
Co-Authored-By: Claude Fable 5.1 <noreply@anthropic.com>
Claude-Session: https://claude.ai/code/session_01HK8wFbKHvmKPXQf2PSK8c1
</commit_message>
<xml_diff>
--- a/labs/Lab01/slides.pptx
+++ b/labs/Lab01/slides.pptx
@@ -43,15 +43,9 @@
     <p:sldId id="291" r:id="rId37"/>
     <p:sldId id="292" r:id="rId38"/>
     <p:sldId id="293" r:id="rId39"/>
-    <p:sldId id="294" r:id="rId40"/>
-    <p:sldId id="295" r:id="rId41"/>
-    <p:sldId id="296" r:id="rId42"/>
-    <p:sldId id="297" r:id="rId43"/>
-    <p:sldId id="298" r:id="rId44"/>
-    <p:sldId id="299" r:id="rId45"/>
   </p:sldIdLst>
   <p:notesMasterIdLst>
-    <p:notesMasterId r:id="rId46"/>
+    <p:notesMasterId r:id="rId40"/>
   </p:notesMasterIdLst>
   <p:sldSz cx="9334500" cy="5248275"/>
   <p:notesSz cx="5248275" cy="9334500"/>
@@ -638,10 +632,22 @@
           <a:p>
             <a:r>
               <a:rPr lang="en-US" dirty="0"/>
-              <a:t>Ask the room to find the arrow that writes a file. There is not one leaving the
-amber box. The model produced text, and a program decided what to do with it.
-This is a picture of Aider, not a required architecture for their build. They
-will draw their own version of this in a week.</a:t>
+              <a:t>The one context slide worth keeping, because it is the part L02 and L03 did not
+show. They have seen that the window is finite and they have read /tokens. They
+have not seen it fill up over a session.
+Walk the two bars. Nothing about the early turn is wrong; the later turn is the
+same prompt after the history has grown, and the thing that stops fitting is
+their own message. Everything above it was spent before they typed.
+The map is charged to this same budget, which on a 4B can be a third of the
+window spent describing files the model then cannot see inside. That is why
+aider-practice turns it down, and why the map is out of scope for the build. Say
+so, so nobody spends week 4 on it.
+Then the bold line, which is the whole reason this slide is still here. Ask what
+they would drop first and what has to survive. Their Stage 1 contract keeps the
+system instructions, the current request and the added file contents, and refuses
+an oversized required input instead of silently trimming it. That refusal is a
+design decision they have to write down and test, and the packet does not make it
+for them.</a:t>
             </a:r>
             <a:endParaRPr lang="en-US" dirty="0"/>
           </a:p>
@@ -729,16 +735,13 @@
           <a:p>
             <a:r>
               <a:rPr lang="en-US" dirty="0"/>
-              <a:t>Do not claim a fixed seven-part ordering. What actually goes into the prompt
-depends on the coder, the model and the settings, and it changes between
-releases. The list above is the shape, not the wire format.
-Ask what the model would need in order to change three files consistently, when
-nothing has told it which three. That question sets up the repo map.
-The /add slide was cut on 2026-09-13 because they have been doing this for two
-weeks. Two things it carried, worth saying if anyone asks rather than putting
-back on the glass: added files can be rewritten while read-only files can only
-be cited, and adding the whole package is not a selection strategy, it is a way
-to spend the budget.</a:t>
+              <a:t>Simplified 2026-09-13 on instructor note: this section was three slides and read
+as confusing, because two of them argued the same point from different angles.
+Two slides now, and they argue in a line: here is the order, here is why that
+order was chosen.
+Open with the one sentence everything else follows from. The model keeps nothing
+between turns. Turn twelve sends everything turn one sent, plus more. That is not
+a limitation to work around, it is the condition their own build runs under.</a:t>
             </a:r>
             <a:endParaRPr lang="en-US" dirty="0"/>
           </a:p>
@@ -826,15 +829,14 @@
           <a:p>
             <a:r>
               <a:rPr lang="en-US" dirty="0"/>
-              <a:t>This is the idea the repo map slides are evidence for, so put it up before them
-rather than after.
-A harness is not mainly a parser or an editor. It is a policy for what to spend
-a finite window on, and every design difference between one tool and the next
-comes back to that policy. Aider's is visible and mostly manual: they add the
-files, it fills the remainder with a ranked guess.
-Their build has this problem on day one and the packet does not solve it for
-them. What gets sent, what gets refused, and what happens when the required
-input alone will not fit are all their decisions to write down.</a:t>
+              <a:t>Three groups rather than a list of seven parts, because the grouping is the point
+and the exact ordinal of each part is not.
+Work the bold line rather than the table. The parts that change every turn were
+deliberately put last. The next slide says what that buys, so put the ordering up
+first and let someone in the room guess why before you explain it.
+Their build assembles this same thing, and the packet asks them to say what goes
+in it and in what order. This slide is the argument that the answer is a design
+decision rather than a detail.</a:t>
             </a:r>
             <a:endParaRPr lang="en-US" dirty="0"/>
           </a:p>
@@ -922,10 +924,25 @@
           <a:p>
             <a:r>
               <a:rPr lang="en-US" dirty="0"/>
-              <a:t>Point at the vertical bars: that is aider quoting source lines. Point at the
-dots: that is everything it decided not to spend tokens on.
-Ask what this is for. The answer is on the next slide: it is aider guessing
-what you would have typed /add for.</a:t>
+              <a:t>Table first, then the three bullets: here is the rule, here is what trips it.
+The rule is not the model remembering. Nothing is remembered between sessions.
+It is the serving layer recognising text it has already processed and picking up
+where it left off, and it holds on the course endpoint as much as on a hosted
+API. A hosted API marks the reuse points explicitly and a local server reuses the
+longest opening it recognises; the rule is identical either way.
+Then the three bullets, all verified in the source, and the third is the one
+nobody guesses. Ask mode is not a smaller code mode: it is a different system
+prompt with the worked examples removed, sitting at the very front, so a quick
+question mid task throws the whole prefix away rather than part of it. Adding a
+file changes both the file block and the map, because files in the chat come out
+of the map. And by default the map is rebuilt from the filenames found in the
+message just typed, so mentioning a file in passing moves it.
+The habit worth giving them: settle the file set before starting, and keep a
+question in its own session. The design lesson worth more: what they put first in
+their own prompt decides what a turn costs.
+If they want dollar figures, quote the provider's current pricing page rather
+than a number from memory. What they will feel on their own machine is the wait
+before the first token, not money.</a:t>
             </a:r>
             <a:endParaRPr lang="en-US" dirty="0"/>
           </a:p>
@@ -968,686 +985,6 @@
 </file>
 
 <file path=ppt/notesSlides/notesSlide14.xml><?xml version="1.0" encoding="utf-8"?>
-<p:notes xmlns:a="http://schemas.openxmlformats.org/drawingml/2006/main" xmlns:r="http://schemas.openxmlformats.org/officeDocument/2006/relationships" xmlns:p="http://schemas.openxmlformats.org/presentationml/2006/main">
-  <p:cSld>
-    <p:spTree>
-      <p:nvGrpSpPr>
-        <p:cNvPr id="1" name=""/>
-        <p:cNvGrpSpPr/>
-        <p:nvPr/>
-      </p:nvGrpSpPr>
-      <p:grpSpPr>
-        <a:xfrm>
-          <a:off x="0" y="0"/>
-          <a:ext cx="0" cy="0"/>
-          <a:chOff x="0" y="0"/>
-          <a:chExt cx="0" cy="0"/>
-        </a:xfrm>
-      </p:grpSpPr>
-      <p:sp>
-        <p:nvSpPr>
-          <p:cNvPr id="2" name="Slide Image Placeholder 1"/>
-          <p:cNvSpPr>
-            <a:spLocks noGrp="1" noRot="1" noChangeAspect="1"/>
-          </p:cNvSpPr>
-          <p:nvPr>
-            <p:ph type="sldImg"/>
-          </p:nvPr>
-        </p:nvSpPr>
-        <p:spPr/>
-      </p:sp>
-      <p:sp>
-        <p:nvSpPr>
-          <p:cNvPr id="3" name="Notes Placeholder 2"/>
-          <p:cNvSpPr>
-            <a:spLocks noGrp="1"/>
-          </p:cNvSpPr>
-          <p:nvPr>
-            <p:ph type="body" idx="1"/>
-          </p:nvPr>
-        </p:nvSpPr>
-        <p:spPr/>
-        <p:txBody>
-          <a:bodyPr/>
-          <a:lstStyle/>
-          <a:p>
-            <a:r>
-              <a:rPr lang="en-US" dirty="0"/>
-              <a:t>Off the slide and worth saying: the ranking is tilted toward files you just
-mentioned, and aider renders down the list until the tokens run out.
-Say the ranking rule plainly: a file that lots of other files depend on scores
-high, because it is probably the one you need to know about.
-The dashed line is the point. It is not "here is your repo," it is "here is as
-much of your repo as fits," and whatever falls under the line is invisible to
-the model. 867 lines of aider to guess what you would have typed /add for.</a:t>
-            </a:r>
-            <a:endParaRPr lang="en-US" dirty="0"/>
-          </a:p>
-        </p:txBody>
-      </p:sp>
-      <p:sp>
-        <p:nvSpPr>
-          <p:cNvPr id="4" name="Slide Number Placeholder 3"/>
-          <p:cNvSpPr>
-            <a:spLocks noGrp="1"/>
-          </p:cNvSpPr>
-          <p:nvPr>
-            <p:ph type="sldNum" sz="quarter" idx="10"/>
-          </p:nvPr>
-        </p:nvSpPr>
-        <p:spPr/>
-        <p:txBody>
-          <a:bodyPr/>
-          <a:lstStyle/>
-          <a:p>
-            <a:fld id="{F7021451-1387-4CA6-816F-3879F97B5CBC}" type="slidenum">
-              <a:rPr lang="en-US"/>
-              <a:t>14</a:t>
-            </a:fld>
-            <a:endParaRPr lang="en-US"/>
-          </a:p>
-        </p:txBody>
-      </p:sp>
-    </p:spTree>
-    <p:extLst>
-      <p:ext uri="{BB962C8B-B14F-4D97-AF65-F5344CB8AC3E}">
-        <p14:creationId xmlns:p14="http://schemas.microsoft.com/office/powerpoint/2010/main" val="1024086991"/>
-      </p:ext>
-    </p:extLst>
-  </p:cSld>
-  <p:clrMapOvr>
-    <a:masterClrMapping/>
-  </p:clrMapOvr>
-</p:notes>
-</file>
-
-<file path=ppt/notesSlides/notesSlide15.xml><?xml version="1.0" encoding="utf-8"?>
-<p:notes xmlns:a="http://schemas.openxmlformats.org/drawingml/2006/main" xmlns:r="http://schemas.openxmlformats.org/officeDocument/2006/relationships" xmlns:p="http://schemas.openxmlformats.org/presentationml/2006/main">
-  <p:cSld>
-    <p:spTree>
-      <p:nvGrpSpPr>
-        <p:cNvPr id="1" name=""/>
-        <p:cNvGrpSpPr/>
-        <p:nvPr/>
-      </p:nvGrpSpPr>
-      <p:grpSpPr>
-        <a:xfrm>
-          <a:off x="0" y="0"/>
-          <a:ext cx="0" cy="0"/>
-          <a:chOff x="0" y="0"/>
-          <a:chExt cx="0" cy="0"/>
-        </a:xfrm>
-      </p:grpSpPr>
-      <p:sp>
-        <p:nvSpPr>
-          <p:cNvPr id="2" name="Slide Image Placeholder 1"/>
-          <p:cNvSpPr>
-            <a:spLocks noGrp="1" noRot="1" noChangeAspect="1"/>
-          </p:cNvSpPr>
-          <p:nvPr>
-            <p:ph type="sldImg"/>
-          </p:nvPr>
-        </p:nvSpPr>
-        <p:spPr/>
-      </p:sp>
-      <p:sp>
-        <p:nvSpPr>
-          <p:cNvPr id="3" name="Notes Placeholder 2"/>
-          <p:cNvSpPr>
-            <a:spLocks noGrp="1"/>
-          </p:cNvSpPr>
-          <p:nvPr>
-            <p:ph type="body" idx="1"/>
-          </p:nvPr>
-        </p:nvSpPr>
-        <p:spPr/>
-        <p:txBody>
-          <a:bodyPr/>
-          <a:lstStyle/>
-          <a:p>
-            <a:r>
-              <a:rPr lang="en-US" dirty="0"/>
-              <a:t>This slide now carries what the separate map-cost slide used to say, because two
-diagrams of the same budget read as two unrelated facts (instructor note
-2026-09-13).
-Walk the two bars. Nothing about the early turn is wrong; the later turn is the
-same prompt after the history has grown, and the thing that stops fitting is
-their own message. Everything above it was spent before they typed.
-The bold line is the map's part in that. It is charged to the same budget as the
-files it was guessing about, which on a 4B can be a third of the window spent
-describing files the model then cannot see inside. That is why aider-practice
-turns it down, and it is why the map is out of scope for the build. Say so, so
-nobody spends week 4 on it.
-Ask what they would drop first and what has to survive. Their Stage 1 contract
-keeps the system instructions, the current request and the added file contents,
-and refuses an oversized required input instead of silently trimming it. That
-refusal is a design decision they have to write down and test.</a:t>
-            </a:r>
-            <a:endParaRPr lang="en-US" dirty="0"/>
-          </a:p>
-        </p:txBody>
-      </p:sp>
-      <p:sp>
-        <p:nvSpPr>
-          <p:cNvPr id="4" name="Slide Number Placeholder 3"/>
-          <p:cNvSpPr>
-            <a:spLocks noGrp="1"/>
-          </p:cNvSpPr>
-          <p:nvPr>
-            <p:ph type="sldNum" sz="quarter" idx="10"/>
-          </p:nvPr>
-        </p:nvSpPr>
-        <p:spPr/>
-        <p:txBody>
-          <a:bodyPr/>
-          <a:lstStyle/>
-          <a:p>
-            <a:fld id="{F7021451-1387-4CA6-816F-3879F97B5CBC}" type="slidenum">
-              <a:rPr lang="en-US"/>
-              <a:t>15</a:t>
-            </a:fld>
-            <a:endParaRPr lang="en-US"/>
-          </a:p>
-        </p:txBody>
-      </p:sp>
-    </p:spTree>
-    <p:extLst>
-      <p:ext uri="{BB962C8B-B14F-4D97-AF65-F5344CB8AC3E}">
-        <p14:creationId xmlns:p14="http://schemas.microsoft.com/office/powerpoint/2010/main" val="1024086991"/>
-      </p:ext>
-    </p:extLst>
-  </p:cSld>
-  <p:clrMapOvr>
-    <a:masterClrMapping/>
-  </p:clrMapOvr>
-</p:notes>
-</file>
-
-<file path=ppt/notesSlides/notesSlide16.xml><?xml version="1.0" encoding="utf-8"?>
-<p:notes xmlns:a="http://schemas.openxmlformats.org/drawingml/2006/main" xmlns:r="http://schemas.openxmlformats.org/officeDocument/2006/relationships" xmlns:p="http://schemas.openxmlformats.org/presentationml/2006/main">
-  <p:cSld>
-    <p:spTree>
-      <p:nvGrpSpPr>
-        <p:cNvPr id="1" name=""/>
-        <p:cNvGrpSpPr/>
-        <p:nvPr/>
-      </p:nvGrpSpPr>
-      <p:grpSpPr>
-        <a:xfrm>
-          <a:off x="0" y="0"/>
-          <a:ext cx="0" cy="0"/>
-          <a:chOff x="0" y="0"/>
-          <a:chExt cx="0" cy="0"/>
-        </a:xfrm>
-      </p:grpSpPr>
-      <p:sp>
-        <p:nvSpPr>
-          <p:cNvPr id="2" name="Slide Image Placeholder 1"/>
-          <p:cNvSpPr>
-            <a:spLocks noGrp="1" noRot="1" noChangeAspect="1"/>
-          </p:cNvSpPr>
-          <p:nvPr>
-            <p:ph type="sldImg"/>
-          </p:nvPr>
-        </p:nvSpPr>
-        <p:spPr/>
-      </p:sp>
-      <p:sp>
-        <p:nvSpPr>
-          <p:cNvPr id="3" name="Notes Placeholder 2"/>
-          <p:cNvSpPr>
-            <a:spLocks noGrp="1"/>
-          </p:cNvSpPr>
-          <p:nvPr>
-            <p:ph type="body" idx="1"/>
-          </p:nvPr>
-        </p:nvSpPr>
-        <p:spPr/>
-        <p:txBody>
-          <a:bodyPr/>
-          <a:lstStyle/>
-          <a:p>
-            <a:r>
-              <a:rPr lang="en-US" dirty="0"/>
-              <a:t>Reworked 2026-09-13: the old version of this section had four slides and two of
-them showed the same seven-part list in different groupings, which is what made
-it read as confusing. It is three slides now and they argue in a line: here is
-the order, here is why the order was chosen, here is what ruins it.
-The one sentence to open with, because everything here follows from it: the
-model keeps nothing between turns. Turn twelve sends everything turn one sent,
-plus more. Every design decision in this section exists because of that.</a:t>
-            </a:r>
-            <a:endParaRPr lang="en-US" dirty="0"/>
-          </a:p>
-        </p:txBody>
-      </p:sp>
-      <p:sp>
-        <p:nvSpPr>
-          <p:cNvPr id="4" name="Slide Number Placeholder 3"/>
-          <p:cNvSpPr>
-            <a:spLocks noGrp="1"/>
-          </p:cNvSpPr>
-          <p:nvPr>
-            <p:ph type="sldNum" sz="quarter" idx="10"/>
-          </p:nvPr>
-        </p:nvSpPr>
-        <p:spPr/>
-        <p:txBody>
-          <a:bodyPr/>
-          <a:lstStyle/>
-          <a:p>
-            <a:fld id="{F7021451-1387-4CA6-816F-3879F97B5CBC}" type="slidenum">
-              <a:rPr lang="en-US"/>
-              <a:t>16</a:t>
-            </a:fld>
-            <a:endParaRPr lang="en-US"/>
-          </a:p>
-        </p:txBody>
-      </p:sp>
-    </p:spTree>
-    <p:extLst>
-      <p:ext uri="{BB962C8B-B14F-4D97-AF65-F5344CB8AC3E}">
-        <p14:creationId xmlns:p14="http://schemas.microsoft.com/office/powerpoint/2010/main" val="1024086991"/>
-      </p:ext>
-    </p:extLst>
-  </p:cSld>
-  <p:clrMapOvr>
-    <a:masterClrMapping/>
-  </p:clrMapOvr>
-</p:notes>
-</file>
-
-<file path=ppt/notesSlides/notesSlide17.xml><?xml version="1.0" encoding="utf-8"?>
-<p:notes xmlns:a="http://schemas.openxmlformats.org/drawingml/2006/main" xmlns:r="http://schemas.openxmlformats.org/officeDocument/2006/relationships" xmlns:p="http://schemas.openxmlformats.org/presentationml/2006/main">
-  <p:cSld>
-    <p:spTree>
-      <p:nvGrpSpPr>
-        <p:cNvPr id="1" name=""/>
-        <p:cNvGrpSpPr/>
-        <p:nvPr/>
-      </p:nvGrpSpPr>
-      <p:grpSpPr>
-        <a:xfrm>
-          <a:off x="0" y="0"/>
-          <a:ext cx="0" cy="0"/>
-          <a:chOff x="0" y="0"/>
-          <a:chExt cx="0" cy="0"/>
-        </a:xfrm>
-      </p:grpSpPr>
-      <p:sp>
-        <p:nvSpPr>
-          <p:cNvPr id="2" name="Slide Image Placeholder 1"/>
-          <p:cNvSpPr>
-            <a:spLocks noGrp="1" noRot="1" noChangeAspect="1"/>
-          </p:cNvSpPr>
-          <p:nvPr>
-            <p:ph type="sldImg"/>
-          </p:nvPr>
-        </p:nvSpPr>
-        <p:spPr/>
-      </p:sp>
-      <p:sp>
-        <p:nvSpPr>
-          <p:cNvPr id="3" name="Notes Placeholder 2"/>
-          <p:cNvSpPr>
-            <a:spLocks noGrp="1"/>
-          </p:cNvSpPr>
-          <p:nvPr>
-            <p:ph type="body" idx="1"/>
-          </p:nvPr>
-        </p:nvSpPr>
-        <p:spPr/>
-        <p:txBody>
-          <a:bodyPr/>
-          <a:lstStyle/>
-          <a:p>
-            <a:r>
-              <a:rPr lang="en-US" dirty="0"/>
-              <a:t>Three groups rather than a numbered list of seven, because the grouping is the
-point and the exact ordinal of each part is not.
-Do not explain why yet. Put it up, say that the order is deliberate and looks
-strange, and let the next slide pay it off. If someone guesses the reason before
-you get there, that is the best outcome available.
-Their build assembles this same thing, and the packet asks them to say what goes
-in it and in what order. This slide is the argument that the answer is a design
-decision rather than a detail.</a:t>
-            </a:r>
-            <a:endParaRPr lang="en-US" dirty="0"/>
-          </a:p>
-        </p:txBody>
-      </p:sp>
-      <p:sp>
-        <p:nvSpPr>
-          <p:cNvPr id="4" name="Slide Number Placeholder 3"/>
-          <p:cNvSpPr>
-            <a:spLocks noGrp="1"/>
-          </p:cNvSpPr>
-          <p:nvPr>
-            <p:ph type="sldNum" sz="quarter" idx="10"/>
-          </p:nvPr>
-        </p:nvSpPr>
-        <p:spPr/>
-        <p:txBody>
-          <a:bodyPr/>
-          <a:lstStyle/>
-          <a:p>
-            <a:fld id="{F7021451-1387-4CA6-816F-3879F97B5CBC}" type="slidenum">
-              <a:rPr lang="en-US"/>
-              <a:t>17</a:t>
-            </a:fld>
-            <a:endParaRPr lang="en-US"/>
-          </a:p>
-        </p:txBody>
-      </p:sp>
-    </p:spTree>
-    <p:extLst>
-      <p:ext uri="{BB962C8B-B14F-4D97-AF65-F5344CB8AC3E}">
-        <p14:creationId xmlns:p14="http://schemas.microsoft.com/office/powerpoint/2010/main" val="1024086991"/>
-      </p:ext>
-    </p:extLst>
-  </p:cSld>
-  <p:clrMapOvr>
-    <a:masterClrMapping/>
-  </p:clrMapOvr>
-</p:notes>
-</file>
-
-<file path=ppt/notesSlides/notesSlide18.xml><?xml version="1.0" encoding="utf-8"?>
-<p:notes xmlns:a="http://schemas.openxmlformats.org/drawingml/2006/main" xmlns:r="http://schemas.openxmlformats.org/officeDocument/2006/relationships" xmlns:p="http://schemas.openxmlformats.org/presentationml/2006/main">
-  <p:cSld>
-    <p:spTree>
-      <p:nvGrpSpPr>
-        <p:cNvPr id="1" name=""/>
-        <p:cNvGrpSpPr/>
-        <p:nvPr/>
-      </p:nvGrpSpPr>
-      <p:grpSpPr>
-        <a:xfrm>
-          <a:off x="0" y="0"/>
-          <a:ext cx="0" cy="0"/>
-          <a:chOff x="0" y="0"/>
-          <a:chExt cx="0" cy="0"/>
-        </a:xfrm>
-      </p:grpSpPr>
-      <p:sp>
-        <p:nvSpPr>
-          <p:cNvPr id="2" name="Slide Image Placeholder 1"/>
-          <p:cNvSpPr>
-            <a:spLocks noGrp="1" noRot="1" noChangeAspect="1"/>
-          </p:cNvSpPr>
-          <p:nvPr>
-            <p:ph type="sldImg"/>
-          </p:nvPr>
-        </p:nvSpPr>
-        <p:spPr/>
-      </p:sp>
-      <p:sp>
-        <p:nvSpPr>
-          <p:cNvPr id="3" name="Notes Placeholder 2"/>
-          <p:cNvSpPr>
-            <a:spLocks noGrp="1"/>
-          </p:cNvSpPr>
-          <p:nvPr>
-            <p:ph type="body" idx="1"/>
-          </p:nvPr>
-        </p:nvSpPr>
-        <p:spPr/>
-        <p:txBody>
-          <a:bodyPr/>
-          <a:lstStyle/>
-          <a:p>
-            <a:r>
-              <a:rPr lang="en-US" dirty="0"/>
-              <a:t>Now the previous slide makes sense. Work the two rows and then point back.
-This is not the model remembering. Nothing is remembered between sessions. It is
-the serving layer recognising text it has already processed and picking up where
-it left off, and it holds on the course endpoint as much as on a hosted API. The
-plumbing differs, a hosted API marks the points explicitly and a local server
-reuses the longest opening it recognises, and the rule is identical either way.
-Then land the bold line against the order slide: the parts that change every
-turn were put at the end so that changing them costs the least. That is a real
-design principle and it is worth more to them than the mechanism itself.
-If they want dollar figures, quote the provider's current pricing page rather
-than a number from memory. What they will feel on their own machine is the
-wait before the first token, not money.</a:t>
-            </a:r>
-            <a:endParaRPr lang="en-US" dirty="0"/>
-          </a:p>
-        </p:txBody>
-      </p:sp>
-      <p:sp>
-        <p:nvSpPr>
-          <p:cNvPr id="4" name="Slide Number Placeholder 3"/>
-          <p:cNvSpPr>
-            <a:spLocks noGrp="1"/>
-          </p:cNvSpPr>
-          <p:nvPr>
-            <p:ph type="sldNum" sz="quarter" idx="10"/>
-          </p:nvPr>
-        </p:nvSpPr>
-        <p:spPr/>
-        <p:txBody>
-          <a:bodyPr/>
-          <a:lstStyle/>
-          <a:p>
-            <a:fld id="{F7021451-1387-4CA6-816F-3879F97B5CBC}" type="slidenum">
-              <a:rPr lang="en-US"/>
-              <a:t>18</a:t>
-            </a:fld>
-            <a:endParaRPr lang="en-US"/>
-          </a:p>
-        </p:txBody>
-      </p:sp>
-    </p:spTree>
-    <p:extLst>
-      <p:ext uri="{BB962C8B-B14F-4D97-AF65-F5344CB8AC3E}">
-        <p14:creationId xmlns:p14="http://schemas.microsoft.com/office/powerpoint/2010/main" val="1024086991"/>
-      </p:ext>
-    </p:extLst>
-  </p:cSld>
-  <p:clrMapOvr>
-    <a:masterClrMapping/>
-  </p:clrMapOvr>
-</p:notes>
-</file>
-
-<file path=ppt/notesSlides/notesSlide19.xml><?xml version="1.0" encoding="utf-8"?>
-<p:notes xmlns:a="http://schemas.openxmlformats.org/drawingml/2006/main" xmlns:r="http://schemas.openxmlformats.org/officeDocument/2006/relationships" xmlns:p="http://schemas.openxmlformats.org/presentationml/2006/main">
-  <p:cSld>
-    <p:spTree>
-      <p:nvGrpSpPr>
-        <p:cNvPr id="1" name=""/>
-        <p:cNvGrpSpPr/>
-        <p:nvPr/>
-      </p:nvGrpSpPr>
-      <p:grpSpPr>
-        <a:xfrm>
-          <a:off x="0" y="0"/>
-          <a:ext cx="0" cy="0"/>
-          <a:chOff x="0" y="0"/>
-          <a:chExt cx="0" cy="0"/>
-        </a:xfrm>
-      </p:grpSpPr>
-      <p:sp>
-        <p:nvSpPr>
-          <p:cNvPr id="2" name="Slide Image Placeholder 1"/>
-          <p:cNvSpPr>
-            <a:spLocks noGrp="1" noRot="1" noChangeAspect="1"/>
-          </p:cNvSpPr>
-          <p:nvPr>
-            <p:ph type="sldImg"/>
-          </p:nvPr>
-        </p:nvSpPr>
-        <p:spPr/>
-      </p:sp>
-      <p:sp>
-        <p:nvSpPr>
-          <p:cNvPr id="3" name="Notes Placeholder 2"/>
-          <p:cNvSpPr>
-            <a:spLocks noGrp="1"/>
-          </p:cNvSpPr>
-          <p:nvPr>
-            <p:ph type="body" idx="1"/>
-          </p:nvPr>
-        </p:nvSpPr>
-        <p:spPr/>
-        <p:txBody>
-          <a:bodyPr/>
-          <a:lstStyle/>
-          <a:p>
-            <a:r>
-              <a:rPr lang="en-US" dirty="0"/>
-              <a:t>Three things, all verified in the source, and the third is the one nobody
-guesses.
-Ask mode is not a smaller code mode. It is a different system prompt with the
-worked examples removed, and it sits at the very front, so flipping between ask
-and code throws the whole prefix away rather than part of it. A quick question
-mid task is not free.
-Adding a file changes the file block and the repo map, because files in the chat
-come out of the map.
-The third: by default the map is rebuilt from the filenames and identifiers
-found in the message just typed. Mention a file in passing and the map moves.
-Aider knows, which is why turning caching on quietly switches the map to a
-stabler refresh mode.
-The habit worth giving them: settle the file set before starting, and keep a
-question in its own session.</a:t>
-            </a:r>
-            <a:endParaRPr lang="en-US" dirty="0"/>
-          </a:p>
-        </p:txBody>
-      </p:sp>
-      <p:sp>
-        <p:nvSpPr>
-          <p:cNvPr id="4" name="Slide Number Placeholder 3"/>
-          <p:cNvSpPr>
-            <a:spLocks noGrp="1"/>
-          </p:cNvSpPr>
-          <p:nvPr>
-            <p:ph type="sldNum" sz="quarter" idx="10"/>
-          </p:nvPr>
-        </p:nvSpPr>
-        <p:spPr/>
-        <p:txBody>
-          <a:bodyPr/>
-          <a:lstStyle/>
-          <a:p>
-            <a:fld id="{F7021451-1387-4CA6-816F-3879F97B5CBC}" type="slidenum">
-              <a:rPr lang="en-US"/>
-              <a:t>19</a:t>
-            </a:fld>
-            <a:endParaRPr lang="en-US"/>
-          </a:p>
-        </p:txBody>
-      </p:sp>
-    </p:spTree>
-    <p:extLst>
-      <p:ext uri="{BB962C8B-B14F-4D97-AF65-F5344CB8AC3E}">
-        <p14:creationId xmlns:p14="http://schemas.microsoft.com/office/powerpoint/2010/main" val="1024086991"/>
-      </p:ext>
-    </p:extLst>
-  </p:cSld>
-  <p:clrMapOvr>
-    <a:masterClrMapping/>
-  </p:clrMapOvr>
-</p:notes>
-</file>
-
-<file path=ppt/notesSlides/notesSlide2.xml><?xml version="1.0" encoding="utf-8"?>
-<p:notes xmlns:a="http://schemas.openxmlformats.org/drawingml/2006/main" xmlns:r="http://schemas.openxmlformats.org/officeDocument/2006/relationships" xmlns:p="http://schemas.openxmlformats.org/presentationml/2006/main">
-  <p:cSld>
-    <p:spTree>
-      <p:nvGrpSpPr>
-        <p:cNvPr id="1" name=""/>
-        <p:cNvGrpSpPr/>
-        <p:nvPr/>
-      </p:nvGrpSpPr>
-      <p:grpSpPr>
-        <a:xfrm>
-          <a:off x="0" y="0"/>
-          <a:ext cx="0" cy="0"/>
-          <a:chOff x="0" y="0"/>
-          <a:chExt cx="0" cy="0"/>
-        </a:xfrm>
-      </p:grpSpPr>
-      <p:sp>
-        <p:nvSpPr>
-          <p:cNvPr id="2" name="Slide Image Placeholder 1"/>
-          <p:cNvSpPr>
-            <a:spLocks noGrp="1" noRot="1" noChangeAspect="1"/>
-          </p:cNvSpPr>
-          <p:nvPr>
-            <p:ph type="sldImg"/>
-          </p:nvPr>
-        </p:nvSpPr>
-        <p:spPr/>
-      </p:sp>
-      <p:sp>
-        <p:nvSpPr>
-          <p:cNvPr id="3" name="Notes Placeholder 2"/>
-          <p:cNvSpPr>
-            <a:spLocks noGrp="1"/>
-          </p:cNvSpPr>
-          <p:nvPr>
-            <p:ph type="body" idx="1"/>
-          </p:nvPr>
-        </p:nvSpPr>
-        <p:spPr/>
-        <p:txBody>
-          <a:bodyPr/>
-          <a:lstStyle/>
-          <a:p>
-            <a:r>
-              <a:rPr lang="en-US" dirty="0"/>
-              <a:t>Put this up while the room settles and leave it up. The agenda is part of the
-first block, not an extra segment in front of it.
-Say out loud that the second half is genuinely office hours: they work, you
-circulate, and nobody hands anything in today. Students who have been told all
-term that labs end in a checkoff will not believe it unless you say it. The
-slide no longer says so, so this is on you to say.
-Do not preview the build past the word itself. The reveal is still yours to
-make in the third section.</a:t>
-            </a:r>
-            <a:endParaRPr lang="en-US" dirty="0"/>
-          </a:p>
-        </p:txBody>
-      </p:sp>
-      <p:sp>
-        <p:nvSpPr>
-          <p:cNvPr id="4" name="Slide Number Placeholder 3"/>
-          <p:cNvSpPr>
-            <a:spLocks noGrp="1"/>
-          </p:cNvSpPr>
-          <p:nvPr>
-            <p:ph type="sldNum" sz="quarter" idx="10"/>
-          </p:nvPr>
-        </p:nvSpPr>
-        <p:spPr/>
-        <p:txBody>
-          <a:bodyPr/>
-          <a:lstStyle/>
-          <a:p>
-            <a:fld id="{F7021451-1387-4CA6-816F-3879F97B5CBC}" type="slidenum">
-              <a:rPr lang="en-US"/>
-              <a:t>2</a:t>
-            </a:fld>
-            <a:endParaRPr lang="en-US"/>
-          </a:p>
-        </p:txBody>
-      </p:sp>
-    </p:spTree>
-    <p:extLst>
-      <p:ext uri="{BB962C8B-B14F-4D97-AF65-F5344CB8AC3E}">
-        <p14:creationId xmlns:p14="http://schemas.microsoft.com/office/powerpoint/2010/main" val="1024086991"/>
-      </p:ext>
-    </p:extLst>
-  </p:cSld>
-  <p:clrMapOvr>
-    <a:masterClrMapping/>
-  </p:clrMapOvr>
-</p:notes>
-</file>
-
-<file path=ppt/notesSlides/notesSlide20.xml><?xml version="1.0" encoding="utf-8"?>
 <p:notes xmlns:a="http://schemas.openxmlformats.org/drawingml/2006/main" xmlns:r="http://schemas.openxmlformats.org/officeDocument/2006/relationships" xmlns:p="http://schemas.openxmlformats.org/presentationml/2006/main">
   <p:cSld>
     <p:spTree>
@@ -1720,7 +1057,7 @@
           <a:p>
             <a:fld id="{F7021451-1387-4CA6-816F-3879F97B5CBC}" type="slidenum">
               <a:rPr lang="en-US"/>
-              <a:t>20</a:t>
+              <a:t>14</a:t>
             </a:fld>
             <a:endParaRPr lang="en-US"/>
           </a:p>
@@ -1739,7 +1076,7 @@
 </p:notes>
 </file>
 
-<file path=ppt/notesSlides/notesSlide21.xml><?xml version="1.0" encoding="utf-8"?>
+<file path=ppt/notesSlides/notesSlide15.xml><?xml version="1.0" encoding="utf-8"?>
 <p:notes xmlns:a="http://schemas.openxmlformats.org/drawingml/2006/main" xmlns:r="http://schemas.openxmlformats.org/officeDocument/2006/relationships" xmlns:p="http://schemas.openxmlformats.org/presentationml/2006/main">
   <p:cSld>
     <p:spTree>
@@ -1816,7 +1153,7 @@
           <a:p>
             <a:fld id="{F7021451-1387-4CA6-816F-3879F97B5CBC}" type="slidenum">
               <a:rPr lang="en-US"/>
-              <a:t>21</a:t>
+              <a:t>15</a:t>
             </a:fld>
             <a:endParaRPr lang="en-US"/>
           </a:p>
@@ -1835,7 +1172,7 @@
 </p:notes>
 </file>
 
-<file path=ppt/notesSlides/notesSlide22.xml><?xml version="1.0" encoding="utf-8"?>
+<file path=ppt/notesSlides/notesSlide16.xml><?xml version="1.0" encoding="utf-8"?>
 <p:notes xmlns:a="http://schemas.openxmlformats.org/drawingml/2006/main" xmlns:r="http://schemas.openxmlformats.org/officeDocument/2006/relationships" xmlns:p="http://schemas.openxmlformats.org/presentationml/2006/main">
   <p:cSld>
     <p:spTree>
@@ -1913,7 +1250,7 @@
           <a:p>
             <a:fld id="{F7021451-1387-4CA6-816F-3879F97B5CBC}" type="slidenum">
               <a:rPr lang="en-US"/>
-              <a:t>22</a:t>
+              <a:t>16</a:t>
             </a:fld>
             <a:endParaRPr lang="en-US"/>
           </a:p>
@@ -1932,7 +1269,7 @@
 </p:notes>
 </file>
 
-<file path=ppt/notesSlides/notesSlide23.xml><?xml version="1.0" encoding="utf-8"?>
+<file path=ppt/notesSlides/notesSlide17.xml><?xml version="1.0" encoding="utf-8"?>
 <p:notes xmlns:a="http://schemas.openxmlformats.org/drawingml/2006/main" xmlns:r="http://schemas.openxmlformats.org/officeDocument/2006/relationships" xmlns:p="http://schemas.openxmlformats.org/presentationml/2006/main">
   <p:cSld>
     <p:spTree>
@@ -2009,7 +1346,7 @@
           <a:p>
             <a:fld id="{F7021451-1387-4CA6-816F-3879F97B5CBC}" type="slidenum">
               <a:rPr lang="en-US"/>
-              <a:t>23</a:t>
+              <a:t>17</a:t>
             </a:fld>
             <a:endParaRPr lang="en-US"/>
           </a:p>
@@ -2028,7 +1365,7 @@
 </p:notes>
 </file>
 
-<file path=ppt/notesSlides/notesSlide24.xml><?xml version="1.0" encoding="utf-8"?>
+<file path=ppt/notesSlides/notesSlide18.xml><?xml version="1.0" encoding="utf-8"?>
 <p:notes xmlns:a="http://schemas.openxmlformats.org/drawingml/2006/main" xmlns:r="http://schemas.openxmlformats.org/officeDocument/2006/relationships" xmlns:p="http://schemas.openxmlformats.org/presentationml/2006/main">
   <p:cSld>
     <p:spTree>
@@ -2107,7 +1444,7 @@
           <a:p>
             <a:fld id="{F7021451-1387-4CA6-816F-3879F97B5CBC}" type="slidenum">
               <a:rPr lang="en-US"/>
-              <a:t>24</a:t>
+              <a:t>18</a:t>
             </a:fld>
             <a:endParaRPr lang="en-US"/>
           </a:p>
@@ -2126,7 +1463,7 @@
 </p:notes>
 </file>
 
-<file path=ppt/notesSlides/notesSlide25.xml><?xml version="1.0" encoding="utf-8"?>
+<file path=ppt/notesSlides/notesSlide19.xml><?xml version="1.0" encoding="utf-8"?>
 <p:notes xmlns:a="http://schemas.openxmlformats.org/drawingml/2006/main" xmlns:r="http://schemas.openxmlformats.org/officeDocument/2006/relationships" xmlns:p="http://schemas.openxmlformats.org/presentationml/2006/main">
   <p:cSld>
     <p:spTree>
@@ -2205,7 +1542,7 @@
           <a:p>
             <a:fld id="{F7021451-1387-4CA6-816F-3879F97B5CBC}" type="slidenum">
               <a:rPr lang="en-US"/>
-              <a:t>25</a:t>
+              <a:t>19</a:t>
             </a:fld>
             <a:endParaRPr lang="en-US"/>
           </a:p>
@@ -2224,7 +1561,102 @@
 </p:notes>
 </file>
 
-<file path=ppt/notesSlides/notesSlide26.xml><?xml version="1.0" encoding="utf-8"?>
+<file path=ppt/notesSlides/notesSlide2.xml><?xml version="1.0" encoding="utf-8"?>
+<p:notes xmlns:a="http://schemas.openxmlformats.org/drawingml/2006/main" xmlns:r="http://schemas.openxmlformats.org/officeDocument/2006/relationships" xmlns:p="http://schemas.openxmlformats.org/presentationml/2006/main">
+  <p:cSld>
+    <p:spTree>
+      <p:nvGrpSpPr>
+        <p:cNvPr id="1" name=""/>
+        <p:cNvGrpSpPr/>
+        <p:nvPr/>
+      </p:nvGrpSpPr>
+      <p:grpSpPr>
+        <a:xfrm>
+          <a:off x="0" y="0"/>
+          <a:ext cx="0" cy="0"/>
+          <a:chOff x="0" y="0"/>
+          <a:chExt cx="0" cy="0"/>
+        </a:xfrm>
+      </p:grpSpPr>
+      <p:sp>
+        <p:nvSpPr>
+          <p:cNvPr id="2" name="Slide Image Placeholder 1"/>
+          <p:cNvSpPr>
+            <a:spLocks noGrp="1" noRot="1" noChangeAspect="1"/>
+          </p:cNvSpPr>
+          <p:nvPr>
+            <p:ph type="sldImg"/>
+          </p:nvPr>
+        </p:nvSpPr>
+        <p:spPr/>
+      </p:sp>
+      <p:sp>
+        <p:nvSpPr>
+          <p:cNvPr id="3" name="Notes Placeholder 2"/>
+          <p:cNvSpPr>
+            <a:spLocks noGrp="1"/>
+          </p:cNvSpPr>
+          <p:nvPr>
+            <p:ph type="body" idx="1"/>
+          </p:nvPr>
+        </p:nvSpPr>
+        <p:spPr/>
+        <p:txBody>
+          <a:bodyPr/>
+          <a:lstStyle/>
+          <a:p>
+            <a:r>
+              <a:rPr lang="en-US" dirty="0"/>
+              <a:t>Put this up while the room settles and leave it up. The agenda is part of the
+first block, not an extra segment in front of it.
+Say out loud that the second half is genuinely office hours: they work, you
+circulate, and nobody hands anything in today. Students who have been told all
+term that labs end in a checkoff will not believe it unless you say it. The
+slide no longer says so, so this is on you to say.
+Do not preview the build past the word itself. The reveal is still yours to
+make in the third section.</a:t>
+            </a:r>
+            <a:endParaRPr lang="en-US" dirty="0"/>
+          </a:p>
+        </p:txBody>
+      </p:sp>
+      <p:sp>
+        <p:nvSpPr>
+          <p:cNvPr id="4" name="Slide Number Placeholder 3"/>
+          <p:cNvSpPr>
+            <a:spLocks noGrp="1"/>
+          </p:cNvSpPr>
+          <p:nvPr>
+            <p:ph type="sldNum" sz="quarter" idx="10"/>
+          </p:nvPr>
+        </p:nvSpPr>
+        <p:spPr/>
+        <p:txBody>
+          <a:bodyPr/>
+          <a:lstStyle/>
+          <a:p>
+            <a:fld id="{F7021451-1387-4CA6-816F-3879F97B5CBC}" type="slidenum">
+              <a:rPr lang="en-US"/>
+              <a:t>2</a:t>
+            </a:fld>
+            <a:endParaRPr lang="en-US"/>
+          </a:p>
+        </p:txBody>
+      </p:sp>
+    </p:spTree>
+    <p:extLst>
+      <p:ext uri="{BB962C8B-B14F-4D97-AF65-F5344CB8AC3E}">
+        <p14:creationId xmlns:p14="http://schemas.microsoft.com/office/powerpoint/2010/main" val="1024086991"/>
+      </p:ext>
+    </p:extLst>
+  </p:cSld>
+  <p:clrMapOvr>
+    <a:masterClrMapping/>
+  </p:clrMapOvr>
+</p:notes>
+</file>
+
+<file path=ppt/notesSlides/notesSlide20.xml><?xml version="1.0" encoding="utf-8"?>
 <p:notes xmlns:a="http://schemas.openxmlformats.org/drawingml/2006/main" xmlns:r="http://schemas.openxmlformats.org/officeDocument/2006/relationships" xmlns:p="http://schemas.openxmlformats.org/presentationml/2006/main">
   <p:cSld>
     <p:spTree>
@@ -2298,7 +1730,7 @@
           <a:p>
             <a:fld id="{F7021451-1387-4CA6-816F-3879F97B5CBC}" type="slidenum">
               <a:rPr lang="en-US"/>
-              <a:t>26</a:t>
+              <a:t>20</a:t>
             </a:fld>
             <a:endParaRPr lang="en-US"/>
           </a:p>
@@ -2317,7 +1749,7 @@
 </p:notes>
 </file>
 
-<file path=ppt/notesSlides/notesSlide27.xml><?xml version="1.0" encoding="utf-8"?>
+<file path=ppt/notesSlides/notesSlide21.xml><?xml version="1.0" encoding="utf-8"?>
 <p:notes xmlns:a="http://schemas.openxmlformats.org/drawingml/2006/main" xmlns:r="http://schemas.openxmlformats.org/officeDocument/2006/relationships" xmlns:p="http://schemas.openxmlformats.org/presentationml/2006/main">
   <p:cSld>
     <p:spTree>
@@ -2405,7 +1837,7 @@
           <a:p>
             <a:fld id="{F7021451-1387-4CA6-816F-3879F97B5CBC}" type="slidenum">
               <a:rPr lang="en-US"/>
-              <a:t>27</a:t>
+              <a:t>21</a:t>
             </a:fld>
             <a:endParaRPr lang="en-US"/>
           </a:p>
@@ -2424,7 +1856,7 @@
 </p:notes>
 </file>
 
-<file path=ppt/notesSlides/notesSlide28.xml><?xml version="1.0" encoding="utf-8"?>
+<file path=ppt/notesSlides/notesSlide22.xml><?xml version="1.0" encoding="utf-8"?>
 <p:notes xmlns:a="http://schemas.openxmlformats.org/drawingml/2006/main" xmlns:r="http://schemas.openxmlformats.org/officeDocument/2006/relationships" xmlns:p="http://schemas.openxmlformats.org/presentationml/2006/main">
   <p:cSld>
     <p:spTree>
@@ -2496,7 +1928,7 @@
           <a:p>
             <a:fld id="{F7021451-1387-4CA6-816F-3879F97B5CBC}" type="slidenum">
               <a:rPr lang="en-US"/>
-              <a:t>28</a:t>
+              <a:t>22</a:t>
             </a:fld>
             <a:endParaRPr lang="en-US"/>
           </a:p>
@@ -2515,7 +1947,7 @@
 </p:notes>
 </file>
 
-<file path=ppt/notesSlides/notesSlide29.xml><?xml version="1.0" encoding="utf-8"?>
+<file path=ppt/notesSlides/notesSlide23.xml><?xml version="1.0" encoding="utf-8"?>
 <p:notes xmlns:a="http://schemas.openxmlformats.org/drawingml/2006/main" xmlns:r="http://schemas.openxmlformats.org/officeDocument/2006/relationships" xmlns:p="http://schemas.openxmlformats.org/presentationml/2006/main">
   <p:cSld>
     <p:spTree>
@@ -2592,7 +2024,7 @@
           <a:p>
             <a:fld id="{F7021451-1387-4CA6-816F-3879F97B5CBC}" type="slidenum">
               <a:rPr lang="en-US"/>
-              <a:t>29</a:t>
+              <a:t>23</a:t>
             </a:fld>
             <a:endParaRPr lang="en-US"/>
           </a:p>
@@ -2611,102 +2043,7 @@
 </p:notes>
 </file>
 
-<file path=ppt/notesSlides/notesSlide3.xml><?xml version="1.0" encoding="utf-8"?>
-<p:notes xmlns:a="http://schemas.openxmlformats.org/drawingml/2006/main" xmlns:r="http://schemas.openxmlformats.org/officeDocument/2006/relationships" xmlns:p="http://schemas.openxmlformats.org/presentationml/2006/main">
-  <p:cSld>
-    <p:spTree>
-      <p:nvGrpSpPr>
-        <p:cNvPr id="1" name=""/>
-        <p:cNvGrpSpPr/>
-        <p:nvPr/>
-      </p:nvGrpSpPr>
-      <p:grpSpPr>
-        <a:xfrm>
-          <a:off x="0" y="0"/>
-          <a:ext cx="0" cy="0"/>
-          <a:chOff x="0" y="0"/>
-          <a:chExt cx="0" cy="0"/>
-        </a:xfrm>
-      </p:grpSpPr>
-      <p:sp>
-        <p:nvSpPr>
-          <p:cNvPr id="2" name="Slide Image Placeholder 1"/>
-          <p:cNvSpPr>
-            <a:spLocks noGrp="1" noRot="1" noChangeAspect="1"/>
-          </p:cNvSpPr>
-          <p:nvPr>
-            <p:ph type="sldImg"/>
-          </p:nvPr>
-        </p:nvSpPr>
-        <p:spPr/>
-      </p:sp>
-      <p:sp>
-        <p:nvSpPr>
-          <p:cNvPr id="3" name="Notes Placeholder 2"/>
-          <p:cNvSpPr>
-            <a:spLocks noGrp="1"/>
-          </p:cNvSpPr>
-          <p:nvPr>
-            <p:ph type="body" idx="1"/>
-          </p:nvPr>
-        </p:nvSpPr>
-        <p:spPr/>
-        <p:txBody>
-          <a:bodyPr/>
-          <a:lstStyle/>
-          <a:p>
-            <a:r>
-              <a:rPr lang="en-US" dirty="0"/>
-              <a:t>This is the slide the deck was missing. Sixteen practice lessons gave them the
-muscle memory and none of the model, and the word "harness" is the one they
-need, because it is the thing they build in Stage 1 and extend in Analyze.
-Say the right-hand column out loud. The model's entire contribution is one
-block of text. Every effect on their machine is the left column acting on it.
-If anyone asks about models, endpoints or config: MODEL-POLICY.md, and it is
-not today's subject. qwen3.5:9b recommended, 4B permitted, any compatible
-endpoint.</a:t>
-            </a:r>
-            <a:endParaRPr lang="en-US" dirty="0"/>
-          </a:p>
-        </p:txBody>
-      </p:sp>
-      <p:sp>
-        <p:nvSpPr>
-          <p:cNvPr id="4" name="Slide Number Placeholder 3"/>
-          <p:cNvSpPr>
-            <a:spLocks noGrp="1"/>
-          </p:cNvSpPr>
-          <p:nvPr>
-            <p:ph type="sldNum" sz="quarter" idx="10"/>
-          </p:nvPr>
-        </p:nvSpPr>
-        <p:spPr/>
-        <p:txBody>
-          <a:bodyPr/>
-          <a:lstStyle/>
-          <a:p>
-            <a:fld id="{F7021451-1387-4CA6-816F-3879F97B5CBC}" type="slidenum">
-              <a:rPr lang="en-US"/>
-              <a:t>3</a:t>
-            </a:fld>
-            <a:endParaRPr lang="en-US"/>
-          </a:p>
-        </p:txBody>
-      </p:sp>
-    </p:spTree>
-    <p:extLst>
-      <p:ext uri="{BB962C8B-B14F-4D97-AF65-F5344CB8AC3E}">
-        <p14:creationId xmlns:p14="http://schemas.microsoft.com/office/powerpoint/2010/main" val="1024086991"/>
-      </p:ext>
-    </p:extLst>
-  </p:cSld>
-  <p:clrMapOvr>
-    <a:masterClrMapping/>
-  </p:clrMapOvr>
-</p:notes>
-</file>
-
-<file path=ppt/notesSlides/notesSlide30.xml><?xml version="1.0" encoding="utf-8"?>
+<file path=ppt/notesSlides/notesSlide24.xml><?xml version="1.0" encoding="utf-8"?>
 <p:notes xmlns:a="http://schemas.openxmlformats.org/drawingml/2006/main" xmlns:r="http://schemas.openxmlformats.org/officeDocument/2006/relationships" xmlns:p="http://schemas.openxmlformats.org/presentationml/2006/main">
   <p:cSld>
     <p:spTree>
@@ -2786,7 +2123,7 @@
           <a:p>
             <a:fld id="{F7021451-1387-4CA6-816F-3879F97B5CBC}" type="slidenum">
               <a:rPr lang="en-US"/>
-              <a:t>30</a:t>
+              <a:t>24</a:t>
             </a:fld>
             <a:endParaRPr lang="en-US"/>
           </a:p>
@@ -2805,7 +2142,7 @@
 </p:notes>
 </file>
 
-<file path=ppt/notesSlides/notesSlide31.xml><?xml version="1.0" encoding="utf-8"?>
+<file path=ppt/notesSlides/notesSlide25.xml><?xml version="1.0" encoding="utf-8"?>
 <p:notes xmlns:a="http://schemas.openxmlformats.org/drawingml/2006/main" xmlns:r="http://schemas.openxmlformats.org/officeDocument/2006/relationships" xmlns:p="http://schemas.openxmlformats.org/presentationml/2006/main">
   <p:cSld>
     <p:spTree>
@@ -2879,7 +2216,7 @@
           <a:p>
             <a:fld id="{F7021451-1387-4CA6-816F-3879F97B5CBC}" type="slidenum">
               <a:rPr lang="en-US"/>
-              <a:t>31</a:t>
+              <a:t>25</a:t>
             </a:fld>
             <a:endParaRPr lang="en-US"/>
           </a:p>
@@ -2898,7 +2235,7 @@
 </p:notes>
 </file>
 
-<file path=ppt/notesSlides/notesSlide32.xml><?xml version="1.0" encoding="utf-8"?>
+<file path=ppt/notesSlides/notesSlide26.xml><?xml version="1.0" encoding="utf-8"?>
 <p:notes xmlns:a="http://schemas.openxmlformats.org/drawingml/2006/main" xmlns:r="http://schemas.openxmlformats.org/officeDocument/2006/relationships" xmlns:p="http://schemas.openxmlformats.org/presentationml/2006/main">
   <p:cSld>
     <p:spTree>
@@ -2974,7 +2311,7 @@
           <a:p>
             <a:fld id="{F7021451-1387-4CA6-816F-3879F97B5CBC}" type="slidenum">
               <a:rPr lang="en-US"/>
-              <a:t>32</a:t>
+              <a:t>26</a:t>
             </a:fld>
             <a:endParaRPr lang="en-US"/>
           </a:p>
@@ -2993,7 +2330,7 @@
 </p:notes>
 </file>
 
-<file path=ppt/notesSlides/notesSlide33.xml><?xml version="1.0" encoding="utf-8"?>
+<file path=ppt/notesSlides/notesSlide27.xml><?xml version="1.0" encoding="utf-8"?>
 <p:notes xmlns:a="http://schemas.openxmlformats.org/drawingml/2006/main" xmlns:r="http://schemas.openxmlformats.org/officeDocument/2006/relationships" xmlns:p="http://schemas.openxmlformats.org/presentationml/2006/main">
   <p:cSld>
     <p:spTree>
@@ -3077,7 +2414,7 @@
           <a:p>
             <a:fld id="{F7021451-1387-4CA6-816F-3879F97B5CBC}" type="slidenum">
               <a:rPr lang="en-US"/>
-              <a:t>33</a:t>
+              <a:t>27</a:t>
             </a:fld>
             <a:endParaRPr lang="en-US"/>
           </a:p>
@@ -3096,7 +2433,7 @@
 </p:notes>
 </file>
 
-<file path=ppt/notesSlides/notesSlide34.xml><?xml version="1.0" encoding="utf-8"?>
+<file path=ppt/notesSlides/notesSlide28.xml><?xml version="1.0" encoding="utf-8"?>
 <p:notes xmlns:a="http://schemas.openxmlformats.org/drawingml/2006/main" xmlns:r="http://schemas.openxmlformats.org/officeDocument/2006/relationships" xmlns:p="http://schemas.openxmlformats.org/presentationml/2006/main">
   <p:cSld>
     <p:spTree>
@@ -3170,7 +2507,7 @@
           <a:p>
             <a:fld id="{F7021451-1387-4CA6-816F-3879F97B5CBC}" type="slidenum">
               <a:rPr lang="en-US"/>
-              <a:t>34</a:t>
+              <a:t>28</a:t>
             </a:fld>
             <a:endParaRPr lang="en-US"/>
           </a:p>
@@ -3189,7 +2526,7 @@
 </p:notes>
 </file>
 
-<file path=ppt/notesSlides/notesSlide35.xml><?xml version="1.0" encoding="utf-8"?>
+<file path=ppt/notesSlides/notesSlide29.xml><?xml version="1.0" encoding="utf-8"?>
 <p:notes xmlns:a="http://schemas.openxmlformats.org/drawingml/2006/main" xmlns:r="http://schemas.openxmlformats.org/officeDocument/2006/relationships" xmlns:p="http://schemas.openxmlformats.org/presentationml/2006/main">
   <p:cSld>
     <p:spTree>
@@ -3262,7 +2599,7 @@
           <a:p>
             <a:fld id="{F7021451-1387-4CA6-816F-3879F97B5CBC}" type="slidenum">
               <a:rPr lang="en-US"/>
-              <a:t>35</a:t>
+              <a:t>29</a:t>
             </a:fld>
             <a:endParaRPr lang="en-US"/>
           </a:p>
@@ -3281,7 +2618,102 @@
 </p:notes>
 </file>
 
-<file path=ppt/notesSlides/notesSlide36.xml><?xml version="1.0" encoding="utf-8"?>
+<file path=ppt/notesSlides/notesSlide3.xml><?xml version="1.0" encoding="utf-8"?>
+<p:notes xmlns:a="http://schemas.openxmlformats.org/drawingml/2006/main" xmlns:r="http://schemas.openxmlformats.org/officeDocument/2006/relationships" xmlns:p="http://schemas.openxmlformats.org/presentationml/2006/main">
+  <p:cSld>
+    <p:spTree>
+      <p:nvGrpSpPr>
+        <p:cNvPr id="1" name=""/>
+        <p:cNvGrpSpPr/>
+        <p:nvPr/>
+      </p:nvGrpSpPr>
+      <p:grpSpPr>
+        <a:xfrm>
+          <a:off x="0" y="0"/>
+          <a:ext cx="0" cy="0"/>
+          <a:chOff x="0" y="0"/>
+          <a:chExt cx="0" cy="0"/>
+        </a:xfrm>
+      </p:grpSpPr>
+      <p:sp>
+        <p:nvSpPr>
+          <p:cNvPr id="2" name="Slide Image Placeholder 1"/>
+          <p:cNvSpPr>
+            <a:spLocks noGrp="1" noRot="1" noChangeAspect="1"/>
+          </p:cNvSpPr>
+          <p:nvPr>
+            <p:ph type="sldImg"/>
+          </p:nvPr>
+        </p:nvSpPr>
+        <p:spPr/>
+      </p:sp>
+      <p:sp>
+        <p:nvSpPr>
+          <p:cNvPr id="3" name="Notes Placeholder 2"/>
+          <p:cNvSpPr>
+            <a:spLocks noGrp="1"/>
+          </p:cNvSpPr>
+          <p:nvPr>
+            <p:ph type="body" idx="1"/>
+          </p:nvPr>
+        </p:nvSpPr>
+        <p:spPr/>
+        <p:txBody>
+          <a:bodyPr/>
+          <a:lstStyle/>
+          <a:p>
+            <a:r>
+              <a:rPr lang="en-US" dirty="0"/>
+              <a:t>This is the slide the deck was missing. Sixteen practice lessons gave them the
+muscle memory and none of the model, and the word "harness" is the one they
+need, because it is the thing they build in Stage 1 and extend in Analyze.
+Say the right-hand column out loud. The model's entire contribution is one
+block of text. Every effect on their machine is the left column acting on it.
+If anyone asks about models, endpoints or config: MODEL-POLICY.md, and it is
+not today's subject. qwen3.5:9b recommended, 4B permitted, any compatible
+endpoint.</a:t>
+            </a:r>
+            <a:endParaRPr lang="en-US" dirty="0"/>
+          </a:p>
+        </p:txBody>
+      </p:sp>
+      <p:sp>
+        <p:nvSpPr>
+          <p:cNvPr id="4" name="Slide Number Placeholder 3"/>
+          <p:cNvSpPr>
+            <a:spLocks noGrp="1"/>
+          </p:cNvSpPr>
+          <p:nvPr>
+            <p:ph type="sldNum" sz="quarter" idx="10"/>
+          </p:nvPr>
+        </p:nvSpPr>
+        <p:spPr/>
+        <p:txBody>
+          <a:bodyPr/>
+          <a:lstStyle/>
+          <a:p>
+            <a:fld id="{F7021451-1387-4CA6-816F-3879F97B5CBC}" type="slidenum">
+              <a:rPr lang="en-US"/>
+              <a:t>3</a:t>
+            </a:fld>
+            <a:endParaRPr lang="en-US"/>
+          </a:p>
+        </p:txBody>
+      </p:sp>
+    </p:spTree>
+    <p:extLst>
+      <p:ext uri="{BB962C8B-B14F-4D97-AF65-F5344CB8AC3E}">
+        <p14:creationId xmlns:p14="http://schemas.microsoft.com/office/powerpoint/2010/main" val="1024086991"/>
+      </p:ext>
+    </p:extLst>
+  </p:cSld>
+  <p:clrMapOvr>
+    <a:masterClrMapping/>
+  </p:clrMapOvr>
+</p:notes>
+</file>
+
+<file path=ppt/notesSlides/notesSlide30.xml><?xml version="1.0" encoding="utf-8"?>
 <p:notes xmlns:a="http://schemas.openxmlformats.org/drawingml/2006/main" xmlns:r="http://schemas.openxmlformats.org/officeDocument/2006/relationships" xmlns:p="http://schemas.openxmlformats.org/presentationml/2006/main">
   <p:cSld>
     <p:spTree>
@@ -3357,7 +2789,7 @@
           <a:p>
             <a:fld id="{F7021451-1387-4CA6-816F-3879F97B5CBC}" type="slidenum">
               <a:rPr lang="en-US"/>
-              <a:t>36</a:t>
+              <a:t>30</a:t>
             </a:fld>
             <a:endParaRPr lang="en-US"/>
           </a:p>
@@ -3376,7 +2808,7 @@
 </p:notes>
 </file>
 
-<file path=ppt/notesSlides/notesSlide37.xml><?xml version="1.0" encoding="utf-8"?>
+<file path=ppt/notesSlides/notesSlide31.xml><?xml version="1.0" encoding="utf-8"?>
 <p:notes xmlns:a="http://schemas.openxmlformats.org/drawingml/2006/main" xmlns:r="http://schemas.openxmlformats.org/officeDocument/2006/relationships" xmlns:p="http://schemas.openxmlformats.org/presentationml/2006/main">
   <p:cSld>
     <p:spTree>
@@ -3452,7 +2884,7 @@
           <a:p>
             <a:fld id="{F7021451-1387-4CA6-816F-3879F97B5CBC}" type="slidenum">
               <a:rPr lang="en-US"/>
-              <a:t>37</a:t>
+              <a:t>31</a:t>
             </a:fld>
             <a:endParaRPr lang="en-US"/>
           </a:p>
@@ -3471,7 +2903,7 @@
 </p:notes>
 </file>
 
-<file path=ppt/notesSlides/notesSlide38.xml><?xml version="1.0" encoding="utf-8"?>
+<file path=ppt/notesSlides/notesSlide32.xml><?xml version="1.0" encoding="utf-8"?>
 <p:notes xmlns:a="http://schemas.openxmlformats.org/drawingml/2006/main" xmlns:r="http://schemas.openxmlformats.org/officeDocument/2006/relationships" xmlns:p="http://schemas.openxmlformats.org/presentationml/2006/main">
   <p:cSld>
     <p:spTree>
@@ -3549,7 +2981,7 @@
           <a:p>
             <a:fld id="{F7021451-1387-4CA6-816F-3879F97B5CBC}" type="slidenum">
               <a:rPr lang="en-US"/>
-              <a:t>38</a:t>
+              <a:t>32</a:t>
             </a:fld>
             <a:endParaRPr lang="en-US"/>
           </a:p>
@@ -3568,7 +3000,7 @@
 </p:notes>
 </file>
 
-<file path=ppt/notesSlides/notesSlide39.xml><?xml version="1.0" encoding="utf-8"?>
+<file path=ppt/notesSlides/notesSlide33.xml><?xml version="1.0" encoding="utf-8"?>
 <p:notes xmlns:a="http://schemas.openxmlformats.org/drawingml/2006/main" xmlns:r="http://schemas.openxmlformats.org/officeDocument/2006/relationships" xmlns:p="http://schemas.openxmlformats.org/presentationml/2006/main">
   <p:cSld>
     <p:spTree>
@@ -3649,7 +3081,7 @@
           <a:p>
             <a:fld id="{F7021451-1387-4CA6-816F-3879F97B5CBC}" type="slidenum">
               <a:rPr lang="en-US"/>
-              <a:t>39</a:t>
+              <a:t>33</a:t>
             </a:fld>
             <a:endParaRPr lang="en-US"/>
           </a:p>
@@ -3668,103 +3100,7 @@
 </p:notes>
 </file>
 
-<file path=ppt/notesSlides/notesSlide4.xml><?xml version="1.0" encoding="utf-8"?>
-<p:notes xmlns:a="http://schemas.openxmlformats.org/drawingml/2006/main" xmlns:r="http://schemas.openxmlformats.org/officeDocument/2006/relationships" xmlns:p="http://schemas.openxmlformats.org/presentationml/2006/main">
-  <p:cSld>
-    <p:spTree>
-      <p:nvGrpSpPr>
-        <p:cNvPr id="1" name=""/>
-        <p:cNvGrpSpPr/>
-        <p:nvPr/>
-      </p:nvGrpSpPr>
-      <p:grpSpPr>
-        <a:xfrm>
-          <a:off x="0" y="0"/>
-          <a:ext cx="0" cy="0"/>
-          <a:chOff x="0" y="0"/>
-          <a:chExt cx="0" cy="0"/>
-        </a:xfrm>
-      </p:grpSpPr>
-      <p:sp>
-        <p:nvSpPr>
-          <p:cNvPr id="2" name="Slide Image Placeholder 1"/>
-          <p:cNvSpPr>
-            <a:spLocks noGrp="1" noRot="1" noChangeAspect="1"/>
-          </p:cNvSpPr>
-          <p:nvPr>
-            <p:ph type="sldImg"/>
-          </p:nvPr>
-        </p:nvSpPr>
-        <p:spPr/>
-      </p:sp>
-      <p:sp>
-        <p:nvSpPr>
-          <p:cNvPr id="3" name="Notes Placeholder 2"/>
-          <p:cNvSpPr>
-            <a:spLocks noGrp="1"/>
-          </p:cNvSpPr>
-          <p:nvPr>
-            <p:ph type="body" idx="1"/>
-          </p:nvPr>
-        </p:nvSpPr>
-        <p:spPr/>
-        <p:txBody>
-          <a:bodyPr/>
-          <a:lstStyle/>
-          <a:p>
-            <a:r>
-              <a:rPr lang="en-US" dirty="0"/>
-              <a:t>Three negatives, and each one is a design decision somebody made rather than a
-limitation of the model.
-The third is the one that surprises people: there is no memory between
-sessions. Continuity is the harness resending the history, which is why
-history spends their token budget later in the deck.
-The 4B and the 9B are asked for different reply shapes, whole files against
-diffs. That is why a classmate's session looks different from theirs, and why
-the trace they see later may not match what they ran in practice.
-Worth saying here, not worth a slide.</a:t>
-            </a:r>
-            <a:endParaRPr lang="en-US" dirty="0"/>
-          </a:p>
-        </p:txBody>
-      </p:sp>
-      <p:sp>
-        <p:nvSpPr>
-          <p:cNvPr id="4" name="Slide Number Placeholder 3"/>
-          <p:cNvSpPr>
-            <a:spLocks noGrp="1"/>
-          </p:cNvSpPr>
-          <p:nvPr>
-            <p:ph type="sldNum" sz="quarter" idx="10"/>
-          </p:nvPr>
-        </p:nvSpPr>
-        <p:spPr/>
-        <p:txBody>
-          <a:bodyPr/>
-          <a:lstStyle/>
-          <a:p>
-            <a:fld id="{F7021451-1387-4CA6-816F-3879F97B5CBC}" type="slidenum">
-              <a:rPr lang="en-US"/>
-              <a:t>4</a:t>
-            </a:fld>
-            <a:endParaRPr lang="en-US"/>
-          </a:p>
-        </p:txBody>
-      </p:sp>
-    </p:spTree>
-    <p:extLst>
-      <p:ext uri="{BB962C8B-B14F-4D97-AF65-F5344CB8AC3E}">
-        <p14:creationId xmlns:p14="http://schemas.microsoft.com/office/powerpoint/2010/main" val="1024086991"/>
-      </p:ext>
-    </p:extLst>
-  </p:cSld>
-  <p:clrMapOvr>
-    <a:masterClrMapping/>
-  </p:clrMapOvr>
-</p:notes>
-</file>
-
-<file path=ppt/notesSlides/notesSlide40.xml><?xml version="1.0" encoding="utf-8"?>
+<file path=ppt/notesSlides/notesSlide34.xml><?xml version="1.0" encoding="utf-8"?>
 <p:notes xmlns:a="http://schemas.openxmlformats.org/drawingml/2006/main" xmlns:r="http://schemas.openxmlformats.org/officeDocument/2006/relationships" xmlns:p="http://schemas.openxmlformats.org/presentationml/2006/main">
   <p:cSld>
     <p:spTree>
@@ -3836,7 +3172,7 @@
           <a:p>
             <a:fld id="{F7021451-1387-4CA6-816F-3879F97B5CBC}" type="slidenum">
               <a:rPr lang="en-US"/>
-              <a:t>40</a:t>
+              <a:t>34</a:t>
             </a:fld>
             <a:endParaRPr lang="en-US"/>
           </a:p>
@@ -3855,7 +3191,7 @@
 </p:notes>
 </file>
 
-<file path=ppt/notesSlides/notesSlide41.xml><?xml version="1.0" encoding="utf-8"?>
+<file path=ppt/notesSlides/notesSlide35.xml><?xml version="1.0" encoding="utf-8"?>
 <p:notes xmlns:a="http://schemas.openxmlformats.org/drawingml/2006/main" xmlns:r="http://schemas.openxmlformats.org/officeDocument/2006/relationships" xmlns:p="http://schemas.openxmlformats.org/presentationml/2006/main">
   <p:cSld>
     <p:spTree>
@@ -3933,7 +3269,7 @@
           <a:p>
             <a:fld id="{F7021451-1387-4CA6-816F-3879F97B5CBC}" type="slidenum">
               <a:rPr lang="en-US"/>
-              <a:t>41</a:t>
+              <a:t>35</a:t>
             </a:fld>
             <a:endParaRPr lang="en-US"/>
           </a:p>
@@ -3952,7 +3288,7 @@
 </p:notes>
 </file>
 
-<file path=ppt/notesSlides/notesSlide42.xml><?xml version="1.0" encoding="utf-8"?>
+<file path=ppt/notesSlides/notesSlide36.xml><?xml version="1.0" encoding="utf-8"?>
 <p:notes xmlns:a="http://schemas.openxmlformats.org/drawingml/2006/main" xmlns:r="http://schemas.openxmlformats.org/officeDocument/2006/relationships" xmlns:p="http://schemas.openxmlformats.org/presentationml/2006/main">
   <p:cSld>
     <p:spTree>
@@ -4028,7 +3364,7 @@
           <a:p>
             <a:fld id="{F7021451-1387-4CA6-816F-3879F97B5CBC}" type="slidenum">
               <a:rPr lang="en-US"/>
-              <a:t>42</a:t>
+              <a:t>36</a:t>
             </a:fld>
             <a:endParaRPr lang="en-US"/>
           </a:p>
@@ -4047,7 +3383,7 @@
 </p:notes>
 </file>
 
-<file path=ppt/notesSlides/notesSlide43.xml><?xml version="1.0" encoding="utf-8"?>
+<file path=ppt/notesSlides/notesSlide37.xml><?xml version="1.0" encoding="utf-8"?>
 <p:notes xmlns:a="http://schemas.openxmlformats.org/drawingml/2006/main" xmlns:r="http://schemas.openxmlformats.org/officeDocument/2006/relationships" xmlns:p="http://schemas.openxmlformats.org/presentationml/2006/main">
   <p:cSld>
     <p:spTree>
@@ -4119,7 +3455,7 @@
           <a:p>
             <a:fld id="{F7021451-1387-4CA6-816F-3879F97B5CBC}" type="slidenum">
               <a:rPr lang="en-US"/>
-              <a:t>43</a:t>
+              <a:t>37</a:t>
             </a:fld>
             <a:endParaRPr lang="en-US"/>
           </a:p>
@@ -4138,7 +3474,7 @@
 </p:notes>
 </file>
 
-<file path=ppt/notesSlides/notesSlide44.xml><?xml version="1.0" encoding="utf-8"?>
+<file path=ppt/notesSlides/notesSlide38.xml><?xml version="1.0" encoding="utf-8"?>
 <p:notes xmlns:a="http://schemas.openxmlformats.org/drawingml/2006/main" xmlns:r="http://schemas.openxmlformats.org/officeDocument/2006/relationships" xmlns:p="http://schemas.openxmlformats.org/presentationml/2006/main">
   <p:cSld>
     <p:spTree>
@@ -4207,7 +3543,103 @@
           <a:p>
             <a:fld id="{F7021451-1387-4CA6-816F-3879F97B5CBC}" type="slidenum">
               <a:rPr lang="en-US"/>
-              <a:t>44</a:t>
+              <a:t>38</a:t>
+            </a:fld>
+            <a:endParaRPr lang="en-US"/>
+          </a:p>
+        </p:txBody>
+      </p:sp>
+    </p:spTree>
+    <p:extLst>
+      <p:ext uri="{BB962C8B-B14F-4D97-AF65-F5344CB8AC3E}">
+        <p14:creationId xmlns:p14="http://schemas.microsoft.com/office/powerpoint/2010/main" val="1024086991"/>
+      </p:ext>
+    </p:extLst>
+  </p:cSld>
+  <p:clrMapOvr>
+    <a:masterClrMapping/>
+  </p:clrMapOvr>
+</p:notes>
+</file>
+
+<file path=ppt/notesSlides/notesSlide4.xml><?xml version="1.0" encoding="utf-8"?>
+<p:notes xmlns:a="http://schemas.openxmlformats.org/drawingml/2006/main" xmlns:r="http://schemas.openxmlformats.org/officeDocument/2006/relationships" xmlns:p="http://schemas.openxmlformats.org/presentationml/2006/main">
+  <p:cSld>
+    <p:spTree>
+      <p:nvGrpSpPr>
+        <p:cNvPr id="1" name=""/>
+        <p:cNvGrpSpPr/>
+        <p:nvPr/>
+      </p:nvGrpSpPr>
+      <p:grpSpPr>
+        <a:xfrm>
+          <a:off x="0" y="0"/>
+          <a:ext cx="0" cy="0"/>
+          <a:chOff x="0" y="0"/>
+          <a:chExt cx="0" cy="0"/>
+        </a:xfrm>
+      </p:grpSpPr>
+      <p:sp>
+        <p:nvSpPr>
+          <p:cNvPr id="2" name="Slide Image Placeholder 1"/>
+          <p:cNvSpPr>
+            <a:spLocks noGrp="1" noRot="1" noChangeAspect="1"/>
+          </p:cNvSpPr>
+          <p:nvPr>
+            <p:ph type="sldImg"/>
+          </p:nvPr>
+        </p:nvSpPr>
+        <p:spPr/>
+      </p:sp>
+      <p:sp>
+        <p:nvSpPr>
+          <p:cNvPr id="3" name="Notes Placeholder 2"/>
+          <p:cNvSpPr>
+            <a:spLocks noGrp="1"/>
+          </p:cNvSpPr>
+          <p:nvPr>
+            <p:ph type="body" idx="1"/>
+          </p:nvPr>
+        </p:nvSpPr>
+        <p:spPr/>
+        <p:txBody>
+          <a:bodyPr/>
+          <a:lstStyle/>
+          <a:p>
+            <a:r>
+              <a:rPr lang="en-US" dirty="0"/>
+              <a:t>Three negatives, and each one is a design decision somebody made rather than a
+limitation of the model.
+The third is the one that surprises people: there is no memory between
+sessions. Continuity is the harness resending the history, which is why
+history spends their token budget later in the deck.
+The 4B and the 9B are asked for different reply shapes, whole files against
+diffs. That is why a classmate's session looks different from theirs, and why
+the trace they see later may not match what they ran in practice.
+Worth saying here, not worth a slide.</a:t>
+            </a:r>
+            <a:endParaRPr lang="en-US" dirty="0"/>
+          </a:p>
+        </p:txBody>
+      </p:sp>
+      <p:sp>
+        <p:nvSpPr>
+          <p:cNvPr id="4" name="Slide Number Placeholder 3"/>
+          <p:cNvSpPr>
+            <a:spLocks noGrp="1"/>
+          </p:cNvSpPr>
+          <p:nvPr>
+            <p:ph type="sldNum" sz="quarter" idx="10"/>
+          </p:nvPr>
+        </p:nvSpPr>
+        <p:spPr/>
+        <p:txBody>
+          <a:bodyPr/>
+          <a:lstStyle/>
+          <a:p>
+            <a:fld id="{F7021451-1387-4CA6-816F-3879F97B5CBC}" type="slidenum">
+              <a:rPr lang="en-US"/>
+              <a:t>4</a:t>
             </a:fld>
             <a:endParaRPr lang="en-US"/>
           </a:p>
@@ -4364,12 +3796,13 @@
           <a:p>
             <a:r>
               <a:rPr lang="en-US" dirty="0"/>
-              <a:t>The centre of the lab, and the idea the rest of it hangs off. They have spent
-two weeks inside what looks like a chat, and it is not one. There is a single
-block of text, assembled from nothing every turn, and Aider writes every part of
-it including the half that appears to be theirs.
-Do not rush this section. The budget, the cache, the stale file and the silent
-undo are all consequences of it.</a:t>
+              <a:t>Cut back hard on 2026-09-13. L02 and L03 already taught the window, the four
+sources that fill it, surgical selection and /tokens, and this block used to
+repeat all of it. What is left is the part they have not met: the repo map, and
+what happens to the budget as a session runs long.
+So do not re-teach context here. One sentence to reconnect it, that only the
+reply belongs to the model and everything else is the harness choosing what the
+model gets to see, and then straight into the map.</a:t>
             </a:r>
             <a:endParaRPr lang="en-US" dirty="0"/>
           </a:p>
@@ -4457,16 +3890,10 @@
           <a:p>
             <a:r>
               <a:rPr lang="en-US" dirty="0"/>
-              <a:t>Read the last one out loud. Aider wrote their irritation, interrobang included,
-and sent it over their name.
-None of this is Aider deceiving them. The chat format has two roles and a
-harness has to put machine-generated context somewhere, so it goes in the user's
-slot. But the model has no way to tell which of those messages a person typed.
-Ask the room: if the model is told a human wrote something a program generated,
-what is it supposed to do with the words "trust this message"? That question is
-the whole grounding problem, and the rest of the deck answers it.
-Their build makes this decision too. Anything it sends that the user did not
-type is a message it is authoring on the user's behalf.</a:t>
+              <a:t>Ask the room to find the arrow that writes a file. There is not one leaving the
+amber box. The model produced text, and a program decided what to do with it.
+This is a picture of Aider, not a required architecture for their build. They
+will draw their own version of this in a week.</a:t>
             </a:r>
             <a:endParaRPr lang="en-US" dirty="0"/>
           </a:p>
@@ -4554,17 +3981,10 @@
           <a:p>
             <a:r>
               <a:rPr lang="en-US" dirty="0"/>
-              <a:t>Row two is the one that lands. Aider writes replies for the model, "Ok, any
-changes I propose will be to those files", and puts them in the history, so the
-next turn reads as a dialogue that has already agreed with itself. The model
-never said it.
-Row three is worth saying slowly. The instruction that tells the model which
-edit format to produce is appended to the end of the student's own message. What
-the model reads as the request is not what they typed.
-There is a cost hidden in row three that comes back later: when the context is
-nearly full, that reminder is the thing dropped to make room. The instruction
-keeping the output parseable is sacrificed exactly when the model is most likely
-to drift.</a:t>
+              <a:t>Point at the vertical bars: that is aider quoting source lines. Point at the
+dots: that is everything it decided not to spend tokens on.
+Ask what this is for. The answer is on the next slide: it is aider guessing
+what you would have typed /add for.</a:t>
             </a:r>
             <a:endParaRPr lang="en-US" dirty="0"/>
           </a:p>
@@ -4652,11 +4072,13 @@
           <a:p>
             <a:r>
               <a:rPr lang="en-US" dirty="0"/>
-              <a:t>This block is now about context rather than a walkthrough of a whole turn
-(instructor cuts 2026-09-13). Most of it is the repo map, because that is the
-part nobody has met before and the part that quietly spends their budget.
-Say up front that only the reply belongs to the model. Everything else in this
-block is the harness deciding what the model gets to see.</a:t>
+              <a:t>Off the slide and worth saying: the ranking is tilted toward files you just
+mentioned, and aider renders down the list until the tokens run out.
+Say the ranking rule plainly: a file that lots of other files depend on scores
+high, because it is probably the one you need to know about.
+The dashed line is the point. It is not "here is your repo," it is "here is as
+much of your repo as fits," and whatever falls under the line is invisible to
+the model. 867 lines of aider to guess what you would have typed /add for.</a:t>
             </a:r>
             <a:endParaRPr lang="en-US" dirty="0"/>
           </a:p>
@@ -6253,243 +5675,9 @@
 </p:sld>
 </file>
 
-<file path=ppt/slides/slide39.xml><?xml version="1.0" encoding="utf-8"?>
-<p:sld xmlns:a="http://schemas.openxmlformats.org/drawingml/2006/main" xmlns:r="http://schemas.openxmlformats.org/officeDocument/2006/relationships" xmlns:p="http://schemas.openxmlformats.org/presentationml/2006/main">
-  <p:cSld name="Slide 39">
-    <p:bg>
-      <p:bgPr>
-        <a:blipFill dpi="0" rotWithShape="1">
-          <a:blip r:embed="rId1">
-            <a:lum/>
-          </a:blip>
-          <a:srcRect/>
-          <a:stretch>
-            <a:fillRect/>
-          </a:stretch>
-        </a:blipFill>
-        <a:effectLst/>
-      </p:bgPr>
-    </p:bg>
-    <p:spTree>
-      <p:nvGrpSpPr>
-        <p:cNvPr id="1" name=""/>
-        <p:cNvGrpSpPr/>
-        <p:nvPr/>
-      </p:nvGrpSpPr>
-      <p:grpSpPr>
-        <a:xfrm>
-          <a:off x="0" y="0"/>
-          <a:ext cx="0" cy="0"/>
-          <a:chOff x="0" y="0"/>
-          <a:chExt cx="0" cy="0"/>
-        </a:xfrm>
-      </p:grpSpPr>
-    </p:spTree>
-  </p:cSld>
-  <p:clrMapOvr>
-    <a:masterClrMapping/>
-  </p:clrMapOvr>
-</p:sld>
-</file>
-
 <file path=ppt/slides/slide4.xml><?xml version="1.0" encoding="utf-8"?>
 <p:sld xmlns:a="http://schemas.openxmlformats.org/drawingml/2006/main" xmlns:r="http://schemas.openxmlformats.org/officeDocument/2006/relationships" xmlns:p="http://schemas.openxmlformats.org/presentationml/2006/main">
   <p:cSld name="Slide 4">
-    <p:bg>
-      <p:bgPr>
-        <a:blipFill dpi="0" rotWithShape="1">
-          <a:blip r:embed="rId1">
-            <a:lum/>
-          </a:blip>
-          <a:srcRect/>
-          <a:stretch>
-            <a:fillRect/>
-          </a:stretch>
-        </a:blipFill>
-        <a:effectLst/>
-      </p:bgPr>
-    </p:bg>
-    <p:spTree>
-      <p:nvGrpSpPr>
-        <p:cNvPr id="1" name=""/>
-        <p:cNvGrpSpPr/>
-        <p:nvPr/>
-      </p:nvGrpSpPr>
-      <p:grpSpPr>
-        <a:xfrm>
-          <a:off x="0" y="0"/>
-          <a:ext cx="0" cy="0"/>
-          <a:chOff x="0" y="0"/>
-          <a:chExt cx="0" cy="0"/>
-        </a:xfrm>
-      </p:grpSpPr>
-    </p:spTree>
-  </p:cSld>
-  <p:clrMapOvr>
-    <a:masterClrMapping/>
-  </p:clrMapOvr>
-</p:sld>
-</file>
-
-<file path=ppt/slides/slide40.xml><?xml version="1.0" encoding="utf-8"?>
-<p:sld xmlns:a="http://schemas.openxmlformats.org/drawingml/2006/main" xmlns:r="http://schemas.openxmlformats.org/officeDocument/2006/relationships" xmlns:p="http://schemas.openxmlformats.org/presentationml/2006/main">
-  <p:cSld name="Slide 40">
-    <p:bg>
-      <p:bgPr>
-        <a:blipFill dpi="0" rotWithShape="1">
-          <a:blip r:embed="rId1">
-            <a:lum/>
-          </a:blip>
-          <a:srcRect/>
-          <a:stretch>
-            <a:fillRect/>
-          </a:stretch>
-        </a:blipFill>
-        <a:effectLst/>
-      </p:bgPr>
-    </p:bg>
-    <p:spTree>
-      <p:nvGrpSpPr>
-        <p:cNvPr id="1" name=""/>
-        <p:cNvGrpSpPr/>
-        <p:nvPr/>
-      </p:nvGrpSpPr>
-      <p:grpSpPr>
-        <a:xfrm>
-          <a:off x="0" y="0"/>
-          <a:ext cx="0" cy="0"/>
-          <a:chOff x="0" y="0"/>
-          <a:chExt cx="0" cy="0"/>
-        </a:xfrm>
-      </p:grpSpPr>
-    </p:spTree>
-  </p:cSld>
-  <p:clrMapOvr>
-    <a:masterClrMapping/>
-  </p:clrMapOvr>
-</p:sld>
-</file>
-
-<file path=ppt/slides/slide41.xml><?xml version="1.0" encoding="utf-8"?>
-<p:sld xmlns:a="http://schemas.openxmlformats.org/drawingml/2006/main" xmlns:r="http://schemas.openxmlformats.org/officeDocument/2006/relationships" xmlns:p="http://schemas.openxmlformats.org/presentationml/2006/main">
-  <p:cSld name="Slide 41">
-    <p:bg>
-      <p:bgPr>
-        <a:blipFill dpi="0" rotWithShape="1">
-          <a:blip r:embed="rId1">
-            <a:lum/>
-          </a:blip>
-          <a:srcRect/>
-          <a:stretch>
-            <a:fillRect/>
-          </a:stretch>
-        </a:blipFill>
-        <a:effectLst/>
-      </p:bgPr>
-    </p:bg>
-    <p:spTree>
-      <p:nvGrpSpPr>
-        <p:cNvPr id="1" name=""/>
-        <p:cNvGrpSpPr/>
-        <p:nvPr/>
-      </p:nvGrpSpPr>
-      <p:grpSpPr>
-        <a:xfrm>
-          <a:off x="0" y="0"/>
-          <a:ext cx="0" cy="0"/>
-          <a:chOff x="0" y="0"/>
-          <a:chExt cx="0" cy="0"/>
-        </a:xfrm>
-      </p:grpSpPr>
-    </p:spTree>
-  </p:cSld>
-  <p:clrMapOvr>
-    <a:masterClrMapping/>
-  </p:clrMapOvr>
-</p:sld>
-</file>
-
-<file path=ppt/slides/slide42.xml><?xml version="1.0" encoding="utf-8"?>
-<p:sld xmlns:a="http://schemas.openxmlformats.org/drawingml/2006/main" xmlns:r="http://schemas.openxmlformats.org/officeDocument/2006/relationships" xmlns:p="http://schemas.openxmlformats.org/presentationml/2006/main">
-  <p:cSld name="Slide 42">
-    <p:bg>
-      <p:bgPr>
-        <a:blipFill dpi="0" rotWithShape="1">
-          <a:blip r:embed="rId1">
-            <a:lum/>
-          </a:blip>
-          <a:srcRect/>
-          <a:stretch>
-            <a:fillRect/>
-          </a:stretch>
-        </a:blipFill>
-        <a:effectLst/>
-      </p:bgPr>
-    </p:bg>
-    <p:spTree>
-      <p:nvGrpSpPr>
-        <p:cNvPr id="1" name=""/>
-        <p:cNvGrpSpPr/>
-        <p:nvPr/>
-      </p:nvGrpSpPr>
-      <p:grpSpPr>
-        <a:xfrm>
-          <a:off x="0" y="0"/>
-          <a:ext cx="0" cy="0"/>
-          <a:chOff x="0" y="0"/>
-          <a:chExt cx="0" cy="0"/>
-        </a:xfrm>
-      </p:grpSpPr>
-    </p:spTree>
-  </p:cSld>
-  <p:clrMapOvr>
-    <a:masterClrMapping/>
-  </p:clrMapOvr>
-</p:sld>
-</file>
-
-<file path=ppt/slides/slide43.xml><?xml version="1.0" encoding="utf-8"?>
-<p:sld xmlns:a="http://schemas.openxmlformats.org/drawingml/2006/main" xmlns:r="http://schemas.openxmlformats.org/officeDocument/2006/relationships" xmlns:p="http://schemas.openxmlformats.org/presentationml/2006/main">
-  <p:cSld name="Slide 43">
-    <p:bg>
-      <p:bgPr>
-        <a:blipFill dpi="0" rotWithShape="1">
-          <a:blip r:embed="rId1">
-            <a:lum/>
-          </a:blip>
-          <a:srcRect/>
-          <a:stretch>
-            <a:fillRect/>
-          </a:stretch>
-        </a:blipFill>
-        <a:effectLst/>
-      </p:bgPr>
-    </p:bg>
-    <p:spTree>
-      <p:nvGrpSpPr>
-        <p:cNvPr id="1" name=""/>
-        <p:cNvGrpSpPr/>
-        <p:nvPr/>
-      </p:nvGrpSpPr>
-      <p:grpSpPr>
-        <a:xfrm>
-          <a:off x="0" y="0"/>
-          <a:ext cx="0" cy="0"/>
-          <a:chOff x="0" y="0"/>
-          <a:chExt cx="0" cy="0"/>
-        </a:xfrm>
-      </p:grpSpPr>
-    </p:spTree>
-  </p:cSld>
-  <p:clrMapOvr>
-    <a:masterClrMapping/>
-  </p:clrMapOvr>
-</p:sld>
-</file>
-
-<file path=ppt/slides/slide44.xml><?xml version="1.0" encoding="utf-8"?>
-<p:sld xmlns:a="http://schemas.openxmlformats.org/drawingml/2006/main" xmlns:r="http://schemas.openxmlformats.org/officeDocument/2006/relationships" xmlns:p="http://schemas.openxmlformats.org/presentationml/2006/main">
-  <p:cSld name="Slide 44">
     <p:bg>
       <p:bgPr>
         <a:blipFill dpi="0" rotWithShape="1">

</xml_diff>

<commit_message>
Lab01: republish at 38 slides after the second cut (#12)
Claude-Session: https://claude.ai/code/session_01HK8wFbKHvmKPXQf2PSK8c1

Co-authored-by: Claude <noreply@anthropic.com>
</commit_message>
<xml_diff>
--- a/labs/Lab01/slides.pptx
+++ b/labs/Lab01/slides.pptx
@@ -43,15 +43,9 @@
     <p:sldId id="291" r:id="rId37"/>
     <p:sldId id="292" r:id="rId38"/>
     <p:sldId id="293" r:id="rId39"/>
-    <p:sldId id="294" r:id="rId40"/>
-    <p:sldId id="295" r:id="rId41"/>
-    <p:sldId id="296" r:id="rId42"/>
-    <p:sldId id="297" r:id="rId43"/>
-    <p:sldId id="298" r:id="rId44"/>
-    <p:sldId id="299" r:id="rId45"/>
   </p:sldIdLst>
   <p:notesMasterIdLst>
-    <p:notesMasterId r:id="rId46"/>
+    <p:notesMasterId r:id="rId40"/>
   </p:notesMasterIdLst>
   <p:sldSz cx="9334500" cy="5248275"/>
   <p:notesSz cx="5248275" cy="9334500"/>
@@ -638,10 +632,22 @@
           <a:p>
             <a:r>
               <a:rPr lang="en-US" dirty="0"/>
-              <a:t>Ask the room to find the arrow that writes a file. There is not one leaving the
-amber box. The model produced text, and a program decided what to do with it.
-This is a picture of Aider, not a required architecture for their build. They
-will draw their own version of this in a week.</a:t>
+              <a:t>The one context slide worth keeping, because it is the part L02 and L03 did not
+show. They have seen that the window is finite and they have read /tokens. They
+have not seen it fill up over a session.
+Walk the two bars. Nothing about the early turn is wrong; the later turn is the
+same prompt after the history has grown, and the thing that stops fitting is
+their own message. Everything above it was spent before they typed.
+The map is charged to this same budget, which on a 4B can be a third of the
+window spent describing files the model then cannot see inside. That is why
+aider-practice turns it down, and why the map is out of scope for the build. Say
+so, so nobody spends week 4 on it.
+Then the bold line, which is the whole reason this slide is still here. Ask what
+they would drop first and what has to survive. Their Stage 1 contract keeps the
+system instructions, the current request and the added file contents, and refuses
+an oversized required input instead of silently trimming it. That refusal is a
+design decision they have to write down and test, and the packet does not make it
+for them.</a:t>
             </a:r>
             <a:endParaRPr lang="en-US" dirty="0"/>
           </a:p>
@@ -729,16 +735,13 @@
           <a:p>
             <a:r>
               <a:rPr lang="en-US" dirty="0"/>
-              <a:t>Do not claim a fixed seven-part ordering. What actually goes into the prompt
-depends on the coder, the model and the settings, and it changes between
-releases. The list above is the shape, not the wire format.
-Ask what the model would need in order to change three files consistently, when
-nothing has told it which three. That question sets up the repo map.
-The /add slide was cut on 2026-09-13 because they have been doing this for two
-weeks. Two things it carried, worth saying if anyone asks rather than putting
-back on the glass: added files can be rewritten while read-only files can only
-be cited, and adding the whole package is not a selection strategy, it is a way
-to spend the budget.</a:t>
+              <a:t>Simplified 2026-09-13 on instructor note: this section was three slides and read
+as confusing, because two of them argued the same point from different angles.
+Two slides now, and they argue in a line: here is the order, here is why that
+order was chosen.
+Open with the one sentence everything else follows from. The model keeps nothing
+between turns. Turn twelve sends everything turn one sent, plus more. That is not
+a limitation to work around, it is the condition their own build runs under.</a:t>
             </a:r>
             <a:endParaRPr lang="en-US" dirty="0"/>
           </a:p>
@@ -826,15 +829,14 @@
           <a:p>
             <a:r>
               <a:rPr lang="en-US" dirty="0"/>
-              <a:t>This is the idea the repo map slides are evidence for, so put it up before them
-rather than after.
-A harness is not mainly a parser or an editor. It is a policy for what to spend
-a finite window on, and every design difference between one tool and the next
-comes back to that policy. Aider's is visible and mostly manual: they add the
-files, it fills the remainder with a ranked guess.
-Their build has this problem on day one and the packet does not solve it for
-them. What gets sent, what gets refused, and what happens when the required
-input alone will not fit are all their decisions to write down.</a:t>
+              <a:t>Three groups rather than a list of seven parts, because the grouping is the point
+and the exact ordinal of each part is not.
+Work the bold line rather than the table. The parts that change every turn were
+deliberately put last. The next slide says what that buys, so put the ordering up
+first and let someone in the room guess why before you explain it.
+Their build assembles this same thing, and the packet asks them to say what goes
+in it and in what order. This slide is the argument that the answer is a design
+decision rather than a detail.</a:t>
             </a:r>
             <a:endParaRPr lang="en-US" dirty="0"/>
           </a:p>
@@ -922,10 +924,25 @@
           <a:p>
             <a:r>
               <a:rPr lang="en-US" dirty="0"/>
-              <a:t>Point at the vertical bars: that is aider quoting source lines. Point at the
-dots: that is everything it decided not to spend tokens on.
-Ask what this is for. The answer is on the next slide: it is aider guessing
-what you would have typed /add for.</a:t>
+              <a:t>Table first, then the three bullets: here is the rule, here is what trips it.
+The rule is not the model remembering. Nothing is remembered between sessions.
+It is the serving layer recognising text it has already processed and picking up
+where it left off, and it holds on the course endpoint as much as on a hosted
+API. A hosted API marks the reuse points explicitly and a local server reuses the
+longest opening it recognises; the rule is identical either way.
+Then the three bullets, all verified in the source, and the third is the one
+nobody guesses. Ask mode is not a smaller code mode: it is a different system
+prompt with the worked examples removed, sitting at the very front, so a quick
+question mid task throws the whole prefix away rather than part of it. Adding a
+file changes both the file block and the map, because files in the chat come out
+of the map. And by default the map is rebuilt from the filenames found in the
+message just typed, so mentioning a file in passing moves it.
+The habit worth giving them: settle the file set before starting, and keep a
+question in its own session. The design lesson worth more: what they put first in
+their own prompt decides what a turn costs.
+If they want dollar figures, quote the provider's current pricing page rather
+than a number from memory. What they will feel on their own machine is the wait
+before the first token, not money.</a:t>
             </a:r>
             <a:endParaRPr lang="en-US" dirty="0"/>
           </a:p>
@@ -968,686 +985,6 @@
 </file>
 
 <file path=ppt/notesSlides/notesSlide14.xml><?xml version="1.0" encoding="utf-8"?>
-<p:notes xmlns:a="http://schemas.openxmlformats.org/drawingml/2006/main" xmlns:r="http://schemas.openxmlformats.org/officeDocument/2006/relationships" xmlns:p="http://schemas.openxmlformats.org/presentationml/2006/main">
-  <p:cSld>
-    <p:spTree>
-      <p:nvGrpSpPr>
-        <p:cNvPr id="1" name=""/>
-        <p:cNvGrpSpPr/>
-        <p:nvPr/>
-      </p:nvGrpSpPr>
-      <p:grpSpPr>
-        <a:xfrm>
-          <a:off x="0" y="0"/>
-          <a:ext cx="0" cy="0"/>
-          <a:chOff x="0" y="0"/>
-          <a:chExt cx="0" cy="0"/>
-        </a:xfrm>
-      </p:grpSpPr>
-      <p:sp>
-        <p:nvSpPr>
-          <p:cNvPr id="2" name="Slide Image Placeholder 1"/>
-          <p:cNvSpPr>
-            <a:spLocks noGrp="1" noRot="1" noChangeAspect="1"/>
-          </p:cNvSpPr>
-          <p:nvPr>
-            <p:ph type="sldImg"/>
-          </p:nvPr>
-        </p:nvSpPr>
-        <p:spPr/>
-      </p:sp>
-      <p:sp>
-        <p:nvSpPr>
-          <p:cNvPr id="3" name="Notes Placeholder 2"/>
-          <p:cNvSpPr>
-            <a:spLocks noGrp="1"/>
-          </p:cNvSpPr>
-          <p:nvPr>
-            <p:ph type="body" idx="1"/>
-          </p:nvPr>
-        </p:nvSpPr>
-        <p:spPr/>
-        <p:txBody>
-          <a:bodyPr/>
-          <a:lstStyle/>
-          <a:p>
-            <a:r>
-              <a:rPr lang="en-US" dirty="0"/>
-              <a:t>Off the slide and worth saying: the ranking is tilted toward files you just
-mentioned, and aider renders down the list until the tokens run out.
-Say the ranking rule plainly: a file that lots of other files depend on scores
-high, because it is probably the one you need to know about.
-The dashed line is the point. It is not "here is your repo," it is "here is as
-much of your repo as fits," and whatever falls under the line is invisible to
-the model. 867 lines of aider to guess what you would have typed /add for.</a:t>
-            </a:r>
-            <a:endParaRPr lang="en-US" dirty="0"/>
-          </a:p>
-        </p:txBody>
-      </p:sp>
-      <p:sp>
-        <p:nvSpPr>
-          <p:cNvPr id="4" name="Slide Number Placeholder 3"/>
-          <p:cNvSpPr>
-            <a:spLocks noGrp="1"/>
-          </p:cNvSpPr>
-          <p:nvPr>
-            <p:ph type="sldNum" sz="quarter" idx="10"/>
-          </p:nvPr>
-        </p:nvSpPr>
-        <p:spPr/>
-        <p:txBody>
-          <a:bodyPr/>
-          <a:lstStyle/>
-          <a:p>
-            <a:fld id="{F7021451-1387-4CA6-816F-3879F97B5CBC}" type="slidenum">
-              <a:rPr lang="en-US"/>
-              <a:t>14</a:t>
-            </a:fld>
-            <a:endParaRPr lang="en-US"/>
-          </a:p>
-        </p:txBody>
-      </p:sp>
-    </p:spTree>
-    <p:extLst>
-      <p:ext uri="{BB962C8B-B14F-4D97-AF65-F5344CB8AC3E}">
-        <p14:creationId xmlns:p14="http://schemas.microsoft.com/office/powerpoint/2010/main" val="1024086991"/>
-      </p:ext>
-    </p:extLst>
-  </p:cSld>
-  <p:clrMapOvr>
-    <a:masterClrMapping/>
-  </p:clrMapOvr>
-</p:notes>
-</file>
-
-<file path=ppt/notesSlides/notesSlide15.xml><?xml version="1.0" encoding="utf-8"?>
-<p:notes xmlns:a="http://schemas.openxmlformats.org/drawingml/2006/main" xmlns:r="http://schemas.openxmlformats.org/officeDocument/2006/relationships" xmlns:p="http://schemas.openxmlformats.org/presentationml/2006/main">
-  <p:cSld>
-    <p:spTree>
-      <p:nvGrpSpPr>
-        <p:cNvPr id="1" name=""/>
-        <p:cNvGrpSpPr/>
-        <p:nvPr/>
-      </p:nvGrpSpPr>
-      <p:grpSpPr>
-        <a:xfrm>
-          <a:off x="0" y="0"/>
-          <a:ext cx="0" cy="0"/>
-          <a:chOff x="0" y="0"/>
-          <a:chExt cx="0" cy="0"/>
-        </a:xfrm>
-      </p:grpSpPr>
-      <p:sp>
-        <p:nvSpPr>
-          <p:cNvPr id="2" name="Slide Image Placeholder 1"/>
-          <p:cNvSpPr>
-            <a:spLocks noGrp="1" noRot="1" noChangeAspect="1"/>
-          </p:cNvSpPr>
-          <p:nvPr>
-            <p:ph type="sldImg"/>
-          </p:nvPr>
-        </p:nvSpPr>
-        <p:spPr/>
-      </p:sp>
-      <p:sp>
-        <p:nvSpPr>
-          <p:cNvPr id="3" name="Notes Placeholder 2"/>
-          <p:cNvSpPr>
-            <a:spLocks noGrp="1"/>
-          </p:cNvSpPr>
-          <p:nvPr>
-            <p:ph type="body" idx="1"/>
-          </p:nvPr>
-        </p:nvSpPr>
-        <p:spPr/>
-        <p:txBody>
-          <a:bodyPr/>
-          <a:lstStyle/>
-          <a:p>
-            <a:r>
-              <a:rPr lang="en-US" dirty="0"/>
-              <a:t>This slide now carries what the separate map-cost slide used to say, because two
-diagrams of the same budget read as two unrelated facts (instructor note
-2026-09-13).
-Walk the two bars. Nothing about the early turn is wrong; the later turn is the
-same prompt after the history has grown, and the thing that stops fitting is
-their own message. Everything above it was spent before they typed.
-The bold line is the map's part in that. It is charged to the same budget as the
-files it was guessing about, which on a 4B can be a third of the window spent
-describing files the model then cannot see inside. That is why aider-practice
-turns it down, and it is why the map is out of scope for the build. Say so, so
-nobody spends week 4 on it.
-Ask what they would drop first and what has to survive. Their Stage 1 contract
-keeps the system instructions, the current request and the added file contents,
-and refuses an oversized required input instead of silently trimming it. That
-refusal is a design decision they have to write down and test.</a:t>
-            </a:r>
-            <a:endParaRPr lang="en-US" dirty="0"/>
-          </a:p>
-        </p:txBody>
-      </p:sp>
-      <p:sp>
-        <p:nvSpPr>
-          <p:cNvPr id="4" name="Slide Number Placeholder 3"/>
-          <p:cNvSpPr>
-            <a:spLocks noGrp="1"/>
-          </p:cNvSpPr>
-          <p:nvPr>
-            <p:ph type="sldNum" sz="quarter" idx="10"/>
-          </p:nvPr>
-        </p:nvSpPr>
-        <p:spPr/>
-        <p:txBody>
-          <a:bodyPr/>
-          <a:lstStyle/>
-          <a:p>
-            <a:fld id="{F7021451-1387-4CA6-816F-3879F97B5CBC}" type="slidenum">
-              <a:rPr lang="en-US"/>
-              <a:t>15</a:t>
-            </a:fld>
-            <a:endParaRPr lang="en-US"/>
-          </a:p>
-        </p:txBody>
-      </p:sp>
-    </p:spTree>
-    <p:extLst>
-      <p:ext uri="{BB962C8B-B14F-4D97-AF65-F5344CB8AC3E}">
-        <p14:creationId xmlns:p14="http://schemas.microsoft.com/office/powerpoint/2010/main" val="1024086991"/>
-      </p:ext>
-    </p:extLst>
-  </p:cSld>
-  <p:clrMapOvr>
-    <a:masterClrMapping/>
-  </p:clrMapOvr>
-</p:notes>
-</file>
-
-<file path=ppt/notesSlides/notesSlide16.xml><?xml version="1.0" encoding="utf-8"?>
-<p:notes xmlns:a="http://schemas.openxmlformats.org/drawingml/2006/main" xmlns:r="http://schemas.openxmlformats.org/officeDocument/2006/relationships" xmlns:p="http://schemas.openxmlformats.org/presentationml/2006/main">
-  <p:cSld>
-    <p:spTree>
-      <p:nvGrpSpPr>
-        <p:cNvPr id="1" name=""/>
-        <p:cNvGrpSpPr/>
-        <p:nvPr/>
-      </p:nvGrpSpPr>
-      <p:grpSpPr>
-        <a:xfrm>
-          <a:off x="0" y="0"/>
-          <a:ext cx="0" cy="0"/>
-          <a:chOff x="0" y="0"/>
-          <a:chExt cx="0" cy="0"/>
-        </a:xfrm>
-      </p:grpSpPr>
-      <p:sp>
-        <p:nvSpPr>
-          <p:cNvPr id="2" name="Slide Image Placeholder 1"/>
-          <p:cNvSpPr>
-            <a:spLocks noGrp="1" noRot="1" noChangeAspect="1"/>
-          </p:cNvSpPr>
-          <p:nvPr>
-            <p:ph type="sldImg"/>
-          </p:nvPr>
-        </p:nvSpPr>
-        <p:spPr/>
-      </p:sp>
-      <p:sp>
-        <p:nvSpPr>
-          <p:cNvPr id="3" name="Notes Placeholder 2"/>
-          <p:cNvSpPr>
-            <a:spLocks noGrp="1"/>
-          </p:cNvSpPr>
-          <p:nvPr>
-            <p:ph type="body" idx="1"/>
-          </p:nvPr>
-        </p:nvSpPr>
-        <p:spPr/>
-        <p:txBody>
-          <a:bodyPr/>
-          <a:lstStyle/>
-          <a:p>
-            <a:r>
-              <a:rPr lang="en-US" dirty="0"/>
-              <a:t>Reworked 2026-09-13: the old version of this section had four slides and two of
-them showed the same seven-part list in different groupings, which is what made
-it read as confusing. It is three slides now and they argue in a line: here is
-the order, here is why the order was chosen, here is what ruins it.
-The one sentence to open with, because everything here follows from it: the
-model keeps nothing between turns. Turn twelve sends everything turn one sent,
-plus more. Every design decision in this section exists because of that.</a:t>
-            </a:r>
-            <a:endParaRPr lang="en-US" dirty="0"/>
-          </a:p>
-        </p:txBody>
-      </p:sp>
-      <p:sp>
-        <p:nvSpPr>
-          <p:cNvPr id="4" name="Slide Number Placeholder 3"/>
-          <p:cNvSpPr>
-            <a:spLocks noGrp="1"/>
-          </p:cNvSpPr>
-          <p:nvPr>
-            <p:ph type="sldNum" sz="quarter" idx="10"/>
-          </p:nvPr>
-        </p:nvSpPr>
-        <p:spPr/>
-        <p:txBody>
-          <a:bodyPr/>
-          <a:lstStyle/>
-          <a:p>
-            <a:fld id="{F7021451-1387-4CA6-816F-3879F97B5CBC}" type="slidenum">
-              <a:rPr lang="en-US"/>
-              <a:t>16</a:t>
-            </a:fld>
-            <a:endParaRPr lang="en-US"/>
-          </a:p>
-        </p:txBody>
-      </p:sp>
-    </p:spTree>
-    <p:extLst>
-      <p:ext uri="{BB962C8B-B14F-4D97-AF65-F5344CB8AC3E}">
-        <p14:creationId xmlns:p14="http://schemas.microsoft.com/office/powerpoint/2010/main" val="1024086991"/>
-      </p:ext>
-    </p:extLst>
-  </p:cSld>
-  <p:clrMapOvr>
-    <a:masterClrMapping/>
-  </p:clrMapOvr>
-</p:notes>
-</file>
-
-<file path=ppt/notesSlides/notesSlide17.xml><?xml version="1.0" encoding="utf-8"?>
-<p:notes xmlns:a="http://schemas.openxmlformats.org/drawingml/2006/main" xmlns:r="http://schemas.openxmlformats.org/officeDocument/2006/relationships" xmlns:p="http://schemas.openxmlformats.org/presentationml/2006/main">
-  <p:cSld>
-    <p:spTree>
-      <p:nvGrpSpPr>
-        <p:cNvPr id="1" name=""/>
-        <p:cNvGrpSpPr/>
-        <p:nvPr/>
-      </p:nvGrpSpPr>
-      <p:grpSpPr>
-        <a:xfrm>
-          <a:off x="0" y="0"/>
-          <a:ext cx="0" cy="0"/>
-          <a:chOff x="0" y="0"/>
-          <a:chExt cx="0" cy="0"/>
-        </a:xfrm>
-      </p:grpSpPr>
-      <p:sp>
-        <p:nvSpPr>
-          <p:cNvPr id="2" name="Slide Image Placeholder 1"/>
-          <p:cNvSpPr>
-            <a:spLocks noGrp="1" noRot="1" noChangeAspect="1"/>
-          </p:cNvSpPr>
-          <p:nvPr>
-            <p:ph type="sldImg"/>
-          </p:nvPr>
-        </p:nvSpPr>
-        <p:spPr/>
-      </p:sp>
-      <p:sp>
-        <p:nvSpPr>
-          <p:cNvPr id="3" name="Notes Placeholder 2"/>
-          <p:cNvSpPr>
-            <a:spLocks noGrp="1"/>
-          </p:cNvSpPr>
-          <p:nvPr>
-            <p:ph type="body" idx="1"/>
-          </p:nvPr>
-        </p:nvSpPr>
-        <p:spPr/>
-        <p:txBody>
-          <a:bodyPr/>
-          <a:lstStyle/>
-          <a:p>
-            <a:r>
-              <a:rPr lang="en-US" dirty="0"/>
-              <a:t>Three groups rather than a numbered list of seven, because the grouping is the
-point and the exact ordinal of each part is not.
-Do not explain why yet. Put it up, say that the order is deliberate and looks
-strange, and let the next slide pay it off. If someone guesses the reason before
-you get there, that is the best outcome available.
-Their build assembles this same thing, and the packet asks them to say what goes
-in it and in what order. This slide is the argument that the answer is a design
-decision rather than a detail.</a:t>
-            </a:r>
-            <a:endParaRPr lang="en-US" dirty="0"/>
-          </a:p>
-        </p:txBody>
-      </p:sp>
-      <p:sp>
-        <p:nvSpPr>
-          <p:cNvPr id="4" name="Slide Number Placeholder 3"/>
-          <p:cNvSpPr>
-            <a:spLocks noGrp="1"/>
-          </p:cNvSpPr>
-          <p:nvPr>
-            <p:ph type="sldNum" sz="quarter" idx="10"/>
-          </p:nvPr>
-        </p:nvSpPr>
-        <p:spPr/>
-        <p:txBody>
-          <a:bodyPr/>
-          <a:lstStyle/>
-          <a:p>
-            <a:fld id="{F7021451-1387-4CA6-816F-3879F97B5CBC}" type="slidenum">
-              <a:rPr lang="en-US"/>
-              <a:t>17</a:t>
-            </a:fld>
-            <a:endParaRPr lang="en-US"/>
-          </a:p>
-        </p:txBody>
-      </p:sp>
-    </p:spTree>
-    <p:extLst>
-      <p:ext uri="{BB962C8B-B14F-4D97-AF65-F5344CB8AC3E}">
-        <p14:creationId xmlns:p14="http://schemas.microsoft.com/office/powerpoint/2010/main" val="1024086991"/>
-      </p:ext>
-    </p:extLst>
-  </p:cSld>
-  <p:clrMapOvr>
-    <a:masterClrMapping/>
-  </p:clrMapOvr>
-</p:notes>
-</file>
-
-<file path=ppt/notesSlides/notesSlide18.xml><?xml version="1.0" encoding="utf-8"?>
-<p:notes xmlns:a="http://schemas.openxmlformats.org/drawingml/2006/main" xmlns:r="http://schemas.openxmlformats.org/officeDocument/2006/relationships" xmlns:p="http://schemas.openxmlformats.org/presentationml/2006/main">
-  <p:cSld>
-    <p:spTree>
-      <p:nvGrpSpPr>
-        <p:cNvPr id="1" name=""/>
-        <p:cNvGrpSpPr/>
-        <p:nvPr/>
-      </p:nvGrpSpPr>
-      <p:grpSpPr>
-        <a:xfrm>
-          <a:off x="0" y="0"/>
-          <a:ext cx="0" cy="0"/>
-          <a:chOff x="0" y="0"/>
-          <a:chExt cx="0" cy="0"/>
-        </a:xfrm>
-      </p:grpSpPr>
-      <p:sp>
-        <p:nvSpPr>
-          <p:cNvPr id="2" name="Slide Image Placeholder 1"/>
-          <p:cNvSpPr>
-            <a:spLocks noGrp="1" noRot="1" noChangeAspect="1"/>
-          </p:cNvSpPr>
-          <p:nvPr>
-            <p:ph type="sldImg"/>
-          </p:nvPr>
-        </p:nvSpPr>
-        <p:spPr/>
-      </p:sp>
-      <p:sp>
-        <p:nvSpPr>
-          <p:cNvPr id="3" name="Notes Placeholder 2"/>
-          <p:cNvSpPr>
-            <a:spLocks noGrp="1"/>
-          </p:cNvSpPr>
-          <p:nvPr>
-            <p:ph type="body" idx="1"/>
-          </p:nvPr>
-        </p:nvSpPr>
-        <p:spPr/>
-        <p:txBody>
-          <a:bodyPr/>
-          <a:lstStyle/>
-          <a:p>
-            <a:r>
-              <a:rPr lang="en-US" dirty="0"/>
-              <a:t>Now the previous slide makes sense. Work the two rows and then point back.
-This is not the model remembering. Nothing is remembered between sessions. It is
-the serving layer recognising text it has already processed and picking up where
-it left off, and it holds on the course endpoint as much as on a hosted API. The
-plumbing differs, a hosted API marks the points explicitly and a local server
-reuses the longest opening it recognises, and the rule is identical either way.
-Then land the bold line against the order slide: the parts that change every
-turn were put at the end so that changing them costs the least. That is a real
-design principle and it is worth more to them than the mechanism itself.
-If they want dollar figures, quote the provider's current pricing page rather
-than a number from memory. What they will feel on their own machine is the
-wait before the first token, not money.</a:t>
-            </a:r>
-            <a:endParaRPr lang="en-US" dirty="0"/>
-          </a:p>
-        </p:txBody>
-      </p:sp>
-      <p:sp>
-        <p:nvSpPr>
-          <p:cNvPr id="4" name="Slide Number Placeholder 3"/>
-          <p:cNvSpPr>
-            <a:spLocks noGrp="1"/>
-          </p:cNvSpPr>
-          <p:nvPr>
-            <p:ph type="sldNum" sz="quarter" idx="10"/>
-          </p:nvPr>
-        </p:nvSpPr>
-        <p:spPr/>
-        <p:txBody>
-          <a:bodyPr/>
-          <a:lstStyle/>
-          <a:p>
-            <a:fld id="{F7021451-1387-4CA6-816F-3879F97B5CBC}" type="slidenum">
-              <a:rPr lang="en-US"/>
-              <a:t>18</a:t>
-            </a:fld>
-            <a:endParaRPr lang="en-US"/>
-          </a:p>
-        </p:txBody>
-      </p:sp>
-    </p:spTree>
-    <p:extLst>
-      <p:ext uri="{BB962C8B-B14F-4D97-AF65-F5344CB8AC3E}">
-        <p14:creationId xmlns:p14="http://schemas.microsoft.com/office/powerpoint/2010/main" val="1024086991"/>
-      </p:ext>
-    </p:extLst>
-  </p:cSld>
-  <p:clrMapOvr>
-    <a:masterClrMapping/>
-  </p:clrMapOvr>
-</p:notes>
-</file>
-
-<file path=ppt/notesSlides/notesSlide19.xml><?xml version="1.0" encoding="utf-8"?>
-<p:notes xmlns:a="http://schemas.openxmlformats.org/drawingml/2006/main" xmlns:r="http://schemas.openxmlformats.org/officeDocument/2006/relationships" xmlns:p="http://schemas.openxmlformats.org/presentationml/2006/main">
-  <p:cSld>
-    <p:spTree>
-      <p:nvGrpSpPr>
-        <p:cNvPr id="1" name=""/>
-        <p:cNvGrpSpPr/>
-        <p:nvPr/>
-      </p:nvGrpSpPr>
-      <p:grpSpPr>
-        <a:xfrm>
-          <a:off x="0" y="0"/>
-          <a:ext cx="0" cy="0"/>
-          <a:chOff x="0" y="0"/>
-          <a:chExt cx="0" cy="0"/>
-        </a:xfrm>
-      </p:grpSpPr>
-      <p:sp>
-        <p:nvSpPr>
-          <p:cNvPr id="2" name="Slide Image Placeholder 1"/>
-          <p:cNvSpPr>
-            <a:spLocks noGrp="1" noRot="1" noChangeAspect="1"/>
-          </p:cNvSpPr>
-          <p:nvPr>
-            <p:ph type="sldImg"/>
-          </p:nvPr>
-        </p:nvSpPr>
-        <p:spPr/>
-      </p:sp>
-      <p:sp>
-        <p:nvSpPr>
-          <p:cNvPr id="3" name="Notes Placeholder 2"/>
-          <p:cNvSpPr>
-            <a:spLocks noGrp="1"/>
-          </p:cNvSpPr>
-          <p:nvPr>
-            <p:ph type="body" idx="1"/>
-          </p:nvPr>
-        </p:nvSpPr>
-        <p:spPr/>
-        <p:txBody>
-          <a:bodyPr/>
-          <a:lstStyle/>
-          <a:p>
-            <a:r>
-              <a:rPr lang="en-US" dirty="0"/>
-              <a:t>Three things, all verified in the source, and the third is the one nobody
-guesses.
-Ask mode is not a smaller code mode. It is a different system prompt with the
-worked examples removed, and it sits at the very front, so flipping between ask
-and code throws the whole prefix away rather than part of it. A quick question
-mid task is not free.
-Adding a file changes the file block and the repo map, because files in the chat
-come out of the map.
-The third: by default the map is rebuilt from the filenames and identifiers
-found in the message just typed. Mention a file in passing and the map moves.
-Aider knows, which is why turning caching on quietly switches the map to a
-stabler refresh mode.
-The habit worth giving them: settle the file set before starting, and keep a
-question in its own session.</a:t>
-            </a:r>
-            <a:endParaRPr lang="en-US" dirty="0"/>
-          </a:p>
-        </p:txBody>
-      </p:sp>
-      <p:sp>
-        <p:nvSpPr>
-          <p:cNvPr id="4" name="Slide Number Placeholder 3"/>
-          <p:cNvSpPr>
-            <a:spLocks noGrp="1"/>
-          </p:cNvSpPr>
-          <p:nvPr>
-            <p:ph type="sldNum" sz="quarter" idx="10"/>
-          </p:nvPr>
-        </p:nvSpPr>
-        <p:spPr/>
-        <p:txBody>
-          <a:bodyPr/>
-          <a:lstStyle/>
-          <a:p>
-            <a:fld id="{F7021451-1387-4CA6-816F-3879F97B5CBC}" type="slidenum">
-              <a:rPr lang="en-US"/>
-              <a:t>19</a:t>
-            </a:fld>
-            <a:endParaRPr lang="en-US"/>
-          </a:p>
-        </p:txBody>
-      </p:sp>
-    </p:spTree>
-    <p:extLst>
-      <p:ext uri="{BB962C8B-B14F-4D97-AF65-F5344CB8AC3E}">
-        <p14:creationId xmlns:p14="http://schemas.microsoft.com/office/powerpoint/2010/main" val="1024086991"/>
-      </p:ext>
-    </p:extLst>
-  </p:cSld>
-  <p:clrMapOvr>
-    <a:masterClrMapping/>
-  </p:clrMapOvr>
-</p:notes>
-</file>
-
-<file path=ppt/notesSlides/notesSlide2.xml><?xml version="1.0" encoding="utf-8"?>
-<p:notes xmlns:a="http://schemas.openxmlformats.org/drawingml/2006/main" xmlns:r="http://schemas.openxmlformats.org/officeDocument/2006/relationships" xmlns:p="http://schemas.openxmlformats.org/presentationml/2006/main">
-  <p:cSld>
-    <p:spTree>
-      <p:nvGrpSpPr>
-        <p:cNvPr id="1" name=""/>
-        <p:cNvGrpSpPr/>
-        <p:nvPr/>
-      </p:nvGrpSpPr>
-      <p:grpSpPr>
-        <a:xfrm>
-          <a:off x="0" y="0"/>
-          <a:ext cx="0" cy="0"/>
-          <a:chOff x="0" y="0"/>
-          <a:chExt cx="0" cy="0"/>
-        </a:xfrm>
-      </p:grpSpPr>
-      <p:sp>
-        <p:nvSpPr>
-          <p:cNvPr id="2" name="Slide Image Placeholder 1"/>
-          <p:cNvSpPr>
-            <a:spLocks noGrp="1" noRot="1" noChangeAspect="1"/>
-          </p:cNvSpPr>
-          <p:nvPr>
-            <p:ph type="sldImg"/>
-          </p:nvPr>
-        </p:nvSpPr>
-        <p:spPr/>
-      </p:sp>
-      <p:sp>
-        <p:nvSpPr>
-          <p:cNvPr id="3" name="Notes Placeholder 2"/>
-          <p:cNvSpPr>
-            <a:spLocks noGrp="1"/>
-          </p:cNvSpPr>
-          <p:nvPr>
-            <p:ph type="body" idx="1"/>
-          </p:nvPr>
-        </p:nvSpPr>
-        <p:spPr/>
-        <p:txBody>
-          <a:bodyPr/>
-          <a:lstStyle/>
-          <a:p>
-            <a:r>
-              <a:rPr lang="en-US" dirty="0"/>
-              <a:t>Put this up while the room settles and leave it up. The agenda is part of the
-first block, not an extra segment in front of it.
-Say out loud that the second half is genuinely office hours: they work, you
-circulate, and nobody hands anything in today. Students who have been told all
-term that labs end in a checkoff will not believe it unless you say it. The
-slide no longer says so, so this is on you to say.
-Do not preview the build past the word itself. The reveal is still yours to
-make in the third section.</a:t>
-            </a:r>
-            <a:endParaRPr lang="en-US" dirty="0"/>
-          </a:p>
-        </p:txBody>
-      </p:sp>
-      <p:sp>
-        <p:nvSpPr>
-          <p:cNvPr id="4" name="Slide Number Placeholder 3"/>
-          <p:cNvSpPr>
-            <a:spLocks noGrp="1"/>
-          </p:cNvSpPr>
-          <p:nvPr>
-            <p:ph type="sldNum" sz="quarter" idx="10"/>
-          </p:nvPr>
-        </p:nvSpPr>
-        <p:spPr/>
-        <p:txBody>
-          <a:bodyPr/>
-          <a:lstStyle/>
-          <a:p>
-            <a:fld id="{F7021451-1387-4CA6-816F-3879F97B5CBC}" type="slidenum">
-              <a:rPr lang="en-US"/>
-              <a:t>2</a:t>
-            </a:fld>
-            <a:endParaRPr lang="en-US"/>
-          </a:p>
-        </p:txBody>
-      </p:sp>
-    </p:spTree>
-    <p:extLst>
-      <p:ext uri="{BB962C8B-B14F-4D97-AF65-F5344CB8AC3E}">
-        <p14:creationId xmlns:p14="http://schemas.microsoft.com/office/powerpoint/2010/main" val="1024086991"/>
-      </p:ext>
-    </p:extLst>
-  </p:cSld>
-  <p:clrMapOvr>
-    <a:masterClrMapping/>
-  </p:clrMapOvr>
-</p:notes>
-</file>
-
-<file path=ppt/notesSlides/notesSlide20.xml><?xml version="1.0" encoding="utf-8"?>
 <p:notes xmlns:a="http://schemas.openxmlformats.org/drawingml/2006/main" xmlns:r="http://schemas.openxmlformats.org/officeDocument/2006/relationships" xmlns:p="http://schemas.openxmlformats.org/presentationml/2006/main">
   <p:cSld>
     <p:spTree>
@@ -1720,7 +1057,7 @@
           <a:p>
             <a:fld id="{F7021451-1387-4CA6-816F-3879F97B5CBC}" type="slidenum">
               <a:rPr lang="en-US"/>
-              <a:t>20</a:t>
+              <a:t>14</a:t>
             </a:fld>
             <a:endParaRPr lang="en-US"/>
           </a:p>
@@ -1739,7 +1076,7 @@
 </p:notes>
 </file>
 
-<file path=ppt/notesSlides/notesSlide21.xml><?xml version="1.0" encoding="utf-8"?>
+<file path=ppt/notesSlides/notesSlide15.xml><?xml version="1.0" encoding="utf-8"?>
 <p:notes xmlns:a="http://schemas.openxmlformats.org/drawingml/2006/main" xmlns:r="http://schemas.openxmlformats.org/officeDocument/2006/relationships" xmlns:p="http://schemas.openxmlformats.org/presentationml/2006/main">
   <p:cSld>
     <p:spTree>
@@ -1816,7 +1153,7 @@
           <a:p>
             <a:fld id="{F7021451-1387-4CA6-816F-3879F97B5CBC}" type="slidenum">
               <a:rPr lang="en-US"/>
-              <a:t>21</a:t>
+              <a:t>15</a:t>
             </a:fld>
             <a:endParaRPr lang="en-US"/>
           </a:p>
@@ -1835,7 +1172,7 @@
 </p:notes>
 </file>
 
-<file path=ppt/notesSlides/notesSlide22.xml><?xml version="1.0" encoding="utf-8"?>
+<file path=ppt/notesSlides/notesSlide16.xml><?xml version="1.0" encoding="utf-8"?>
 <p:notes xmlns:a="http://schemas.openxmlformats.org/drawingml/2006/main" xmlns:r="http://schemas.openxmlformats.org/officeDocument/2006/relationships" xmlns:p="http://schemas.openxmlformats.org/presentationml/2006/main">
   <p:cSld>
     <p:spTree>
@@ -1913,7 +1250,7 @@
           <a:p>
             <a:fld id="{F7021451-1387-4CA6-816F-3879F97B5CBC}" type="slidenum">
               <a:rPr lang="en-US"/>
-              <a:t>22</a:t>
+              <a:t>16</a:t>
             </a:fld>
             <a:endParaRPr lang="en-US"/>
           </a:p>
@@ -1932,7 +1269,7 @@
 </p:notes>
 </file>
 
-<file path=ppt/notesSlides/notesSlide23.xml><?xml version="1.0" encoding="utf-8"?>
+<file path=ppt/notesSlides/notesSlide17.xml><?xml version="1.0" encoding="utf-8"?>
 <p:notes xmlns:a="http://schemas.openxmlformats.org/drawingml/2006/main" xmlns:r="http://schemas.openxmlformats.org/officeDocument/2006/relationships" xmlns:p="http://schemas.openxmlformats.org/presentationml/2006/main">
   <p:cSld>
     <p:spTree>
@@ -2009,7 +1346,7 @@
           <a:p>
             <a:fld id="{F7021451-1387-4CA6-816F-3879F97B5CBC}" type="slidenum">
               <a:rPr lang="en-US"/>
-              <a:t>23</a:t>
+              <a:t>17</a:t>
             </a:fld>
             <a:endParaRPr lang="en-US"/>
           </a:p>
@@ -2028,7 +1365,7 @@
 </p:notes>
 </file>
 
-<file path=ppt/notesSlides/notesSlide24.xml><?xml version="1.0" encoding="utf-8"?>
+<file path=ppt/notesSlides/notesSlide18.xml><?xml version="1.0" encoding="utf-8"?>
 <p:notes xmlns:a="http://schemas.openxmlformats.org/drawingml/2006/main" xmlns:r="http://schemas.openxmlformats.org/officeDocument/2006/relationships" xmlns:p="http://schemas.openxmlformats.org/presentationml/2006/main">
   <p:cSld>
     <p:spTree>
@@ -2107,7 +1444,7 @@
           <a:p>
             <a:fld id="{F7021451-1387-4CA6-816F-3879F97B5CBC}" type="slidenum">
               <a:rPr lang="en-US"/>
-              <a:t>24</a:t>
+              <a:t>18</a:t>
             </a:fld>
             <a:endParaRPr lang="en-US"/>
           </a:p>
@@ -2126,7 +1463,7 @@
 </p:notes>
 </file>
 
-<file path=ppt/notesSlides/notesSlide25.xml><?xml version="1.0" encoding="utf-8"?>
+<file path=ppt/notesSlides/notesSlide19.xml><?xml version="1.0" encoding="utf-8"?>
 <p:notes xmlns:a="http://schemas.openxmlformats.org/drawingml/2006/main" xmlns:r="http://schemas.openxmlformats.org/officeDocument/2006/relationships" xmlns:p="http://schemas.openxmlformats.org/presentationml/2006/main">
   <p:cSld>
     <p:spTree>
@@ -2205,7 +1542,7 @@
           <a:p>
             <a:fld id="{F7021451-1387-4CA6-816F-3879F97B5CBC}" type="slidenum">
               <a:rPr lang="en-US"/>
-              <a:t>25</a:t>
+              <a:t>19</a:t>
             </a:fld>
             <a:endParaRPr lang="en-US"/>
           </a:p>
@@ -2224,7 +1561,102 @@
 </p:notes>
 </file>
 
-<file path=ppt/notesSlides/notesSlide26.xml><?xml version="1.0" encoding="utf-8"?>
+<file path=ppt/notesSlides/notesSlide2.xml><?xml version="1.0" encoding="utf-8"?>
+<p:notes xmlns:a="http://schemas.openxmlformats.org/drawingml/2006/main" xmlns:r="http://schemas.openxmlformats.org/officeDocument/2006/relationships" xmlns:p="http://schemas.openxmlformats.org/presentationml/2006/main">
+  <p:cSld>
+    <p:spTree>
+      <p:nvGrpSpPr>
+        <p:cNvPr id="1" name=""/>
+        <p:cNvGrpSpPr/>
+        <p:nvPr/>
+      </p:nvGrpSpPr>
+      <p:grpSpPr>
+        <a:xfrm>
+          <a:off x="0" y="0"/>
+          <a:ext cx="0" cy="0"/>
+          <a:chOff x="0" y="0"/>
+          <a:chExt cx="0" cy="0"/>
+        </a:xfrm>
+      </p:grpSpPr>
+      <p:sp>
+        <p:nvSpPr>
+          <p:cNvPr id="2" name="Slide Image Placeholder 1"/>
+          <p:cNvSpPr>
+            <a:spLocks noGrp="1" noRot="1" noChangeAspect="1"/>
+          </p:cNvSpPr>
+          <p:nvPr>
+            <p:ph type="sldImg"/>
+          </p:nvPr>
+        </p:nvSpPr>
+        <p:spPr/>
+      </p:sp>
+      <p:sp>
+        <p:nvSpPr>
+          <p:cNvPr id="3" name="Notes Placeholder 2"/>
+          <p:cNvSpPr>
+            <a:spLocks noGrp="1"/>
+          </p:cNvSpPr>
+          <p:nvPr>
+            <p:ph type="body" idx="1"/>
+          </p:nvPr>
+        </p:nvSpPr>
+        <p:spPr/>
+        <p:txBody>
+          <a:bodyPr/>
+          <a:lstStyle/>
+          <a:p>
+            <a:r>
+              <a:rPr lang="en-US" dirty="0"/>
+              <a:t>Put this up while the room settles and leave it up. The agenda is part of the
+first block, not an extra segment in front of it.
+Say out loud that the second half is genuinely office hours: they work, you
+circulate, and nobody hands anything in today. Students who have been told all
+term that labs end in a checkoff will not believe it unless you say it. The
+slide no longer says so, so this is on you to say.
+Do not preview the build past the word itself. The reveal is still yours to
+make in the third section.</a:t>
+            </a:r>
+            <a:endParaRPr lang="en-US" dirty="0"/>
+          </a:p>
+        </p:txBody>
+      </p:sp>
+      <p:sp>
+        <p:nvSpPr>
+          <p:cNvPr id="4" name="Slide Number Placeholder 3"/>
+          <p:cNvSpPr>
+            <a:spLocks noGrp="1"/>
+          </p:cNvSpPr>
+          <p:nvPr>
+            <p:ph type="sldNum" sz="quarter" idx="10"/>
+          </p:nvPr>
+        </p:nvSpPr>
+        <p:spPr/>
+        <p:txBody>
+          <a:bodyPr/>
+          <a:lstStyle/>
+          <a:p>
+            <a:fld id="{F7021451-1387-4CA6-816F-3879F97B5CBC}" type="slidenum">
+              <a:rPr lang="en-US"/>
+              <a:t>2</a:t>
+            </a:fld>
+            <a:endParaRPr lang="en-US"/>
+          </a:p>
+        </p:txBody>
+      </p:sp>
+    </p:spTree>
+    <p:extLst>
+      <p:ext uri="{BB962C8B-B14F-4D97-AF65-F5344CB8AC3E}">
+        <p14:creationId xmlns:p14="http://schemas.microsoft.com/office/powerpoint/2010/main" val="1024086991"/>
+      </p:ext>
+    </p:extLst>
+  </p:cSld>
+  <p:clrMapOvr>
+    <a:masterClrMapping/>
+  </p:clrMapOvr>
+</p:notes>
+</file>
+
+<file path=ppt/notesSlides/notesSlide20.xml><?xml version="1.0" encoding="utf-8"?>
 <p:notes xmlns:a="http://schemas.openxmlformats.org/drawingml/2006/main" xmlns:r="http://schemas.openxmlformats.org/officeDocument/2006/relationships" xmlns:p="http://schemas.openxmlformats.org/presentationml/2006/main">
   <p:cSld>
     <p:spTree>
@@ -2298,7 +1730,7 @@
           <a:p>
             <a:fld id="{F7021451-1387-4CA6-816F-3879F97B5CBC}" type="slidenum">
               <a:rPr lang="en-US"/>
-              <a:t>26</a:t>
+              <a:t>20</a:t>
             </a:fld>
             <a:endParaRPr lang="en-US"/>
           </a:p>
@@ -2317,7 +1749,7 @@
 </p:notes>
 </file>
 
-<file path=ppt/notesSlides/notesSlide27.xml><?xml version="1.0" encoding="utf-8"?>
+<file path=ppt/notesSlides/notesSlide21.xml><?xml version="1.0" encoding="utf-8"?>
 <p:notes xmlns:a="http://schemas.openxmlformats.org/drawingml/2006/main" xmlns:r="http://schemas.openxmlformats.org/officeDocument/2006/relationships" xmlns:p="http://schemas.openxmlformats.org/presentationml/2006/main">
   <p:cSld>
     <p:spTree>
@@ -2405,7 +1837,7 @@
           <a:p>
             <a:fld id="{F7021451-1387-4CA6-816F-3879F97B5CBC}" type="slidenum">
               <a:rPr lang="en-US"/>
-              <a:t>27</a:t>
+              <a:t>21</a:t>
             </a:fld>
             <a:endParaRPr lang="en-US"/>
           </a:p>
@@ -2424,7 +1856,7 @@
 </p:notes>
 </file>
 
-<file path=ppt/notesSlides/notesSlide28.xml><?xml version="1.0" encoding="utf-8"?>
+<file path=ppt/notesSlides/notesSlide22.xml><?xml version="1.0" encoding="utf-8"?>
 <p:notes xmlns:a="http://schemas.openxmlformats.org/drawingml/2006/main" xmlns:r="http://schemas.openxmlformats.org/officeDocument/2006/relationships" xmlns:p="http://schemas.openxmlformats.org/presentationml/2006/main">
   <p:cSld>
     <p:spTree>
@@ -2496,7 +1928,7 @@
           <a:p>
             <a:fld id="{F7021451-1387-4CA6-816F-3879F97B5CBC}" type="slidenum">
               <a:rPr lang="en-US"/>
-              <a:t>28</a:t>
+              <a:t>22</a:t>
             </a:fld>
             <a:endParaRPr lang="en-US"/>
           </a:p>
@@ -2515,7 +1947,7 @@
 </p:notes>
 </file>
 
-<file path=ppt/notesSlides/notesSlide29.xml><?xml version="1.0" encoding="utf-8"?>
+<file path=ppt/notesSlides/notesSlide23.xml><?xml version="1.0" encoding="utf-8"?>
 <p:notes xmlns:a="http://schemas.openxmlformats.org/drawingml/2006/main" xmlns:r="http://schemas.openxmlformats.org/officeDocument/2006/relationships" xmlns:p="http://schemas.openxmlformats.org/presentationml/2006/main">
   <p:cSld>
     <p:spTree>
@@ -2592,7 +2024,7 @@
           <a:p>
             <a:fld id="{F7021451-1387-4CA6-816F-3879F97B5CBC}" type="slidenum">
               <a:rPr lang="en-US"/>
-              <a:t>29</a:t>
+              <a:t>23</a:t>
             </a:fld>
             <a:endParaRPr lang="en-US"/>
           </a:p>
@@ -2611,102 +2043,7 @@
 </p:notes>
 </file>
 
-<file path=ppt/notesSlides/notesSlide3.xml><?xml version="1.0" encoding="utf-8"?>
-<p:notes xmlns:a="http://schemas.openxmlformats.org/drawingml/2006/main" xmlns:r="http://schemas.openxmlformats.org/officeDocument/2006/relationships" xmlns:p="http://schemas.openxmlformats.org/presentationml/2006/main">
-  <p:cSld>
-    <p:spTree>
-      <p:nvGrpSpPr>
-        <p:cNvPr id="1" name=""/>
-        <p:cNvGrpSpPr/>
-        <p:nvPr/>
-      </p:nvGrpSpPr>
-      <p:grpSpPr>
-        <a:xfrm>
-          <a:off x="0" y="0"/>
-          <a:ext cx="0" cy="0"/>
-          <a:chOff x="0" y="0"/>
-          <a:chExt cx="0" cy="0"/>
-        </a:xfrm>
-      </p:grpSpPr>
-      <p:sp>
-        <p:nvSpPr>
-          <p:cNvPr id="2" name="Slide Image Placeholder 1"/>
-          <p:cNvSpPr>
-            <a:spLocks noGrp="1" noRot="1" noChangeAspect="1"/>
-          </p:cNvSpPr>
-          <p:nvPr>
-            <p:ph type="sldImg"/>
-          </p:nvPr>
-        </p:nvSpPr>
-        <p:spPr/>
-      </p:sp>
-      <p:sp>
-        <p:nvSpPr>
-          <p:cNvPr id="3" name="Notes Placeholder 2"/>
-          <p:cNvSpPr>
-            <a:spLocks noGrp="1"/>
-          </p:cNvSpPr>
-          <p:nvPr>
-            <p:ph type="body" idx="1"/>
-          </p:nvPr>
-        </p:nvSpPr>
-        <p:spPr/>
-        <p:txBody>
-          <a:bodyPr/>
-          <a:lstStyle/>
-          <a:p>
-            <a:r>
-              <a:rPr lang="en-US" dirty="0"/>
-              <a:t>This is the slide the deck was missing. Sixteen practice lessons gave them the
-muscle memory and none of the model, and the word "harness" is the one they
-need, because it is the thing they build in Stage 1 and extend in Analyze.
-Say the right-hand column out loud. The model's entire contribution is one
-block of text. Every effect on their machine is the left column acting on it.
-If anyone asks about models, endpoints or config: MODEL-POLICY.md, and it is
-not today's subject. qwen3.5:9b recommended, 4B permitted, any compatible
-endpoint.</a:t>
-            </a:r>
-            <a:endParaRPr lang="en-US" dirty="0"/>
-          </a:p>
-        </p:txBody>
-      </p:sp>
-      <p:sp>
-        <p:nvSpPr>
-          <p:cNvPr id="4" name="Slide Number Placeholder 3"/>
-          <p:cNvSpPr>
-            <a:spLocks noGrp="1"/>
-          </p:cNvSpPr>
-          <p:nvPr>
-            <p:ph type="sldNum" sz="quarter" idx="10"/>
-          </p:nvPr>
-        </p:nvSpPr>
-        <p:spPr/>
-        <p:txBody>
-          <a:bodyPr/>
-          <a:lstStyle/>
-          <a:p>
-            <a:fld id="{F7021451-1387-4CA6-816F-3879F97B5CBC}" type="slidenum">
-              <a:rPr lang="en-US"/>
-              <a:t>3</a:t>
-            </a:fld>
-            <a:endParaRPr lang="en-US"/>
-          </a:p>
-        </p:txBody>
-      </p:sp>
-    </p:spTree>
-    <p:extLst>
-      <p:ext uri="{BB962C8B-B14F-4D97-AF65-F5344CB8AC3E}">
-        <p14:creationId xmlns:p14="http://schemas.microsoft.com/office/powerpoint/2010/main" val="1024086991"/>
-      </p:ext>
-    </p:extLst>
-  </p:cSld>
-  <p:clrMapOvr>
-    <a:masterClrMapping/>
-  </p:clrMapOvr>
-</p:notes>
-</file>
-
-<file path=ppt/notesSlides/notesSlide30.xml><?xml version="1.0" encoding="utf-8"?>
+<file path=ppt/notesSlides/notesSlide24.xml><?xml version="1.0" encoding="utf-8"?>
 <p:notes xmlns:a="http://schemas.openxmlformats.org/drawingml/2006/main" xmlns:r="http://schemas.openxmlformats.org/officeDocument/2006/relationships" xmlns:p="http://schemas.openxmlformats.org/presentationml/2006/main">
   <p:cSld>
     <p:spTree>
@@ -2786,7 +2123,7 @@
           <a:p>
             <a:fld id="{F7021451-1387-4CA6-816F-3879F97B5CBC}" type="slidenum">
               <a:rPr lang="en-US"/>
-              <a:t>30</a:t>
+              <a:t>24</a:t>
             </a:fld>
             <a:endParaRPr lang="en-US"/>
           </a:p>
@@ -2805,7 +2142,7 @@
 </p:notes>
 </file>
 
-<file path=ppt/notesSlides/notesSlide31.xml><?xml version="1.0" encoding="utf-8"?>
+<file path=ppt/notesSlides/notesSlide25.xml><?xml version="1.0" encoding="utf-8"?>
 <p:notes xmlns:a="http://schemas.openxmlformats.org/drawingml/2006/main" xmlns:r="http://schemas.openxmlformats.org/officeDocument/2006/relationships" xmlns:p="http://schemas.openxmlformats.org/presentationml/2006/main">
   <p:cSld>
     <p:spTree>
@@ -2879,7 +2216,7 @@
           <a:p>
             <a:fld id="{F7021451-1387-4CA6-816F-3879F97B5CBC}" type="slidenum">
               <a:rPr lang="en-US"/>
-              <a:t>31</a:t>
+              <a:t>25</a:t>
             </a:fld>
             <a:endParaRPr lang="en-US"/>
           </a:p>
@@ -2898,7 +2235,7 @@
 </p:notes>
 </file>
 
-<file path=ppt/notesSlides/notesSlide32.xml><?xml version="1.0" encoding="utf-8"?>
+<file path=ppt/notesSlides/notesSlide26.xml><?xml version="1.0" encoding="utf-8"?>
 <p:notes xmlns:a="http://schemas.openxmlformats.org/drawingml/2006/main" xmlns:r="http://schemas.openxmlformats.org/officeDocument/2006/relationships" xmlns:p="http://schemas.openxmlformats.org/presentationml/2006/main">
   <p:cSld>
     <p:spTree>
@@ -2974,7 +2311,7 @@
           <a:p>
             <a:fld id="{F7021451-1387-4CA6-816F-3879F97B5CBC}" type="slidenum">
               <a:rPr lang="en-US"/>
-              <a:t>32</a:t>
+              <a:t>26</a:t>
             </a:fld>
             <a:endParaRPr lang="en-US"/>
           </a:p>
@@ -2993,7 +2330,7 @@
 </p:notes>
 </file>
 
-<file path=ppt/notesSlides/notesSlide33.xml><?xml version="1.0" encoding="utf-8"?>
+<file path=ppt/notesSlides/notesSlide27.xml><?xml version="1.0" encoding="utf-8"?>
 <p:notes xmlns:a="http://schemas.openxmlformats.org/drawingml/2006/main" xmlns:r="http://schemas.openxmlformats.org/officeDocument/2006/relationships" xmlns:p="http://schemas.openxmlformats.org/presentationml/2006/main">
   <p:cSld>
     <p:spTree>
@@ -3077,7 +2414,7 @@
           <a:p>
             <a:fld id="{F7021451-1387-4CA6-816F-3879F97B5CBC}" type="slidenum">
               <a:rPr lang="en-US"/>
-              <a:t>33</a:t>
+              <a:t>27</a:t>
             </a:fld>
             <a:endParaRPr lang="en-US"/>
           </a:p>
@@ -3096,7 +2433,7 @@
 </p:notes>
 </file>
 
-<file path=ppt/notesSlides/notesSlide34.xml><?xml version="1.0" encoding="utf-8"?>
+<file path=ppt/notesSlides/notesSlide28.xml><?xml version="1.0" encoding="utf-8"?>
 <p:notes xmlns:a="http://schemas.openxmlformats.org/drawingml/2006/main" xmlns:r="http://schemas.openxmlformats.org/officeDocument/2006/relationships" xmlns:p="http://schemas.openxmlformats.org/presentationml/2006/main">
   <p:cSld>
     <p:spTree>
@@ -3170,7 +2507,7 @@
           <a:p>
             <a:fld id="{F7021451-1387-4CA6-816F-3879F97B5CBC}" type="slidenum">
               <a:rPr lang="en-US"/>
-              <a:t>34</a:t>
+              <a:t>28</a:t>
             </a:fld>
             <a:endParaRPr lang="en-US"/>
           </a:p>
@@ -3189,7 +2526,7 @@
 </p:notes>
 </file>
 
-<file path=ppt/notesSlides/notesSlide35.xml><?xml version="1.0" encoding="utf-8"?>
+<file path=ppt/notesSlides/notesSlide29.xml><?xml version="1.0" encoding="utf-8"?>
 <p:notes xmlns:a="http://schemas.openxmlformats.org/drawingml/2006/main" xmlns:r="http://schemas.openxmlformats.org/officeDocument/2006/relationships" xmlns:p="http://schemas.openxmlformats.org/presentationml/2006/main">
   <p:cSld>
     <p:spTree>
@@ -3262,7 +2599,7 @@
           <a:p>
             <a:fld id="{F7021451-1387-4CA6-816F-3879F97B5CBC}" type="slidenum">
               <a:rPr lang="en-US"/>
-              <a:t>35</a:t>
+              <a:t>29</a:t>
             </a:fld>
             <a:endParaRPr lang="en-US"/>
           </a:p>
@@ -3281,7 +2618,102 @@
 </p:notes>
 </file>
 
-<file path=ppt/notesSlides/notesSlide36.xml><?xml version="1.0" encoding="utf-8"?>
+<file path=ppt/notesSlides/notesSlide3.xml><?xml version="1.0" encoding="utf-8"?>
+<p:notes xmlns:a="http://schemas.openxmlformats.org/drawingml/2006/main" xmlns:r="http://schemas.openxmlformats.org/officeDocument/2006/relationships" xmlns:p="http://schemas.openxmlformats.org/presentationml/2006/main">
+  <p:cSld>
+    <p:spTree>
+      <p:nvGrpSpPr>
+        <p:cNvPr id="1" name=""/>
+        <p:cNvGrpSpPr/>
+        <p:nvPr/>
+      </p:nvGrpSpPr>
+      <p:grpSpPr>
+        <a:xfrm>
+          <a:off x="0" y="0"/>
+          <a:ext cx="0" cy="0"/>
+          <a:chOff x="0" y="0"/>
+          <a:chExt cx="0" cy="0"/>
+        </a:xfrm>
+      </p:grpSpPr>
+      <p:sp>
+        <p:nvSpPr>
+          <p:cNvPr id="2" name="Slide Image Placeholder 1"/>
+          <p:cNvSpPr>
+            <a:spLocks noGrp="1" noRot="1" noChangeAspect="1"/>
+          </p:cNvSpPr>
+          <p:nvPr>
+            <p:ph type="sldImg"/>
+          </p:nvPr>
+        </p:nvSpPr>
+        <p:spPr/>
+      </p:sp>
+      <p:sp>
+        <p:nvSpPr>
+          <p:cNvPr id="3" name="Notes Placeholder 2"/>
+          <p:cNvSpPr>
+            <a:spLocks noGrp="1"/>
+          </p:cNvSpPr>
+          <p:nvPr>
+            <p:ph type="body" idx="1"/>
+          </p:nvPr>
+        </p:nvSpPr>
+        <p:spPr/>
+        <p:txBody>
+          <a:bodyPr/>
+          <a:lstStyle/>
+          <a:p>
+            <a:r>
+              <a:rPr lang="en-US" dirty="0"/>
+              <a:t>This is the slide the deck was missing. Sixteen practice lessons gave them the
+muscle memory and none of the model, and the word "harness" is the one they
+need, because it is the thing they build in Stage 1 and extend in Analyze.
+Say the right-hand column out loud. The model's entire contribution is one
+block of text. Every effect on their machine is the left column acting on it.
+If anyone asks about models, endpoints or config: MODEL-POLICY.md, and it is
+not today's subject. qwen3.5:9b recommended, 4B permitted, any compatible
+endpoint.</a:t>
+            </a:r>
+            <a:endParaRPr lang="en-US" dirty="0"/>
+          </a:p>
+        </p:txBody>
+      </p:sp>
+      <p:sp>
+        <p:nvSpPr>
+          <p:cNvPr id="4" name="Slide Number Placeholder 3"/>
+          <p:cNvSpPr>
+            <a:spLocks noGrp="1"/>
+          </p:cNvSpPr>
+          <p:nvPr>
+            <p:ph type="sldNum" sz="quarter" idx="10"/>
+          </p:nvPr>
+        </p:nvSpPr>
+        <p:spPr/>
+        <p:txBody>
+          <a:bodyPr/>
+          <a:lstStyle/>
+          <a:p>
+            <a:fld id="{F7021451-1387-4CA6-816F-3879F97B5CBC}" type="slidenum">
+              <a:rPr lang="en-US"/>
+              <a:t>3</a:t>
+            </a:fld>
+            <a:endParaRPr lang="en-US"/>
+          </a:p>
+        </p:txBody>
+      </p:sp>
+    </p:spTree>
+    <p:extLst>
+      <p:ext uri="{BB962C8B-B14F-4D97-AF65-F5344CB8AC3E}">
+        <p14:creationId xmlns:p14="http://schemas.microsoft.com/office/powerpoint/2010/main" val="1024086991"/>
+      </p:ext>
+    </p:extLst>
+  </p:cSld>
+  <p:clrMapOvr>
+    <a:masterClrMapping/>
+  </p:clrMapOvr>
+</p:notes>
+</file>
+
+<file path=ppt/notesSlides/notesSlide30.xml><?xml version="1.0" encoding="utf-8"?>
 <p:notes xmlns:a="http://schemas.openxmlformats.org/drawingml/2006/main" xmlns:r="http://schemas.openxmlformats.org/officeDocument/2006/relationships" xmlns:p="http://schemas.openxmlformats.org/presentationml/2006/main">
   <p:cSld>
     <p:spTree>
@@ -3357,7 +2789,7 @@
           <a:p>
             <a:fld id="{F7021451-1387-4CA6-816F-3879F97B5CBC}" type="slidenum">
               <a:rPr lang="en-US"/>
-              <a:t>36</a:t>
+              <a:t>30</a:t>
             </a:fld>
             <a:endParaRPr lang="en-US"/>
           </a:p>
@@ -3376,7 +2808,7 @@
 </p:notes>
 </file>
 
-<file path=ppt/notesSlides/notesSlide37.xml><?xml version="1.0" encoding="utf-8"?>
+<file path=ppt/notesSlides/notesSlide31.xml><?xml version="1.0" encoding="utf-8"?>
 <p:notes xmlns:a="http://schemas.openxmlformats.org/drawingml/2006/main" xmlns:r="http://schemas.openxmlformats.org/officeDocument/2006/relationships" xmlns:p="http://schemas.openxmlformats.org/presentationml/2006/main">
   <p:cSld>
     <p:spTree>
@@ -3452,7 +2884,7 @@
           <a:p>
             <a:fld id="{F7021451-1387-4CA6-816F-3879F97B5CBC}" type="slidenum">
               <a:rPr lang="en-US"/>
-              <a:t>37</a:t>
+              <a:t>31</a:t>
             </a:fld>
             <a:endParaRPr lang="en-US"/>
           </a:p>
@@ -3471,7 +2903,7 @@
 </p:notes>
 </file>
 
-<file path=ppt/notesSlides/notesSlide38.xml><?xml version="1.0" encoding="utf-8"?>
+<file path=ppt/notesSlides/notesSlide32.xml><?xml version="1.0" encoding="utf-8"?>
 <p:notes xmlns:a="http://schemas.openxmlformats.org/drawingml/2006/main" xmlns:r="http://schemas.openxmlformats.org/officeDocument/2006/relationships" xmlns:p="http://schemas.openxmlformats.org/presentationml/2006/main">
   <p:cSld>
     <p:spTree>
@@ -3549,7 +2981,7 @@
           <a:p>
             <a:fld id="{F7021451-1387-4CA6-816F-3879F97B5CBC}" type="slidenum">
               <a:rPr lang="en-US"/>
-              <a:t>38</a:t>
+              <a:t>32</a:t>
             </a:fld>
             <a:endParaRPr lang="en-US"/>
           </a:p>
@@ -3568,7 +3000,7 @@
 </p:notes>
 </file>
 
-<file path=ppt/notesSlides/notesSlide39.xml><?xml version="1.0" encoding="utf-8"?>
+<file path=ppt/notesSlides/notesSlide33.xml><?xml version="1.0" encoding="utf-8"?>
 <p:notes xmlns:a="http://schemas.openxmlformats.org/drawingml/2006/main" xmlns:r="http://schemas.openxmlformats.org/officeDocument/2006/relationships" xmlns:p="http://schemas.openxmlformats.org/presentationml/2006/main">
   <p:cSld>
     <p:spTree>
@@ -3649,7 +3081,7 @@
           <a:p>
             <a:fld id="{F7021451-1387-4CA6-816F-3879F97B5CBC}" type="slidenum">
               <a:rPr lang="en-US"/>
-              <a:t>39</a:t>
+              <a:t>33</a:t>
             </a:fld>
             <a:endParaRPr lang="en-US"/>
           </a:p>
@@ -3668,103 +3100,7 @@
 </p:notes>
 </file>
 
-<file path=ppt/notesSlides/notesSlide4.xml><?xml version="1.0" encoding="utf-8"?>
-<p:notes xmlns:a="http://schemas.openxmlformats.org/drawingml/2006/main" xmlns:r="http://schemas.openxmlformats.org/officeDocument/2006/relationships" xmlns:p="http://schemas.openxmlformats.org/presentationml/2006/main">
-  <p:cSld>
-    <p:spTree>
-      <p:nvGrpSpPr>
-        <p:cNvPr id="1" name=""/>
-        <p:cNvGrpSpPr/>
-        <p:nvPr/>
-      </p:nvGrpSpPr>
-      <p:grpSpPr>
-        <a:xfrm>
-          <a:off x="0" y="0"/>
-          <a:ext cx="0" cy="0"/>
-          <a:chOff x="0" y="0"/>
-          <a:chExt cx="0" cy="0"/>
-        </a:xfrm>
-      </p:grpSpPr>
-      <p:sp>
-        <p:nvSpPr>
-          <p:cNvPr id="2" name="Slide Image Placeholder 1"/>
-          <p:cNvSpPr>
-            <a:spLocks noGrp="1" noRot="1" noChangeAspect="1"/>
-          </p:cNvSpPr>
-          <p:nvPr>
-            <p:ph type="sldImg"/>
-          </p:nvPr>
-        </p:nvSpPr>
-        <p:spPr/>
-      </p:sp>
-      <p:sp>
-        <p:nvSpPr>
-          <p:cNvPr id="3" name="Notes Placeholder 2"/>
-          <p:cNvSpPr>
-            <a:spLocks noGrp="1"/>
-          </p:cNvSpPr>
-          <p:nvPr>
-            <p:ph type="body" idx="1"/>
-          </p:nvPr>
-        </p:nvSpPr>
-        <p:spPr/>
-        <p:txBody>
-          <a:bodyPr/>
-          <a:lstStyle/>
-          <a:p>
-            <a:r>
-              <a:rPr lang="en-US" dirty="0"/>
-              <a:t>Three negatives, and each one is a design decision somebody made rather than a
-limitation of the model.
-The third is the one that surprises people: there is no memory between
-sessions. Continuity is the harness resending the history, which is why
-history spends their token budget later in the deck.
-The 4B and the 9B are asked for different reply shapes, whole files against
-diffs. That is why a classmate's session looks different from theirs, and why
-the trace they see later may not match what they ran in practice.
-Worth saying here, not worth a slide.</a:t>
-            </a:r>
-            <a:endParaRPr lang="en-US" dirty="0"/>
-          </a:p>
-        </p:txBody>
-      </p:sp>
-      <p:sp>
-        <p:nvSpPr>
-          <p:cNvPr id="4" name="Slide Number Placeholder 3"/>
-          <p:cNvSpPr>
-            <a:spLocks noGrp="1"/>
-          </p:cNvSpPr>
-          <p:nvPr>
-            <p:ph type="sldNum" sz="quarter" idx="10"/>
-          </p:nvPr>
-        </p:nvSpPr>
-        <p:spPr/>
-        <p:txBody>
-          <a:bodyPr/>
-          <a:lstStyle/>
-          <a:p>
-            <a:fld id="{F7021451-1387-4CA6-816F-3879F97B5CBC}" type="slidenum">
-              <a:rPr lang="en-US"/>
-              <a:t>4</a:t>
-            </a:fld>
-            <a:endParaRPr lang="en-US"/>
-          </a:p>
-        </p:txBody>
-      </p:sp>
-    </p:spTree>
-    <p:extLst>
-      <p:ext uri="{BB962C8B-B14F-4D97-AF65-F5344CB8AC3E}">
-        <p14:creationId xmlns:p14="http://schemas.microsoft.com/office/powerpoint/2010/main" val="1024086991"/>
-      </p:ext>
-    </p:extLst>
-  </p:cSld>
-  <p:clrMapOvr>
-    <a:masterClrMapping/>
-  </p:clrMapOvr>
-</p:notes>
-</file>
-
-<file path=ppt/notesSlides/notesSlide40.xml><?xml version="1.0" encoding="utf-8"?>
+<file path=ppt/notesSlides/notesSlide34.xml><?xml version="1.0" encoding="utf-8"?>
 <p:notes xmlns:a="http://schemas.openxmlformats.org/drawingml/2006/main" xmlns:r="http://schemas.openxmlformats.org/officeDocument/2006/relationships" xmlns:p="http://schemas.openxmlformats.org/presentationml/2006/main">
   <p:cSld>
     <p:spTree>
@@ -3836,7 +3172,7 @@
           <a:p>
             <a:fld id="{F7021451-1387-4CA6-816F-3879F97B5CBC}" type="slidenum">
               <a:rPr lang="en-US"/>
-              <a:t>40</a:t>
+              <a:t>34</a:t>
             </a:fld>
             <a:endParaRPr lang="en-US"/>
           </a:p>
@@ -3855,7 +3191,7 @@
 </p:notes>
 </file>
 
-<file path=ppt/notesSlides/notesSlide41.xml><?xml version="1.0" encoding="utf-8"?>
+<file path=ppt/notesSlides/notesSlide35.xml><?xml version="1.0" encoding="utf-8"?>
 <p:notes xmlns:a="http://schemas.openxmlformats.org/drawingml/2006/main" xmlns:r="http://schemas.openxmlformats.org/officeDocument/2006/relationships" xmlns:p="http://schemas.openxmlformats.org/presentationml/2006/main">
   <p:cSld>
     <p:spTree>
@@ -3933,7 +3269,7 @@
           <a:p>
             <a:fld id="{F7021451-1387-4CA6-816F-3879F97B5CBC}" type="slidenum">
               <a:rPr lang="en-US"/>
-              <a:t>41</a:t>
+              <a:t>35</a:t>
             </a:fld>
             <a:endParaRPr lang="en-US"/>
           </a:p>
@@ -3952,7 +3288,7 @@
 </p:notes>
 </file>
 
-<file path=ppt/notesSlides/notesSlide42.xml><?xml version="1.0" encoding="utf-8"?>
+<file path=ppt/notesSlides/notesSlide36.xml><?xml version="1.0" encoding="utf-8"?>
 <p:notes xmlns:a="http://schemas.openxmlformats.org/drawingml/2006/main" xmlns:r="http://schemas.openxmlformats.org/officeDocument/2006/relationships" xmlns:p="http://schemas.openxmlformats.org/presentationml/2006/main">
   <p:cSld>
     <p:spTree>
@@ -4028,7 +3364,7 @@
           <a:p>
             <a:fld id="{F7021451-1387-4CA6-816F-3879F97B5CBC}" type="slidenum">
               <a:rPr lang="en-US"/>
-              <a:t>42</a:t>
+              <a:t>36</a:t>
             </a:fld>
             <a:endParaRPr lang="en-US"/>
           </a:p>
@@ -4047,7 +3383,7 @@
 </p:notes>
 </file>
 
-<file path=ppt/notesSlides/notesSlide43.xml><?xml version="1.0" encoding="utf-8"?>
+<file path=ppt/notesSlides/notesSlide37.xml><?xml version="1.0" encoding="utf-8"?>
 <p:notes xmlns:a="http://schemas.openxmlformats.org/drawingml/2006/main" xmlns:r="http://schemas.openxmlformats.org/officeDocument/2006/relationships" xmlns:p="http://schemas.openxmlformats.org/presentationml/2006/main">
   <p:cSld>
     <p:spTree>
@@ -4119,7 +3455,7 @@
           <a:p>
             <a:fld id="{F7021451-1387-4CA6-816F-3879F97B5CBC}" type="slidenum">
               <a:rPr lang="en-US"/>
-              <a:t>43</a:t>
+              <a:t>37</a:t>
             </a:fld>
             <a:endParaRPr lang="en-US"/>
           </a:p>
@@ -4138,7 +3474,7 @@
 </p:notes>
 </file>
 
-<file path=ppt/notesSlides/notesSlide44.xml><?xml version="1.0" encoding="utf-8"?>
+<file path=ppt/notesSlides/notesSlide38.xml><?xml version="1.0" encoding="utf-8"?>
 <p:notes xmlns:a="http://schemas.openxmlformats.org/drawingml/2006/main" xmlns:r="http://schemas.openxmlformats.org/officeDocument/2006/relationships" xmlns:p="http://schemas.openxmlformats.org/presentationml/2006/main">
   <p:cSld>
     <p:spTree>
@@ -4207,7 +3543,103 @@
           <a:p>
             <a:fld id="{F7021451-1387-4CA6-816F-3879F97B5CBC}" type="slidenum">
               <a:rPr lang="en-US"/>
-              <a:t>44</a:t>
+              <a:t>38</a:t>
+            </a:fld>
+            <a:endParaRPr lang="en-US"/>
+          </a:p>
+        </p:txBody>
+      </p:sp>
+    </p:spTree>
+    <p:extLst>
+      <p:ext uri="{BB962C8B-B14F-4D97-AF65-F5344CB8AC3E}">
+        <p14:creationId xmlns:p14="http://schemas.microsoft.com/office/powerpoint/2010/main" val="1024086991"/>
+      </p:ext>
+    </p:extLst>
+  </p:cSld>
+  <p:clrMapOvr>
+    <a:masterClrMapping/>
+  </p:clrMapOvr>
+</p:notes>
+</file>
+
+<file path=ppt/notesSlides/notesSlide4.xml><?xml version="1.0" encoding="utf-8"?>
+<p:notes xmlns:a="http://schemas.openxmlformats.org/drawingml/2006/main" xmlns:r="http://schemas.openxmlformats.org/officeDocument/2006/relationships" xmlns:p="http://schemas.openxmlformats.org/presentationml/2006/main">
+  <p:cSld>
+    <p:spTree>
+      <p:nvGrpSpPr>
+        <p:cNvPr id="1" name=""/>
+        <p:cNvGrpSpPr/>
+        <p:nvPr/>
+      </p:nvGrpSpPr>
+      <p:grpSpPr>
+        <a:xfrm>
+          <a:off x="0" y="0"/>
+          <a:ext cx="0" cy="0"/>
+          <a:chOff x="0" y="0"/>
+          <a:chExt cx="0" cy="0"/>
+        </a:xfrm>
+      </p:grpSpPr>
+      <p:sp>
+        <p:nvSpPr>
+          <p:cNvPr id="2" name="Slide Image Placeholder 1"/>
+          <p:cNvSpPr>
+            <a:spLocks noGrp="1" noRot="1" noChangeAspect="1"/>
+          </p:cNvSpPr>
+          <p:nvPr>
+            <p:ph type="sldImg"/>
+          </p:nvPr>
+        </p:nvSpPr>
+        <p:spPr/>
+      </p:sp>
+      <p:sp>
+        <p:nvSpPr>
+          <p:cNvPr id="3" name="Notes Placeholder 2"/>
+          <p:cNvSpPr>
+            <a:spLocks noGrp="1"/>
+          </p:cNvSpPr>
+          <p:nvPr>
+            <p:ph type="body" idx="1"/>
+          </p:nvPr>
+        </p:nvSpPr>
+        <p:spPr/>
+        <p:txBody>
+          <a:bodyPr/>
+          <a:lstStyle/>
+          <a:p>
+            <a:r>
+              <a:rPr lang="en-US" dirty="0"/>
+              <a:t>Three negatives, and each one is a design decision somebody made rather than a
+limitation of the model.
+The third is the one that surprises people: there is no memory between
+sessions. Continuity is the harness resending the history, which is why
+history spends their token budget later in the deck.
+The 4B and the 9B are asked for different reply shapes, whole files against
+diffs. That is why a classmate's session looks different from theirs, and why
+the trace they see later may not match what they ran in practice.
+Worth saying here, not worth a slide.</a:t>
+            </a:r>
+            <a:endParaRPr lang="en-US" dirty="0"/>
+          </a:p>
+        </p:txBody>
+      </p:sp>
+      <p:sp>
+        <p:nvSpPr>
+          <p:cNvPr id="4" name="Slide Number Placeholder 3"/>
+          <p:cNvSpPr>
+            <a:spLocks noGrp="1"/>
+          </p:cNvSpPr>
+          <p:nvPr>
+            <p:ph type="sldNum" sz="quarter" idx="10"/>
+          </p:nvPr>
+        </p:nvSpPr>
+        <p:spPr/>
+        <p:txBody>
+          <a:bodyPr/>
+          <a:lstStyle/>
+          <a:p>
+            <a:fld id="{F7021451-1387-4CA6-816F-3879F97B5CBC}" type="slidenum">
+              <a:rPr lang="en-US"/>
+              <a:t>4</a:t>
             </a:fld>
             <a:endParaRPr lang="en-US"/>
           </a:p>
@@ -4364,12 +3796,13 @@
           <a:p>
             <a:r>
               <a:rPr lang="en-US" dirty="0"/>
-              <a:t>The centre of the lab, and the idea the rest of it hangs off. They have spent
-two weeks inside what looks like a chat, and it is not one. There is a single
-block of text, assembled from nothing every turn, and Aider writes every part of
-it including the half that appears to be theirs.
-Do not rush this section. The budget, the cache, the stale file and the silent
-undo are all consequences of it.</a:t>
+              <a:t>Cut back hard on 2026-09-13. L02 and L03 already taught the window, the four
+sources that fill it, surgical selection and /tokens, and this block used to
+repeat all of it. What is left is the part they have not met: the repo map, and
+what happens to the budget as a session runs long.
+So do not re-teach context here. One sentence to reconnect it, that only the
+reply belongs to the model and everything else is the harness choosing what the
+model gets to see, and then straight into the map.</a:t>
             </a:r>
             <a:endParaRPr lang="en-US" dirty="0"/>
           </a:p>
@@ -4457,16 +3890,10 @@
           <a:p>
             <a:r>
               <a:rPr lang="en-US" dirty="0"/>
-              <a:t>Read the last one out loud. Aider wrote their irritation, interrobang included,
-and sent it over their name.
-None of this is Aider deceiving them. The chat format has two roles and a
-harness has to put machine-generated context somewhere, so it goes in the user's
-slot. But the model has no way to tell which of those messages a person typed.
-Ask the room: if the model is told a human wrote something a program generated,
-what is it supposed to do with the words "trust this message"? That question is
-the whole grounding problem, and the rest of the deck answers it.
-Their build makes this decision too. Anything it sends that the user did not
-type is a message it is authoring on the user's behalf.</a:t>
+              <a:t>Ask the room to find the arrow that writes a file. There is not one leaving the
+amber box. The model produced text, and a program decided what to do with it.
+This is a picture of Aider, not a required architecture for their build. They
+will draw their own version of this in a week.</a:t>
             </a:r>
             <a:endParaRPr lang="en-US" dirty="0"/>
           </a:p>
@@ -4554,17 +3981,10 @@
           <a:p>
             <a:r>
               <a:rPr lang="en-US" dirty="0"/>
-              <a:t>Row two is the one that lands. Aider writes replies for the model, "Ok, any
-changes I propose will be to those files", and puts them in the history, so the
-next turn reads as a dialogue that has already agreed with itself. The model
-never said it.
-Row three is worth saying slowly. The instruction that tells the model which
-edit format to produce is appended to the end of the student's own message. What
-the model reads as the request is not what they typed.
-There is a cost hidden in row three that comes back later: when the context is
-nearly full, that reminder is the thing dropped to make room. The instruction
-keeping the output parseable is sacrificed exactly when the model is most likely
-to drift.</a:t>
+              <a:t>Point at the vertical bars: that is aider quoting source lines. Point at the
+dots: that is everything it decided not to spend tokens on.
+Ask what this is for. The answer is on the next slide: it is aider guessing
+what you would have typed /add for.</a:t>
             </a:r>
             <a:endParaRPr lang="en-US" dirty="0"/>
           </a:p>
@@ -4652,11 +4072,13 @@
           <a:p>
             <a:r>
               <a:rPr lang="en-US" dirty="0"/>
-              <a:t>This block is now about context rather than a walkthrough of a whole turn
-(instructor cuts 2026-09-13). Most of it is the repo map, because that is the
-part nobody has met before and the part that quietly spends their budget.
-Say up front that only the reply belongs to the model. Everything else in this
-block is the harness deciding what the model gets to see.</a:t>
+              <a:t>Off the slide and worth saying: the ranking is tilted toward files you just
+mentioned, and aider renders down the list until the tokens run out.
+Say the ranking rule plainly: a file that lots of other files depend on scores
+high, because it is probably the one you need to know about.
+The dashed line is the point. It is not "here is your repo," it is "here is as
+much of your repo as fits," and whatever falls under the line is invisible to
+the model. 867 lines of aider to guess what you would have typed /add for.</a:t>
             </a:r>
             <a:endParaRPr lang="en-US" dirty="0"/>
           </a:p>
@@ -6253,243 +5675,9 @@
 </p:sld>
 </file>
 
-<file path=ppt/slides/slide39.xml><?xml version="1.0" encoding="utf-8"?>
-<p:sld xmlns:a="http://schemas.openxmlformats.org/drawingml/2006/main" xmlns:r="http://schemas.openxmlformats.org/officeDocument/2006/relationships" xmlns:p="http://schemas.openxmlformats.org/presentationml/2006/main">
-  <p:cSld name="Slide 39">
-    <p:bg>
-      <p:bgPr>
-        <a:blipFill dpi="0" rotWithShape="1">
-          <a:blip r:embed="rId1">
-            <a:lum/>
-          </a:blip>
-          <a:srcRect/>
-          <a:stretch>
-            <a:fillRect/>
-          </a:stretch>
-        </a:blipFill>
-        <a:effectLst/>
-      </p:bgPr>
-    </p:bg>
-    <p:spTree>
-      <p:nvGrpSpPr>
-        <p:cNvPr id="1" name=""/>
-        <p:cNvGrpSpPr/>
-        <p:nvPr/>
-      </p:nvGrpSpPr>
-      <p:grpSpPr>
-        <a:xfrm>
-          <a:off x="0" y="0"/>
-          <a:ext cx="0" cy="0"/>
-          <a:chOff x="0" y="0"/>
-          <a:chExt cx="0" cy="0"/>
-        </a:xfrm>
-      </p:grpSpPr>
-    </p:spTree>
-  </p:cSld>
-  <p:clrMapOvr>
-    <a:masterClrMapping/>
-  </p:clrMapOvr>
-</p:sld>
-</file>
-
 <file path=ppt/slides/slide4.xml><?xml version="1.0" encoding="utf-8"?>
 <p:sld xmlns:a="http://schemas.openxmlformats.org/drawingml/2006/main" xmlns:r="http://schemas.openxmlformats.org/officeDocument/2006/relationships" xmlns:p="http://schemas.openxmlformats.org/presentationml/2006/main">
   <p:cSld name="Slide 4">
-    <p:bg>
-      <p:bgPr>
-        <a:blipFill dpi="0" rotWithShape="1">
-          <a:blip r:embed="rId1">
-            <a:lum/>
-          </a:blip>
-          <a:srcRect/>
-          <a:stretch>
-            <a:fillRect/>
-          </a:stretch>
-        </a:blipFill>
-        <a:effectLst/>
-      </p:bgPr>
-    </p:bg>
-    <p:spTree>
-      <p:nvGrpSpPr>
-        <p:cNvPr id="1" name=""/>
-        <p:cNvGrpSpPr/>
-        <p:nvPr/>
-      </p:nvGrpSpPr>
-      <p:grpSpPr>
-        <a:xfrm>
-          <a:off x="0" y="0"/>
-          <a:ext cx="0" cy="0"/>
-          <a:chOff x="0" y="0"/>
-          <a:chExt cx="0" cy="0"/>
-        </a:xfrm>
-      </p:grpSpPr>
-    </p:spTree>
-  </p:cSld>
-  <p:clrMapOvr>
-    <a:masterClrMapping/>
-  </p:clrMapOvr>
-</p:sld>
-</file>
-
-<file path=ppt/slides/slide40.xml><?xml version="1.0" encoding="utf-8"?>
-<p:sld xmlns:a="http://schemas.openxmlformats.org/drawingml/2006/main" xmlns:r="http://schemas.openxmlformats.org/officeDocument/2006/relationships" xmlns:p="http://schemas.openxmlformats.org/presentationml/2006/main">
-  <p:cSld name="Slide 40">
-    <p:bg>
-      <p:bgPr>
-        <a:blipFill dpi="0" rotWithShape="1">
-          <a:blip r:embed="rId1">
-            <a:lum/>
-          </a:blip>
-          <a:srcRect/>
-          <a:stretch>
-            <a:fillRect/>
-          </a:stretch>
-        </a:blipFill>
-        <a:effectLst/>
-      </p:bgPr>
-    </p:bg>
-    <p:spTree>
-      <p:nvGrpSpPr>
-        <p:cNvPr id="1" name=""/>
-        <p:cNvGrpSpPr/>
-        <p:nvPr/>
-      </p:nvGrpSpPr>
-      <p:grpSpPr>
-        <a:xfrm>
-          <a:off x="0" y="0"/>
-          <a:ext cx="0" cy="0"/>
-          <a:chOff x="0" y="0"/>
-          <a:chExt cx="0" cy="0"/>
-        </a:xfrm>
-      </p:grpSpPr>
-    </p:spTree>
-  </p:cSld>
-  <p:clrMapOvr>
-    <a:masterClrMapping/>
-  </p:clrMapOvr>
-</p:sld>
-</file>
-
-<file path=ppt/slides/slide41.xml><?xml version="1.0" encoding="utf-8"?>
-<p:sld xmlns:a="http://schemas.openxmlformats.org/drawingml/2006/main" xmlns:r="http://schemas.openxmlformats.org/officeDocument/2006/relationships" xmlns:p="http://schemas.openxmlformats.org/presentationml/2006/main">
-  <p:cSld name="Slide 41">
-    <p:bg>
-      <p:bgPr>
-        <a:blipFill dpi="0" rotWithShape="1">
-          <a:blip r:embed="rId1">
-            <a:lum/>
-          </a:blip>
-          <a:srcRect/>
-          <a:stretch>
-            <a:fillRect/>
-          </a:stretch>
-        </a:blipFill>
-        <a:effectLst/>
-      </p:bgPr>
-    </p:bg>
-    <p:spTree>
-      <p:nvGrpSpPr>
-        <p:cNvPr id="1" name=""/>
-        <p:cNvGrpSpPr/>
-        <p:nvPr/>
-      </p:nvGrpSpPr>
-      <p:grpSpPr>
-        <a:xfrm>
-          <a:off x="0" y="0"/>
-          <a:ext cx="0" cy="0"/>
-          <a:chOff x="0" y="0"/>
-          <a:chExt cx="0" cy="0"/>
-        </a:xfrm>
-      </p:grpSpPr>
-    </p:spTree>
-  </p:cSld>
-  <p:clrMapOvr>
-    <a:masterClrMapping/>
-  </p:clrMapOvr>
-</p:sld>
-</file>
-
-<file path=ppt/slides/slide42.xml><?xml version="1.0" encoding="utf-8"?>
-<p:sld xmlns:a="http://schemas.openxmlformats.org/drawingml/2006/main" xmlns:r="http://schemas.openxmlformats.org/officeDocument/2006/relationships" xmlns:p="http://schemas.openxmlformats.org/presentationml/2006/main">
-  <p:cSld name="Slide 42">
-    <p:bg>
-      <p:bgPr>
-        <a:blipFill dpi="0" rotWithShape="1">
-          <a:blip r:embed="rId1">
-            <a:lum/>
-          </a:blip>
-          <a:srcRect/>
-          <a:stretch>
-            <a:fillRect/>
-          </a:stretch>
-        </a:blipFill>
-        <a:effectLst/>
-      </p:bgPr>
-    </p:bg>
-    <p:spTree>
-      <p:nvGrpSpPr>
-        <p:cNvPr id="1" name=""/>
-        <p:cNvGrpSpPr/>
-        <p:nvPr/>
-      </p:nvGrpSpPr>
-      <p:grpSpPr>
-        <a:xfrm>
-          <a:off x="0" y="0"/>
-          <a:ext cx="0" cy="0"/>
-          <a:chOff x="0" y="0"/>
-          <a:chExt cx="0" cy="0"/>
-        </a:xfrm>
-      </p:grpSpPr>
-    </p:spTree>
-  </p:cSld>
-  <p:clrMapOvr>
-    <a:masterClrMapping/>
-  </p:clrMapOvr>
-</p:sld>
-</file>
-
-<file path=ppt/slides/slide43.xml><?xml version="1.0" encoding="utf-8"?>
-<p:sld xmlns:a="http://schemas.openxmlformats.org/drawingml/2006/main" xmlns:r="http://schemas.openxmlformats.org/officeDocument/2006/relationships" xmlns:p="http://schemas.openxmlformats.org/presentationml/2006/main">
-  <p:cSld name="Slide 43">
-    <p:bg>
-      <p:bgPr>
-        <a:blipFill dpi="0" rotWithShape="1">
-          <a:blip r:embed="rId1">
-            <a:lum/>
-          </a:blip>
-          <a:srcRect/>
-          <a:stretch>
-            <a:fillRect/>
-          </a:stretch>
-        </a:blipFill>
-        <a:effectLst/>
-      </p:bgPr>
-    </p:bg>
-    <p:spTree>
-      <p:nvGrpSpPr>
-        <p:cNvPr id="1" name=""/>
-        <p:cNvGrpSpPr/>
-        <p:nvPr/>
-      </p:nvGrpSpPr>
-      <p:grpSpPr>
-        <a:xfrm>
-          <a:off x="0" y="0"/>
-          <a:ext cx="0" cy="0"/>
-          <a:chOff x="0" y="0"/>
-          <a:chExt cx="0" cy="0"/>
-        </a:xfrm>
-      </p:grpSpPr>
-    </p:spTree>
-  </p:cSld>
-  <p:clrMapOvr>
-    <a:masterClrMapping/>
-  </p:clrMapOvr>
-</p:sld>
-</file>
-
-<file path=ppt/slides/slide44.xml><?xml version="1.0" encoding="utf-8"?>
-<p:sld xmlns:a="http://schemas.openxmlformats.org/drawingml/2006/main" xmlns:r="http://schemas.openxmlformats.org/officeDocument/2006/relationships" xmlns:p="http://schemas.openxmlformats.org/presentationml/2006/main">
-  <p:cSld name="Slide 44">
     <p:bg>
       <p:bgPr>
         <a:blipFill dpi="0" rotWithShape="1">

</xml_diff>

<commit_message>
Lab01: republish at 41 slides with the rewritten closing section
Co-Authored-By: Claude Fable 5.1 <noreply@anthropic.com>
Claude-Session: https://claude.ai/code/session_01HK8wFbKHvmKPXQf2PSK8c1
</commit_message>
<xml_diff>
--- a/labs/Lab01/slides.pptx
+++ b/labs/Lab01/slides.pptx
@@ -43,9 +43,12 @@
     <p:sldId id="291" r:id="rId37"/>
     <p:sldId id="292" r:id="rId38"/>
     <p:sldId id="293" r:id="rId39"/>
+    <p:sldId id="294" r:id="rId40"/>
+    <p:sldId id="295" r:id="rId41"/>
+    <p:sldId id="296" r:id="rId42"/>
   </p:sldIdLst>
   <p:notesMasterIdLst>
-    <p:notesMasterId r:id="rId40"/>
+    <p:notesMasterId r:id="rId43"/>
   </p:notesMasterIdLst>
   <p:sldSz cx="9334500" cy="5248275"/>
   <p:notesSz cx="5248275" cy="9334500"/>
@@ -1702,6 +1705,96 @@
           <a:p>
             <a:r>
               <a:rPr lang="en-US" dirty="0"/>
+              <a:t>Section slide added 2026-09-14 at the instructor's request, so the hackathon
+reads as its own block rather than a tail on the grounding slides. Two slides
+under it: the format, and the workspace. Three or four minutes in total.</a:t>
+            </a:r>
+            <a:endParaRPr lang="en-US" dirty="0"/>
+          </a:p>
+        </p:txBody>
+      </p:sp>
+      <p:sp>
+        <p:nvSpPr>
+          <p:cNvPr id="4" name="Slide Number Placeholder 3"/>
+          <p:cNvSpPr>
+            <a:spLocks noGrp="1"/>
+          </p:cNvSpPr>
+          <p:nvPr>
+            <p:ph type="sldNum" sz="quarter" idx="10"/>
+          </p:nvPr>
+        </p:nvSpPr>
+        <p:spPr/>
+        <p:txBody>
+          <a:bodyPr/>
+          <a:lstStyle/>
+          <a:p>
+            <a:fld id="{F7021451-1387-4CA6-816F-3879F97B5CBC}" type="slidenum">
+              <a:rPr lang="en-US"/>
+              <a:t>20</a:t>
+            </a:fld>
+            <a:endParaRPr lang="en-US"/>
+          </a:p>
+        </p:txBody>
+      </p:sp>
+    </p:spTree>
+    <p:extLst>
+      <p:ext uri="{BB962C8B-B14F-4D97-AF65-F5344CB8AC3E}">
+        <p14:creationId xmlns:p14="http://schemas.microsoft.com/office/powerpoint/2010/main" val="1024086991"/>
+      </p:ext>
+    </p:extLst>
+  </p:cSld>
+  <p:clrMapOvr>
+    <a:masterClrMapping/>
+  </p:clrMapOvr>
+</p:notes>
+</file>
+
+<file path=ppt/notesSlides/notesSlide21.xml><?xml version="1.0" encoding="utf-8"?>
+<p:notes xmlns:a="http://schemas.openxmlformats.org/drawingml/2006/main" xmlns:r="http://schemas.openxmlformats.org/officeDocument/2006/relationships" xmlns:p="http://schemas.openxmlformats.org/presentationml/2006/main">
+  <p:cSld>
+    <p:spTree>
+      <p:nvGrpSpPr>
+        <p:cNvPr id="1" name=""/>
+        <p:cNvGrpSpPr/>
+        <p:nvPr/>
+      </p:nvGrpSpPr>
+      <p:grpSpPr>
+        <a:xfrm>
+          <a:off x="0" y="0"/>
+          <a:ext cx="0" cy="0"/>
+          <a:chOff x="0" y="0"/>
+          <a:chExt cx="0" cy="0"/>
+        </a:xfrm>
+      </p:grpSpPr>
+      <p:sp>
+        <p:nvSpPr>
+          <p:cNvPr id="2" name="Slide Image Placeholder 1"/>
+          <p:cNvSpPr>
+            <a:spLocks noGrp="1" noRot="1" noChangeAspect="1"/>
+          </p:cNvSpPr>
+          <p:nvPr>
+            <p:ph type="sldImg"/>
+          </p:nvPr>
+        </p:nvSpPr>
+        <p:spPr/>
+      </p:sp>
+      <p:sp>
+        <p:nvSpPr>
+          <p:cNvPr id="3" name="Notes Placeholder 2"/>
+          <p:cNvSpPr>
+            <a:spLocks noGrp="1"/>
+          </p:cNvSpPr>
+          <p:nvPr>
+            <p:ph type="body" idx="1"/>
+          </p:nvPr>
+        </p:nvSpPr>
+        <p:spPr/>
+        <p:txBody>
+          <a:bodyPr/>
+          <a:lstStyle/>
+          <a:p>
+            <a:r>
+              <a:rPr lang="en-US" dirty="0"/>
               <a:t>Three minutes including logistics. Room, time and the model in the workspace are
 announced by staff. Do not invent any of them here.
 Say the accommodations line out loud: conflicts and accommodations go to staff
@@ -1730,7 +1823,7 @@
           <a:p>
             <a:fld id="{F7021451-1387-4CA6-816F-3879F97B5CBC}" type="slidenum">
               <a:rPr lang="en-US"/>
-              <a:t>20</a:t>
+              <a:t>21</a:t>
             </a:fld>
             <a:endParaRPr lang="en-US"/>
           </a:p>
@@ -1749,7 +1842,7 @@
 </p:notes>
 </file>
 
-<file path=ppt/notesSlides/notesSlide21.xml><?xml version="1.0" encoding="utf-8"?>
+<file path=ppt/notesSlides/notesSlide22.xml><?xml version="1.0" encoding="utf-8"?>
 <p:notes xmlns:a="http://schemas.openxmlformats.org/drawingml/2006/main" xmlns:r="http://schemas.openxmlformats.org/officeDocument/2006/relationships" xmlns:p="http://schemas.openxmlformats.org/presentationml/2006/main">
   <p:cSld>
     <p:spTree>
@@ -1795,7 +1888,10 @@
           <a:p>
             <a:r>
               <a:rPr lang="en-US" dirty="0"/>
-              <a:t>Nobody installs anything and nobody needs the network. The workspace opens with
+              <a:t>The caption with the token figures and the closing line about bringing a build
+that runs both came off this slide on 2026-09-14 at the instructor's request.
+Both points are still worth saying; they are yours to say, not the slide's.
+Nobody installs anything and nobody needs the network. The workspace opens with
 the tools already pointed at the right place and their own repository in it.
 The caption is the point of the slide and it connects straight back to the
 budget block. The reference pack in the image is most of the Python
@@ -1837,7 +1933,7 @@
           <a:p>
             <a:fld id="{F7021451-1387-4CA6-816F-3879F97B5CBC}" type="slidenum">
               <a:rPr lang="en-US"/>
-              <a:t>21</a:t>
+              <a:t>22</a:t>
             </a:fld>
             <a:endParaRPr lang="en-US"/>
           </a:p>
@@ -1856,7 +1952,7 @@
 </p:notes>
 </file>
 
-<file path=ppt/notesSlides/notesSlide22.xml><?xml version="1.0" encoding="utf-8"?>
+<file path=ppt/notesSlides/notesSlide23.xml><?xml version="1.0" encoding="utf-8"?>
 <p:notes xmlns:a="http://schemas.openxmlformats.org/drawingml/2006/main" xmlns:r="http://schemas.openxmlformats.org/officeDocument/2006/relationships" xmlns:p="http://schemas.openxmlformats.org/presentationml/2006/main">
   <p:cSld>
     <p:spTree>
@@ -1928,7 +2024,7 @@
           <a:p>
             <a:fld id="{F7021451-1387-4CA6-816F-3879F97B5CBC}" type="slidenum">
               <a:rPr lang="en-US"/>
-              <a:t>22</a:t>
+              <a:t>23</a:t>
             </a:fld>
             <a:endParaRPr lang="en-US"/>
           </a:p>
@@ -1947,7 +2043,7 @@
 </p:notes>
 </file>
 
-<file path=ppt/notesSlides/notesSlide23.xml><?xml version="1.0" encoding="utf-8"?>
+<file path=ppt/notesSlides/notesSlide24.xml><?xml version="1.0" encoding="utf-8"?>
 <p:notes xmlns:a="http://schemas.openxmlformats.org/drawingml/2006/main" xmlns:r="http://schemas.openxmlformats.org/officeDocument/2006/relationships" xmlns:p="http://schemas.openxmlformats.org/presentationml/2006/main">
   <p:cSld>
     <p:spTree>
@@ -2024,7 +2120,7 @@
           <a:p>
             <a:fld id="{F7021451-1387-4CA6-816F-3879F97B5CBC}" type="slidenum">
               <a:rPr lang="en-US"/>
-              <a:t>23</a:t>
+              <a:t>24</a:t>
             </a:fld>
             <a:endParaRPr lang="en-US"/>
           </a:p>
@@ -2043,7 +2139,7 @@
 </p:notes>
 </file>
 
-<file path=ppt/notesSlides/notesSlide24.xml><?xml version="1.0" encoding="utf-8"?>
+<file path=ppt/notesSlides/notesSlide25.xml><?xml version="1.0" encoding="utf-8"?>
 <p:notes xmlns:a="http://schemas.openxmlformats.org/drawingml/2006/main" xmlns:r="http://schemas.openxmlformats.org/officeDocument/2006/relationships" xmlns:p="http://schemas.openxmlformats.org/presentationml/2006/main">
   <p:cSld>
     <p:spTree>
@@ -2123,7 +2219,7 @@
           <a:p>
             <a:fld id="{F7021451-1387-4CA6-816F-3879F97B5CBC}" type="slidenum">
               <a:rPr lang="en-US"/>
-              <a:t>24</a:t>
+              <a:t>25</a:t>
             </a:fld>
             <a:endParaRPr lang="en-US"/>
           </a:p>
@@ -2142,7 +2238,7 @@
 </p:notes>
 </file>
 
-<file path=ppt/notesSlides/notesSlide25.xml><?xml version="1.0" encoding="utf-8"?>
+<file path=ppt/notesSlides/notesSlide26.xml><?xml version="1.0" encoding="utf-8"?>
 <p:notes xmlns:a="http://schemas.openxmlformats.org/drawingml/2006/main" xmlns:r="http://schemas.openxmlformats.org/officeDocument/2006/relationships" xmlns:p="http://schemas.openxmlformats.org/presentationml/2006/main">
   <p:cSld>
     <p:spTree>
@@ -2216,7 +2312,7 @@
           <a:p>
             <a:fld id="{F7021451-1387-4CA6-816F-3879F97B5CBC}" type="slidenum">
               <a:rPr lang="en-US"/>
-              <a:t>25</a:t>
+              <a:t>26</a:t>
             </a:fld>
             <a:endParaRPr lang="en-US"/>
           </a:p>
@@ -2235,7 +2331,7 @@
 </p:notes>
 </file>
 
-<file path=ppt/notesSlides/notesSlide26.xml><?xml version="1.0" encoding="utf-8"?>
+<file path=ppt/notesSlides/notesSlide27.xml><?xml version="1.0" encoding="utf-8"?>
 <p:notes xmlns:a="http://schemas.openxmlformats.org/drawingml/2006/main" xmlns:r="http://schemas.openxmlformats.org/officeDocument/2006/relationships" xmlns:p="http://schemas.openxmlformats.org/presentationml/2006/main">
   <p:cSld>
     <p:spTree>
@@ -2311,7 +2407,7 @@
           <a:p>
             <a:fld id="{F7021451-1387-4CA6-816F-3879F97B5CBC}" type="slidenum">
               <a:rPr lang="en-US"/>
-              <a:t>26</a:t>
+              <a:t>27</a:t>
             </a:fld>
             <a:endParaRPr lang="en-US"/>
           </a:p>
@@ -2330,7 +2426,7 @@
 </p:notes>
 </file>
 
-<file path=ppt/notesSlides/notesSlide27.xml><?xml version="1.0" encoding="utf-8"?>
+<file path=ppt/notesSlides/notesSlide28.xml><?xml version="1.0" encoding="utf-8"?>
 <p:notes xmlns:a="http://schemas.openxmlformats.org/drawingml/2006/main" xmlns:r="http://schemas.openxmlformats.org/officeDocument/2006/relationships" xmlns:p="http://schemas.openxmlformats.org/presentationml/2006/main">
   <p:cSld>
     <p:spTree>
@@ -2414,7 +2510,7 @@
           <a:p>
             <a:fld id="{F7021451-1387-4CA6-816F-3879F97B5CBC}" type="slidenum">
               <a:rPr lang="en-US"/>
-              <a:t>27</a:t>
+              <a:t>28</a:t>
             </a:fld>
             <a:endParaRPr lang="en-US"/>
           </a:p>
@@ -2433,7 +2529,7 @@
 </p:notes>
 </file>
 
-<file path=ppt/notesSlides/notesSlide28.xml><?xml version="1.0" encoding="utf-8"?>
+<file path=ppt/notesSlides/notesSlide29.xml><?xml version="1.0" encoding="utf-8"?>
 <p:notes xmlns:a="http://schemas.openxmlformats.org/drawingml/2006/main" xmlns:r="http://schemas.openxmlformats.org/officeDocument/2006/relationships" xmlns:p="http://schemas.openxmlformats.org/presentationml/2006/main">
   <p:cSld>
     <p:spTree>
@@ -2485,98 +2581,6 @@
 Sessions and model disclosure are required but score no points of their own.
 They are what lets staff follow the rest of the evidence, so a submission
 without them loses credit wherever a claim cannot be checked.</a:t>
-            </a:r>
-            <a:endParaRPr lang="en-US" dirty="0"/>
-          </a:p>
-        </p:txBody>
-      </p:sp>
-      <p:sp>
-        <p:nvSpPr>
-          <p:cNvPr id="4" name="Slide Number Placeholder 3"/>
-          <p:cNvSpPr>
-            <a:spLocks noGrp="1"/>
-          </p:cNvSpPr>
-          <p:nvPr>
-            <p:ph type="sldNum" sz="quarter" idx="10"/>
-          </p:nvPr>
-        </p:nvSpPr>
-        <p:spPr/>
-        <p:txBody>
-          <a:bodyPr/>
-          <a:lstStyle/>
-          <a:p>
-            <a:fld id="{F7021451-1387-4CA6-816F-3879F97B5CBC}" type="slidenum">
-              <a:rPr lang="en-US"/>
-              <a:t>28</a:t>
-            </a:fld>
-            <a:endParaRPr lang="en-US"/>
-          </a:p>
-        </p:txBody>
-      </p:sp>
-    </p:spTree>
-    <p:extLst>
-      <p:ext uri="{BB962C8B-B14F-4D97-AF65-F5344CB8AC3E}">
-        <p14:creationId xmlns:p14="http://schemas.microsoft.com/office/powerpoint/2010/main" val="1024086991"/>
-      </p:ext>
-    </p:extLst>
-  </p:cSld>
-  <p:clrMapOvr>
-    <a:masterClrMapping/>
-  </p:clrMapOvr>
-</p:notes>
-</file>
-
-<file path=ppt/notesSlides/notesSlide29.xml><?xml version="1.0" encoding="utf-8"?>
-<p:notes xmlns:a="http://schemas.openxmlformats.org/drawingml/2006/main" xmlns:r="http://schemas.openxmlformats.org/officeDocument/2006/relationships" xmlns:p="http://schemas.openxmlformats.org/presentationml/2006/main">
-  <p:cSld>
-    <p:spTree>
-      <p:nvGrpSpPr>
-        <p:cNvPr id="1" name=""/>
-        <p:cNvGrpSpPr/>
-        <p:nvPr/>
-      </p:nvGrpSpPr>
-      <p:grpSpPr>
-        <a:xfrm>
-          <a:off x="0" y="0"/>
-          <a:ext cx="0" cy="0"/>
-          <a:chOff x="0" y="0"/>
-          <a:chExt cx="0" cy="0"/>
-        </a:xfrm>
-      </p:grpSpPr>
-      <p:sp>
-        <p:nvSpPr>
-          <p:cNvPr id="2" name="Slide Image Placeholder 1"/>
-          <p:cNvSpPr>
-            <a:spLocks noGrp="1" noRot="1" noChangeAspect="1"/>
-          </p:cNvSpPr>
-          <p:nvPr>
-            <p:ph type="sldImg"/>
-          </p:nvPr>
-        </p:nvSpPr>
-        <p:spPr/>
-      </p:sp>
-      <p:sp>
-        <p:nvSpPr>
-          <p:cNvPr id="3" name="Notes Placeholder 2"/>
-          <p:cNvSpPr>
-            <a:spLocks noGrp="1"/>
-          </p:cNvSpPr>
-          <p:nvPr>
-            <p:ph type="body" idx="1"/>
-          </p:nvPr>
-        </p:nvSpPr>
-        <p:spPr/>
-        <p:txBody>
-          <a:bodyPr/>
-          <a:lstStyle/>
-          <a:p>
-            <a:r>
-              <a:rPr lang="en-US" dirty="0"/>
-              <a:t>Exact model IDs and the observed-session exception are in the assignment packet.
-Read them from there rather than from memory.
-The pattern being ruled out is a frontier model for the design followed by a
-local model for the code. Keep the sessions, disclose real aliases and any
-quantization you know about.</a:t>
             </a:r>
             <a:endParaRPr lang="en-US" dirty="0"/>
           </a:p>
@@ -2759,14 +2763,11 @@
           <a:p>
             <a:r>
               <a:rPr lang="en-US" dirty="0"/>
-              <a:t>Reworked into a discussion 2026-09-13. It was two dense tables at the end of a
-long taught half and it read as a summary nobody asked for.
-It is now a short argument followed by real questions. The tables are the
-material for the discussion, not the point of the section. Put one up, give them
-the line, and then get out of the way.
-The question some of them have been holding for two weeks is why this course
-teaches on Aider rather than the tool everyone talks about. Answer it here, once,
-and answer it honestly rather than defending the choice.</a:t>
+              <a:t>Exact model IDs and the observed-session exception are in the assignment packet.
+Read them from there rather than from memory.
+The pattern being ruled out is a frontier model for the design followed by a
+local model for the code. Keep the sessions, disclose real aliases and any
+quantization you know about.</a:t>
             </a:r>
             <a:endParaRPr lang="en-US" dirty="0"/>
           </a:p>
@@ -2854,11 +2855,205 @@
           <a:p>
             <a:r>
               <a:rPr lang="en-US" dirty="0"/>
+              <a:t>Rewritten 2026-09-14 on instructor direction: the discussion slide is gone and
+the section is now five slides that make an argument rather than a summary.
+What you can see, what seeing it costs, who chooses the context, what you own,
+and the one question left open for tomorrow.
+The question some of them have been holding for two weeks is why this course
+teaches on Aider rather than the tool everyone talks about. This section answers
+it, once, honestly, and without defending the choice. The short form: every
+decision a harness makes is on display here, they are about to build one, and
+the bigger tools are this loop with more of it automated.</a:t>
+            </a:r>
+            <a:endParaRPr lang="en-US" dirty="0"/>
+          </a:p>
+        </p:txBody>
+      </p:sp>
+      <p:sp>
+        <p:nvSpPr>
+          <p:cNvPr id="4" name="Slide Number Placeholder 3"/>
+          <p:cNvSpPr>
+            <a:spLocks noGrp="1"/>
+          </p:cNvSpPr>
+          <p:nvPr>
+            <p:ph type="sldNum" sz="quarter" idx="10"/>
+          </p:nvPr>
+        </p:nvSpPr>
+        <p:spPr/>
+        <p:txBody>
+          <a:bodyPr/>
+          <a:lstStyle/>
+          <a:p>
+            <a:fld id="{F7021451-1387-4CA6-816F-3879F97B5CBC}" type="slidenum">
+              <a:rPr lang="en-US"/>
+              <a:t>31</a:t>
+            </a:fld>
+            <a:endParaRPr lang="en-US"/>
+          </a:p>
+        </p:txBody>
+      </p:sp>
+    </p:spTree>
+    <p:extLst>
+      <p:ext uri="{BB962C8B-B14F-4D97-AF65-F5344CB8AC3E}">
+        <p14:creationId xmlns:p14="http://schemas.microsoft.com/office/powerpoint/2010/main" val="1024086991"/>
+      </p:ext>
+    </p:extLst>
+  </p:cSld>
+  <p:clrMapOvr>
+    <a:masterClrMapping/>
+  </p:clrMapOvr>
+</p:notes>
+</file>
+
+<file path=ppt/notesSlides/notesSlide32.xml><?xml version="1.0" encoding="utf-8"?>
+<p:notes xmlns:a="http://schemas.openxmlformats.org/drawingml/2006/main" xmlns:r="http://schemas.openxmlformats.org/officeDocument/2006/relationships" xmlns:p="http://schemas.openxmlformats.org/presentationml/2006/main">
+  <p:cSld>
+    <p:spTree>
+      <p:nvGrpSpPr>
+        <p:cNvPr id="1" name=""/>
+        <p:cNvGrpSpPr/>
+        <p:nvPr/>
+      </p:nvGrpSpPr>
+      <p:grpSpPr>
+        <a:xfrm>
+          <a:off x="0" y="0"/>
+          <a:ext cx="0" cy="0"/>
+          <a:chOff x="0" y="0"/>
+          <a:chExt cx="0" cy="0"/>
+        </a:xfrm>
+      </p:grpSpPr>
+      <p:sp>
+        <p:nvSpPr>
+          <p:cNvPr id="2" name="Slide Image Placeholder 1"/>
+          <p:cNvSpPr>
+            <a:spLocks noGrp="1" noRot="1" noChangeAspect="1"/>
+          </p:cNvSpPr>
+          <p:nvPr>
+            <p:ph type="sldImg"/>
+          </p:nvPr>
+        </p:nvSpPr>
+        <p:spPr/>
+      </p:sp>
+      <p:sp>
+        <p:nvSpPr>
+          <p:cNvPr id="3" name="Notes Placeholder 2"/>
+          <p:cNvSpPr>
+            <a:spLocks noGrp="1"/>
+          </p:cNvSpPr>
+          <p:nvPr>
+            <p:ph type="body" idx="1"/>
+          </p:nvPr>
+        </p:nvSpPr>
+        <p:spPr/>
+        <p:txBody>
+          <a:bodyPr/>
+          <a:lstStyle/>
+          <a:p>
+            <a:r>
+              <a:rPr lang="en-US" dirty="0"/>
+              <a:t>Four decisions every harness makes, and for each one the moment in the last two
+weeks when they made it or watched it. That is the whole pedagogical case: not
+that Aider is the best tool, but that it is the one where the joins show.
+The bold line is the argument against starting on a more automated tool. It
+would make the same four decisions, and they would never see any of them, so
+they would leave knowing how to use it and not how it works. This course is
+about how it works, because in three weeks they have to write one.
+If someone says the more automated tool is better: agree. It is. That is a
+different claim from being better to learn on, and the next slide is about what
+the difference costs.</a:t>
+            </a:r>
+            <a:endParaRPr lang="en-US" dirty="0"/>
+          </a:p>
+        </p:txBody>
+      </p:sp>
+      <p:sp>
+        <p:nvSpPr>
+          <p:cNvPr id="4" name="Slide Number Placeholder 3"/>
+          <p:cNvSpPr>
+            <a:spLocks noGrp="1"/>
+          </p:cNvSpPr>
+          <p:nvPr>
+            <p:ph type="sldNum" sz="quarter" idx="10"/>
+          </p:nvPr>
+        </p:nvSpPr>
+        <p:spPr/>
+        <p:txBody>
+          <a:bodyPr/>
+          <a:lstStyle/>
+          <a:p>
+            <a:fld id="{F7021451-1387-4CA6-816F-3879F97B5CBC}" type="slidenum">
+              <a:rPr lang="en-US"/>
+              <a:t>32</a:t>
+            </a:fld>
+            <a:endParaRPr lang="en-US"/>
+          </a:p>
+        </p:txBody>
+      </p:sp>
+    </p:spTree>
+    <p:extLst>
+      <p:ext uri="{BB962C8B-B14F-4D97-AF65-F5344CB8AC3E}">
+        <p14:creationId xmlns:p14="http://schemas.microsoft.com/office/powerpoint/2010/main" val="1024086991"/>
+      </p:ext>
+    </p:extLst>
+  </p:cSld>
+  <p:clrMapOvr>
+    <a:masterClrMapping/>
+  </p:clrMapOvr>
+</p:notes>
+</file>
+
+<file path=ppt/notesSlides/notesSlide33.xml><?xml version="1.0" encoding="utf-8"?>
+<p:notes xmlns:a="http://schemas.openxmlformats.org/drawingml/2006/main" xmlns:r="http://schemas.openxmlformats.org/officeDocument/2006/relationships" xmlns:p="http://schemas.openxmlformats.org/presentationml/2006/main">
+  <p:cSld>
+    <p:spTree>
+      <p:nvGrpSpPr>
+        <p:cNvPr id="1" name=""/>
+        <p:cNvGrpSpPr/>
+        <p:nvPr/>
+      </p:nvGrpSpPr>
+      <p:grpSpPr>
+        <a:xfrm>
+          <a:off x="0" y="0"/>
+          <a:ext cx="0" cy="0"/>
+          <a:chOff x="0" y="0"/>
+          <a:chExt cx="0" cy="0"/>
+        </a:xfrm>
+      </p:grpSpPr>
+      <p:sp>
+        <p:nvSpPr>
+          <p:cNvPr id="2" name="Slide Image Placeholder 1"/>
+          <p:cNvSpPr>
+            <a:spLocks noGrp="1" noRot="1" noChangeAspect="1"/>
+          </p:cNvSpPr>
+          <p:nvPr>
+            <p:ph type="sldImg"/>
+          </p:nvPr>
+        </p:nvSpPr>
+        <p:spPr/>
+      </p:sp>
+      <p:sp>
+        <p:nvSpPr>
+          <p:cNvPr id="3" name="Notes Placeholder 2"/>
+          <p:cNvSpPr>
+            <a:spLocks noGrp="1"/>
+          </p:cNvSpPr>
+          <p:nvPr>
+            <p:ph type="body" idx="1"/>
+          </p:nvPr>
+        </p:nvSpPr>
+        <p:spPr/>
+        <p:txBody>
+          <a:bodyPr/>
+          <a:lstStyle/>
+          <a:p>
+            <a:r>
+              <a:rPr lang="en-US" dirty="0"/>
               <a:t>Read down it and resist making the left column win. Each line is a single design
 choice seen twice, which is what a trade-off actually is, and the right column is
 not a list of bugs.
-Do not spend long here. The rows are the raw material for the questions two
-slides on, and the discussion is worth more than your commentary.
+Their build inherits every row. When they write the specification this week they
+are choosing which side of each one to stand on, and the packet does not choose
+for them.
 The row to expand if you expand one: forgetting between sessions is not a
 limitation of the model. Every tool of this kind does it. Continuity is the
 harness re-sending, which is the first thing they learned today.</a:t>
@@ -2884,7 +3079,7 @@
           <a:p>
             <a:fld id="{F7021451-1387-4CA6-816F-3879F97B5CBC}" type="slidenum">
               <a:rPr lang="en-US"/>
-              <a:t>31</a:t>
+              <a:t>33</a:t>
             </a:fld>
             <a:endParaRPr lang="en-US"/>
           </a:p>
@@ -2903,7 +3098,7 @@
 </p:notes>
 </file>
 
-<file path=ppt/notesSlides/notesSlide32.xml><?xml version="1.0" encoding="utf-8"?>
+<file path=ppt/notesSlides/notesSlide34.xml><?xml version="1.0" encoding="utf-8"?>
 <p:notes xmlns:a="http://schemas.openxmlformats.org/drawingml/2006/main" xmlns:r="http://schemas.openxmlformats.org/officeDocument/2006/relationships" xmlns:p="http://schemas.openxmlformats.org/presentationml/2006/main">
   <p:cSld>
     <p:spTree>
@@ -2956,9 +3151,9 @@
 the same decisions without displaying them, which is exactly what makes it a
 worse thing to learn on and a better thing to use.
 Stop at context. Who picks the next action is tomorrow's lecture and it has a
-live demo for it, so do not pre-empt it.
-Then the bold line, which is the promise: none of this is magic, it is machinery,
-and they start writing it this week.</a:t>
+live demo for it, so do not pre-empt it beyond the last slide of this section.
+Then the bold line, which is the promise: none of this is machinery they cannot
+build, and they start writing it this week.</a:t>
             </a:r>
             <a:endParaRPr lang="en-US" dirty="0"/>
           </a:p>
@@ -2981,7 +3176,7 @@
           <a:p>
             <a:fld id="{F7021451-1387-4CA6-816F-3879F97B5CBC}" type="slidenum">
               <a:rPr lang="en-US"/>
-              <a:t>32</a:t>
+              <a:t>34</a:t>
             </a:fld>
             <a:endParaRPr lang="en-US"/>
           </a:p>
@@ -3000,7 +3195,7 @@
 </p:notes>
 </file>
 
-<file path=ppt/notesSlides/notesSlide33.xml><?xml version="1.0" encoding="utf-8"?>
+<file path=ppt/notesSlides/notesSlide35.xml><?xml version="1.0" encoding="utf-8"?>
 <p:notes xmlns:a="http://schemas.openxmlformats.org/drawingml/2006/main" xmlns:r="http://schemas.openxmlformats.org/officeDocument/2006/relationships" xmlns:p="http://schemas.openxmlformats.org/presentationml/2006/main">
   <p:cSld>
     <p:spTree>
@@ -3046,19 +3241,16 @@
           <a:p>
             <a:r>
               <a:rPr lang="en-US" dirty="0"/>
-              <a:t>Leave this up and let them talk. Five minutes, and it is fine if only two of the
-three get air.
-One is the honest one: somebody will say they would never ship a tool that
-forgets everything, and that is a real design position with a real cost, which is
-the whole point of the ledger.
-Two is the bridge to tomorrow's lecture and to Analyze, so take an answer and
-leave it open rather than resolving it.
-Three is the one that makes them better engineers this week. It comes straight
-off the error-message slide: the audience for a failure might be the user, the
-model, or the log, and choosing wrong is why so many of their sessions will
-stall. Their failure-path tests are worth eight points.
-If the room is flat, ask three directly at one person's build rather than at the
-room.</a:t>
+              <a:t>This is the idea that outlasts the course. Aider talks to any endpoint that
+speaks the common API, which is why it runs against the course server, against
+a model on their own laptop, and against a paid provider with one line changed.
+The model is swappable. It is a dependency, like a database driver.
+What is not swappable is the harness: which text goes in, in what order, what a
+reply is allowed to do, what gets written and committed. Every slide today was
+about that layer, and none of it belonged to the model.
+Their build has this shape by design: one endpoint, any permitted model, and
+everything they are graded on lives above the API call. The same is true of the
+tool everyone talks about. Its value is not the model behind it.</a:t>
             </a:r>
             <a:endParaRPr lang="en-US" dirty="0"/>
           </a:p>
@@ -3081,7 +3273,7 @@
           <a:p>
             <a:fld id="{F7021451-1387-4CA6-816F-3879F97B5CBC}" type="slidenum">
               <a:rPr lang="en-US"/>
-              <a:t>33</a:t>
+              <a:t>35</a:t>
             </a:fld>
             <a:endParaRPr lang="en-US"/>
           </a:p>
@@ -3100,7 +3292,103 @@
 </p:notes>
 </file>
 
-<file path=ppt/notesSlides/notesSlide34.xml><?xml version="1.0" encoding="utf-8"?>
+<file path=ppt/notesSlides/notesSlide36.xml><?xml version="1.0" encoding="utf-8"?>
+<p:notes xmlns:a="http://schemas.openxmlformats.org/drawingml/2006/main" xmlns:r="http://schemas.openxmlformats.org/officeDocument/2006/relationships" xmlns:p="http://schemas.openxmlformats.org/presentationml/2006/main">
+  <p:cSld>
+    <p:spTree>
+      <p:nvGrpSpPr>
+        <p:cNvPr id="1" name=""/>
+        <p:cNvGrpSpPr/>
+        <p:nvPr/>
+      </p:nvGrpSpPr>
+      <p:grpSpPr>
+        <a:xfrm>
+          <a:off x="0" y="0"/>
+          <a:ext cx="0" cy="0"/>
+          <a:chOff x="0" y="0"/>
+          <a:chExt cx="0" cy="0"/>
+        </a:xfrm>
+      </p:grpSpPr>
+      <p:sp>
+        <p:nvSpPr>
+          <p:cNvPr id="2" name="Slide Image Placeholder 1"/>
+          <p:cNvSpPr>
+            <a:spLocks noGrp="1" noRot="1" noChangeAspect="1"/>
+          </p:cNvSpPr>
+          <p:nvPr>
+            <p:ph type="sldImg"/>
+          </p:nvPr>
+        </p:nvSpPr>
+        <p:spPr/>
+      </p:sp>
+      <p:sp>
+        <p:nvSpPr>
+          <p:cNvPr id="3" name="Notes Placeholder 2"/>
+          <p:cNvSpPr>
+            <a:spLocks noGrp="1"/>
+          </p:cNvSpPr>
+          <p:nvPr>
+            <p:ph type="body" idx="1"/>
+          </p:nvPr>
+        </p:nvSpPr>
+        <p:spPr/>
+        <p:txBody>
+          <a:bodyPr/>
+          <a:lstStyle/>
+          <a:p>
+            <a:r>
+              <a:rPr lang="en-US" dirty="0"/>
+              <a:t>The bridge, and the end of the taught half. Six steps, and today they followed
+one request through all of them. Every tool of this kind, whatever its name and
+whoever makes it, runs the same six.
+Ask the room which of the six belonged to the model. One: the answer. At every
+other step the thing that decided what happened next was them, or a rule
+somebody wrote down in advance.
+Then leave the bold line up and do not answer it. Tomorrow's lecture opens on
+exactly this question, has a live demo for it, and spends ninety minutes on the
+answer. Saying more here spoils it; saying this much is what makes tomorrow land.</a:t>
+            </a:r>
+            <a:endParaRPr lang="en-US" dirty="0"/>
+          </a:p>
+        </p:txBody>
+      </p:sp>
+      <p:sp>
+        <p:nvSpPr>
+          <p:cNvPr id="4" name="Slide Number Placeholder 3"/>
+          <p:cNvSpPr>
+            <a:spLocks noGrp="1"/>
+          </p:cNvSpPr>
+          <p:nvPr>
+            <p:ph type="sldNum" sz="quarter" idx="10"/>
+          </p:nvPr>
+        </p:nvSpPr>
+        <p:spPr/>
+        <p:txBody>
+          <a:bodyPr/>
+          <a:lstStyle/>
+          <a:p>
+            <a:fld id="{F7021451-1387-4CA6-816F-3879F97B5CBC}" type="slidenum">
+              <a:rPr lang="en-US"/>
+              <a:t>36</a:t>
+            </a:fld>
+            <a:endParaRPr lang="en-US"/>
+          </a:p>
+        </p:txBody>
+      </p:sp>
+    </p:spTree>
+    <p:extLst>
+      <p:ext uri="{BB962C8B-B14F-4D97-AF65-F5344CB8AC3E}">
+        <p14:creationId xmlns:p14="http://schemas.microsoft.com/office/powerpoint/2010/main" val="1024086991"/>
+      </p:ext>
+    </p:extLst>
+  </p:cSld>
+  <p:clrMapOvr>
+    <a:masterClrMapping/>
+  </p:clrMapOvr>
+</p:notes>
+</file>
+
+<file path=ppt/notesSlides/notesSlide37.xml><?xml version="1.0" encoding="utf-8"?>
 <p:notes xmlns:a="http://schemas.openxmlformats.org/drawingml/2006/main" xmlns:r="http://schemas.openxmlformats.org/officeDocument/2006/relationships" xmlns:p="http://schemas.openxmlformats.org/presentationml/2006/main">
   <p:cSld>
     <p:spTree>
@@ -3172,7 +3460,7 @@
           <a:p>
             <a:fld id="{F7021451-1387-4CA6-816F-3879F97B5CBC}" type="slidenum">
               <a:rPr lang="en-US"/>
-              <a:t>34</a:t>
+              <a:t>37</a:t>
             </a:fld>
             <a:endParaRPr lang="en-US"/>
           </a:p>
@@ -3191,7 +3479,7 @@
 </p:notes>
 </file>
 
-<file path=ppt/notesSlides/notesSlide35.xml><?xml version="1.0" encoding="utf-8"?>
+<file path=ppt/notesSlides/notesSlide38.xml><?xml version="1.0" encoding="utf-8"?>
 <p:notes xmlns:a="http://schemas.openxmlformats.org/drawingml/2006/main" xmlns:r="http://schemas.openxmlformats.org/officeDocument/2006/relationships" xmlns:p="http://schemas.openxmlformats.org/presentationml/2006/main">
   <p:cSld>
     <p:spTree>
@@ -3269,7 +3557,7 @@
           <a:p>
             <a:fld id="{F7021451-1387-4CA6-816F-3879F97B5CBC}" type="slidenum">
               <a:rPr lang="en-US"/>
-              <a:t>35</a:t>
+              <a:t>38</a:t>
             </a:fld>
             <a:endParaRPr lang="en-US"/>
           </a:p>
@@ -3288,7 +3576,7 @@
 </p:notes>
 </file>
 
-<file path=ppt/notesSlides/notesSlide36.xml><?xml version="1.0" encoding="utf-8"?>
+<file path=ppt/notesSlides/notesSlide39.xml><?xml version="1.0" encoding="utf-8"?>
 <p:notes xmlns:a="http://schemas.openxmlformats.org/drawingml/2006/main" xmlns:r="http://schemas.openxmlformats.org/officeDocument/2006/relationships" xmlns:p="http://schemas.openxmlformats.org/presentationml/2006/main">
   <p:cSld>
     <p:spTree>
@@ -3364,186 +3652,7 @@
           <a:p>
             <a:fld id="{F7021451-1387-4CA6-816F-3879F97B5CBC}" type="slidenum">
               <a:rPr lang="en-US"/>
-              <a:t>36</a:t>
-            </a:fld>
-            <a:endParaRPr lang="en-US"/>
-          </a:p>
-        </p:txBody>
-      </p:sp>
-    </p:spTree>
-    <p:extLst>
-      <p:ext uri="{BB962C8B-B14F-4D97-AF65-F5344CB8AC3E}">
-        <p14:creationId xmlns:p14="http://schemas.microsoft.com/office/powerpoint/2010/main" val="1024086991"/>
-      </p:ext>
-    </p:extLst>
-  </p:cSld>
-  <p:clrMapOvr>
-    <a:masterClrMapping/>
-  </p:clrMapOvr>
-</p:notes>
-</file>
-
-<file path=ppt/notesSlides/notesSlide37.xml><?xml version="1.0" encoding="utf-8"?>
-<p:notes xmlns:a="http://schemas.openxmlformats.org/drawingml/2006/main" xmlns:r="http://schemas.openxmlformats.org/officeDocument/2006/relationships" xmlns:p="http://schemas.openxmlformats.org/presentationml/2006/main">
-  <p:cSld>
-    <p:spTree>
-      <p:nvGrpSpPr>
-        <p:cNvPr id="1" name=""/>
-        <p:cNvGrpSpPr/>
-        <p:nvPr/>
-      </p:nvGrpSpPr>
-      <p:grpSpPr>
-        <a:xfrm>
-          <a:off x="0" y="0"/>
-          <a:ext cx="0" cy="0"/>
-          <a:chOff x="0" y="0"/>
-          <a:chExt cx="0" cy="0"/>
-        </a:xfrm>
-      </p:grpSpPr>
-      <p:sp>
-        <p:nvSpPr>
-          <p:cNvPr id="2" name="Slide Image Placeholder 1"/>
-          <p:cNvSpPr>
-            <a:spLocks noGrp="1" noRot="1" noChangeAspect="1"/>
-          </p:cNvSpPr>
-          <p:nvPr>
-            <p:ph type="sldImg"/>
-          </p:nvPr>
-        </p:nvSpPr>
-        <p:spPr/>
-      </p:sp>
-      <p:sp>
-        <p:nvSpPr>
-          <p:cNvPr id="3" name="Notes Placeholder 2"/>
-          <p:cNvSpPr>
-            <a:spLocks noGrp="1"/>
-          </p:cNvSpPr>
-          <p:nvPr>
-            <p:ph type="body" idx="1"/>
-          </p:nvPr>
-        </p:nvSpPr>
-        <p:spPr/>
-        <p:txBody>
-          <a:bodyPr/>
-          <a:lstStyle/>
-          <a:p>
-            <a:r>
-              <a:rPr lang="en-US" dirty="0"/>
-              <a:t>Stop talking. Staff circulate from here. Leave the deck up so students can page
-back through it themselves.
-This is the point where you say plainly that nothing is due at the end of
-today. Most of them will still expect a checkoff.</a:t>
-            </a:r>
-            <a:endParaRPr lang="en-US" dirty="0"/>
-          </a:p>
-        </p:txBody>
-      </p:sp>
-      <p:sp>
-        <p:nvSpPr>
-          <p:cNvPr id="4" name="Slide Number Placeholder 3"/>
-          <p:cNvSpPr>
-            <a:spLocks noGrp="1"/>
-          </p:cNvSpPr>
-          <p:nvPr>
-            <p:ph type="sldNum" sz="quarter" idx="10"/>
-          </p:nvPr>
-        </p:nvSpPr>
-        <p:spPr/>
-        <p:txBody>
-          <a:bodyPr/>
-          <a:lstStyle/>
-          <a:p>
-            <a:fld id="{F7021451-1387-4CA6-816F-3879F97B5CBC}" type="slidenum">
-              <a:rPr lang="en-US"/>
-              <a:t>37</a:t>
-            </a:fld>
-            <a:endParaRPr lang="en-US"/>
-          </a:p>
-        </p:txBody>
-      </p:sp>
-    </p:spTree>
-    <p:extLst>
-      <p:ext uri="{BB962C8B-B14F-4D97-AF65-F5344CB8AC3E}">
-        <p14:creationId xmlns:p14="http://schemas.microsoft.com/office/powerpoint/2010/main" val="1024086991"/>
-      </p:ext>
-    </p:extLst>
-  </p:cSld>
-  <p:clrMapOvr>
-    <a:masterClrMapping/>
-  </p:clrMapOvr>
-</p:notes>
-</file>
-
-<file path=ppt/notesSlides/notesSlide38.xml><?xml version="1.0" encoding="utf-8"?>
-<p:notes xmlns:a="http://schemas.openxmlformats.org/drawingml/2006/main" xmlns:r="http://schemas.openxmlformats.org/officeDocument/2006/relationships" xmlns:p="http://schemas.openxmlformats.org/presentationml/2006/main">
-  <p:cSld>
-    <p:spTree>
-      <p:nvGrpSpPr>
-        <p:cNvPr id="1" name=""/>
-        <p:cNvGrpSpPr/>
-        <p:nvPr/>
-      </p:nvGrpSpPr>
-      <p:grpSpPr>
-        <a:xfrm>
-          <a:off x="0" y="0"/>
-          <a:ext cx="0" cy="0"/>
-          <a:chOff x="0" y="0"/>
-          <a:chExt cx="0" cy="0"/>
-        </a:xfrm>
-      </p:grpSpPr>
-      <p:sp>
-        <p:nvSpPr>
-          <p:cNvPr id="2" name="Slide Image Placeholder 1"/>
-          <p:cNvSpPr>
-            <a:spLocks noGrp="1" noRot="1" noChangeAspect="1"/>
-          </p:cNvSpPr>
-          <p:nvPr>
-            <p:ph type="sldImg"/>
-          </p:nvPr>
-        </p:nvSpPr>
-        <p:spPr/>
-      </p:sp>
-      <p:sp>
-        <p:nvSpPr>
-          <p:cNvPr id="3" name="Notes Placeholder 2"/>
-          <p:cNvSpPr>
-            <a:spLocks noGrp="1"/>
-          </p:cNvSpPr>
-          <p:nvPr>
-            <p:ph type="body" idx="1"/>
-          </p:nvPr>
-        </p:nvSpPr>
-        <p:spPr/>
-        <p:txBody>
-          <a:bodyPr/>
-          <a:lstStyle/>
-          <a:p>
-            <a:r>
-              <a:rPr lang="en-US" dirty="0"/>
-              <a:t/>
-            </a:r>
-            <a:endParaRPr lang="en-US" dirty="0"/>
-          </a:p>
-        </p:txBody>
-      </p:sp>
-      <p:sp>
-        <p:nvSpPr>
-          <p:cNvPr id="4" name="Slide Number Placeholder 3"/>
-          <p:cNvSpPr>
-            <a:spLocks noGrp="1"/>
-          </p:cNvSpPr>
-          <p:nvPr>
-            <p:ph type="sldNum" sz="quarter" idx="10"/>
-          </p:nvPr>
-        </p:nvSpPr>
-        <p:spPr/>
-        <p:txBody>
-          <a:bodyPr/>
-          <a:lstStyle/>
-          <a:p>
-            <a:fld id="{F7021451-1387-4CA6-816F-3879F97B5CBC}" type="slidenum">
-              <a:rPr lang="en-US"/>
-              <a:t>38</a:t>
+              <a:t>39</a:t>
             </a:fld>
             <a:endParaRPr lang="en-US"/>
           </a:p>
@@ -3640,6 +3749,185 @@
             <a:fld id="{F7021451-1387-4CA6-816F-3879F97B5CBC}" type="slidenum">
               <a:rPr lang="en-US"/>
               <a:t>4</a:t>
+            </a:fld>
+            <a:endParaRPr lang="en-US"/>
+          </a:p>
+        </p:txBody>
+      </p:sp>
+    </p:spTree>
+    <p:extLst>
+      <p:ext uri="{BB962C8B-B14F-4D97-AF65-F5344CB8AC3E}">
+        <p14:creationId xmlns:p14="http://schemas.microsoft.com/office/powerpoint/2010/main" val="1024086991"/>
+      </p:ext>
+    </p:extLst>
+  </p:cSld>
+  <p:clrMapOvr>
+    <a:masterClrMapping/>
+  </p:clrMapOvr>
+</p:notes>
+</file>
+
+<file path=ppt/notesSlides/notesSlide40.xml><?xml version="1.0" encoding="utf-8"?>
+<p:notes xmlns:a="http://schemas.openxmlformats.org/drawingml/2006/main" xmlns:r="http://schemas.openxmlformats.org/officeDocument/2006/relationships" xmlns:p="http://schemas.openxmlformats.org/presentationml/2006/main">
+  <p:cSld>
+    <p:spTree>
+      <p:nvGrpSpPr>
+        <p:cNvPr id="1" name=""/>
+        <p:cNvGrpSpPr/>
+        <p:nvPr/>
+      </p:nvGrpSpPr>
+      <p:grpSpPr>
+        <a:xfrm>
+          <a:off x="0" y="0"/>
+          <a:ext cx="0" cy="0"/>
+          <a:chOff x="0" y="0"/>
+          <a:chExt cx="0" cy="0"/>
+        </a:xfrm>
+      </p:grpSpPr>
+      <p:sp>
+        <p:nvSpPr>
+          <p:cNvPr id="2" name="Slide Image Placeholder 1"/>
+          <p:cNvSpPr>
+            <a:spLocks noGrp="1" noRot="1" noChangeAspect="1"/>
+          </p:cNvSpPr>
+          <p:nvPr>
+            <p:ph type="sldImg"/>
+          </p:nvPr>
+        </p:nvSpPr>
+        <p:spPr/>
+      </p:sp>
+      <p:sp>
+        <p:nvSpPr>
+          <p:cNvPr id="3" name="Notes Placeholder 2"/>
+          <p:cNvSpPr>
+            <a:spLocks noGrp="1"/>
+          </p:cNvSpPr>
+          <p:nvPr>
+            <p:ph type="body" idx="1"/>
+          </p:nvPr>
+        </p:nvSpPr>
+        <p:spPr/>
+        <p:txBody>
+          <a:bodyPr/>
+          <a:lstStyle/>
+          <a:p>
+            <a:r>
+              <a:rPr lang="en-US" dirty="0"/>
+              <a:t>Stop talking. Staff circulate from here. Leave the deck up so students can page
+back through it themselves.
+This is the point where you say plainly that nothing is due at the end of
+today. Most of them will still expect a checkoff.</a:t>
+            </a:r>
+            <a:endParaRPr lang="en-US" dirty="0"/>
+          </a:p>
+        </p:txBody>
+      </p:sp>
+      <p:sp>
+        <p:nvSpPr>
+          <p:cNvPr id="4" name="Slide Number Placeholder 3"/>
+          <p:cNvSpPr>
+            <a:spLocks noGrp="1"/>
+          </p:cNvSpPr>
+          <p:nvPr>
+            <p:ph type="sldNum" sz="quarter" idx="10"/>
+          </p:nvPr>
+        </p:nvSpPr>
+        <p:spPr/>
+        <p:txBody>
+          <a:bodyPr/>
+          <a:lstStyle/>
+          <a:p>
+            <a:fld id="{F7021451-1387-4CA6-816F-3879F97B5CBC}" type="slidenum">
+              <a:rPr lang="en-US"/>
+              <a:t>40</a:t>
+            </a:fld>
+            <a:endParaRPr lang="en-US"/>
+          </a:p>
+        </p:txBody>
+      </p:sp>
+    </p:spTree>
+    <p:extLst>
+      <p:ext uri="{BB962C8B-B14F-4D97-AF65-F5344CB8AC3E}">
+        <p14:creationId xmlns:p14="http://schemas.microsoft.com/office/powerpoint/2010/main" val="1024086991"/>
+      </p:ext>
+    </p:extLst>
+  </p:cSld>
+  <p:clrMapOvr>
+    <a:masterClrMapping/>
+  </p:clrMapOvr>
+</p:notes>
+</file>
+
+<file path=ppt/notesSlides/notesSlide41.xml><?xml version="1.0" encoding="utf-8"?>
+<p:notes xmlns:a="http://schemas.openxmlformats.org/drawingml/2006/main" xmlns:r="http://schemas.openxmlformats.org/officeDocument/2006/relationships" xmlns:p="http://schemas.openxmlformats.org/presentationml/2006/main">
+  <p:cSld>
+    <p:spTree>
+      <p:nvGrpSpPr>
+        <p:cNvPr id="1" name=""/>
+        <p:cNvGrpSpPr/>
+        <p:nvPr/>
+      </p:nvGrpSpPr>
+      <p:grpSpPr>
+        <a:xfrm>
+          <a:off x="0" y="0"/>
+          <a:ext cx="0" cy="0"/>
+          <a:chOff x="0" y="0"/>
+          <a:chExt cx="0" cy="0"/>
+        </a:xfrm>
+      </p:grpSpPr>
+      <p:sp>
+        <p:nvSpPr>
+          <p:cNvPr id="2" name="Slide Image Placeholder 1"/>
+          <p:cNvSpPr>
+            <a:spLocks noGrp="1" noRot="1" noChangeAspect="1"/>
+          </p:cNvSpPr>
+          <p:nvPr>
+            <p:ph type="sldImg"/>
+          </p:nvPr>
+        </p:nvSpPr>
+        <p:spPr/>
+      </p:sp>
+      <p:sp>
+        <p:nvSpPr>
+          <p:cNvPr id="3" name="Notes Placeholder 2"/>
+          <p:cNvSpPr>
+            <a:spLocks noGrp="1"/>
+          </p:cNvSpPr>
+          <p:nvPr>
+            <p:ph type="body" idx="1"/>
+          </p:nvPr>
+        </p:nvSpPr>
+        <p:spPr/>
+        <p:txBody>
+          <a:bodyPr/>
+          <a:lstStyle/>
+          <a:p>
+            <a:r>
+              <a:rPr lang="en-US" dirty="0"/>
+              <a:t/>
+            </a:r>
+            <a:endParaRPr lang="en-US" dirty="0"/>
+          </a:p>
+        </p:txBody>
+      </p:sp>
+      <p:sp>
+        <p:nvSpPr>
+          <p:cNvPr id="4" name="Slide Number Placeholder 3"/>
+          <p:cNvSpPr>
+            <a:spLocks noGrp="1"/>
+          </p:cNvSpPr>
+          <p:nvPr>
+            <p:ph type="sldNum" sz="quarter" idx="10"/>
+          </p:nvPr>
+        </p:nvSpPr>
+        <p:spPr/>
+        <p:txBody>
+          <a:bodyPr/>
+          <a:lstStyle/>
+          <a:p>
+            <a:fld id="{F7021451-1387-4CA6-816F-3879F97B5CBC}" type="slidenum">
+              <a:rPr lang="en-US"/>
+              <a:t>41</a:t>
             </a:fld>
             <a:endParaRPr lang="en-US"/>
           </a:p>
@@ -5675,9 +5963,126 @@
 </p:sld>
 </file>
 
+<file path=ppt/slides/slide39.xml><?xml version="1.0" encoding="utf-8"?>
+<p:sld xmlns:a="http://schemas.openxmlformats.org/drawingml/2006/main" xmlns:r="http://schemas.openxmlformats.org/officeDocument/2006/relationships" xmlns:p="http://schemas.openxmlformats.org/presentationml/2006/main">
+  <p:cSld name="Slide 39">
+    <p:bg>
+      <p:bgPr>
+        <a:blipFill dpi="0" rotWithShape="1">
+          <a:blip r:embed="rId1">
+            <a:lum/>
+          </a:blip>
+          <a:srcRect/>
+          <a:stretch>
+            <a:fillRect/>
+          </a:stretch>
+        </a:blipFill>
+        <a:effectLst/>
+      </p:bgPr>
+    </p:bg>
+    <p:spTree>
+      <p:nvGrpSpPr>
+        <p:cNvPr id="1" name=""/>
+        <p:cNvGrpSpPr/>
+        <p:nvPr/>
+      </p:nvGrpSpPr>
+      <p:grpSpPr>
+        <a:xfrm>
+          <a:off x="0" y="0"/>
+          <a:ext cx="0" cy="0"/>
+          <a:chOff x="0" y="0"/>
+          <a:chExt cx="0" cy="0"/>
+        </a:xfrm>
+      </p:grpSpPr>
+    </p:spTree>
+  </p:cSld>
+  <p:clrMapOvr>
+    <a:masterClrMapping/>
+  </p:clrMapOvr>
+</p:sld>
+</file>
+
 <file path=ppt/slides/slide4.xml><?xml version="1.0" encoding="utf-8"?>
 <p:sld xmlns:a="http://schemas.openxmlformats.org/drawingml/2006/main" xmlns:r="http://schemas.openxmlformats.org/officeDocument/2006/relationships" xmlns:p="http://schemas.openxmlformats.org/presentationml/2006/main">
   <p:cSld name="Slide 4">
+    <p:bg>
+      <p:bgPr>
+        <a:blipFill dpi="0" rotWithShape="1">
+          <a:blip r:embed="rId1">
+            <a:lum/>
+          </a:blip>
+          <a:srcRect/>
+          <a:stretch>
+            <a:fillRect/>
+          </a:stretch>
+        </a:blipFill>
+        <a:effectLst/>
+      </p:bgPr>
+    </p:bg>
+    <p:spTree>
+      <p:nvGrpSpPr>
+        <p:cNvPr id="1" name=""/>
+        <p:cNvGrpSpPr/>
+        <p:nvPr/>
+      </p:nvGrpSpPr>
+      <p:grpSpPr>
+        <a:xfrm>
+          <a:off x="0" y="0"/>
+          <a:ext cx="0" cy="0"/>
+          <a:chOff x="0" y="0"/>
+          <a:chExt cx="0" cy="0"/>
+        </a:xfrm>
+      </p:grpSpPr>
+    </p:spTree>
+  </p:cSld>
+  <p:clrMapOvr>
+    <a:masterClrMapping/>
+  </p:clrMapOvr>
+</p:sld>
+</file>
+
+<file path=ppt/slides/slide40.xml><?xml version="1.0" encoding="utf-8"?>
+<p:sld xmlns:a="http://schemas.openxmlformats.org/drawingml/2006/main" xmlns:r="http://schemas.openxmlformats.org/officeDocument/2006/relationships" xmlns:p="http://schemas.openxmlformats.org/presentationml/2006/main">
+  <p:cSld name="Slide 40">
+    <p:bg>
+      <p:bgPr>
+        <a:blipFill dpi="0" rotWithShape="1">
+          <a:blip r:embed="rId1">
+            <a:lum/>
+          </a:blip>
+          <a:srcRect/>
+          <a:stretch>
+            <a:fillRect/>
+          </a:stretch>
+        </a:blipFill>
+        <a:effectLst/>
+      </p:bgPr>
+    </p:bg>
+    <p:spTree>
+      <p:nvGrpSpPr>
+        <p:cNvPr id="1" name=""/>
+        <p:cNvGrpSpPr/>
+        <p:nvPr/>
+      </p:nvGrpSpPr>
+      <p:grpSpPr>
+        <a:xfrm>
+          <a:off x="0" y="0"/>
+          <a:ext cx="0" cy="0"/>
+          <a:chOff x="0" y="0"/>
+          <a:chExt cx="0" cy="0"/>
+        </a:xfrm>
+      </p:grpSpPr>
+    </p:spTree>
+  </p:cSld>
+  <p:clrMapOvr>
+    <a:masterClrMapping/>
+  </p:clrMapOvr>
+</p:sld>
+</file>
+
+<file path=ppt/slides/slide41.xml><?xml version="1.0" encoding="utf-8"?>
+<p:sld xmlns:a="http://schemas.openxmlformats.org/drawingml/2006/main" xmlns:r="http://schemas.openxmlformats.org/officeDocument/2006/relationships" xmlns:p="http://schemas.openxmlformats.org/presentationml/2006/main">
+  <p:cSld name="Slide 41">
     <p:bg>
       <p:bgPr>
         <a:blipFill dpi="0" rotWithShape="1">

</xml_diff>

<commit_message>
Lab01: republish at 41 slides with the rewritten closing section (#13)
Claude-Session: https://claude.ai/code/session_01HK8wFbKHvmKPXQf2PSK8c1

Co-authored-by: Claude <noreply@anthropic.com>
</commit_message>
<xml_diff>
--- a/labs/Lab01/slides.pptx
+++ b/labs/Lab01/slides.pptx
@@ -43,9 +43,12 @@
     <p:sldId id="291" r:id="rId37"/>
     <p:sldId id="292" r:id="rId38"/>
     <p:sldId id="293" r:id="rId39"/>
+    <p:sldId id="294" r:id="rId40"/>
+    <p:sldId id="295" r:id="rId41"/>
+    <p:sldId id="296" r:id="rId42"/>
   </p:sldIdLst>
   <p:notesMasterIdLst>
-    <p:notesMasterId r:id="rId40"/>
+    <p:notesMasterId r:id="rId43"/>
   </p:notesMasterIdLst>
   <p:sldSz cx="9334500" cy="5248275"/>
   <p:notesSz cx="5248275" cy="9334500"/>
@@ -1702,6 +1705,96 @@
           <a:p>
             <a:r>
               <a:rPr lang="en-US" dirty="0"/>
+              <a:t>Section slide added 2026-09-14 at the instructor's request, so the hackathon
+reads as its own block rather than a tail on the grounding slides. Two slides
+under it: the format, and the workspace. Three or four minutes in total.</a:t>
+            </a:r>
+            <a:endParaRPr lang="en-US" dirty="0"/>
+          </a:p>
+        </p:txBody>
+      </p:sp>
+      <p:sp>
+        <p:nvSpPr>
+          <p:cNvPr id="4" name="Slide Number Placeholder 3"/>
+          <p:cNvSpPr>
+            <a:spLocks noGrp="1"/>
+          </p:cNvSpPr>
+          <p:nvPr>
+            <p:ph type="sldNum" sz="quarter" idx="10"/>
+          </p:nvPr>
+        </p:nvSpPr>
+        <p:spPr/>
+        <p:txBody>
+          <a:bodyPr/>
+          <a:lstStyle/>
+          <a:p>
+            <a:fld id="{F7021451-1387-4CA6-816F-3879F97B5CBC}" type="slidenum">
+              <a:rPr lang="en-US"/>
+              <a:t>20</a:t>
+            </a:fld>
+            <a:endParaRPr lang="en-US"/>
+          </a:p>
+        </p:txBody>
+      </p:sp>
+    </p:spTree>
+    <p:extLst>
+      <p:ext uri="{BB962C8B-B14F-4D97-AF65-F5344CB8AC3E}">
+        <p14:creationId xmlns:p14="http://schemas.microsoft.com/office/powerpoint/2010/main" val="1024086991"/>
+      </p:ext>
+    </p:extLst>
+  </p:cSld>
+  <p:clrMapOvr>
+    <a:masterClrMapping/>
+  </p:clrMapOvr>
+</p:notes>
+</file>
+
+<file path=ppt/notesSlides/notesSlide21.xml><?xml version="1.0" encoding="utf-8"?>
+<p:notes xmlns:a="http://schemas.openxmlformats.org/drawingml/2006/main" xmlns:r="http://schemas.openxmlformats.org/officeDocument/2006/relationships" xmlns:p="http://schemas.openxmlformats.org/presentationml/2006/main">
+  <p:cSld>
+    <p:spTree>
+      <p:nvGrpSpPr>
+        <p:cNvPr id="1" name=""/>
+        <p:cNvGrpSpPr/>
+        <p:nvPr/>
+      </p:nvGrpSpPr>
+      <p:grpSpPr>
+        <a:xfrm>
+          <a:off x="0" y="0"/>
+          <a:ext cx="0" cy="0"/>
+          <a:chOff x="0" y="0"/>
+          <a:chExt cx="0" cy="0"/>
+        </a:xfrm>
+      </p:grpSpPr>
+      <p:sp>
+        <p:nvSpPr>
+          <p:cNvPr id="2" name="Slide Image Placeholder 1"/>
+          <p:cNvSpPr>
+            <a:spLocks noGrp="1" noRot="1" noChangeAspect="1"/>
+          </p:cNvSpPr>
+          <p:nvPr>
+            <p:ph type="sldImg"/>
+          </p:nvPr>
+        </p:nvSpPr>
+        <p:spPr/>
+      </p:sp>
+      <p:sp>
+        <p:nvSpPr>
+          <p:cNvPr id="3" name="Notes Placeholder 2"/>
+          <p:cNvSpPr>
+            <a:spLocks noGrp="1"/>
+          </p:cNvSpPr>
+          <p:nvPr>
+            <p:ph type="body" idx="1"/>
+          </p:nvPr>
+        </p:nvSpPr>
+        <p:spPr/>
+        <p:txBody>
+          <a:bodyPr/>
+          <a:lstStyle/>
+          <a:p>
+            <a:r>
+              <a:rPr lang="en-US" dirty="0"/>
               <a:t>Three minutes including logistics. Room, time and the model in the workspace are
 announced by staff. Do not invent any of them here.
 Say the accommodations line out loud: conflicts and accommodations go to staff
@@ -1730,7 +1823,7 @@
           <a:p>
             <a:fld id="{F7021451-1387-4CA6-816F-3879F97B5CBC}" type="slidenum">
               <a:rPr lang="en-US"/>
-              <a:t>20</a:t>
+              <a:t>21</a:t>
             </a:fld>
             <a:endParaRPr lang="en-US"/>
           </a:p>
@@ -1749,7 +1842,7 @@
 </p:notes>
 </file>
 
-<file path=ppt/notesSlides/notesSlide21.xml><?xml version="1.0" encoding="utf-8"?>
+<file path=ppt/notesSlides/notesSlide22.xml><?xml version="1.0" encoding="utf-8"?>
 <p:notes xmlns:a="http://schemas.openxmlformats.org/drawingml/2006/main" xmlns:r="http://schemas.openxmlformats.org/officeDocument/2006/relationships" xmlns:p="http://schemas.openxmlformats.org/presentationml/2006/main">
   <p:cSld>
     <p:spTree>
@@ -1795,7 +1888,10 @@
           <a:p>
             <a:r>
               <a:rPr lang="en-US" dirty="0"/>
-              <a:t>Nobody installs anything and nobody needs the network. The workspace opens with
+              <a:t>The caption with the token figures and the closing line about bringing a build
+that runs both came off this slide on 2026-09-14 at the instructor's request.
+Both points are still worth saying; they are yours to say, not the slide's.
+Nobody installs anything and nobody needs the network. The workspace opens with
 the tools already pointed at the right place and their own repository in it.
 The caption is the point of the slide and it connects straight back to the
 budget block. The reference pack in the image is most of the Python
@@ -1837,7 +1933,7 @@
           <a:p>
             <a:fld id="{F7021451-1387-4CA6-816F-3879F97B5CBC}" type="slidenum">
               <a:rPr lang="en-US"/>
-              <a:t>21</a:t>
+              <a:t>22</a:t>
             </a:fld>
             <a:endParaRPr lang="en-US"/>
           </a:p>
@@ -1856,7 +1952,7 @@
 </p:notes>
 </file>
 
-<file path=ppt/notesSlides/notesSlide22.xml><?xml version="1.0" encoding="utf-8"?>
+<file path=ppt/notesSlides/notesSlide23.xml><?xml version="1.0" encoding="utf-8"?>
 <p:notes xmlns:a="http://schemas.openxmlformats.org/drawingml/2006/main" xmlns:r="http://schemas.openxmlformats.org/officeDocument/2006/relationships" xmlns:p="http://schemas.openxmlformats.org/presentationml/2006/main">
   <p:cSld>
     <p:spTree>
@@ -1928,7 +2024,7 @@
           <a:p>
             <a:fld id="{F7021451-1387-4CA6-816F-3879F97B5CBC}" type="slidenum">
               <a:rPr lang="en-US"/>
-              <a:t>22</a:t>
+              <a:t>23</a:t>
             </a:fld>
             <a:endParaRPr lang="en-US"/>
           </a:p>
@@ -1947,7 +2043,7 @@
 </p:notes>
 </file>
 
-<file path=ppt/notesSlides/notesSlide23.xml><?xml version="1.0" encoding="utf-8"?>
+<file path=ppt/notesSlides/notesSlide24.xml><?xml version="1.0" encoding="utf-8"?>
 <p:notes xmlns:a="http://schemas.openxmlformats.org/drawingml/2006/main" xmlns:r="http://schemas.openxmlformats.org/officeDocument/2006/relationships" xmlns:p="http://schemas.openxmlformats.org/presentationml/2006/main">
   <p:cSld>
     <p:spTree>
@@ -2024,7 +2120,7 @@
           <a:p>
             <a:fld id="{F7021451-1387-4CA6-816F-3879F97B5CBC}" type="slidenum">
               <a:rPr lang="en-US"/>
-              <a:t>23</a:t>
+              <a:t>24</a:t>
             </a:fld>
             <a:endParaRPr lang="en-US"/>
           </a:p>
@@ -2043,7 +2139,7 @@
 </p:notes>
 </file>
 
-<file path=ppt/notesSlides/notesSlide24.xml><?xml version="1.0" encoding="utf-8"?>
+<file path=ppt/notesSlides/notesSlide25.xml><?xml version="1.0" encoding="utf-8"?>
 <p:notes xmlns:a="http://schemas.openxmlformats.org/drawingml/2006/main" xmlns:r="http://schemas.openxmlformats.org/officeDocument/2006/relationships" xmlns:p="http://schemas.openxmlformats.org/presentationml/2006/main">
   <p:cSld>
     <p:spTree>
@@ -2123,7 +2219,7 @@
           <a:p>
             <a:fld id="{F7021451-1387-4CA6-816F-3879F97B5CBC}" type="slidenum">
               <a:rPr lang="en-US"/>
-              <a:t>24</a:t>
+              <a:t>25</a:t>
             </a:fld>
             <a:endParaRPr lang="en-US"/>
           </a:p>
@@ -2142,7 +2238,7 @@
 </p:notes>
 </file>
 
-<file path=ppt/notesSlides/notesSlide25.xml><?xml version="1.0" encoding="utf-8"?>
+<file path=ppt/notesSlides/notesSlide26.xml><?xml version="1.0" encoding="utf-8"?>
 <p:notes xmlns:a="http://schemas.openxmlformats.org/drawingml/2006/main" xmlns:r="http://schemas.openxmlformats.org/officeDocument/2006/relationships" xmlns:p="http://schemas.openxmlformats.org/presentationml/2006/main">
   <p:cSld>
     <p:spTree>
@@ -2216,7 +2312,7 @@
           <a:p>
             <a:fld id="{F7021451-1387-4CA6-816F-3879F97B5CBC}" type="slidenum">
               <a:rPr lang="en-US"/>
-              <a:t>25</a:t>
+              <a:t>26</a:t>
             </a:fld>
             <a:endParaRPr lang="en-US"/>
           </a:p>
@@ -2235,7 +2331,7 @@
 </p:notes>
 </file>
 
-<file path=ppt/notesSlides/notesSlide26.xml><?xml version="1.0" encoding="utf-8"?>
+<file path=ppt/notesSlides/notesSlide27.xml><?xml version="1.0" encoding="utf-8"?>
 <p:notes xmlns:a="http://schemas.openxmlformats.org/drawingml/2006/main" xmlns:r="http://schemas.openxmlformats.org/officeDocument/2006/relationships" xmlns:p="http://schemas.openxmlformats.org/presentationml/2006/main">
   <p:cSld>
     <p:spTree>
@@ -2311,7 +2407,7 @@
           <a:p>
             <a:fld id="{F7021451-1387-4CA6-816F-3879F97B5CBC}" type="slidenum">
               <a:rPr lang="en-US"/>
-              <a:t>26</a:t>
+              <a:t>27</a:t>
             </a:fld>
             <a:endParaRPr lang="en-US"/>
           </a:p>
@@ -2330,7 +2426,7 @@
 </p:notes>
 </file>
 
-<file path=ppt/notesSlides/notesSlide27.xml><?xml version="1.0" encoding="utf-8"?>
+<file path=ppt/notesSlides/notesSlide28.xml><?xml version="1.0" encoding="utf-8"?>
 <p:notes xmlns:a="http://schemas.openxmlformats.org/drawingml/2006/main" xmlns:r="http://schemas.openxmlformats.org/officeDocument/2006/relationships" xmlns:p="http://schemas.openxmlformats.org/presentationml/2006/main">
   <p:cSld>
     <p:spTree>
@@ -2414,7 +2510,7 @@
           <a:p>
             <a:fld id="{F7021451-1387-4CA6-816F-3879F97B5CBC}" type="slidenum">
               <a:rPr lang="en-US"/>
-              <a:t>27</a:t>
+              <a:t>28</a:t>
             </a:fld>
             <a:endParaRPr lang="en-US"/>
           </a:p>
@@ -2433,7 +2529,7 @@
 </p:notes>
 </file>
 
-<file path=ppt/notesSlides/notesSlide28.xml><?xml version="1.0" encoding="utf-8"?>
+<file path=ppt/notesSlides/notesSlide29.xml><?xml version="1.0" encoding="utf-8"?>
 <p:notes xmlns:a="http://schemas.openxmlformats.org/drawingml/2006/main" xmlns:r="http://schemas.openxmlformats.org/officeDocument/2006/relationships" xmlns:p="http://schemas.openxmlformats.org/presentationml/2006/main">
   <p:cSld>
     <p:spTree>
@@ -2485,98 +2581,6 @@
 Sessions and model disclosure are required but score no points of their own.
 They are what lets staff follow the rest of the evidence, so a submission
 without them loses credit wherever a claim cannot be checked.</a:t>
-            </a:r>
-            <a:endParaRPr lang="en-US" dirty="0"/>
-          </a:p>
-        </p:txBody>
-      </p:sp>
-      <p:sp>
-        <p:nvSpPr>
-          <p:cNvPr id="4" name="Slide Number Placeholder 3"/>
-          <p:cNvSpPr>
-            <a:spLocks noGrp="1"/>
-          </p:cNvSpPr>
-          <p:nvPr>
-            <p:ph type="sldNum" sz="quarter" idx="10"/>
-          </p:nvPr>
-        </p:nvSpPr>
-        <p:spPr/>
-        <p:txBody>
-          <a:bodyPr/>
-          <a:lstStyle/>
-          <a:p>
-            <a:fld id="{F7021451-1387-4CA6-816F-3879F97B5CBC}" type="slidenum">
-              <a:rPr lang="en-US"/>
-              <a:t>28</a:t>
-            </a:fld>
-            <a:endParaRPr lang="en-US"/>
-          </a:p>
-        </p:txBody>
-      </p:sp>
-    </p:spTree>
-    <p:extLst>
-      <p:ext uri="{BB962C8B-B14F-4D97-AF65-F5344CB8AC3E}">
-        <p14:creationId xmlns:p14="http://schemas.microsoft.com/office/powerpoint/2010/main" val="1024086991"/>
-      </p:ext>
-    </p:extLst>
-  </p:cSld>
-  <p:clrMapOvr>
-    <a:masterClrMapping/>
-  </p:clrMapOvr>
-</p:notes>
-</file>
-
-<file path=ppt/notesSlides/notesSlide29.xml><?xml version="1.0" encoding="utf-8"?>
-<p:notes xmlns:a="http://schemas.openxmlformats.org/drawingml/2006/main" xmlns:r="http://schemas.openxmlformats.org/officeDocument/2006/relationships" xmlns:p="http://schemas.openxmlformats.org/presentationml/2006/main">
-  <p:cSld>
-    <p:spTree>
-      <p:nvGrpSpPr>
-        <p:cNvPr id="1" name=""/>
-        <p:cNvGrpSpPr/>
-        <p:nvPr/>
-      </p:nvGrpSpPr>
-      <p:grpSpPr>
-        <a:xfrm>
-          <a:off x="0" y="0"/>
-          <a:ext cx="0" cy="0"/>
-          <a:chOff x="0" y="0"/>
-          <a:chExt cx="0" cy="0"/>
-        </a:xfrm>
-      </p:grpSpPr>
-      <p:sp>
-        <p:nvSpPr>
-          <p:cNvPr id="2" name="Slide Image Placeholder 1"/>
-          <p:cNvSpPr>
-            <a:spLocks noGrp="1" noRot="1" noChangeAspect="1"/>
-          </p:cNvSpPr>
-          <p:nvPr>
-            <p:ph type="sldImg"/>
-          </p:nvPr>
-        </p:nvSpPr>
-        <p:spPr/>
-      </p:sp>
-      <p:sp>
-        <p:nvSpPr>
-          <p:cNvPr id="3" name="Notes Placeholder 2"/>
-          <p:cNvSpPr>
-            <a:spLocks noGrp="1"/>
-          </p:cNvSpPr>
-          <p:nvPr>
-            <p:ph type="body" idx="1"/>
-          </p:nvPr>
-        </p:nvSpPr>
-        <p:spPr/>
-        <p:txBody>
-          <a:bodyPr/>
-          <a:lstStyle/>
-          <a:p>
-            <a:r>
-              <a:rPr lang="en-US" dirty="0"/>
-              <a:t>Exact model IDs and the observed-session exception are in the assignment packet.
-Read them from there rather than from memory.
-The pattern being ruled out is a frontier model for the design followed by a
-local model for the code. Keep the sessions, disclose real aliases and any
-quantization you know about.</a:t>
             </a:r>
             <a:endParaRPr lang="en-US" dirty="0"/>
           </a:p>
@@ -2759,14 +2763,11 @@
           <a:p>
             <a:r>
               <a:rPr lang="en-US" dirty="0"/>
-              <a:t>Reworked into a discussion 2026-09-13. It was two dense tables at the end of a
-long taught half and it read as a summary nobody asked for.
-It is now a short argument followed by real questions. The tables are the
-material for the discussion, not the point of the section. Put one up, give them
-the line, and then get out of the way.
-The question some of them have been holding for two weeks is why this course
-teaches on Aider rather than the tool everyone talks about. Answer it here, once,
-and answer it honestly rather than defending the choice.</a:t>
+              <a:t>Exact model IDs and the observed-session exception are in the assignment packet.
+Read them from there rather than from memory.
+The pattern being ruled out is a frontier model for the design followed by a
+local model for the code. Keep the sessions, disclose real aliases and any
+quantization you know about.</a:t>
             </a:r>
             <a:endParaRPr lang="en-US" dirty="0"/>
           </a:p>
@@ -2854,11 +2855,205 @@
           <a:p>
             <a:r>
               <a:rPr lang="en-US" dirty="0"/>
+              <a:t>Rewritten 2026-09-14 on instructor direction: the discussion slide is gone and
+the section is now five slides that make an argument rather than a summary.
+What you can see, what seeing it costs, who chooses the context, what you own,
+and the one question left open for tomorrow.
+The question some of them have been holding for two weeks is why this course
+teaches on Aider rather than the tool everyone talks about. This section answers
+it, once, honestly, and without defending the choice. The short form: every
+decision a harness makes is on display here, they are about to build one, and
+the bigger tools are this loop with more of it automated.</a:t>
+            </a:r>
+            <a:endParaRPr lang="en-US" dirty="0"/>
+          </a:p>
+        </p:txBody>
+      </p:sp>
+      <p:sp>
+        <p:nvSpPr>
+          <p:cNvPr id="4" name="Slide Number Placeholder 3"/>
+          <p:cNvSpPr>
+            <a:spLocks noGrp="1"/>
+          </p:cNvSpPr>
+          <p:nvPr>
+            <p:ph type="sldNum" sz="quarter" idx="10"/>
+          </p:nvPr>
+        </p:nvSpPr>
+        <p:spPr/>
+        <p:txBody>
+          <a:bodyPr/>
+          <a:lstStyle/>
+          <a:p>
+            <a:fld id="{F7021451-1387-4CA6-816F-3879F97B5CBC}" type="slidenum">
+              <a:rPr lang="en-US"/>
+              <a:t>31</a:t>
+            </a:fld>
+            <a:endParaRPr lang="en-US"/>
+          </a:p>
+        </p:txBody>
+      </p:sp>
+    </p:spTree>
+    <p:extLst>
+      <p:ext uri="{BB962C8B-B14F-4D97-AF65-F5344CB8AC3E}">
+        <p14:creationId xmlns:p14="http://schemas.microsoft.com/office/powerpoint/2010/main" val="1024086991"/>
+      </p:ext>
+    </p:extLst>
+  </p:cSld>
+  <p:clrMapOvr>
+    <a:masterClrMapping/>
+  </p:clrMapOvr>
+</p:notes>
+</file>
+
+<file path=ppt/notesSlides/notesSlide32.xml><?xml version="1.0" encoding="utf-8"?>
+<p:notes xmlns:a="http://schemas.openxmlformats.org/drawingml/2006/main" xmlns:r="http://schemas.openxmlformats.org/officeDocument/2006/relationships" xmlns:p="http://schemas.openxmlformats.org/presentationml/2006/main">
+  <p:cSld>
+    <p:spTree>
+      <p:nvGrpSpPr>
+        <p:cNvPr id="1" name=""/>
+        <p:cNvGrpSpPr/>
+        <p:nvPr/>
+      </p:nvGrpSpPr>
+      <p:grpSpPr>
+        <a:xfrm>
+          <a:off x="0" y="0"/>
+          <a:ext cx="0" cy="0"/>
+          <a:chOff x="0" y="0"/>
+          <a:chExt cx="0" cy="0"/>
+        </a:xfrm>
+      </p:grpSpPr>
+      <p:sp>
+        <p:nvSpPr>
+          <p:cNvPr id="2" name="Slide Image Placeholder 1"/>
+          <p:cNvSpPr>
+            <a:spLocks noGrp="1" noRot="1" noChangeAspect="1"/>
+          </p:cNvSpPr>
+          <p:nvPr>
+            <p:ph type="sldImg"/>
+          </p:nvPr>
+        </p:nvSpPr>
+        <p:spPr/>
+      </p:sp>
+      <p:sp>
+        <p:nvSpPr>
+          <p:cNvPr id="3" name="Notes Placeholder 2"/>
+          <p:cNvSpPr>
+            <a:spLocks noGrp="1"/>
+          </p:cNvSpPr>
+          <p:nvPr>
+            <p:ph type="body" idx="1"/>
+          </p:nvPr>
+        </p:nvSpPr>
+        <p:spPr/>
+        <p:txBody>
+          <a:bodyPr/>
+          <a:lstStyle/>
+          <a:p>
+            <a:r>
+              <a:rPr lang="en-US" dirty="0"/>
+              <a:t>Four decisions every harness makes, and for each one the moment in the last two
+weeks when they made it or watched it. That is the whole pedagogical case: not
+that Aider is the best tool, but that it is the one where the joins show.
+The bold line is the argument against starting on a more automated tool. It
+would make the same four decisions, and they would never see any of them, so
+they would leave knowing how to use it and not how it works. This course is
+about how it works, because in three weeks they have to write one.
+If someone says the more automated tool is better: agree. It is. That is a
+different claim from being better to learn on, and the next slide is about what
+the difference costs.</a:t>
+            </a:r>
+            <a:endParaRPr lang="en-US" dirty="0"/>
+          </a:p>
+        </p:txBody>
+      </p:sp>
+      <p:sp>
+        <p:nvSpPr>
+          <p:cNvPr id="4" name="Slide Number Placeholder 3"/>
+          <p:cNvSpPr>
+            <a:spLocks noGrp="1"/>
+          </p:cNvSpPr>
+          <p:nvPr>
+            <p:ph type="sldNum" sz="quarter" idx="10"/>
+          </p:nvPr>
+        </p:nvSpPr>
+        <p:spPr/>
+        <p:txBody>
+          <a:bodyPr/>
+          <a:lstStyle/>
+          <a:p>
+            <a:fld id="{F7021451-1387-4CA6-816F-3879F97B5CBC}" type="slidenum">
+              <a:rPr lang="en-US"/>
+              <a:t>32</a:t>
+            </a:fld>
+            <a:endParaRPr lang="en-US"/>
+          </a:p>
+        </p:txBody>
+      </p:sp>
+    </p:spTree>
+    <p:extLst>
+      <p:ext uri="{BB962C8B-B14F-4D97-AF65-F5344CB8AC3E}">
+        <p14:creationId xmlns:p14="http://schemas.microsoft.com/office/powerpoint/2010/main" val="1024086991"/>
+      </p:ext>
+    </p:extLst>
+  </p:cSld>
+  <p:clrMapOvr>
+    <a:masterClrMapping/>
+  </p:clrMapOvr>
+</p:notes>
+</file>
+
+<file path=ppt/notesSlides/notesSlide33.xml><?xml version="1.0" encoding="utf-8"?>
+<p:notes xmlns:a="http://schemas.openxmlformats.org/drawingml/2006/main" xmlns:r="http://schemas.openxmlformats.org/officeDocument/2006/relationships" xmlns:p="http://schemas.openxmlformats.org/presentationml/2006/main">
+  <p:cSld>
+    <p:spTree>
+      <p:nvGrpSpPr>
+        <p:cNvPr id="1" name=""/>
+        <p:cNvGrpSpPr/>
+        <p:nvPr/>
+      </p:nvGrpSpPr>
+      <p:grpSpPr>
+        <a:xfrm>
+          <a:off x="0" y="0"/>
+          <a:ext cx="0" cy="0"/>
+          <a:chOff x="0" y="0"/>
+          <a:chExt cx="0" cy="0"/>
+        </a:xfrm>
+      </p:grpSpPr>
+      <p:sp>
+        <p:nvSpPr>
+          <p:cNvPr id="2" name="Slide Image Placeholder 1"/>
+          <p:cNvSpPr>
+            <a:spLocks noGrp="1" noRot="1" noChangeAspect="1"/>
+          </p:cNvSpPr>
+          <p:nvPr>
+            <p:ph type="sldImg"/>
+          </p:nvPr>
+        </p:nvSpPr>
+        <p:spPr/>
+      </p:sp>
+      <p:sp>
+        <p:nvSpPr>
+          <p:cNvPr id="3" name="Notes Placeholder 2"/>
+          <p:cNvSpPr>
+            <a:spLocks noGrp="1"/>
+          </p:cNvSpPr>
+          <p:nvPr>
+            <p:ph type="body" idx="1"/>
+          </p:nvPr>
+        </p:nvSpPr>
+        <p:spPr/>
+        <p:txBody>
+          <a:bodyPr/>
+          <a:lstStyle/>
+          <a:p>
+            <a:r>
+              <a:rPr lang="en-US" dirty="0"/>
               <a:t>Read down it and resist making the left column win. Each line is a single design
 choice seen twice, which is what a trade-off actually is, and the right column is
 not a list of bugs.
-Do not spend long here. The rows are the raw material for the questions two
-slides on, and the discussion is worth more than your commentary.
+Their build inherits every row. When they write the specification this week they
+are choosing which side of each one to stand on, and the packet does not choose
+for them.
 The row to expand if you expand one: forgetting between sessions is not a
 limitation of the model. Every tool of this kind does it. Continuity is the
 harness re-sending, which is the first thing they learned today.</a:t>
@@ -2884,7 +3079,7 @@
           <a:p>
             <a:fld id="{F7021451-1387-4CA6-816F-3879F97B5CBC}" type="slidenum">
               <a:rPr lang="en-US"/>
-              <a:t>31</a:t>
+              <a:t>33</a:t>
             </a:fld>
             <a:endParaRPr lang="en-US"/>
           </a:p>
@@ -2903,7 +3098,7 @@
 </p:notes>
 </file>
 
-<file path=ppt/notesSlides/notesSlide32.xml><?xml version="1.0" encoding="utf-8"?>
+<file path=ppt/notesSlides/notesSlide34.xml><?xml version="1.0" encoding="utf-8"?>
 <p:notes xmlns:a="http://schemas.openxmlformats.org/drawingml/2006/main" xmlns:r="http://schemas.openxmlformats.org/officeDocument/2006/relationships" xmlns:p="http://schemas.openxmlformats.org/presentationml/2006/main">
   <p:cSld>
     <p:spTree>
@@ -2956,9 +3151,9 @@
 the same decisions without displaying them, which is exactly what makes it a
 worse thing to learn on and a better thing to use.
 Stop at context. Who picks the next action is tomorrow's lecture and it has a
-live demo for it, so do not pre-empt it.
-Then the bold line, which is the promise: none of this is magic, it is machinery,
-and they start writing it this week.</a:t>
+live demo for it, so do not pre-empt it beyond the last slide of this section.
+Then the bold line, which is the promise: none of this is machinery they cannot
+build, and they start writing it this week.</a:t>
             </a:r>
             <a:endParaRPr lang="en-US" dirty="0"/>
           </a:p>
@@ -2981,7 +3176,7 @@
           <a:p>
             <a:fld id="{F7021451-1387-4CA6-816F-3879F97B5CBC}" type="slidenum">
               <a:rPr lang="en-US"/>
-              <a:t>32</a:t>
+              <a:t>34</a:t>
             </a:fld>
             <a:endParaRPr lang="en-US"/>
           </a:p>
@@ -3000,7 +3195,7 @@
 </p:notes>
 </file>
 
-<file path=ppt/notesSlides/notesSlide33.xml><?xml version="1.0" encoding="utf-8"?>
+<file path=ppt/notesSlides/notesSlide35.xml><?xml version="1.0" encoding="utf-8"?>
 <p:notes xmlns:a="http://schemas.openxmlformats.org/drawingml/2006/main" xmlns:r="http://schemas.openxmlformats.org/officeDocument/2006/relationships" xmlns:p="http://schemas.openxmlformats.org/presentationml/2006/main">
   <p:cSld>
     <p:spTree>
@@ -3046,19 +3241,16 @@
           <a:p>
             <a:r>
               <a:rPr lang="en-US" dirty="0"/>
-              <a:t>Leave this up and let them talk. Five minutes, and it is fine if only two of the
-three get air.
-One is the honest one: somebody will say they would never ship a tool that
-forgets everything, and that is a real design position with a real cost, which is
-the whole point of the ledger.
-Two is the bridge to tomorrow's lecture and to Analyze, so take an answer and
-leave it open rather than resolving it.
-Three is the one that makes them better engineers this week. It comes straight
-off the error-message slide: the audience for a failure might be the user, the
-model, or the log, and choosing wrong is why so many of their sessions will
-stall. Their failure-path tests are worth eight points.
-If the room is flat, ask three directly at one person's build rather than at the
-room.</a:t>
+              <a:t>This is the idea that outlasts the course. Aider talks to any endpoint that
+speaks the common API, which is why it runs against the course server, against
+a model on their own laptop, and against a paid provider with one line changed.
+The model is swappable. It is a dependency, like a database driver.
+What is not swappable is the harness: which text goes in, in what order, what a
+reply is allowed to do, what gets written and committed. Every slide today was
+about that layer, and none of it belonged to the model.
+Their build has this shape by design: one endpoint, any permitted model, and
+everything they are graded on lives above the API call. The same is true of the
+tool everyone talks about. Its value is not the model behind it.</a:t>
             </a:r>
             <a:endParaRPr lang="en-US" dirty="0"/>
           </a:p>
@@ -3081,7 +3273,7 @@
           <a:p>
             <a:fld id="{F7021451-1387-4CA6-816F-3879F97B5CBC}" type="slidenum">
               <a:rPr lang="en-US"/>
-              <a:t>33</a:t>
+              <a:t>35</a:t>
             </a:fld>
             <a:endParaRPr lang="en-US"/>
           </a:p>
@@ -3100,7 +3292,103 @@
 </p:notes>
 </file>
 
-<file path=ppt/notesSlides/notesSlide34.xml><?xml version="1.0" encoding="utf-8"?>
+<file path=ppt/notesSlides/notesSlide36.xml><?xml version="1.0" encoding="utf-8"?>
+<p:notes xmlns:a="http://schemas.openxmlformats.org/drawingml/2006/main" xmlns:r="http://schemas.openxmlformats.org/officeDocument/2006/relationships" xmlns:p="http://schemas.openxmlformats.org/presentationml/2006/main">
+  <p:cSld>
+    <p:spTree>
+      <p:nvGrpSpPr>
+        <p:cNvPr id="1" name=""/>
+        <p:cNvGrpSpPr/>
+        <p:nvPr/>
+      </p:nvGrpSpPr>
+      <p:grpSpPr>
+        <a:xfrm>
+          <a:off x="0" y="0"/>
+          <a:ext cx="0" cy="0"/>
+          <a:chOff x="0" y="0"/>
+          <a:chExt cx="0" cy="0"/>
+        </a:xfrm>
+      </p:grpSpPr>
+      <p:sp>
+        <p:nvSpPr>
+          <p:cNvPr id="2" name="Slide Image Placeholder 1"/>
+          <p:cNvSpPr>
+            <a:spLocks noGrp="1" noRot="1" noChangeAspect="1"/>
+          </p:cNvSpPr>
+          <p:nvPr>
+            <p:ph type="sldImg"/>
+          </p:nvPr>
+        </p:nvSpPr>
+        <p:spPr/>
+      </p:sp>
+      <p:sp>
+        <p:nvSpPr>
+          <p:cNvPr id="3" name="Notes Placeholder 2"/>
+          <p:cNvSpPr>
+            <a:spLocks noGrp="1"/>
+          </p:cNvSpPr>
+          <p:nvPr>
+            <p:ph type="body" idx="1"/>
+          </p:nvPr>
+        </p:nvSpPr>
+        <p:spPr/>
+        <p:txBody>
+          <a:bodyPr/>
+          <a:lstStyle/>
+          <a:p>
+            <a:r>
+              <a:rPr lang="en-US" dirty="0"/>
+              <a:t>The bridge, and the end of the taught half. Six steps, and today they followed
+one request through all of them. Every tool of this kind, whatever its name and
+whoever makes it, runs the same six.
+Ask the room which of the six belonged to the model. One: the answer. At every
+other step the thing that decided what happened next was them, or a rule
+somebody wrote down in advance.
+Then leave the bold line up and do not answer it. Tomorrow's lecture opens on
+exactly this question, has a live demo for it, and spends ninety minutes on the
+answer. Saying more here spoils it; saying this much is what makes tomorrow land.</a:t>
+            </a:r>
+            <a:endParaRPr lang="en-US" dirty="0"/>
+          </a:p>
+        </p:txBody>
+      </p:sp>
+      <p:sp>
+        <p:nvSpPr>
+          <p:cNvPr id="4" name="Slide Number Placeholder 3"/>
+          <p:cNvSpPr>
+            <a:spLocks noGrp="1"/>
+          </p:cNvSpPr>
+          <p:nvPr>
+            <p:ph type="sldNum" sz="quarter" idx="10"/>
+          </p:nvPr>
+        </p:nvSpPr>
+        <p:spPr/>
+        <p:txBody>
+          <a:bodyPr/>
+          <a:lstStyle/>
+          <a:p>
+            <a:fld id="{F7021451-1387-4CA6-816F-3879F97B5CBC}" type="slidenum">
+              <a:rPr lang="en-US"/>
+              <a:t>36</a:t>
+            </a:fld>
+            <a:endParaRPr lang="en-US"/>
+          </a:p>
+        </p:txBody>
+      </p:sp>
+    </p:spTree>
+    <p:extLst>
+      <p:ext uri="{BB962C8B-B14F-4D97-AF65-F5344CB8AC3E}">
+        <p14:creationId xmlns:p14="http://schemas.microsoft.com/office/powerpoint/2010/main" val="1024086991"/>
+      </p:ext>
+    </p:extLst>
+  </p:cSld>
+  <p:clrMapOvr>
+    <a:masterClrMapping/>
+  </p:clrMapOvr>
+</p:notes>
+</file>
+
+<file path=ppt/notesSlides/notesSlide37.xml><?xml version="1.0" encoding="utf-8"?>
 <p:notes xmlns:a="http://schemas.openxmlformats.org/drawingml/2006/main" xmlns:r="http://schemas.openxmlformats.org/officeDocument/2006/relationships" xmlns:p="http://schemas.openxmlformats.org/presentationml/2006/main">
   <p:cSld>
     <p:spTree>
@@ -3172,7 +3460,7 @@
           <a:p>
             <a:fld id="{F7021451-1387-4CA6-816F-3879F97B5CBC}" type="slidenum">
               <a:rPr lang="en-US"/>
-              <a:t>34</a:t>
+              <a:t>37</a:t>
             </a:fld>
             <a:endParaRPr lang="en-US"/>
           </a:p>
@@ -3191,7 +3479,7 @@
 </p:notes>
 </file>
 
-<file path=ppt/notesSlides/notesSlide35.xml><?xml version="1.0" encoding="utf-8"?>
+<file path=ppt/notesSlides/notesSlide38.xml><?xml version="1.0" encoding="utf-8"?>
 <p:notes xmlns:a="http://schemas.openxmlformats.org/drawingml/2006/main" xmlns:r="http://schemas.openxmlformats.org/officeDocument/2006/relationships" xmlns:p="http://schemas.openxmlformats.org/presentationml/2006/main">
   <p:cSld>
     <p:spTree>
@@ -3269,7 +3557,7 @@
           <a:p>
             <a:fld id="{F7021451-1387-4CA6-816F-3879F97B5CBC}" type="slidenum">
               <a:rPr lang="en-US"/>
-              <a:t>35</a:t>
+              <a:t>38</a:t>
             </a:fld>
             <a:endParaRPr lang="en-US"/>
           </a:p>
@@ -3288,7 +3576,7 @@
 </p:notes>
 </file>
 
-<file path=ppt/notesSlides/notesSlide36.xml><?xml version="1.0" encoding="utf-8"?>
+<file path=ppt/notesSlides/notesSlide39.xml><?xml version="1.0" encoding="utf-8"?>
 <p:notes xmlns:a="http://schemas.openxmlformats.org/drawingml/2006/main" xmlns:r="http://schemas.openxmlformats.org/officeDocument/2006/relationships" xmlns:p="http://schemas.openxmlformats.org/presentationml/2006/main">
   <p:cSld>
     <p:spTree>
@@ -3364,186 +3652,7 @@
           <a:p>
             <a:fld id="{F7021451-1387-4CA6-816F-3879F97B5CBC}" type="slidenum">
               <a:rPr lang="en-US"/>
-              <a:t>36</a:t>
-            </a:fld>
-            <a:endParaRPr lang="en-US"/>
-          </a:p>
-        </p:txBody>
-      </p:sp>
-    </p:spTree>
-    <p:extLst>
-      <p:ext uri="{BB962C8B-B14F-4D97-AF65-F5344CB8AC3E}">
-        <p14:creationId xmlns:p14="http://schemas.microsoft.com/office/powerpoint/2010/main" val="1024086991"/>
-      </p:ext>
-    </p:extLst>
-  </p:cSld>
-  <p:clrMapOvr>
-    <a:masterClrMapping/>
-  </p:clrMapOvr>
-</p:notes>
-</file>
-
-<file path=ppt/notesSlides/notesSlide37.xml><?xml version="1.0" encoding="utf-8"?>
-<p:notes xmlns:a="http://schemas.openxmlformats.org/drawingml/2006/main" xmlns:r="http://schemas.openxmlformats.org/officeDocument/2006/relationships" xmlns:p="http://schemas.openxmlformats.org/presentationml/2006/main">
-  <p:cSld>
-    <p:spTree>
-      <p:nvGrpSpPr>
-        <p:cNvPr id="1" name=""/>
-        <p:cNvGrpSpPr/>
-        <p:nvPr/>
-      </p:nvGrpSpPr>
-      <p:grpSpPr>
-        <a:xfrm>
-          <a:off x="0" y="0"/>
-          <a:ext cx="0" cy="0"/>
-          <a:chOff x="0" y="0"/>
-          <a:chExt cx="0" cy="0"/>
-        </a:xfrm>
-      </p:grpSpPr>
-      <p:sp>
-        <p:nvSpPr>
-          <p:cNvPr id="2" name="Slide Image Placeholder 1"/>
-          <p:cNvSpPr>
-            <a:spLocks noGrp="1" noRot="1" noChangeAspect="1"/>
-          </p:cNvSpPr>
-          <p:nvPr>
-            <p:ph type="sldImg"/>
-          </p:nvPr>
-        </p:nvSpPr>
-        <p:spPr/>
-      </p:sp>
-      <p:sp>
-        <p:nvSpPr>
-          <p:cNvPr id="3" name="Notes Placeholder 2"/>
-          <p:cNvSpPr>
-            <a:spLocks noGrp="1"/>
-          </p:cNvSpPr>
-          <p:nvPr>
-            <p:ph type="body" idx="1"/>
-          </p:nvPr>
-        </p:nvSpPr>
-        <p:spPr/>
-        <p:txBody>
-          <a:bodyPr/>
-          <a:lstStyle/>
-          <a:p>
-            <a:r>
-              <a:rPr lang="en-US" dirty="0"/>
-              <a:t>Stop talking. Staff circulate from here. Leave the deck up so students can page
-back through it themselves.
-This is the point where you say plainly that nothing is due at the end of
-today. Most of them will still expect a checkoff.</a:t>
-            </a:r>
-            <a:endParaRPr lang="en-US" dirty="0"/>
-          </a:p>
-        </p:txBody>
-      </p:sp>
-      <p:sp>
-        <p:nvSpPr>
-          <p:cNvPr id="4" name="Slide Number Placeholder 3"/>
-          <p:cNvSpPr>
-            <a:spLocks noGrp="1"/>
-          </p:cNvSpPr>
-          <p:nvPr>
-            <p:ph type="sldNum" sz="quarter" idx="10"/>
-          </p:nvPr>
-        </p:nvSpPr>
-        <p:spPr/>
-        <p:txBody>
-          <a:bodyPr/>
-          <a:lstStyle/>
-          <a:p>
-            <a:fld id="{F7021451-1387-4CA6-816F-3879F97B5CBC}" type="slidenum">
-              <a:rPr lang="en-US"/>
-              <a:t>37</a:t>
-            </a:fld>
-            <a:endParaRPr lang="en-US"/>
-          </a:p>
-        </p:txBody>
-      </p:sp>
-    </p:spTree>
-    <p:extLst>
-      <p:ext uri="{BB962C8B-B14F-4D97-AF65-F5344CB8AC3E}">
-        <p14:creationId xmlns:p14="http://schemas.microsoft.com/office/powerpoint/2010/main" val="1024086991"/>
-      </p:ext>
-    </p:extLst>
-  </p:cSld>
-  <p:clrMapOvr>
-    <a:masterClrMapping/>
-  </p:clrMapOvr>
-</p:notes>
-</file>
-
-<file path=ppt/notesSlides/notesSlide38.xml><?xml version="1.0" encoding="utf-8"?>
-<p:notes xmlns:a="http://schemas.openxmlformats.org/drawingml/2006/main" xmlns:r="http://schemas.openxmlformats.org/officeDocument/2006/relationships" xmlns:p="http://schemas.openxmlformats.org/presentationml/2006/main">
-  <p:cSld>
-    <p:spTree>
-      <p:nvGrpSpPr>
-        <p:cNvPr id="1" name=""/>
-        <p:cNvGrpSpPr/>
-        <p:nvPr/>
-      </p:nvGrpSpPr>
-      <p:grpSpPr>
-        <a:xfrm>
-          <a:off x="0" y="0"/>
-          <a:ext cx="0" cy="0"/>
-          <a:chOff x="0" y="0"/>
-          <a:chExt cx="0" cy="0"/>
-        </a:xfrm>
-      </p:grpSpPr>
-      <p:sp>
-        <p:nvSpPr>
-          <p:cNvPr id="2" name="Slide Image Placeholder 1"/>
-          <p:cNvSpPr>
-            <a:spLocks noGrp="1" noRot="1" noChangeAspect="1"/>
-          </p:cNvSpPr>
-          <p:nvPr>
-            <p:ph type="sldImg"/>
-          </p:nvPr>
-        </p:nvSpPr>
-        <p:spPr/>
-      </p:sp>
-      <p:sp>
-        <p:nvSpPr>
-          <p:cNvPr id="3" name="Notes Placeholder 2"/>
-          <p:cNvSpPr>
-            <a:spLocks noGrp="1"/>
-          </p:cNvSpPr>
-          <p:nvPr>
-            <p:ph type="body" idx="1"/>
-          </p:nvPr>
-        </p:nvSpPr>
-        <p:spPr/>
-        <p:txBody>
-          <a:bodyPr/>
-          <a:lstStyle/>
-          <a:p>
-            <a:r>
-              <a:rPr lang="en-US" dirty="0"/>
-              <a:t/>
-            </a:r>
-            <a:endParaRPr lang="en-US" dirty="0"/>
-          </a:p>
-        </p:txBody>
-      </p:sp>
-      <p:sp>
-        <p:nvSpPr>
-          <p:cNvPr id="4" name="Slide Number Placeholder 3"/>
-          <p:cNvSpPr>
-            <a:spLocks noGrp="1"/>
-          </p:cNvSpPr>
-          <p:nvPr>
-            <p:ph type="sldNum" sz="quarter" idx="10"/>
-          </p:nvPr>
-        </p:nvSpPr>
-        <p:spPr/>
-        <p:txBody>
-          <a:bodyPr/>
-          <a:lstStyle/>
-          <a:p>
-            <a:fld id="{F7021451-1387-4CA6-816F-3879F97B5CBC}" type="slidenum">
-              <a:rPr lang="en-US"/>
-              <a:t>38</a:t>
+              <a:t>39</a:t>
             </a:fld>
             <a:endParaRPr lang="en-US"/>
           </a:p>
@@ -3640,6 +3749,185 @@
             <a:fld id="{F7021451-1387-4CA6-816F-3879F97B5CBC}" type="slidenum">
               <a:rPr lang="en-US"/>
               <a:t>4</a:t>
+            </a:fld>
+            <a:endParaRPr lang="en-US"/>
+          </a:p>
+        </p:txBody>
+      </p:sp>
+    </p:spTree>
+    <p:extLst>
+      <p:ext uri="{BB962C8B-B14F-4D97-AF65-F5344CB8AC3E}">
+        <p14:creationId xmlns:p14="http://schemas.microsoft.com/office/powerpoint/2010/main" val="1024086991"/>
+      </p:ext>
+    </p:extLst>
+  </p:cSld>
+  <p:clrMapOvr>
+    <a:masterClrMapping/>
+  </p:clrMapOvr>
+</p:notes>
+</file>
+
+<file path=ppt/notesSlides/notesSlide40.xml><?xml version="1.0" encoding="utf-8"?>
+<p:notes xmlns:a="http://schemas.openxmlformats.org/drawingml/2006/main" xmlns:r="http://schemas.openxmlformats.org/officeDocument/2006/relationships" xmlns:p="http://schemas.openxmlformats.org/presentationml/2006/main">
+  <p:cSld>
+    <p:spTree>
+      <p:nvGrpSpPr>
+        <p:cNvPr id="1" name=""/>
+        <p:cNvGrpSpPr/>
+        <p:nvPr/>
+      </p:nvGrpSpPr>
+      <p:grpSpPr>
+        <a:xfrm>
+          <a:off x="0" y="0"/>
+          <a:ext cx="0" cy="0"/>
+          <a:chOff x="0" y="0"/>
+          <a:chExt cx="0" cy="0"/>
+        </a:xfrm>
+      </p:grpSpPr>
+      <p:sp>
+        <p:nvSpPr>
+          <p:cNvPr id="2" name="Slide Image Placeholder 1"/>
+          <p:cNvSpPr>
+            <a:spLocks noGrp="1" noRot="1" noChangeAspect="1"/>
+          </p:cNvSpPr>
+          <p:nvPr>
+            <p:ph type="sldImg"/>
+          </p:nvPr>
+        </p:nvSpPr>
+        <p:spPr/>
+      </p:sp>
+      <p:sp>
+        <p:nvSpPr>
+          <p:cNvPr id="3" name="Notes Placeholder 2"/>
+          <p:cNvSpPr>
+            <a:spLocks noGrp="1"/>
+          </p:cNvSpPr>
+          <p:nvPr>
+            <p:ph type="body" idx="1"/>
+          </p:nvPr>
+        </p:nvSpPr>
+        <p:spPr/>
+        <p:txBody>
+          <a:bodyPr/>
+          <a:lstStyle/>
+          <a:p>
+            <a:r>
+              <a:rPr lang="en-US" dirty="0"/>
+              <a:t>Stop talking. Staff circulate from here. Leave the deck up so students can page
+back through it themselves.
+This is the point where you say plainly that nothing is due at the end of
+today. Most of them will still expect a checkoff.</a:t>
+            </a:r>
+            <a:endParaRPr lang="en-US" dirty="0"/>
+          </a:p>
+        </p:txBody>
+      </p:sp>
+      <p:sp>
+        <p:nvSpPr>
+          <p:cNvPr id="4" name="Slide Number Placeholder 3"/>
+          <p:cNvSpPr>
+            <a:spLocks noGrp="1"/>
+          </p:cNvSpPr>
+          <p:nvPr>
+            <p:ph type="sldNum" sz="quarter" idx="10"/>
+          </p:nvPr>
+        </p:nvSpPr>
+        <p:spPr/>
+        <p:txBody>
+          <a:bodyPr/>
+          <a:lstStyle/>
+          <a:p>
+            <a:fld id="{F7021451-1387-4CA6-816F-3879F97B5CBC}" type="slidenum">
+              <a:rPr lang="en-US"/>
+              <a:t>40</a:t>
+            </a:fld>
+            <a:endParaRPr lang="en-US"/>
+          </a:p>
+        </p:txBody>
+      </p:sp>
+    </p:spTree>
+    <p:extLst>
+      <p:ext uri="{BB962C8B-B14F-4D97-AF65-F5344CB8AC3E}">
+        <p14:creationId xmlns:p14="http://schemas.microsoft.com/office/powerpoint/2010/main" val="1024086991"/>
+      </p:ext>
+    </p:extLst>
+  </p:cSld>
+  <p:clrMapOvr>
+    <a:masterClrMapping/>
+  </p:clrMapOvr>
+</p:notes>
+</file>
+
+<file path=ppt/notesSlides/notesSlide41.xml><?xml version="1.0" encoding="utf-8"?>
+<p:notes xmlns:a="http://schemas.openxmlformats.org/drawingml/2006/main" xmlns:r="http://schemas.openxmlformats.org/officeDocument/2006/relationships" xmlns:p="http://schemas.openxmlformats.org/presentationml/2006/main">
+  <p:cSld>
+    <p:spTree>
+      <p:nvGrpSpPr>
+        <p:cNvPr id="1" name=""/>
+        <p:cNvGrpSpPr/>
+        <p:nvPr/>
+      </p:nvGrpSpPr>
+      <p:grpSpPr>
+        <a:xfrm>
+          <a:off x="0" y="0"/>
+          <a:ext cx="0" cy="0"/>
+          <a:chOff x="0" y="0"/>
+          <a:chExt cx="0" cy="0"/>
+        </a:xfrm>
+      </p:grpSpPr>
+      <p:sp>
+        <p:nvSpPr>
+          <p:cNvPr id="2" name="Slide Image Placeholder 1"/>
+          <p:cNvSpPr>
+            <a:spLocks noGrp="1" noRot="1" noChangeAspect="1"/>
+          </p:cNvSpPr>
+          <p:nvPr>
+            <p:ph type="sldImg"/>
+          </p:nvPr>
+        </p:nvSpPr>
+        <p:spPr/>
+      </p:sp>
+      <p:sp>
+        <p:nvSpPr>
+          <p:cNvPr id="3" name="Notes Placeholder 2"/>
+          <p:cNvSpPr>
+            <a:spLocks noGrp="1"/>
+          </p:cNvSpPr>
+          <p:nvPr>
+            <p:ph type="body" idx="1"/>
+          </p:nvPr>
+        </p:nvSpPr>
+        <p:spPr/>
+        <p:txBody>
+          <a:bodyPr/>
+          <a:lstStyle/>
+          <a:p>
+            <a:r>
+              <a:rPr lang="en-US" dirty="0"/>
+              <a:t/>
+            </a:r>
+            <a:endParaRPr lang="en-US" dirty="0"/>
+          </a:p>
+        </p:txBody>
+      </p:sp>
+      <p:sp>
+        <p:nvSpPr>
+          <p:cNvPr id="4" name="Slide Number Placeholder 3"/>
+          <p:cNvSpPr>
+            <a:spLocks noGrp="1"/>
+          </p:cNvSpPr>
+          <p:nvPr>
+            <p:ph type="sldNum" sz="quarter" idx="10"/>
+          </p:nvPr>
+        </p:nvSpPr>
+        <p:spPr/>
+        <p:txBody>
+          <a:bodyPr/>
+          <a:lstStyle/>
+          <a:p>
+            <a:fld id="{F7021451-1387-4CA6-816F-3879F97B5CBC}" type="slidenum">
+              <a:rPr lang="en-US"/>
+              <a:t>41</a:t>
             </a:fld>
             <a:endParaRPr lang="en-US"/>
           </a:p>
@@ -5675,9 +5963,126 @@
 </p:sld>
 </file>
 
+<file path=ppt/slides/slide39.xml><?xml version="1.0" encoding="utf-8"?>
+<p:sld xmlns:a="http://schemas.openxmlformats.org/drawingml/2006/main" xmlns:r="http://schemas.openxmlformats.org/officeDocument/2006/relationships" xmlns:p="http://schemas.openxmlformats.org/presentationml/2006/main">
+  <p:cSld name="Slide 39">
+    <p:bg>
+      <p:bgPr>
+        <a:blipFill dpi="0" rotWithShape="1">
+          <a:blip r:embed="rId1">
+            <a:lum/>
+          </a:blip>
+          <a:srcRect/>
+          <a:stretch>
+            <a:fillRect/>
+          </a:stretch>
+        </a:blipFill>
+        <a:effectLst/>
+      </p:bgPr>
+    </p:bg>
+    <p:spTree>
+      <p:nvGrpSpPr>
+        <p:cNvPr id="1" name=""/>
+        <p:cNvGrpSpPr/>
+        <p:nvPr/>
+      </p:nvGrpSpPr>
+      <p:grpSpPr>
+        <a:xfrm>
+          <a:off x="0" y="0"/>
+          <a:ext cx="0" cy="0"/>
+          <a:chOff x="0" y="0"/>
+          <a:chExt cx="0" cy="0"/>
+        </a:xfrm>
+      </p:grpSpPr>
+    </p:spTree>
+  </p:cSld>
+  <p:clrMapOvr>
+    <a:masterClrMapping/>
+  </p:clrMapOvr>
+</p:sld>
+</file>
+
 <file path=ppt/slides/slide4.xml><?xml version="1.0" encoding="utf-8"?>
 <p:sld xmlns:a="http://schemas.openxmlformats.org/drawingml/2006/main" xmlns:r="http://schemas.openxmlformats.org/officeDocument/2006/relationships" xmlns:p="http://schemas.openxmlformats.org/presentationml/2006/main">
   <p:cSld name="Slide 4">
+    <p:bg>
+      <p:bgPr>
+        <a:blipFill dpi="0" rotWithShape="1">
+          <a:blip r:embed="rId1">
+            <a:lum/>
+          </a:blip>
+          <a:srcRect/>
+          <a:stretch>
+            <a:fillRect/>
+          </a:stretch>
+        </a:blipFill>
+        <a:effectLst/>
+      </p:bgPr>
+    </p:bg>
+    <p:spTree>
+      <p:nvGrpSpPr>
+        <p:cNvPr id="1" name=""/>
+        <p:cNvGrpSpPr/>
+        <p:nvPr/>
+      </p:nvGrpSpPr>
+      <p:grpSpPr>
+        <a:xfrm>
+          <a:off x="0" y="0"/>
+          <a:ext cx="0" cy="0"/>
+          <a:chOff x="0" y="0"/>
+          <a:chExt cx="0" cy="0"/>
+        </a:xfrm>
+      </p:grpSpPr>
+    </p:spTree>
+  </p:cSld>
+  <p:clrMapOvr>
+    <a:masterClrMapping/>
+  </p:clrMapOvr>
+</p:sld>
+</file>
+
+<file path=ppt/slides/slide40.xml><?xml version="1.0" encoding="utf-8"?>
+<p:sld xmlns:a="http://schemas.openxmlformats.org/drawingml/2006/main" xmlns:r="http://schemas.openxmlformats.org/officeDocument/2006/relationships" xmlns:p="http://schemas.openxmlformats.org/presentationml/2006/main">
+  <p:cSld name="Slide 40">
+    <p:bg>
+      <p:bgPr>
+        <a:blipFill dpi="0" rotWithShape="1">
+          <a:blip r:embed="rId1">
+            <a:lum/>
+          </a:blip>
+          <a:srcRect/>
+          <a:stretch>
+            <a:fillRect/>
+          </a:stretch>
+        </a:blipFill>
+        <a:effectLst/>
+      </p:bgPr>
+    </p:bg>
+    <p:spTree>
+      <p:nvGrpSpPr>
+        <p:cNvPr id="1" name=""/>
+        <p:cNvGrpSpPr/>
+        <p:nvPr/>
+      </p:nvGrpSpPr>
+      <p:grpSpPr>
+        <a:xfrm>
+          <a:off x="0" y="0"/>
+          <a:ext cx="0" cy="0"/>
+          <a:chOff x="0" y="0"/>
+          <a:chExt cx="0" cy="0"/>
+        </a:xfrm>
+      </p:grpSpPr>
+    </p:spTree>
+  </p:cSld>
+  <p:clrMapOvr>
+    <a:masterClrMapping/>
+  </p:clrMapOvr>
+</p:sld>
+</file>
+
+<file path=ppt/slides/slide41.xml><?xml version="1.0" encoding="utf-8"?>
+<p:sld xmlns:a="http://schemas.openxmlformats.org/drawingml/2006/main" xmlns:r="http://schemas.openxmlformats.org/officeDocument/2006/relationships" xmlns:p="http://schemas.openxmlformats.org/presentationml/2006/main">
+  <p:cSld name="Slide 41">
     <p:bg>
       <p:bgPr>
         <a:blipFill dpi="0" rotWithShape="1">

</xml_diff>

<commit_message>
Lab01: republish at 44 slides, the deck the room gets today
The published copy was four slides behind the term repo on the morning Lab01
delivers. Students pulling it today would have read a different deck from the
one in the room.

Unpublished since the last republish: the caching slide cut, "The part you own"
cut, the closing section retitled as the combination it is, and the two closing
sections merged into one arc.

Exports verified against the source before shipping rather than trusting
timestamps: the PPTX carries 44 pages against 44 expected click steps. Term
repo and materials are byte-identical for all three files, which is the
equality /audit checks. Only the three public files ship; README.md stays in
the term repo.

Claude-Session: https://claude.ai/code/session_01QALchBYHfjmrqAeXPjxTh7
</commit_message>
<xml_diff>
--- a/labs/Lab01/slides.pptx
+++ b/labs/Lab01/slides.pptx
@@ -46,9 +46,12 @@
     <p:sldId id="294" r:id="rId40"/>
     <p:sldId id="295" r:id="rId41"/>
     <p:sldId id="296" r:id="rId42"/>
+    <p:sldId id="297" r:id="rId43"/>
+    <p:sldId id="298" r:id="rId44"/>
+    <p:sldId id="299" r:id="rId45"/>
   </p:sldIdLst>
   <p:notesMasterIdLst>
-    <p:notesMasterId r:id="rId43"/>
+    <p:notesMasterId r:id="rId46"/>
   </p:notesMasterIdLst>
   <p:sldSz cx="9334500" cy="5248275"/>
   <p:notesSz cx="5248275" cy="9334500"/>
@@ -635,496 +638,6 @@
           <a:p>
             <a:r>
               <a:rPr lang="en-US" dirty="0"/>
-              <a:t>The one context slide worth keeping, because it is the part L02 and L03 did not
-show. They have seen that the window is finite and they have read /tokens. They
-have not seen it fill up over a session.
-Walk the two bars. Nothing about the early turn is wrong; the later turn is the
-same prompt after the history has grown, and the thing that stops fitting is
-their own message. Everything above it was spent before they typed.
-The map is charged to this same budget, which on a 4B can be a third of the
-window spent describing files the model then cannot see inside. That is why
-aider-practice turns it down, and why the map is out of scope for the build. Say
-so, so nobody spends week 4 on it.
-Then the bold line, which is the whole reason this slide is still here. Ask what
-they would drop first and what has to survive. Their Stage 1 contract keeps the
-system instructions, the current request and the added file contents, and refuses
-an oversized required input instead of silently trimming it. That refusal is a
-design decision they have to write down and test, and the packet does not make it
-for them.</a:t>
-            </a:r>
-            <a:endParaRPr lang="en-US" dirty="0"/>
-          </a:p>
-        </p:txBody>
-      </p:sp>
-      <p:sp>
-        <p:nvSpPr>
-          <p:cNvPr id="4" name="Slide Number Placeholder 3"/>
-          <p:cNvSpPr>
-            <a:spLocks noGrp="1"/>
-          </p:cNvSpPr>
-          <p:nvPr>
-            <p:ph type="sldNum" sz="quarter" idx="10"/>
-          </p:nvPr>
-        </p:nvSpPr>
-        <p:spPr/>
-        <p:txBody>
-          <a:bodyPr/>
-          <a:lstStyle/>
-          <a:p>
-            <a:fld id="{F7021451-1387-4CA6-816F-3879F97B5CBC}" type="slidenum">
-              <a:rPr lang="en-US"/>
-              <a:t>10</a:t>
-            </a:fld>
-            <a:endParaRPr lang="en-US"/>
-          </a:p>
-        </p:txBody>
-      </p:sp>
-    </p:spTree>
-    <p:extLst>
-      <p:ext uri="{BB962C8B-B14F-4D97-AF65-F5344CB8AC3E}">
-        <p14:creationId xmlns:p14="http://schemas.microsoft.com/office/powerpoint/2010/main" val="1024086991"/>
-      </p:ext>
-    </p:extLst>
-  </p:cSld>
-  <p:clrMapOvr>
-    <a:masterClrMapping/>
-  </p:clrMapOvr>
-</p:notes>
-</file>
-
-<file path=ppt/notesSlides/notesSlide11.xml><?xml version="1.0" encoding="utf-8"?>
-<p:notes xmlns:a="http://schemas.openxmlformats.org/drawingml/2006/main" xmlns:r="http://schemas.openxmlformats.org/officeDocument/2006/relationships" xmlns:p="http://schemas.openxmlformats.org/presentationml/2006/main">
-  <p:cSld>
-    <p:spTree>
-      <p:nvGrpSpPr>
-        <p:cNvPr id="1" name=""/>
-        <p:cNvGrpSpPr/>
-        <p:nvPr/>
-      </p:nvGrpSpPr>
-      <p:grpSpPr>
-        <a:xfrm>
-          <a:off x="0" y="0"/>
-          <a:ext cx="0" cy="0"/>
-          <a:chOff x="0" y="0"/>
-          <a:chExt cx="0" cy="0"/>
-        </a:xfrm>
-      </p:grpSpPr>
-      <p:sp>
-        <p:nvSpPr>
-          <p:cNvPr id="2" name="Slide Image Placeholder 1"/>
-          <p:cNvSpPr>
-            <a:spLocks noGrp="1" noRot="1" noChangeAspect="1"/>
-          </p:cNvSpPr>
-          <p:nvPr>
-            <p:ph type="sldImg"/>
-          </p:nvPr>
-        </p:nvSpPr>
-        <p:spPr/>
-      </p:sp>
-      <p:sp>
-        <p:nvSpPr>
-          <p:cNvPr id="3" name="Notes Placeholder 2"/>
-          <p:cNvSpPr>
-            <a:spLocks noGrp="1"/>
-          </p:cNvSpPr>
-          <p:nvPr>
-            <p:ph type="body" idx="1"/>
-          </p:nvPr>
-        </p:nvSpPr>
-        <p:spPr/>
-        <p:txBody>
-          <a:bodyPr/>
-          <a:lstStyle/>
-          <a:p>
-            <a:r>
-              <a:rPr lang="en-US" dirty="0"/>
-              <a:t>Simplified 2026-09-13 on instructor note: this section was three slides and read
-as confusing, because two of them argued the same point from different angles.
-Two slides now, and they argue in a line: here is the order, here is why that
-order was chosen.
-Open with the one sentence everything else follows from. The model keeps nothing
-between turns. Turn twelve sends everything turn one sent, plus more. That is not
-a limitation to work around, it is the condition their own build runs under.</a:t>
-            </a:r>
-            <a:endParaRPr lang="en-US" dirty="0"/>
-          </a:p>
-        </p:txBody>
-      </p:sp>
-      <p:sp>
-        <p:nvSpPr>
-          <p:cNvPr id="4" name="Slide Number Placeholder 3"/>
-          <p:cNvSpPr>
-            <a:spLocks noGrp="1"/>
-          </p:cNvSpPr>
-          <p:nvPr>
-            <p:ph type="sldNum" sz="quarter" idx="10"/>
-          </p:nvPr>
-        </p:nvSpPr>
-        <p:spPr/>
-        <p:txBody>
-          <a:bodyPr/>
-          <a:lstStyle/>
-          <a:p>
-            <a:fld id="{F7021451-1387-4CA6-816F-3879F97B5CBC}" type="slidenum">
-              <a:rPr lang="en-US"/>
-              <a:t>11</a:t>
-            </a:fld>
-            <a:endParaRPr lang="en-US"/>
-          </a:p>
-        </p:txBody>
-      </p:sp>
-    </p:spTree>
-    <p:extLst>
-      <p:ext uri="{BB962C8B-B14F-4D97-AF65-F5344CB8AC3E}">
-        <p14:creationId xmlns:p14="http://schemas.microsoft.com/office/powerpoint/2010/main" val="1024086991"/>
-      </p:ext>
-    </p:extLst>
-  </p:cSld>
-  <p:clrMapOvr>
-    <a:masterClrMapping/>
-  </p:clrMapOvr>
-</p:notes>
-</file>
-
-<file path=ppt/notesSlides/notesSlide12.xml><?xml version="1.0" encoding="utf-8"?>
-<p:notes xmlns:a="http://schemas.openxmlformats.org/drawingml/2006/main" xmlns:r="http://schemas.openxmlformats.org/officeDocument/2006/relationships" xmlns:p="http://schemas.openxmlformats.org/presentationml/2006/main">
-  <p:cSld>
-    <p:spTree>
-      <p:nvGrpSpPr>
-        <p:cNvPr id="1" name=""/>
-        <p:cNvGrpSpPr/>
-        <p:nvPr/>
-      </p:nvGrpSpPr>
-      <p:grpSpPr>
-        <a:xfrm>
-          <a:off x="0" y="0"/>
-          <a:ext cx="0" cy="0"/>
-          <a:chOff x="0" y="0"/>
-          <a:chExt cx="0" cy="0"/>
-        </a:xfrm>
-      </p:grpSpPr>
-      <p:sp>
-        <p:nvSpPr>
-          <p:cNvPr id="2" name="Slide Image Placeholder 1"/>
-          <p:cNvSpPr>
-            <a:spLocks noGrp="1" noRot="1" noChangeAspect="1"/>
-          </p:cNvSpPr>
-          <p:nvPr>
-            <p:ph type="sldImg"/>
-          </p:nvPr>
-        </p:nvSpPr>
-        <p:spPr/>
-      </p:sp>
-      <p:sp>
-        <p:nvSpPr>
-          <p:cNvPr id="3" name="Notes Placeholder 2"/>
-          <p:cNvSpPr>
-            <a:spLocks noGrp="1"/>
-          </p:cNvSpPr>
-          <p:nvPr>
-            <p:ph type="body" idx="1"/>
-          </p:nvPr>
-        </p:nvSpPr>
-        <p:spPr/>
-        <p:txBody>
-          <a:bodyPr/>
-          <a:lstStyle/>
-          <a:p>
-            <a:r>
-              <a:rPr lang="en-US" dirty="0"/>
-              <a:t>Three groups rather than a list of seven parts, because the grouping is the point
-and the exact ordinal of each part is not.
-Work the bold line rather than the table. The parts that change every turn were
-deliberately put last. The next slide says what that buys, so put the ordering up
-first and let someone in the room guess why before you explain it.
-Their build assembles this same thing, and the packet asks them to say what goes
-in it and in what order. This slide is the argument that the answer is a design
-decision rather than a detail.</a:t>
-            </a:r>
-            <a:endParaRPr lang="en-US" dirty="0"/>
-          </a:p>
-        </p:txBody>
-      </p:sp>
-      <p:sp>
-        <p:nvSpPr>
-          <p:cNvPr id="4" name="Slide Number Placeholder 3"/>
-          <p:cNvSpPr>
-            <a:spLocks noGrp="1"/>
-          </p:cNvSpPr>
-          <p:nvPr>
-            <p:ph type="sldNum" sz="quarter" idx="10"/>
-          </p:nvPr>
-        </p:nvSpPr>
-        <p:spPr/>
-        <p:txBody>
-          <a:bodyPr/>
-          <a:lstStyle/>
-          <a:p>
-            <a:fld id="{F7021451-1387-4CA6-816F-3879F97B5CBC}" type="slidenum">
-              <a:rPr lang="en-US"/>
-              <a:t>12</a:t>
-            </a:fld>
-            <a:endParaRPr lang="en-US"/>
-          </a:p>
-        </p:txBody>
-      </p:sp>
-    </p:spTree>
-    <p:extLst>
-      <p:ext uri="{BB962C8B-B14F-4D97-AF65-F5344CB8AC3E}">
-        <p14:creationId xmlns:p14="http://schemas.microsoft.com/office/powerpoint/2010/main" val="1024086991"/>
-      </p:ext>
-    </p:extLst>
-  </p:cSld>
-  <p:clrMapOvr>
-    <a:masterClrMapping/>
-  </p:clrMapOvr>
-</p:notes>
-</file>
-
-<file path=ppt/notesSlides/notesSlide13.xml><?xml version="1.0" encoding="utf-8"?>
-<p:notes xmlns:a="http://schemas.openxmlformats.org/drawingml/2006/main" xmlns:r="http://schemas.openxmlformats.org/officeDocument/2006/relationships" xmlns:p="http://schemas.openxmlformats.org/presentationml/2006/main">
-  <p:cSld>
-    <p:spTree>
-      <p:nvGrpSpPr>
-        <p:cNvPr id="1" name=""/>
-        <p:cNvGrpSpPr/>
-        <p:nvPr/>
-      </p:nvGrpSpPr>
-      <p:grpSpPr>
-        <a:xfrm>
-          <a:off x="0" y="0"/>
-          <a:ext cx="0" cy="0"/>
-          <a:chOff x="0" y="0"/>
-          <a:chExt cx="0" cy="0"/>
-        </a:xfrm>
-      </p:grpSpPr>
-      <p:sp>
-        <p:nvSpPr>
-          <p:cNvPr id="2" name="Slide Image Placeholder 1"/>
-          <p:cNvSpPr>
-            <a:spLocks noGrp="1" noRot="1" noChangeAspect="1"/>
-          </p:cNvSpPr>
-          <p:nvPr>
-            <p:ph type="sldImg"/>
-          </p:nvPr>
-        </p:nvSpPr>
-        <p:spPr/>
-      </p:sp>
-      <p:sp>
-        <p:nvSpPr>
-          <p:cNvPr id="3" name="Notes Placeholder 2"/>
-          <p:cNvSpPr>
-            <a:spLocks noGrp="1"/>
-          </p:cNvSpPr>
-          <p:nvPr>
-            <p:ph type="body" idx="1"/>
-          </p:nvPr>
-        </p:nvSpPr>
-        <p:spPr/>
-        <p:txBody>
-          <a:bodyPr/>
-          <a:lstStyle/>
-          <a:p>
-            <a:r>
-              <a:rPr lang="en-US" dirty="0"/>
-              <a:t>Table first, then the three bullets: here is the rule, here is what trips it.
-The rule is not the model remembering. Nothing is remembered between sessions.
-It is the serving layer recognising text it has already processed and picking up
-where it left off, and it holds on the course endpoint as much as on a hosted
-API. A hosted API marks the reuse points explicitly and a local server reuses the
-longest opening it recognises; the rule is identical either way.
-Then the three bullets, all verified in the source, and the third is the one
-nobody guesses. Ask mode is not a smaller code mode: it is a different system
-prompt with the worked examples removed, sitting at the very front, so a quick
-question mid task throws the whole prefix away rather than part of it. Adding a
-file changes both the file block and the map, because files in the chat come out
-of the map. And by default the map is rebuilt from the filenames found in the
-message just typed, so mentioning a file in passing moves it.
-The habit worth giving them: settle the file set before starting, and keep a
-question in its own session. The design lesson worth more: what they put first in
-their own prompt decides what a turn costs.
-If they want dollar figures, quote the provider's current pricing page rather
-than a number from memory. What they will feel on their own machine is the wait
-before the first token, not money.</a:t>
-            </a:r>
-            <a:endParaRPr lang="en-US" dirty="0"/>
-          </a:p>
-        </p:txBody>
-      </p:sp>
-      <p:sp>
-        <p:nvSpPr>
-          <p:cNvPr id="4" name="Slide Number Placeholder 3"/>
-          <p:cNvSpPr>
-            <a:spLocks noGrp="1"/>
-          </p:cNvSpPr>
-          <p:nvPr>
-            <p:ph type="sldNum" sz="quarter" idx="10"/>
-          </p:nvPr>
-        </p:nvSpPr>
-        <p:spPr/>
-        <p:txBody>
-          <a:bodyPr/>
-          <a:lstStyle/>
-          <a:p>
-            <a:fld id="{F7021451-1387-4CA6-816F-3879F97B5CBC}" type="slidenum">
-              <a:rPr lang="en-US"/>
-              <a:t>13</a:t>
-            </a:fld>
-            <a:endParaRPr lang="en-US"/>
-          </a:p>
-        </p:txBody>
-      </p:sp>
-    </p:spTree>
-    <p:extLst>
-      <p:ext uri="{BB962C8B-B14F-4D97-AF65-F5344CB8AC3E}">
-        <p14:creationId xmlns:p14="http://schemas.microsoft.com/office/powerpoint/2010/main" val="1024086991"/>
-      </p:ext>
-    </p:extLst>
-  </p:cSld>
-  <p:clrMapOvr>
-    <a:masterClrMapping/>
-  </p:clrMapOvr>
-</p:notes>
-</file>
-
-<file path=ppt/notesSlides/notesSlide14.xml><?xml version="1.0" encoding="utf-8"?>
-<p:notes xmlns:a="http://schemas.openxmlformats.org/drawingml/2006/main" xmlns:r="http://schemas.openxmlformats.org/officeDocument/2006/relationships" xmlns:p="http://schemas.openxmlformats.org/presentationml/2006/main">
-  <p:cSld>
-    <p:spTree>
-      <p:nvGrpSpPr>
-        <p:cNvPr id="1" name=""/>
-        <p:cNvGrpSpPr/>
-        <p:nvPr/>
-      </p:nvGrpSpPr>
-      <p:grpSpPr>
-        <a:xfrm>
-          <a:off x="0" y="0"/>
-          <a:ext cx="0" cy="0"/>
-          <a:chOff x="0" y="0"/>
-          <a:chExt cx="0" cy="0"/>
-        </a:xfrm>
-      </p:grpSpPr>
-      <p:sp>
-        <p:nvSpPr>
-          <p:cNvPr id="2" name="Slide Image Placeholder 1"/>
-          <p:cNvSpPr>
-            <a:spLocks noGrp="1" noRot="1" noChangeAspect="1"/>
-          </p:cNvSpPr>
-          <p:nvPr>
-            <p:ph type="sldImg"/>
-          </p:nvPr>
-        </p:nvSpPr>
-        <p:spPr/>
-      </p:sp>
-      <p:sp>
-        <p:nvSpPr>
-          <p:cNvPr id="3" name="Notes Placeholder 2"/>
-          <p:cNvSpPr>
-            <a:spLocks noGrp="1"/>
-          </p:cNvSpPr>
-          <p:nvPr>
-            <p:ph type="body" idx="1"/>
-          </p:nvPr>
-        </p:nvSpPr>
-        <p:spPr/>
-        <p:txBody>
-          <a:bodyPr/>
-          <a:lstStyle/>
-          <a:p>
-            <a:r>
-              <a:rPr lang="en-US" dirty="0"/>
-              <a:t>Ask what a block like this does not tell you. It names one file. A change that
-needs three files needs three blocks, and nothing in the format obliges the
-model to produce all three. A student who reads one well-formed block sees a
-finished feature.
-Nothing has changed on disk yet. This is a proposal in a chat reply.</a:t>
-            </a:r>
-            <a:endParaRPr lang="en-US" dirty="0"/>
-          </a:p>
-        </p:txBody>
-      </p:sp>
-      <p:sp>
-        <p:nvSpPr>
-          <p:cNvPr id="4" name="Slide Number Placeholder 3"/>
-          <p:cNvSpPr>
-            <a:spLocks noGrp="1"/>
-          </p:cNvSpPr>
-          <p:nvPr>
-            <p:ph type="sldNum" sz="quarter" idx="10"/>
-          </p:nvPr>
-        </p:nvSpPr>
-        <p:spPr/>
-        <p:txBody>
-          <a:bodyPr/>
-          <a:lstStyle/>
-          <a:p>
-            <a:fld id="{F7021451-1387-4CA6-816F-3879F97B5CBC}" type="slidenum">
-              <a:rPr lang="en-US"/>
-              <a:t>14</a:t>
-            </a:fld>
-            <a:endParaRPr lang="en-US"/>
-          </a:p>
-        </p:txBody>
-      </p:sp>
-    </p:spTree>
-    <p:extLst>
-      <p:ext uri="{BB962C8B-B14F-4D97-AF65-F5344CB8AC3E}">
-        <p14:creationId xmlns:p14="http://schemas.microsoft.com/office/powerpoint/2010/main" val="1024086991"/>
-      </p:ext>
-    </p:extLst>
-  </p:cSld>
-  <p:clrMapOvr>
-    <a:masterClrMapping/>
-  </p:clrMapOvr>
-</p:notes>
-</file>
-
-<file path=ppt/notesSlides/notesSlide15.xml><?xml version="1.0" encoding="utf-8"?>
-<p:notes xmlns:a="http://schemas.openxmlformats.org/drawingml/2006/main" xmlns:r="http://schemas.openxmlformats.org/officeDocument/2006/relationships" xmlns:p="http://schemas.openxmlformats.org/presentationml/2006/main">
-  <p:cSld>
-    <p:spTree>
-      <p:nvGrpSpPr>
-        <p:cNvPr id="1" name=""/>
-        <p:cNvGrpSpPr/>
-        <p:nvPr/>
-      </p:nvGrpSpPr>
-      <p:grpSpPr>
-        <a:xfrm>
-          <a:off x="0" y="0"/>
-          <a:ext cx="0" cy="0"/>
-          <a:chOff x="0" y="0"/>
-          <a:chExt cx="0" cy="0"/>
-        </a:xfrm>
-      </p:grpSpPr>
-      <p:sp>
-        <p:nvSpPr>
-          <p:cNvPr id="2" name="Slide Image Placeholder 1"/>
-          <p:cNvSpPr>
-            <a:spLocks noGrp="1" noRot="1" noChangeAspect="1"/>
-          </p:cNvSpPr>
-          <p:nvPr>
-            <p:ph type="sldImg"/>
-          </p:nvPr>
-        </p:nvSpPr>
-        <p:spPr/>
-      </p:sp>
-      <p:sp>
-        <p:nvSpPr>
-          <p:cNvPr id="3" name="Notes Placeholder 2"/>
-          <p:cNvSpPr>
-            <a:spLocks noGrp="1"/>
-          </p:cNvSpPr>
-          <p:nvPr>
-            <p:ph type="body" idx="1"/>
-          </p:nvPr>
-        </p:nvSpPr>
-        <p:spPr/>
-        <p:txBody>
-          <a:bodyPr/>
-          <a:lstStyle/>
-          <a:p>
-            <a:r>
-              <a:rPr lang="en-US" dirty="0"/>
               <a:t>Step back from the format for a moment. Whatever the model is asked to produce,
 it is producing text, and the harness has to recover a machine-actionable
 instruction from it. Search and replace blocks are one encoding of that. Function
@@ -1156,7 +669,7 @@
           <a:p>
             <a:fld id="{F7021451-1387-4CA6-816F-3879F97B5CBC}" type="slidenum">
               <a:rPr lang="en-US"/>
-              <a:t>15</a:t>
+              <a:t>10</a:t>
             </a:fld>
             <a:endParaRPr lang="en-US"/>
           </a:p>
@@ -1175,7 +688,1303 @@
 </p:notes>
 </file>
 
+<file path=ppt/notesSlides/notesSlide11.xml><?xml version="1.0" encoding="utf-8"?>
+<p:notes xmlns:a="http://schemas.openxmlformats.org/drawingml/2006/main" xmlns:r="http://schemas.openxmlformats.org/officeDocument/2006/relationships" xmlns:p="http://schemas.openxmlformats.org/presentationml/2006/main">
+  <p:cSld>
+    <p:spTree>
+      <p:nvGrpSpPr>
+        <p:cNvPr id="1" name=""/>
+        <p:cNvGrpSpPr/>
+        <p:nvPr/>
+      </p:nvGrpSpPr>
+      <p:grpSpPr>
+        <a:xfrm>
+          <a:off x="0" y="0"/>
+          <a:ext cx="0" cy="0"/>
+          <a:chOff x="0" y="0"/>
+          <a:chExt cx="0" cy="0"/>
+        </a:xfrm>
+      </p:grpSpPr>
+      <p:sp>
+        <p:nvSpPr>
+          <p:cNvPr id="2" name="Slide Image Placeholder 1"/>
+          <p:cNvSpPr>
+            <a:spLocks noGrp="1" noRot="1" noChangeAspect="1"/>
+          </p:cNvSpPr>
+          <p:nvPr>
+            <p:ph type="sldImg"/>
+          </p:nvPr>
+        </p:nvSpPr>
+        <p:spPr/>
+      </p:sp>
+      <p:sp>
+        <p:nvSpPr>
+          <p:cNvPr id="3" name="Notes Placeholder 2"/>
+          <p:cNvSpPr>
+            <a:spLocks noGrp="1"/>
+          </p:cNvSpPr>
+          <p:nvPr>
+            <p:ph type="body" idx="1"/>
+          </p:nvPr>
+        </p:nvSpPr>
+        <p:spPr/>
+        <p:txBody>
+          <a:bodyPr/>
+          <a:lstStyle/>
+          <a:p>
+            <a:r>
+              <a:rPr lang="en-US" dirty="0"/>
+              <a:t>The question under this slide is the one some of them have carried for two
+weeks: why does the tool everyone talks about feel smarter than this one? Same
+kind of model. What it lacks is machinery around the model, and every row here
+is a decision somebody wrote code for.
+Row three is worth a beat. Nothing carries between Aider sessions by default,
+and nothing carries between ChatGPT or Claude Code sessions either. One
+harness keeps notes for you, the other reads notes you keep, and both paste
+them into the prompt. Continuity is always the harness re-sending, which is
+the condition their own build runs under.
+Row four is the one that matters next. Aider does not go looking for files;
+they name them. The next section is about the one place it guesses, and why
+that guess passed for intelligence.
+Do not go past the fourth row. What happens when the model picks its next
+action is tomorrow's lecture, with a live demo, and L05 opens on the question
+this deck leaves open at the end of the taught half.
+Their build lacks all four rows as well, by design. The packet excludes the map
+and does not ask for an editor, completions or memory.</a:t>
+            </a:r>
+            <a:endParaRPr lang="en-US" dirty="0"/>
+          </a:p>
+        </p:txBody>
+      </p:sp>
+      <p:sp>
+        <p:nvSpPr>
+          <p:cNvPr id="4" name="Slide Number Placeholder 3"/>
+          <p:cNvSpPr>
+            <a:spLocks noGrp="1"/>
+          </p:cNvSpPr>
+          <p:nvPr>
+            <p:ph type="sldNum" sz="quarter" idx="10"/>
+          </p:nvPr>
+        </p:nvSpPr>
+        <p:spPr/>
+        <p:txBody>
+          <a:bodyPr/>
+          <a:lstStyle/>
+          <a:p>
+            <a:fld id="{F7021451-1387-4CA6-816F-3879F97B5CBC}" type="slidenum">
+              <a:rPr lang="en-US"/>
+              <a:t>11</a:t>
+            </a:fld>
+            <a:endParaRPr lang="en-US"/>
+          </a:p>
+        </p:txBody>
+      </p:sp>
+    </p:spTree>
+    <p:extLst>
+      <p:ext uri="{BB962C8B-B14F-4D97-AF65-F5344CB8AC3E}">
+        <p14:creationId xmlns:p14="http://schemas.microsoft.com/office/powerpoint/2010/main" val="1024086991"/>
+      </p:ext>
+    </p:extLst>
+  </p:cSld>
+  <p:clrMapOvr>
+    <a:masterClrMapping/>
+  </p:clrMapOvr>
+</p:notes>
+</file>
+
+<file path=ppt/notesSlides/notesSlide12.xml><?xml version="1.0" encoding="utf-8"?>
+<p:notes xmlns:a="http://schemas.openxmlformats.org/drawingml/2006/main" xmlns:r="http://schemas.openxmlformats.org/officeDocument/2006/relationships" xmlns:p="http://schemas.openxmlformats.org/presentationml/2006/main">
+  <p:cSld>
+    <p:spTree>
+      <p:nvGrpSpPr>
+        <p:cNvPr id="1" name=""/>
+        <p:cNvGrpSpPr/>
+        <p:nvPr/>
+      </p:nvGrpSpPr>
+      <p:grpSpPr>
+        <a:xfrm>
+          <a:off x="0" y="0"/>
+          <a:ext cx="0" cy="0"/>
+          <a:chOff x="0" y="0"/>
+          <a:chExt cx="0" cy="0"/>
+        </a:xfrm>
+      </p:grpSpPr>
+      <p:sp>
+        <p:nvSpPr>
+          <p:cNvPr id="2" name="Slide Image Placeholder 1"/>
+          <p:cNvSpPr>
+            <a:spLocks noGrp="1" noRot="1" noChangeAspect="1"/>
+          </p:cNvSpPr>
+          <p:nvPr>
+            <p:ph type="sldImg"/>
+          </p:nvPr>
+        </p:nvSpPr>
+        <p:spPr/>
+      </p:sp>
+      <p:sp>
+        <p:nvSpPr>
+          <p:cNvPr id="3" name="Notes Placeholder 2"/>
+          <p:cNvSpPr>
+            <a:spLocks noGrp="1"/>
+          </p:cNvSpPr>
+          <p:nvPr>
+            <p:ph type="body" idx="1"/>
+          </p:nvPr>
+        </p:nvSpPr>
+        <p:spPr/>
+        <p:txBody>
+          <a:bodyPr/>
+          <a:lstStyle/>
+          <a:p>
+            <a:r>
+              <a:rPr lang="en-US" dirty="0"/>
+              <a:t>Reworked 2026-09-13 on instructor direction. The section used to open on the
+Aider diagram, which belongs to the harness, and the commands slide sat in
+front of the section title and read as a stray. Both are where they belong
+now, and the section reads as one question: for each part of the prompt, who
+chose it, you or the harness.
+L02 and L03 taught the window, the four sources, surgical selection and
+/tokens. Do not re-teach them. The cut here is different: not what is in the
+prompt but who put it there, and then the one part the harness chooses on its
+own, which is the part that passed for intelligence.</a:t>
+            </a:r>
+            <a:endParaRPr lang="en-US" dirty="0"/>
+          </a:p>
+        </p:txBody>
+      </p:sp>
+      <p:sp>
+        <p:nvSpPr>
+          <p:cNvPr id="4" name="Slide Number Placeholder 3"/>
+          <p:cNvSpPr>
+            <a:spLocks noGrp="1"/>
+          </p:cNvSpPr>
+          <p:nvPr>
+            <p:ph type="sldNum" sz="quarter" idx="10"/>
+          </p:nvPr>
+        </p:nvSpPr>
+        <p:spPr/>
+        <p:txBody>
+          <a:bodyPr/>
+          <a:lstStyle/>
+          <a:p>
+            <a:fld id="{F7021451-1387-4CA6-816F-3879F97B5CBC}" type="slidenum">
+              <a:rPr lang="en-US"/>
+              <a:t>12</a:t>
+            </a:fld>
+            <a:endParaRPr lang="en-US"/>
+          </a:p>
+        </p:txBody>
+      </p:sp>
+    </p:spTree>
+    <p:extLst>
+      <p:ext uri="{BB962C8B-B14F-4D97-AF65-F5344CB8AC3E}">
+        <p14:creationId xmlns:p14="http://schemas.microsoft.com/office/powerpoint/2010/main" val="1024086991"/>
+      </p:ext>
+    </p:extLst>
+  </p:cSld>
+  <p:clrMapOvr>
+    <a:masterClrMapping/>
+  </p:clrMapOvr>
+</p:notes>
+</file>
+
+<file path=ppt/notesSlides/notesSlide13.xml><?xml version="1.0" encoding="utf-8"?>
+<p:notes xmlns:a="http://schemas.openxmlformats.org/drawingml/2006/main" xmlns:r="http://schemas.openxmlformats.org/officeDocument/2006/relationships" xmlns:p="http://schemas.openxmlformats.org/presentationml/2006/main">
+  <p:cSld>
+    <p:spTree>
+      <p:nvGrpSpPr>
+        <p:cNvPr id="1" name=""/>
+        <p:cNvGrpSpPr/>
+        <p:nvPr/>
+      </p:nvGrpSpPr>
+      <p:grpSpPr>
+        <a:xfrm>
+          <a:off x="0" y="0"/>
+          <a:ext cx="0" cy="0"/>
+          <a:chOff x="0" y="0"/>
+          <a:chExt cx="0" cy="0"/>
+        </a:xfrm>
+      </p:grpSpPr>
+      <p:sp>
+        <p:nvSpPr>
+          <p:cNvPr id="2" name="Slide Image Placeholder 1"/>
+          <p:cNvSpPr>
+            <a:spLocks noGrp="1" noRot="1" noChangeAspect="1"/>
+          </p:cNvSpPr>
+          <p:nvPr>
+            <p:ph type="sldImg"/>
+          </p:nvPr>
+        </p:nvSpPr>
+        <p:spPr/>
+      </p:sp>
+      <p:sp>
+        <p:nvSpPr>
+          <p:cNvPr id="3" name="Notes Placeholder 2"/>
+          <p:cNvSpPr>
+            <a:spLocks noGrp="1"/>
+          </p:cNvSpPr>
+          <p:nvPr>
+            <p:ph type="body" idx="1"/>
+          </p:nvPr>
+        </p:nvSpPr>
+        <p:spPr/>
+        <p:txBody>
+          <a:bodyPr/>
+          <a:lstStyle/>
+          <a:p>
+            <a:r>
+              <a:rPr lang="en-US" dirty="0"/>
+              <a:t>Same parts L03 listed, cut a different way. Read down the right-hand column
+and sort the rows: yours, Aider's, shared.
+Yours: the files and the message. Aider's: the system prompt, which changes
+when they switch between ask and code, and the map, which they have never
+typed a command for. Shared: the history, which they write one turn at a time
+and Aider summarises with the weak model once it grows past a limit.
+The model has no row, and two slides on says why: in Aider it can only write.
+When it wants a file it can only mention the name, and Aider's regex and your
+yes do the rest.
+The bold line points at the next two slides. Of the two rows Aider owns, the
+system prompt is dull and the map is the one that fooled them.</a:t>
+            </a:r>
+            <a:endParaRPr lang="en-US" dirty="0"/>
+          </a:p>
+        </p:txBody>
+      </p:sp>
+      <p:sp>
+        <p:nvSpPr>
+          <p:cNvPr id="4" name="Slide Number Placeholder 3"/>
+          <p:cNvSpPr>
+            <a:spLocks noGrp="1"/>
+          </p:cNvSpPr>
+          <p:nvPr>
+            <p:ph type="sldNum" sz="quarter" idx="10"/>
+          </p:nvPr>
+        </p:nvSpPr>
+        <p:spPr/>
+        <p:txBody>
+          <a:bodyPr/>
+          <a:lstStyle/>
+          <a:p>
+            <a:fld id="{F7021451-1387-4CA6-816F-3879F97B5CBC}" type="slidenum">
+              <a:rPr lang="en-US"/>
+              <a:t>13</a:t>
+            </a:fld>
+            <a:endParaRPr lang="en-US"/>
+          </a:p>
+        </p:txBody>
+      </p:sp>
+    </p:spTree>
+    <p:extLst>
+      <p:ext uri="{BB962C8B-B14F-4D97-AF65-F5344CB8AC3E}">
+        <p14:creationId xmlns:p14="http://schemas.microsoft.com/office/powerpoint/2010/main" val="1024086991"/>
+      </p:ext>
+    </p:extLst>
+  </p:cSld>
+  <p:clrMapOvr>
+    <a:masterClrMapping/>
+  </p:clrMapOvr>
+</p:notes>
+</file>
+
+<file path=ppt/notesSlides/notesSlide14.xml><?xml version="1.0" encoding="utf-8"?>
+<p:notes xmlns:a="http://schemas.openxmlformats.org/drawingml/2006/main" xmlns:r="http://schemas.openxmlformats.org/officeDocument/2006/relationships" xmlns:p="http://schemas.openxmlformats.org/presentationml/2006/main">
+  <p:cSld>
+    <p:spTree>
+      <p:nvGrpSpPr>
+        <p:cNvPr id="1" name=""/>
+        <p:cNvGrpSpPr/>
+        <p:nvPr/>
+      </p:nvGrpSpPr>
+      <p:grpSpPr>
+        <a:xfrm>
+          <a:off x="0" y="0"/>
+          <a:ext cx="0" cy="0"/>
+          <a:chOff x="0" y="0"/>
+          <a:chExt cx="0" cy="0"/>
+        </a:xfrm>
+      </p:grpSpPr>
+      <p:sp>
+        <p:nvSpPr>
+          <p:cNvPr id="2" name="Slide Image Placeholder 1"/>
+          <p:cNvSpPr>
+            <a:spLocks noGrp="1" noRot="1" noChangeAspect="1"/>
+          </p:cNvSpPr>
+          <p:nvPr>
+            <p:ph type="sldImg"/>
+          </p:nvPr>
+        </p:nvSpPr>
+        <p:spPr/>
+      </p:sp>
+      <p:sp>
+        <p:nvSpPr>
+          <p:cNvPr id="3" name="Notes Placeholder 2"/>
+          <p:cNvSpPr>
+            <a:spLocks noGrp="1"/>
+          </p:cNvSpPr>
+          <p:nvPr>
+            <p:ph type="body" idx="1"/>
+          </p:nvPr>
+        </p:nvSpPr>
+        <p:spPr/>
+        <p:txBody>
+          <a:bodyPr/>
+          <a:lstStyle/>
+          <a:p>
+            <a:r>
+              <a:rPr lang="en-US" dirty="0"/>
+              <a:t>Moved under the context section on 2026-09-13; it used to sit before the
+section title. It is the human's half of the last slide, as commands.
+Two commands in the whole set touch the repository, and one of those is the
+undo. That asymmetry is the approval layer they are about to build, visible in
+a tool they already use. Aider does not ask before it writes; their build must.
+/help lists more than this and the set moves between versions. Run it live if
+asked rather than reciting.</a:t>
+            </a:r>
+            <a:endParaRPr lang="en-US" dirty="0"/>
+          </a:p>
+        </p:txBody>
+      </p:sp>
+      <p:sp>
+        <p:nvSpPr>
+          <p:cNvPr id="4" name="Slide Number Placeholder 3"/>
+          <p:cNvSpPr>
+            <a:spLocks noGrp="1"/>
+          </p:cNvSpPr>
+          <p:nvPr>
+            <p:ph type="sldNum" sz="quarter" idx="10"/>
+          </p:nvPr>
+        </p:nvSpPr>
+        <p:spPr/>
+        <p:txBody>
+          <a:bodyPr/>
+          <a:lstStyle/>
+          <a:p>
+            <a:fld id="{F7021451-1387-4CA6-816F-3879F97B5CBC}" type="slidenum">
+              <a:rPr lang="en-US"/>
+              <a:t>14</a:t>
+            </a:fld>
+            <a:endParaRPr lang="en-US"/>
+          </a:p>
+        </p:txBody>
+      </p:sp>
+    </p:spTree>
+    <p:extLst>
+      <p:ext uri="{BB962C8B-B14F-4D97-AF65-F5344CB8AC3E}">
+        <p14:creationId xmlns:p14="http://schemas.microsoft.com/office/powerpoint/2010/main" val="1024086991"/>
+      </p:ext>
+    </p:extLst>
+  </p:cSld>
+  <p:clrMapOvr>
+    <a:masterClrMapping/>
+  </p:clrMapOvr>
+</p:notes>
+</file>
+
+<file path=ppt/notesSlides/notesSlide15.xml><?xml version="1.0" encoding="utf-8"?>
+<p:notes xmlns:a="http://schemas.openxmlformats.org/drawingml/2006/main" xmlns:r="http://schemas.openxmlformats.org/officeDocument/2006/relationships" xmlns:p="http://schemas.openxmlformats.org/presentationml/2006/main">
+  <p:cSld>
+    <p:spTree>
+      <p:nvGrpSpPr>
+        <p:cNvPr id="1" name=""/>
+        <p:cNvGrpSpPr/>
+        <p:nvPr/>
+      </p:nvGrpSpPr>
+      <p:grpSpPr>
+        <a:xfrm>
+          <a:off x="0" y="0"/>
+          <a:ext cx="0" cy="0"/>
+          <a:chOff x="0" y="0"/>
+          <a:chExt cx="0" cy="0"/>
+        </a:xfrm>
+      </p:grpSpPr>
+      <p:sp>
+        <p:nvSpPr>
+          <p:cNvPr id="2" name="Slide Image Placeholder 1"/>
+          <p:cNvSpPr>
+            <a:spLocks noGrp="1" noRot="1" noChangeAspect="1"/>
+          </p:cNvSpPr>
+          <p:nvPr>
+            <p:ph type="sldImg"/>
+          </p:nvPr>
+        </p:nvSpPr>
+        <p:spPr/>
+      </p:sp>
+      <p:sp>
+        <p:nvSpPr>
+          <p:cNvPr id="3" name="Notes Placeholder 2"/>
+          <p:cNvSpPr>
+            <a:spLocks noGrp="1"/>
+          </p:cNvSpPr>
+          <p:nvPr>
+            <p:ph type="body" idx="1"/>
+          </p:nvPr>
+        </p:nvSpPr>
+        <p:spPr/>
+        <p:txBody>
+          <a:bodyPr/>
+          <a:lstStyle/>
+          <a:p>
+            <a:r>
+              <a:rPr lang="en-US" dirty="0"/>
+              <a:t>Added 2026-09-13, late, on instructor direction: the two tools handle a file
+the model wants in different ways, and the difference is worth a slide.
+Start with the first row. The model in Aider has one verb. Its reply is edit
+blocks, and everything else in the deck, the map, the file mention, the lint
+and test loop, the shell suggestions, is machinery Aider bolts on around it to
+make that one verb land better. None of it is the model deciding anything.
+Row two is the one to say slowly. When Aider's model "asks for a file" it has
+not asked for anything. It wrote a filename in prose, a regex in Aider found
+it, Aider put "Add file to the chat?" on the screen, and a human said yes. The
+model did not decide to read the file. It mentioned a name.
+Claude Code's model does decide: it emits a read call and the harness runs it,
+subject to a permission rule somebody configured. That is a real difference in
+who chooses, and it is the closest this lab gets to tomorrow's question. Stop
+at the file. How the loop continues after a read is L05.
+Row four is the maintenance difference, and the middle section is about it.
+Aider's copy is rebuilt from disk every turn, so it cannot go stale. Claude
+Code's is a snapshot in the history, current until the file changes, and stale
+after that until the model reads it again.</a:t>
+            </a:r>
+            <a:endParaRPr lang="en-US" dirty="0"/>
+          </a:p>
+        </p:txBody>
+      </p:sp>
+      <p:sp>
+        <p:nvSpPr>
+          <p:cNvPr id="4" name="Slide Number Placeholder 3"/>
+          <p:cNvSpPr>
+            <a:spLocks noGrp="1"/>
+          </p:cNvSpPr>
+          <p:nvPr>
+            <p:ph type="sldNum" sz="quarter" idx="10"/>
+          </p:nvPr>
+        </p:nvSpPr>
+        <p:spPr/>
+        <p:txBody>
+          <a:bodyPr/>
+          <a:lstStyle/>
+          <a:p>
+            <a:fld id="{F7021451-1387-4CA6-816F-3879F97B5CBC}" type="slidenum">
+              <a:rPr lang="en-US"/>
+              <a:t>15</a:t>
+            </a:fld>
+            <a:endParaRPr lang="en-US"/>
+          </a:p>
+        </p:txBody>
+      </p:sp>
+    </p:spTree>
+    <p:extLst>
+      <p:ext uri="{BB962C8B-B14F-4D97-AF65-F5344CB8AC3E}">
+        <p14:creationId xmlns:p14="http://schemas.microsoft.com/office/powerpoint/2010/main" val="1024086991"/>
+      </p:ext>
+    </p:extLst>
+  </p:cSld>
+  <p:clrMapOvr>
+    <a:masterClrMapping/>
+  </p:clrMapOvr>
+</p:notes>
+</file>
+
 <file path=ppt/notesSlides/notesSlide16.xml><?xml version="1.0" encoding="utf-8"?>
+<p:notes xmlns:a="http://schemas.openxmlformats.org/drawingml/2006/main" xmlns:r="http://schemas.openxmlformats.org/officeDocument/2006/relationships" xmlns:p="http://schemas.openxmlformats.org/presentationml/2006/main">
+  <p:cSld>
+    <p:spTree>
+      <p:nvGrpSpPr>
+        <p:cNvPr id="1" name=""/>
+        <p:cNvGrpSpPr/>
+        <p:nvPr/>
+      </p:nvGrpSpPr>
+      <p:grpSpPr>
+        <a:xfrm>
+          <a:off x="0" y="0"/>
+          <a:ext cx="0" cy="0"/>
+          <a:chOff x="0" y="0"/>
+          <a:chExt cx="0" cy="0"/>
+        </a:xfrm>
+      </p:grpSpPr>
+      <p:sp>
+        <p:nvSpPr>
+          <p:cNvPr id="2" name="Slide Image Placeholder 1"/>
+          <p:cNvSpPr>
+            <a:spLocks noGrp="1" noRot="1" noChangeAspect="1"/>
+          </p:cNvSpPr>
+          <p:nvPr>
+            <p:ph type="sldImg"/>
+          </p:nvPr>
+        </p:nvSpPr>
+        <p:spPr/>
+      </p:sp>
+      <p:sp>
+        <p:nvSpPr>
+          <p:cNvPr id="3" name="Notes Placeholder 2"/>
+          <p:cNvSpPr>
+            <a:spLocks noGrp="1"/>
+          </p:cNvSpPr>
+          <p:nvPr>
+            <p:ph type="body" idx="1"/>
+          </p:nvPr>
+        </p:nvSpPr>
+        <p:spPr/>
+        <p:txBody>
+          <a:bodyPr/>
+          <a:lstStyle/>
+          <a:p>
+            <a:r>
+              <a:rPr lang="en-US" dirty="0"/>
+              <a:t>Everyone in the room has had this moment: they added one file, asked for a
+change, and the reply named a class from a file they never mentioned. That was
+not the model knowing the repo. It was this block, sent every turn.
+Point at the vertical bars: that is aider quoting source lines. Point at the
+dots: that is everything it decided not to spend tokens on. Signatures only,
+no bodies, so the model can name a function it has never read.
+The first session is when it looked cleverest, and there is a reason. With no
+files added, Aider doubles the map's token budget, so the map is largest
+exactly when they had given it nothing.
+Ask what this is for. The answer is on the next slide: it is aider guessing
+what you would have typed /add for.</a:t>
+            </a:r>
+            <a:endParaRPr lang="en-US" dirty="0"/>
+          </a:p>
+        </p:txBody>
+      </p:sp>
+      <p:sp>
+        <p:nvSpPr>
+          <p:cNvPr id="4" name="Slide Number Placeholder 3"/>
+          <p:cNvSpPr>
+            <a:spLocks noGrp="1"/>
+          </p:cNvSpPr>
+          <p:nvPr>
+            <p:ph type="sldNum" sz="quarter" idx="10"/>
+          </p:nvPr>
+        </p:nvSpPr>
+        <p:spPr/>
+        <p:txBody>
+          <a:bodyPr/>
+          <a:lstStyle/>
+          <a:p>
+            <a:fld id="{F7021451-1387-4CA6-816F-3879F97B5CBC}" type="slidenum">
+              <a:rPr lang="en-US"/>
+              <a:t>16</a:t>
+            </a:fld>
+            <a:endParaRPr lang="en-US"/>
+          </a:p>
+        </p:txBody>
+      </p:sp>
+    </p:spTree>
+    <p:extLst>
+      <p:ext uri="{BB962C8B-B14F-4D97-AF65-F5344CB8AC3E}">
+        <p14:creationId xmlns:p14="http://schemas.microsoft.com/office/powerpoint/2010/main" val="1024086991"/>
+      </p:ext>
+    </p:extLst>
+  </p:cSld>
+  <p:clrMapOvr>
+    <a:masterClrMapping/>
+  </p:clrMapOvr>
+</p:notes>
+</file>
+
+<file path=ppt/notesSlides/notesSlide17.xml><?xml version="1.0" encoding="utf-8"?>
+<p:notes xmlns:a="http://schemas.openxmlformats.org/drawingml/2006/main" xmlns:r="http://schemas.openxmlformats.org/officeDocument/2006/relationships" xmlns:p="http://schemas.openxmlformats.org/presentationml/2006/main">
+  <p:cSld>
+    <p:spTree>
+      <p:nvGrpSpPr>
+        <p:cNvPr id="1" name=""/>
+        <p:cNvGrpSpPr/>
+        <p:nvPr/>
+      </p:nvGrpSpPr>
+      <p:grpSpPr>
+        <a:xfrm>
+          <a:off x="0" y="0"/>
+          <a:ext cx="0" cy="0"/>
+          <a:chOff x="0" y="0"/>
+          <a:chExt cx="0" cy="0"/>
+        </a:xfrm>
+      </p:grpSpPr>
+      <p:sp>
+        <p:nvSpPr>
+          <p:cNvPr id="2" name="Slide Image Placeholder 1"/>
+          <p:cNvSpPr>
+            <a:spLocks noGrp="1" noRot="1" noChangeAspect="1"/>
+          </p:cNvSpPr>
+          <p:nvPr>
+            <p:ph type="sldImg"/>
+          </p:nvPr>
+        </p:nvSpPr>
+        <p:spPr/>
+      </p:sp>
+      <p:sp>
+        <p:nvSpPr>
+          <p:cNvPr id="3" name="Notes Placeholder 2"/>
+          <p:cNvSpPr>
+            <a:spLocks noGrp="1"/>
+          </p:cNvSpPr>
+          <p:nvPr>
+            <p:ph type="body" idx="1"/>
+          </p:nvPr>
+        </p:nvSpPr>
+        <p:spPr/>
+        <p:txBody>
+          <a:bodyPr/>
+          <a:lstStyle/>
+          <a:p>
+            <a:r>
+              <a:rPr lang="en-US" dirty="0"/>
+              <a:t>Off the slide and worth saying: the ranking is tilted toward files you just
+mentioned, and aider renders down the list until the tokens run out.
+Say the ranking rule plainly: a file that lots of other files depend on scores
+high, because it is probably the one you need to know about.
+The dashed line is the point, and the bold line says it. It is not "here is
+your repo," it is "here is as much of your repo as fits," and whatever falls
+under the line is invisible to the model. The same guess that looked like
+intelligence on the last slide is silent about everything below the line. 867
+lines of aider to guess what you would have typed /add for.</a:t>
+            </a:r>
+            <a:endParaRPr lang="en-US" dirty="0"/>
+          </a:p>
+        </p:txBody>
+      </p:sp>
+      <p:sp>
+        <p:nvSpPr>
+          <p:cNvPr id="4" name="Slide Number Placeholder 3"/>
+          <p:cNvSpPr>
+            <a:spLocks noGrp="1"/>
+          </p:cNvSpPr>
+          <p:nvPr>
+            <p:ph type="sldNum" sz="quarter" idx="10"/>
+          </p:nvPr>
+        </p:nvSpPr>
+        <p:spPr/>
+        <p:txBody>
+          <a:bodyPr/>
+          <a:lstStyle/>
+          <a:p>
+            <a:fld id="{F7021451-1387-4CA6-816F-3879F97B5CBC}" type="slidenum">
+              <a:rPr lang="en-US"/>
+              <a:t>17</a:t>
+            </a:fld>
+            <a:endParaRPr lang="en-US"/>
+          </a:p>
+        </p:txBody>
+      </p:sp>
+    </p:spTree>
+    <p:extLst>
+      <p:ext uri="{BB962C8B-B14F-4D97-AF65-F5344CB8AC3E}">
+        <p14:creationId xmlns:p14="http://schemas.microsoft.com/office/powerpoint/2010/main" val="1024086991"/>
+      </p:ext>
+    </p:extLst>
+  </p:cSld>
+  <p:clrMapOvr>
+    <a:masterClrMapping/>
+  </p:clrMapOvr>
+</p:notes>
+</file>
+
+<file path=ppt/notesSlides/notesSlide18.xml><?xml version="1.0" encoding="utf-8"?>
+<p:notes xmlns:a="http://schemas.openxmlformats.org/drawingml/2006/main" xmlns:r="http://schemas.openxmlformats.org/officeDocument/2006/relationships" xmlns:p="http://schemas.openxmlformats.org/presentationml/2006/main">
+  <p:cSld>
+    <p:spTree>
+      <p:nvGrpSpPr>
+        <p:cNvPr id="1" name=""/>
+        <p:cNvGrpSpPr/>
+        <p:nvPr/>
+      </p:nvGrpSpPr>
+      <p:grpSpPr>
+        <a:xfrm>
+          <a:off x="0" y="0"/>
+          <a:ext cx="0" cy="0"/>
+          <a:chOff x="0" y="0"/>
+          <a:chExt cx="0" cy="0"/>
+        </a:xfrm>
+      </p:grpSpPr>
+      <p:sp>
+        <p:nvSpPr>
+          <p:cNvPr id="2" name="Slide Image Placeholder 1"/>
+          <p:cNvSpPr>
+            <a:spLocks noGrp="1" noRot="1" noChangeAspect="1"/>
+          </p:cNvSpPr>
+          <p:nvPr>
+            <p:ph type="sldImg"/>
+          </p:nvPr>
+        </p:nvSpPr>
+        <p:spPr/>
+      </p:sp>
+      <p:sp>
+        <p:nvSpPr>
+          <p:cNvPr id="3" name="Notes Placeholder 2"/>
+          <p:cNvSpPr>
+            <a:spLocks noGrp="1"/>
+          </p:cNvSpPr>
+          <p:nvPr>
+            <p:ph type="body" idx="1"/>
+          </p:nvPr>
+        </p:nvSpPr>
+        <p:spPr/>
+        <p:txBody>
+          <a:bodyPr/>
+          <a:lstStyle/>
+          <a:p>
+            <a:r>
+              <a:rPr lang="en-US" dirty="0"/>
+              <a:t>The one context slide worth keeping, because it is the part L02 and L03 did not
+show. They have seen that the window is finite and they have read /tokens. They
+have not seen it fill up over a session.
+Walk the two bars. Nothing about the early turn is wrong; the later turn is the
+same prompt after the history has grown, and the thing that stops fitting is
+their own message. Everything above it was spent before they typed.
+The map is charged to this same budget, which on a 4B can be a third of the
+window spent describing files the model then cannot see inside. That is why the
+aider-practice cheatsheet says to turn it down, and why the map is out of scope
+for the build. Say
+so, so nobody spends week 4 on it.
+Then the bold line, which is the whole reason this slide is still here. Ask what
+they would drop first and what has to survive. Their Stage 1 contract keeps the
+system instructions, the current request and the added file contents, and refuses
+an oversized required input instead of silently trimming it. That refusal is a
+design decision they have to write down and test, and the packet does not make it
+for them.</a:t>
+            </a:r>
+            <a:endParaRPr lang="en-US" dirty="0"/>
+          </a:p>
+        </p:txBody>
+      </p:sp>
+      <p:sp>
+        <p:nvSpPr>
+          <p:cNvPr id="4" name="Slide Number Placeholder 3"/>
+          <p:cNvSpPr>
+            <a:spLocks noGrp="1"/>
+          </p:cNvSpPr>
+          <p:nvPr>
+            <p:ph type="sldNum" sz="quarter" idx="10"/>
+          </p:nvPr>
+        </p:nvSpPr>
+        <p:spPr/>
+        <p:txBody>
+          <a:bodyPr/>
+          <a:lstStyle/>
+          <a:p>
+            <a:fld id="{F7021451-1387-4CA6-816F-3879F97B5CBC}" type="slidenum">
+              <a:rPr lang="en-US"/>
+              <a:t>18</a:t>
+            </a:fld>
+            <a:endParaRPr lang="en-US"/>
+          </a:p>
+        </p:txBody>
+      </p:sp>
+    </p:spTree>
+    <p:extLst>
+      <p:ext uri="{BB962C8B-B14F-4D97-AF65-F5344CB8AC3E}">
+        <p14:creationId xmlns:p14="http://schemas.microsoft.com/office/powerpoint/2010/main" val="1024086991"/>
+      </p:ext>
+    </p:extLst>
+  </p:cSld>
+  <p:clrMapOvr>
+    <a:masterClrMapping/>
+  </p:clrMapOvr>
+</p:notes>
+</file>
+
+<file path=ppt/notesSlides/notesSlide19.xml><?xml version="1.0" encoding="utf-8"?>
+<p:notes xmlns:a="http://schemas.openxmlformats.org/drawingml/2006/main" xmlns:r="http://schemas.openxmlformats.org/officeDocument/2006/relationships" xmlns:p="http://schemas.openxmlformats.org/presentationml/2006/main">
+  <p:cSld>
+    <p:spTree>
+      <p:nvGrpSpPr>
+        <p:cNvPr id="1" name=""/>
+        <p:cNvGrpSpPr/>
+        <p:nvPr/>
+      </p:nvGrpSpPr>
+      <p:grpSpPr>
+        <a:xfrm>
+          <a:off x="0" y="0"/>
+          <a:ext cx="0" cy="0"/>
+          <a:chOff x="0" y="0"/>
+          <a:chExt cx="0" cy="0"/>
+        </a:xfrm>
+      </p:grpSpPr>
+      <p:sp>
+        <p:nvSpPr>
+          <p:cNvPr id="2" name="Slide Image Placeholder 1"/>
+          <p:cNvSpPr>
+            <a:spLocks noGrp="1" noRot="1" noChangeAspect="1"/>
+          </p:cNvSpPr>
+          <p:nvPr>
+            <p:ph type="sldImg"/>
+          </p:nvPr>
+        </p:nvSpPr>
+        <p:spPr/>
+      </p:sp>
+      <p:sp>
+        <p:nvSpPr>
+          <p:cNvPr id="3" name="Notes Placeholder 2"/>
+          <p:cNvSpPr>
+            <a:spLocks noGrp="1"/>
+          </p:cNvSpPr>
+          <p:nvPr>
+            <p:ph type="body" idx="1"/>
+          </p:nvPr>
+        </p:nvSpPr>
+        <p:spPr/>
+        <p:txBody>
+          <a:bodyPr/>
+          <a:lstStyle/>
+          <a:p>
+            <a:r>
+              <a:rPr lang="en-US" dirty="0"/>
+              <a:t>Reworked 2026-09-13, late, on instructor direction: the prompt's structure
+and how Aider manages it, and nothing about caching. Five slides. The prompt
+top to bottom. How Aider keeps each part current. Architect mode as a second
+prompt built fresh. Errors written for the model. After an edit lands. The
+cost slide ("Higher up is more expensive to change") was cut later the same
+night; prefix reuse is one sentence in the order slide's notes now.
+Gone from here: "Edit-shaped replies" and "An action through a text channel",
+which now sit in the harness section where a reply belongs; "How a file update
+arrives" and "What it remembers", merged into "After an edit lands"; and "The
+silent undo", cut.
+Open with the one sentence everything else follows from. The model keeps
+nothing between turns. Turn twelve sends everything turn one sent, plus more.
+That is not a limitation to work around, it is the condition their own build
+runs under.</a:t>
+            </a:r>
+            <a:endParaRPr lang="en-US" dirty="0"/>
+          </a:p>
+        </p:txBody>
+      </p:sp>
+      <p:sp>
+        <p:nvSpPr>
+          <p:cNvPr id="4" name="Slide Number Placeholder 3"/>
+          <p:cNvSpPr>
+            <a:spLocks noGrp="1"/>
+          </p:cNvSpPr>
+          <p:nvPr>
+            <p:ph type="sldNum" sz="quarter" idx="10"/>
+          </p:nvPr>
+        </p:nvSpPr>
+        <p:spPr/>
+        <p:txBody>
+          <a:bodyPr/>
+          <a:lstStyle/>
+          <a:p>
+            <a:fld id="{F7021451-1387-4CA6-816F-3879F97B5CBC}" type="slidenum">
+              <a:rPr lang="en-US"/>
+              <a:t>19</a:t>
+            </a:fld>
+            <a:endParaRPr lang="en-US"/>
+          </a:p>
+        </p:txBody>
+      </p:sp>
+    </p:spTree>
+    <p:extLst>
+      <p:ext uri="{BB962C8B-B14F-4D97-AF65-F5344CB8AC3E}">
+        <p14:creationId xmlns:p14="http://schemas.microsoft.com/office/powerpoint/2010/main" val="1024086991"/>
+      </p:ext>
+    </p:extLst>
+  </p:cSld>
+  <p:clrMapOvr>
+    <a:masterClrMapping/>
+  </p:clrMapOvr>
+</p:notes>
+</file>
+
+<file path=ppt/notesSlides/notesSlide2.xml><?xml version="1.0" encoding="utf-8"?>
+<p:notes xmlns:a="http://schemas.openxmlformats.org/drawingml/2006/main" xmlns:r="http://schemas.openxmlformats.org/officeDocument/2006/relationships" xmlns:p="http://schemas.openxmlformats.org/presentationml/2006/main">
+  <p:cSld>
+    <p:spTree>
+      <p:nvGrpSpPr>
+        <p:cNvPr id="1" name=""/>
+        <p:cNvGrpSpPr/>
+        <p:nvPr/>
+      </p:nvGrpSpPr>
+      <p:grpSpPr>
+        <a:xfrm>
+          <a:off x="0" y="0"/>
+          <a:ext cx="0" cy="0"/>
+          <a:chOff x="0" y="0"/>
+          <a:chExt cx="0" cy="0"/>
+        </a:xfrm>
+      </p:grpSpPr>
+      <p:sp>
+        <p:nvSpPr>
+          <p:cNvPr id="2" name="Slide Image Placeholder 1"/>
+          <p:cNvSpPr>
+            <a:spLocks noGrp="1" noRot="1" noChangeAspect="1"/>
+          </p:cNvSpPr>
+          <p:nvPr>
+            <p:ph type="sldImg"/>
+          </p:nvPr>
+        </p:nvSpPr>
+        <p:spPr/>
+      </p:sp>
+      <p:sp>
+        <p:nvSpPr>
+          <p:cNvPr id="3" name="Notes Placeholder 2"/>
+          <p:cNvSpPr>
+            <a:spLocks noGrp="1"/>
+          </p:cNvSpPr>
+          <p:nvPr>
+            <p:ph type="body" idx="1"/>
+          </p:nvPr>
+        </p:nvSpPr>
+        <p:spPr/>
+        <p:txBody>
+          <a:bodyPr/>
+          <a:lstStyle/>
+          <a:p>
+            <a:r>
+              <a:rPr lang="en-US" dirty="0"/>
+              <a:t>Put this up while the room settles and leave it up. The agenda is part of the
+first block, not an extra segment in front of it.
+Say out loud that the second half is genuinely office hours: they work, you
+circulate, and nobody hands anything in today. Students who have been told all
+term that labs end in a checkoff will not believe it unless you say it. The
+slide no longer says so, so this is on you to say.
+Do not preview the build past the word itself. The reveal is still yours to
+make in the third section.</a:t>
+            </a:r>
+            <a:endParaRPr lang="en-US" dirty="0"/>
+          </a:p>
+        </p:txBody>
+      </p:sp>
+      <p:sp>
+        <p:nvSpPr>
+          <p:cNvPr id="4" name="Slide Number Placeholder 3"/>
+          <p:cNvSpPr>
+            <a:spLocks noGrp="1"/>
+          </p:cNvSpPr>
+          <p:nvPr>
+            <p:ph type="sldNum" sz="quarter" idx="10"/>
+          </p:nvPr>
+        </p:nvSpPr>
+        <p:spPr/>
+        <p:txBody>
+          <a:bodyPr/>
+          <a:lstStyle/>
+          <a:p>
+            <a:fld id="{F7021451-1387-4CA6-816F-3879F97B5CBC}" type="slidenum">
+              <a:rPr lang="en-US"/>
+              <a:t>2</a:t>
+            </a:fld>
+            <a:endParaRPr lang="en-US"/>
+          </a:p>
+        </p:txBody>
+      </p:sp>
+    </p:spTree>
+    <p:extLst>
+      <p:ext uri="{BB962C8B-B14F-4D97-AF65-F5344CB8AC3E}">
+        <p14:creationId xmlns:p14="http://schemas.microsoft.com/office/powerpoint/2010/main" val="1024086991"/>
+      </p:ext>
+    </p:extLst>
+  </p:cSld>
+  <p:clrMapOvr>
+    <a:masterClrMapping/>
+  </p:clrMapOvr>
+</p:notes>
+</file>
+
+<file path=ppt/notesSlides/notesSlide20.xml><?xml version="1.0" encoding="utf-8"?>
+<p:notes xmlns:a="http://schemas.openxmlformats.org/drawingml/2006/main" xmlns:r="http://schemas.openxmlformats.org/officeDocument/2006/relationships" xmlns:p="http://schemas.openxmlformats.org/presentationml/2006/main">
+  <p:cSld>
+    <p:spTree>
+      <p:nvGrpSpPr>
+        <p:cNvPr id="1" name=""/>
+        <p:cNvGrpSpPr/>
+        <p:nvPr/>
+      </p:nvGrpSpPr>
+      <p:grpSpPr>
+        <a:xfrm>
+          <a:off x="0" y="0"/>
+          <a:ext cx="0" cy="0"/>
+          <a:chOff x="0" y="0"/>
+          <a:chExt cx="0" cy="0"/>
+        </a:xfrm>
+      </p:grpSpPr>
+      <p:sp>
+        <p:nvSpPr>
+          <p:cNvPr id="2" name="Slide Image Placeholder 1"/>
+          <p:cNvSpPr>
+            <a:spLocks noGrp="1" noRot="1" noChangeAspect="1"/>
+          </p:cNvSpPr>
+          <p:nvPr>
+            <p:ph type="sldImg"/>
+          </p:nvPr>
+        </p:nvSpPr>
+        <p:spPr/>
+      </p:sp>
+      <p:sp>
+        <p:nvSpPr>
+          <p:cNvPr id="3" name="Notes Placeholder 2"/>
+          <p:cNvSpPr>
+            <a:spLocks noGrp="1"/>
+          </p:cNvSpPr>
+          <p:nvPr>
+            <p:ph type="body" idx="1"/>
+          </p:nvPr>
+        </p:nvSpPr>
+        <p:spPr/>
+        <p:txBody>
+          <a:bodyPr/>
+          <a:lstStyle/>
+          <a:p>
+            <a:r>
+              <a:rPr lang="en-US" dirty="0"/>
+              <a:t>The eight parts in the order Aider sends them, read from the source. The
+brackets group them by how often they change: the system prompt and its worked
+examples almost never, the read-only files and the map when they ask for
+something, and the bottom four every single turn.
+Work the bold line rather than the parts. The parts that change every turn
+were deliberately put last. One sentence on why, and no slide: a server skips
+re-reading an opening it has already seen, so stable-first makes most turns
+cheaper. Put the order up and let someone in the room guess that before you
+say it.
+Their build assembles this same thing, and the packet asks them to say what
+goes in it and in what order. This slide is the argument that the answer is a
+design decision rather than a detail.</a:t>
+            </a:r>
+            <a:endParaRPr lang="en-US" dirty="0"/>
+          </a:p>
+        </p:txBody>
+      </p:sp>
+      <p:sp>
+        <p:nvSpPr>
+          <p:cNvPr id="4" name="Slide Number Placeholder 3"/>
+          <p:cNvSpPr>
+            <a:spLocks noGrp="1"/>
+          </p:cNvSpPr>
+          <p:nvPr>
+            <p:ph type="sldNum" sz="quarter" idx="10"/>
+          </p:nvPr>
+        </p:nvSpPr>
+        <p:spPr/>
+        <p:txBody>
+          <a:bodyPr/>
+          <a:lstStyle/>
+          <a:p>
+            <a:fld id="{F7021451-1387-4CA6-816F-3879F97B5CBC}" type="slidenum">
+              <a:rPr lang="en-US"/>
+              <a:t>20</a:t>
+            </a:fld>
+            <a:endParaRPr lang="en-US"/>
+          </a:p>
+        </p:txBody>
+      </p:sp>
+    </p:spTree>
+    <p:extLst>
+      <p:ext uri="{BB962C8B-B14F-4D97-AF65-F5344CB8AC3E}">
+        <p14:creationId xmlns:p14="http://schemas.microsoft.com/office/powerpoint/2010/main" val="1024086991"/>
+      </p:ext>
+    </p:extLst>
+  </p:cSld>
+  <p:clrMapOvr>
+    <a:masterClrMapping/>
+  </p:clrMapOvr>
+</p:notes>
+</file>
+
+<file path=ppt/notesSlides/notesSlide21.xml><?xml version="1.0" encoding="utf-8"?>
+<p:notes xmlns:a="http://schemas.openxmlformats.org/drawingml/2006/main" xmlns:r="http://schemas.openxmlformats.org/officeDocument/2006/relationships" xmlns:p="http://schemas.openxmlformats.org/presentationml/2006/main">
+  <p:cSld>
+    <p:spTree>
+      <p:nvGrpSpPr>
+        <p:cNvPr id="1" name=""/>
+        <p:cNvGrpSpPr/>
+        <p:nvPr/>
+      </p:nvGrpSpPr>
+      <p:grpSpPr>
+        <a:xfrm>
+          <a:off x="0" y="0"/>
+          <a:ext cx="0" cy="0"/>
+          <a:chOff x="0" y="0"/>
+          <a:chExt cx="0" cy="0"/>
+        </a:xfrm>
+      </p:grpSpPr>
+      <p:sp>
+        <p:nvSpPr>
+          <p:cNvPr id="2" name="Slide Image Placeholder 1"/>
+          <p:cNvSpPr>
+            <a:spLocks noGrp="1" noRot="1" noChangeAspect="1"/>
+          </p:cNvSpPr>
+          <p:nvPr>
+            <p:ph type="sldImg"/>
+          </p:nvPr>
+        </p:nvSpPr>
+        <p:spPr/>
+      </p:sp>
+      <p:sp>
+        <p:nvSpPr>
+          <p:cNvPr id="3" name="Notes Placeholder 2"/>
+          <p:cNvSpPr>
+            <a:spLocks noGrp="1"/>
+          </p:cNvSpPr>
+          <p:nvPr>
+            <p:ph type="body" idx="1"/>
+          </p:nvPr>
+        </p:nvSpPr>
+        <p:spPr/>
+        <p:txBody>
+          <a:bodyPr/>
+          <a:lstStyle/>
+          <a:p>
+            <a:r>
+              <a:rPr lang="en-US" dirty="0"/>
+              <a:t>The slide the instructor asked for: not what is in the prompt, but what Aider
+does to each part between one turn and the next. Every row was read out of
+the 0.86.2 source.
+The system prompt is chosen by mode, and ask mode also drops the worked
+examples. Read-only and added files are read
+from disk again on every turn, so there is exactly one copy of each and it is
+current. The map is re-ranked around the filenames and identifiers in the
+message just typed. The history grows by both halves of every turn and is
+summarised by the weak model once it passes a token limit. And the format
+reminder is stuck onto the end of the student's own message, and left out
+when there is no room for it.
+Ask which rows their build has. The system prompt, the files, the history and
+the message. No map, and the reminder is theirs to decide. Then ask which of
+those they have to re-read every turn, and why: the answer is the files, and
+the reason is the last slide of this section. Next: architect mode, which
+builds a second prompt out of these same parts.</a:t>
+            </a:r>
+            <a:endParaRPr lang="en-US" dirty="0"/>
+          </a:p>
+        </p:txBody>
+      </p:sp>
+      <p:sp>
+        <p:nvSpPr>
+          <p:cNvPr id="4" name="Slide Number Placeholder 3"/>
+          <p:cNvSpPr>
+            <a:spLocks noGrp="1"/>
+          </p:cNvSpPr>
+          <p:nvPr>
+            <p:ph type="sldNum" sz="quarter" idx="10"/>
+          </p:nvPr>
+        </p:nvSpPr>
+        <p:spPr/>
+        <p:txBody>
+          <a:bodyPr/>
+          <a:lstStyle/>
+          <a:p>
+            <a:fld id="{F7021451-1387-4CA6-816F-3879F97B5CBC}" type="slidenum">
+              <a:rPr lang="en-US"/>
+              <a:t>21</a:t>
+            </a:fld>
+            <a:endParaRPr lang="en-US"/>
+          </a:p>
+        </p:txBody>
+      </p:sp>
+    </p:spTree>
+    <p:extLst>
+      <p:ext uri="{BB962C8B-B14F-4D97-AF65-F5344CB8AC3E}">
+        <p14:creationId xmlns:p14="http://schemas.microsoft.com/office/powerpoint/2010/main" val="1024086991"/>
+      </p:ext>
+    </p:extLst>
+  </p:cSld>
+  <p:clrMapOvr>
+    <a:masterClrMapping/>
+  </p:clrMapOvr>
+</p:notes>
+</file>
+
+<file path=ppt/notesSlides/notesSlide22.xml><?xml version="1.0" encoding="utf-8"?>
+<p:notes xmlns:a="http://schemas.openxmlformats.org/drawingml/2006/main" xmlns:r="http://schemas.openxmlformats.org/officeDocument/2006/relationships" xmlns:p="http://schemas.openxmlformats.org/presentationml/2006/main">
+  <p:cSld>
+    <p:spTree>
+      <p:nvGrpSpPr>
+        <p:cNvPr id="1" name=""/>
+        <p:cNvGrpSpPr/>
+        <p:nvPr/>
+      </p:nvGrpSpPr>
+      <p:grpSpPr>
+        <a:xfrm>
+          <a:off x="0" y="0"/>
+          <a:ext cx="0" cy="0"/>
+          <a:chOff x="0" y="0"/>
+          <a:chExt cx="0" cy="0"/>
+        </a:xfrm>
+      </p:grpSpPr>
+      <p:sp>
+        <p:nvSpPr>
+          <p:cNvPr id="2" name="Slide Image Placeholder 1"/>
+          <p:cNvSpPr>
+            <a:spLocks noGrp="1" noRot="1" noChangeAspect="1"/>
+          </p:cNvSpPr>
+          <p:nvPr>
+            <p:ph type="sldImg"/>
+          </p:nvPr>
+        </p:nvSpPr>
+        <p:spPr/>
+      </p:sp>
+      <p:sp>
+        <p:nvSpPr>
+          <p:cNvPr id="3" name="Notes Placeholder 2"/>
+          <p:cNvSpPr>
+            <a:spLocks noGrp="1"/>
+          </p:cNvSpPr>
+          <p:nvPr>
+            <p:ph type="body" idx="1"/>
+          </p:nvPr>
+        </p:nvSpPr>
+        <p:spPr/>
+        <p:txBody>
+          <a:bodyPr/>
+          <a:lstStyle/>
+          <a:p>
+            <a:r>
+              <a:rPr lang="en-US" dirty="0"/>
+              <a:t>Added 2026-09-13, late, on instructor direction. They used this in lesson 6
+and the lesson said it was two model calls. This is what the two prompts hold,
+built out of the same parts as the last two slides.
+From the source: when the plan is accepted, Aider creates a second coder with
+empty history, no repo map, the edit-format system prompt, and the plan as its
+only user message. The editor sees the files and the plan. Nothing else. The
+architect's own prompt is the full stack, and it stays in one mode for the
+whole conversation, so its system prompt never swaps.
+Say why it is built that way. A long prompt full of history is a good prompt
+for deciding what to do and a bad one for producing an exact edit. Splitting
+the job gives each call the prompt it needs: the whole picture for the plan,
+a short focused one for the edit. That is the reason architect mode scores
+better on small models, and it is a structure decision, not a model feature.
+`auto-accept-architect: false` in the practice repo is why it stopped to ask
+before the second call. Their build could do the same in an increment: plan
+with the full context, edit with a small one.</a:t>
+            </a:r>
+            <a:endParaRPr lang="en-US" dirty="0"/>
+          </a:p>
+        </p:txBody>
+      </p:sp>
+      <p:sp>
+        <p:nvSpPr>
+          <p:cNvPr id="4" name="Slide Number Placeholder 3"/>
+          <p:cNvSpPr>
+            <a:spLocks noGrp="1"/>
+          </p:cNvSpPr>
+          <p:nvPr>
+            <p:ph type="sldNum" sz="quarter" idx="10"/>
+          </p:nvPr>
+        </p:nvSpPr>
+        <p:spPr/>
+        <p:txBody>
+          <a:bodyPr/>
+          <a:lstStyle/>
+          <a:p>
+            <a:fld id="{F7021451-1387-4CA6-816F-3879F97B5CBC}" type="slidenum">
+              <a:rPr lang="en-US"/>
+              <a:t>22</a:t>
+            </a:fld>
+            <a:endParaRPr lang="en-US"/>
+          </a:p>
+        </p:txBody>
+      </p:sp>
+    </p:spTree>
+    <p:extLst>
+      <p:ext uri="{BB962C8B-B14F-4D97-AF65-F5344CB8AC3E}">
+        <p14:creationId xmlns:p14="http://schemas.microsoft.com/office/powerpoint/2010/main" val="1024086991"/>
+      </p:ext>
+    </p:extLst>
+  </p:cSld>
+  <p:clrMapOvr>
+    <a:masterClrMapping/>
+  </p:clrMapOvr>
+</p:notes>
+</file>
+
+<file path=ppt/notesSlides/notesSlide23.xml><?xml version="1.0" encoding="utf-8"?>
 <p:notes xmlns:a="http://schemas.openxmlformats.org/drawingml/2006/main" xmlns:r="http://schemas.openxmlformats.org/officeDocument/2006/relationships" xmlns:p="http://schemas.openxmlformats.org/presentationml/2006/main">
   <p:cSld>
     <p:spTree>
@@ -1253,7 +2062,7 @@
           <a:p>
             <a:fld id="{F7021451-1387-4CA6-816F-3879F97B5CBC}" type="slidenum">
               <a:rPr lang="en-US"/>
-              <a:t>16</a:t>
+              <a:t>23</a:t>
             </a:fld>
             <a:endParaRPr lang="en-US"/>
           </a:p>
@@ -1272,7 +2081,7 @@
 </p:notes>
 </file>
 
-<file path=ppt/notesSlides/notesSlide17.xml><?xml version="1.0" encoding="utf-8"?>
+<file path=ppt/notesSlides/notesSlide24.xml><?xml version="1.0" encoding="utf-8"?>
 <p:notes xmlns:a="http://schemas.openxmlformats.org/drawingml/2006/main" xmlns:r="http://schemas.openxmlformats.org/officeDocument/2006/relationships" xmlns:p="http://schemas.openxmlformats.org/presentationml/2006/main">
   <p:cSld>
     <p:spTree>
@@ -1318,15 +2127,28 @@
           <a:p>
             <a:r>
               <a:rPr lang="en-US" dirty="0"/>
-              <a:t>The obvious question once they understand the prefix: after an edit lands, does
-the model get told, or does the text change under it? Both, and the second
+              <a:t>Merged 2026-09-13, late, from "How a file update arrives" and "What it
+remembers", which the instructor found hard to present as two slides. Same
+stack as the rest of the section, two parts called out.
+The question once they understand the prompt is rebuilt: after an edit lands,
+is the model told, or does the text change under it? Both, and the second
 matters more.
-The file block is rebuilt from disk on every turn, so there is exactly one copy
-of each file in the prompt and it is current. Aider also adds a sentence, in the
-student's voice, saying it committed with a given hash.
-The last line is worth saying out loud. A file they edit themselves in another
-window is picked up on the next turn with no announcement at all. Nothing in the
-transcript marks it.</a:t>
+The file block is rebuilt from disk, so there is one copy of each file and it
+is current. No diff is ever sent and no old copy is kept. Aider also adds one
+line to the history, in the student's voice, saying it committed with a given
+hash. That is all the model is told.
+The history is the other half. The model's own replies stay word for word, and
+they are full of edit blocks quoting the old text. So its record of the
+previous version is exactly the lines it chose to change and nothing around
+them, a biased sample of the past. That is why Aider's own prompt warns the
+model that other messages may hold outdated contents. It cannot fix that, only
+warn.
+Two consequences worth saying. A file they edit themselves in another window
+is picked up next turn with no announcement. And /undo on the course models
+tells the model nothing, so its history still holds the edit it proposed and
+the file no longer does. The silent undo slide came off the deck tonight; the
+fact stays here, and it is why their specification requires undo to be an
+owned, current-session operation on a clean target.</a:t>
             </a:r>
             <a:endParaRPr lang="en-US" dirty="0"/>
           </a:p>
@@ -1349,7 +2171,7 @@
           <a:p>
             <a:fld id="{F7021451-1387-4CA6-816F-3879F97B5CBC}" type="slidenum">
               <a:rPr lang="en-US"/>
-              <a:t>17</a:t>
+              <a:t>24</a:t>
             </a:fld>
             <a:endParaRPr lang="en-US"/>
           </a:p>
@@ -1368,298 +2190,7 @@
 </p:notes>
 </file>
 
-<file path=ppt/notesSlides/notesSlide18.xml><?xml version="1.0" encoding="utf-8"?>
-<p:notes xmlns:a="http://schemas.openxmlformats.org/drawingml/2006/main" xmlns:r="http://schemas.openxmlformats.org/officeDocument/2006/relationships" xmlns:p="http://schemas.openxmlformats.org/presentationml/2006/main">
-  <p:cSld>
-    <p:spTree>
-      <p:nvGrpSpPr>
-        <p:cNvPr id="1" name=""/>
-        <p:cNvGrpSpPr/>
-        <p:nvPr/>
-      </p:nvGrpSpPr>
-      <p:grpSpPr>
-        <a:xfrm>
-          <a:off x="0" y="0"/>
-          <a:ext cx="0" cy="0"/>
-          <a:chOff x="0" y="0"/>
-          <a:chExt cx="0" cy="0"/>
-        </a:xfrm>
-      </p:grpSpPr>
-      <p:sp>
-        <p:nvSpPr>
-          <p:cNvPr id="2" name="Slide Image Placeholder 1"/>
-          <p:cNvSpPr>
-            <a:spLocks noGrp="1" noRot="1" noChangeAspect="1"/>
-          </p:cNvSpPr>
-          <p:nvPr>
-            <p:ph type="sldImg"/>
-          </p:nvPr>
-        </p:nvSpPr>
-        <p:spPr/>
-      </p:sp>
-      <p:sp>
-        <p:nvSpPr>
-          <p:cNvPr id="3" name="Notes Placeholder 2"/>
-          <p:cNvSpPr>
-            <a:spLocks noGrp="1"/>
-          </p:cNvSpPr>
-          <p:nvPr>
-            <p:ph type="body" idx="1"/>
-          </p:nvPr>
-        </p:nvSpPr>
-        <p:spPr/>
-        <p:txBody>
-          <a:bodyPr/>
-          <a:lstStyle/>
-          <a:p>
-            <a:r>
-              <a:rPr lang="en-US" dirty="0"/>
-              <a:t>Follow the consequence carefully, because this is where the room usually gets a
-surprise.
-Old copies of the file never pile up: that block is reassembled every turn. But
-the model's replies stay in the history word for word, and those replies are
-full of search blocks quoting the old text exactly. So the model's record of the
-previous version is whatever it happened to quote, which is precisely the lines
-it chose to change and nothing around them. A biased sample of the past.
-Which explains the line in Aider's own prompt warning that other messages may
-hold outdated contents. It is not defending against its own file blocks, it is
-defending against the model's memory of its own edits, and all it can do is
-issue an instruction and hope.</a:t>
-            </a:r>
-            <a:endParaRPr lang="en-US" dirty="0"/>
-          </a:p>
-        </p:txBody>
-      </p:sp>
-      <p:sp>
-        <p:nvSpPr>
-          <p:cNvPr id="4" name="Slide Number Placeholder 3"/>
-          <p:cNvSpPr>
-            <a:spLocks noGrp="1"/>
-          </p:cNvSpPr>
-          <p:nvPr>
-            <p:ph type="sldNum" sz="quarter" idx="10"/>
-          </p:nvPr>
-        </p:nvSpPr>
-        <p:spPr/>
-        <p:txBody>
-          <a:bodyPr/>
-          <a:lstStyle/>
-          <a:p>
-            <a:fld id="{F7021451-1387-4CA6-816F-3879F97B5CBC}" type="slidenum">
-              <a:rPr lang="en-US"/>
-              <a:t>18</a:t>
-            </a:fld>
-            <a:endParaRPr lang="en-US"/>
-          </a:p>
-        </p:txBody>
-      </p:sp>
-    </p:spTree>
-    <p:extLst>
-      <p:ext uri="{BB962C8B-B14F-4D97-AF65-F5344CB8AC3E}">
-        <p14:creationId xmlns:p14="http://schemas.microsoft.com/office/powerpoint/2010/main" val="1024086991"/>
-      </p:ext>
-    </p:extLst>
-  </p:cSld>
-  <p:clrMapOvr>
-    <a:masterClrMapping/>
-  </p:clrMapOvr>
-</p:notes>
-</file>
-
-<file path=ppt/notesSlides/notesSlide19.xml><?xml version="1.0" encoding="utf-8"?>
-<p:notes xmlns:a="http://schemas.openxmlformats.org/drawingml/2006/main" xmlns:r="http://schemas.openxmlformats.org/officeDocument/2006/relationships" xmlns:p="http://schemas.openxmlformats.org/presentationml/2006/main">
-  <p:cSld>
-    <p:spTree>
-      <p:nvGrpSpPr>
-        <p:cNvPr id="1" name=""/>
-        <p:cNvGrpSpPr/>
-        <p:nvPr/>
-      </p:nvGrpSpPr>
-      <p:grpSpPr>
-        <a:xfrm>
-          <a:off x="0" y="0"/>
-          <a:ext cx="0" cy="0"/>
-          <a:chOff x="0" y="0"/>
-          <a:chExt cx="0" cy="0"/>
-        </a:xfrm>
-      </p:grpSpPr>
-      <p:sp>
-        <p:nvSpPr>
-          <p:cNvPr id="2" name="Slide Image Placeholder 1"/>
-          <p:cNvSpPr>
-            <a:spLocks noGrp="1" noRot="1" noChangeAspect="1"/>
-          </p:cNvSpPr>
-          <p:nvPr>
-            <p:ph type="sldImg"/>
-          </p:nvPr>
-        </p:nvSpPr>
-        <p:spPr/>
-      </p:sp>
-      <p:sp>
-        <p:nvSpPr>
-          <p:cNvPr id="3" name="Notes Placeholder 2"/>
-          <p:cNvSpPr>
-            <a:spLocks noGrp="1"/>
-          </p:cNvSpPr>
-          <p:nvPr>
-            <p:ph type="body" idx="1"/>
-          </p:nvPr>
-        </p:nvSpPr>
-        <p:spPr/>
-        <p:txBody>
-          <a:bodyPr/>
-          <a:lstStyle/>
-          <a:p>
-            <a:r>
-              <a:rPr lang="en-US" dirty="0"/>
-              <a:t>Aider can send the model a note when an edit is undone, but only for a handful
-of models, and the course configuration is not one of them. So on qwen the undo
-is silent.
-Put the pieces together with the room. The file reverts. The model is told
-nothing. Its own search block for the edit that no longer exists is still in the
-history. Ask it for a follow-up change built on that edit and the block will not
-match, and the only feedback it gets is that the match failed.
-This is the single clearest case of a harness failing to keep a model grounded,
-and it is why their specification requires undo to be an owned, current-session
-operation on a clean target. That requirement is not bureaucracy, it is this
-slide.</a:t>
-            </a:r>
-            <a:endParaRPr lang="en-US" dirty="0"/>
-          </a:p>
-        </p:txBody>
-      </p:sp>
-      <p:sp>
-        <p:nvSpPr>
-          <p:cNvPr id="4" name="Slide Number Placeholder 3"/>
-          <p:cNvSpPr>
-            <a:spLocks noGrp="1"/>
-          </p:cNvSpPr>
-          <p:nvPr>
-            <p:ph type="sldNum" sz="quarter" idx="10"/>
-          </p:nvPr>
-        </p:nvSpPr>
-        <p:spPr/>
-        <p:txBody>
-          <a:bodyPr/>
-          <a:lstStyle/>
-          <a:p>
-            <a:fld id="{F7021451-1387-4CA6-816F-3879F97B5CBC}" type="slidenum">
-              <a:rPr lang="en-US"/>
-              <a:t>19</a:t>
-            </a:fld>
-            <a:endParaRPr lang="en-US"/>
-          </a:p>
-        </p:txBody>
-      </p:sp>
-    </p:spTree>
-    <p:extLst>
-      <p:ext uri="{BB962C8B-B14F-4D97-AF65-F5344CB8AC3E}">
-        <p14:creationId xmlns:p14="http://schemas.microsoft.com/office/powerpoint/2010/main" val="1024086991"/>
-      </p:ext>
-    </p:extLst>
-  </p:cSld>
-  <p:clrMapOvr>
-    <a:masterClrMapping/>
-  </p:clrMapOvr>
-</p:notes>
-</file>
-
-<file path=ppt/notesSlides/notesSlide2.xml><?xml version="1.0" encoding="utf-8"?>
-<p:notes xmlns:a="http://schemas.openxmlformats.org/drawingml/2006/main" xmlns:r="http://schemas.openxmlformats.org/officeDocument/2006/relationships" xmlns:p="http://schemas.openxmlformats.org/presentationml/2006/main">
-  <p:cSld>
-    <p:spTree>
-      <p:nvGrpSpPr>
-        <p:cNvPr id="1" name=""/>
-        <p:cNvGrpSpPr/>
-        <p:nvPr/>
-      </p:nvGrpSpPr>
-      <p:grpSpPr>
-        <a:xfrm>
-          <a:off x="0" y="0"/>
-          <a:ext cx="0" cy="0"/>
-          <a:chOff x="0" y="0"/>
-          <a:chExt cx="0" cy="0"/>
-        </a:xfrm>
-      </p:grpSpPr>
-      <p:sp>
-        <p:nvSpPr>
-          <p:cNvPr id="2" name="Slide Image Placeholder 1"/>
-          <p:cNvSpPr>
-            <a:spLocks noGrp="1" noRot="1" noChangeAspect="1"/>
-          </p:cNvSpPr>
-          <p:nvPr>
-            <p:ph type="sldImg"/>
-          </p:nvPr>
-        </p:nvSpPr>
-        <p:spPr/>
-      </p:sp>
-      <p:sp>
-        <p:nvSpPr>
-          <p:cNvPr id="3" name="Notes Placeholder 2"/>
-          <p:cNvSpPr>
-            <a:spLocks noGrp="1"/>
-          </p:cNvSpPr>
-          <p:nvPr>
-            <p:ph type="body" idx="1"/>
-          </p:nvPr>
-        </p:nvSpPr>
-        <p:spPr/>
-        <p:txBody>
-          <a:bodyPr/>
-          <a:lstStyle/>
-          <a:p>
-            <a:r>
-              <a:rPr lang="en-US" dirty="0"/>
-              <a:t>Put this up while the room settles and leave it up. The agenda is part of the
-first block, not an extra segment in front of it.
-Say out loud that the second half is genuinely office hours: they work, you
-circulate, and nobody hands anything in today. Students who have been told all
-term that labs end in a checkoff will not believe it unless you say it. The
-slide no longer says so, so this is on you to say.
-Do not preview the build past the word itself. The reveal is still yours to
-make in the third section.</a:t>
-            </a:r>
-            <a:endParaRPr lang="en-US" dirty="0"/>
-          </a:p>
-        </p:txBody>
-      </p:sp>
-      <p:sp>
-        <p:nvSpPr>
-          <p:cNvPr id="4" name="Slide Number Placeholder 3"/>
-          <p:cNvSpPr>
-            <a:spLocks noGrp="1"/>
-          </p:cNvSpPr>
-          <p:nvPr>
-            <p:ph type="sldNum" sz="quarter" idx="10"/>
-          </p:nvPr>
-        </p:nvSpPr>
-        <p:spPr/>
-        <p:txBody>
-          <a:bodyPr/>
-          <a:lstStyle/>
-          <a:p>
-            <a:fld id="{F7021451-1387-4CA6-816F-3879F97B5CBC}" type="slidenum">
-              <a:rPr lang="en-US"/>
-              <a:t>2</a:t>
-            </a:fld>
-            <a:endParaRPr lang="en-US"/>
-          </a:p>
-        </p:txBody>
-      </p:sp>
-    </p:spTree>
-    <p:extLst>
-      <p:ext uri="{BB962C8B-B14F-4D97-AF65-F5344CB8AC3E}">
-        <p14:creationId xmlns:p14="http://schemas.microsoft.com/office/powerpoint/2010/main" val="1024086991"/>
-      </p:ext>
-    </p:extLst>
-  </p:cSld>
-  <p:clrMapOvr>
-    <a:masterClrMapping/>
-  </p:clrMapOvr>
-</p:notes>
-</file>
-
-<file path=ppt/notesSlides/notesSlide20.xml><?xml version="1.0" encoding="utf-8"?>
+<file path=ppt/notesSlides/notesSlide25.xml><?xml version="1.0" encoding="utf-8"?>
 <p:notes xmlns:a="http://schemas.openxmlformats.org/drawingml/2006/main" xmlns:r="http://schemas.openxmlformats.org/officeDocument/2006/relationships" xmlns:p="http://schemas.openxmlformats.org/presentationml/2006/main">
   <p:cSld>
     <p:spTree>
@@ -1730,7 +2261,7 @@
           <a:p>
             <a:fld id="{F7021451-1387-4CA6-816F-3879F97B5CBC}" type="slidenum">
               <a:rPr lang="en-US"/>
-              <a:t>20</a:t>
+              <a:t>25</a:t>
             </a:fld>
             <a:endParaRPr lang="en-US"/>
           </a:p>
@@ -1749,7 +2280,7 @@
 </p:notes>
 </file>
 
-<file path=ppt/notesSlides/notesSlide21.xml><?xml version="1.0" encoding="utf-8"?>
+<file path=ppt/notesSlides/notesSlide26.xml><?xml version="1.0" encoding="utf-8"?>
 <p:notes xmlns:a="http://schemas.openxmlformats.org/drawingml/2006/main" xmlns:r="http://schemas.openxmlformats.org/officeDocument/2006/relationships" xmlns:p="http://schemas.openxmlformats.org/presentationml/2006/main">
   <p:cSld>
     <p:spTree>
@@ -1823,7 +2354,7 @@
           <a:p>
             <a:fld id="{F7021451-1387-4CA6-816F-3879F97B5CBC}" type="slidenum">
               <a:rPr lang="en-US"/>
-              <a:t>21</a:t>
+              <a:t>26</a:t>
             </a:fld>
             <a:endParaRPr lang="en-US"/>
           </a:p>
@@ -1842,7 +2373,7 @@
 </p:notes>
 </file>
 
-<file path=ppt/notesSlides/notesSlide22.xml><?xml version="1.0" encoding="utf-8"?>
+<file path=ppt/notesSlides/notesSlide27.xml><?xml version="1.0" encoding="utf-8"?>
 <p:notes xmlns:a="http://schemas.openxmlformats.org/drawingml/2006/main" xmlns:r="http://schemas.openxmlformats.org/officeDocument/2006/relationships" xmlns:p="http://schemas.openxmlformats.org/presentationml/2006/main">
   <p:cSld>
     <p:spTree>
@@ -1933,7 +2464,7 @@
           <a:p>
             <a:fld id="{F7021451-1387-4CA6-816F-3879F97B5CBC}" type="slidenum">
               <a:rPr lang="en-US"/>
-              <a:t>22</a:t>
+              <a:t>27</a:t>
             </a:fld>
             <a:endParaRPr lang="en-US"/>
           </a:p>
@@ -1952,7 +2483,7 @@
 </p:notes>
 </file>
 
-<file path=ppt/notesSlides/notesSlide23.xml><?xml version="1.0" encoding="utf-8"?>
+<file path=ppt/notesSlides/notesSlide28.xml><?xml version="1.0" encoding="utf-8"?>
 <p:notes xmlns:a="http://schemas.openxmlformats.org/drawingml/2006/main" xmlns:r="http://schemas.openxmlformats.org/officeDocument/2006/relationships" xmlns:p="http://schemas.openxmlformats.org/presentationml/2006/main">
   <p:cSld>
     <p:spTree>
@@ -2024,7 +2555,7 @@
           <a:p>
             <a:fld id="{F7021451-1387-4CA6-816F-3879F97B5CBC}" type="slidenum">
               <a:rPr lang="en-US"/>
-              <a:t>23</a:t>
+              <a:t>28</a:t>
             </a:fld>
             <a:endParaRPr lang="en-US"/>
           </a:p>
@@ -2043,7 +2574,7 @@
 </p:notes>
 </file>
 
-<file path=ppt/notesSlides/notesSlide24.xml><?xml version="1.0" encoding="utf-8"?>
+<file path=ppt/notesSlides/notesSlide29.xml><?xml version="1.0" encoding="utf-8"?>
 <p:notes xmlns:a="http://schemas.openxmlformats.org/drawingml/2006/main" xmlns:r="http://schemas.openxmlformats.org/officeDocument/2006/relationships" xmlns:p="http://schemas.openxmlformats.org/presentationml/2006/main">
   <p:cSld>
     <p:spTree>
@@ -2120,7 +2651,7 @@
           <a:p>
             <a:fld id="{F7021451-1387-4CA6-816F-3879F97B5CBC}" type="slidenum">
               <a:rPr lang="en-US"/>
-              <a:t>24</a:t>
+              <a:t>29</a:t>
             </a:fld>
             <a:endParaRPr lang="en-US"/>
           </a:p>
@@ -2139,7 +2670,107 @@
 </p:notes>
 </file>
 
-<file path=ppt/notesSlides/notesSlide25.xml><?xml version="1.0" encoding="utf-8"?>
+<file path=ppt/notesSlides/notesSlide3.xml><?xml version="1.0" encoding="utf-8"?>
+<p:notes xmlns:a="http://schemas.openxmlformats.org/drawingml/2006/main" xmlns:r="http://schemas.openxmlformats.org/officeDocument/2006/relationships" xmlns:p="http://schemas.openxmlformats.org/presentationml/2006/main">
+  <p:cSld>
+    <p:spTree>
+      <p:nvGrpSpPr>
+        <p:cNvPr id="1" name=""/>
+        <p:cNvGrpSpPr/>
+        <p:nvPr/>
+      </p:nvGrpSpPr>
+      <p:grpSpPr>
+        <a:xfrm>
+          <a:off x="0" y="0"/>
+          <a:ext cx="0" cy="0"/>
+          <a:chOff x="0" y="0"/>
+          <a:chExt cx="0" cy="0"/>
+        </a:xfrm>
+      </p:grpSpPr>
+      <p:sp>
+        <p:nvSpPr>
+          <p:cNvPr id="2" name="Slide Image Placeholder 1"/>
+          <p:cNvSpPr>
+            <a:spLocks noGrp="1" noRot="1" noChangeAspect="1"/>
+          </p:cNvSpPr>
+          <p:nvPr>
+            <p:ph type="sldImg"/>
+          </p:nvPr>
+        </p:nvSpPr>
+        <p:spPr/>
+      </p:sp>
+      <p:sp>
+        <p:nvSpPr>
+          <p:cNvPr id="3" name="Notes Placeholder 2"/>
+          <p:cNvSpPr>
+            <a:spLocks noGrp="1"/>
+          </p:cNvSpPr>
+          <p:nvPr>
+            <p:ph type="body" idx="1"/>
+          </p:nvPr>
+        </p:nvSpPr>
+        <p:spPr/>
+        <p:txBody>
+          <a:bodyPr/>
+          <a:lstStyle/>
+          <a:p>
+            <a:r>
+              <a:rPr lang="en-US" dirty="0"/>
+              <a:t>Section slide added 2026-09-13 on instructor direction: the harness is the
+first section of the lab and should read as one. Eight slides under it. The
+four harnesses they have already used, then what a harness is and what the
+model never touches. Aider drawn as one, then what its reply looks like: the
+edit block, the two shapes it comes in, and the general problem of recovering
+an action from text. Then what Aider lacks that the familiar ones have.
+The examples come before the definition, so the word lands on tools they know
+before it gets an abstract shape. The reply slides moved here from the middle
+of the deck the same night, because a reply is the harness's "answer" card and
+was sitting in a section about caching.
+The section exists because sixteen practice lessons gave them the muscle
+memory and none of the model, and "harness" is the word they need: it is the
+thing they build in Stage 1 and extend in Analyze.</a:t>
+            </a:r>
+            <a:endParaRPr lang="en-US" dirty="0"/>
+          </a:p>
+        </p:txBody>
+      </p:sp>
+      <p:sp>
+        <p:nvSpPr>
+          <p:cNvPr id="4" name="Slide Number Placeholder 3"/>
+          <p:cNvSpPr>
+            <a:spLocks noGrp="1"/>
+          </p:cNvSpPr>
+          <p:nvPr>
+            <p:ph type="sldNum" sz="quarter" idx="10"/>
+          </p:nvPr>
+        </p:nvSpPr>
+        <p:spPr/>
+        <p:txBody>
+          <a:bodyPr/>
+          <a:lstStyle/>
+          <a:p>
+            <a:fld id="{F7021451-1387-4CA6-816F-3879F97B5CBC}" type="slidenum">
+              <a:rPr lang="en-US"/>
+              <a:t>3</a:t>
+            </a:fld>
+            <a:endParaRPr lang="en-US"/>
+          </a:p>
+        </p:txBody>
+      </p:sp>
+    </p:spTree>
+    <p:extLst>
+      <p:ext uri="{BB962C8B-B14F-4D97-AF65-F5344CB8AC3E}">
+        <p14:creationId xmlns:p14="http://schemas.microsoft.com/office/powerpoint/2010/main" val="1024086991"/>
+      </p:ext>
+    </p:extLst>
+  </p:cSld>
+  <p:clrMapOvr>
+    <a:masterClrMapping/>
+  </p:clrMapOvr>
+</p:notes>
+</file>
+
+<file path=ppt/notesSlides/notesSlide30.xml><?xml version="1.0" encoding="utf-8"?>
 <p:notes xmlns:a="http://schemas.openxmlformats.org/drawingml/2006/main" xmlns:r="http://schemas.openxmlformats.org/officeDocument/2006/relationships" xmlns:p="http://schemas.openxmlformats.org/presentationml/2006/main">
   <p:cSld>
     <p:spTree>
@@ -2219,7 +2850,7 @@
           <a:p>
             <a:fld id="{F7021451-1387-4CA6-816F-3879F97B5CBC}" type="slidenum">
               <a:rPr lang="en-US"/>
-              <a:t>25</a:t>
+              <a:t>30</a:t>
             </a:fld>
             <a:endParaRPr lang="en-US"/>
           </a:p>
@@ -2238,7 +2869,7 @@
 </p:notes>
 </file>
 
-<file path=ppt/notesSlides/notesSlide26.xml><?xml version="1.0" encoding="utf-8"?>
+<file path=ppt/notesSlides/notesSlide31.xml><?xml version="1.0" encoding="utf-8"?>
 <p:notes xmlns:a="http://schemas.openxmlformats.org/drawingml/2006/main" xmlns:r="http://schemas.openxmlformats.org/officeDocument/2006/relationships" xmlns:p="http://schemas.openxmlformats.org/presentationml/2006/main">
   <p:cSld>
     <p:spTree>
@@ -2312,7 +2943,7 @@
           <a:p>
             <a:fld id="{F7021451-1387-4CA6-816F-3879F97B5CBC}" type="slidenum">
               <a:rPr lang="en-US"/>
-              <a:t>26</a:t>
+              <a:t>31</a:t>
             </a:fld>
             <a:endParaRPr lang="en-US"/>
           </a:p>
@@ -2331,7 +2962,7 @@
 </p:notes>
 </file>
 
-<file path=ppt/notesSlides/notesSlide27.xml><?xml version="1.0" encoding="utf-8"?>
+<file path=ppt/notesSlides/notesSlide32.xml><?xml version="1.0" encoding="utf-8"?>
 <p:notes xmlns:a="http://schemas.openxmlformats.org/drawingml/2006/main" xmlns:r="http://schemas.openxmlformats.org/officeDocument/2006/relationships" xmlns:p="http://schemas.openxmlformats.org/presentationml/2006/main">
   <p:cSld>
     <p:spTree>
@@ -2407,7 +3038,7 @@
           <a:p>
             <a:fld id="{F7021451-1387-4CA6-816F-3879F97B5CBC}" type="slidenum">
               <a:rPr lang="en-US"/>
-              <a:t>27</a:t>
+              <a:t>32</a:t>
             </a:fld>
             <a:endParaRPr lang="en-US"/>
           </a:p>
@@ -2426,7 +3057,7 @@
 </p:notes>
 </file>
 
-<file path=ppt/notesSlides/notesSlide28.xml><?xml version="1.0" encoding="utf-8"?>
+<file path=ppt/notesSlides/notesSlide33.xml><?xml version="1.0" encoding="utf-8"?>
 <p:notes xmlns:a="http://schemas.openxmlformats.org/drawingml/2006/main" xmlns:r="http://schemas.openxmlformats.org/officeDocument/2006/relationships" xmlns:p="http://schemas.openxmlformats.org/presentationml/2006/main">
   <p:cSld>
     <p:spTree>
@@ -2510,7 +3141,7 @@
           <a:p>
             <a:fld id="{F7021451-1387-4CA6-816F-3879F97B5CBC}" type="slidenum">
               <a:rPr lang="en-US"/>
-              <a:t>28</a:t>
+              <a:t>33</a:t>
             </a:fld>
             <a:endParaRPr lang="en-US"/>
           </a:p>
@@ -2529,7 +3160,7 @@
 </p:notes>
 </file>
 
-<file path=ppt/notesSlides/notesSlide29.xml><?xml version="1.0" encoding="utf-8"?>
+<file path=ppt/notesSlides/notesSlide34.xml><?xml version="1.0" encoding="utf-8"?>
 <p:notes xmlns:a="http://schemas.openxmlformats.org/drawingml/2006/main" xmlns:r="http://schemas.openxmlformats.org/officeDocument/2006/relationships" xmlns:p="http://schemas.openxmlformats.org/presentationml/2006/main">
   <p:cSld>
     <p:spTree>
@@ -2603,7 +3234,7 @@
           <a:p>
             <a:fld id="{F7021451-1387-4CA6-816F-3879F97B5CBC}" type="slidenum">
               <a:rPr lang="en-US"/>
-              <a:t>29</a:t>
+              <a:t>34</a:t>
             </a:fld>
             <a:endParaRPr lang="en-US"/>
           </a:p>
@@ -2622,102 +3253,7 @@
 </p:notes>
 </file>
 
-<file path=ppt/notesSlides/notesSlide3.xml><?xml version="1.0" encoding="utf-8"?>
-<p:notes xmlns:a="http://schemas.openxmlformats.org/drawingml/2006/main" xmlns:r="http://schemas.openxmlformats.org/officeDocument/2006/relationships" xmlns:p="http://schemas.openxmlformats.org/presentationml/2006/main">
-  <p:cSld>
-    <p:spTree>
-      <p:nvGrpSpPr>
-        <p:cNvPr id="1" name=""/>
-        <p:cNvGrpSpPr/>
-        <p:nvPr/>
-      </p:nvGrpSpPr>
-      <p:grpSpPr>
-        <a:xfrm>
-          <a:off x="0" y="0"/>
-          <a:ext cx="0" cy="0"/>
-          <a:chOff x="0" y="0"/>
-          <a:chExt cx="0" cy="0"/>
-        </a:xfrm>
-      </p:grpSpPr>
-      <p:sp>
-        <p:nvSpPr>
-          <p:cNvPr id="2" name="Slide Image Placeholder 1"/>
-          <p:cNvSpPr>
-            <a:spLocks noGrp="1" noRot="1" noChangeAspect="1"/>
-          </p:cNvSpPr>
-          <p:nvPr>
-            <p:ph type="sldImg"/>
-          </p:nvPr>
-        </p:nvSpPr>
-        <p:spPr/>
-      </p:sp>
-      <p:sp>
-        <p:nvSpPr>
-          <p:cNvPr id="3" name="Notes Placeholder 2"/>
-          <p:cNvSpPr>
-            <a:spLocks noGrp="1"/>
-          </p:cNvSpPr>
-          <p:nvPr>
-            <p:ph type="body" idx="1"/>
-          </p:nvPr>
-        </p:nvSpPr>
-        <p:spPr/>
-        <p:txBody>
-          <a:bodyPr/>
-          <a:lstStyle/>
-          <a:p>
-            <a:r>
-              <a:rPr lang="en-US" dirty="0"/>
-              <a:t>This is the slide the deck was missing. Sixteen practice lessons gave them the
-muscle memory and none of the model, and the word "harness" is the one they
-need, because it is the thing they build in Stage 1 and extend in Analyze.
-Say the right-hand column out loud. The model's entire contribution is one
-block of text. Every effect on their machine is the left column acting on it.
-If anyone asks about models, endpoints or config: MODEL-POLICY.md, and it is
-not today's subject. qwen3.5:9b recommended, 4B permitted, any compatible
-endpoint.</a:t>
-            </a:r>
-            <a:endParaRPr lang="en-US" dirty="0"/>
-          </a:p>
-        </p:txBody>
-      </p:sp>
-      <p:sp>
-        <p:nvSpPr>
-          <p:cNvPr id="4" name="Slide Number Placeholder 3"/>
-          <p:cNvSpPr>
-            <a:spLocks noGrp="1"/>
-          </p:cNvSpPr>
-          <p:nvPr>
-            <p:ph type="sldNum" sz="quarter" idx="10"/>
-          </p:nvPr>
-        </p:nvSpPr>
-        <p:spPr/>
-        <p:txBody>
-          <a:bodyPr/>
-          <a:lstStyle/>
-          <a:p>
-            <a:fld id="{F7021451-1387-4CA6-816F-3879F97B5CBC}" type="slidenum">
-              <a:rPr lang="en-US"/>
-              <a:t>3</a:t>
-            </a:fld>
-            <a:endParaRPr lang="en-US"/>
-          </a:p>
-        </p:txBody>
-      </p:sp>
-    </p:spTree>
-    <p:extLst>
-      <p:ext uri="{BB962C8B-B14F-4D97-AF65-F5344CB8AC3E}">
-        <p14:creationId xmlns:p14="http://schemas.microsoft.com/office/powerpoint/2010/main" val="1024086991"/>
-      </p:ext>
-    </p:extLst>
-  </p:cSld>
-  <p:clrMapOvr>
-    <a:masterClrMapping/>
-  </p:clrMapOvr>
-</p:notes>
-</file>
-
-<file path=ppt/notesSlides/notesSlide30.xml><?xml version="1.0" encoding="utf-8"?>
+<file path=ppt/notesSlides/notesSlide35.xml><?xml version="1.0" encoding="utf-8"?>
 <p:notes xmlns:a="http://schemas.openxmlformats.org/drawingml/2006/main" xmlns:r="http://schemas.openxmlformats.org/officeDocument/2006/relationships" xmlns:p="http://schemas.openxmlformats.org/presentationml/2006/main">
   <p:cSld>
     <p:spTree>
@@ -2790,7 +3326,7 @@
           <a:p>
             <a:fld id="{F7021451-1387-4CA6-816F-3879F97B5CBC}" type="slidenum">
               <a:rPr lang="en-US"/>
-              <a:t>30</a:t>
+              <a:t>35</a:t>
             </a:fld>
             <a:endParaRPr lang="en-US"/>
           </a:p>
@@ -2809,7 +3345,7 @@
 </p:notes>
 </file>
 
-<file path=ppt/notesSlides/notesSlide31.xml><?xml version="1.0" encoding="utf-8"?>
+<file path=ppt/notesSlides/notesSlide36.xml><?xml version="1.0" encoding="utf-8"?>
 <p:notes xmlns:a="http://schemas.openxmlformats.org/drawingml/2006/main" xmlns:r="http://schemas.openxmlformats.org/officeDocument/2006/relationships" xmlns:p="http://schemas.openxmlformats.org/presentationml/2006/main">
   <p:cSld>
     <p:spTree>
@@ -2855,15 +3391,18 @@
           <a:p>
             <a:r>
               <a:rPr lang="en-US" dirty="0"/>
-              <a:t>Rewritten 2026-09-14 on instructor direction: the discussion slide is gone and
-the section is now five slides that make an argument rather than a summary.
-What you can see, what seeing it costs, who chooses the context, what you own,
-and the one question left open for tomorrow.
-The question some of them have been holding for two weeks is why this course
-teaches on Aider rather than the tool everyone talks about. This section answers
-it, once, honestly, and without defending the choice. The short form: every
-decision a harness makes is on display here, they are about to build one, and
-the bigger tools are this loop with more of it automated.</a:t>
+              <a:t>Combined 2026-09-13, late, on instructor direction, from "Why this tool" and
+"What comes next", and titled as the combination. He found himself saying the
+last section's content during this one. One arc now, six slides, past to
+future. "The part you own" was cut on instruction later the same night. Where the field started.
+Aider is good to learn on. The models are weak on purpose. One repository to
+December. You will know how Claude Code works. The same loop
+with more machinery, which ends on the question L05 opens with.
+Each slide's notes end with a "Next:" line saying what the following slide
+carries, so nothing gets said a slide early. The order is the talk: this is
+where it started, it is the one to learn on, the weak models are deliberate,
+that harness grows through three phases, it ends up Claude Code-shaped and you will know why, and one question
+is left open for tomorrow.</a:t>
             </a:r>
             <a:endParaRPr lang="en-US" dirty="0"/>
           </a:p>
@@ -2886,7 +3425,7 @@
           <a:p>
             <a:fld id="{F7021451-1387-4CA6-816F-3879F97B5CBC}" type="slidenum">
               <a:rPr lang="en-US"/>
-              <a:t>31</a:t>
+              <a:t>36</a:t>
             </a:fld>
             <a:endParaRPr lang="en-US"/>
           </a:p>
@@ -2905,7 +3444,106 @@
 </p:notes>
 </file>
 
-<file path=ppt/notesSlides/notesSlide32.xml><?xml version="1.0" encoding="utf-8"?>
+<file path=ppt/notesSlides/notesSlide37.xml><?xml version="1.0" encoding="utf-8"?>
+<p:notes xmlns:a="http://schemas.openxmlformats.org/drawingml/2006/main" xmlns:r="http://schemas.openxmlformats.org/officeDocument/2006/relationships" xmlns:p="http://schemas.openxmlformats.org/presentationml/2006/main">
+  <p:cSld>
+    <p:spTree>
+      <p:nvGrpSpPr>
+        <p:cNvPr id="1" name=""/>
+        <p:cNvGrpSpPr/>
+        <p:nvPr/>
+      </p:nvGrpSpPr>
+      <p:grpSpPr>
+        <a:xfrm>
+          <a:off x="0" y="0"/>
+          <a:ext cx="0" cy="0"/>
+          <a:chOff x="0" y="0"/>
+          <a:chExt cx="0" cy="0"/>
+        </a:xfrm>
+      </p:grpSpPr>
+      <p:sp>
+        <p:nvSpPr>
+          <p:cNvPr id="2" name="Slide Image Placeholder 1"/>
+          <p:cNvSpPr>
+            <a:spLocks noGrp="1" noRot="1" noChangeAspect="1"/>
+          </p:cNvSpPr>
+          <p:nvPr>
+            <p:ph type="sldImg"/>
+          </p:nvPr>
+        </p:nvSpPr>
+        <p:spPr/>
+      </p:sp>
+      <p:sp>
+        <p:nvSpPr>
+          <p:cNvPr id="3" name="Notes Placeholder 2"/>
+          <p:cNvSpPr>
+            <a:spLocks noGrp="1"/>
+          </p:cNvSpPr>
+          <p:nvPr>
+            <p:ph type="body" idx="1"/>
+          </p:nvPr>
+        </p:nvSpPr>
+        <p:spPr/>
+        <p:txBody>
+          <a:bodyPr/>
+          <a:lstStyle/>
+          <a:p>
+            <a:r>
+              <a:rPr lang="en-US" dirty="0"/>
+              <a:t>L01's four waves, compressed to the two that matter here. Aider and Cursor are
+the first generation of tools where the model edits files rather than pasting
+into a chat. Claude Code and Codex came two years later and run the same loop
+with far more of it automated.
+The third row is the reason for the first two. Aider is open source and still
+runs the original loop, so the whole thing is readable: the repo map they saw
+earlier is under nine hundred lines. Nothing about the tool everyone talks
+about is that inspectable.
+Do not say what "most of it automated" means. That is the closing slide's
+question and L05's lecture.
+Next: the four decisions you can see in Aider. Do not list them here; the
+row that says Aider is readable is enough.</a:t>
+            </a:r>
+            <a:endParaRPr lang="en-US" dirty="0"/>
+          </a:p>
+        </p:txBody>
+      </p:sp>
+      <p:sp>
+        <p:nvSpPr>
+          <p:cNvPr id="4" name="Slide Number Placeholder 3"/>
+          <p:cNvSpPr>
+            <a:spLocks noGrp="1"/>
+          </p:cNvSpPr>
+          <p:nvPr>
+            <p:ph type="sldNum" sz="quarter" idx="10"/>
+          </p:nvPr>
+        </p:nvSpPr>
+        <p:spPr/>
+        <p:txBody>
+          <a:bodyPr/>
+          <a:lstStyle/>
+          <a:p>
+            <a:fld id="{F7021451-1387-4CA6-816F-3879F97B5CBC}" type="slidenum">
+              <a:rPr lang="en-US"/>
+              <a:t>37</a:t>
+            </a:fld>
+            <a:endParaRPr lang="en-US"/>
+          </a:p>
+        </p:txBody>
+      </p:sp>
+    </p:spTree>
+    <p:extLst>
+      <p:ext uri="{BB962C8B-B14F-4D97-AF65-F5344CB8AC3E}">
+        <p14:creationId xmlns:p14="http://schemas.microsoft.com/office/powerpoint/2010/main" val="1024086991"/>
+      </p:ext>
+    </p:extLst>
+  </p:cSld>
+  <p:clrMapOvr>
+    <a:masterClrMapping/>
+  </p:clrMapOvr>
+</p:notes>
+</file>
+
+<file path=ppt/notesSlides/notesSlide38.xml><?xml version="1.0" encoding="utf-8"?>
 <p:notes xmlns:a="http://schemas.openxmlformats.org/drawingml/2006/main" xmlns:r="http://schemas.openxmlformats.org/officeDocument/2006/relationships" xmlns:p="http://schemas.openxmlformats.org/presentationml/2006/main">
   <p:cSld>
     <p:spTree>
@@ -2952,15 +3590,18 @@
             <a:r>
               <a:rPr lang="en-US" dirty="0"/>
               <a:t>Four decisions every harness makes, and for each one the moment in the last two
-weeks when they made it or watched it. That is the whole pedagogical case: not
-that Aider is the best tool, but that it is the one where the joins show.
+weeks when they made it or watched it. That is the whole pedagogical case, and
+the headline now says it rather than implying it: Aider is not the best tool,
+it is the one where the joins show, and that is what makes it the one to learn
+on.
 The bold line is the argument against starting on a more automated tool. It
 would make the same four decisions, and they would never see any of them, so
 they would leave knowing how to use it and not how it works. This course is
 about how it works, because in three weeks they have to write one.
 If someone says the more automated tool is better: agree. It is. That is a
 different claim from being better to learn on, and the next slide is about what
-the difference costs.</a:t>
+the difference costs.
+Next: the weak models. Do not defend the 4B here; the next slide does.</a:t>
             </a:r>
             <a:endParaRPr lang="en-US" dirty="0"/>
           </a:p>
@@ -2983,7 +3624,7 @@
           <a:p>
             <a:fld id="{F7021451-1387-4CA6-816F-3879F97B5CBC}" type="slidenum">
               <a:rPr lang="en-US"/>
-              <a:t>32</a:t>
+              <a:t>38</a:t>
             </a:fld>
             <a:endParaRPr lang="en-US"/>
           </a:p>
@@ -3002,7 +3643,7 @@
 </p:notes>
 </file>
 
-<file path=ppt/notesSlides/notesSlide33.xml><?xml version="1.0" encoding="utf-8"?>
+<file path=ppt/notesSlides/notesSlide39.xml><?xml version="1.0" encoding="utf-8"?>
 <p:notes xmlns:a="http://schemas.openxmlformats.org/drawingml/2006/main" xmlns:r="http://schemas.openxmlformats.org/officeDocument/2006/relationships" xmlns:p="http://schemas.openxmlformats.org/presentationml/2006/main">
   <p:cSld>
     <p:spTree>
@@ -3048,15 +3689,20 @@
           <a:p>
             <a:r>
               <a:rPr lang="en-US" dirty="0"/>
-              <a:t>Read down it and resist making the left column win. Each line is a single design
-choice seen twice, which is what a trade-off actually is, and the right column is
-not a list of bugs.
-Their build inherits every row. When they write the specification this week they
-are choosing which side of each one to stand on, and the packet does not choose
-for them.
-The row to expand if you expand one: forgetting between sessions is not a
-limitation of the model. Every tool of this kind does it. Continuity is the
-harness re-sending, which is the first thing they learned today.</a:t>
+              <a:t>The direct version of something the course has only implied. Most people who
+have decided AI cannot code met a weak model with no context management and a
+vague prompt, and drew a conclusion. That is the setup every student in this
+room has run sixteen times, and L03 gave them three words for what went wrong.
+So they can now reproduce the skeptic's experience on demand and say which
+lever was set wrong. A frontier model would not have taught them that, because
+it hides the same failures behind polish and they happen less often.
+The 4B fails in the practice lessons on purpose. It is weak enough to punish a
+sloppy context or a vague ask immediately, which is how the habit lands. The
+next slide is why none of that is baked in: the model is one config line.
+Next: the arc to December. The weak model is the setup, the growing
+repository is the payoff, so stop at the bold line and let the timeline say
+it. If the room needs it, one sentence: the model is one config line and the
+harness is theirs; there is no longer a slide for that.</a:t>
             </a:r>
             <a:endParaRPr lang="en-US" dirty="0"/>
           </a:p>
@@ -3079,7 +3725,7 @@
           <a:p>
             <a:fld id="{F7021451-1387-4CA6-816F-3879F97B5CBC}" type="slidenum">
               <a:rPr lang="en-US"/>
-              <a:t>33</a:t>
+              <a:t>39</a:t>
             </a:fld>
             <a:endParaRPr lang="en-US"/>
           </a:p>
@@ -3098,7 +3744,7 @@
 </p:notes>
 </file>
 
-<file path=ppt/notesSlides/notesSlide34.xml><?xml version="1.0" encoding="utf-8"?>
+<file path=ppt/notesSlides/notesSlide4.xml><?xml version="1.0" encoding="utf-8"?>
 <p:notes xmlns:a="http://schemas.openxmlformats.org/drawingml/2006/main" xmlns:r="http://schemas.openxmlformats.org/officeDocument/2006/relationships" xmlns:p="http://schemas.openxmlformats.org/presentationml/2006/main">
   <p:cSld>
     <p:spTree>
@@ -3144,16 +3790,24 @@
           <a:p>
             <a:r>
               <a:rPr lang="en-US" dirty="0"/>
-              <a:t>The ladder, and the real answer to why this lab is worth two hours. All three
-rungs solve one problem, getting the right text in front of the model, and they
-differ only in who does the choosing.
-Aider stands on the first two with the joins showing. A more automated tool makes
-the same decisions without displaying them, which is exactly what makes it a
-worse thing to learn on and a better thing to use.
-Stop at context. Who picks the next action is tomorrow's lecture and it has a
-live demo for it, so do not pre-empt it beyond the last slide of this section.
-Then the bold line, which is the promise: none of this is machinery they cannot
-build, and they start writing it this week.</a:t>
+              <a:t>Opens the section, on instructor direction, so the word lands on tools they
+know before it gets a definition. Three of these they used before the course
+and never called a harness. Read one row across: what the program put in
+front of the model, and what it did with the text that came back. Every row
+is the same two jobs, and the next slide names them.
+ChatGPT's memory is the clean example. It feels like the model remembering
+you. It is the harness keeping notes and pasting them into the prompt, and
+two slides on is why: the model keeps nothing between sessions, so anything
+that persists is the harness re-sending it. Claude Code's notes are the same
+trick from the other side, a file you keep that is read in at the start of
+every session.
+Read the third column as the approval layer. Cursor waits for accept. Claude
+Code asks, or does not, depending on a permission setting somebody chose.
+Aider does not wait: it writes and commits, and /undo is the recovery. Their
+build has to ask before it writes, which is the packet's rule, and this column
+is the same decision made four different ways.
+Do not go further into Claude Code than its row. How it decides what to read
+and what to run is tomorrow's lecture, with a live demo behind it.</a:t>
             </a:r>
             <a:endParaRPr lang="en-US" dirty="0"/>
           </a:p>
@@ -3176,7 +3830,7 @@
           <a:p>
             <a:fld id="{F7021451-1387-4CA6-816F-3879F97B5CBC}" type="slidenum">
               <a:rPr lang="en-US"/>
-              <a:t>34</a:t>
+              <a:t>4</a:t>
             </a:fld>
             <a:endParaRPr lang="en-US"/>
           </a:p>
@@ -3195,291 +3849,7 @@
 </p:notes>
 </file>
 
-<file path=ppt/notesSlides/notesSlide35.xml><?xml version="1.0" encoding="utf-8"?>
-<p:notes xmlns:a="http://schemas.openxmlformats.org/drawingml/2006/main" xmlns:r="http://schemas.openxmlformats.org/officeDocument/2006/relationships" xmlns:p="http://schemas.openxmlformats.org/presentationml/2006/main">
-  <p:cSld>
-    <p:spTree>
-      <p:nvGrpSpPr>
-        <p:cNvPr id="1" name=""/>
-        <p:cNvGrpSpPr/>
-        <p:nvPr/>
-      </p:nvGrpSpPr>
-      <p:grpSpPr>
-        <a:xfrm>
-          <a:off x="0" y="0"/>
-          <a:ext cx="0" cy="0"/>
-          <a:chOff x="0" y="0"/>
-          <a:chExt cx="0" cy="0"/>
-        </a:xfrm>
-      </p:grpSpPr>
-      <p:sp>
-        <p:nvSpPr>
-          <p:cNvPr id="2" name="Slide Image Placeholder 1"/>
-          <p:cNvSpPr>
-            <a:spLocks noGrp="1" noRot="1" noChangeAspect="1"/>
-          </p:cNvSpPr>
-          <p:nvPr>
-            <p:ph type="sldImg"/>
-          </p:nvPr>
-        </p:nvSpPr>
-        <p:spPr/>
-      </p:sp>
-      <p:sp>
-        <p:nvSpPr>
-          <p:cNvPr id="3" name="Notes Placeholder 2"/>
-          <p:cNvSpPr>
-            <a:spLocks noGrp="1"/>
-          </p:cNvSpPr>
-          <p:nvPr>
-            <p:ph type="body" idx="1"/>
-          </p:nvPr>
-        </p:nvSpPr>
-        <p:spPr/>
-        <p:txBody>
-          <a:bodyPr/>
-          <a:lstStyle/>
-          <a:p>
-            <a:r>
-              <a:rPr lang="en-US" dirty="0"/>
-              <a:t>This is the idea that outlasts the course. Aider talks to any endpoint that
-speaks the common API, which is why it runs against the course server, against
-a model on their own laptop, and against a paid provider with one line changed.
-The model is swappable. It is a dependency, like a database driver.
-What is not swappable is the harness: which text goes in, in what order, what a
-reply is allowed to do, what gets written and committed. Every slide today was
-about that layer, and none of it belonged to the model.
-Their build has this shape by design: one endpoint, any permitted model, and
-everything they are graded on lives above the API call. The same is true of the
-tool everyone talks about. Its value is not the model behind it.</a:t>
-            </a:r>
-            <a:endParaRPr lang="en-US" dirty="0"/>
-          </a:p>
-        </p:txBody>
-      </p:sp>
-      <p:sp>
-        <p:nvSpPr>
-          <p:cNvPr id="4" name="Slide Number Placeholder 3"/>
-          <p:cNvSpPr>
-            <a:spLocks noGrp="1"/>
-          </p:cNvSpPr>
-          <p:nvPr>
-            <p:ph type="sldNum" sz="quarter" idx="10"/>
-          </p:nvPr>
-        </p:nvSpPr>
-        <p:spPr/>
-        <p:txBody>
-          <a:bodyPr/>
-          <a:lstStyle/>
-          <a:p>
-            <a:fld id="{F7021451-1387-4CA6-816F-3879F97B5CBC}" type="slidenum">
-              <a:rPr lang="en-US"/>
-              <a:t>35</a:t>
-            </a:fld>
-            <a:endParaRPr lang="en-US"/>
-          </a:p>
-        </p:txBody>
-      </p:sp>
-    </p:spTree>
-    <p:extLst>
-      <p:ext uri="{BB962C8B-B14F-4D97-AF65-F5344CB8AC3E}">
-        <p14:creationId xmlns:p14="http://schemas.microsoft.com/office/powerpoint/2010/main" val="1024086991"/>
-      </p:ext>
-    </p:extLst>
-  </p:cSld>
-  <p:clrMapOvr>
-    <a:masterClrMapping/>
-  </p:clrMapOvr>
-</p:notes>
-</file>
-
-<file path=ppt/notesSlides/notesSlide36.xml><?xml version="1.0" encoding="utf-8"?>
-<p:notes xmlns:a="http://schemas.openxmlformats.org/drawingml/2006/main" xmlns:r="http://schemas.openxmlformats.org/officeDocument/2006/relationships" xmlns:p="http://schemas.openxmlformats.org/presentationml/2006/main">
-  <p:cSld>
-    <p:spTree>
-      <p:nvGrpSpPr>
-        <p:cNvPr id="1" name=""/>
-        <p:cNvGrpSpPr/>
-        <p:nvPr/>
-      </p:nvGrpSpPr>
-      <p:grpSpPr>
-        <a:xfrm>
-          <a:off x="0" y="0"/>
-          <a:ext cx="0" cy="0"/>
-          <a:chOff x="0" y="0"/>
-          <a:chExt cx="0" cy="0"/>
-        </a:xfrm>
-      </p:grpSpPr>
-      <p:sp>
-        <p:nvSpPr>
-          <p:cNvPr id="2" name="Slide Image Placeholder 1"/>
-          <p:cNvSpPr>
-            <a:spLocks noGrp="1" noRot="1" noChangeAspect="1"/>
-          </p:cNvSpPr>
-          <p:nvPr>
-            <p:ph type="sldImg"/>
-          </p:nvPr>
-        </p:nvSpPr>
-        <p:spPr/>
-      </p:sp>
-      <p:sp>
-        <p:nvSpPr>
-          <p:cNvPr id="3" name="Notes Placeholder 2"/>
-          <p:cNvSpPr>
-            <a:spLocks noGrp="1"/>
-          </p:cNvSpPr>
-          <p:nvPr>
-            <p:ph type="body" idx="1"/>
-          </p:nvPr>
-        </p:nvSpPr>
-        <p:spPr/>
-        <p:txBody>
-          <a:bodyPr/>
-          <a:lstStyle/>
-          <a:p>
-            <a:r>
-              <a:rPr lang="en-US" dirty="0"/>
-              <a:t>The bridge, and the end of the taught half. Six steps, and today they followed
-one request through all of them. Every tool of this kind, whatever its name and
-whoever makes it, runs the same six.
-Ask the room which of the six belonged to the model. One: the answer. At every
-other step the thing that decided what happened next was them, or a rule
-somebody wrote down in advance.
-Then leave the bold line up and do not answer it. Tomorrow's lecture opens on
-exactly this question, has a live demo for it, and spends ninety minutes on the
-answer. Saying more here spoils it; saying this much is what makes tomorrow land.</a:t>
-            </a:r>
-            <a:endParaRPr lang="en-US" dirty="0"/>
-          </a:p>
-        </p:txBody>
-      </p:sp>
-      <p:sp>
-        <p:nvSpPr>
-          <p:cNvPr id="4" name="Slide Number Placeholder 3"/>
-          <p:cNvSpPr>
-            <a:spLocks noGrp="1"/>
-          </p:cNvSpPr>
-          <p:nvPr>
-            <p:ph type="sldNum" sz="quarter" idx="10"/>
-          </p:nvPr>
-        </p:nvSpPr>
-        <p:spPr/>
-        <p:txBody>
-          <a:bodyPr/>
-          <a:lstStyle/>
-          <a:p>
-            <a:fld id="{F7021451-1387-4CA6-816F-3879F97B5CBC}" type="slidenum">
-              <a:rPr lang="en-US"/>
-              <a:t>36</a:t>
-            </a:fld>
-            <a:endParaRPr lang="en-US"/>
-          </a:p>
-        </p:txBody>
-      </p:sp>
-    </p:spTree>
-    <p:extLst>
-      <p:ext uri="{BB962C8B-B14F-4D97-AF65-F5344CB8AC3E}">
-        <p14:creationId xmlns:p14="http://schemas.microsoft.com/office/powerpoint/2010/main" val="1024086991"/>
-      </p:ext>
-    </p:extLst>
-  </p:cSld>
-  <p:clrMapOvr>
-    <a:masterClrMapping/>
-  </p:clrMapOvr>
-</p:notes>
-</file>
-
-<file path=ppt/notesSlides/notesSlide37.xml><?xml version="1.0" encoding="utf-8"?>
-<p:notes xmlns:a="http://schemas.openxmlformats.org/drawingml/2006/main" xmlns:r="http://schemas.openxmlformats.org/officeDocument/2006/relationships" xmlns:p="http://schemas.openxmlformats.org/presentationml/2006/main">
-  <p:cSld>
-    <p:spTree>
-      <p:nvGrpSpPr>
-        <p:cNvPr id="1" name=""/>
-        <p:cNvGrpSpPr/>
-        <p:nvPr/>
-      </p:nvGrpSpPr>
-      <p:grpSpPr>
-        <a:xfrm>
-          <a:off x="0" y="0"/>
-          <a:ext cx="0" cy="0"/>
-          <a:chOff x="0" y="0"/>
-          <a:chExt cx="0" cy="0"/>
-        </a:xfrm>
-      </p:grpSpPr>
-      <p:sp>
-        <p:nvSpPr>
-          <p:cNvPr id="2" name="Slide Image Placeholder 1"/>
-          <p:cNvSpPr>
-            <a:spLocks noGrp="1" noRot="1" noChangeAspect="1"/>
-          </p:cNvSpPr>
-          <p:nvPr>
-            <p:ph type="sldImg"/>
-          </p:nvPr>
-        </p:nvSpPr>
-        <p:spPr/>
-      </p:sp>
-      <p:sp>
-        <p:nvSpPr>
-          <p:cNvPr id="3" name="Notes Placeholder 2"/>
-          <p:cNvSpPr>
-            <a:spLocks noGrp="1"/>
-          </p:cNvSpPr>
-          <p:nvPr>
-            <p:ph type="body" idx="1"/>
-          </p:nvPr>
-        </p:nvSpPr>
-        <p:spPr/>
-        <p:txBody>
-          <a:bodyPr/>
-          <a:lstStyle/>
-          <a:p>
-            <a:r>
-              <a:rPr lang="en-US" dirty="0"/>
-              <a:t>Short, and it comes after the ledger. The point is the arc, not a tour of
-tools.
-Nothing here is a Stage 1 dependency and no subscription is needed for this
-course.</a:t>
-            </a:r>
-            <a:endParaRPr lang="en-US" dirty="0"/>
-          </a:p>
-        </p:txBody>
-      </p:sp>
-      <p:sp>
-        <p:nvSpPr>
-          <p:cNvPr id="4" name="Slide Number Placeholder 3"/>
-          <p:cNvSpPr>
-            <a:spLocks noGrp="1"/>
-          </p:cNvSpPr>
-          <p:nvPr>
-            <p:ph type="sldNum" sz="quarter" idx="10"/>
-          </p:nvPr>
-        </p:nvSpPr>
-        <p:spPr/>
-        <p:txBody>
-          <a:bodyPr/>
-          <a:lstStyle/>
-          <a:p>
-            <a:fld id="{F7021451-1387-4CA6-816F-3879F97B5CBC}" type="slidenum">
-              <a:rPr lang="en-US"/>
-              <a:t>37</a:t>
-            </a:fld>
-            <a:endParaRPr lang="en-US"/>
-          </a:p>
-        </p:txBody>
-      </p:sp>
-    </p:spTree>
-    <p:extLst>
-      <p:ext uri="{BB962C8B-B14F-4D97-AF65-F5344CB8AC3E}">
-        <p14:creationId xmlns:p14="http://schemas.microsoft.com/office/powerpoint/2010/main" val="1024086991"/>
-      </p:ext>
-    </p:extLst>
-  </p:cSld>
-  <p:clrMapOvr>
-    <a:masterClrMapping/>
-  </p:clrMapOvr>
-</p:notes>
-</file>
-
-<file path=ppt/notesSlides/notesSlide38.xml><?xml version="1.0" encoding="utf-8"?>
+<file path=ppt/notesSlides/notesSlide40.xml><?xml version="1.0" encoding="utf-8"?>
 <p:notes xmlns:a="http://schemas.openxmlformats.org/drawingml/2006/main" xmlns:r="http://schemas.openxmlformats.org/officeDocument/2006/relationships" xmlns:p="http://schemas.openxmlformats.org/presentationml/2006/main">
   <p:cSld>
     <p:spTree>
@@ -3534,7 +3904,9 @@
 because L05 delivers exactly that the next day with a live demo behind it. Do
 not reconstruct it here.
 Do not estimate the workload out loud. Do say that a runnable slice early is
-what keeps the December integration from being a surprise.</a:t>
+what keeps the December integration from being a surprise.
+Next: the destination, named. Do not say Claude Code on this slide. The dots
+are Apply, Analyze and Create, and the next slide says what they add up to.</a:t>
             </a:r>
             <a:endParaRPr lang="en-US" dirty="0"/>
           </a:p>
@@ -3557,7 +3929,7 @@
           <a:p>
             <a:fld id="{F7021451-1387-4CA6-816F-3879F97B5CBC}" type="slidenum">
               <a:rPr lang="en-US"/>
-              <a:t>38</a:t>
+              <a:t>40</a:t>
             </a:fld>
             <a:endParaRPr lang="en-US"/>
           </a:p>
@@ -3576,7 +3948,7 @@
 </p:notes>
 </file>
 
-<file path=ppt/notesSlides/notesSlide39.xml><?xml version="1.0" encoding="utf-8"?>
+<file path=ppt/notesSlides/notesSlide41.xml><?xml version="1.0" encoding="utf-8"?>
 <p:notes xmlns:a="http://schemas.openxmlformats.org/drawingml/2006/main" xmlns:r="http://schemas.openxmlformats.org/officeDocument/2006/relationships" xmlns:p="http://schemas.openxmlformats.org/presentationml/2006/main">
   <p:cSld>
     <p:spTree>
@@ -3622,14 +3994,23 @@
           <a:p>
             <a:r>
               <a:rPr lang="en-US" dirty="0"/>
-              <a:t>This is the last thing they hear before office hours, so land it and stop.
-Name the two tools as a shape, not as a target to clone and not as something
-they need an account for. What makes it that shape is the list they will build:
-tools the model chooses, an approval layer, state that survives a run, more
-than one way in.
-The design habit to start now: when a decision could close off one of those,
-leave a boundary rather than an implementation. That is the useful half of the
-slide this replaced.</a:t>
+              <a:t>Merged 2026-09-13, late, from "You will know how Claude Code works" and "The
+harness by December", on the instructor's reading that he was saying this
+slide's content a section early. There is now one place in the deck that
+names the destination, and it is here.
+The lead line first. Name Claude Code, or OpenClaw, as a shape, not a target
+to clone and not something they need an account for. What makes it that shape
+is the list they will build: tools the model chooses, an approval layer, state
+that survives a run, more than one way in. The design habit to start now: when
+a decision could close off one of those, leave a boundary rather than an
+implementation.
+Then the table. Say the left column as what a user sees and the right column
+as what a builder knows. Each row is a moment they will recognise from using
+the tool, paired with the code in their own repository that does the same job:
+the loop this month, the tools and the permission gate in Analyze, memory and
+hardening in Create.
+Nobody needs a subscription for anything in this course.
+Next: the open question. Do not say who picks the next action here.</a:t>
             </a:r>
             <a:endParaRPr lang="en-US" dirty="0"/>
           </a:p>
@@ -3652,7 +4033,7 @@
           <a:p>
             <a:fld id="{F7021451-1387-4CA6-816F-3879F97B5CBC}" type="slidenum">
               <a:rPr lang="en-US"/>
-              <a:t>39</a:t>
+              <a:t>41</a:t>
             </a:fld>
             <a:endParaRPr lang="en-US"/>
           </a:p>
@@ -3671,7 +4052,7 @@
 </p:notes>
 </file>
 
-<file path=ppt/notesSlides/notesSlide4.xml><?xml version="1.0" encoding="utf-8"?>
+<file path=ppt/notesSlides/notesSlide42.xml><?xml version="1.0" encoding="utf-8"?>
 <p:notes xmlns:a="http://schemas.openxmlformats.org/drawingml/2006/main" xmlns:r="http://schemas.openxmlformats.org/officeDocument/2006/relationships" xmlns:p="http://schemas.openxmlformats.org/presentationml/2006/main">
   <p:cSld>
     <p:spTree>
@@ -3717,15 +4098,16 @@
           <a:p>
             <a:r>
               <a:rPr lang="en-US" dirty="0"/>
-              <a:t>Three negatives, and each one is a design decision somebody made rather than a
-limitation of the model.
-The third is the one that surprises people: there is no memory between
-sessions. Continuity is the harness resending the history, which is why
-history spends their token budget later in the deck.
-The 4B and the 9B are asked for different reply shapes, whole files against
-diffs. That is why a classmate's session looks different from theirs, and why
-the trace they see later may not match what they ran in practice.
-Worth saying here, not worth a slide.</a:t>
+              <a:t>The bridge, and the end of the taught half. Six steps, and today they followed
+one request through all of them. Every tool of this kind, whatever its name and
+whoever makes it, runs the same six.
+Ask the room which of the six belonged to the model. One: the answer. At every
+other step the thing that decided what happened next was them, or a rule
+somebody wrote down in advance.
+Then leave the bold line up and do not answer it. Tomorrow's lecture opens on
+exactly this question, has a live demo for it, and spends ninety minutes on the
+answer. Saying more here spoils it; saying this much is what makes tomorrow land.
+This is the last slide before office hours. Leave the question up.</a:t>
             </a:r>
             <a:endParaRPr lang="en-US" dirty="0"/>
           </a:p>
@@ -3748,7 +4130,7 @@
           <a:p>
             <a:fld id="{F7021451-1387-4CA6-816F-3879F97B5CBC}" type="slidenum">
               <a:rPr lang="en-US"/>
-              <a:t>4</a:t>
+              <a:t>42</a:t>
             </a:fld>
             <a:endParaRPr lang="en-US"/>
           </a:p>
@@ -3767,7 +4149,7 @@
 </p:notes>
 </file>
 
-<file path=ppt/notesSlides/notesSlide40.xml><?xml version="1.0" encoding="utf-8"?>
+<file path=ppt/notesSlides/notesSlide43.xml><?xml version="1.0" encoding="utf-8"?>
 <p:notes xmlns:a="http://schemas.openxmlformats.org/drawingml/2006/main" xmlns:r="http://schemas.openxmlformats.org/officeDocument/2006/relationships" xmlns:p="http://schemas.openxmlformats.org/presentationml/2006/main">
   <p:cSld>
     <p:spTree>
@@ -3839,7 +4221,7 @@
           <a:p>
             <a:fld id="{F7021451-1387-4CA6-816F-3879F97B5CBC}" type="slidenum">
               <a:rPr lang="en-US"/>
-              <a:t>40</a:t>
+              <a:t>43</a:t>
             </a:fld>
             <a:endParaRPr lang="en-US"/>
           </a:p>
@@ -3858,7 +4240,7 @@
 </p:notes>
 </file>
 
-<file path=ppt/notesSlides/notesSlide41.xml><?xml version="1.0" encoding="utf-8"?>
+<file path=ppt/notesSlides/notesSlide44.xml><?xml version="1.0" encoding="utf-8"?>
 <p:notes xmlns:a="http://schemas.openxmlformats.org/drawingml/2006/main" xmlns:r="http://schemas.openxmlformats.org/officeDocument/2006/relationships" xmlns:p="http://schemas.openxmlformats.org/presentationml/2006/main">
   <p:cSld>
     <p:spTree>
@@ -3927,7 +4309,7 @@
           <a:p>
             <a:fld id="{F7021451-1387-4CA6-816F-3879F97B5CBC}" type="slidenum">
               <a:rPr lang="en-US"/>
-              <a:t>41</a:t>
+              <a:t>44</a:t>
             </a:fld>
             <a:endParaRPr lang="en-US"/>
           </a:p>
@@ -3992,11 +4374,18 @@
           <a:p>
             <a:r>
               <a:rPr lang="en-US" dirty="0"/>
-              <a:t>Two commands in the whole set touch the repository, and one of those is the
-undo. That asymmetry is the approval layer they are about to build, visible in
-a tool they already use.
-/help lists more than this and the set moves between versions. Run it live if
-asked rather than reciting.</a:t>
+              <a:t>Reworked 2026-09-13 on instructor direction; the two-column table it replaces
+read as confusing. Three cards in the order a turn happens, and the middle one
+is the model's whole contribution.
+The two column headings of the last slide are the two blue cards. Assemble is
+what goes in front of the model. Apply is what is done with the reply. Say the
+three words out loud: the last slide of the taught half adds three more to
+them and asks which of the six belonged to the model. One, the answer.
+Every effect on their machine is a blue card acting on the amber one's text.
+That is the sentence the rest of the lab depends on.
+If anyone asks about models, endpoints or config: MODEL-POLICY.md, and it is
+not today's subject. qwen3.5:9b recommended, 4B permitted, any compatible
+endpoint.</a:t>
             </a:r>
             <a:endParaRPr lang="en-US" dirty="0"/>
           </a:p>
@@ -4084,13 +4473,16 @@
           <a:p>
             <a:r>
               <a:rPr lang="en-US" dirty="0"/>
-              <a:t>Cut back hard on 2026-09-13. L02 and L03 already taught the window, the four
-sources that fill it, surgical selection and /tokens, and this block used to
-repeat all of it. What is left is the part they have not met: the repo map, and
-what happens to the budget as a session runs long.
-So do not re-teach context here. One sentence to reconnect it, that only the
-reply belongs to the model and everything else is the harness choosing what the
-model gets to see, and then straight into the map.</a:t>
+              <a:t>Three negatives, and each one is a design decision somebody made rather than a
+limitation of the model.
+The third is the one that surprises people: there is no memory between
+sessions. Continuity is the harness resending the history, which is why
+history spends their token budget later in the deck, and why ChatGPT seeming
+to remember them, two slides back, was its harness keeping notes.
+The 4B and the 9B are asked for different reply shapes, whole files against
+diffs. That is why a classmate's session looks different from theirs, and why
+the trace they see later may not match what they ran in practice.
+Worth saying here, not worth a slide.</a:t>
             </a:r>
             <a:endParaRPr lang="en-US" dirty="0"/>
           </a:p>
@@ -4178,8 +4570,13 @@
           <a:p>
             <a:r>
               <a:rPr lang="en-US" dirty="0"/>
-              <a:t>Ask the room to find the arrow that writes a file. There is not one leaving the
-amber box. The model produced text, and a program decided what to do with it.
+              <a:t>The definition, drawn for the tool in hand. Ask the room to find the arrow that
+writes a file. There is not one leaving the amber box. The model produced text,
+and a program decided what to do with it.
+Three boxes inside the Aider band, and they are the three cards with the commit
+added: assemble the request, parse and apply the reply, record it. The next
+three slides are the middle box: what a reply looks like, and what the harness
+has to recover from it.
 This is a picture of Aider, not a required architecture for their build. They
 will draw their own version of this in a week.</a:t>
             </a:r>
@@ -4269,10 +4666,11 @@
           <a:p>
             <a:r>
               <a:rPr lang="en-US" dirty="0"/>
-              <a:t>Point at the vertical bars: that is aider quoting source lines. Point at the
-dots: that is everything it decided not to spend tokens on.
-Ask what this is for. The answer is on the next slide: it is aider guessing
-what you would have typed /add for.</a:t>
+              <a:t>Ask what a block like this does not tell you. It names one file. A change that
+needs three files needs three blocks, and nothing in the format obliges the
+model to produce all three. A student who reads one well-formed block sees a
+finished feature.
+Nothing has changed on disk yet. This is a proposal in a chat reply.</a:t>
             </a:r>
             <a:endParaRPr lang="en-US" dirty="0"/>
           </a:p>
@@ -4360,13 +4758,19 @@
           <a:p>
             <a:r>
               <a:rPr lang="en-US" dirty="0"/>
-              <a:t>Off the slide and worth saying: the ranking is tilted toward files you just
-mentioned, and aider renders down the list until the tokens run out.
-Say the ranking rule plainly: a file that lots of other files depend on scores
-high, because it is probably the one you need to know about.
-The dashed line is the point. It is not "here is your repo," it is "here is as
-much of your repo as fits," and whatever falls under the line is invisible to
-the model. 867 lines of aider to guess what you would have typed /add for.</a:t>
+              <a:t>Added 2026-09-13, late, on instructor direction for more substance. The last
+slide showed one shape. This is the other, and it is the one most of them have
+been running: the practice settings file gives the 4B and the 9B
+`edit_format: whole`, with "try: diff" on the 9B.
+Whole is reliable on a small model because there is nothing to match, and
+expensive because every edit resends the whole file. It fails by omission: the
+model rewrites the file and quietly drops a line it was not thinking about,
+which is what the L01 demo's first prompt did and nobody noticed. Diff is cheap
+and fails loudly: the search text has to match the disk exactly, and when it
+does not, the block is refused and the model is told so.
+The bold line is the point. The shape is not a property of the model. It is
+one line in a settings file the harness reads, and their build makes the same
+choice when it decides what a reply has to look like.</a:t>
             </a:r>
             <a:endParaRPr lang="en-US" dirty="0"/>
           </a:p>
@@ -6083,6 +6487,123 @@
 <file path=ppt/slides/slide41.xml><?xml version="1.0" encoding="utf-8"?>
 <p:sld xmlns:a="http://schemas.openxmlformats.org/drawingml/2006/main" xmlns:r="http://schemas.openxmlformats.org/officeDocument/2006/relationships" xmlns:p="http://schemas.openxmlformats.org/presentationml/2006/main">
   <p:cSld name="Slide 41">
+    <p:bg>
+      <p:bgPr>
+        <a:blipFill dpi="0" rotWithShape="1">
+          <a:blip r:embed="rId1">
+            <a:lum/>
+          </a:blip>
+          <a:srcRect/>
+          <a:stretch>
+            <a:fillRect/>
+          </a:stretch>
+        </a:blipFill>
+        <a:effectLst/>
+      </p:bgPr>
+    </p:bg>
+    <p:spTree>
+      <p:nvGrpSpPr>
+        <p:cNvPr id="1" name=""/>
+        <p:cNvGrpSpPr/>
+        <p:nvPr/>
+      </p:nvGrpSpPr>
+      <p:grpSpPr>
+        <a:xfrm>
+          <a:off x="0" y="0"/>
+          <a:ext cx="0" cy="0"/>
+          <a:chOff x="0" y="0"/>
+          <a:chExt cx="0" cy="0"/>
+        </a:xfrm>
+      </p:grpSpPr>
+    </p:spTree>
+  </p:cSld>
+  <p:clrMapOvr>
+    <a:masterClrMapping/>
+  </p:clrMapOvr>
+</p:sld>
+</file>
+
+<file path=ppt/slides/slide42.xml><?xml version="1.0" encoding="utf-8"?>
+<p:sld xmlns:a="http://schemas.openxmlformats.org/drawingml/2006/main" xmlns:r="http://schemas.openxmlformats.org/officeDocument/2006/relationships" xmlns:p="http://schemas.openxmlformats.org/presentationml/2006/main">
+  <p:cSld name="Slide 42">
+    <p:bg>
+      <p:bgPr>
+        <a:blipFill dpi="0" rotWithShape="1">
+          <a:blip r:embed="rId1">
+            <a:lum/>
+          </a:blip>
+          <a:srcRect/>
+          <a:stretch>
+            <a:fillRect/>
+          </a:stretch>
+        </a:blipFill>
+        <a:effectLst/>
+      </p:bgPr>
+    </p:bg>
+    <p:spTree>
+      <p:nvGrpSpPr>
+        <p:cNvPr id="1" name=""/>
+        <p:cNvGrpSpPr/>
+        <p:nvPr/>
+      </p:nvGrpSpPr>
+      <p:grpSpPr>
+        <a:xfrm>
+          <a:off x="0" y="0"/>
+          <a:ext cx="0" cy="0"/>
+          <a:chOff x="0" y="0"/>
+          <a:chExt cx="0" cy="0"/>
+        </a:xfrm>
+      </p:grpSpPr>
+    </p:spTree>
+  </p:cSld>
+  <p:clrMapOvr>
+    <a:masterClrMapping/>
+  </p:clrMapOvr>
+</p:sld>
+</file>
+
+<file path=ppt/slides/slide43.xml><?xml version="1.0" encoding="utf-8"?>
+<p:sld xmlns:a="http://schemas.openxmlformats.org/drawingml/2006/main" xmlns:r="http://schemas.openxmlformats.org/officeDocument/2006/relationships" xmlns:p="http://schemas.openxmlformats.org/presentationml/2006/main">
+  <p:cSld name="Slide 43">
+    <p:bg>
+      <p:bgPr>
+        <a:blipFill dpi="0" rotWithShape="1">
+          <a:blip r:embed="rId1">
+            <a:lum/>
+          </a:blip>
+          <a:srcRect/>
+          <a:stretch>
+            <a:fillRect/>
+          </a:stretch>
+        </a:blipFill>
+        <a:effectLst/>
+      </p:bgPr>
+    </p:bg>
+    <p:spTree>
+      <p:nvGrpSpPr>
+        <p:cNvPr id="1" name=""/>
+        <p:cNvGrpSpPr/>
+        <p:nvPr/>
+      </p:nvGrpSpPr>
+      <p:grpSpPr>
+        <a:xfrm>
+          <a:off x="0" y="0"/>
+          <a:ext cx="0" cy="0"/>
+          <a:chOff x="0" y="0"/>
+          <a:chExt cx="0" cy="0"/>
+        </a:xfrm>
+      </p:grpSpPr>
+    </p:spTree>
+  </p:cSld>
+  <p:clrMapOvr>
+    <a:masterClrMapping/>
+  </p:clrMapOvr>
+</p:sld>
+</file>
+
+<file path=ppt/slides/slide44.xml><?xml version="1.0" encoding="utf-8"?>
+<p:sld xmlns:a="http://schemas.openxmlformats.org/drawingml/2006/main" xmlns:r="http://schemas.openxmlformats.org/officeDocument/2006/relationships" xmlns:p="http://schemas.openxmlformats.org/presentationml/2006/main">
+  <p:cSld name="Slide 44">
     <p:bg>
       <p:bgPr>
         <a:blipFill dpi="0" rotWithShape="1">

</xml_diff>

<commit_message>
Lab01: closing section opens on autonomy and the tiers
Claude-Session: https://claude.ai/code/session_01L8CTxHxvnQoTgLJ1mMqNbK
</commit_message>
<xml_diff>
--- a/labs/Lab01/slides.pptx
+++ b/labs/Lab01/slides.pptx
@@ -48,10 +48,9 @@
     <p:sldId id="296" r:id="rId42"/>
     <p:sldId id="297" r:id="rId43"/>
     <p:sldId id="298" r:id="rId44"/>
-    <p:sldId id="299" r:id="rId45"/>
   </p:sldIdLst>
   <p:notesMasterIdLst>
-    <p:notesMasterId r:id="rId46"/>
+    <p:notesMasterId r:id="rId45"/>
   </p:notesMasterIdLst>
   <p:sldSz cx="9334500" cy="5248275"/>
   <p:notesSz cx="5248275" cy="9334500"/>
@@ -3391,18 +3390,20 @@
           <a:p>
             <a:r>
               <a:rPr lang="en-US" dirty="0"/>
-              <a:t>Combined 2026-09-13, late, on instructor direction, from "Why this tool" and
-"What comes next", and titled as the combination. He found himself saying the
-last section's content during this one. One arc now, six slides, past to
-future. "The part you own" was cut on instruction later the same night. Where the field started.
-Aider is good to learn on. The models are weak on purpose. One repository to
-December. You will know how Claude Code works. The same loop
-with more machinery, which ends on the question L05 opens with.
+              <a:t>Rewritten 2026-09-15 on instructor direction. The old opening of this section
+argued for Aider and for the weak models, and both arguments had already been
+made in L01 to L04, so those three slides are gone: "This is where the field
+started", "Aider is good to learn on" and "The models are weak on purpose".
+The section now opens on autonomy: what a harness decides, how much of that
+the model has been handed since 2023, and the fact that this course climbs
+those tiers in one repository. The three slides after that were kept and
+tightened.
+Five slides. What a harness decides, and who got to decide it in 2023 against
+2025. The three tiers, and that they are built here in order. One repository
+to December. You will know how Claude Code works. The same loop with more
+machinery, ending on what is left for L05.
 Each slide's notes end with a "Next:" line saying what the following slide
-carries, so nothing gets said a slide early. The order is the talk: this is
-where it started, it is the one to learn on, the weak models are deliberate,
-that harness grows through three phases, it ends up Claude Code-shaped and you will know why, and one question
-is left open for tomorrow.</a:t>
+carries, so nothing gets said a slide early.</a:t>
             </a:r>
             <a:endParaRPr lang="en-US" dirty="0"/>
           </a:p>
@@ -3490,18 +3491,17 @@
           <a:p>
             <a:r>
               <a:rPr lang="en-US" dirty="0"/>
-              <a:t>L01's four waves, compressed to the two that matter here. Aider and Cursor are
-the first generation of tools where the model edits files rather than pasting
-into a chat. Claude Code and Codex came two years later and run the same loop
-with far more of it automated.
-The third row is the reason for the first two. Aider is open source and still
-runs the original loop, so the whole thing is readable: the repo map they saw
-earlier is under nine hundred lines. Nothing about the tool everyone talks
-about is that inspectable.
-Do not say what "most of it automated" means. That is the closing slide's
-question and L05's lecture.
-Next: the four decisions you can see in Aider. Do not list them here; the
-row that says Aider is readable is enough.</a:t>
+              <a:t>Every row is a decision the harness makes, and the two columns are who it lets
+make it. Read the middle column first: in Aider they made every one of these
+themselves for two weeks, and the model's contribution was one block of text.
+Then the right column: the same four decisions, and at each one the harness
+now lets the model choose and checks the choice against a rule.
+That is what "more autonomous" means, and it is where the complexity and the
+power of a 2025 harness live. The model on the right is often the same model
+as on the left. What changed is how much of its own turn it gets to decide.
+Do not say how a harness lets the model pick the next action, or what that
+costs. L05 spends ninety minutes on exactly that, with a live demo.
+Next: the tiers, and that they are built here in order.</a:t>
             </a:r>
             <a:endParaRPr lang="en-US" dirty="0"/>
           </a:p>
@@ -3589,19 +3589,18 @@
           <a:p>
             <a:r>
               <a:rPr lang="en-US" dirty="0"/>
-              <a:t>Four decisions every harness makes, and for each one the moment in the last two
-weeks when they made it or watched it. That is the whole pedagogical case, and
-the headline now says it rather than implying it: Aider is not the best tool,
-it is the one where the joins show, and that is what makes it the one to learn
-on.
-The bold line is the argument against starting on a more automated tool. It
-would make the same four decisions, and they would never see any of them, so
-they would leave knowing how to use it and not how it works. This course is
-about how it works, because in three weeks they have to write one.
-If someone says the more automated tool is better: agree. It is. That is a
-different claim from being better to learn on, and the next slide is about what
-the difference costs.
-Next: the weak models. Do not defend the 4B here; the next slide does.</a:t>
+              <a:t>The three tiers are the three phases, and the order is the order harnesses
+grew in. Tier 1 is the build they are reading about this week: they choose
+what the model sees, and nothing touches disk until they say yes. Tier 2 moves
+one decision, the next action, from them to the model, and the price of that
+move is an approval layer they have to write. Tier 3 is what makes it usable
+day after day: memory, hardening, more than one way in.
+The bold line is the design of the course. The model does not grow between
+now and December, so nothing they gain in autonomy comes from a bigger model.
+It comes from harness code in their own repository. That is also why the
+model is one config line and the harness is the product.
+Next: the same three tiers as a timeline, with what each adds in code. Do
+not walk the phases here; the next slide does.</a:t>
             </a:r>
             <a:endParaRPr lang="en-US" dirty="0"/>
           </a:p>
@@ -3689,20 +3688,18 @@
           <a:p>
             <a:r>
               <a:rPr lang="en-US" dirty="0"/>
-              <a:t>The direct version of something the course has only implied. Most people who
-have decided AI cannot code met a weak model with no context management and a
-vague prompt, and drew a conclusion. That is the setup every student in this
-room has run sixteen times, and L03 gave them three words for what went wrong.
-So they can now reproduce the skeptic's experience on demand and say which
-lever was set wrong. A frontier model would not have taught them that, because
-it hides the same failures behind polish and they happen less often.
-The 4B fails in the practice lessons on purpose. It is weak enough to punish a
-sloppy context or a vague ask immediately, which is how the habit lands. The
-next slide is why none of that is baked in: the model is one config line.
-Next: the arc to December. The weak model is the setup, the growing
-repository is the payoff, so stop at the bold line and let the timeline say
-it. If the room needs it, one sentence: the model is one config line and the
-harness is theirs; there is no longer a slide for that.</a:t>
+              <a:t>Walk the timeline left to right and say what each dot adds in code: tier 1 is
+the loop, exact edits and git they build this month; tier 2 is tools the model
+chooses and the approval layer that gates them; tier 3 is state that survives
+a run, hardening, and another way in.
+Build advice that used to sit on this slide and still belongs in the room: one
+small checkable result first, and keep the phase snapshots.
+The 2023-against-2025 table two slides back is as far as the tool comparison
+goes in this lab. L05 has the live demo; do not reconstruct it here.
+Do not estimate the workload out loud. Do say that a runnable slice early is
+what keeps the December integration from being a surprise.
+Next: the destination, named. Do not say Claude Code on this slide. The dots
+are Apply, Analyze and Create, and the next slide says what they add up to.</a:t>
             </a:r>
             <a:endParaRPr lang="en-US" dirty="0"/>
           </a:p>
@@ -3895,105 +3892,6 @@
           <a:p>
             <a:r>
               <a:rPr lang="en-US" dirty="0"/>
-              <a:t>Walk the timeline left to right and say what changes at each dot: first the
-human is in the loop, then the model picks the tools, then it keeps state and
-survives contact with real work.
-Build advice that used to sit on this slide and still belongs in the room: one
-small checkable result first, and keep the phase snapshots.
-The Aider versus agentic CLI comparison that used to follow this slide is gone,
-because L05 delivers exactly that the next day with a live demo behind it. Do
-not reconstruct it here.
-Do not estimate the workload out loud. Do say that a runnable slice early is
-what keeps the December integration from being a surprise.
-Next: the destination, named. Do not say Claude Code on this slide. The dots
-are Apply, Analyze and Create, and the next slide says what they add up to.</a:t>
-            </a:r>
-            <a:endParaRPr lang="en-US" dirty="0"/>
-          </a:p>
-        </p:txBody>
-      </p:sp>
-      <p:sp>
-        <p:nvSpPr>
-          <p:cNvPr id="4" name="Slide Number Placeholder 3"/>
-          <p:cNvSpPr>
-            <a:spLocks noGrp="1"/>
-          </p:cNvSpPr>
-          <p:nvPr>
-            <p:ph type="sldNum" sz="quarter" idx="10"/>
-          </p:nvPr>
-        </p:nvSpPr>
-        <p:spPr/>
-        <p:txBody>
-          <a:bodyPr/>
-          <a:lstStyle/>
-          <a:p>
-            <a:fld id="{F7021451-1387-4CA6-816F-3879F97B5CBC}" type="slidenum">
-              <a:rPr lang="en-US"/>
-              <a:t>40</a:t>
-            </a:fld>
-            <a:endParaRPr lang="en-US"/>
-          </a:p>
-        </p:txBody>
-      </p:sp>
-    </p:spTree>
-    <p:extLst>
-      <p:ext uri="{BB962C8B-B14F-4D97-AF65-F5344CB8AC3E}">
-        <p14:creationId xmlns:p14="http://schemas.microsoft.com/office/powerpoint/2010/main" val="1024086991"/>
-      </p:ext>
-    </p:extLst>
-  </p:cSld>
-  <p:clrMapOvr>
-    <a:masterClrMapping/>
-  </p:clrMapOvr>
-</p:notes>
-</file>
-
-<file path=ppt/notesSlides/notesSlide41.xml><?xml version="1.0" encoding="utf-8"?>
-<p:notes xmlns:a="http://schemas.openxmlformats.org/drawingml/2006/main" xmlns:r="http://schemas.openxmlformats.org/officeDocument/2006/relationships" xmlns:p="http://schemas.openxmlformats.org/presentationml/2006/main">
-  <p:cSld>
-    <p:spTree>
-      <p:nvGrpSpPr>
-        <p:cNvPr id="1" name=""/>
-        <p:cNvGrpSpPr/>
-        <p:nvPr/>
-      </p:nvGrpSpPr>
-      <p:grpSpPr>
-        <a:xfrm>
-          <a:off x="0" y="0"/>
-          <a:ext cx="0" cy="0"/>
-          <a:chOff x="0" y="0"/>
-          <a:chExt cx="0" cy="0"/>
-        </a:xfrm>
-      </p:grpSpPr>
-      <p:sp>
-        <p:nvSpPr>
-          <p:cNvPr id="2" name="Slide Image Placeholder 1"/>
-          <p:cNvSpPr>
-            <a:spLocks noGrp="1" noRot="1" noChangeAspect="1"/>
-          </p:cNvSpPr>
-          <p:nvPr>
-            <p:ph type="sldImg"/>
-          </p:nvPr>
-        </p:nvSpPr>
-        <p:spPr/>
-      </p:sp>
-      <p:sp>
-        <p:nvSpPr>
-          <p:cNvPr id="3" name="Notes Placeholder 2"/>
-          <p:cNvSpPr>
-            <a:spLocks noGrp="1"/>
-          </p:cNvSpPr>
-          <p:nvPr>
-            <p:ph type="body" idx="1"/>
-          </p:nvPr>
-        </p:nvSpPr>
-        <p:spPr/>
-        <p:txBody>
-          <a:bodyPr/>
-          <a:lstStyle/>
-          <a:p>
-            <a:r>
-              <a:rPr lang="en-US" dirty="0"/>
               <a:t>Merged 2026-09-13, late, from "You will know how Claude Code works" and "The
 harness by December", on the instructor's reading that he was saying this
 slide's content a section early. There is now one place in the deck that
@@ -4033,7 +3931,7 @@
           <a:p>
             <a:fld id="{F7021451-1387-4CA6-816F-3879F97B5CBC}" type="slidenum">
               <a:rPr lang="en-US"/>
-              <a:t>41</a:t>
+              <a:t>40</a:t>
             </a:fld>
             <a:endParaRPr lang="en-US"/>
           </a:p>
@@ -4052,7 +3950,7 @@
 </p:notes>
 </file>
 
-<file path=ppt/notesSlides/notesSlide42.xml><?xml version="1.0" encoding="utf-8"?>
+<file path=ppt/notesSlides/notesSlide41.xml><?xml version="1.0" encoding="utf-8"?>
 <p:notes xmlns:a="http://schemas.openxmlformats.org/drawingml/2006/main" xmlns:r="http://schemas.openxmlformats.org/officeDocument/2006/relationships" xmlns:p="http://schemas.openxmlformats.org/presentationml/2006/main">
   <p:cSld>
     <p:spTree>
@@ -4101,13 +3999,14 @@
               <a:t>The bridge, and the end of the taught half. Six steps, and today they followed
 one request through all of them. Every tool of this kind, whatever its name and
 whoever makes it, runs the same six.
-Ask the room which of the six belonged to the model. One: the answer. At every
-other step the thing that decided what happened next was them, or a rule
-somebody wrote down in advance.
-Then leave the bold line up and do not answer it. Tomorrow's lecture opens on
-exactly this question, has a live demo for it, and spends ninety minutes on the
-answer. Saying more here spoils it; saying this much is what makes tomorrow land.
-This is the last slide before office hours. Leave the question up.</a:t>
+Ask the room which of the six belonged to the model in their own sessions.
+One: the answer. At every other step the thing that decided what happened
+next was them, or a rule somebody wrote down in advance.
+Then leave the bold line up. The autonomy slide already said that at tier 2
+the model picks the next action. What this deck has not said is how a harness
+makes that possible and what it costs, and L05 opens on exactly that with a
+live demo. Saying more here spoils it.
+This is the last slide before office hours. Leave the line up.</a:t>
             </a:r>
             <a:endParaRPr lang="en-US" dirty="0"/>
           </a:p>
@@ -4130,7 +4029,7 @@
           <a:p>
             <a:fld id="{F7021451-1387-4CA6-816F-3879F97B5CBC}" type="slidenum">
               <a:rPr lang="en-US"/>
-              <a:t>42</a:t>
+              <a:t>41</a:t>
             </a:fld>
             <a:endParaRPr lang="en-US"/>
           </a:p>
@@ -4149,7 +4048,7 @@
 </p:notes>
 </file>
 
-<file path=ppt/notesSlides/notesSlide43.xml><?xml version="1.0" encoding="utf-8"?>
+<file path=ppt/notesSlides/notesSlide42.xml><?xml version="1.0" encoding="utf-8"?>
 <p:notes xmlns:a="http://schemas.openxmlformats.org/drawingml/2006/main" xmlns:r="http://schemas.openxmlformats.org/officeDocument/2006/relationships" xmlns:p="http://schemas.openxmlformats.org/presentationml/2006/main">
   <p:cSld>
     <p:spTree>
@@ -4221,7 +4120,7 @@
           <a:p>
             <a:fld id="{F7021451-1387-4CA6-816F-3879F97B5CBC}" type="slidenum">
               <a:rPr lang="en-US"/>
-              <a:t>43</a:t>
+              <a:t>42</a:t>
             </a:fld>
             <a:endParaRPr lang="en-US"/>
           </a:p>
@@ -4240,7 +4139,7 @@
 </p:notes>
 </file>
 
-<file path=ppt/notesSlides/notesSlide44.xml><?xml version="1.0" encoding="utf-8"?>
+<file path=ppt/notesSlides/notesSlide43.xml><?xml version="1.0" encoding="utf-8"?>
 <p:notes xmlns:a="http://schemas.openxmlformats.org/drawingml/2006/main" xmlns:r="http://schemas.openxmlformats.org/officeDocument/2006/relationships" xmlns:p="http://schemas.openxmlformats.org/presentationml/2006/main">
   <p:cSld>
     <p:spTree>
@@ -4309,7 +4208,7 @@
           <a:p>
             <a:fld id="{F7021451-1387-4CA6-816F-3879F97B5CBC}" type="slidenum">
               <a:rPr lang="en-US"/>
-              <a:t>44</a:t>
+              <a:t>43</a:t>
             </a:fld>
             <a:endParaRPr lang="en-US"/>
           </a:p>
@@ -6565,45 +6464,6 @@
 <file path=ppt/slides/slide43.xml><?xml version="1.0" encoding="utf-8"?>
 <p:sld xmlns:a="http://schemas.openxmlformats.org/drawingml/2006/main" xmlns:r="http://schemas.openxmlformats.org/officeDocument/2006/relationships" xmlns:p="http://schemas.openxmlformats.org/presentationml/2006/main">
   <p:cSld name="Slide 43">
-    <p:bg>
-      <p:bgPr>
-        <a:blipFill dpi="0" rotWithShape="1">
-          <a:blip r:embed="rId1">
-            <a:lum/>
-          </a:blip>
-          <a:srcRect/>
-          <a:stretch>
-            <a:fillRect/>
-          </a:stretch>
-        </a:blipFill>
-        <a:effectLst/>
-      </p:bgPr>
-    </p:bg>
-    <p:spTree>
-      <p:nvGrpSpPr>
-        <p:cNvPr id="1" name=""/>
-        <p:cNvGrpSpPr/>
-        <p:nvPr/>
-      </p:nvGrpSpPr>
-      <p:grpSpPr>
-        <a:xfrm>
-          <a:off x="0" y="0"/>
-          <a:ext cx="0" cy="0"/>
-          <a:chOff x="0" y="0"/>
-          <a:chExt cx="0" cy="0"/>
-        </a:xfrm>
-      </p:grpSpPr>
-    </p:spTree>
-  </p:cSld>
-  <p:clrMapOvr>
-    <a:masterClrMapping/>
-  </p:clrMapOvr>
-</p:sld>
-</file>
-
-<file path=ppt/slides/slide44.xml><?xml version="1.0" encoding="utf-8"?>
-<p:sld xmlns:a="http://schemas.openxmlformats.org/drawingml/2006/main" xmlns:r="http://schemas.openxmlformats.org/officeDocument/2006/relationships" xmlns:p="http://schemas.openxmlformats.org/presentationml/2006/main">
-  <p:cSld name="Slide 44">
     <p:bg>
       <p:bgPr>
         <a:blipFill dpi="0" rotWithShape="1">

</xml_diff>

<commit_message>
Lab01: the tiers slide is Project milestones, M1 to M3
Claude-Session: https://claude.ai/code/session_01L8CTxHxvnQoTgLJ1mMqNbK
</commit_message>
<xml_diff>
--- a/labs/Lab01/slides.pptx
+++ b/labs/Lab01/slides.pptx
@@ -3395,11 +3395,11 @@
 made in L01 to L04, so those three slides are gone: "This is where the field
 started", "Aider is good to learn on" and "The models are weak on purpose".
 The section now opens on autonomy: what a harness decides, how much of that
-the model has been handed since 2023, and the fact that this course climbs
-those tiers in one repository. The three slides after that were kept and
+the model has been handed since 2023, and the fact that this course reaches
+those milestones in one repository. The three slides after that were kept and
 tightened.
 Five slides. What a harness decides, and who got to decide it in 2023 against
-2025. The three tiers, and that they are built here in order. One repository
+2025. The three milestones, M1 to M3, built here in order. One repository
 to December. You will know how Claude Code works. The same loop with more
 machinery, ending on what is left for L05.
 Each slide's notes end with a "Next:" line saying what the following slide
@@ -3501,7 +3501,7 @@
 as on the left. What changed is how much of its own turn it gets to decide.
 Do not say how a harness lets the model pick the next action, or what that
 costs. L05 spends ninety minutes on exactly that, with a live demo.
-Next: the tiers, and that they are built here in order.</a:t>
+Next: the milestones, M1 to M3, built here in order.</a:t>
             </a:r>
             <a:endParaRPr lang="en-US" dirty="0"/>
           </a:p>
@@ -3589,17 +3589,17 @@
           <a:p>
             <a:r>
               <a:rPr lang="en-US" dirty="0"/>
-              <a:t>The three tiers are the three phases, and the order is the order harnesses
-grew in. Tier 1 is the build they are reading about this week: they choose
-what the model sees, and nothing touches disk until they say yes. Tier 2 moves
+              <a:t>The three milestones are the three phases, and the order is the order harnesses
+grew in. M1 is the build they are reading about this week: they choose
+what the model sees, and nothing touches disk until they say yes. M2 moves
 one decision, the next action, from them to the model, and the price of that
-move is an approval layer they have to write. Tier 3 is what makes it usable
+move is an approval layer they have to write. M3 is what makes it usable
 day after day: memory, hardening, more than one way in.
 The bold line is the design of the course. The model does not grow between
 now and December, so nothing they gain in autonomy comes from a bigger model.
 It comes from harness code in their own repository. That is also why the
 model is one config line and the harness is the product.
-Next: the same three tiers as a timeline, with what each adds in code. Do
+Next: the same three milestones as a timeline, with what each adds in code. Do
 not walk the phases here; the next slide does.</a:t>
             </a:r>
             <a:endParaRPr lang="en-US" dirty="0"/>
@@ -3688,9 +3688,9 @@
           <a:p>
             <a:r>
               <a:rPr lang="en-US" dirty="0"/>
-              <a:t>Walk the timeline left to right and say what each dot adds in code: tier 1 is
-the loop, exact edits and git they build this month; tier 2 is tools the model
-chooses and the approval layer that gates them; tier 3 is state that survives
+              <a:t>Walk the timeline left to right and say what each dot adds in code: M1 is
+the loop, exact edits and git they build this month; M2 is tools the model
+chooses and the approval layer that gates them; M3 is state that survives
 a run, hardening, and another way in.
 Build advice that used to sit on this slide and still belongs in the room: one
 small checkable result first, and keep the phase snapshots.
@@ -4002,7 +4002,7 @@
 Ask the room which of the six belonged to the model in their own sessions.
 One: the answer. At every other step the thing that decided what happened
 next was them, or a rule somebody wrote down in advance.
-Then leave the bold line up. The autonomy slide already said that at tier 2
+Then leave the bold line up. The autonomy slide already said that at M2
 the model picks the next action. What this deck has not said is how a harness
 makes that possible and what it costs, and L05 opens on exactly that with a
 live demo. Saying more here spoils it.

</xml_diff>

<commit_message>
Lab01: fold the design artifacts into Specification before implementation
Claude-Session: https://claude.ai/code/session_01L8CTxHxvnQoTgLJ1mMqNbK
</commit_message>
<xml_diff>
--- a/labs/Lab01/slides.pptx
+++ b/labs/Lab01/slides.pptx
@@ -47,10 +47,9 @@
     <p:sldId id="295" r:id="rId41"/>
     <p:sldId id="296" r:id="rId42"/>
     <p:sldId id="297" r:id="rId43"/>
-    <p:sldId id="298" r:id="rId44"/>
   </p:sldIdLst>
   <p:notesMasterIdLst>
-    <p:notesMasterId r:id="rId45"/>
+    <p:notesMasterId r:id="rId44"/>
   </p:notesMasterIdLst>
   <p:sldSz cx="9334500" cy="5248275"/>
   <p:notesSz cx="5248275" cy="9334500"/>
@@ -2820,6 +2819,12 @@
 requirements, their own acceptance criteria, and their own increments.
 The history is evidence, not bureaucracy. A design committed after the code it
 describes earns nothing, and they cannot reconstruct it at the end.
+Row by row. The requirements have to cover the configuration and execution
+contracts as well as the seven features, with observable outcomes, edge cases
+and exclusions, and each one has to trace to an acceptance criterion of their
+own. The diagrams describe their system, not Aider: copying this morning's
+picture earns nothing, Mermaid is enough, and labels have to be legible and
+accurate. There is no length requirement anywhere in this section.
 An increment is not a commit and not a single change. It is a sizeable slice of
 the build that they break out and define themselves, with an observable result,
 its own scoped context and its own ordered tasks. Closest thing they have met is
@@ -2869,99 +2874,6 @@
 </file>
 
 <file path=ppt/notesSlides/notesSlide31.xml><?xml version="1.0" encoding="utf-8"?>
-<p:notes xmlns:a="http://schemas.openxmlformats.org/drawingml/2006/main" xmlns:r="http://schemas.openxmlformats.org/officeDocument/2006/relationships" xmlns:p="http://schemas.openxmlformats.org/presentationml/2006/main">
-  <p:cSld>
-    <p:spTree>
-      <p:nvGrpSpPr>
-        <p:cNvPr id="1" name=""/>
-        <p:cNvGrpSpPr/>
-        <p:nvPr/>
-      </p:nvGrpSpPr>
-      <p:grpSpPr>
-        <a:xfrm>
-          <a:off x="0" y="0"/>
-          <a:ext cx="0" cy="0"/>
-          <a:chOff x="0" y="0"/>
-          <a:chExt cx="0" cy="0"/>
-        </a:xfrm>
-      </p:grpSpPr>
-      <p:sp>
-        <p:nvSpPr>
-          <p:cNvPr id="2" name="Slide Image Placeholder 1"/>
-          <p:cNvSpPr>
-            <a:spLocks noGrp="1" noRot="1" noChangeAspect="1"/>
-          </p:cNvSpPr>
-          <p:nvPr>
-            <p:ph type="sldImg"/>
-          </p:nvPr>
-        </p:nvSpPr>
-        <p:spPr/>
-      </p:sp>
-      <p:sp>
-        <p:nvSpPr>
-          <p:cNvPr id="3" name="Notes Placeholder 2"/>
-          <p:cNvSpPr>
-            <a:spLocks noGrp="1"/>
-          </p:cNvSpPr>
-          <p:nvPr>
-            <p:ph type="body" idx="1"/>
-          </p:nvPr>
-        </p:nvSpPr>
-        <p:spPr/>
-        <p:txBody>
-          <a:bodyPr/>
-          <a:lstStyle/>
-          <a:p>
-            <a:r>
-              <a:rPr lang="en-US" dirty="0"/>
-              <a:t>Their requirements have to cover the configuration and execution contracts as
-well as the seven features, with observable outcomes, edge cases and exclusions,
-and each one has to trace to an acceptance criterion of their own.
-The diagrams describe their system, not Aider. Copying this morning's picture
-earns nothing. Mermaid is enough, labels have to be legible and accurate, and
-there is no length requirement anywhere in this section.</a:t>
-            </a:r>
-            <a:endParaRPr lang="en-US" dirty="0"/>
-          </a:p>
-        </p:txBody>
-      </p:sp>
-      <p:sp>
-        <p:nvSpPr>
-          <p:cNvPr id="4" name="Slide Number Placeholder 3"/>
-          <p:cNvSpPr>
-            <a:spLocks noGrp="1"/>
-          </p:cNvSpPr>
-          <p:nvPr>
-            <p:ph type="sldNum" sz="quarter" idx="10"/>
-          </p:nvPr>
-        </p:nvSpPr>
-        <p:spPr/>
-        <p:txBody>
-          <a:bodyPr/>
-          <a:lstStyle/>
-          <a:p>
-            <a:fld id="{F7021451-1387-4CA6-816F-3879F97B5CBC}" type="slidenum">
-              <a:rPr lang="en-US"/>
-              <a:t>31</a:t>
-            </a:fld>
-            <a:endParaRPr lang="en-US"/>
-          </a:p>
-        </p:txBody>
-      </p:sp>
-    </p:spTree>
-    <p:extLst>
-      <p:ext uri="{BB962C8B-B14F-4D97-AF65-F5344CB8AC3E}">
-        <p14:creationId xmlns:p14="http://schemas.microsoft.com/office/powerpoint/2010/main" val="1024086991"/>
-      </p:ext>
-    </p:extLst>
-  </p:cSld>
-  <p:clrMapOvr>
-    <a:masterClrMapping/>
-  </p:clrMapOvr>
-</p:notes>
-</file>
-
-<file path=ppt/notesSlides/notesSlide32.xml><?xml version="1.0" encoding="utf-8"?>
 <p:notes xmlns:a="http://schemas.openxmlformats.org/drawingml/2006/main" xmlns:r="http://schemas.openxmlformats.org/officeDocument/2006/relationships" xmlns:p="http://schemas.openxmlformats.org/presentationml/2006/main">
   <p:cSld>
     <p:spTree>
@@ -3037,7 +2949,7 @@
           <a:p>
             <a:fld id="{F7021451-1387-4CA6-816F-3879F97B5CBC}" type="slidenum">
               <a:rPr lang="en-US"/>
-              <a:t>32</a:t>
+              <a:t>31</a:t>
             </a:fld>
             <a:endParaRPr lang="en-US"/>
           </a:p>
@@ -3056,7 +2968,7 @@
 </p:notes>
 </file>
 
-<file path=ppt/notesSlides/notesSlide33.xml><?xml version="1.0" encoding="utf-8"?>
+<file path=ppt/notesSlides/notesSlide32.xml><?xml version="1.0" encoding="utf-8"?>
 <p:notes xmlns:a="http://schemas.openxmlformats.org/drawingml/2006/main" xmlns:r="http://schemas.openxmlformats.org/officeDocument/2006/relationships" xmlns:p="http://schemas.openxmlformats.org/presentationml/2006/main">
   <p:cSld>
     <p:spTree>
@@ -3140,7 +3052,7 @@
           <a:p>
             <a:fld id="{F7021451-1387-4CA6-816F-3879F97B5CBC}" type="slidenum">
               <a:rPr lang="en-US"/>
-              <a:t>33</a:t>
+              <a:t>32</a:t>
             </a:fld>
             <a:endParaRPr lang="en-US"/>
           </a:p>
@@ -3159,7 +3071,7 @@
 </p:notes>
 </file>
 
-<file path=ppt/notesSlides/notesSlide34.xml><?xml version="1.0" encoding="utf-8"?>
+<file path=ppt/notesSlides/notesSlide33.xml><?xml version="1.0" encoding="utf-8"?>
 <p:notes xmlns:a="http://schemas.openxmlformats.org/drawingml/2006/main" xmlns:r="http://schemas.openxmlformats.org/officeDocument/2006/relationships" xmlns:p="http://schemas.openxmlformats.org/presentationml/2006/main">
   <p:cSld>
     <p:spTree>
@@ -3233,7 +3145,7 @@
           <a:p>
             <a:fld id="{F7021451-1387-4CA6-816F-3879F97B5CBC}" type="slidenum">
               <a:rPr lang="en-US"/>
-              <a:t>34</a:t>
+              <a:t>33</a:t>
             </a:fld>
             <a:endParaRPr lang="en-US"/>
           </a:p>
@@ -3252,7 +3164,7 @@
 </p:notes>
 </file>
 
-<file path=ppt/notesSlides/notesSlide35.xml><?xml version="1.0" encoding="utf-8"?>
+<file path=ppt/notesSlides/notesSlide34.xml><?xml version="1.0" encoding="utf-8"?>
 <p:notes xmlns:a="http://schemas.openxmlformats.org/drawingml/2006/main" xmlns:r="http://schemas.openxmlformats.org/officeDocument/2006/relationships" xmlns:p="http://schemas.openxmlformats.org/presentationml/2006/main">
   <p:cSld>
     <p:spTree>
@@ -3325,7 +3237,7 @@
           <a:p>
             <a:fld id="{F7021451-1387-4CA6-816F-3879F97B5CBC}" type="slidenum">
               <a:rPr lang="en-US"/>
-              <a:t>35</a:t>
+              <a:t>34</a:t>
             </a:fld>
             <a:endParaRPr lang="en-US"/>
           </a:p>
@@ -3344,7 +3256,7 @@
 </p:notes>
 </file>
 
-<file path=ppt/notesSlides/notesSlide36.xml><?xml version="1.0" encoding="utf-8"?>
+<file path=ppt/notesSlides/notesSlide35.xml><?xml version="1.0" encoding="utf-8"?>
 <p:notes xmlns:a="http://schemas.openxmlformats.org/drawingml/2006/main" xmlns:r="http://schemas.openxmlformats.org/officeDocument/2006/relationships" xmlns:p="http://schemas.openxmlformats.org/presentationml/2006/main">
   <p:cSld>
     <p:spTree>
@@ -3426,7 +3338,7 @@
           <a:p>
             <a:fld id="{F7021451-1387-4CA6-816F-3879F97B5CBC}" type="slidenum">
               <a:rPr lang="en-US"/>
-              <a:t>36</a:t>
+              <a:t>35</a:t>
             </a:fld>
             <a:endParaRPr lang="en-US"/>
           </a:p>
@@ -3445,7 +3357,7 @@
 </p:notes>
 </file>
 
-<file path=ppt/notesSlides/notesSlide37.xml><?xml version="1.0" encoding="utf-8"?>
+<file path=ppt/notesSlides/notesSlide36.xml><?xml version="1.0" encoding="utf-8"?>
 <p:notes xmlns:a="http://schemas.openxmlformats.org/drawingml/2006/main" xmlns:r="http://schemas.openxmlformats.org/officeDocument/2006/relationships" xmlns:p="http://schemas.openxmlformats.org/presentationml/2006/main">
   <p:cSld>
     <p:spTree>
@@ -3524,7 +3436,7 @@
           <a:p>
             <a:fld id="{F7021451-1387-4CA6-816F-3879F97B5CBC}" type="slidenum">
               <a:rPr lang="en-US"/>
-              <a:t>37</a:t>
+              <a:t>36</a:t>
             </a:fld>
             <a:endParaRPr lang="en-US"/>
           </a:p>
@@ -3543,7 +3455,7 @@
 </p:notes>
 </file>
 
-<file path=ppt/notesSlides/notesSlide38.xml><?xml version="1.0" encoding="utf-8"?>
+<file path=ppt/notesSlides/notesSlide37.xml><?xml version="1.0" encoding="utf-8"?>
 <p:notes xmlns:a="http://schemas.openxmlformats.org/drawingml/2006/main" xmlns:r="http://schemas.openxmlformats.org/officeDocument/2006/relationships" xmlns:p="http://schemas.openxmlformats.org/presentationml/2006/main">
   <p:cSld>
     <p:spTree>
@@ -3623,7 +3535,7 @@
           <a:p>
             <a:fld id="{F7021451-1387-4CA6-816F-3879F97B5CBC}" type="slidenum">
               <a:rPr lang="en-US"/>
-              <a:t>38</a:t>
+              <a:t>37</a:t>
             </a:fld>
             <a:endParaRPr lang="en-US"/>
           </a:p>
@@ -3642,7 +3554,7 @@
 </p:notes>
 </file>
 
-<file path=ppt/notesSlides/notesSlide39.xml><?xml version="1.0" encoding="utf-8"?>
+<file path=ppt/notesSlides/notesSlide38.xml><?xml version="1.0" encoding="utf-8"?>
 <p:notes xmlns:a="http://schemas.openxmlformats.org/drawingml/2006/main" xmlns:r="http://schemas.openxmlformats.org/officeDocument/2006/relationships" xmlns:p="http://schemas.openxmlformats.org/presentationml/2006/main">
   <p:cSld>
     <p:spTree>
@@ -3700,6 +3612,110 @@
 what keeps the December integration from being a surprise.
 Next: the destination, named. Do not say Claude Code on this slide. The dots
 are Apply, Analyze and Create, and the next slide says what they add up to.</a:t>
+            </a:r>
+            <a:endParaRPr lang="en-US" dirty="0"/>
+          </a:p>
+        </p:txBody>
+      </p:sp>
+      <p:sp>
+        <p:nvSpPr>
+          <p:cNvPr id="4" name="Slide Number Placeholder 3"/>
+          <p:cNvSpPr>
+            <a:spLocks noGrp="1"/>
+          </p:cNvSpPr>
+          <p:nvPr>
+            <p:ph type="sldNum" sz="quarter" idx="10"/>
+          </p:nvPr>
+        </p:nvSpPr>
+        <p:spPr/>
+        <p:txBody>
+          <a:bodyPr/>
+          <a:lstStyle/>
+          <a:p>
+            <a:fld id="{F7021451-1387-4CA6-816F-3879F97B5CBC}" type="slidenum">
+              <a:rPr lang="en-US"/>
+              <a:t>38</a:t>
+            </a:fld>
+            <a:endParaRPr lang="en-US"/>
+          </a:p>
+        </p:txBody>
+      </p:sp>
+    </p:spTree>
+    <p:extLst>
+      <p:ext uri="{BB962C8B-B14F-4D97-AF65-F5344CB8AC3E}">
+        <p14:creationId xmlns:p14="http://schemas.microsoft.com/office/powerpoint/2010/main" val="1024086991"/>
+      </p:ext>
+    </p:extLst>
+  </p:cSld>
+  <p:clrMapOvr>
+    <a:masterClrMapping/>
+  </p:clrMapOvr>
+</p:notes>
+</file>
+
+<file path=ppt/notesSlides/notesSlide39.xml><?xml version="1.0" encoding="utf-8"?>
+<p:notes xmlns:a="http://schemas.openxmlformats.org/drawingml/2006/main" xmlns:r="http://schemas.openxmlformats.org/officeDocument/2006/relationships" xmlns:p="http://schemas.openxmlformats.org/presentationml/2006/main">
+  <p:cSld>
+    <p:spTree>
+      <p:nvGrpSpPr>
+        <p:cNvPr id="1" name=""/>
+        <p:cNvGrpSpPr/>
+        <p:nvPr/>
+      </p:nvGrpSpPr>
+      <p:grpSpPr>
+        <a:xfrm>
+          <a:off x="0" y="0"/>
+          <a:ext cx="0" cy="0"/>
+          <a:chOff x="0" y="0"/>
+          <a:chExt cx="0" cy="0"/>
+        </a:xfrm>
+      </p:grpSpPr>
+      <p:sp>
+        <p:nvSpPr>
+          <p:cNvPr id="2" name="Slide Image Placeholder 1"/>
+          <p:cNvSpPr>
+            <a:spLocks noGrp="1" noRot="1" noChangeAspect="1"/>
+          </p:cNvSpPr>
+          <p:nvPr>
+            <p:ph type="sldImg"/>
+          </p:nvPr>
+        </p:nvSpPr>
+        <p:spPr/>
+      </p:sp>
+      <p:sp>
+        <p:nvSpPr>
+          <p:cNvPr id="3" name="Notes Placeholder 2"/>
+          <p:cNvSpPr>
+            <a:spLocks noGrp="1"/>
+          </p:cNvSpPr>
+          <p:nvPr>
+            <p:ph type="body" idx="1"/>
+          </p:nvPr>
+        </p:nvSpPr>
+        <p:spPr/>
+        <p:txBody>
+          <a:bodyPr/>
+          <a:lstStyle/>
+          <a:p>
+            <a:r>
+              <a:rPr lang="en-US" dirty="0"/>
+              <a:t>Merged 2026-09-13, late, from "You will know how Claude Code works" and "The
+harness by December", on the instructor's reading that he was saying this
+slide's content a section early. There is now one place in the deck that
+names the destination, and it is here.
+The lead line first. Name Claude Code, or OpenClaw, as a shape, not a target
+to clone and not something they need an account for. What makes it that shape
+is the list they will build: tools the model chooses, an approval layer, state
+that survives a run, more than one way in. The design habit to start now: when
+a decision could close off one of those, leave a boundary rather than an
+implementation.
+Then the table. Say the left column as what a user sees and the right column
+as what a builder knows. Each row is a moment they will recognise from using
+the tool, paired with the code in their own repository that does the same job:
+the loop this month, the tools and the permission gate in Analyze, memory and
+hardening in Create.
+Nobody needs a subscription for anything in this course.
+Next: the open question. Do not say who picks the next action here.</a:t>
             </a:r>
             <a:endParaRPr lang="en-US" dirty="0"/>
           </a:p>
@@ -3892,110 +3908,6 @@
           <a:p>
             <a:r>
               <a:rPr lang="en-US" dirty="0"/>
-              <a:t>Merged 2026-09-13, late, from "You will know how Claude Code works" and "The
-harness by December", on the instructor's reading that he was saying this
-slide's content a section early. There is now one place in the deck that
-names the destination, and it is here.
-The lead line first. Name Claude Code, or OpenClaw, as a shape, not a target
-to clone and not something they need an account for. What makes it that shape
-is the list they will build: tools the model chooses, an approval layer, state
-that survives a run, more than one way in. The design habit to start now: when
-a decision could close off one of those, leave a boundary rather than an
-implementation.
-Then the table. Say the left column as what a user sees and the right column
-as what a builder knows. Each row is a moment they will recognise from using
-the tool, paired with the code in their own repository that does the same job:
-the loop this month, the tools and the permission gate in Analyze, memory and
-hardening in Create.
-Nobody needs a subscription for anything in this course.
-Next: the open question. Do not say who picks the next action here.</a:t>
-            </a:r>
-            <a:endParaRPr lang="en-US" dirty="0"/>
-          </a:p>
-        </p:txBody>
-      </p:sp>
-      <p:sp>
-        <p:nvSpPr>
-          <p:cNvPr id="4" name="Slide Number Placeholder 3"/>
-          <p:cNvSpPr>
-            <a:spLocks noGrp="1"/>
-          </p:cNvSpPr>
-          <p:nvPr>
-            <p:ph type="sldNum" sz="quarter" idx="10"/>
-          </p:nvPr>
-        </p:nvSpPr>
-        <p:spPr/>
-        <p:txBody>
-          <a:bodyPr/>
-          <a:lstStyle/>
-          <a:p>
-            <a:fld id="{F7021451-1387-4CA6-816F-3879F97B5CBC}" type="slidenum">
-              <a:rPr lang="en-US"/>
-              <a:t>40</a:t>
-            </a:fld>
-            <a:endParaRPr lang="en-US"/>
-          </a:p>
-        </p:txBody>
-      </p:sp>
-    </p:spTree>
-    <p:extLst>
-      <p:ext uri="{BB962C8B-B14F-4D97-AF65-F5344CB8AC3E}">
-        <p14:creationId xmlns:p14="http://schemas.microsoft.com/office/powerpoint/2010/main" val="1024086991"/>
-      </p:ext>
-    </p:extLst>
-  </p:cSld>
-  <p:clrMapOvr>
-    <a:masterClrMapping/>
-  </p:clrMapOvr>
-</p:notes>
-</file>
-
-<file path=ppt/notesSlides/notesSlide41.xml><?xml version="1.0" encoding="utf-8"?>
-<p:notes xmlns:a="http://schemas.openxmlformats.org/drawingml/2006/main" xmlns:r="http://schemas.openxmlformats.org/officeDocument/2006/relationships" xmlns:p="http://schemas.openxmlformats.org/presentationml/2006/main">
-  <p:cSld>
-    <p:spTree>
-      <p:nvGrpSpPr>
-        <p:cNvPr id="1" name=""/>
-        <p:cNvGrpSpPr/>
-        <p:nvPr/>
-      </p:nvGrpSpPr>
-      <p:grpSpPr>
-        <a:xfrm>
-          <a:off x="0" y="0"/>
-          <a:ext cx="0" cy="0"/>
-          <a:chOff x="0" y="0"/>
-          <a:chExt cx="0" cy="0"/>
-        </a:xfrm>
-      </p:grpSpPr>
-      <p:sp>
-        <p:nvSpPr>
-          <p:cNvPr id="2" name="Slide Image Placeholder 1"/>
-          <p:cNvSpPr>
-            <a:spLocks noGrp="1" noRot="1" noChangeAspect="1"/>
-          </p:cNvSpPr>
-          <p:nvPr>
-            <p:ph type="sldImg"/>
-          </p:nvPr>
-        </p:nvSpPr>
-        <p:spPr/>
-      </p:sp>
-      <p:sp>
-        <p:nvSpPr>
-          <p:cNvPr id="3" name="Notes Placeholder 2"/>
-          <p:cNvSpPr>
-            <a:spLocks noGrp="1"/>
-          </p:cNvSpPr>
-          <p:nvPr>
-            <p:ph type="body" idx="1"/>
-          </p:nvPr>
-        </p:nvSpPr>
-        <p:spPr/>
-        <p:txBody>
-          <a:bodyPr/>
-          <a:lstStyle/>
-          <a:p>
-            <a:r>
-              <a:rPr lang="en-US" dirty="0"/>
               <a:t>The bridge, and the end of the taught half. Six steps, and today they followed
 one request through all of them. Every tool of this kind, whatever its name and
 whoever makes it, runs the same six.
@@ -4029,7 +3941,7 @@
           <a:p>
             <a:fld id="{F7021451-1387-4CA6-816F-3879F97B5CBC}" type="slidenum">
               <a:rPr lang="en-US"/>
-              <a:t>41</a:t>
+              <a:t>40</a:t>
             </a:fld>
             <a:endParaRPr lang="en-US"/>
           </a:p>
@@ -4048,7 +3960,7 @@
 </p:notes>
 </file>
 
-<file path=ppt/notesSlides/notesSlide42.xml><?xml version="1.0" encoding="utf-8"?>
+<file path=ppt/notesSlides/notesSlide41.xml><?xml version="1.0" encoding="utf-8"?>
 <p:notes xmlns:a="http://schemas.openxmlformats.org/drawingml/2006/main" xmlns:r="http://schemas.openxmlformats.org/officeDocument/2006/relationships" xmlns:p="http://schemas.openxmlformats.org/presentationml/2006/main">
   <p:cSld>
     <p:spTree>
@@ -4120,7 +4032,7 @@
           <a:p>
             <a:fld id="{F7021451-1387-4CA6-816F-3879F97B5CBC}" type="slidenum">
               <a:rPr lang="en-US"/>
-              <a:t>42</a:t>
+              <a:t>41</a:t>
             </a:fld>
             <a:endParaRPr lang="en-US"/>
           </a:p>
@@ -4139,7 +4051,7 @@
 </p:notes>
 </file>
 
-<file path=ppt/notesSlides/notesSlide43.xml><?xml version="1.0" encoding="utf-8"?>
+<file path=ppt/notesSlides/notesSlide42.xml><?xml version="1.0" encoding="utf-8"?>
 <p:notes xmlns:a="http://schemas.openxmlformats.org/drawingml/2006/main" xmlns:r="http://schemas.openxmlformats.org/officeDocument/2006/relationships" xmlns:p="http://schemas.openxmlformats.org/presentationml/2006/main">
   <p:cSld>
     <p:spTree>
@@ -4208,7 +4120,7 @@
           <a:p>
             <a:fld id="{F7021451-1387-4CA6-816F-3879F97B5CBC}" type="slidenum">
               <a:rPr lang="en-US"/>
-              <a:t>43</a:t>
+              <a:t>42</a:t>
             </a:fld>
             <a:endParaRPr lang="en-US"/>
           </a:p>
@@ -6425,45 +6337,6 @@
 <file path=ppt/slides/slide42.xml><?xml version="1.0" encoding="utf-8"?>
 <p:sld xmlns:a="http://schemas.openxmlformats.org/drawingml/2006/main" xmlns:r="http://schemas.openxmlformats.org/officeDocument/2006/relationships" xmlns:p="http://schemas.openxmlformats.org/presentationml/2006/main">
   <p:cSld name="Slide 42">
-    <p:bg>
-      <p:bgPr>
-        <a:blipFill dpi="0" rotWithShape="1">
-          <a:blip r:embed="rId1">
-            <a:lum/>
-          </a:blip>
-          <a:srcRect/>
-          <a:stretch>
-            <a:fillRect/>
-          </a:stretch>
-        </a:blipFill>
-        <a:effectLst/>
-      </p:bgPr>
-    </p:bg>
-    <p:spTree>
-      <p:nvGrpSpPr>
-        <p:cNvPr id="1" name=""/>
-        <p:cNvGrpSpPr/>
-        <p:nvPr/>
-      </p:nvGrpSpPr>
-      <p:grpSpPr>
-        <a:xfrm>
-          <a:off x="0" y="0"/>
-          <a:ext cx="0" cy="0"/>
-          <a:chOff x="0" y="0"/>
-          <a:chExt cx="0" cy="0"/>
-        </a:xfrm>
-      </p:grpSpPr>
-    </p:spTree>
-  </p:cSld>
-  <p:clrMapOvr>
-    <a:masterClrMapping/>
-  </p:clrMapOvr>
-</p:sld>
-</file>
-
-<file path=ppt/slides/slide43.xml><?xml version="1.0" encoding="utf-8"?>
-<p:sld xmlns:a="http://schemas.openxmlformats.org/drawingml/2006/main" xmlns:r="http://schemas.openxmlformats.org/officeDocument/2006/relationships" xmlns:p="http://schemas.openxmlformats.org/presentationml/2006/main">
-  <p:cSld name="Slide 43">
     <p:bg>
       <p:bgPr>
         <a:blipFill dpi="0" rotWithShape="1">

</xml_diff>